<commit_message>
Fix CAPEX totals with updated Composição de Custo e POB values
Atualiza Serviço/Material/Total e POB (agora POB-dia) por ativo nos
slides de Composição de CAPEX e na Visão Executiva, a partir dos
valores corrigidos fornecidos pelo usuário para os 4 ativos. A
categoria Desenvolvimento de Produção passa a aparecer na lista de
Categoria (antes zerada para todos os ativos) mas segue excluída do
somatório total, conforme instrução original. A tabela de Escopos do
CAPEX segue com o extrato anterior (coluna 'Valor Total') e ganhou uma
nota informando que pode não somar exatamente ao novo total, até que
uma planilha atualizada seja fornecida.

Co-Authored-By: Claude Sonnet 5 <noreply@anthropic.com>
Claude-Session: https://claude.ai/code/session_01QXLKdFvqaqrRbUKxEFJW9L
</commit_message>
<xml_diff>
--- a/PRIO_Plano_Trabalho_CAPEX_2027.pptx
+++ b/PRIO_Plano_Trabalho_CAPEX_2027.pptx
@@ -250,16 +250,16 @@
                 <c:formatCode>General</c:formatCode>
                 <c:ptCount val="4"/>
                 <c:pt idx="0">
-                  <c:v>15.98</c:v>
+                  <c:v>18.14</c:v>
                 </c:pt>
                 <c:pt idx="1">
-                  <c:v>7.19</c:v>
+                  <c:v>8.83</c:v>
                 </c:pt>
                 <c:pt idx="2">
-                  <c:v>2.91</c:v>
+                  <c:v>3.46</c:v>
                 </c:pt>
                 <c:pt idx="3">
-                  <c:v>3.44</c:v>
+                  <c:v>4.55</c:v>
                 </c:pt>
               </c:numCache>
             </c:numRef>
@@ -2813,7 +2813,7 @@
                 <a:ea typeface="Cambria" pitchFamily="34" charset="-122"/>
                 <a:cs typeface="Cambria" pitchFamily="34" charset="-120"/>
               </a:rPr>
-              <a:t>US$ 1,7 mi</a:t>
+              <a:t>US$ 2,6 mi</a:t>
             </a:r>
             <a:endParaRPr lang="en-US" sz="2100" dirty="0"/>
           </a:p>
@@ -2913,7 +2913,7 @@
                 <a:ea typeface="Cambria" pitchFamily="34" charset="-122"/>
                 <a:cs typeface="Cambria" pitchFamily="34" charset="-120"/>
               </a:rPr>
-              <a:t>US$ 1,2 mi</a:t>
+              <a:t>US$ 3,7 mi</a:t>
             </a:r>
             <a:endParaRPr lang="en-US" sz="2100" dirty="0"/>
           </a:p>
@@ -3013,7 +3013,7 @@
                 <a:ea typeface="Cambria" pitchFamily="34" charset="-122"/>
                 <a:cs typeface="Cambria" pitchFamily="34" charset="-120"/>
               </a:rPr>
-              <a:t>US$ 2,9 mi</a:t>
+              <a:t>US$ 3,5 mi</a:t>
             </a:r>
             <a:endParaRPr lang="en-US" sz="2100" dirty="0"/>
           </a:p>
@@ -3113,7 +3113,7 @@
                 <a:ea typeface="Cambria" pitchFamily="34" charset="-122"/>
                 <a:cs typeface="Cambria" pitchFamily="34" charset="-120"/>
               </a:rPr>
-              <a:t>121</a:t>
+              <a:t>3.846</a:t>
             </a:r>
             <a:endParaRPr lang="en-US" sz="2100" dirty="0"/>
           </a:p>
@@ -3152,7 +3152,7 @@
                 <a:ea typeface="Calibri" pitchFamily="34" charset="-122"/>
                 <a:cs typeface="Calibri" pitchFamily="34" charset="-120"/>
               </a:rPr>
-              <a:t>POB TOTAL</a:t>
+              <a:t>POB TOTAL (POB-DIA)</a:t>
             </a:r>
             <a:endParaRPr lang="en-US" sz="850" dirty="0"/>
           </a:p>
@@ -3292,7 +3292,7 @@
                 <a:ea typeface="Calibri" pitchFamily="34" charset="-122"/>
                 <a:cs typeface="Calibri" pitchFamily="34" charset="-120"/>
               </a:rPr>
-              <a:t>US$ 2,3 mi</a:t>
+              <a:t>US$ 5,1 mi</a:t>
             </a:r>
             <a:endParaRPr lang="en-US" sz="1100" dirty="0"/>
           </a:p>
@@ -3323,7 +3323,7 @@
               <a:buNone/>
             </a:pPr>
             <a:r>
-              <a:rPr lang="en-US" sz="900" dirty="0">
+              <a:rPr lang="en-US" sz="850" dirty="0">
                 <a:solidFill>
                   <a:srgbClr val="5B6B73"/>
                 </a:solidFill>
@@ -3331,9 +3331,9 @@
                 <a:ea typeface="Calibri" pitchFamily="34" charset="-122"/>
                 <a:cs typeface="Calibri" pitchFamily="34" charset="-120"/>
               </a:rPr>
-              <a:t>51 POB</a:t>
+              <a:t>2.176 POB-dia</a:t>
             </a:r>
-            <a:endParaRPr lang="en-US" sz="900" dirty="0"/>
+            <a:endParaRPr lang="en-US" sz="850" dirty="0"/>
           </a:p>
         </p:txBody>
       </p:sp>
@@ -3429,7 +3429,7 @@
                 <a:ea typeface="Calibri" pitchFamily="34" charset="-122"/>
                 <a:cs typeface="Calibri" pitchFamily="34" charset="-120"/>
               </a:rPr>
-              <a:t>US$ 565,1 mil</a:t>
+              <a:t>US$ 1,1 mi</a:t>
             </a:r>
             <a:endParaRPr lang="en-US" sz="1100" dirty="0"/>
           </a:p>
@@ -3460,7 +3460,7 @@
               <a:buNone/>
             </a:pPr>
             <a:r>
-              <a:rPr lang="en-US" sz="900" dirty="0">
+              <a:rPr lang="en-US" sz="850" dirty="0">
                 <a:solidFill>
                   <a:srgbClr val="5B6B73"/>
                 </a:solidFill>
@@ -3468,9 +3468,9 @@
                 <a:ea typeface="Calibri" pitchFamily="34" charset="-122"/>
                 <a:cs typeface="Calibri" pitchFamily="34" charset="-120"/>
               </a:rPr>
-              <a:t>70 POB</a:t>
+              <a:t>1.650 POB-dia</a:t>
             </a:r>
-            <a:endParaRPr lang="en-US" sz="900" dirty="0"/>
+            <a:endParaRPr lang="en-US" sz="850" dirty="0"/>
           </a:p>
         </p:txBody>
       </p:sp>
@@ -3483,6 +3483,260 @@
         <p:spPr>
           <a:xfrm>
             <a:off x="566928" y="3630168"/>
+            <a:ext cx="2995574" cy="365760"/>
+          </a:xfrm>
+          <a:prstGeom prst="rect">
+            <a:avLst/>
+          </a:prstGeom>
+          <a:noFill/>
+          <a:ln/>
+        </p:spPr>
+        <p:txBody>
+          <a:bodyPr wrap="square" lIns="0" tIns="0" rIns="0" bIns="0" rtlCol="0" anchor="ctr"/>
+          <a:lstStyle/>
+          <a:p>
+            <a:pPr indent="0" marL="0">
+              <a:buNone/>
+            </a:pPr>
+            <a:r>
+              <a:rPr lang="en-US" sz="1100" dirty="0">
+                <a:solidFill>
+                  <a:srgbClr val="1C2B33"/>
+                </a:solidFill>
+                <a:latin typeface="Calibri" pitchFamily="34" charset="0"/>
+                <a:ea typeface="Calibri" pitchFamily="34" charset="-122"/>
+                <a:cs typeface="Calibri" pitchFamily="34" charset="-120"/>
+              </a:rPr>
+              <a:t>P&amp;Q - Processos</a:t>
+            </a:r>
+            <a:endParaRPr lang="en-US" sz="1100" dirty="0"/>
+          </a:p>
+        </p:txBody>
+      </p:sp>
+      <p:sp>
+        <p:nvSpPr>
+          <p:cNvPr id="28" name="Text 26"/>
+          <p:cNvSpPr txBox="1"/>
+          <p:nvPr/>
+        </p:nvSpPr>
+        <p:spPr>
+          <a:xfrm>
+            <a:off x="3452774" y="3630168"/>
+            <a:ext cx="1497787" cy="365760"/>
+          </a:xfrm>
+          <a:prstGeom prst="rect">
+            <a:avLst/>
+          </a:prstGeom>
+          <a:noFill/>
+          <a:ln/>
+        </p:spPr>
+        <p:txBody>
+          <a:bodyPr wrap="square" lIns="0" tIns="0" rIns="0" bIns="0" rtlCol="0" anchor="ctr"/>
+          <a:lstStyle/>
+          <a:p>
+            <a:pPr algn="r" indent="0" marL="0">
+              <a:buNone/>
+            </a:pPr>
+            <a:r>
+              <a:rPr lang="en-US" sz="1100" b="1" dirty="0">
+                <a:solidFill>
+                  <a:srgbClr val="0B2A3D"/>
+                </a:solidFill>
+                <a:latin typeface="Calibri" pitchFamily="34" charset="0"/>
+                <a:ea typeface="Calibri" pitchFamily="34" charset="-122"/>
+                <a:cs typeface="Calibri" pitchFamily="34" charset="-120"/>
+              </a:rPr>
+              <a:t>US$ 150,5 mil</a:t>
+            </a:r>
+            <a:endParaRPr lang="en-US" sz="1100" dirty="0"/>
+          </a:p>
+        </p:txBody>
+      </p:sp>
+      <p:sp>
+        <p:nvSpPr>
+          <p:cNvPr id="29" name="Text 27"/>
+          <p:cNvSpPr txBox="1"/>
+          <p:nvPr/>
+        </p:nvSpPr>
+        <p:spPr>
+          <a:xfrm>
+            <a:off x="4840834" y="3630168"/>
+            <a:ext cx="965606" cy="365760"/>
+          </a:xfrm>
+          <a:prstGeom prst="rect">
+            <a:avLst/>
+          </a:prstGeom>
+          <a:noFill/>
+          <a:ln/>
+        </p:spPr>
+        <p:txBody>
+          <a:bodyPr wrap="square" lIns="0" tIns="0" rIns="0" bIns="0" rtlCol="0" anchor="ctr"/>
+          <a:lstStyle/>
+          <a:p>
+            <a:pPr algn="r" indent="0" marL="0">
+              <a:buNone/>
+            </a:pPr>
+            <a:r>
+              <a:rPr lang="en-US" sz="850" dirty="0">
+                <a:solidFill>
+                  <a:srgbClr val="5B6B73"/>
+                </a:solidFill>
+                <a:latin typeface="Calibri" pitchFamily="34" charset="0"/>
+                <a:ea typeface="Calibri" pitchFamily="34" charset="-122"/>
+                <a:cs typeface="Calibri" pitchFamily="34" charset="-120"/>
+              </a:rPr>
+              <a:t>14 POB-dia</a:t>
+            </a:r>
+            <a:endParaRPr lang="en-US" sz="850" dirty="0"/>
+          </a:p>
+        </p:txBody>
+      </p:sp>
+      <p:sp>
+        <p:nvSpPr>
+          <p:cNvPr id="30" name="Shape 28"/>
+          <p:cNvSpPr/>
+          <p:nvPr/>
+        </p:nvSpPr>
+        <p:spPr>
+          <a:xfrm>
+            <a:off x="457200" y="3995928"/>
+            <a:ext cx="5349240" cy="365760"/>
+          </a:xfrm>
+          <a:prstGeom prst="rect">
+            <a:avLst/>
+          </a:prstGeom>
+          <a:solidFill>
+            <a:srgbClr val="F0F4F5"/>
+          </a:solidFill>
+          <a:ln/>
+        </p:spPr>
+      </p:sp>
+      <p:sp>
+        <p:nvSpPr>
+          <p:cNvPr id="31" name="Text 29"/>
+          <p:cNvSpPr txBox="1"/>
+          <p:nvPr/>
+        </p:nvSpPr>
+        <p:spPr>
+          <a:xfrm>
+            <a:off x="566928" y="3995928"/>
+            <a:ext cx="2995574" cy="365760"/>
+          </a:xfrm>
+          <a:prstGeom prst="rect">
+            <a:avLst/>
+          </a:prstGeom>
+          <a:noFill/>
+          <a:ln/>
+        </p:spPr>
+        <p:txBody>
+          <a:bodyPr wrap="square" lIns="0" tIns="0" rIns="0" bIns="0" rtlCol="0" anchor="ctr"/>
+          <a:lstStyle/>
+          <a:p>
+            <a:pPr indent="0" marL="0">
+              <a:buNone/>
+            </a:pPr>
+            <a:r>
+              <a:rPr lang="en-US" sz="1100" dirty="0">
+                <a:solidFill>
+                  <a:srgbClr val="1C2B33"/>
+                </a:solidFill>
+                <a:latin typeface="Calibri" pitchFamily="34" charset="0"/>
+                <a:ea typeface="Calibri" pitchFamily="34" charset="-122"/>
+                <a:cs typeface="Calibri" pitchFamily="34" charset="-120"/>
+              </a:rPr>
+              <a:t>P&amp;Q - Químicos</a:t>
+            </a:r>
+            <a:endParaRPr lang="en-US" sz="1100" dirty="0"/>
+          </a:p>
+        </p:txBody>
+      </p:sp>
+      <p:sp>
+        <p:nvSpPr>
+          <p:cNvPr id="32" name="Text 30"/>
+          <p:cNvSpPr txBox="1"/>
+          <p:nvPr/>
+        </p:nvSpPr>
+        <p:spPr>
+          <a:xfrm>
+            <a:off x="3452774" y="3995928"/>
+            <a:ext cx="1497787" cy="365760"/>
+          </a:xfrm>
+          <a:prstGeom prst="rect">
+            <a:avLst/>
+          </a:prstGeom>
+          <a:noFill/>
+          <a:ln/>
+        </p:spPr>
+        <p:txBody>
+          <a:bodyPr wrap="square" lIns="0" tIns="0" rIns="0" bIns="0" rtlCol="0" anchor="ctr"/>
+          <a:lstStyle/>
+          <a:p>
+            <a:pPr algn="r" indent="0" marL="0">
+              <a:buNone/>
+            </a:pPr>
+            <a:r>
+              <a:rPr lang="en-US" sz="1100" b="1" dirty="0">
+                <a:solidFill>
+                  <a:srgbClr val="0B2A3D"/>
+                </a:solidFill>
+                <a:latin typeface="Calibri" pitchFamily="34" charset="0"/>
+                <a:ea typeface="Calibri" pitchFamily="34" charset="-122"/>
+                <a:cs typeface="Calibri" pitchFamily="34" charset="-120"/>
+              </a:rPr>
+              <a:t>US$ 10,0 mil</a:t>
+            </a:r>
+            <a:endParaRPr lang="en-US" sz="1100" dirty="0"/>
+          </a:p>
+        </p:txBody>
+      </p:sp>
+      <p:sp>
+        <p:nvSpPr>
+          <p:cNvPr id="33" name="Text 31"/>
+          <p:cNvSpPr txBox="1"/>
+          <p:nvPr/>
+        </p:nvSpPr>
+        <p:spPr>
+          <a:xfrm>
+            <a:off x="4840834" y="3995928"/>
+            <a:ext cx="965606" cy="365760"/>
+          </a:xfrm>
+          <a:prstGeom prst="rect">
+            <a:avLst/>
+          </a:prstGeom>
+          <a:noFill/>
+          <a:ln/>
+        </p:spPr>
+        <p:txBody>
+          <a:bodyPr wrap="square" lIns="0" tIns="0" rIns="0" bIns="0" rtlCol="0" anchor="ctr"/>
+          <a:lstStyle/>
+          <a:p>
+            <a:pPr algn="r" indent="0" marL="0">
+              <a:buNone/>
+            </a:pPr>
+            <a:r>
+              <a:rPr lang="en-US" sz="850" dirty="0">
+                <a:solidFill>
+                  <a:srgbClr val="5B6B73"/>
+                </a:solidFill>
+                <a:latin typeface="Calibri" pitchFamily="34" charset="0"/>
+                <a:ea typeface="Calibri" pitchFamily="34" charset="-122"/>
+                <a:cs typeface="Calibri" pitchFamily="34" charset="-120"/>
+              </a:rPr>
+              <a:t>6 POB-dia</a:t>
+            </a:r>
+            <a:endParaRPr lang="en-US" sz="850" dirty="0"/>
+          </a:p>
+        </p:txBody>
+      </p:sp>
+      <p:sp>
+        <p:nvSpPr>
+          <p:cNvPr id="34" name="Text 32"/>
+          <p:cNvSpPr txBox="1"/>
+          <p:nvPr/>
+        </p:nvSpPr>
+        <p:spPr>
+          <a:xfrm>
+            <a:off x="566928" y="4361688"/>
             <a:ext cx="2995574" cy="365760"/>
           </a:xfrm>
           <a:prstGeom prst="rect">
@@ -3515,13 +3769,13 @@
       </p:sp>
       <p:sp>
         <p:nvSpPr>
-          <p:cNvPr id="28" name="Text 26"/>
+          <p:cNvPr id="35" name="Text 33"/>
           <p:cNvSpPr txBox="1"/>
           <p:nvPr/>
         </p:nvSpPr>
         <p:spPr>
           <a:xfrm>
-            <a:off x="3452774" y="3630168"/>
+            <a:off x="3452774" y="4361688"/>
             <a:ext cx="1497787" cy="365760"/>
           </a:xfrm>
           <a:prstGeom prst="rect">
@@ -3554,13 +3808,13 @@
       </p:sp>
       <p:sp>
         <p:nvSpPr>
-          <p:cNvPr id="29" name="Text 27"/>
+          <p:cNvPr id="36" name="Text 34"/>
           <p:cNvSpPr txBox="1"/>
           <p:nvPr/>
         </p:nvSpPr>
         <p:spPr>
           <a:xfrm>
-            <a:off x="4840834" y="3630168"/>
+            <a:off x="4840834" y="4361688"/>
             <a:ext cx="965606" cy="365760"/>
           </a:xfrm>
           <a:prstGeom prst="rect">
@@ -3577,7 +3831,7 @@
               <a:buNone/>
             </a:pPr>
             <a:r>
-              <a:rPr lang="en-US" sz="900" dirty="0">
+              <a:rPr lang="en-US" sz="850" dirty="0">
                 <a:solidFill>
                   <a:srgbClr val="5B6B73"/>
                 </a:solidFill>
@@ -3585,15 +3839,15 @@
                 <a:ea typeface="Calibri" pitchFamily="34" charset="-122"/>
                 <a:cs typeface="Calibri" pitchFamily="34" charset="-120"/>
               </a:rPr>
-              <a:t>0 POB</a:t>
+              <a:t>0 POB-dia</a:t>
             </a:r>
-            <a:endParaRPr lang="en-US" sz="900" dirty="0"/>
+            <a:endParaRPr lang="en-US" sz="850" dirty="0"/>
           </a:p>
         </p:txBody>
       </p:sp>
       <p:sp>
         <p:nvSpPr>
-          <p:cNvPr id="30" name="Text 28"/>
+          <p:cNvPr id="37" name="Text 35"/>
           <p:cNvSpPr txBox="1"/>
           <p:nvPr/>
         </p:nvSpPr>
@@ -3632,7 +3886,7 @@
       </p:sp>
       <p:sp>
         <p:nvSpPr>
-          <p:cNvPr id="31" name="Shape 29"/>
+          <p:cNvPr id="38" name="Shape 36"/>
           <p:cNvSpPr/>
           <p:nvPr/>
         </p:nvSpPr>
@@ -3655,13 +3909,150 @@
       </p:sp>
       <p:sp>
         <p:nvSpPr>
-          <p:cNvPr id="32" name="Text 30"/>
+          <p:cNvPr id="39" name="Text 37"/>
           <p:cNvSpPr txBox="1"/>
           <p:nvPr/>
         </p:nvSpPr>
         <p:spPr>
           <a:xfrm>
             <a:off x="6464808" y="2898648"/>
+            <a:ext cx="2995574" cy="365760"/>
+          </a:xfrm>
+          <a:prstGeom prst="rect">
+            <a:avLst/>
+          </a:prstGeom>
+          <a:noFill/>
+          <a:ln/>
+        </p:spPr>
+        <p:txBody>
+          <a:bodyPr wrap="square" lIns="0" tIns="0" rIns="0" bIns="0" rtlCol="0" anchor="ctr"/>
+          <a:lstStyle/>
+          <a:p>
+            <a:pPr indent="0" marL="0">
+              <a:buNone/>
+            </a:pPr>
+            <a:r>
+              <a:rPr lang="en-US" sz="1100" dirty="0">
+                <a:solidFill>
+                  <a:srgbClr val="1C2B33"/>
+                </a:solidFill>
+                <a:latin typeface="Calibri" pitchFamily="34" charset="0"/>
+                <a:ea typeface="Calibri" pitchFamily="34" charset="-122"/>
+                <a:cs typeface="Calibri" pitchFamily="34" charset="-120"/>
+              </a:rPr>
+              <a:t>Desenvolvimento de Produção</a:t>
+            </a:r>
+            <a:endParaRPr lang="en-US" sz="1100" dirty="0"/>
+          </a:p>
+        </p:txBody>
+      </p:sp>
+      <p:sp>
+        <p:nvSpPr>
+          <p:cNvPr id="40" name="Text 38"/>
+          <p:cNvSpPr txBox="1"/>
+          <p:nvPr/>
+        </p:nvSpPr>
+        <p:spPr>
+          <a:xfrm>
+            <a:off x="9350654" y="2898648"/>
+            <a:ext cx="1497787" cy="365760"/>
+          </a:xfrm>
+          <a:prstGeom prst="rect">
+            <a:avLst/>
+          </a:prstGeom>
+          <a:noFill/>
+          <a:ln/>
+        </p:spPr>
+        <p:txBody>
+          <a:bodyPr wrap="square" lIns="0" tIns="0" rIns="0" bIns="0" rtlCol="0" anchor="ctr"/>
+          <a:lstStyle/>
+          <a:p>
+            <a:pPr algn="r" indent="0" marL="0">
+              <a:buNone/>
+            </a:pPr>
+            <a:r>
+              <a:rPr lang="en-US" sz="1100" b="1" dirty="0">
+                <a:solidFill>
+                  <a:srgbClr val="0B2A3D"/>
+                </a:solidFill>
+                <a:latin typeface="Calibri" pitchFamily="34" charset="0"/>
+                <a:ea typeface="Calibri" pitchFamily="34" charset="-122"/>
+                <a:cs typeface="Calibri" pitchFamily="34" charset="-120"/>
+              </a:rPr>
+              <a:t>US$ 2,9 mi</a:t>
+            </a:r>
+            <a:endParaRPr lang="en-US" sz="1100" dirty="0"/>
+          </a:p>
+        </p:txBody>
+      </p:sp>
+      <p:sp>
+        <p:nvSpPr>
+          <p:cNvPr id="41" name="Text 39"/>
+          <p:cNvSpPr txBox="1"/>
+          <p:nvPr/>
+        </p:nvSpPr>
+        <p:spPr>
+          <a:xfrm>
+            <a:off x="10738714" y="2898648"/>
+            <a:ext cx="965606" cy="365760"/>
+          </a:xfrm>
+          <a:prstGeom prst="rect">
+            <a:avLst/>
+          </a:prstGeom>
+          <a:noFill/>
+          <a:ln/>
+        </p:spPr>
+        <p:txBody>
+          <a:bodyPr wrap="square" lIns="0" tIns="0" rIns="0" bIns="0" rtlCol="0" anchor="ctr"/>
+          <a:lstStyle/>
+          <a:p>
+            <a:pPr algn="r" indent="0" marL="0">
+              <a:buNone/>
+            </a:pPr>
+            <a:r>
+              <a:rPr lang="en-US" sz="850" dirty="0">
+                <a:solidFill>
+                  <a:srgbClr val="5B6B73"/>
+                </a:solidFill>
+                <a:latin typeface="Calibri" pitchFamily="34" charset="0"/>
+                <a:ea typeface="Calibri" pitchFamily="34" charset="-122"/>
+                <a:cs typeface="Calibri" pitchFamily="34" charset="-120"/>
+              </a:rPr>
+              <a:t>1.223 POB-dia</a:t>
+            </a:r>
+            <a:endParaRPr lang="en-US" sz="850" dirty="0"/>
+          </a:p>
+        </p:txBody>
+      </p:sp>
+      <p:sp>
+        <p:nvSpPr>
+          <p:cNvPr id="42" name="Shape 40"/>
+          <p:cNvSpPr/>
+          <p:nvPr/>
+        </p:nvSpPr>
+        <p:spPr>
+          <a:xfrm>
+            <a:off x="6355080" y="3264408"/>
+            <a:ext cx="5349240" cy="365760"/>
+          </a:xfrm>
+          <a:prstGeom prst="rect">
+            <a:avLst/>
+          </a:prstGeom>
+          <a:solidFill>
+            <a:srgbClr val="F0F4F5"/>
+          </a:solidFill>
+          <a:ln/>
+        </p:spPr>
+      </p:sp>
+      <p:sp>
+        <p:nvSpPr>
+          <p:cNvPr id="43" name="Text 41"/>
+          <p:cNvSpPr txBox="1"/>
+          <p:nvPr/>
+        </p:nvSpPr>
+        <p:spPr>
+          <a:xfrm>
+            <a:off x="6464808" y="3264408"/>
             <a:ext cx="2995574" cy="365760"/>
           </a:xfrm>
           <a:prstGeom prst="rect">
@@ -3694,13 +4085,13 @@
       </p:sp>
       <p:sp>
         <p:nvSpPr>
-          <p:cNvPr id="33" name="Text 31"/>
+          <p:cNvPr id="44" name="Text 42"/>
           <p:cNvSpPr txBox="1"/>
           <p:nvPr/>
         </p:nvSpPr>
         <p:spPr>
           <a:xfrm>
-            <a:off x="9350654" y="2898648"/>
+            <a:off x="9350654" y="3264408"/>
             <a:ext cx="1497787" cy="365760"/>
           </a:xfrm>
           <a:prstGeom prst="rect">
@@ -3725,7 +4116,7 @@
                 <a:ea typeface="Calibri" pitchFamily="34" charset="-122"/>
                 <a:cs typeface="Calibri" pitchFamily="34" charset="-120"/>
               </a:rPr>
-              <a:t>US$ 2,3 mi</a:t>
+              <a:t>US$ 2,9 mi</a:t>
             </a:r>
             <a:endParaRPr lang="en-US" sz="1100" dirty="0"/>
           </a:p>
@@ -3733,13 +4124,13 @@
       </p:sp>
       <p:sp>
         <p:nvSpPr>
-          <p:cNvPr id="34" name="Text 32"/>
+          <p:cNvPr id="45" name="Text 43"/>
           <p:cNvSpPr txBox="1"/>
           <p:nvPr/>
         </p:nvSpPr>
         <p:spPr>
           <a:xfrm>
-            <a:off x="10738714" y="2898648"/>
+            <a:off x="10738714" y="3264408"/>
             <a:ext cx="965606" cy="365760"/>
           </a:xfrm>
           <a:prstGeom prst="rect">
@@ -3756,7 +4147,7 @@
               <a:buNone/>
             </a:pPr>
             <a:r>
-              <a:rPr lang="en-US" sz="900" dirty="0">
+              <a:rPr lang="en-US" sz="850" dirty="0">
                 <a:solidFill>
                   <a:srgbClr val="5B6B73"/>
                 </a:solidFill>
@@ -3764,41 +4155,21 @@
                 <a:ea typeface="Calibri" pitchFamily="34" charset="-122"/>
                 <a:cs typeface="Calibri" pitchFamily="34" charset="-120"/>
               </a:rPr>
-              <a:t>119 POB</a:t>
+              <a:t>2.589 POB-dia</a:t>
             </a:r>
-            <a:endParaRPr lang="en-US" sz="900" dirty="0"/>
+            <a:endParaRPr lang="en-US" sz="850" dirty="0"/>
           </a:p>
         </p:txBody>
       </p:sp>
       <p:sp>
         <p:nvSpPr>
-          <p:cNvPr id="35" name="Shape 33"/>
-          <p:cNvSpPr/>
-          <p:nvPr/>
-        </p:nvSpPr>
-        <p:spPr>
-          <a:xfrm>
-            <a:off x="6355080" y="3264408"/>
-            <a:ext cx="5349240" cy="365760"/>
-          </a:xfrm>
-          <a:prstGeom prst="rect">
-            <a:avLst/>
-          </a:prstGeom>
-          <a:solidFill>
-            <a:srgbClr val="F0F4F5"/>
-          </a:solidFill>
-          <a:ln/>
-        </p:spPr>
-      </p:sp>
-      <p:sp>
-        <p:nvSpPr>
-          <p:cNvPr id="36" name="Text 34"/>
+          <p:cNvPr id="46" name="Text 44"/>
           <p:cNvSpPr txBox="1"/>
           <p:nvPr/>
         </p:nvSpPr>
         <p:spPr>
           <a:xfrm>
-            <a:off x="6464808" y="3264408"/>
+            <a:off x="6464808" y="3630168"/>
             <a:ext cx="2995574" cy="365760"/>
           </a:xfrm>
           <a:prstGeom prst="rect">
@@ -3831,13 +4202,13 @@
       </p:sp>
       <p:sp>
         <p:nvSpPr>
-          <p:cNvPr id="37" name="Text 35"/>
+          <p:cNvPr id="47" name="Text 45"/>
           <p:cNvSpPr txBox="1"/>
           <p:nvPr/>
         </p:nvSpPr>
         <p:spPr>
           <a:xfrm>
-            <a:off x="9350654" y="3264408"/>
+            <a:off x="9350654" y="3630168"/>
             <a:ext cx="1497787" cy="365760"/>
           </a:xfrm>
           <a:prstGeom prst="rect">
@@ -3870,13 +4241,13 @@
       </p:sp>
       <p:sp>
         <p:nvSpPr>
-          <p:cNvPr id="38" name="Text 36"/>
+          <p:cNvPr id="48" name="Text 46"/>
           <p:cNvSpPr txBox="1"/>
           <p:nvPr/>
         </p:nvSpPr>
         <p:spPr>
           <a:xfrm>
-            <a:off x="10738714" y="3264408"/>
+            <a:off x="10738714" y="3630168"/>
             <a:ext cx="965606" cy="365760"/>
           </a:xfrm>
           <a:prstGeom prst="rect">
@@ -3893,7 +4264,7 @@
               <a:buNone/>
             </a:pPr>
             <a:r>
-              <a:rPr lang="en-US" sz="900" dirty="0">
+              <a:rPr lang="en-US" sz="850" dirty="0">
                 <a:solidFill>
                   <a:srgbClr val="5B6B73"/>
                 </a:solidFill>
@@ -3901,21 +4272,158 @@
                 <a:ea typeface="Calibri" pitchFamily="34" charset="-122"/>
                 <a:cs typeface="Calibri" pitchFamily="34" charset="-120"/>
               </a:rPr>
-              <a:t>2 POB</a:t>
+              <a:t>28 POB-dia</a:t>
             </a:r>
-            <a:endParaRPr lang="en-US" sz="900" dirty="0"/>
+            <a:endParaRPr lang="en-US" sz="850" dirty="0"/>
           </a:p>
         </p:txBody>
       </p:sp>
       <p:sp>
         <p:nvSpPr>
-          <p:cNvPr id="39" name="Text 37"/>
+          <p:cNvPr id="49" name="Shape 47"/>
+          <p:cNvSpPr/>
+          <p:nvPr/>
+        </p:nvSpPr>
+        <p:spPr>
+          <a:xfrm>
+            <a:off x="6355080" y="3995928"/>
+            <a:ext cx="5349240" cy="365760"/>
+          </a:xfrm>
+          <a:prstGeom prst="rect">
+            <a:avLst/>
+          </a:prstGeom>
+          <a:solidFill>
+            <a:srgbClr val="F0F4F5"/>
+          </a:solidFill>
+          <a:ln/>
+        </p:spPr>
+      </p:sp>
+      <p:sp>
+        <p:nvSpPr>
+          <p:cNvPr id="50" name="Text 48"/>
           <p:cNvSpPr txBox="1"/>
           <p:nvPr/>
         </p:nvSpPr>
         <p:spPr>
           <a:xfrm>
-            <a:off x="6464808" y="3630168"/>
+            <a:off x="6464808" y="3995928"/>
+            <a:ext cx="2995574" cy="365760"/>
+          </a:xfrm>
+          <a:prstGeom prst="rect">
+            <a:avLst/>
+          </a:prstGeom>
+          <a:noFill/>
+          <a:ln/>
+        </p:spPr>
+        <p:txBody>
+          <a:bodyPr wrap="square" lIns="0" tIns="0" rIns="0" bIns="0" rtlCol="0" anchor="ctr"/>
+          <a:lstStyle/>
+          <a:p>
+            <a:pPr indent="0" marL="0">
+              <a:buNone/>
+            </a:pPr>
+            <a:r>
+              <a:rPr lang="en-US" sz="1100" dirty="0">
+                <a:solidFill>
+                  <a:srgbClr val="1C2B33"/>
+                </a:solidFill>
+                <a:latin typeface="Calibri" pitchFamily="34" charset="0"/>
+                <a:ea typeface="Calibri" pitchFamily="34" charset="-122"/>
+                <a:cs typeface="Calibri" pitchFamily="34" charset="-120"/>
+              </a:rPr>
+              <a:t>Rotina Operacional</a:t>
+            </a:r>
+            <a:endParaRPr lang="en-US" sz="1100" dirty="0"/>
+          </a:p>
+        </p:txBody>
+      </p:sp>
+      <p:sp>
+        <p:nvSpPr>
+          <p:cNvPr id="51" name="Text 49"/>
+          <p:cNvSpPr txBox="1"/>
+          <p:nvPr/>
+        </p:nvSpPr>
+        <p:spPr>
+          <a:xfrm>
+            <a:off x="9350654" y="3995928"/>
+            <a:ext cx="1497787" cy="365760"/>
+          </a:xfrm>
+          <a:prstGeom prst="rect">
+            <a:avLst/>
+          </a:prstGeom>
+          <a:noFill/>
+          <a:ln/>
+        </p:spPr>
+        <p:txBody>
+          <a:bodyPr wrap="square" lIns="0" tIns="0" rIns="0" bIns="0" rtlCol="0" anchor="ctr"/>
+          <a:lstStyle/>
+          <a:p>
+            <a:pPr algn="r" indent="0" marL="0">
+              <a:buNone/>
+            </a:pPr>
+            <a:r>
+              <a:rPr lang="en-US" sz="1100" b="1" dirty="0">
+                <a:solidFill>
+                  <a:srgbClr val="0B2A3D"/>
+                </a:solidFill>
+                <a:latin typeface="Calibri" pitchFamily="34" charset="0"/>
+                <a:ea typeface="Calibri" pitchFamily="34" charset="-122"/>
+                <a:cs typeface="Calibri" pitchFamily="34" charset="-120"/>
+              </a:rPr>
+              <a:t>US$ 10,0 mil</a:t>
+            </a:r>
+            <a:endParaRPr lang="en-US" sz="1100" dirty="0"/>
+          </a:p>
+        </p:txBody>
+      </p:sp>
+      <p:sp>
+        <p:nvSpPr>
+          <p:cNvPr id="52" name="Text 50"/>
+          <p:cNvSpPr txBox="1"/>
+          <p:nvPr/>
+        </p:nvSpPr>
+        <p:spPr>
+          <a:xfrm>
+            <a:off x="10738714" y="3995928"/>
+            <a:ext cx="965606" cy="365760"/>
+          </a:xfrm>
+          <a:prstGeom prst="rect">
+            <a:avLst/>
+          </a:prstGeom>
+          <a:noFill/>
+          <a:ln/>
+        </p:spPr>
+        <p:txBody>
+          <a:bodyPr wrap="square" lIns="0" tIns="0" rIns="0" bIns="0" rtlCol="0" anchor="ctr"/>
+          <a:lstStyle/>
+          <a:p>
+            <a:pPr algn="r" indent="0" marL="0">
+              <a:buNone/>
+            </a:pPr>
+            <a:r>
+              <a:rPr lang="en-US" sz="850" dirty="0">
+                <a:solidFill>
+                  <a:srgbClr val="5B6B73"/>
+                </a:solidFill>
+                <a:latin typeface="Calibri" pitchFamily="34" charset="0"/>
+                <a:ea typeface="Calibri" pitchFamily="34" charset="-122"/>
+                <a:cs typeface="Calibri" pitchFamily="34" charset="-120"/>
+              </a:rPr>
+              <a:t>6 POB-dia</a:t>
+            </a:r>
+            <a:endParaRPr lang="en-US" sz="850" dirty="0"/>
+          </a:p>
+        </p:txBody>
+      </p:sp>
+      <p:sp>
+        <p:nvSpPr>
+          <p:cNvPr id="53" name="Text 51"/>
+          <p:cNvSpPr txBox="1"/>
+          <p:nvPr/>
+        </p:nvSpPr>
+        <p:spPr>
+          <a:xfrm>
+            <a:off x="6464808" y="4361688"/>
             <a:ext cx="2995574" cy="365760"/>
           </a:xfrm>
           <a:prstGeom prst="rect">
@@ -3948,13 +4456,13 @@
       </p:sp>
       <p:sp>
         <p:nvSpPr>
-          <p:cNvPr id="40" name="Text 38"/>
+          <p:cNvPr id="54" name="Text 52"/>
           <p:cNvSpPr txBox="1"/>
           <p:nvPr/>
         </p:nvSpPr>
         <p:spPr>
           <a:xfrm>
-            <a:off x="9350654" y="3630168"/>
+            <a:off x="9350654" y="4361688"/>
             <a:ext cx="1497787" cy="365760"/>
           </a:xfrm>
           <a:prstGeom prst="rect">
@@ -3987,13 +4495,13 @@
       </p:sp>
       <p:sp>
         <p:nvSpPr>
-          <p:cNvPr id="41" name="Text 39"/>
+          <p:cNvPr id="55" name="Text 53"/>
           <p:cNvSpPr txBox="1"/>
           <p:nvPr/>
         </p:nvSpPr>
         <p:spPr>
           <a:xfrm>
-            <a:off x="10738714" y="3630168"/>
+            <a:off x="10738714" y="4361688"/>
             <a:ext cx="965606" cy="365760"/>
           </a:xfrm>
           <a:prstGeom prst="rect">
@@ -4010,7 +4518,7 @@
               <a:buNone/>
             </a:pPr>
             <a:r>
-              <a:rPr lang="en-US" sz="900" dirty="0">
+              <a:rPr lang="en-US" sz="850" dirty="0">
                 <a:solidFill>
                   <a:srgbClr val="5B6B73"/>
                 </a:solidFill>
@@ -4018,15 +4526,15 @@
                 <a:ea typeface="Calibri" pitchFamily="34" charset="-122"/>
                 <a:cs typeface="Calibri" pitchFamily="34" charset="-120"/>
               </a:rPr>
-              <a:t>0 POB</a:t>
+              <a:t>0 POB-dia</a:t>
             </a:r>
-            <a:endParaRPr lang="en-US" sz="900" dirty="0"/>
+            <a:endParaRPr lang="en-US" sz="850" dirty="0"/>
           </a:p>
         </p:txBody>
       </p:sp>
       <p:sp>
         <p:nvSpPr>
-          <p:cNvPr id="42" name="Text 40"/>
+          <p:cNvPr id="56" name="Text 54"/>
           <p:cNvSpPr txBox="1"/>
           <p:nvPr/>
         </p:nvSpPr>
@@ -4057,7 +4565,7 @@
                 <a:ea typeface="Calibri" pitchFamily="34" charset="-122"/>
                 <a:cs typeface="Calibri" pitchFamily="34" charset="-120"/>
               </a:rPr>
-              <a:t>Metodologia: soma de Custo de Serviço + Custo de Material (Jan–Dez), para itens de Cost Allocation = CAPEX com status 'Contar' ou 'TA'. O total desconsidera a categoria Desenvolvimento de Produção (sem itens para este ativo).</a:t>
+              <a:t>Metodologia: soma de Custo de Serviço + Custo de Material (Jan–Dez), para itens de Cost Allocation = CAPEX com status 'Contar' ou 'TA'. POB em POB-dia (pessoas a bordo × dias). O total desconsidera a categoria Desenvolvimento de Produção (US$ 2,9 mi, mantida na lista de Categoria apenas para referência).</a:t>
             </a:r>
             <a:endParaRPr lang="en-US" sz="850" dirty="0"/>
           </a:p>
@@ -7996,7 +8504,7 @@
                 <a:ea typeface="Calibri" pitchFamily="34" charset="-122"/>
                 <a:cs typeface="Calibri" pitchFamily="34" charset="-120"/>
               </a:rPr>
-              <a:t>Fonte: Plano Integrado · aba 'Geral - Em análise' · itens de Cost Allocation = CAPEX, status 'Contar' + 'TA'. Lista completa disponível na planilha em anexo.</a:t>
+              <a:t>Fonte: Plano Integrado · aba 'Geral - Em análise' · coluna 'Valor Total' · itens de Cost Allocation = CAPEX, status 'Contar' + 'TA'. Lista completa disponível na planilha em anexo. Extrato pendente de atualização — pode não somar exatamente ao total da Composição de Custo e POB.</a:t>
             </a:r>
             <a:endParaRPr lang="en-US" sz="850" dirty="0"/>
           </a:p>
@@ -8483,7 +8991,7 @@
                 <a:ea typeface="Cambria" pitchFamily="34" charset="-122"/>
                 <a:cs typeface="Cambria" pitchFamily="34" charset="-120"/>
               </a:rPr>
-              <a:t>US$ 2,3 mi</a:t>
+              <a:t>US$ 5,9 mi</a:t>
             </a:r>
             <a:endParaRPr lang="en-US" sz="2100" dirty="0"/>
           </a:p>
@@ -8583,7 +9091,7 @@
                 <a:ea typeface="Cambria" pitchFamily="34" charset="-122"/>
                 <a:cs typeface="Cambria" pitchFamily="34" charset="-120"/>
               </a:rPr>
-              <a:t>US$ 1,1 mi</a:t>
+              <a:t>US$ 7,1 mi</a:t>
             </a:r>
             <a:endParaRPr lang="en-US" sz="2100" dirty="0"/>
           </a:p>
@@ -8683,7 +9191,7 @@
                 <a:ea typeface="Cambria" pitchFamily="34" charset="-122"/>
                 <a:cs typeface="Cambria" pitchFamily="34" charset="-120"/>
               </a:rPr>
-              <a:t>US$ 3,4 mi</a:t>
+              <a:t>US$ 4,5 mi</a:t>
             </a:r>
             <a:endParaRPr lang="en-US" sz="2100" dirty="0"/>
           </a:p>
@@ -8783,7 +9291,7 @@
                 <a:ea typeface="Cambria" pitchFamily="34" charset="-122"/>
                 <a:cs typeface="Cambria" pitchFamily="34" charset="-120"/>
               </a:rPr>
-              <a:t>135</a:t>
+              <a:t>5.186</a:t>
             </a:r>
             <a:endParaRPr lang="en-US" sz="2100" dirty="0"/>
           </a:p>
@@ -8822,7 +9330,7 @@
                 <a:ea typeface="Calibri" pitchFamily="34" charset="-122"/>
                 <a:cs typeface="Calibri" pitchFamily="34" charset="-120"/>
               </a:rPr>
-              <a:t>POB TOTAL</a:t>
+              <a:t>POB TOTAL (POB-DIA)</a:t>
             </a:r>
             <a:endParaRPr lang="en-US" sz="850" dirty="0"/>
           </a:p>
@@ -8962,7 +9470,7 @@
                 <a:ea typeface="Calibri" pitchFamily="34" charset="-122"/>
                 <a:cs typeface="Calibri" pitchFamily="34" charset="-120"/>
               </a:rPr>
-              <a:t>US$ 1,8 mi</a:t>
+              <a:t>US$ 10,1 mi</a:t>
             </a:r>
             <a:endParaRPr lang="en-US" sz="1100" dirty="0"/>
           </a:p>
@@ -8993,7 +9501,7 @@
               <a:buNone/>
             </a:pPr>
             <a:r>
-              <a:rPr lang="en-US" sz="900" dirty="0">
+              <a:rPr lang="en-US" sz="850" dirty="0">
                 <a:solidFill>
                   <a:srgbClr val="5B6B73"/>
                 </a:solidFill>
@@ -9001,9 +9509,9 @@
                 <a:ea typeface="Calibri" pitchFamily="34" charset="-122"/>
                 <a:cs typeface="Calibri" pitchFamily="34" charset="-120"/>
               </a:rPr>
-              <a:t>41 POB</a:t>
+              <a:t>3.036 POB-dia</a:t>
             </a:r>
-            <a:endParaRPr lang="en-US" sz="900" dirty="0"/>
+            <a:endParaRPr lang="en-US" sz="850" dirty="0"/>
           </a:p>
         </p:txBody>
       </p:sp>
@@ -9099,7 +9607,7 @@
                 <a:ea typeface="Calibri" pitchFamily="34" charset="-122"/>
                 <a:cs typeface="Calibri" pitchFamily="34" charset="-120"/>
               </a:rPr>
-              <a:t>US$ 889,8 mil</a:t>
+              <a:t>US$ 1,9 mi</a:t>
             </a:r>
             <a:endParaRPr lang="en-US" sz="1100" dirty="0"/>
           </a:p>
@@ -9130,7 +9638,7 @@
               <a:buNone/>
             </a:pPr>
             <a:r>
-              <a:rPr lang="en-US" sz="900" dirty="0">
+              <a:rPr lang="en-US" sz="850" dirty="0">
                 <a:solidFill>
                   <a:srgbClr val="5B6B73"/>
                 </a:solidFill>
@@ -9138,9 +9646,9 @@
                 <a:ea typeface="Calibri" pitchFamily="34" charset="-122"/>
                 <a:cs typeface="Calibri" pitchFamily="34" charset="-120"/>
               </a:rPr>
-              <a:t>90 POB</a:t>
+              <a:t>2.010 POB-dia</a:t>
             </a:r>
-            <a:endParaRPr lang="en-US" sz="900" dirty="0"/>
+            <a:endParaRPr lang="en-US" sz="850" dirty="0"/>
           </a:p>
         </p:txBody>
       </p:sp>
@@ -9247,7 +9755,7 @@
               <a:buNone/>
             </a:pPr>
             <a:r>
-              <a:rPr lang="en-US" sz="900" dirty="0">
+              <a:rPr lang="en-US" sz="850" dirty="0">
                 <a:solidFill>
                   <a:srgbClr val="5B6B73"/>
                 </a:solidFill>
@@ -9255,9 +9763,9 @@
                 <a:ea typeface="Calibri" pitchFamily="34" charset="-122"/>
                 <a:cs typeface="Calibri" pitchFamily="34" charset="-120"/>
               </a:rPr>
-              <a:t>4 POB</a:t>
+              <a:t>120 POB-dia</a:t>
             </a:r>
-            <a:endParaRPr lang="en-US" sz="900" dirty="0"/>
+            <a:endParaRPr lang="en-US" sz="850" dirty="0"/>
           </a:p>
         </p:txBody>
       </p:sp>
@@ -9290,6 +9798,260 @@
         <p:spPr>
           <a:xfrm>
             <a:off x="566928" y="3995928"/>
+            <a:ext cx="2995574" cy="365760"/>
+          </a:xfrm>
+          <a:prstGeom prst="rect">
+            <a:avLst/>
+          </a:prstGeom>
+          <a:noFill/>
+          <a:ln/>
+        </p:spPr>
+        <p:txBody>
+          <a:bodyPr wrap="square" lIns="0" tIns="0" rIns="0" bIns="0" rtlCol="0" anchor="ctr"/>
+          <a:lstStyle/>
+          <a:p>
+            <a:pPr indent="0" marL="0">
+              <a:buNone/>
+            </a:pPr>
+            <a:r>
+              <a:rPr lang="en-US" sz="1100" dirty="0">
+                <a:solidFill>
+                  <a:srgbClr val="1C2B33"/>
+                </a:solidFill>
+                <a:latin typeface="Calibri" pitchFamily="34" charset="0"/>
+                <a:ea typeface="Calibri" pitchFamily="34" charset="-122"/>
+                <a:cs typeface="Calibri" pitchFamily="34" charset="-120"/>
+              </a:rPr>
+              <a:t>CON - Construção</a:t>
+            </a:r>
+            <a:endParaRPr lang="en-US" sz="1100" dirty="0"/>
+          </a:p>
+        </p:txBody>
+      </p:sp>
+      <p:sp>
+        <p:nvSpPr>
+          <p:cNvPr id="32" name="Text 30"/>
+          <p:cNvSpPr txBox="1"/>
+          <p:nvPr/>
+        </p:nvSpPr>
+        <p:spPr>
+          <a:xfrm>
+            <a:off x="3452774" y="3995928"/>
+            <a:ext cx="1497787" cy="365760"/>
+          </a:xfrm>
+          <a:prstGeom prst="rect">
+            <a:avLst/>
+          </a:prstGeom>
+          <a:noFill/>
+          <a:ln/>
+        </p:spPr>
+        <p:txBody>
+          <a:bodyPr wrap="square" lIns="0" tIns="0" rIns="0" bIns="0" rtlCol="0" anchor="ctr"/>
+          <a:lstStyle/>
+          <a:p>
+            <a:pPr algn="r" indent="0" marL="0">
+              <a:buNone/>
+            </a:pPr>
+            <a:r>
+              <a:rPr lang="en-US" sz="1100" b="1" dirty="0">
+                <a:solidFill>
+                  <a:srgbClr val="0B2A3D"/>
+                </a:solidFill>
+                <a:latin typeface="Calibri" pitchFamily="34" charset="0"/>
+                <a:ea typeface="Calibri" pitchFamily="34" charset="-122"/>
+                <a:cs typeface="Calibri" pitchFamily="34" charset="-120"/>
+              </a:rPr>
+              <a:t>US$ 150,5 mil</a:t>
+            </a:r>
+            <a:endParaRPr lang="en-US" sz="1100" dirty="0"/>
+          </a:p>
+        </p:txBody>
+      </p:sp>
+      <p:sp>
+        <p:nvSpPr>
+          <p:cNvPr id="33" name="Text 31"/>
+          <p:cNvSpPr txBox="1"/>
+          <p:nvPr/>
+        </p:nvSpPr>
+        <p:spPr>
+          <a:xfrm>
+            <a:off x="4840834" y="3995928"/>
+            <a:ext cx="965606" cy="365760"/>
+          </a:xfrm>
+          <a:prstGeom prst="rect">
+            <a:avLst/>
+          </a:prstGeom>
+          <a:noFill/>
+          <a:ln/>
+        </p:spPr>
+        <p:txBody>
+          <a:bodyPr wrap="square" lIns="0" tIns="0" rIns="0" bIns="0" rtlCol="0" anchor="ctr"/>
+          <a:lstStyle/>
+          <a:p>
+            <a:pPr algn="r" indent="0" marL="0">
+              <a:buNone/>
+            </a:pPr>
+            <a:r>
+              <a:rPr lang="en-US" sz="850" dirty="0">
+                <a:solidFill>
+                  <a:srgbClr val="5B6B73"/>
+                </a:solidFill>
+                <a:latin typeface="Calibri" pitchFamily="34" charset="0"/>
+                <a:ea typeface="Calibri" pitchFamily="34" charset="-122"/>
+                <a:cs typeface="Calibri" pitchFamily="34" charset="-120"/>
+              </a:rPr>
+              <a:t>14 POB-dia</a:t>
+            </a:r>
+            <a:endParaRPr lang="en-US" sz="850" dirty="0"/>
+          </a:p>
+        </p:txBody>
+      </p:sp>
+      <p:sp>
+        <p:nvSpPr>
+          <p:cNvPr id="34" name="Text 32"/>
+          <p:cNvSpPr txBox="1"/>
+          <p:nvPr/>
+        </p:nvSpPr>
+        <p:spPr>
+          <a:xfrm>
+            <a:off x="566928" y="4361688"/>
+            <a:ext cx="2995574" cy="365760"/>
+          </a:xfrm>
+          <a:prstGeom prst="rect">
+            <a:avLst/>
+          </a:prstGeom>
+          <a:noFill/>
+          <a:ln/>
+        </p:spPr>
+        <p:txBody>
+          <a:bodyPr wrap="square" lIns="0" tIns="0" rIns="0" bIns="0" rtlCol="0" anchor="ctr"/>
+          <a:lstStyle/>
+          <a:p>
+            <a:pPr indent="0" marL="0">
+              <a:buNone/>
+            </a:pPr>
+            <a:r>
+              <a:rPr lang="en-US" sz="1100" dirty="0">
+                <a:solidFill>
+                  <a:srgbClr val="1C2B33"/>
+                </a:solidFill>
+                <a:latin typeface="Calibri" pitchFamily="34" charset="0"/>
+                <a:ea typeface="Calibri" pitchFamily="34" charset="-122"/>
+                <a:cs typeface="Calibri" pitchFamily="34" charset="-120"/>
+              </a:rPr>
+              <a:t>P&amp;Q - Químicos</a:t>
+            </a:r>
+            <a:endParaRPr lang="en-US" sz="1100" dirty="0"/>
+          </a:p>
+        </p:txBody>
+      </p:sp>
+      <p:sp>
+        <p:nvSpPr>
+          <p:cNvPr id="35" name="Text 33"/>
+          <p:cNvSpPr txBox="1"/>
+          <p:nvPr/>
+        </p:nvSpPr>
+        <p:spPr>
+          <a:xfrm>
+            <a:off x="3452774" y="4361688"/>
+            <a:ext cx="1497787" cy="365760"/>
+          </a:xfrm>
+          <a:prstGeom prst="rect">
+            <a:avLst/>
+          </a:prstGeom>
+          <a:noFill/>
+          <a:ln/>
+        </p:spPr>
+        <p:txBody>
+          <a:bodyPr wrap="square" lIns="0" tIns="0" rIns="0" bIns="0" rtlCol="0" anchor="ctr"/>
+          <a:lstStyle/>
+          <a:p>
+            <a:pPr algn="r" indent="0" marL="0">
+              <a:buNone/>
+            </a:pPr>
+            <a:r>
+              <a:rPr lang="en-US" sz="1100" b="1" dirty="0">
+                <a:solidFill>
+                  <a:srgbClr val="0B2A3D"/>
+                </a:solidFill>
+                <a:latin typeface="Calibri" pitchFamily="34" charset="0"/>
+                <a:ea typeface="Calibri" pitchFamily="34" charset="-122"/>
+                <a:cs typeface="Calibri" pitchFamily="34" charset="-120"/>
+              </a:rPr>
+              <a:t>US$ 10,0 mil</a:t>
+            </a:r>
+            <a:endParaRPr lang="en-US" sz="1100" dirty="0"/>
+          </a:p>
+        </p:txBody>
+      </p:sp>
+      <p:sp>
+        <p:nvSpPr>
+          <p:cNvPr id="36" name="Text 34"/>
+          <p:cNvSpPr txBox="1"/>
+          <p:nvPr/>
+        </p:nvSpPr>
+        <p:spPr>
+          <a:xfrm>
+            <a:off x="4840834" y="4361688"/>
+            <a:ext cx="965606" cy="365760"/>
+          </a:xfrm>
+          <a:prstGeom prst="rect">
+            <a:avLst/>
+          </a:prstGeom>
+          <a:noFill/>
+          <a:ln/>
+        </p:spPr>
+        <p:txBody>
+          <a:bodyPr wrap="square" lIns="0" tIns="0" rIns="0" bIns="0" rtlCol="0" anchor="ctr"/>
+          <a:lstStyle/>
+          <a:p>
+            <a:pPr algn="r" indent="0" marL="0">
+              <a:buNone/>
+            </a:pPr>
+            <a:r>
+              <a:rPr lang="en-US" sz="850" dirty="0">
+                <a:solidFill>
+                  <a:srgbClr val="5B6B73"/>
+                </a:solidFill>
+                <a:latin typeface="Calibri" pitchFamily="34" charset="0"/>
+                <a:ea typeface="Calibri" pitchFamily="34" charset="-122"/>
+                <a:cs typeface="Calibri" pitchFamily="34" charset="-120"/>
+              </a:rPr>
+              <a:t>6 POB-dia</a:t>
+            </a:r>
+            <a:endParaRPr lang="en-US" sz="850" dirty="0"/>
+          </a:p>
+        </p:txBody>
+      </p:sp>
+      <p:sp>
+        <p:nvSpPr>
+          <p:cNvPr id="37" name="Shape 35"/>
+          <p:cNvSpPr/>
+          <p:nvPr/>
+        </p:nvSpPr>
+        <p:spPr>
+          <a:xfrm>
+            <a:off x="457200" y="4727448"/>
+            <a:ext cx="5349240" cy="365760"/>
+          </a:xfrm>
+          <a:prstGeom prst="rect">
+            <a:avLst/>
+          </a:prstGeom>
+          <a:solidFill>
+            <a:srgbClr val="F0F4F5"/>
+          </a:solidFill>
+          <a:ln/>
+        </p:spPr>
+      </p:sp>
+      <p:sp>
+        <p:nvSpPr>
+          <p:cNvPr id="38" name="Text 36"/>
+          <p:cNvSpPr txBox="1"/>
+          <p:nvPr/>
+        </p:nvSpPr>
+        <p:spPr>
+          <a:xfrm>
+            <a:off x="566928" y="4727448"/>
             <a:ext cx="2995574" cy="365760"/>
           </a:xfrm>
           <a:prstGeom prst="rect">
@@ -9322,13 +10084,13 @@
       </p:sp>
       <p:sp>
         <p:nvSpPr>
-          <p:cNvPr id="32" name="Text 30"/>
+          <p:cNvPr id="39" name="Text 37"/>
           <p:cNvSpPr txBox="1"/>
           <p:nvPr/>
         </p:nvSpPr>
         <p:spPr>
           <a:xfrm>
-            <a:off x="3452774" y="3995928"/>
+            <a:off x="3452774" y="4727448"/>
             <a:ext cx="1497787" cy="365760"/>
           </a:xfrm>
           <a:prstGeom prst="rect">
@@ -9361,13 +10123,13 @@
       </p:sp>
       <p:sp>
         <p:nvSpPr>
-          <p:cNvPr id="33" name="Text 31"/>
+          <p:cNvPr id="40" name="Text 38"/>
           <p:cNvSpPr txBox="1"/>
           <p:nvPr/>
         </p:nvSpPr>
         <p:spPr>
           <a:xfrm>
-            <a:off x="4840834" y="3995928"/>
+            <a:off x="4840834" y="4727448"/>
             <a:ext cx="965606" cy="365760"/>
           </a:xfrm>
           <a:prstGeom prst="rect">
@@ -9384,7 +10146,7 @@
               <a:buNone/>
             </a:pPr>
             <a:r>
-              <a:rPr lang="en-US" sz="900" dirty="0">
+              <a:rPr lang="en-US" sz="850" dirty="0">
                 <a:solidFill>
                   <a:srgbClr val="5B6B73"/>
                 </a:solidFill>
@@ -9392,15 +10154,15 @@
                 <a:ea typeface="Calibri" pitchFamily="34" charset="-122"/>
                 <a:cs typeface="Calibri" pitchFamily="34" charset="-120"/>
               </a:rPr>
-              <a:t>0 POB</a:t>
+              <a:t>0 POB-dia</a:t>
             </a:r>
-            <a:endParaRPr lang="en-US" sz="900" dirty="0"/>
+            <a:endParaRPr lang="en-US" sz="850" dirty="0"/>
           </a:p>
         </p:txBody>
       </p:sp>
       <p:sp>
         <p:nvSpPr>
-          <p:cNvPr id="34" name="Text 32"/>
+          <p:cNvPr id="41" name="Text 39"/>
           <p:cNvSpPr txBox="1"/>
           <p:nvPr/>
         </p:nvSpPr>
@@ -9439,7 +10201,7 @@
       </p:sp>
       <p:sp>
         <p:nvSpPr>
-          <p:cNvPr id="35" name="Shape 33"/>
+          <p:cNvPr id="42" name="Shape 40"/>
           <p:cNvSpPr/>
           <p:nvPr/>
         </p:nvSpPr>
@@ -9462,13 +10224,150 @@
       </p:sp>
       <p:sp>
         <p:nvSpPr>
-          <p:cNvPr id="36" name="Text 34"/>
+          <p:cNvPr id="43" name="Text 41"/>
           <p:cNvSpPr txBox="1"/>
           <p:nvPr/>
         </p:nvSpPr>
         <p:spPr>
           <a:xfrm>
             <a:off x="6464808" y="2898648"/>
+            <a:ext cx="2995574" cy="365760"/>
+          </a:xfrm>
+          <a:prstGeom prst="rect">
+            <a:avLst/>
+          </a:prstGeom>
+          <a:noFill/>
+          <a:ln/>
+        </p:spPr>
+        <p:txBody>
+          <a:bodyPr wrap="square" lIns="0" tIns="0" rIns="0" bIns="0" rtlCol="0" anchor="ctr"/>
+          <a:lstStyle/>
+          <a:p>
+            <a:pPr indent="0" marL="0">
+              <a:buNone/>
+            </a:pPr>
+            <a:r>
+              <a:rPr lang="en-US" sz="1100" dirty="0">
+                <a:solidFill>
+                  <a:srgbClr val="1C2B33"/>
+                </a:solidFill>
+                <a:latin typeface="Calibri" pitchFamily="34" charset="0"/>
+                <a:ea typeface="Calibri" pitchFamily="34" charset="-122"/>
+                <a:cs typeface="Calibri" pitchFamily="34" charset="-120"/>
+              </a:rPr>
+              <a:t>Desenvolvimento de Produção</a:t>
+            </a:r>
+            <a:endParaRPr lang="en-US" sz="1100" dirty="0"/>
+          </a:p>
+        </p:txBody>
+      </p:sp>
+      <p:sp>
+        <p:nvSpPr>
+          <p:cNvPr id="44" name="Text 42"/>
+          <p:cNvSpPr txBox="1"/>
+          <p:nvPr/>
+        </p:nvSpPr>
+        <p:spPr>
+          <a:xfrm>
+            <a:off x="9350654" y="2898648"/>
+            <a:ext cx="1497787" cy="365760"/>
+          </a:xfrm>
+          <a:prstGeom prst="rect">
+            <a:avLst/>
+          </a:prstGeom>
+          <a:noFill/>
+          <a:ln/>
+        </p:spPr>
+        <p:txBody>
+          <a:bodyPr wrap="square" lIns="0" tIns="0" rIns="0" bIns="0" rtlCol="0" anchor="ctr"/>
+          <a:lstStyle/>
+          <a:p>
+            <a:pPr algn="r" indent="0" marL="0">
+              <a:buNone/>
+            </a:pPr>
+            <a:r>
+              <a:rPr lang="en-US" sz="1100" b="1" dirty="0">
+                <a:solidFill>
+                  <a:srgbClr val="0B2A3D"/>
+                </a:solidFill>
+                <a:latin typeface="Calibri" pitchFamily="34" charset="0"/>
+                <a:ea typeface="Calibri" pitchFamily="34" charset="-122"/>
+                <a:cs typeface="Calibri" pitchFamily="34" charset="-120"/>
+              </a:rPr>
+              <a:t>US$ 8,4 mi</a:t>
+            </a:r>
+            <a:endParaRPr lang="en-US" sz="1100" dirty="0"/>
+          </a:p>
+        </p:txBody>
+      </p:sp>
+      <p:sp>
+        <p:nvSpPr>
+          <p:cNvPr id="45" name="Text 43"/>
+          <p:cNvSpPr txBox="1"/>
+          <p:nvPr/>
+        </p:nvSpPr>
+        <p:spPr>
+          <a:xfrm>
+            <a:off x="10738714" y="2898648"/>
+            <a:ext cx="965606" cy="365760"/>
+          </a:xfrm>
+          <a:prstGeom prst="rect">
+            <a:avLst/>
+          </a:prstGeom>
+          <a:noFill/>
+          <a:ln/>
+        </p:spPr>
+        <p:txBody>
+          <a:bodyPr wrap="square" lIns="0" tIns="0" rIns="0" bIns="0" rtlCol="0" anchor="ctr"/>
+          <a:lstStyle/>
+          <a:p>
+            <a:pPr algn="r" indent="0" marL="0">
+              <a:buNone/>
+            </a:pPr>
+            <a:r>
+              <a:rPr lang="en-US" sz="850" dirty="0">
+                <a:solidFill>
+                  <a:srgbClr val="5B6B73"/>
+                </a:solidFill>
+                <a:latin typeface="Calibri" pitchFamily="34" charset="0"/>
+                <a:ea typeface="Calibri" pitchFamily="34" charset="-122"/>
+                <a:cs typeface="Calibri" pitchFamily="34" charset="-120"/>
+              </a:rPr>
+              <a:t>2.284 POB-dia</a:t>
+            </a:r>
+            <a:endParaRPr lang="en-US" sz="850" dirty="0"/>
+          </a:p>
+        </p:txBody>
+      </p:sp>
+      <p:sp>
+        <p:nvSpPr>
+          <p:cNvPr id="46" name="Shape 44"/>
+          <p:cNvSpPr/>
+          <p:nvPr/>
+        </p:nvSpPr>
+        <p:spPr>
+          <a:xfrm>
+            <a:off x="6355080" y="3264408"/>
+            <a:ext cx="5349240" cy="365760"/>
+          </a:xfrm>
+          <a:prstGeom prst="rect">
+            <a:avLst/>
+          </a:prstGeom>
+          <a:solidFill>
+            <a:srgbClr val="F0F4F5"/>
+          </a:solidFill>
+          <a:ln/>
+        </p:spPr>
+      </p:sp>
+      <p:sp>
+        <p:nvSpPr>
+          <p:cNvPr id="47" name="Text 45"/>
+          <p:cNvSpPr txBox="1"/>
+          <p:nvPr/>
+        </p:nvSpPr>
+        <p:spPr>
+          <a:xfrm>
+            <a:off x="6464808" y="3264408"/>
             <a:ext cx="2995574" cy="365760"/>
           </a:xfrm>
           <a:prstGeom prst="rect">
@@ -9501,13 +10400,13 @@
       </p:sp>
       <p:sp>
         <p:nvSpPr>
-          <p:cNvPr id="37" name="Text 35"/>
+          <p:cNvPr id="48" name="Text 46"/>
           <p:cNvSpPr txBox="1"/>
           <p:nvPr/>
         </p:nvSpPr>
         <p:spPr>
           <a:xfrm>
-            <a:off x="9350654" y="2898648"/>
+            <a:off x="9350654" y="3264408"/>
             <a:ext cx="1497787" cy="365760"/>
           </a:xfrm>
           <a:prstGeom prst="rect">
@@ -9532,7 +10431,7 @@
                 <a:ea typeface="Calibri" pitchFamily="34" charset="-122"/>
                 <a:cs typeface="Calibri" pitchFamily="34" charset="-120"/>
               </a:rPr>
-              <a:t>US$ 2,8 mi</a:t>
+              <a:t>US$ 3,9 mi</a:t>
             </a:r>
             <a:endParaRPr lang="en-US" sz="1100" dirty="0"/>
           </a:p>
@@ -9540,13 +10439,13 @@
       </p:sp>
       <p:sp>
         <p:nvSpPr>
-          <p:cNvPr id="38" name="Text 36"/>
+          <p:cNvPr id="49" name="Text 47"/>
           <p:cNvSpPr txBox="1"/>
           <p:nvPr/>
         </p:nvSpPr>
         <p:spPr>
           <a:xfrm>
-            <a:off x="10738714" y="2898648"/>
+            <a:off x="10738714" y="3264408"/>
             <a:ext cx="965606" cy="365760"/>
           </a:xfrm>
           <a:prstGeom prst="rect">
@@ -9563,7 +10462,7 @@
               <a:buNone/>
             </a:pPr>
             <a:r>
-              <a:rPr lang="en-US" sz="900" dirty="0">
+              <a:rPr lang="en-US" sz="850" dirty="0">
                 <a:solidFill>
                   <a:srgbClr val="5B6B73"/>
                 </a:solidFill>
@@ -9571,41 +10470,21 @@
                 <a:ea typeface="Calibri" pitchFamily="34" charset="-122"/>
                 <a:cs typeface="Calibri" pitchFamily="34" charset="-120"/>
               </a:rPr>
-              <a:t>129 POB</a:t>
+              <a:t>2.844 POB-dia</a:t>
             </a:r>
-            <a:endParaRPr lang="en-US" sz="900" dirty="0"/>
+            <a:endParaRPr lang="en-US" sz="850" dirty="0"/>
           </a:p>
         </p:txBody>
       </p:sp>
       <p:sp>
         <p:nvSpPr>
-          <p:cNvPr id="39" name="Shape 37"/>
-          <p:cNvSpPr/>
-          <p:nvPr/>
-        </p:nvSpPr>
-        <p:spPr>
-          <a:xfrm>
-            <a:off x="6355080" y="3264408"/>
-            <a:ext cx="5349240" cy="365760"/>
-          </a:xfrm>
-          <a:prstGeom prst="rect">
-            <a:avLst/>
-          </a:prstGeom>
-          <a:solidFill>
-            <a:srgbClr val="F0F4F5"/>
-          </a:solidFill>
-          <a:ln/>
-        </p:spPr>
-      </p:sp>
-      <p:sp>
-        <p:nvSpPr>
-          <p:cNvPr id="40" name="Text 38"/>
+          <p:cNvPr id="50" name="Text 48"/>
           <p:cNvSpPr txBox="1"/>
           <p:nvPr/>
         </p:nvSpPr>
         <p:spPr>
           <a:xfrm>
-            <a:off x="6464808" y="3264408"/>
+            <a:off x="6464808" y="3630168"/>
             <a:ext cx="2995574" cy="365760"/>
           </a:xfrm>
           <a:prstGeom prst="rect">
@@ -9638,13 +10517,13 @@
       </p:sp>
       <p:sp>
         <p:nvSpPr>
-          <p:cNvPr id="41" name="Text 39"/>
+          <p:cNvPr id="51" name="Text 49"/>
           <p:cNvSpPr txBox="1"/>
           <p:nvPr/>
         </p:nvSpPr>
         <p:spPr>
           <a:xfrm>
-            <a:off x="9350654" y="3264408"/>
+            <a:off x="9350654" y="3630168"/>
             <a:ext cx="1497787" cy="365760"/>
           </a:xfrm>
           <a:prstGeom prst="rect">
@@ -9677,13 +10556,13 @@
       </p:sp>
       <p:sp>
         <p:nvSpPr>
-          <p:cNvPr id="42" name="Text 40"/>
+          <p:cNvPr id="52" name="Text 50"/>
           <p:cNvSpPr txBox="1"/>
           <p:nvPr/>
         </p:nvSpPr>
         <p:spPr>
           <a:xfrm>
-            <a:off x="10738714" y="3264408"/>
+            <a:off x="10738714" y="3630168"/>
             <a:ext cx="965606" cy="365760"/>
           </a:xfrm>
           <a:prstGeom prst="rect">
@@ -9700,7 +10579,7 @@
               <a:buNone/>
             </a:pPr>
             <a:r>
-              <a:rPr lang="en-US" sz="900" dirty="0">
+              <a:rPr lang="en-US" sz="850" dirty="0">
                 <a:solidFill>
                   <a:srgbClr val="5B6B73"/>
                 </a:solidFill>
@@ -9708,21 +10587,158 @@
                 <a:ea typeface="Calibri" pitchFamily="34" charset="-122"/>
                 <a:cs typeface="Calibri" pitchFamily="34" charset="-120"/>
               </a:rPr>
-              <a:t>6 POB</a:t>
+              <a:t>52 POB-dia</a:t>
             </a:r>
-            <a:endParaRPr lang="en-US" sz="900" dirty="0"/>
+            <a:endParaRPr lang="en-US" sz="850" dirty="0"/>
           </a:p>
         </p:txBody>
       </p:sp>
       <p:sp>
         <p:nvSpPr>
-          <p:cNvPr id="43" name="Text 41"/>
+          <p:cNvPr id="53" name="Shape 51"/>
+          <p:cNvSpPr/>
+          <p:nvPr/>
+        </p:nvSpPr>
+        <p:spPr>
+          <a:xfrm>
+            <a:off x="6355080" y="3995928"/>
+            <a:ext cx="5349240" cy="365760"/>
+          </a:xfrm>
+          <a:prstGeom prst="rect">
+            <a:avLst/>
+          </a:prstGeom>
+          <a:solidFill>
+            <a:srgbClr val="F0F4F5"/>
+          </a:solidFill>
+          <a:ln/>
+        </p:spPr>
+      </p:sp>
+      <p:sp>
+        <p:nvSpPr>
+          <p:cNvPr id="54" name="Text 52"/>
           <p:cNvSpPr txBox="1"/>
           <p:nvPr/>
         </p:nvSpPr>
         <p:spPr>
           <a:xfrm>
-            <a:off x="6464808" y="3630168"/>
+            <a:off x="6464808" y="3995928"/>
+            <a:ext cx="2995574" cy="365760"/>
+          </a:xfrm>
+          <a:prstGeom prst="rect">
+            <a:avLst/>
+          </a:prstGeom>
+          <a:noFill/>
+          <a:ln/>
+        </p:spPr>
+        <p:txBody>
+          <a:bodyPr wrap="square" lIns="0" tIns="0" rIns="0" bIns="0" rtlCol="0" anchor="ctr"/>
+          <a:lstStyle/>
+          <a:p>
+            <a:pPr indent="0" marL="0">
+              <a:buNone/>
+            </a:pPr>
+            <a:r>
+              <a:rPr lang="en-US" sz="1100" dirty="0">
+                <a:solidFill>
+                  <a:srgbClr val="1C2B33"/>
+                </a:solidFill>
+                <a:latin typeface="Calibri" pitchFamily="34" charset="0"/>
+                <a:ea typeface="Calibri" pitchFamily="34" charset="-122"/>
+                <a:cs typeface="Calibri" pitchFamily="34" charset="-120"/>
+              </a:rPr>
+              <a:t>Rotina Operacional</a:t>
+            </a:r>
+            <a:endParaRPr lang="en-US" sz="1100" dirty="0"/>
+          </a:p>
+        </p:txBody>
+      </p:sp>
+      <p:sp>
+        <p:nvSpPr>
+          <p:cNvPr id="55" name="Text 53"/>
+          <p:cNvSpPr txBox="1"/>
+          <p:nvPr/>
+        </p:nvSpPr>
+        <p:spPr>
+          <a:xfrm>
+            <a:off x="9350654" y="3995928"/>
+            <a:ext cx="1497787" cy="365760"/>
+          </a:xfrm>
+          <a:prstGeom prst="rect">
+            <a:avLst/>
+          </a:prstGeom>
+          <a:noFill/>
+          <a:ln/>
+        </p:spPr>
+        <p:txBody>
+          <a:bodyPr wrap="square" lIns="0" tIns="0" rIns="0" bIns="0" rtlCol="0" anchor="ctr"/>
+          <a:lstStyle/>
+          <a:p>
+            <a:pPr algn="r" indent="0" marL="0">
+              <a:buNone/>
+            </a:pPr>
+            <a:r>
+              <a:rPr lang="en-US" sz="1100" b="1" dirty="0">
+                <a:solidFill>
+                  <a:srgbClr val="0B2A3D"/>
+                </a:solidFill>
+                <a:latin typeface="Calibri" pitchFamily="34" charset="0"/>
+                <a:ea typeface="Calibri" pitchFamily="34" charset="-122"/>
+                <a:cs typeface="Calibri" pitchFamily="34" charset="-120"/>
+              </a:rPr>
+              <a:t>US$ 10,0 mil</a:t>
+            </a:r>
+            <a:endParaRPr lang="en-US" sz="1100" dirty="0"/>
+          </a:p>
+        </p:txBody>
+      </p:sp>
+      <p:sp>
+        <p:nvSpPr>
+          <p:cNvPr id="56" name="Text 54"/>
+          <p:cNvSpPr txBox="1"/>
+          <p:nvPr/>
+        </p:nvSpPr>
+        <p:spPr>
+          <a:xfrm>
+            <a:off x="10738714" y="3995928"/>
+            <a:ext cx="965606" cy="365760"/>
+          </a:xfrm>
+          <a:prstGeom prst="rect">
+            <a:avLst/>
+          </a:prstGeom>
+          <a:noFill/>
+          <a:ln/>
+        </p:spPr>
+        <p:txBody>
+          <a:bodyPr wrap="square" lIns="0" tIns="0" rIns="0" bIns="0" rtlCol="0" anchor="ctr"/>
+          <a:lstStyle/>
+          <a:p>
+            <a:pPr algn="r" indent="0" marL="0">
+              <a:buNone/>
+            </a:pPr>
+            <a:r>
+              <a:rPr lang="en-US" sz="850" dirty="0">
+                <a:solidFill>
+                  <a:srgbClr val="5B6B73"/>
+                </a:solidFill>
+                <a:latin typeface="Calibri" pitchFamily="34" charset="0"/>
+                <a:ea typeface="Calibri" pitchFamily="34" charset="-122"/>
+                <a:cs typeface="Calibri" pitchFamily="34" charset="-120"/>
+              </a:rPr>
+              <a:t>6 POB-dia</a:t>
+            </a:r>
+            <a:endParaRPr lang="en-US" sz="850" dirty="0"/>
+          </a:p>
+        </p:txBody>
+      </p:sp>
+      <p:sp>
+        <p:nvSpPr>
+          <p:cNvPr id="57" name="Text 55"/>
+          <p:cNvSpPr txBox="1"/>
+          <p:nvPr/>
+        </p:nvSpPr>
+        <p:spPr>
+          <a:xfrm>
+            <a:off x="6464808" y="4361688"/>
             <a:ext cx="2995574" cy="365760"/>
           </a:xfrm>
           <a:prstGeom prst="rect">
@@ -9755,13 +10771,13 @@
       </p:sp>
       <p:sp>
         <p:nvSpPr>
-          <p:cNvPr id="44" name="Text 42"/>
+          <p:cNvPr id="58" name="Text 56"/>
           <p:cNvSpPr txBox="1"/>
           <p:nvPr/>
         </p:nvSpPr>
         <p:spPr>
           <a:xfrm>
-            <a:off x="9350654" y="3630168"/>
+            <a:off x="9350654" y="4361688"/>
             <a:ext cx="1497787" cy="365760"/>
           </a:xfrm>
           <a:prstGeom prst="rect">
@@ -9794,13 +10810,13 @@
       </p:sp>
       <p:sp>
         <p:nvSpPr>
-          <p:cNvPr id="45" name="Text 43"/>
+          <p:cNvPr id="59" name="Text 57"/>
           <p:cNvSpPr txBox="1"/>
           <p:nvPr/>
         </p:nvSpPr>
         <p:spPr>
           <a:xfrm>
-            <a:off x="10738714" y="3630168"/>
+            <a:off x="10738714" y="4361688"/>
             <a:ext cx="965606" cy="365760"/>
           </a:xfrm>
           <a:prstGeom prst="rect">
@@ -9817,7 +10833,7 @@
               <a:buNone/>
             </a:pPr>
             <a:r>
-              <a:rPr lang="en-US" sz="900" dirty="0">
+              <a:rPr lang="en-US" sz="850" dirty="0">
                 <a:solidFill>
                   <a:srgbClr val="5B6B73"/>
                 </a:solidFill>
@@ -9825,15 +10841,15 @@
                 <a:ea typeface="Calibri" pitchFamily="34" charset="-122"/>
                 <a:cs typeface="Calibri" pitchFamily="34" charset="-120"/>
               </a:rPr>
-              <a:t>0 POB</a:t>
+              <a:t>0 POB-dia</a:t>
             </a:r>
-            <a:endParaRPr lang="en-US" sz="900" dirty="0"/>
+            <a:endParaRPr lang="en-US" sz="850" dirty="0"/>
           </a:p>
         </p:txBody>
       </p:sp>
       <p:sp>
         <p:nvSpPr>
-          <p:cNvPr id="46" name="Text 44"/>
+          <p:cNvPr id="60" name="Text 58"/>
           <p:cNvSpPr txBox="1"/>
           <p:nvPr/>
         </p:nvSpPr>
@@ -9864,7 +10880,7 @@
                 <a:ea typeface="Calibri" pitchFamily="34" charset="-122"/>
                 <a:cs typeface="Calibri" pitchFamily="34" charset="-120"/>
               </a:rPr>
-              <a:t>Metodologia: soma de Custo de Serviço + Custo de Material (Jan–Dez), para itens de Cost Allocation = CAPEX com status 'Contar' ou 'TA'. O total desconsidera a categoria Desenvolvimento de Produção (sem itens para este ativo).</a:t>
+              <a:t>Metodologia: soma de Custo de Serviço + Custo de Material (Jan–Dez), para itens de Cost Allocation = CAPEX com status 'Contar' ou 'TA'. POB em POB-dia (pessoas a bordo × dias). O total desconsidera a categoria Desenvolvimento de Produção (US$ 8,4 mi, mantida na lista de Categoria apenas para referência).</a:t>
             </a:r>
             <a:endParaRPr lang="en-US" sz="850" dirty="0"/>
           </a:p>
@@ -13803,7 +14819,7 @@
                 <a:ea typeface="Calibri" pitchFamily="34" charset="-122"/>
                 <a:cs typeface="Calibri" pitchFamily="34" charset="-120"/>
               </a:rPr>
-              <a:t>Fonte: Plano Integrado · aba 'Geral - Em análise' · itens de Cost Allocation = CAPEX, status 'Contar' + 'TA'. Lista completa disponível na planilha em anexo.</a:t>
+              <a:t>Fonte: Plano Integrado · aba 'Geral - Em análise' · coluna 'Valor Total' · itens de Cost Allocation = CAPEX, status 'Contar' + 'TA'. Lista completa disponível na planilha em anexo. Extrato pendente de atualização — pode não somar exatamente ao total da Composição de Custo e POB.</a:t>
             </a:r>
             <a:endParaRPr lang="en-US" sz="850" dirty="0"/>
           </a:p>
@@ -13967,7 +14983,7 @@
                 <a:ea typeface="Cambria" pitchFamily="34" charset="-122"/>
                 <a:cs typeface="Cambria" pitchFamily="34" charset="-120"/>
               </a:rPr>
-              <a:t>US$ 29,5 mi</a:t>
+              <a:t>US$ 35,0 mi</a:t>
             </a:r>
             <a:endParaRPr lang="en-US" sz="2600" dirty="0"/>
           </a:p>
@@ -14106,7 +15122,7 @@
                 <a:ea typeface="Cambria" pitchFamily="34" charset="-122"/>
                 <a:cs typeface="Cambria" pitchFamily="34" charset="-120"/>
               </a:rPr>
-              <a:t>706</a:t>
+              <a:t>19.668</a:t>
             </a:r>
             <a:endParaRPr lang="en-US" sz="2600" dirty="0"/>
           </a:p>
@@ -14145,7 +15161,7 @@
                 <a:ea typeface="Calibri" pitchFamily="34" charset="-122"/>
                 <a:cs typeface="Calibri" pitchFamily="34" charset="-120"/>
               </a:rPr>
-              <a:t>POB TOTAL</a:t>
+              <a:t>POB TOTAL (POB-DIA)</a:t>
             </a:r>
             <a:endParaRPr lang="en-US" sz="950" dirty="0"/>
           </a:p>
@@ -14184,7 +15200,7 @@
                 <a:ea typeface="Calibri" pitchFamily="34" charset="-122"/>
                 <a:cs typeface="Calibri" pitchFamily="34" charset="-120"/>
               </a:rPr>
-              <a:t>pessoas a bordo alocadas</a:t>
+              <a:t>pessoas a bordo × dias, no ano</a:t>
             </a:r>
             <a:endParaRPr lang="en-US" sz="850" dirty="0"/>
           </a:p>
@@ -14688,7 +15704,7 @@
                             <a:srgbClr val="FFFFFF"/>
                           </a:solidFill>
                         </a:rPr>
-                        <a:t>POB</a:t>
+                        <a:t>POB-DIA</a:t>
                       </a:r>
                       <a:endParaRPr lang="en-US" sz="1000" dirty="0"/>
                     </a:p>
@@ -14873,7 +15889,7 @@
                             <a:srgbClr val="1C2B33"/>
                           </a:solidFill>
                         </a:rPr>
-                        <a:t>US$ 16,0 mi</a:t>
+                        <a:t>US$ 18,1 mi</a:t>
                       </a:r>
                       <a:endParaRPr lang="en-US" sz="1050" dirty="0"/>
                     </a:p>
@@ -14934,7 +15950,7 @@
                             <a:srgbClr val="1C2B33"/>
                           </a:solidFill>
                         </a:rPr>
-                        <a:t>268</a:t>
+                        <a:t>5.544</a:t>
                       </a:r>
                       <a:endParaRPr lang="en-US" sz="1050" dirty="0"/>
                     </a:p>
@@ -15119,7 +16135,7 @@
                             <a:srgbClr val="1C2B33"/>
                           </a:solidFill>
                         </a:rPr>
-                        <a:t>US$ 7,2 mi</a:t>
+                        <a:t>US$ 8,8 mi</a:t>
                       </a:r>
                       <a:endParaRPr lang="en-US" sz="1050" dirty="0"/>
                     </a:p>
@@ -15180,7 +16196,7 @@
                             <a:srgbClr val="1C2B33"/>
                           </a:solidFill>
                         </a:rPr>
-                        <a:t>182</a:t>
+                        <a:t>5.092</a:t>
                       </a:r>
                       <a:endParaRPr lang="en-US" sz="1050" dirty="0"/>
                     </a:p>
@@ -15365,7 +16381,7 @@
                             <a:srgbClr val="1C2B33"/>
                           </a:solidFill>
                         </a:rPr>
-                        <a:t>US$ 2,9 mi</a:t>
+                        <a:t>US$ 3,5 mi</a:t>
                       </a:r>
                       <a:endParaRPr lang="en-US" sz="1050" dirty="0"/>
                     </a:p>
@@ -15426,7 +16442,7 @@
                             <a:srgbClr val="1C2B33"/>
                           </a:solidFill>
                         </a:rPr>
-                        <a:t>121</a:t>
+                        <a:t>3.846</a:t>
                       </a:r>
                       <a:endParaRPr lang="en-US" sz="1050" dirty="0"/>
                     </a:p>
@@ -15611,7 +16627,7 @@
                             <a:srgbClr val="1C2B33"/>
                           </a:solidFill>
                         </a:rPr>
-                        <a:t>US$ 3,4 mi</a:t>
+                        <a:t>US$ 4,5 mi</a:t>
                       </a:r>
                       <a:endParaRPr lang="en-US" sz="1050" dirty="0"/>
                     </a:p>
@@ -15672,7 +16688,7 @@
                             <a:srgbClr val="1C2B33"/>
                           </a:solidFill>
                         </a:rPr>
-                        <a:t>135</a:t>
+                        <a:t>5.186</a:t>
                       </a:r>
                       <a:endParaRPr lang="en-US" sz="1050" dirty="0"/>
                     </a:p>
@@ -15857,7 +16873,7 @@
                             <a:srgbClr val="0B2A3D"/>
                           </a:solidFill>
                         </a:rPr>
-                        <a:t>US$ 29,5 mi</a:t>
+                        <a:t>US$ 35,0 mi</a:t>
                       </a:r>
                       <a:endParaRPr lang="en-US" sz="1050" dirty="0"/>
                     </a:p>
@@ -15918,7 +16934,7 @@
                             <a:srgbClr val="0B2A3D"/>
                           </a:solidFill>
                         </a:rPr>
-                        <a:t>706</a:t>
+                        <a:t>19.668</a:t>
                       </a:r>
                       <a:endParaRPr lang="en-US" sz="1050" dirty="0"/>
                     </a:p>
@@ -16651,7 +17667,7 @@
                 <a:ea typeface="Cambria" pitchFamily="34" charset="-122"/>
                 <a:cs typeface="Cambria" pitchFamily="34" charset="-120"/>
               </a:rPr>
-              <a:t>US$ 9,8 mi</a:t>
+              <a:t>US$ 12,0 mi</a:t>
             </a:r>
             <a:endParaRPr lang="en-US" sz="2100" dirty="0"/>
           </a:p>
@@ -16751,7 +17767,7 @@
                 <a:ea typeface="Cambria" pitchFamily="34" charset="-122"/>
                 <a:cs typeface="Cambria" pitchFamily="34" charset="-120"/>
               </a:rPr>
-              <a:t>US$ 16,0 mi</a:t>
+              <a:t>US$ 18,1 mi</a:t>
             </a:r>
             <a:endParaRPr lang="en-US" sz="2100" dirty="0"/>
           </a:p>
@@ -16851,7 +17867,7 @@
                 <a:ea typeface="Cambria" pitchFamily="34" charset="-122"/>
                 <a:cs typeface="Cambria" pitchFamily="34" charset="-120"/>
               </a:rPr>
-              <a:t>268</a:t>
+              <a:t>5.544</a:t>
             </a:r>
             <a:endParaRPr lang="en-US" sz="2100" dirty="0"/>
           </a:p>
@@ -16890,7 +17906,7 @@
                 <a:ea typeface="Calibri" pitchFamily="34" charset="-122"/>
                 <a:cs typeface="Calibri" pitchFamily="34" charset="-120"/>
               </a:rPr>
-              <a:t>POB TOTAL</a:t>
+              <a:t>POB TOTAL (POB-DIA)</a:t>
             </a:r>
             <a:endParaRPr lang="en-US" sz="850" dirty="0"/>
           </a:p>
@@ -17061,7 +18077,7 @@
               <a:buNone/>
             </a:pPr>
             <a:r>
-              <a:rPr lang="en-US" sz="900" dirty="0">
+              <a:rPr lang="en-US" sz="850" dirty="0">
                 <a:solidFill>
                   <a:srgbClr val="5B6B73"/>
                 </a:solidFill>
@@ -17069,9 +18085,9 @@
                 <a:ea typeface="Calibri" pitchFamily="34" charset="-122"/>
                 <a:cs typeface="Calibri" pitchFamily="34" charset="-120"/>
               </a:rPr>
-              <a:t>92 POB</a:t>
+              <a:t>1.611 POB-dia</a:t>
             </a:r>
-            <a:endParaRPr lang="en-US" sz="900" dirty="0"/>
+            <a:endParaRPr lang="en-US" sz="850" dirty="0"/>
           </a:p>
         </p:txBody>
       </p:sp>
@@ -17198,7 +18214,7 @@
               <a:buNone/>
             </a:pPr>
             <a:r>
-              <a:rPr lang="en-US" sz="900" dirty="0">
+              <a:rPr lang="en-US" sz="850" dirty="0">
                 <a:solidFill>
                   <a:srgbClr val="5B6B73"/>
                 </a:solidFill>
@@ -17206,9 +18222,9 @@
                 <a:ea typeface="Calibri" pitchFamily="34" charset="-122"/>
                 <a:cs typeface="Calibri" pitchFamily="34" charset="-120"/>
               </a:rPr>
-              <a:t>16 POB</a:t>
+              <a:t>224 POB-dia</a:t>
             </a:r>
-            <a:endParaRPr lang="en-US" sz="900" dirty="0"/>
+            <a:endParaRPr lang="en-US" sz="850" dirty="0"/>
           </a:p>
         </p:txBody>
       </p:sp>
@@ -17221,6 +18237,143 @@
         <p:spPr>
           <a:xfrm>
             <a:off x="566928" y="3630168"/>
+            <a:ext cx="2995574" cy="365760"/>
+          </a:xfrm>
+          <a:prstGeom prst="rect">
+            <a:avLst/>
+          </a:prstGeom>
+          <a:noFill/>
+          <a:ln/>
+        </p:spPr>
+        <p:txBody>
+          <a:bodyPr wrap="square" lIns="0" tIns="0" rIns="0" bIns="0" rtlCol="0" anchor="ctr"/>
+          <a:lstStyle/>
+          <a:p>
+            <a:pPr indent="0" marL="0">
+              <a:buNone/>
+            </a:pPr>
+            <a:r>
+              <a:rPr lang="en-US" sz="1100" dirty="0">
+                <a:solidFill>
+                  <a:srgbClr val="1C2B33"/>
+                </a:solidFill>
+                <a:latin typeface="Calibri" pitchFamily="34" charset="0"/>
+                <a:ea typeface="Calibri" pitchFamily="34" charset="-122"/>
+                <a:cs typeface="Calibri" pitchFamily="34" charset="-120"/>
+              </a:rPr>
+              <a:t>TA - Parada Programada</a:t>
+            </a:r>
+            <a:endParaRPr lang="en-US" sz="1100" dirty="0"/>
+          </a:p>
+        </p:txBody>
+      </p:sp>
+      <p:sp>
+        <p:nvSpPr>
+          <p:cNvPr id="28" name="Text 26"/>
+          <p:cNvSpPr txBox="1"/>
+          <p:nvPr/>
+        </p:nvSpPr>
+        <p:spPr>
+          <a:xfrm>
+            <a:off x="3452774" y="3630168"/>
+            <a:ext cx="1497787" cy="365760"/>
+          </a:xfrm>
+          <a:prstGeom prst="rect">
+            <a:avLst/>
+          </a:prstGeom>
+          <a:noFill/>
+          <a:ln/>
+        </p:spPr>
+        <p:txBody>
+          <a:bodyPr wrap="square" lIns="0" tIns="0" rIns="0" bIns="0" rtlCol="0" anchor="ctr"/>
+          <a:lstStyle/>
+          <a:p>
+            <a:pPr algn="r" indent="0" marL="0">
+              <a:buNone/>
+            </a:pPr>
+            <a:r>
+              <a:rPr lang="en-US" sz="1100" b="1" dirty="0">
+                <a:solidFill>
+                  <a:srgbClr val="0B2A3D"/>
+                </a:solidFill>
+                <a:latin typeface="Calibri" pitchFamily="34" charset="0"/>
+                <a:ea typeface="Calibri" pitchFamily="34" charset="-122"/>
+                <a:cs typeface="Calibri" pitchFamily="34" charset="-120"/>
+              </a:rPr>
+              <a:t>US$ 3,3 mi</a:t>
+            </a:r>
+            <a:endParaRPr lang="en-US" sz="1100" dirty="0"/>
+          </a:p>
+        </p:txBody>
+      </p:sp>
+      <p:sp>
+        <p:nvSpPr>
+          <p:cNvPr id="29" name="Text 27"/>
+          <p:cNvSpPr txBox="1"/>
+          <p:nvPr/>
+        </p:nvSpPr>
+        <p:spPr>
+          <a:xfrm>
+            <a:off x="4840834" y="3630168"/>
+            <a:ext cx="965606" cy="365760"/>
+          </a:xfrm>
+          <a:prstGeom prst="rect">
+            <a:avLst/>
+          </a:prstGeom>
+          <a:noFill/>
+          <a:ln/>
+        </p:spPr>
+        <p:txBody>
+          <a:bodyPr wrap="square" lIns="0" tIns="0" rIns="0" bIns="0" rtlCol="0" anchor="ctr"/>
+          <a:lstStyle/>
+          <a:p>
+            <a:pPr algn="r" indent="0" marL="0">
+              <a:buNone/>
+            </a:pPr>
+            <a:r>
+              <a:rPr lang="en-US" sz="850" dirty="0">
+                <a:solidFill>
+                  <a:srgbClr val="5B6B73"/>
+                </a:solidFill>
+                <a:latin typeface="Calibri" pitchFamily="34" charset="0"/>
+                <a:ea typeface="Calibri" pitchFamily="34" charset="-122"/>
+                <a:cs typeface="Calibri" pitchFamily="34" charset="-120"/>
+              </a:rPr>
+              <a:t>2.865 POB-dia</a:t>
+            </a:r>
+            <a:endParaRPr lang="en-US" sz="850" dirty="0"/>
+          </a:p>
+        </p:txBody>
+      </p:sp>
+      <p:sp>
+        <p:nvSpPr>
+          <p:cNvPr id="30" name="Shape 28"/>
+          <p:cNvSpPr/>
+          <p:nvPr/>
+        </p:nvSpPr>
+        <p:spPr>
+          <a:xfrm>
+            <a:off x="457200" y="3995928"/>
+            <a:ext cx="5349240" cy="365760"/>
+          </a:xfrm>
+          <a:prstGeom prst="rect">
+            <a:avLst/>
+          </a:prstGeom>
+          <a:solidFill>
+            <a:srgbClr val="F0F4F5"/>
+          </a:solidFill>
+          <a:ln/>
+        </p:spPr>
+      </p:sp>
+      <p:sp>
+        <p:nvSpPr>
+          <p:cNvPr id="31" name="Text 29"/>
+          <p:cNvSpPr txBox="1"/>
+          <p:nvPr/>
+        </p:nvSpPr>
+        <p:spPr>
+          <a:xfrm>
+            <a:off x="566928" y="3995928"/>
             <a:ext cx="2995574" cy="365760"/>
           </a:xfrm>
           <a:prstGeom prst="rect">
@@ -17253,13 +18406,13 @@
       </p:sp>
       <p:sp>
         <p:nvSpPr>
-          <p:cNvPr id="28" name="Text 26"/>
+          <p:cNvPr id="32" name="Text 30"/>
           <p:cNvSpPr txBox="1"/>
           <p:nvPr/>
         </p:nvSpPr>
         <p:spPr>
           <a:xfrm>
-            <a:off x="3452774" y="3630168"/>
+            <a:off x="3452774" y="3995928"/>
             <a:ext cx="1497787" cy="365760"/>
           </a:xfrm>
           <a:prstGeom prst="rect">
@@ -17292,13 +18445,13 @@
       </p:sp>
       <p:sp>
         <p:nvSpPr>
-          <p:cNvPr id="29" name="Text 27"/>
+          <p:cNvPr id="33" name="Text 31"/>
           <p:cNvSpPr txBox="1"/>
           <p:nvPr/>
         </p:nvSpPr>
         <p:spPr>
           <a:xfrm>
-            <a:off x="4840834" y="3630168"/>
+            <a:off x="4840834" y="3995928"/>
             <a:ext cx="965606" cy="365760"/>
           </a:xfrm>
           <a:prstGeom prst="rect">
@@ -17315,7 +18468,7 @@
               <a:buNone/>
             </a:pPr>
             <a:r>
-              <a:rPr lang="en-US" sz="900" dirty="0">
+              <a:rPr lang="en-US" sz="850" dirty="0">
                 <a:solidFill>
                   <a:srgbClr val="5B6B73"/>
                 </a:solidFill>
@@ -17323,146 +18476,9 @@
                 <a:ea typeface="Calibri" pitchFamily="34" charset="-122"/>
                 <a:cs typeface="Calibri" pitchFamily="34" charset="-120"/>
               </a:rPr>
-              <a:t>14 POB</a:t>
+              <a:t>248 POB-dia</a:t>
             </a:r>
-            <a:endParaRPr lang="en-US" sz="900" dirty="0"/>
-          </a:p>
-        </p:txBody>
-      </p:sp>
-      <p:sp>
-        <p:nvSpPr>
-          <p:cNvPr id="30" name="Shape 28"/>
-          <p:cNvSpPr/>
-          <p:nvPr/>
-        </p:nvSpPr>
-        <p:spPr>
-          <a:xfrm>
-            <a:off x="457200" y="3995928"/>
-            <a:ext cx="5349240" cy="365760"/>
-          </a:xfrm>
-          <a:prstGeom prst="rect">
-            <a:avLst/>
-          </a:prstGeom>
-          <a:solidFill>
-            <a:srgbClr val="F0F4F5"/>
-          </a:solidFill>
-          <a:ln/>
-        </p:spPr>
-      </p:sp>
-      <p:sp>
-        <p:nvSpPr>
-          <p:cNvPr id="31" name="Text 29"/>
-          <p:cNvSpPr txBox="1"/>
-          <p:nvPr/>
-        </p:nvSpPr>
-        <p:spPr>
-          <a:xfrm>
-            <a:off x="566928" y="3995928"/>
-            <a:ext cx="2995574" cy="365760"/>
-          </a:xfrm>
-          <a:prstGeom prst="rect">
-            <a:avLst/>
-          </a:prstGeom>
-          <a:noFill/>
-          <a:ln/>
-        </p:spPr>
-        <p:txBody>
-          <a:bodyPr wrap="square" lIns="0" tIns="0" rIns="0" bIns="0" rtlCol="0" anchor="ctr"/>
-          <a:lstStyle/>
-          <a:p>
-            <a:pPr indent="0" marL="0">
-              <a:buNone/>
-            </a:pPr>
-            <a:r>
-              <a:rPr lang="en-US" sz="1100" dirty="0">
-                <a:solidFill>
-                  <a:srgbClr val="1C2B33"/>
-                </a:solidFill>
-                <a:latin typeface="Calibri" pitchFamily="34" charset="0"/>
-                <a:ea typeface="Calibri" pitchFamily="34" charset="-122"/>
-                <a:cs typeface="Calibri" pitchFamily="34" charset="-120"/>
-              </a:rPr>
-              <a:t>TA - Parada Programada</a:t>
-            </a:r>
-            <a:endParaRPr lang="en-US" sz="1100" dirty="0"/>
-          </a:p>
-        </p:txBody>
-      </p:sp>
-      <p:sp>
-        <p:nvSpPr>
-          <p:cNvPr id="32" name="Text 30"/>
-          <p:cNvSpPr txBox="1"/>
-          <p:nvPr/>
-        </p:nvSpPr>
-        <p:spPr>
-          <a:xfrm>
-            <a:off x="3452774" y="3995928"/>
-            <a:ext cx="1497787" cy="365760"/>
-          </a:xfrm>
-          <a:prstGeom prst="rect">
-            <a:avLst/>
-          </a:prstGeom>
-          <a:noFill/>
-          <a:ln/>
-        </p:spPr>
-        <p:txBody>
-          <a:bodyPr wrap="square" lIns="0" tIns="0" rIns="0" bIns="0" rtlCol="0" anchor="ctr"/>
-          <a:lstStyle/>
-          <a:p>
-            <a:pPr algn="r" indent="0" marL="0">
-              <a:buNone/>
-            </a:pPr>
-            <a:r>
-              <a:rPr lang="en-US" sz="1100" b="1" dirty="0">
-                <a:solidFill>
-                  <a:srgbClr val="0B2A3D"/>
-                </a:solidFill>
-                <a:latin typeface="Calibri" pitchFamily="34" charset="0"/>
-                <a:ea typeface="Calibri" pitchFamily="34" charset="-122"/>
-                <a:cs typeface="Calibri" pitchFamily="34" charset="-120"/>
-              </a:rPr>
-              <a:t>US$ 1,2 mi</a:t>
-            </a:r>
-            <a:endParaRPr lang="en-US" sz="1100" dirty="0"/>
-          </a:p>
-        </p:txBody>
-      </p:sp>
-      <p:sp>
-        <p:nvSpPr>
-          <p:cNvPr id="33" name="Text 31"/>
-          <p:cNvSpPr txBox="1"/>
-          <p:nvPr/>
-        </p:nvSpPr>
-        <p:spPr>
-          <a:xfrm>
-            <a:off x="4840834" y="3995928"/>
-            <a:ext cx="965606" cy="365760"/>
-          </a:xfrm>
-          <a:prstGeom prst="rect">
-            <a:avLst/>
-          </a:prstGeom>
-          <a:noFill/>
-          <a:ln/>
-        </p:spPr>
-        <p:txBody>
-          <a:bodyPr wrap="square" lIns="0" tIns="0" rIns="0" bIns="0" rtlCol="0" anchor="ctr"/>
-          <a:lstStyle/>
-          <a:p>
-            <a:pPr algn="r" indent="0" marL="0">
-              <a:buNone/>
-            </a:pPr>
-            <a:r>
-              <a:rPr lang="en-US" sz="900" dirty="0">
-                <a:solidFill>
-                  <a:srgbClr val="5B6B73"/>
-                </a:solidFill>
-                <a:latin typeface="Calibri" pitchFamily="34" charset="0"/>
-                <a:ea typeface="Calibri" pitchFamily="34" charset="-122"/>
-                <a:cs typeface="Calibri" pitchFamily="34" charset="-120"/>
-              </a:rPr>
-              <a:t>127 POB</a:t>
-            </a:r>
-            <a:endParaRPr lang="en-US" sz="900" dirty="0"/>
+            <a:endParaRPr lang="en-US" sz="850" dirty="0"/>
           </a:p>
         </p:txBody>
       </p:sp>
@@ -17569,7 +18585,7 @@
               <a:buNone/>
             </a:pPr>
             <a:r>
-              <a:rPr lang="en-US" sz="900" dirty="0">
+              <a:rPr lang="en-US" sz="850" dirty="0">
                 <a:solidFill>
                   <a:srgbClr val="5B6B73"/>
                 </a:solidFill>
@@ -17577,9 +18593,9 @@
                 <a:ea typeface="Calibri" pitchFamily="34" charset="-122"/>
                 <a:cs typeface="Calibri" pitchFamily="34" charset="-120"/>
               </a:rPr>
-              <a:t>18 POB</a:t>
+              <a:t>540 POB-dia</a:t>
             </a:r>
-            <a:endParaRPr lang="en-US" sz="900" dirty="0"/>
+            <a:endParaRPr lang="en-US" sz="850" dirty="0"/>
           </a:p>
         </p:txBody>
       </p:sp>
@@ -17612,6 +18628,123 @@
         <p:spPr>
           <a:xfrm>
             <a:off x="566928" y="4727448"/>
+            <a:ext cx="2995574" cy="365760"/>
+          </a:xfrm>
+          <a:prstGeom prst="rect">
+            <a:avLst/>
+          </a:prstGeom>
+          <a:noFill/>
+          <a:ln/>
+        </p:spPr>
+        <p:txBody>
+          <a:bodyPr wrap="square" lIns="0" tIns="0" rIns="0" bIns="0" rtlCol="0" anchor="ctr"/>
+          <a:lstStyle/>
+          <a:p>
+            <a:pPr indent="0" marL="0">
+              <a:buNone/>
+            </a:pPr>
+            <a:r>
+              <a:rPr lang="en-US" sz="1100" dirty="0">
+                <a:solidFill>
+                  <a:srgbClr val="1C2B33"/>
+                </a:solidFill>
+                <a:latin typeface="Calibri" pitchFamily="34" charset="0"/>
+                <a:ea typeface="Calibri" pitchFamily="34" charset="-122"/>
+                <a:cs typeface="Calibri" pitchFamily="34" charset="-120"/>
+              </a:rPr>
+              <a:t>P&amp;Q - Químicos</a:t>
+            </a:r>
+            <a:endParaRPr lang="en-US" sz="1100" dirty="0"/>
+          </a:p>
+        </p:txBody>
+      </p:sp>
+      <p:sp>
+        <p:nvSpPr>
+          <p:cNvPr id="39" name="Text 37"/>
+          <p:cNvSpPr txBox="1"/>
+          <p:nvPr/>
+        </p:nvSpPr>
+        <p:spPr>
+          <a:xfrm>
+            <a:off x="3452774" y="4727448"/>
+            <a:ext cx="1497787" cy="365760"/>
+          </a:xfrm>
+          <a:prstGeom prst="rect">
+            <a:avLst/>
+          </a:prstGeom>
+          <a:noFill/>
+          <a:ln/>
+        </p:spPr>
+        <p:txBody>
+          <a:bodyPr wrap="square" lIns="0" tIns="0" rIns="0" bIns="0" rtlCol="0" anchor="ctr"/>
+          <a:lstStyle/>
+          <a:p>
+            <a:pPr algn="r" indent="0" marL="0">
+              <a:buNone/>
+            </a:pPr>
+            <a:r>
+              <a:rPr lang="en-US" sz="1100" b="1" dirty="0">
+                <a:solidFill>
+                  <a:srgbClr val="0B2A3D"/>
+                </a:solidFill>
+                <a:latin typeface="Calibri" pitchFamily="34" charset="0"/>
+                <a:ea typeface="Calibri" pitchFamily="34" charset="-122"/>
+                <a:cs typeface="Calibri" pitchFamily="34" charset="-120"/>
+              </a:rPr>
+              <a:t>US$ 140,5 mil</a:t>
+            </a:r>
+            <a:endParaRPr lang="en-US" sz="1100" dirty="0"/>
+          </a:p>
+        </p:txBody>
+      </p:sp>
+      <p:sp>
+        <p:nvSpPr>
+          <p:cNvPr id="40" name="Text 38"/>
+          <p:cNvSpPr txBox="1"/>
+          <p:nvPr/>
+        </p:nvSpPr>
+        <p:spPr>
+          <a:xfrm>
+            <a:off x="4840834" y="4727448"/>
+            <a:ext cx="965606" cy="365760"/>
+          </a:xfrm>
+          <a:prstGeom prst="rect">
+            <a:avLst/>
+          </a:prstGeom>
+          <a:noFill/>
+          <a:ln/>
+        </p:spPr>
+        <p:txBody>
+          <a:bodyPr wrap="square" lIns="0" tIns="0" rIns="0" bIns="0" rtlCol="0" anchor="ctr"/>
+          <a:lstStyle/>
+          <a:p>
+            <a:pPr algn="r" indent="0" marL="0">
+              <a:buNone/>
+            </a:pPr>
+            <a:r>
+              <a:rPr lang="en-US" sz="850" dirty="0">
+                <a:solidFill>
+                  <a:srgbClr val="5B6B73"/>
+                </a:solidFill>
+                <a:latin typeface="Calibri" pitchFamily="34" charset="0"/>
+                <a:ea typeface="Calibri" pitchFamily="34" charset="-122"/>
+                <a:cs typeface="Calibri" pitchFamily="34" charset="-120"/>
+              </a:rPr>
+              <a:t>56 POB-dia</a:t>
+            </a:r>
+            <a:endParaRPr lang="en-US" sz="850" dirty="0"/>
+          </a:p>
+        </p:txBody>
+      </p:sp>
+      <p:sp>
+        <p:nvSpPr>
+          <p:cNvPr id="41" name="Text 39"/>
+          <p:cNvSpPr txBox="1"/>
+          <p:nvPr/>
+        </p:nvSpPr>
+        <p:spPr>
+          <a:xfrm>
+            <a:off x="566928" y="5093208"/>
             <a:ext cx="2995574" cy="365760"/>
           </a:xfrm>
           <a:prstGeom prst="rect">
@@ -17644,13 +18777,13 @@
       </p:sp>
       <p:sp>
         <p:nvSpPr>
-          <p:cNvPr id="39" name="Text 37"/>
+          <p:cNvPr id="42" name="Text 40"/>
           <p:cNvSpPr txBox="1"/>
           <p:nvPr/>
         </p:nvSpPr>
         <p:spPr>
           <a:xfrm>
-            <a:off x="3452774" y="4727448"/>
+            <a:off x="3452774" y="5093208"/>
             <a:ext cx="1497787" cy="365760"/>
           </a:xfrm>
           <a:prstGeom prst="rect">
@@ -17683,13 +18816,13 @@
       </p:sp>
       <p:sp>
         <p:nvSpPr>
-          <p:cNvPr id="40" name="Text 38"/>
+          <p:cNvPr id="43" name="Text 41"/>
           <p:cNvSpPr txBox="1"/>
           <p:nvPr/>
         </p:nvSpPr>
         <p:spPr>
           <a:xfrm>
-            <a:off x="4840834" y="4727448"/>
+            <a:off x="4840834" y="5093208"/>
             <a:ext cx="965606" cy="365760"/>
           </a:xfrm>
           <a:prstGeom prst="rect">
@@ -17706,7 +18839,7 @@
               <a:buNone/>
             </a:pPr>
             <a:r>
-              <a:rPr lang="en-US" sz="900" dirty="0">
+              <a:rPr lang="en-US" sz="850" dirty="0">
                 <a:solidFill>
                   <a:srgbClr val="5B6B73"/>
                 </a:solidFill>
@@ -17714,126 +18847,9 @@
                 <a:ea typeface="Calibri" pitchFamily="34" charset="-122"/>
                 <a:cs typeface="Calibri" pitchFamily="34" charset="-120"/>
               </a:rPr>
-              <a:t>0 POB</a:t>
+              <a:t>0 POB-dia</a:t>
             </a:r>
-            <a:endParaRPr lang="en-US" sz="900" dirty="0"/>
-          </a:p>
-        </p:txBody>
-      </p:sp>
-      <p:sp>
-        <p:nvSpPr>
-          <p:cNvPr id="41" name="Text 39"/>
-          <p:cNvSpPr txBox="1"/>
-          <p:nvPr/>
-        </p:nvSpPr>
-        <p:spPr>
-          <a:xfrm>
-            <a:off x="566928" y="5093208"/>
-            <a:ext cx="2995574" cy="365760"/>
-          </a:xfrm>
-          <a:prstGeom prst="rect">
-            <a:avLst/>
-          </a:prstGeom>
-          <a:noFill/>
-          <a:ln/>
-        </p:spPr>
-        <p:txBody>
-          <a:bodyPr wrap="square" lIns="0" tIns="0" rIns="0" bIns="0" rtlCol="0" anchor="ctr"/>
-          <a:lstStyle/>
-          <a:p>
-            <a:pPr indent="0" marL="0">
-              <a:buNone/>
-            </a:pPr>
-            <a:r>
-              <a:rPr lang="en-US" sz="1100" dirty="0">
-                <a:solidFill>
-                  <a:srgbClr val="1C2B33"/>
-                </a:solidFill>
-                <a:latin typeface="Calibri" pitchFamily="34" charset="0"/>
-                <a:ea typeface="Calibri" pitchFamily="34" charset="-122"/>
-                <a:cs typeface="Calibri" pitchFamily="34" charset="-120"/>
-              </a:rPr>
-              <a:t>P&amp;Q - Químicos</a:t>
-            </a:r>
-            <a:endParaRPr lang="en-US" sz="1100" dirty="0"/>
-          </a:p>
-        </p:txBody>
-      </p:sp>
-      <p:sp>
-        <p:nvSpPr>
-          <p:cNvPr id="42" name="Text 40"/>
-          <p:cNvSpPr txBox="1"/>
-          <p:nvPr/>
-        </p:nvSpPr>
-        <p:spPr>
-          <a:xfrm>
-            <a:off x="3452774" y="5093208"/>
-            <a:ext cx="1497787" cy="365760"/>
-          </a:xfrm>
-          <a:prstGeom prst="rect">
-            <a:avLst/>
-          </a:prstGeom>
-          <a:noFill/>
-          <a:ln/>
-        </p:spPr>
-        <p:txBody>
-          <a:bodyPr wrap="square" lIns="0" tIns="0" rIns="0" bIns="0" rtlCol="0" anchor="ctr"/>
-          <a:lstStyle/>
-          <a:p>
-            <a:pPr algn="r" indent="0" marL="0">
-              <a:buNone/>
-            </a:pPr>
-            <a:r>
-              <a:rPr lang="en-US" sz="1100" b="1" dirty="0">
-                <a:solidFill>
-                  <a:srgbClr val="0B2A3D"/>
-                </a:solidFill>
-                <a:latin typeface="Calibri" pitchFamily="34" charset="0"/>
-                <a:ea typeface="Calibri" pitchFamily="34" charset="-122"/>
-                <a:cs typeface="Calibri" pitchFamily="34" charset="-120"/>
-              </a:rPr>
-              <a:t>US$ 40,0 mil</a:t>
-            </a:r>
-            <a:endParaRPr lang="en-US" sz="1100" dirty="0"/>
-          </a:p>
-        </p:txBody>
-      </p:sp>
-      <p:sp>
-        <p:nvSpPr>
-          <p:cNvPr id="43" name="Text 41"/>
-          <p:cNvSpPr txBox="1"/>
-          <p:nvPr/>
-        </p:nvSpPr>
-        <p:spPr>
-          <a:xfrm>
-            <a:off x="4840834" y="5093208"/>
-            <a:ext cx="965606" cy="365760"/>
-          </a:xfrm>
-          <a:prstGeom prst="rect">
-            <a:avLst/>
-          </a:prstGeom>
-          <a:noFill/>
-          <a:ln/>
-        </p:spPr>
-        <p:txBody>
-          <a:bodyPr wrap="square" lIns="0" tIns="0" rIns="0" bIns="0" rtlCol="0" anchor="ctr"/>
-          <a:lstStyle/>
-          <a:p>
-            <a:pPr algn="r" indent="0" marL="0">
-              <a:buNone/>
-            </a:pPr>
-            <a:r>
-              <a:rPr lang="en-US" sz="900" dirty="0">
-                <a:solidFill>
-                  <a:srgbClr val="5B6B73"/>
-                </a:solidFill>
-                <a:latin typeface="Calibri" pitchFamily="34" charset="0"/>
-                <a:ea typeface="Calibri" pitchFamily="34" charset="-122"/>
-                <a:cs typeface="Calibri" pitchFamily="34" charset="-120"/>
-              </a:rPr>
-              <a:t>1 POB</a:t>
-            </a:r>
-            <a:endParaRPr lang="en-US" sz="900" dirty="0"/>
+            <a:endParaRPr lang="en-US" sz="850" dirty="0"/>
           </a:p>
         </p:txBody>
       </p:sp>
@@ -17971,7 +18987,7 @@
                 <a:ea typeface="Calibri" pitchFamily="34" charset="-122"/>
                 <a:cs typeface="Calibri" pitchFamily="34" charset="-120"/>
               </a:rPr>
-              <a:t>US$ 7,0 mi</a:t>
+              <a:t>US$ 9,2 mi</a:t>
             </a:r>
             <a:endParaRPr lang="en-US" sz="1100" dirty="0"/>
           </a:p>
@@ -18002,7 +19018,7 @@
               <a:buNone/>
             </a:pPr>
             <a:r>
-              <a:rPr lang="en-US" sz="900" dirty="0">
+              <a:rPr lang="en-US" sz="850" dirty="0">
                 <a:solidFill>
                   <a:srgbClr val="5B6B73"/>
                 </a:solidFill>
@@ -18010,9 +19026,9 @@
                 <a:ea typeface="Calibri" pitchFamily="34" charset="-122"/>
                 <a:cs typeface="Calibri" pitchFamily="34" charset="-120"/>
               </a:rPr>
-              <a:t>175 POB</a:t>
+              <a:t>3.447 POB-dia</a:t>
             </a:r>
-            <a:endParaRPr lang="en-US" sz="900" dirty="0"/>
+            <a:endParaRPr lang="en-US" sz="850" dirty="0"/>
           </a:p>
         </p:txBody>
       </p:sp>
@@ -18139,7 +19155,7 @@
               <a:buNone/>
             </a:pPr>
             <a:r>
-              <a:rPr lang="en-US" sz="900" dirty="0">
+              <a:rPr lang="en-US" sz="850" dirty="0">
                 <a:solidFill>
                   <a:srgbClr val="5B6B73"/>
                 </a:solidFill>
@@ -18147,9 +19163,9 @@
                 <a:ea typeface="Calibri" pitchFamily="34" charset="-122"/>
                 <a:cs typeface="Calibri" pitchFamily="34" charset="-120"/>
               </a:rPr>
-              <a:t>38 POB</a:t>
+              <a:t>988 POB-dia</a:t>
             </a:r>
-            <a:endParaRPr lang="en-US" sz="900" dirty="0"/>
+            <a:endParaRPr lang="en-US" sz="850" dirty="0"/>
           </a:p>
         </p:txBody>
       </p:sp>
@@ -18256,7 +19272,7 @@
               <a:buNone/>
             </a:pPr>
             <a:r>
-              <a:rPr lang="en-US" sz="900" dirty="0">
+              <a:rPr lang="en-US" sz="850" dirty="0">
                 <a:solidFill>
                   <a:srgbClr val="5B6B73"/>
                 </a:solidFill>
@@ -18264,9 +19280,9 @@
                 <a:ea typeface="Calibri" pitchFamily="34" charset="-122"/>
                 <a:cs typeface="Calibri" pitchFamily="34" charset="-120"/>
               </a:rPr>
-              <a:t>32 POB</a:t>
+              <a:t>674 POB-dia</a:t>
             </a:r>
-            <a:endParaRPr lang="en-US" sz="900" dirty="0"/>
+            <a:endParaRPr lang="en-US" sz="850" dirty="0"/>
           </a:p>
         </p:txBody>
       </p:sp>
@@ -18393,7 +19409,7 @@
               <a:buNone/>
             </a:pPr>
             <a:r>
-              <a:rPr lang="en-US" sz="900" dirty="0">
+              <a:rPr lang="en-US" sz="850" dirty="0">
                 <a:solidFill>
                   <a:srgbClr val="5B6B73"/>
                 </a:solidFill>
@@ -18401,15 +19417,132 @@
                 <a:ea typeface="Calibri" pitchFamily="34" charset="-122"/>
                 <a:cs typeface="Calibri" pitchFamily="34" charset="-120"/>
               </a:rPr>
-              <a:t>23 POB</a:t>
+              <a:t>392 POB-dia</a:t>
             </a:r>
-            <a:endParaRPr lang="en-US" sz="900" dirty="0"/>
+            <a:endParaRPr lang="en-US" sz="850" dirty="0"/>
           </a:p>
         </p:txBody>
       </p:sp>
       <p:sp>
         <p:nvSpPr>
           <p:cNvPr id="60" name="Text 58"/>
+          <p:cNvSpPr txBox="1"/>
+          <p:nvPr/>
+        </p:nvSpPr>
+        <p:spPr>
+          <a:xfrm>
+            <a:off x="6464808" y="4361688"/>
+            <a:ext cx="2995574" cy="365760"/>
+          </a:xfrm>
+          <a:prstGeom prst="rect">
+            <a:avLst/>
+          </a:prstGeom>
+          <a:noFill/>
+          <a:ln/>
+        </p:spPr>
+        <p:txBody>
+          <a:bodyPr wrap="square" lIns="0" tIns="0" rIns="0" bIns="0" rtlCol="0" anchor="ctr"/>
+          <a:lstStyle/>
+          <a:p>
+            <a:pPr indent="0" marL="0">
+              <a:buNone/>
+            </a:pPr>
+            <a:r>
+              <a:rPr lang="en-US" sz="1100" dirty="0">
+                <a:solidFill>
+                  <a:srgbClr val="1C2B33"/>
+                </a:solidFill>
+                <a:latin typeface="Calibri" pitchFamily="34" charset="0"/>
+                <a:ea typeface="Calibri" pitchFamily="34" charset="-122"/>
+                <a:cs typeface="Calibri" pitchFamily="34" charset="-120"/>
+              </a:rPr>
+              <a:t>Desenvolvimento de Produção</a:t>
+            </a:r>
+            <a:endParaRPr lang="en-US" sz="1100" dirty="0"/>
+          </a:p>
+        </p:txBody>
+      </p:sp>
+      <p:sp>
+        <p:nvSpPr>
+          <p:cNvPr id="61" name="Text 59"/>
+          <p:cNvSpPr txBox="1"/>
+          <p:nvPr/>
+        </p:nvSpPr>
+        <p:spPr>
+          <a:xfrm>
+            <a:off x="9350654" y="4361688"/>
+            <a:ext cx="1497787" cy="365760"/>
+          </a:xfrm>
+          <a:prstGeom prst="rect">
+            <a:avLst/>
+          </a:prstGeom>
+          <a:noFill/>
+          <a:ln/>
+        </p:spPr>
+        <p:txBody>
+          <a:bodyPr wrap="square" lIns="0" tIns="0" rIns="0" bIns="0" rtlCol="0" anchor="ctr"/>
+          <a:lstStyle/>
+          <a:p>
+            <a:pPr algn="r" indent="0" marL="0">
+              <a:buNone/>
+            </a:pPr>
+            <a:r>
+              <a:rPr lang="en-US" sz="1100" b="1" dirty="0">
+                <a:solidFill>
+                  <a:srgbClr val="0B2A3D"/>
+                </a:solidFill>
+                <a:latin typeface="Calibri" pitchFamily="34" charset="0"/>
+                <a:ea typeface="Calibri" pitchFamily="34" charset="-122"/>
+                <a:cs typeface="Calibri" pitchFamily="34" charset="-120"/>
+              </a:rPr>
+              <a:t>US$ 90,5 mil</a:t>
+            </a:r>
+            <a:endParaRPr lang="en-US" sz="1100" dirty="0"/>
+          </a:p>
+        </p:txBody>
+      </p:sp>
+      <p:sp>
+        <p:nvSpPr>
+          <p:cNvPr id="62" name="Text 60"/>
+          <p:cNvSpPr txBox="1"/>
+          <p:nvPr/>
+        </p:nvSpPr>
+        <p:spPr>
+          <a:xfrm>
+            <a:off x="10738714" y="4361688"/>
+            <a:ext cx="965606" cy="365760"/>
+          </a:xfrm>
+          <a:prstGeom prst="rect">
+            <a:avLst/>
+          </a:prstGeom>
+          <a:noFill/>
+          <a:ln/>
+        </p:spPr>
+        <p:txBody>
+          <a:bodyPr wrap="square" lIns="0" tIns="0" rIns="0" bIns="0" rtlCol="0" anchor="ctr"/>
+          <a:lstStyle/>
+          <a:p>
+            <a:pPr algn="r" indent="0" marL="0">
+              <a:buNone/>
+            </a:pPr>
+            <a:r>
+              <a:rPr lang="en-US" sz="850" dirty="0">
+                <a:solidFill>
+                  <a:srgbClr val="5B6B73"/>
+                </a:solidFill>
+                <a:latin typeface="Calibri" pitchFamily="34" charset="0"/>
+                <a:ea typeface="Calibri" pitchFamily="34" charset="-122"/>
+                <a:cs typeface="Calibri" pitchFamily="34" charset="-120"/>
+              </a:rPr>
+              <a:t>43 POB-dia</a:t>
+            </a:r>
+            <a:endParaRPr lang="en-US" sz="850" dirty="0"/>
+          </a:p>
+        </p:txBody>
+      </p:sp>
+      <p:sp>
+        <p:nvSpPr>
+          <p:cNvPr id="63" name="Text 61"/>
           <p:cNvSpPr txBox="1"/>
           <p:nvPr/>
         </p:nvSpPr>
@@ -18440,7 +19573,7 @@
                 <a:ea typeface="Calibri" pitchFamily="34" charset="-122"/>
                 <a:cs typeface="Calibri" pitchFamily="34" charset="-120"/>
               </a:rPr>
-              <a:t>Metodologia: soma de Custo de Serviço + Custo de Material (Jan–Dez), para itens de Cost Allocation = CAPEX com status 'Contar' ou 'TA'. O total desconsidera a categoria Desenvolvimento de Produção (sem itens para este ativo).</a:t>
+              <a:t>Metodologia: soma de Custo de Serviço + Custo de Material (Jan–Dez), para itens de Cost Allocation = CAPEX com status 'Contar' ou 'TA'. POB em POB-dia (pessoas a bordo × dias). O total desconsidera a categoria Desenvolvimento de Produção (US$ 90,5 mil, mantida na lista de Categoria apenas para referência).</a:t>
             </a:r>
             <a:endParaRPr lang="en-US" sz="850" dirty="0"/>
           </a:p>
@@ -22379,7 +23512,7 @@
                 <a:ea typeface="Calibri" pitchFamily="34" charset="-122"/>
                 <a:cs typeface="Calibri" pitchFamily="34" charset="-120"/>
               </a:rPr>
-              <a:t>Fonte: Plano Integrado · aba 'Geral - Em análise' · itens de Cost Allocation = CAPEX, status 'Contar' + 'TA'. Lista completa disponível na planilha em anexo.</a:t>
+              <a:t>Fonte: Plano Integrado · aba 'Geral - Em análise' · coluna 'Valor Total' · itens de Cost Allocation = CAPEX, status 'Contar' + 'TA'. Lista completa disponível na planilha em anexo. Extrato pendente de atualização — pode não somar exatamente ao total da Composição de Custo e POB.</a:t>
             </a:r>
             <a:endParaRPr lang="en-US" sz="850" dirty="0"/>
           </a:p>
@@ -22866,7 +23999,7 @@
                 <a:ea typeface="Cambria" pitchFamily="34" charset="-122"/>
                 <a:cs typeface="Cambria" pitchFamily="34" charset="-120"/>
               </a:rPr>
-              <a:t>US$ 5,9 mi</a:t>
+              <a:t>US$ 7,2 mi</a:t>
             </a:r>
             <a:endParaRPr lang="en-US" sz="2100" dirty="0"/>
           </a:p>
@@ -22966,7 +24099,7 @@
                 <a:ea typeface="Cambria" pitchFamily="34" charset="-122"/>
                 <a:cs typeface="Cambria" pitchFamily="34" charset="-120"/>
               </a:rPr>
-              <a:t>US$ 1,3 mi</a:t>
+              <a:t>US$ 8,0 mi</a:t>
             </a:r>
             <a:endParaRPr lang="en-US" sz="2100" dirty="0"/>
           </a:p>
@@ -23066,7 +24199,7 @@
                 <a:ea typeface="Cambria" pitchFamily="34" charset="-122"/>
                 <a:cs typeface="Cambria" pitchFamily="34" charset="-120"/>
               </a:rPr>
-              <a:t>US$ 7,2 mi</a:t>
+              <a:t>US$ 8,8 mi</a:t>
             </a:r>
             <a:endParaRPr lang="en-US" sz="2100" dirty="0"/>
           </a:p>
@@ -23166,7 +24299,7 @@
                 <a:ea typeface="Cambria" pitchFamily="34" charset="-122"/>
                 <a:cs typeface="Cambria" pitchFamily="34" charset="-120"/>
               </a:rPr>
-              <a:t>182</a:t>
+              <a:t>5.092</a:t>
             </a:r>
             <a:endParaRPr lang="en-US" sz="2100" dirty="0"/>
           </a:p>
@@ -23205,7 +24338,7 @@
                 <a:ea typeface="Calibri" pitchFamily="34" charset="-122"/>
                 <a:cs typeface="Calibri" pitchFamily="34" charset="-120"/>
               </a:rPr>
-              <a:t>POB TOTAL</a:t>
+              <a:t>POB TOTAL (POB-DIA)</a:t>
             </a:r>
             <a:endParaRPr lang="en-US" sz="850" dirty="0"/>
           </a:p>
@@ -23306,6 +24439,143 @@
                 <a:ea typeface="Calibri" pitchFamily="34" charset="-122"/>
                 <a:cs typeface="Calibri" pitchFamily="34" charset="-120"/>
               </a:rPr>
+              <a:t>Projetos</a:t>
+            </a:r>
+            <a:endParaRPr lang="en-US" sz="1100" dirty="0"/>
+          </a:p>
+        </p:txBody>
+      </p:sp>
+      <p:sp>
+        <p:nvSpPr>
+          <p:cNvPr id="21" name="Text 19"/>
+          <p:cNvSpPr txBox="1"/>
+          <p:nvPr/>
+        </p:nvSpPr>
+        <p:spPr>
+          <a:xfrm>
+            <a:off x="3452774" y="2898648"/>
+            <a:ext cx="1497787" cy="365760"/>
+          </a:xfrm>
+          <a:prstGeom prst="rect">
+            <a:avLst/>
+          </a:prstGeom>
+          <a:noFill/>
+          <a:ln/>
+        </p:spPr>
+        <p:txBody>
+          <a:bodyPr wrap="square" lIns="0" tIns="0" rIns="0" bIns="0" rtlCol="0" anchor="ctr"/>
+          <a:lstStyle/>
+          <a:p>
+            <a:pPr algn="r" indent="0" marL="0">
+              <a:buNone/>
+            </a:pPr>
+            <a:r>
+              <a:rPr lang="en-US" sz="1100" b="1" dirty="0">
+                <a:solidFill>
+                  <a:srgbClr val="0B2A3D"/>
+                </a:solidFill>
+                <a:latin typeface="Calibri" pitchFamily="34" charset="0"/>
+                <a:ea typeface="Calibri" pitchFamily="34" charset="-122"/>
+                <a:cs typeface="Calibri" pitchFamily="34" charset="-120"/>
+              </a:rPr>
+              <a:t>US$ 8,3 mi</a:t>
+            </a:r>
+            <a:endParaRPr lang="en-US" sz="1100" dirty="0"/>
+          </a:p>
+        </p:txBody>
+      </p:sp>
+      <p:sp>
+        <p:nvSpPr>
+          <p:cNvPr id="22" name="Text 20"/>
+          <p:cNvSpPr txBox="1"/>
+          <p:nvPr/>
+        </p:nvSpPr>
+        <p:spPr>
+          <a:xfrm>
+            <a:off x="4840834" y="2898648"/>
+            <a:ext cx="965606" cy="365760"/>
+          </a:xfrm>
+          <a:prstGeom prst="rect">
+            <a:avLst/>
+          </a:prstGeom>
+          <a:noFill/>
+          <a:ln/>
+        </p:spPr>
+        <p:txBody>
+          <a:bodyPr wrap="square" lIns="0" tIns="0" rIns="0" bIns="0" rtlCol="0" anchor="ctr"/>
+          <a:lstStyle/>
+          <a:p>
+            <a:pPr algn="r" indent="0" marL="0">
+              <a:buNone/>
+            </a:pPr>
+            <a:r>
+              <a:rPr lang="en-US" sz="850" dirty="0">
+                <a:solidFill>
+                  <a:srgbClr val="5B6B73"/>
+                </a:solidFill>
+                <a:latin typeface="Calibri" pitchFamily="34" charset="0"/>
+                <a:ea typeface="Calibri" pitchFamily="34" charset="-122"/>
+                <a:cs typeface="Calibri" pitchFamily="34" charset="-120"/>
+              </a:rPr>
+              <a:t>1.932 POB-dia</a:t>
+            </a:r>
+            <a:endParaRPr lang="en-US" sz="850" dirty="0"/>
+          </a:p>
+        </p:txBody>
+      </p:sp>
+      <p:sp>
+        <p:nvSpPr>
+          <p:cNvPr id="23" name="Shape 21"/>
+          <p:cNvSpPr/>
+          <p:nvPr/>
+        </p:nvSpPr>
+        <p:spPr>
+          <a:xfrm>
+            <a:off x="457200" y="3264408"/>
+            <a:ext cx="5349240" cy="365760"/>
+          </a:xfrm>
+          <a:prstGeom prst="rect">
+            <a:avLst/>
+          </a:prstGeom>
+          <a:solidFill>
+            <a:srgbClr val="F0F4F5"/>
+          </a:solidFill>
+          <a:ln/>
+        </p:spPr>
+      </p:sp>
+      <p:sp>
+        <p:nvSpPr>
+          <p:cNvPr id="24" name="Text 22"/>
+          <p:cNvSpPr txBox="1"/>
+          <p:nvPr/>
+        </p:nvSpPr>
+        <p:spPr>
+          <a:xfrm>
+            <a:off x="566928" y="3264408"/>
+            <a:ext cx="2995574" cy="365760"/>
+          </a:xfrm>
+          <a:prstGeom prst="rect">
+            <a:avLst/>
+          </a:prstGeom>
+          <a:noFill/>
+          <a:ln/>
+        </p:spPr>
+        <p:txBody>
+          <a:bodyPr wrap="square" lIns="0" tIns="0" rIns="0" bIns="0" rtlCol="0" anchor="ctr"/>
+          <a:lstStyle/>
+          <a:p>
+            <a:pPr indent="0" marL="0">
+              <a:buNone/>
+            </a:pPr>
+            <a:r>
+              <a:rPr lang="en-US" sz="1100" dirty="0">
+                <a:solidFill>
+                  <a:srgbClr val="1C2B33"/>
+                </a:solidFill>
+                <a:latin typeface="Calibri" pitchFamily="34" charset="0"/>
+                <a:ea typeface="Calibri" pitchFamily="34" charset="-122"/>
+                <a:cs typeface="Calibri" pitchFamily="34" charset="-120"/>
+              </a:rPr>
               <a:t>MNT – Manutenção</a:t>
             </a:r>
             <a:endParaRPr lang="en-US" sz="1100" dirty="0"/>
@@ -23314,13 +24584,13 @@
       </p:sp>
       <p:sp>
         <p:nvSpPr>
-          <p:cNvPr id="21" name="Text 19"/>
+          <p:cNvPr id="25" name="Text 23"/>
           <p:cNvSpPr txBox="1"/>
           <p:nvPr/>
         </p:nvSpPr>
         <p:spPr>
           <a:xfrm>
-            <a:off x="3452774" y="2898648"/>
+            <a:off x="3452774" y="3264408"/>
             <a:ext cx="1497787" cy="365760"/>
           </a:xfrm>
           <a:prstGeom prst="rect">
@@ -23353,13 +24623,13 @@
       </p:sp>
       <p:sp>
         <p:nvSpPr>
-          <p:cNvPr id="22" name="Text 20"/>
+          <p:cNvPr id="26" name="Text 24"/>
           <p:cNvSpPr txBox="1"/>
           <p:nvPr/>
         </p:nvSpPr>
         <p:spPr>
           <a:xfrm>
-            <a:off x="4840834" y="2898648"/>
+            <a:off x="4840834" y="3264408"/>
             <a:ext cx="965606" cy="365760"/>
           </a:xfrm>
           <a:prstGeom prst="rect">
@@ -23376,7 +24646,7 @@
               <a:buNone/>
             </a:pPr>
             <a:r>
-              <a:rPr lang="en-US" sz="900" dirty="0">
+              <a:rPr lang="en-US" sz="850" dirty="0">
                 <a:solidFill>
                   <a:srgbClr val="5B6B73"/>
                 </a:solidFill>
@@ -23384,146 +24654,9 @@
                 <a:ea typeface="Calibri" pitchFamily="34" charset="-122"/>
                 <a:cs typeface="Calibri" pitchFamily="34" charset="-120"/>
               </a:rPr>
-              <a:t>20 POB</a:t>
+              <a:t>700 POB-dia</a:t>
             </a:r>
-            <a:endParaRPr lang="en-US" sz="900" dirty="0"/>
-          </a:p>
-        </p:txBody>
-      </p:sp>
-      <p:sp>
-        <p:nvSpPr>
-          <p:cNvPr id="23" name="Shape 21"/>
-          <p:cNvSpPr/>
-          <p:nvPr/>
-        </p:nvSpPr>
-        <p:spPr>
-          <a:xfrm>
-            <a:off x="457200" y="3264408"/>
-            <a:ext cx="5349240" cy="365760"/>
-          </a:xfrm>
-          <a:prstGeom prst="rect">
-            <a:avLst/>
-          </a:prstGeom>
-          <a:solidFill>
-            <a:srgbClr val="F0F4F5"/>
-          </a:solidFill>
-          <a:ln/>
-        </p:spPr>
-      </p:sp>
-      <p:sp>
-        <p:nvSpPr>
-          <p:cNvPr id="24" name="Text 22"/>
-          <p:cNvSpPr txBox="1"/>
-          <p:nvPr/>
-        </p:nvSpPr>
-        <p:spPr>
-          <a:xfrm>
-            <a:off x="566928" y="3264408"/>
-            <a:ext cx="2995574" cy="365760"/>
-          </a:xfrm>
-          <a:prstGeom prst="rect">
-            <a:avLst/>
-          </a:prstGeom>
-          <a:noFill/>
-          <a:ln/>
-        </p:spPr>
-        <p:txBody>
-          <a:bodyPr wrap="square" lIns="0" tIns="0" rIns="0" bIns="0" rtlCol="0" anchor="ctr"/>
-          <a:lstStyle/>
-          <a:p>
-            <a:pPr indent="0" marL="0">
-              <a:buNone/>
-            </a:pPr>
-            <a:r>
-              <a:rPr lang="en-US" sz="1100" dirty="0">
-                <a:solidFill>
-                  <a:srgbClr val="1C2B33"/>
-                </a:solidFill>
-                <a:latin typeface="Calibri" pitchFamily="34" charset="0"/>
-                <a:ea typeface="Calibri" pitchFamily="34" charset="-122"/>
-                <a:cs typeface="Calibri" pitchFamily="34" charset="-120"/>
-              </a:rPr>
-              <a:t>Projetos</a:t>
-            </a:r>
-            <a:endParaRPr lang="en-US" sz="1100" dirty="0"/>
-          </a:p>
-        </p:txBody>
-      </p:sp>
-      <p:sp>
-        <p:nvSpPr>
-          <p:cNvPr id="25" name="Text 23"/>
-          <p:cNvSpPr txBox="1"/>
-          <p:nvPr/>
-        </p:nvSpPr>
-        <p:spPr>
-          <a:xfrm>
-            <a:off x="3452774" y="3264408"/>
-            <a:ext cx="1497787" cy="365760"/>
-          </a:xfrm>
-          <a:prstGeom prst="rect">
-            <a:avLst/>
-          </a:prstGeom>
-          <a:noFill/>
-          <a:ln/>
-        </p:spPr>
-        <p:txBody>
-          <a:bodyPr wrap="square" lIns="0" tIns="0" rIns="0" bIns="0" rtlCol="0" anchor="ctr"/>
-          <a:lstStyle/>
-          <a:p>
-            <a:pPr algn="r" indent="0" marL="0">
-              <a:buNone/>
-            </a:pPr>
-            <a:r>
-              <a:rPr lang="en-US" sz="1100" b="1" dirty="0">
-                <a:solidFill>
-                  <a:srgbClr val="0B2A3D"/>
-                </a:solidFill>
-                <a:latin typeface="Calibri" pitchFamily="34" charset="0"/>
-                <a:ea typeface="Calibri" pitchFamily="34" charset="-122"/>
-                <a:cs typeface="Calibri" pitchFamily="34" charset="-120"/>
-              </a:rPr>
-              <a:t>US$ 2,2 mi</a:t>
-            </a:r>
-            <a:endParaRPr lang="en-US" sz="1100" dirty="0"/>
-          </a:p>
-        </p:txBody>
-      </p:sp>
-      <p:sp>
-        <p:nvSpPr>
-          <p:cNvPr id="26" name="Text 24"/>
-          <p:cNvSpPr txBox="1"/>
-          <p:nvPr/>
-        </p:nvSpPr>
-        <p:spPr>
-          <a:xfrm>
-            <a:off x="4840834" y="3264408"/>
-            <a:ext cx="965606" cy="365760"/>
-          </a:xfrm>
-          <a:prstGeom prst="rect">
-            <a:avLst/>
-          </a:prstGeom>
-          <a:noFill/>
-          <a:ln/>
-        </p:spPr>
-        <p:txBody>
-          <a:bodyPr wrap="square" lIns="0" tIns="0" rIns="0" bIns="0" rtlCol="0" anchor="ctr"/>
-          <a:lstStyle/>
-          <a:p>
-            <a:pPr algn="r" indent="0" marL="0">
-              <a:buNone/>
-            </a:pPr>
-            <a:r>
-              <a:rPr lang="en-US" sz="900" dirty="0">
-                <a:solidFill>
-                  <a:srgbClr val="5B6B73"/>
-                </a:solidFill>
-                <a:latin typeface="Calibri" pitchFamily="34" charset="0"/>
-                <a:ea typeface="Calibri" pitchFamily="34" charset="-122"/>
-                <a:cs typeface="Calibri" pitchFamily="34" charset="-120"/>
-              </a:rPr>
-              <a:t>54 POB</a:t>
-            </a:r>
-            <a:endParaRPr lang="en-US" sz="900" dirty="0"/>
+            <a:endParaRPr lang="en-US" sz="850" dirty="0"/>
           </a:p>
         </p:txBody>
       </p:sp>
@@ -23599,7 +24732,7 @@
                 <a:ea typeface="Calibri" pitchFamily="34" charset="-122"/>
                 <a:cs typeface="Calibri" pitchFamily="34" charset="-120"/>
               </a:rPr>
-              <a:t>US$ 897,7 mil</a:t>
+              <a:t>US$ 2,5 mi</a:t>
             </a:r>
             <a:endParaRPr lang="en-US" sz="1100" dirty="0"/>
           </a:p>
@@ -23630,7 +24763,7 @@
               <a:buNone/>
             </a:pPr>
             <a:r>
-              <a:rPr lang="en-US" sz="900" dirty="0">
+              <a:rPr lang="en-US" sz="850" dirty="0">
                 <a:solidFill>
                   <a:srgbClr val="5B6B73"/>
                 </a:solidFill>
@@ -23638,9 +24771,9 @@
                 <a:ea typeface="Calibri" pitchFamily="34" charset="-122"/>
                 <a:cs typeface="Calibri" pitchFamily="34" charset="-120"/>
               </a:rPr>
-              <a:t>101 POB</a:t>
+              <a:t>2.280 POB-dia</a:t>
             </a:r>
-            <a:endParaRPr lang="en-US" sz="900" dirty="0"/>
+            <a:endParaRPr lang="en-US" sz="850" dirty="0"/>
           </a:p>
         </p:txBody>
       </p:sp>
@@ -23767,7 +24900,7 @@
               <a:buNone/>
             </a:pPr>
             <a:r>
-              <a:rPr lang="en-US" sz="900" dirty="0">
+              <a:rPr lang="en-US" sz="850" dirty="0">
                 <a:solidFill>
                   <a:srgbClr val="5B6B73"/>
                 </a:solidFill>
@@ -23775,9 +24908,9 @@
                 <a:ea typeface="Calibri" pitchFamily="34" charset="-122"/>
                 <a:cs typeface="Calibri" pitchFamily="34" charset="-120"/>
               </a:rPr>
-              <a:t>5 POB</a:t>
+              <a:t>150 POB-dia</a:t>
             </a:r>
-            <a:endParaRPr lang="en-US" sz="900" dirty="0"/>
+            <a:endParaRPr lang="en-US" sz="850" dirty="0"/>
           </a:p>
         </p:txBody>
       </p:sp>
@@ -23790,6 +24923,143 @@
         <p:spPr>
           <a:xfrm>
             <a:off x="566928" y="4361688"/>
+            <a:ext cx="2995574" cy="365760"/>
+          </a:xfrm>
+          <a:prstGeom prst="rect">
+            <a:avLst/>
+          </a:prstGeom>
+          <a:noFill/>
+          <a:ln/>
+        </p:spPr>
+        <p:txBody>
+          <a:bodyPr wrap="square" lIns="0" tIns="0" rIns="0" bIns="0" rtlCol="0" anchor="ctr"/>
+          <a:lstStyle/>
+          <a:p>
+            <a:pPr indent="0" marL="0">
+              <a:buNone/>
+            </a:pPr>
+            <a:r>
+              <a:rPr lang="en-US" sz="1100" dirty="0">
+                <a:solidFill>
+                  <a:srgbClr val="1C2B33"/>
+                </a:solidFill>
+                <a:latin typeface="Calibri" pitchFamily="34" charset="0"/>
+                <a:ea typeface="Calibri" pitchFamily="34" charset="-122"/>
+                <a:cs typeface="Calibri" pitchFamily="34" charset="-120"/>
+              </a:rPr>
+              <a:t>P&amp;Q - Processos</a:t>
+            </a:r>
+            <a:endParaRPr lang="en-US" sz="1100" dirty="0"/>
+          </a:p>
+        </p:txBody>
+      </p:sp>
+      <p:sp>
+        <p:nvSpPr>
+          <p:cNvPr id="35" name="Text 33"/>
+          <p:cNvSpPr txBox="1"/>
+          <p:nvPr/>
+        </p:nvSpPr>
+        <p:spPr>
+          <a:xfrm>
+            <a:off x="3452774" y="4361688"/>
+            <a:ext cx="1497787" cy="365760"/>
+          </a:xfrm>
+          <a:prstGeom prst="rect">
+            <a:avLst/>
+          </a:prstGeom>
+          <a:noFill/>
+          <a:ln/>
+        </p:spPr>
+        <p:txBody>
+          <a:bodyPr wrap="square" lIns="0" tIns="0" rIns="0" bIns="0" rtlCol="0" anchor="ctr"/>
+          <a:lstStyle/>
+          <a:p>
+            <a:pPr algn="r" indent="0" marL="0">
+              <a:buNone/>
+            </a:pPr>
+            <a:r>
+              <a:rPr lang="en-US" sz="1100" b="1" dirty="0">
+                <a:solidFill>
+                  <a:srgbClr val="0B2A3D"/>
+                </a:solidFill>
+                <a:latin typeface="Calibri" pitchFamily="34" charset="0"/>
+                <a:ea typeface="Calibri" pitchFamily="34" charset="-122"/>
+                <a:cs typeface="Calibri" pitchFamily="34" charset="-120"/>
+              </a:rPr>
+              <a:t>US$ 150,5 mil</a:t>
+            </a:r>
+            <a:endParaRPr lang="en-US" sz="1100" dirty="0"/>
+          </a:p>
+        </p:txBody>
+      </p:sp>
+      <p:sp>
+        <p:nvSpPr>
+          <p:cNvPr id="36" name="Text 34"/>
+          <p:cNvSpPr txBox="1"/>
+          <p:nvPr/>
+        </p:nvSpPr>
+        <p:spPr>
+          <a:xfrm>
+            <a:off x="4840834" y="4361688"/>
+            <a:ext cx="965606" cy="365760"/>
+          </a:xfrm>
+          <a:prstGeom prst="rect">
+            <a:avLst/>
+          </a:prstGeom>
+          <a:noFill/>
+          <a:ln/>
+        </p:spPr>
+        <p:txBody>
+          <a:bodyPr wrap="square" lIns="0" tIns="0" rIns="0" bIns="0" rtlCol="0" anchor="ctr"/>
+          <a:lstStyle/>
+          <a:p>
+            <a:pPr algn="r" indent="0" marL="0">
+              <a:buNone/>
+            </a:pPr>
+            <a:r>
+              <a:rPr lang="en-US" sz="850" dirty="0">
+                <a:solidFill>
+                  <a:srgbClr val="5B6B73"/>
+                </a:solidFill>
+                <a:latin typeface="Calibri" pitchFamily="34" charset="0"/>
+                <a:ea typeface="Calibri" pitchFamily="34" charset="-122"/>
+                <a:cs typeface="Calibri" pitchFamily="34" charset="-120"/>
+              </a:rPr>
+              <a:t>14 POB-dia</a:t>
+            </a:r>
+            <a:endParaRPr lang="en-US" sz="850" dirty="0"/>
+          </a:p>
+        </p:txBody>
+      </p:sp>
+      <p:sp>
+        <p:nvSpPr>
+          <p:cNvPr id="37" name="Shape 35"/>
+          <p:cNvSpPr/>
+          <p:nvPr/>
+        </p:nvSpPr>
+        <p:spPr>
+          <a:xfrm>
+            <a:off x="457200" y="4727448"/>
+            <a:ext cx="5349240" cy="365760"/>
+          </a:xfrm>
+          <a:prstGeom prst="rect">
+            <a:avLst/>
+          </a:prstGeom>
+          <a:solidFill>
+            <a:srgbClr val="F0F4F5"/>
+          </a:solidFill>
+          <a:ln/>
+        </p:spPr>
+      </p:sp>
+      <p:sp>
+        <p:nvSpPr>
+          <p:cNvPr id="38" name="Text 36"/>
+          <p:cNvSpPr txBox="1"/>
+          <p:nvPr/>
+        </p:nvSpPr>
+        <p:spPr>
+          <a:xfrm>
+            <a:off x="566928" y="4727448"/>
             <a:ext cx="2995574" cy="365760"/>
           </a:xfrm>
           <a:prstGeom prst="rect">
@@ -23822,13 +25092,13 @@
       </p:sp>
       <p:sp>
         <p:nvSpPr>
-          <p:cNvPr id="35" name="Text 33"/>
+          <p:cNvPr id="39" name="Text 37"/>
           <p:cNvSpPr txBox="1"/>
           <p:nvPr/>
         </p:nvSpPr>
         <p:spPr>
           <a:xfrm>
-            <a:off x="3452774" y="4361688"/>
+            <a:off x="3452774" y="4727448"/>
             <a:ext cx="1497787" cy="365760"/>
           </a:xfrm>
           <a:prstGeom prst="rect">
@@ -23853,7 +25123,7 @@
                 <a:ea typeface="Calibri" pitchFamily="34" charset="-122"/>
                 <a:cs typeface="Calibri" pitchFamily="34" charset="-120"/>
               </a:rPr>
-              <a:t>US$ 30,0 mil</a:t>
+              <a:t>US$ 40,0 mil</a:t>
             </a:r>
             <a:endParaRPr lang="en-US" sz="1100" dirty="0"/>
           </a:p>
@@ -23861,13 +25131,13 @@
       </p:sp>
       <p:sp>
         <p:nvSpPr>
-          <p:cNvPr id="36" name="Text 34"/>
+          <p:cNvPr id="40" name="Text 38"/>
           <p:cNvSpPr txBox="1"/>
           <p:nvPr/>
         </p:nvSpPr>
         <p:spPr>
           <a:xfrm>
-            <a:off x="4840834" y="4361688"/>
+            <a:off x="4840834" y="4727448"/>
             <a:ext cx="965606" cy="365760"/>
           </a:xfrm>
           <a:prstGeom prst="rect">
@@ -23884,7 +25154,7 @@
               <a:buNone/>
             </a:pPr>
             <a:r>
-              <a:rPr lang="en-US" sz="900" dirty="0">
+              <a:rPr lang="en-US" sz="850" dirty="0">
                 <a:solidFill>
                   <a:srgbClr val="5B6B73"/>
                 </a:solidFill>
@@ -23892,41 +25162,21 @@
                 <a:ea typeface="Calibri" pitchFamily="34" charset="-122"/>
                 <a:cs typeface="Calibri" pitchFamily="34" charset="-120"/>
               </a:rPr>
-              <a:t>2 POB</a:t>
+              <a:t>16 POB-dia</a:t>
             </a:r>
-            <a:endParaRPr lang="en-US" sz="900" dirty="0"/>
+            <a:endParaRPr lang="en-US" sz="850" dirty="0"/>
           </a:p>
         </p:txBody>
       </p:sp>
       <p:sp>
         <p:nvSpPr>
-          <p:cNvPr id="37" name="Shape 35"/>
-          <p:cNvSpPr/>
-          <p:nvPr/>
-        </p:nvSpPr>
-        <p:spPr>
-          <a:xfrm>
-            <a:off x="457200" y="4727448"/>
-            <a:ext cx="5349240" cy="365760"/>
-          </a:xfrm>
-          <a:prstGeom prst="rect">
-            <a:avLst/>
-          </a:prstGeom>
-          <a:solidFill>
-            <a:srgbClr val="F0F4F5"/>
-          </a:solidFill>
-          <a:ln/>
-        </p:spPr>
-      </p:sp>
-      <p:sp>
-        <p:nvSpPr>
-          <p:cNvPr id="38" name="Text 36"/>
+          <p:cNvPr id="41" name="Text 39"/>
           <p:cNvSpPr txBox="1"/>
           <p:nvPr/>
         </p:nvSpPr>
         <p:spPr>
           <a:xfrm>
-            <a:off x="566928" y="4727448"/>
+            <a:off x="566928" y="5093208"/>
             <a:ext cx="2995574" cy="365760"/>
           </a:xfrm>
           <a:prstGeom prst="rect">
@@ -23959,13 +25209,13 @@
       </p:sp>
       <p:sp>
         <p:nvSpPr>
-          <p:cNvPr id="39" name="Text 37"/>
+          <p:cNvPr id="42" name="Text 40"/>
           <p:cNvSpPr txBox="1"/>
           <p:nvPr/>
         </p:nvSpPr>
         <p:spPr>
           <a:xfrm>
-            <a:off x="3452774" y="4727448"/>
+            <a:off x="3452774" y="5093208"/>
             <a:ext cx="1497787" cy="365760"/>
           </a:xfrm>
           <a:prstGeom prst="rect">
@@ -23998,13 +25248,13 @@
       </p:sp>
       <p:sp>
         <p:nvSpPr>
-          <p:cNvPr id="40" name="Text 38"/>
+          <p:cNvPr id="43" name="Text 41"/>
           <p:cNvSpPr txBox="1"/>
           <p:nvPr/>
         </p:nvSpPr>
         <p:spPr>
           <a:xfrm>
-            <a:off x="4840834" y="4727448"/>
+            <a:off x="4840834" y="5093208"/>
             <a:ext cx="965606" cy="365760"/>
           </a:xfrm>
           <a:prstGeom prst="rect">
@@ -24021,7 +25271,7 @@
               <a:buNone/>
             </a:pPr>
             <a:r>
-              <a:rPr lang="en-US" sz="900" dirty="0">
+              <a:rPr lang="en-US" sz="850" dirty="0">
                 <a:solidFill>
                   <a:srgbClr val="5B6B73"/>
                 </a:solidFill>
@@ -24029,15 +25279,15 @@
                 <a:ea typeface="Calibri" pitchFamily="34" charset="-122"/>
                 <a:cs typeface="Calibri" pitchFamily="34" charset="-120"/>
               </a:rPr>
-              <a:t>0 POB</a:t>
+              <a:t>0 POB-dia</a:t>
             </a:r>
-            <a:endParaRPr lang="en-US" sz="900" dirty="0"/>
+            <a:endParaRPr lang="en-US" sz="850" dirty="0"/>
           </a:p>
         </p:txBody>
       </p:sp>
       <p:sp>
         <p:nvSpPr>
-          <p:cNvPr id="41" name="Text 39"/>
+          <p:cNvPr id="44" name="Text 42"/>
           <p:cNvSpPr txBox="1"/>
           <p:nvPr/>
         </p:nvSpPr>
@@ -24076,7 +25326,7 @@
       </p:sp>
       <p:sp>
         <p:nvSpPr>
-          <p:cNvPr id="42" name="Shape 40"/>
+          <p:cNvPr id="45" name="Shape 43"/>
           <p:cNvSpPr/>
           <p:nvPr/>
         </p:nvSpPr>
@@ -24099,13 +25349,267 @@
       </p:sp>
       <p:sp>
         <p:nvSpPr>
-          <p:cNvPr id="43" name="Text 41"/>
+          <p:cNvPr id="46" name="Text 44"/>
           <p:cNvSpPr txBox="1"/>
           <p:nvPr/>
         </p:nvSpPr>
         <p:spPr>
           <a:xfrm>
             <a:off x="6464808" y="2898648"/>
+            <a:ext cx="2995574" cy="365760"/>
+          </a:xfrm>
+          <a:prstGeom prst="rect">
+            <a:avLst/>
+          </a:prstGeom>
+          <a:noFill/>
+          <a:ln/>
+        </p:spPr>
+        <p:txBody>
+          <a:bodyPr wrap="square" lIns="0" tIns="0" rIns="0" bIns="0" rtlCol="0" anchor="ctr"/>
+          <a:lstStyle/>
+          <a:p>
+            <a:pPr indent="0" marL="0">
+              <a:buNone/>
+            </a:pPr>
+            <a:r>
+              <a:rPr lang="en-US" sz="1100" dirty="0">
+                <a:solidFill>
+                  <a:srgbClr val="1C2B33"/>
+                </a:solidFill>
+                <a:latin typeface="Calibri" pitchFamily="34" charset="0"/>
+                <a:ea typeface="Calibri" pitchFamily="34" charset="-122"/>
+                <a:cs typeface="Calibri" pitchFamily="34" charset="-120"/>
+              </a:rPr>
+              <a:t>Desenvolvimento de Produção</a:t>
+            </a:r>
+            <a:endParaRPr lang="en-US" sz="1100" dirty="0"/>
+          </a:p>
+        </p:txBody>
+      </p:sp>
+      <p:sp>
+        <p:nvSpPr>
+          <p:cNvPr id="47" name="Text 45"/>
+          <p:cNvSpPr txBox="1"/>
+          <p:nvPr/>
+        </p:nvSpPr>
+        <p:spPr>
+          <a:xfrm>
+            <a:off x="9350654" y="2898648"/>
+            <a:ext cx="1497787" cy="365760"/>
+          </a:xfrm>
+          <a:prstGeom prst="rect">
+            <a:avLst/>
+          </a:prstGeom>
+          <a:noFill/>
+          <a:ln/>
+        </p:spPr>
+        <p:txBody>
+          <a:bodyPr wrap="square" lIns="0" tIns="0" rIns="0" bIns="0" rtlCol="0" anchor="ctr"/>
+          <a:lstStyle/>
+          <a:p>
+            <a:pPr algn="r" indent="0" marL="0">
+              <a:buNone/>
+            </a:pPr>
+            <a:r>
+              <a:rPr lang="en-US" sz="1100" b="1" dirty="0">
+                <a:solidFill>
+                  <a:srgbClr val="0B2A3D"/>
+                </a:solidFill>
+                <a:latin typeface="Calibri" pitchFamily="34" charset="0"/>
+                <a:ea typeface="Calibri" pitchFamily="34" charset="-122"/>
+                <a:cs typeface="Calibri" pitchFamily="34" charset="-120"/>
+              </a:rPr>
+              <a:t>US$ 6,3 mi</a:t>
+            </a:r>
+            <a:endParaRPr lang="en-US" sz="1100" dirty="0"/>
+          </a:p>
+        </p:txBody>
+      </p:sp>
+      <p:sp>
+        <p:nvSpPr>
+          <p:cNvPr id="48" name="Text 46"/>
+          <p:cNvSpPr txBox="1"/>
+          <p:nvPr/>
+        </p:nvSpPr>
+        <p:spPr>
+          <a:xfrm>
+            <a:off x="10738714" y="2898648"/>
+            <a:ext cx="965606" cy="365760"/>
+          </a:xfrm>
+          <a:prstGeom prst="rect">
+            <a:avLst/>
+          </a:prstGeom>
+          <a:noFill/>
+          <a:ln/>
+        </p:spPr>
+        <p:txBody>
+          <a:bodyPr wrap="square" lIns="0" tIns="0" rIns="0" bIns="0" rtlCol="0" anchor="ctr"/>
+          <a:lstStyle/>
+          <a:p>
+            <a:pPr algn="r" indent="0" marL="0">
+              <a:buNone/>
+            </a:pPr>
+            <a:r>
+              <a:rPr lang="en-US" sz="850" dirty="0">
+                <a:solidFill>
+                  <a:srgbClr val="5B6B73"/>
+                </a:solidFill>
+                <a:latin typeface="Calibri" pitchFamily="34" charset="0"/>
+                <a:ea typeface="Calibri" pitchFamily="34" charset="-122"/>
+                <a:cs typeface="Calibri" pitchFamily="34" charset="-120"/>
+              </a:rPr>
+              <a:t>990 POB-dia</a:t>
+            </a:r>
+            <a:endParaRPr lang="en-US" sz="850" dirty="0"/>
+          </a:p>
+        </p:txBody>
+      </p:sp>
+      <p:sp>
+        <p:nvSpPr>
+          <p:cNvPr id="49" name="Shape 47"/>
+          <p:cNvSpPr/>
+          <p:nvPr/>
+        </p:nvSpPr>
+        <p:spPr>
+          <a:xfrm>
+            <a:off x="6355080" y="3264408"/>
+            <a:ext cx="5349240" cy="365760"/>
+          </a:xfrm>
+          <a:prstGeom prst="rect">
+            <a:avLst/>
+          </a:prstGeom>
+          <a:solidFill>
+            <a:srgbClr val="F0F4F5"/>
+          </a:solidFill>
+          <a:ln/>
+        </p:spPr>
+      </p:sp>
+      <p:sp>
+        <p:nvSpPr>
+          <p:cNvPr id="50" name="Text 48"/>
+          <p:cNvSpPr txBox="1"/>
+          <p:nvPr/>
+        </p:nvSpPr>
+        <p:spPr>
+          <a:xfrm>
+            <a:off x="6464808" y="3264408"/>
+            <a:ext cx="2995574" cy="365760"/>
+          </a:xfrm>
+          <a:prstGeom prst="rect">
+            <a:avLst/>
+          </a:prstGeom>
+          <a:noFill/>
+          <a:ln/>
+        </p:spPr>
+        <p:txBody>
+          <a:bodyPr wrap="square" lIns="0" tIns="0" rIns="0" bIns="0" rtlCol="0" anchor="ctr"/>
+          <a:lstStyle/>
+          <a:p>
+            <a:pPr indent="0" marL="0">
+              <a:buNone/>
+            </a:pPr>
+            <a:r>
+              <a:rPr lang="en-US" sz="1100" dirty="0">
+                <a:solidFill>
+                  <a:srgbClr val="1C2B33"/>
+                </a:solidFill>
+                <a:latin typeface="Calibri" pitchFamily="34" charset="0"/>
+                <a:ea typeface="Calibri" pitchFamily="34" charset="-122"/>
+                <a:cs typeface="Calibri" pitchFamily="34" charset="-120"/>
+              </a:rPr>
+              <a:t>Eficiência de Produção</a:t>
+            </a:r>
+            <a:endParaRPr lang="en-US" sz="1100" dirty="0"/>
+          </a:p>
+        </p:txBody>
+      </p:sp>
+      <p:sp>
+        <p:nvSpPr>
+          <p:cNvPr id="51" name="Text 49"/>
+          <p:cNvSpPr txBox="1"/>
+          <p:nvPr/>
+        </p:nvSpPr>
+        <p:spPr>
+          <a:xfrm>
+            <a:off x="9350654" y="3264408"/>
+            <a:ext cx="1497787" cy="365760"/>
+          </a:xfrm>
+          <a:prstGeom prst="rect">
+            <a:avLst/>
+          </a:prstGeom>
+          <a:noFill/>
+          <a:ln/>
+        </p:spPr>
+        <p:txBody>
+          <a:bodyPr wrap="square" lIns="0" tIns="0" rIns="0" bIns="0" rtlCol="0" anchor="ctr"/>
+          <a:lstStyle/>
+          <a:p>
+            <a:pPr algn="r" indent="0" marL="0">
+              <a:buNone/>
+            </a:pPr>
+            <a:r>
+              <a:rPr lang="en-US" sz="1100" b="1" dirty="0">
+                <a:solidFill>
+                  <a:srgbClr val="0B2A3D"/>
+                </a:solidFill>
+                <a:latin typeface="Calibri" pitchFamily="34" charset="0"/>
+                <a:ea typeface="Calibri" pitchFamily="34" charset="-122"/>
+                <a:cs typeface="Calibri" pitchFamily="34" charset="-120"/>
+              </a:rPr>
+              <a:t>US$ 3,7 mi</a:t>
+            </a:r>
+            <a:endParaRPr lang="en-US" sz="1100" dirty="0"/>
+          </a:p>
+        </p:txBody>
+      </p:sp>
+      <p:sp>
+        <p:nvSpPr>
+          <p:cNvPr id="52" name="Text 50"/>
+          <p:cNvSpPr txBox="1"/>
+          <p:nvPr/>
+        </p:nvSpPr>
+        <p:spPr>
+          <a:xfrm>
+            <a:off x="10738714" y="3264408"/>
+            <a:ext cx="965606" cy="365760"/>
+          </a:xfrm>
+          <a:prstGeom prst="rect">
+            <a:avLst/>
+          </a:prstGeom>
+          <a:noFill/>
+          <a:ln/>
+        </p:spPr>
+        <p:txBody>
+          <a:bodyPr wrap="square" lIns="0" tIns="0" rIns="0" bIns="0" rtlCol="0" anchor="ctr"/>
+          <a:lstStyle/>
+          <a:p>
+            <a:pPr algn="r" indent="0" marL="0">
+              <a:buNone/>
+            </a:pPr>
+            <a:r>
+              <a:rPr lang="en-US" sz="850" dirty="0">
+                <a:solidFill>
+                  <a:srgbClr val="5B6B73"/>
+                </a:solidFill>
+                <a:latin typeface="Calibri" pitchFamily="34" charset="0"/>
+                <a:ea typeface="Calibri" pitchFamily="34" charset="-122"/>
+                <a:cs typeface="Calibri" pitchFamily="34" charset="-120"/>
+              </a:rPr>
+              <a:t>2.860 POB-dia</a:t>
+            </a:r>
+            <a:endParaRPr lang="en-US" sz="850" dirty="0"/>
+          </a:p>
+        </p:txBody>
+      </p:sp>
+      <p:sp>
+        <p:nvSpPr>
+          <p:cNvPr id="53" name="Text 51"/>
+          <p:cNvSpPr txBox="1"/>
+          <p:nvPr/>
+        </p:nvSpPr>
+        <p:spPr>
+          <a:xfrm>
+            <a:off x="6464808" y="3630168"/>
             <a:ext cx="2995574" cy="365760"/>
           </a:xfrm>
           <a:prstGeom prst="rect">
@@ -24138,13 +25642,13 @@
       </p:sp>
       <p:sp>
         <p:nvSpPr>
-          <p:cNvPr id="44" name="Text 42"/>
+          <p:cNvPr id="54" name="Text 52"/>
           <p:cNvSpPr txBox="1"/>
           <p:nvPr/>
         </p:nvSpPr>
         <p:spPr>
           <a:xfrm>
-            <a:off x="9350654" y="2898648"/>
+            <a:off x="9350654" y="3630168"/>
             <a:ext cx="1497787" cy="365760"/>
           </a:xfrm>
           <a:prstGeom prst="rect">
@@ -24177,13 +25681,13 @@
       </p:sp>
       <p:sp>
         <p:nvSpPr>
-          <p:cNvPr id="45" name="Text 43"/>
+          <p:cNvPr id="55" name="Text 53"/>
           <p:cNvSpPr txBox="1"/>
           <p:nvPr/>
         </p:nvSpPr>
         <p:spPr>
           <a:xfrm>
-            <a:off x="10738714" y="2898648"/>
+            <a:off x="10738714" y="3630168"/>
             <a:ext cx="965606" cy="365760"/>
           </a:xfrm>
           <a:prstGeom prst="rect">
@@ -24200,7 +25704,7 @@
               <a:buNone/>
             </a:pPr>
             <a:r>
-              <a:rPr lang="en-US" sz="900" dirty="0">
+              <a:rPr lang="en-US" sz="850" dirty="0">
                 <a:solidFill>
                   <a:srgbClr val="5B6B73"/>
                 </a:solidFill>
@@ -24208,21 +25712,21 @@
                 <a:ea typeface="Calibri" pitchFamily="34" charset="-122"/>
                 <a:cs typeface="Calibri" pitchFamily="34" charset="-120"/>
               </a:rPr>
-              <a:t>20 POB</a:t>
+              <a:t>700 POB-dia</a:t>
             </a:r>
-            <a:endParaRPr lang="en-US" sz="900" dirty="0"/>
+            <a:endParaRPr lang="en-US" sz="850" dirty="0"/>
           </a:p>
         </p:txBody>
       </p:sp>
       <p:sp>
         <p:nvSpPr>
-          <p:cNvPr id="46" name="Shape 44"/>
+          <p:cNvPr id="56" name="Shape 54"/>
           <p:cNvSpPr/>
           <p:nvPr/>
         </p:nvSpPr>
         <p:spPr>
           <a:xfrm>
-            <a:off x="6355080" y="3264408"/>
+            <a:off x="6355080" y="3995928"/>
             <a:ext cx="5349240" cy="365760"/>
           </a:xfrm>
           <a:prstGeom prst="rect">
@@ -24236,130 +25740,13 @@
       </p:sp>
       <p:sp>
         <p:nvSpPr>
-          <p:cNvPr id="47" name="Text 45"/>
+          <p:cNvPr id="57" name="Text 55"/>
           <p:cNvSpPr txBox="1"/>
           <p:nvPr/>
         </p:nvSpPr>
         <p:spPr>
           <a:xfrm>
-            <a:off x="6464808" y="3264408"/>
-            <a:ext cx="2995574" cy="365760"/>
-          </a:xfrm>
-          <a:prstGeom prst="rect">
-            <a:avLst/>
-          </a:prstGeom>
-          <a:noFill/>
-          <a:ln/>
-        </p:spPr>
-        <p:txBody>
-          <a:bodyPr wrap="square" lIns="0" tIns="0" rIns="0" bIns="0" rtlCol="0" anchor="ctr"/>
-          <a:lstStyle/>
-          <a:p>
-            <a:pPr indent="0" marL="0">
-              <a:buNone/>
-            </a:pPr>
-            <a:r>
-              <a:rPr lang="en-US" sz="1100" dirty="0">
-                <a:solidFill>
-                  <a:srgbClr val="1C2B33"/>
-                </a:solidFill>
-                <a:latin typeface="Calibri" pitchFamily="34" charset="0"/>
-                <a:ea typeface="Calibri" pitchFamily="34" charset="-122"/>
-                <a:cs typeface="Calibri" pitchFamily="34" charset="-120"/>
-              </a:rPr>
-              <a:t>Eficiência de Produção</a:t>
-            </a:r>
-            <a:endParaRPr lang="en-US" sz="1100" dirty="0"/>
-          </a:p>
-        </p:txBody>
-      </p:sp>
-      <p:sp>
-        <p:nvSpPr>
-          <p:cNvPr id="48" name="Text 46"/>
-          <p:cNvSpPr txBox="1"/>
-          <p:nvPr/>
-        </p:nvSpPr>
-        <p:spPr>
-          <a:xfrm>
-            <a:off x="9350654" y="3264408"/>
-            <a:ext cx="1497787" cy="365760"/>
-          </a:xfrm>
-          <a:prstGeom prst="rect">
-            <a:avLst/>
-          </a:prstGeom>
-          <a:noFill/>
-          <a:ln/>
-        </p:spPr>
-        <p:txBody>
-          <a:bodyPr wrap="square" lIns="0" tIns="0" rIns="0" bIns="0" rtlCol="0" anchor="ctr"/>
-          <a:lstStyle/>
-          <a:p>
-            <a:pPr algn="r" indent="0" marL="0">
-              <a:buNone/>
-            </a:pPr>
-            <a:r>
-              <a:rPr lang="en-US" sz="1100" b="1" dirty="0">
-                <a:solidFill>
-                  <a:srgbClr val="0B2A3D"/>
-                </a:solidFill>
-                <a:latin typeface="Calibri" pitchFamily="34" charset="0"/>
-                <a:ea typeface="Calibri" pitchFamily="34" charset="-122"/>
-                <a:cs typeface="Calibri" pitchFamily="34" charset="-120"/>
-              </a:rPr>
-              <a:t>US$ 2,1 mi</a:t>
-            </a:r>
-            <a:endParaRPr lang="en-US" sz="1100" dirty="0"/>
-          </a:p>
-        </p:txBody>
-      </p:sp>
-      <p:sp>
-        <p:nvSpPr>
-          <p:cNvPr id="49" name="Text 47"/>
-          <p:cNvSpPr txBox="1"/>
-          <p:nvPr/>
-        </p:nvSpPr>
-        <p:spPr>
-          <a:xfrm>
-            <a:off x="10738714" y="3264408"/>
-            <a:ext cx="965606" cy="365760"/>
-          </a:xfrm>
-          <a:prstGeom prst="rect">
-            <a:avLst/>
-          </a:prstGeom>
-          <a:noFill/>
-          <a:ln/>
-        </p:spPr>
-        <p:txBody>
-          <a:bodyPr wrap="square" lIns="0" tIns="0" rIns="0" bIns="0" rtlCol="0" anchor="ctr"/>
-          <a:lstStyle/>
-          <a:p>
-            <a:pPr algn="r" indent="0" marL="0">
-              <a:buNone/>
-            </a:pPr>
-            <a:r>
-              <a:rPr lang="en-US" sz="900" dirty="0">
-                <a:solidFill>
-                  <a:srgbClr val="5B6B73"/>
-                </a:solidFill>
-                <a:latin typeface="Calibri" pitchFamily="34" charset="0"/>
-                <a:ea typeface="Calibri" pitchFamily="34" charset="-122"/>
-                <a:cs typeface="Calibri" pitchFamily="34" charset="-120"/>
-              </a:rPr>
-              <a:t>132 POB</a:t>
-            </a:r>
-            <a:endParaRPr lang="en-US" sz="900" dirty="0"/>
-          </a:p>
-        </p:txBody>
-      </p:sp>
-      <p:sp>
-        <p:nvSpPr>
-          <p:cNvPr id="50" name="Text 48"/>
-          <p:cNvSpPr txBox="1"/>
-          <p:nvPr/>
-        </p:nvSpPr>
-        <p:spPr>
-          <a:xfrm>
-            <a:off x="6464808" y="3630168"/>
+            <a:off x="6464808" y="3995928"/>
             <a:ext cx="2995574" cy="365760"/>
           </a:xfrm>
           <a:prstGeom prst="rect">
@@ -24392,13 +25779,13 @@
       </p:sp>
       <p:sp>
         <p:nvSpPr>
-          <p:cNvPr id="51" name="Text 49"/>
+          <p:cNvPr id="58" name="Text 56"/>
           <p:cNvSpPr txBox="1"/>
           <p:nvPr/>
         </p:nvSpPr>
         <p:spPr>
           <a:xfrm>
-            <a:off x="9350654" y="3630168"/>
+            <a:off x="9350654" y="3995928"/>
             <a:ext cx="1497787" cy="365760"/>
           </a:xfrm>
           <a:prstGeom prst="rect">
@@ -24431,13 +25818,13 @@
       </p:sp>
       <p:sp>
         <p:nvSpPr>
-          <p:cNvPr id="52" name="Text 50"/>
+          <p:cNvPr id="59" name="Text 57"/>
           <p:cNvSpPr txBox="1"/>
           <p:nvPr/>
         </p:nvSpPr>
         <p:spPr>
           <a:xfrm>
-            <a:off x="10738714" y="3630168"/>
+            <a:off x="10738714" y="3995928"/>
             <a:ext cx="965606" cy="365760"/>
           </a:xfrm>
           <a:prstGeom prst="rect">
@@ -24454,7 +25841,7 @@
               <a:buNone/>
             </a:pPr>
             <a:r>
-              <a:rPr lang="en-US" sz="900" dirty="0">
+              <a:rPr lang="en-US" sz="850" dirty="0">
                 <a:solidFill>
                   <a:srgbClr val="5B6B73"/>
                 </a:solidFill>
@@ -24462,41 +25849,21 @@
                 <a:ea typeface="Calibri" pitchFamily="34" charset="-122"/>
                 <a:cs typeface="Calibri" pitchFamily="34" charset="-120"/>
               </a:rPr>
-              <a:t>12 POB</a:t>
+              <a:t>116 POB-dia</a:t>
             </a:r>
-            <a:endParaRPr lang="en-US" sz="900" dirty="0"/>
+            <a:endParaRPr lang="en-US" sz="850" dirty="0"/>
           </a:p>
         </p:txBody>
       </p:sp>
       <p:sp>
         <p:nvSpPr>
-          <p:cNvPr id="53" name="Shape 51"/>
-          <p:cNvSpPr/>
-          <p:nvPr/>
-        </p:nvSpPr>
-        <p:spPr>
-          <a:xfrm>
-            <a:off x="6355080" y="3995928"/>
-            <a:ext cx="5349240" cy="365760"/>
-          </a:xfrm>
-          <a:prstGeom prst="rect">
-            <a:avLst/>
-          </a:prstGeom>
-          <a:solidFill>
-            <a:srgbClr val="F0F4F5"/>
-          </a:solidFill>
-          <a:ln/>
-        </p:spPr>
-      </p:sp>
-      <p:sp>
-        <p:nvSpPr>
-          <p:cNvPr id="54" name="Text 52"/>
+          <p:cNvPr id="60" name="Text 58"/>
           <p:cNvSpPr txBox="1"/>
           <p:nvPr/>
         </p:nvSpPr>
         <p:spPr>
           <a:xfrm>
-            <a:off x="6464808" y="3995928"/>
+            <a:off x="6464808" y="4361688"/>
             <a:ext cx="2995574" cy="365760"/>
           </a:xfrm>
           <a:prstGeom prst="rect">
@@ -24529,13 +25896,13 @@
       </p:sp>
       <p:sp>
         <p:nvSpPr>
-          <p:cNvPr id="55" name="Text 53"/>
+          <p:cNvPr id="61" name="Text 59"/>
           <p:cNvSpPr txBox="1"/>
           <p:nvPr/>
         </p:nvSpPr>
         <p:spPr>
           <a:xfrm>
-            <a:off x="9350654" y="3995928"/>
+            <a:off x="9350654" y="4361688"/>
             <a:ext cx="1497787" cy="365760"/>
           </a:xfrm>
           <a:prstGeom prst="rect">
@@ -24560,7 +25927,7 @@
                 <a:ea typeface="Calibri" pitchFamily="34" charset="-122"/>
                 <a:cs typeface="Calibri" pitchFamily="34" charset="-120"/>
               </a:rPr>
-              <a:t>US$ 465,5 mil</a:t>
+              <a:t>US$ 475,5 mil</a:t>
             </a:r>
             <a:endParaRPr lang="en-US" sz="1100" dirty="0"/>
           </a:p>
@@ -24568,13 +25935,13 @@
       </p:sp>
       <p:sp>
         <p:nvSpPr>
-          <p:cNvPr id="56" name="Text 54"/>
+          <p:cNvPr id="62" name="Text 60"/>
           <p:cNvSpPr txBox="1"/>
           <p:nvPr/>
         </p:nvSpPr>
         <p:spPr>
           <a:xfrm>
-            <a:off x="10738714" y="3995928"/>
+            <a:off x="10738714" y="4361688"/>
             <a:ext cx="965606" cy="365760"/>
           </a:xfrm>
           <a:prstGeom prst="rect">
@@ -24591,7 +25958,7 @@
               <a:buNone/>
             </a:pPr>
             <a:r>
-              <a:rPr lang="en-US" sz="900" dirty="0">
+              <a:rPr lang="en-US" sz="850" dirty="0">
                 <a:solidFill>
                   <a:srgbClr val="5B6B73"/>
                 </a:solidFill>
@@ -24599,15 +25966,15 @@
                 <a:ea typeface="Calibri" pitchFamily="34" charset="-122"/>
                 <a:cs typeface="Calibri" pitchFamily="34" charset="-120"/>
               </a:rPr>
-              <a:t>18 POB</a:t>
+              <a:t>426 POB-dia</a:t>
             </a:r>
-            <a:endParaRPr lang="en-US" sz="900" dirty="0"/>
+            <a:endParaRPr lang="en-US" sz="850" dirty="0"/>
           </a:p>
         </p:txBody>
       </p:sp>
       <p:sp>
         <p:nvSpPr>
-          <p:cNvPr id="57" name="Text 55"/>
+          <p:cNvPr id="63" name="Text 61"/>
           <p:cNvSpPr txBox="1"/>
           <p:nvPr/>
         </p:nvSpPr>
@@ -24638,7 +26005,7 @@
                 <a:ea typeface="Calibri" pitchFamily="34" charset="-122"/>
                 <a:cs typeface="Calibri" pitchFamily="34" charset="-120"/>
               </a:rPr>
-              <a:t>Metodologia: soma de Custo de Serviço + Custo de Material (Jan–Dez), para itens de Cost Allocation = CAPEX com status 'Contar' ou 'TA'. O total desconsidera a categoria Desenvolvimento de Produção (sem itens para este ativo).</a:t>
+              <a:t>Metodologia: soma de Custo de Serviço + Custo de Material (Jan–Dez), para itens de Cost Allocation = CAPEX com status 'Contar' ou 'TA'. POB em POB-dia (pessoas a bordo × dias). O total desconsidera a categoria Desenvolvimento de Produção (US$ 6,3 mi, mantida na lista de Categoria apenas para referência).</a:t>
             </a:r>
             <a:endParaRPr lang="en-US" sz="850" dirty="0"/>
           </a:p>
@@ -28577,7 +29944,7 @@
                 <a:ea typeface="Calibri" pitchFamily="34" charset="-122"/>
                 <a:cs typeface="Calibri" pitchFamily="34" charset="-120"/>
               </a:rPr>
-              <a:t>Fonte: Plano Integrado · aba 'Geral - Em análise' · itens de Cost Allocation = CAPEX, status 'Contar' + 'TA'. Lista completa disponível na planilha em anexo.</a:t>
+              <a:t>Fonte: Plano Integrado · aba 'Geral - Em análise' · coluna 'Valor Total' · itens de Cost Allocation = CAPEX, status 'Contar' + 'TA'. Lista completa disponível na planilha em anexo. Extrato pendente de atualização — pode não somar exatamente ao total da Composição de Custo e POB.</a:t>
             </a:r>
             <a:endParaRPr lang="en-US" sz="850" dirty="0"/>
           </a:p>

</xml_diff>

<commit_message>
Revert CAPEX totals fix, restore original deck as main version
Per explicit request, the first generated deck (based on the Plano
Integrado Excel export) is the correct one. Reverts the previous
commit that replaced Composição de Custo e POB figures with values
from the manually-provided screenshots.

Co-Authored-By: Claude Sonnet 5 <noreply@anthropic.com>
Claude-Session: https://claude.ai/code/session_01QXLKdFvqaqrRbUKxEFJW9L
</commit_message>
<xml_diff>
--- a/PRIO_Plano_Trabalho_CAPEX_2027.pptx
+++ b/PRIO_Plano_Trabalho_CAPEX_2027.pptx
@@ -250,16 +250,16 @@
                 <c:formatCode>General</c:formatCode>
                 <c:ptCount val="4"/>
                 <c:pt idx="0">
-                  <c:v>18.14</c:v>
+                  <c:v>15.98</c:v>
                 </c:pt>
                 <c:pt idx="1">
-                  <c:v>8.83</c:v>
+                  <c:v>7.19</c:v>
                 </c:pt>
                 <c:pt idx="2">
-                  <c:v>3.46</c:v>
+                  <c:v>2.91</c:v>
                 </c:pt>
                 <c:pt idx="3">
-                  <c:v>4.55</c:v>
+                  <c:v>3.44</c:v>
                 </c:pt>
               </c:numCache>
             </c:numRef>
@@ -2813,7 +2813,7 @@
                 <a:ea typeface="Cambria" pitchFamily="34" charset="-122"/>
                 <a:cs typeface="Cambria" pitchFamily="34" charset="-120"/>
               </a:rPr>
-              <a:t>US$ 2,6 mi</a:t>
+              <a:t>US$ 1,7 mi</a:t>
             </a:r>
             <a:endParaRPr lang="en-US" sz="2100" dirty="0"/>
           </a:p>
@@ -2913,7 +2913,7 @@
                 <a:ea typeface="Cambria" pitchFamily="34" charset="-122"/>
                 <a:cs typeface="Cambria" pitchFamily="34" charset="-120"/>
               </a:rPr>
-              <a:t>US$ 3,7 mi</a:t>
+              <a:t>US$ 1,2 mi</a:t>
             </a:r>
             <a:endParaRPr lang="en-US" sz="2100" dirty="0"/>
           </a:p>
@@ -3013,7 +3013,7 @@
                 <a:ea typeface="Cambria" pitchFamily="34" charset="-122"/>
                 <a:cs typeface="Cambria" pitchFamily="34" charset="-120"/>
               </a:rPr>
-              <a:t>US$ 3,5 mi</a:t>
+              <a:t>US$ 2,9 mi</a:t>
             </a:r>
             <a:endParaRPr lang="en-US" sz="2100" dirty="0"/>
           </a:p>
@@ -3113,7 +3113,7 @@
                 <a:ea typeface="Cambria" pitchFamily="34" charset="-122"/>
                 <a:cs typeface="Cambria" pitchFamily="34" charset="-120"/>
               </a:rPr>
-              <a:t>3.846</a:t>
+              <a:t>121</a:t>
             </a:r>
             <a:endParaRPr lang="en-US" sz="2100" dirty="0"/>
           </a:p>
@@ -3152,7 +3152,7 @@
                 <a:ea typeface="Calibri" pitchFamily="34" charset="-122"/>
                 <a:cs typeface="Calibri" pitchFamily="34" charset="-120"/>
               </a:rPr>
-              <a:t>POB TOTAL (POB-DIA)</a:t>
+              <a:t>POB TOTAL</a:t>
             </a:r>
             <a:endParaRPr lang="en-US" sz="850" dirty="0"/>
           </a:p>
@@ -3292,7 +3292,7 @@
                 <a:ea typeface="Calibri" pitchFamily="34" charset="-122"/>
                 <a:cs typeface="Calibri" pitchFamily="34" charset="-120"/>
               </a:rPr>
-              <a:t>US$ 5,1 mi</a:t>
+              <a:t>US$ 2,3 mi</a:t>
             </a:r>
             <a:endParaRPr lang="en-US" sz="1100" dirty="0"/>
           </a:p>
@@ -3323,7 +3323,7 @@
               <a:buNone/>
             </a:pPr>
             <a:r>
-              <a:rPr lang="en-US" sz="850" dirty="0">
+              <a:rPr lang="en-US" sz="900" dirty="0">
                 <a:solidFill>
                   <a:srgbClr val="5B6B73"/>
                 </a:solidFill>
@@ -3331,9 +3331,9 @@
                 <a:ea typeface="Calibri" pitchFamily="34" charset="-122"/>
                 <a:cs typeface="Calibri" pitchFamily="34" charset="-120"/>
               </a:rPr>
-              <a:t>2.176 POB-dia</a:t>
+              <a:t>51 POB</a:t>
             </a:r>
-            <a:endParaRPr lang="en-US" sz="850" dirty="0"/>
+            <a:endParaRPr lang="en-US" sz="900" dirty="0"/>
           </a:p>
         </p:txBody>
       </p:sp>
@@ -3429,7 +3429,7 @@
                 <a:ea typeface="Calibri" pitchFamily="34" charset="-122"/>
                 <a:cs typeface="Calibri" pitchFamily="34" charset="-120"/>
               </a:rPr>
-              <a:t>US$ 1,1 mi</a:t>
+              <a:t>US$ 565,1 mil</a:t>
             </a:r>
             <a:endParaRPr lang="en-US" sz="1100" dirty="0"/>
           </a:p>
@@ -3460,7 +3460,7 @@
               <a:buNone/>
             </a:pPr>
             <a:r>
-              <a:rPr lang="en-US" sz="850" dirty="0">
+              <a:rPr lang="en-US" sz="900" dirty="0">
                 <a:solidFill>
                   <a:srgbClr val="5B6B73"/>
                 </a:solidFill>
@@ -3468,9 +3468,9 @@
                 <a:ea typeface="Calibri" pitchFamily="34" charset="-122"/>
                 <a:cs typeface="Calibri" pitchFamily="34" charset="-120"/>
               </a:rPr>
-              <a:t>1.650 POB-dia</a:t>
+              <a:t>70 POB</a:t>
             </a:r>
-            <a:endParaRPr lang="en-US" sz="850" dirty="0"/>
+            <a:endParaRPr lang="en-US" sz="900" dirty="0"/>
           </a:p>
         </p:txBody>
       </p:sp>
@@ -3483,260 +3483,6 @@
         <p:spPr>
           <a:xfrm>
             <a:off x="566928" y="3630168"/>
-            <a:ext cx="2995574" cy="365760"/>
-          </a:xfrm>
-          <a:prstGeom prst="rect">
-            <a:avLst/>
-          </a:prstGeom>
-          <a:noFill/>
-          <a:ln/>
-        </p:spPr>
-        <p:txBody>
-          <a:bodyPr wrap="square" lIns="0" tIns="0" rIns="0" bIns="0" rtlCol="0" anchor="ctr"/>
-          <a:lstStyle/>
-          <a:p>
-            <a:pPr indent="0" marL="0">
-              <a:buNone/>
-            </a:pPr>
-            <a:r>
-              <a:rPr lang="en-US" sz="1100" dirty="0">
-                <a:solidFill>
-                  <a:srgbClr val="1C2B33"/>
-                </a:solidFill>
-                <a:latin typeface="Calibri" pitchFamily="34" charset="0"/>
-                <a:ea typeface="Calibri" pitchFamily="34" charset="-122"/>
-                <a:cs typeface="Calibri" pitchFamily="34" charset="-120"/>
-              </a:rPr>
-              <a:t>P&amp;Q - Processos</a:t>
-            </a:r>
-            <a:endParaRPr lang="en-US" sz="1100" dirty="0"/>
-          </a:p>
-        </p:txBody>
-      </p:sp>
-      <p:sp>
-        <p:nvSpPr>
-          <p:cNvPr id="28" name="Text 26"/>
-          <p:cNvSpPr txBox="1"/>
-          <p:nvPr/>
-        </p:nvSpPr>
-        <p:spPr>
-          <a:xfrm>
-            <a:off x="3452774" y="3630168"/>
-            <a:ext cx="1497787" cy="365760"/>
-          </a:xfrm>
-          <a:prstGeom prst="rect">
-            <a:avLst/>
-          </a:prstGeom>
-          <a:noFill/>
-          <a:ln/>
-        </p:spPr>
-        <p:txBody>
-          <a:bodyPr wrap="square" lIns="0" tIns="0" rIns="0" bIns="0" rtlCol="0" anchor="ctr"/>
-          <a:lstStyle/>
-          <a:p>
-            <a:pPr algn="r" indent="0" marL="0">
-              <a:buNone/>
-            </a:pPr>
-            <a:r>
-              <a:rPr lang="en-US" sz="1100" b="1" dirty="0">
-                <a:solidFill>
-                  <a:srgbClr val="0B2A3D"/>
-                </a:solidFill>
-                <a:latin typeface="Calibri" pitchFamily="34" charset="0"/>
-                <a:ea typeface="Calibri" pitchFamily="34" charset="-122"/>
-                <a:cs typeface="Calibri" pitchFamily="34" charset="-120"/>
-              </a:rPr>
-              <a:t>US$ 150,5 mil</a:t>
-            </a:r>
-            <a:endParaRPr lang="en-US" sz="1100" dirty="0"/>
-          </a:p>
-        </p:txBody>
-      </p:sp>
-      <p:sp>
-        <p:nvSpPr>
-          <p:cNvPr id="29" name="Text 27"/>
-          <p:cNvSpPr txBox="1"/>
-          <p:nvPr/>
-        </p:nvSpPr>
-        <p:spPr>
-          <a:xfrm>
-            <a:off x="4840834" y="3630168"/>
-            <a:ext cx="965606" cy="365760"/>
-          </a:xfrm>
-          <a:prstGeom prst="rect">
-            <a:avLst/>
-          </a:prstGeom>
-          <a:noFill/>
-          <a:ln/>
-        </p:spPr>
-        <p:txBody>
-          <a:bodyPr wrap="square" lIns="0" tIns="0" rIns="0" bIns="0" rtlCol="0" anchor="ctr"/>
-          <a:lstStyle/>
-          <a:p>
-            <a:pPr algn="r" indent="0" marL="0">
-              <a:buNone/>
-            </a:pPr>
-            <a:r>
-              <a:rPr lang="en-US" sz="850" dirty="0">
-                <a:solidFill>
-                  <a:srgbClr val="5B6B73"/>
-                </a:solidFill>
-                <a:latin typeface="Calibri" pitchFamily="34" charset="0"/>
-                <a:ea typeface="Calibri" pitchFamily="34" charset="-122"/>
-                <a:cs typeface="Calibri" pitchFamily="34" charset="-120"/>
-              </a:rPr>
-              <a:t>14 POB-dia</a:t>
-            </a:r>
-            <a:endParaRPr lang="en-US" sz="850" dirty="0"/>
-          </a:p>
-        </p:txBody>
-      </p:sp>
-      <p:sp>
-        <p:nvSpPr>
-          <p:cNvPr id="30" name="Shape 28"/>
-          <p:cNvSpPr/>
-          <p:nvPr/>
-        </p:nvSpPr>
-        <p:spPr>
-          <a:xfrm>
-            <a:off x="457200" y="3995928"/>
-            <a:ext cx="5349240" cy="365760"/>
-          </a:xfrm>
-          <a:prstGeom prst="rect">
-            <a:avLst/>
-          </a:prstGeom>
-          <a:solidFill>
-            <a:srgbClr val="F0F4F5"/>
-          </a:solidFill>
-          <a:ln/>
-        </p:spPr>
-      </p:sp>
-      <p:sp>
-        <p:nvSpPr>
-          <p:cNvPr id="31" name="Text 29"/>
-          <p:cNvSpPr txBox="1"/>
-          <p:nvPr/>
-        </p:nvSpPr>
-        <p:spPr>
-          <a:xfrm>
-            <a:off x="566928" y="3995928"/>
-            <a:ext cx="2995574" cy="365760"/>
-          </a:xfrm>
-          <a:prstGeom prst="rect">
-            <a:avLst/>
-          </a:prstGeom>
-          <a:noFill/>
-          <a:ln/>
-        </p:spPr>
-        <p:txBody>
-          <a:bodyPr wrap="square" lIns="0" tIns="0" rIns="0" bIns="0" rtlCol="0" anchor="ctr"/>
-          <a:lstStyle/>
-          <a:p>
-            <a:pPr indent="0" marL="0">
-              <a:buNone/>
-            </a:pPr>
-            <a:r>
-              <a:rPr lang="en-US" sz="1100" dirty="0">
-                <a:solidFill>
-                  <a:srgbClr val="1C2B33"/>
-                </a:solidFill>
-                <a:latin typeface="Calibri" pitchFamily="34" charset="0"/>
-                <a:ea typeface="Calibri" pitchFamily="34" charset="-122"/>
-                <a:cs typeface="Calibri" pitchFamily="34" charset="-120"/>
-              </a:rPr>
-              <a:t>P&amp;Q - Químicos</a:t>
-            </a:r>
-            <a:endParaRPr lang="en-US" sz="1100" dirty="0"/>
-          </a:p>
-        </p:txBody>
-      </p:sp>
-      <p:sp>
-        <p:nvSpPr>
-          <p:cNvPr id="32" name="Text 30"/>
-          <p:cNvSpPr txBox="1"/>
-          <p:nvPr/>
-        </p:nvSpPr>
-        <p:spPr>
-          <a:xfrm>
-            <a:off x="3452774" y="3995928"/>
-            <a:ext cx="1497787" cy="365760"/>
-          </a:xfrm>
-          <a:prstGeom prst="rect">
-            <a:avLst/>
-          </a:prstGeom>
-          <a:noFill/>
-          <a:ln/>
-        </p:spPr>
-        <p:txBody>
-          <a:bodyPr wrap="square" lIns="0" tIns="0" rIns="0" bIns="0" rtlCol="0" anchor="ctr"/>
-          <a:lstStyle/>
-          <a:p>
-            <a:pPr algn="r" indent="0" marL="0">
-              <a:buNone/>
-            </a:pPr>
-            <a:r>
-              <a:rPr lang="en-US" sz="1100" b="1" dirty="0">
-                <a:solidFill>
-                  <a:srgbClr val="0B2A3D"/>
-                </a:solidFill>
-                <a:latin typeface="Calibri" pitchFamily="34" charset="0"/>
-                <a:ea typeface="Calibri" pitchFamily="34" charset="-122"/>
-                <a:cs typeface="Calibri" pitchFamily="34" charset="-120"/>
-              </a:rPr>
-              <a:t>US$ 10,0 mil</a:t>
-            </a:r>
-            <a:endParaRPr lang="en-US" sz="1100" dirty="0"/>
-          </a:p>
-        </p:txBody>
-      </p:sp>
-      <p:sp>
-        <p:nvSpPr>
-          <p:cNvPr id="33" name="Text 31"/>
-          <p:cNvSpPr txBox="1"/>
-          <p:nvPr/>
-        </p:nvSpPr>
-        <p:spPr>
-          <a:xfrm>
-            <a:off x="4840834" y="3995928"/>
-            <a:ext cx="965606" cy="365760"/>
-          </a:xfrm>
-          <a:prstGeom prst="rect">
-            <a:avLst/>
-          </a:prstGeom>
-          <a:noFill/>
-          <a:ln/>
-        </p:spPr>
-        <p:txBody>
-          <a:bodyPr wrap="square" lIns="0" tIns="0" rIns="0" bIns="0" rtlCol="0" anchor="ctr"/>
-          <a:lstStyle/>
-          <a:p>
-            <a:pPr algn="r" indent="0" marL="0">
-              <a:buNone/>
-            </a:pPr>
-            <a:r>
-              <a:rPr lang="en-US" sz="850" dirty="0">
-                <a:solidFill>
-                  <a:srgbClr val="5B6B73"/>
-                </a:solidFill>
-                <a:latin typeface="Calibri" pitchFamily="34" charset="0"/>
-                <a:ea typeface="Calibri" pitchFamily="34" charset="-122"/>
-                <a:cs typeface="Calibri" pitchFamily="34" charset="-120"/>
-              </a:rPr>
-              <a:t>6 POB-dia</a:t>
-            </a:r>
-            <a:endParaRPr lang="en-US" sz="850" dirty="0"/>
-          </a:p>
-        </p:txBody>
-      </p:sp>
-      <p:sp>
-        <p:nvSpPr>
-          <p:cNvPr id="34" name="Text 32"/>
-          <p:cNvSpPr txBox="1"/>
-          <p:nvPr/>
-        </p:nvSpPr>
-        <p:spPr>
-          <a:xfrm>
-            <a:off x="566928" y="4361688"/>
             <a:ext cx="2995574" cy="365760"/>
           </a:xfrm>
           <a:prstGeom prst="rect">
@@ -3769,13 +3515,13 @@
       </p:sp>
       <p:sp>
         <p:nvSpPr>
-          <p:cNvPr id="35" name="Text 33"/>
+          <p:cNvPr id="28" name="Text 26"/>
           <p:cNvSpPr txBox="1"/>
           <p:nvPr/>
         </p:nvSpPr>
         <p:spPr>
           <a:xfrm>
-            <a:off x="3452774" y="4361688"/>
+            <a:off x="3452774" y="3630168"/>
             <a:ext cx="1497787" cy="365760"/>
           </a:xfrm>
           <a:prstGeom prst="rect">
@@ -3808,13 +3554,13 @@
       </p:sp>
       <p:sp>
         <p:nvSpPr>
-          <p:cNvPr id="36" name="Text 34"/>
+          <p:cNvPr id="29" name="Text 27"/>
           <p:cNvSpPr txBox="1"/>
           <p:nvPr/>
         </p:nvSpPr>
         <p:spPr>
           <a:xfrm>
-            <a:off x="4840834" y="4361688"/>
+            <a:off x="4840834" y="3630168"/>
             <a:ext cx="965606" cy="365760"/>
           </a:xfrm>
           <a:prstGeom prst="rect">
@@ -3831,7 +3577,7 @@
               <a:buNone/>
             </a:pPr>
             <a:r>
-              <a:rPr lang="en-US" sz="850" dirty="0">
+              <a:rPr lang="en-US" sz="900" dirty="0">
                 <a:solidFill>
                   <a:srgbClr val="5B6B73"/>
                 </a:solidFill>
@@ -3839,15 +3585,15 @@
                 <a:ea typeface="Calibri" pitchFamily="34" charset="-122"/>
                 <a:cs typeface="Calibri" pitchFamily="34" charset="-120"/>
               </a:rPr>
-              <a:t>0 POB-dia</a:t>
+              <a:t>0 POB</a:t>
             </a:r>
-            <a:endParaRPr lang="en-US" sz="850" dirty="0"/>
+            <a:endParaRPr lang="en-US" sz="900" dirty="0"/>
           </a:p>
         </p:txBody>
       </p:sp>
       <p:sp>
         <p:nvSpPr>
-          <p:cNvPr id="37" name="Text 35"/>
+          <p:cNvPr id="30" name="Text 28"/>
           <p:cNvSpPr txBox="1"/>
           <p:nvPr/>
         </p:nvSpPr>
@@ -3886,7 +3632,7 @@
       </p:sp>
       <p:sp>
         <p:nvSpPr>
-          <p:cNvPr id="38" name="Shape 36"/>
+          <p:cNvPr id="31" name="Shape 29"/>
           <p:cNvSpPr/>
           <p:nvPr/>
         </p:nvSpPr>
@@ -3909,150 +3655,13 @@
       </p:sp>
       <p:sp>
         <p:nvSpPr>
-          <p:cNvPr id="39" name="Text 37"/>
+          <p:cNvPr id="32" name="Text 30"/>
           <p:cNvSpPr txBox="1"/>
           <p:nvPr/>
         </p:nvSpPr>
         <p:spPr>
           <a:xfrm>
             <a:off x="6464808" y="2898648"/>
-            <a:ext cx="2995574" cy="365760"/>
-          </a:xfrm>
-          <a:prstGeom prst="rect">
-            <a:avLst/>
-          </a:prstGeom>
-          <a:noFill/>
-          <a:ln/>
-        </p:spPr>
-        <p:txBody>
-          <a:bodyPr wrap="square" lIns="0" tIns="0" rIns="0" bIns="0" rtlCol="0" anchor="ctr"/>
-          <a:lstStyle/>
-          <a:p>
-            <a:pPr indent="0" marL="0">
-              <a:buNone/>
-            </a:pPr>
-            <a:r>
-              <a:rPr lang="en-US" sz="1100" dirty="0">
-                <a:solidFill>
-                  <a:srgbClr val="1C2B33"/>
-                </a:solidFill>
-                <a:latin typeface="Calibri" pitchFamily="34" charset="0"/>
-                <a:ea typeface="Calibri" pitchFamily="34" charset="-122"/>
-                <a:cs typeface="Calibri" pitchFamily="34" charset="-120"/>
-              </a:rPr>
-              <a:t>Desenvolvimento de Produção</a:t>
-            </a:r>
-            <a:endParaRPr lang="en-US" sz="1100" dirty="0"/>
-          </a:p>
-        </p:txBody>
-      </p:sp>
-      <p:sp>
-        <p:nvSpPr>
-          <p:cNvPr id="40" name="Text 38"/>
-          <p:cNvSpPr txBox="1"/>
-          <p:nvPr/>
-        </p:nvSpPr>
-        <p:spPr>
-          <a:xfrm>
-            <a:off x="9350654" y="2898648"/>
-            <a:ext cx="1497787" cy="365760"/>
-          </a:xfrm>
-          <a:prstGeom prst="rect">
-            <a:avLst/>
-          </a:prstGeom>
-          <a:noFill/>
-          <a:ln/>
-        </p:spPr>
-        <p:txBody>
-          <a:bodyPr wrap="square" lIns="0" tIns="0" rIns="0" bIns="0" rtlCol="0" anchor="ctr"/>
-          <a:lstStyle/>
-          <a:p>
-            <a:pPr algn="r" indent="0" marL="0">
-              <a:buNone/>
-            </a:pPr>
-            <a:r>
-              <a:rPr lang="en-US" sz="1100" b="1" dirty="0">
-                <a:solidFill>
-                  <a:srgbClr val="0B2A3D"/>
-                </a:solidFill>
-                <a:latin typeface="Calibri" pitchFamily="34" charset="0"/>
-                <a:ea typeface="Calibri" pitchFamily="34" charset="-122"/>
-                <a:cs typeface="Calibri" pitchFamily="34" charset="-120"/>
-              </a:rPr>
-              <a:t>US$ 2,9 mi</a:t>
-            </a:r>
-            <a:endParaRPr lang="en-US" sz="1100" dirty="0"/>
-          </a:p>
-        </p:txBody>
-      </p:sp>
-      <p:sp>
-        <p:nvSpPr>
-          <p:cNvPr id="41" name="Text 39"/>
-          <p:cNvSpPr txBox="1"/>
-          <p:nvPr/>
-        </p:nvSpPr>
-        <p:spPr>
-          <a:xfrm>
-            <a:off x="10738714" y="2898648"/>
-            <a:ext cx="965606" cy="365760"/>
-          </a:xfrm>
-          <a:prstGeom prst="rect">
-            <a:avLst/>
-          </a:prstGeom>
-          <a:noFill/>
-          <a:ln/>
-        </p:spPr>
-        <p:txBody>
-          <a:bodyPr wrap="square" lIns="0" tIns="0" rIns="0" bIns="0" rtlCol="0" anchor="ctr"/>
-          <a:lstStyle/>
-          <a:p>
-            <a:pPr algn="r" indent="0" marL="0">
-              <a:buNone/>
-            </a:pPr>
-            <a:r>
-              <a:rPr lang="en-US" sz="850" dirty="0">
-                <a:solidFill>
-                  <a:srgbClr val="5B6B73"/>
-                </a:solidFill>
-                <a:latin typeface="Calibri" pitchFamily="34" charset="0"/>
-                <a:ea typeface="Calibri" pitchFamily="34" charset="-122"/>
-                <a:cs typeface="Calibri" pitchFamily="34" charset="-120"/>
-              </a:rPr>
-              <a:t>1.223 POB-dia</a:t>
-            </a:r>
-            <a:endParaRPr lang="en-US" sz="850" dirty="0"/>
-          </a:p>
-        </p:txBody>
-      </p:sp>
-      <p:sp>
-        <p:nvSpPr>
-          <p:cNvPr id="42" name="Shape 40"/>
-          <p:cNvSpPr/>
-          <p:nvPr/>
-        </p:nvSpPr>
-        <p:spPr>
-          <a:xfrm>
-            <a:off x="6355080" y="3264408"/>
-            <a:ext cx="5349240" cy="365760"/>
-          </a:xfrm>
-          <a:prstGeom prst="rect">
-            <a:avLst/>
-          </a:prstGeom>
-          <a:solidFill>
-            <a:srgbClr val="F0F4F5"/>
-          </a:solidFill>
-          <a:ln/>
-        </p:spPr>
-      </p:sp>
-      <p:sp>
-        <p:nvSpPr>
-          <p:cNvPr id="43" name="Text 41"/>
-          <p:cNvSpPr txBox="1"/>
-          <p:nvPr/>
-        </p:nvSpPr>
-        <p:spPr>
-          <a:xfrm>
-            <a:off x="6464808" y="3264408"/>
             <a:ext cx="2995574" cy="365760"/>
           </a:xfrm>
           <a:prstGeom prst="rect">
@@ -4085,13 +3694,13 @@
       </p:sp>
       <p:sp>
         <p:nvSpPr>
-          <p:cNvPr id="44" name="Text 42"/>
+          <p:cNvPr id="33" name="Text 31"/>
           <p:cNvSpPr txBox="1"/>
           <p:nvPr/>
         </p:nvSpPr>
         <p:spPr>
           <a:xfrm>
-            <a:off x="9350654" y="3264408"/>
+            <a:off x="9350654" y="2898648"/>
             <a:ext cx="1497787" cy="365760"/>
           </a:xfrm>
           <a:prstGeom prst="rect">
@@ -4116,7 +3725,7 @@
                 <a:ea typeface="Calibri" pitchFamily="34" charset="-122"/>
                 <a:cs typeface="Calibri" pitchFamily="34" charset="-120"/>
               </a:rPr>
-              <a:t>US$ 2,9 mi</a:t>
+              <a:t>US$ 2,3 mi</a:t>
             </a:r>
             <a:endParaRPr lang="en-US" sz="1100" dirty="0"/>
           </a:p>
@@ -4124,13 +3733,13 @@
       </p:sp>
       <p:sp>
         <p:nvSpPr>
-          <p:cNvPr id="45" name="Text 43"/>
+          <p:cNvPr id="34" name="Text 32"/>
           <p:cNvSpPr txBox="1"/>
           <p:nvPr/>
         </p:nvSpPr>
         <p:spPr>
           <a:xfrm>
-            <a:off x="10738714" y="3264408"/>
+            <a:off x="10738714" y="2898648"/>
             <a:ext cx="965606" cy="365760"/>
           </a:xfrm>
           <a:prstGeom prst="rect">
@@ -4147,7 +3756,7 @@
               <a:buNone/>
             </a:pPr>
             <a:r>
-              <a:rPr lang="en-US" sz="850" dirty="0">
+              <a:rPr lang="en-US" sz="900" dirty="0">
                 <a:solidFill>
                   <a:srgbClr val="5B6B73"/>
                 </a:solidFill>
@@ -4155,21 +3764,41 @@
                 <a:ea typeface="Calibri" pitchFamily="34" charset="-122"/>
                 <a:cs typeface="Calibri" pitchFamily="34" charset="-120"/>
               </a:rPr>
-              <a:t>2.589 POB-dia</a:t>
+              <a:t>119 POB</a:t>
             </a:r>
-            <a:endParaRPr lang="en-US" sz="850" dirty="0"/>
+            <a:endParaRPr lang="en-US" sz="900" dirty="0"/>
           </a:p>
         </p:txBody>
       </p:sp>
       <p:sp>
         <p:nvSpPr>
-          <p:cNvPr id="46" name="Text 44"/>
+          <p:cNvPr id="35" name="Shape 33"/>
+          <p:cNvSpPr/>
+          <p:nvPr/>
+        </p:nvSpPr>
+        <p:spPr>
+          <a:xfrm>
+            <a:off x="6355080" y="3264408"/>
+            <a:ext cx="5349240" cy="365760"/>
+          </a:xfrm>
+          <a:prstGeom prst="rect">
+            <a:avLst/>
+          </a:prstGeom>
+          <a:solidFill>
+            <a:srgbClr val="F0F4F5"/>
+          </a:solidFill>
+          <a:ln/>
+        </p:spPr>
+      </p:sp>
+      <p:sp>
+        <p:nvSpPr>
+          <p:cNvPr id="36" name="Text 34"/>
           <p:cNvSpPr txBox="1"/>
           <p:nvPr/>
         </p:nvSpPr>
         <p:spPr>
           <a:xfrm>
-            <a:off x="6464808" y="3630168"/>
+            <a:off x="6464808" y="3264408"/>
             <a:ext cx="2995574" cy="365760"/>
           </a:xfrm>
           <a:prstGeom prst="rect">
@@ -4202,13 +3831,13 @@
       </p:sp>
       <p:sp>
         <p:nvSpPr>
-          <p:cNvPr id="47" name="Text 45"/>
+          <p:cNvPr id="37" name="Text 35"/>
           <p:cNvSpPr txBox="1"/>
           <p:nvPr/>
         </p:nvSpPr>
         <p:spPr>
           <a:xfrm>
-            <a:off x="9350654" y="3630168"/>
+            <a:off x="9350654" y="3264408"/>
             <a:ext cx="1497787" cy="365760"/>
           </a:xfrm>
           <a:prstGeom prst="rect">
@@ -4241,13 +3870,13 @@
       </p:sp>
       <p:sp>
         <p:nvSpPr>
-          <p:cNvPr id="48" name="Text 46"/>
+          <p:cNvPr id="38" name="Text 36"/>
           <p:cNvSpPr txBox="1"/>
           <p:nvPr/>
         </p:nvSpPr>
         <p:spPr>
           <a:xfrm>
-            <a:off x="10738714" y="3630168"/>
+            <a:off x="10738714" y="3264408"/>
             <a:ext cx="965606" cy="365760"/>
           </a:xfrm>
           <a:prstGeom prst="rect">
@@ -4264,7 +3893,7 @@
               <a:buNone/>
             </a:pPr>
             <a:r>
-              <a:rPr lang="en-US" sz="850" dirty="0">
+              <a:rPr lang="en-US" sz="900" dirty="0">
                 <a:solidFill>
                   <a:srgbClr val="5B6B73"/>
                 </a:solidFill>
@@ -4272,158 +3901,21 @@
                 <a:ea typeface="Calibri" pitchFamily="34" charset="-122"/>
                 <a:cs typeface="Calibri" pitchFamily="34" charset="-120"/>
               </a:rPr>
-              <a:t>28 POB-dia</a:t>
+              <a:t>2 POB</a:t>
             </a:r>
-            <a:endParaRPr lang="en-US" sz="850" dirty="0"/>
+            <a:endParaRPr lang="en-US" sz="900" dirty="0"/>
           </a:p>
         </p:txBody>
       </p:sp>
       <p:sp>
         <p:nvSpPr>
-          <p:cNvPr id="49" name="Shape 47"/>
-          <p:cNvSpPr/>
+          <p:cNvPr id="39" name="Text 37"/>
+          <p:cNvSpPr txBox="1"/>
           <p:nvPr/>
         </p:nvSpPr>
         <p:spPr>
           <a:xfrm>
-            <a:off x="6355080" y="3995928"/>
-            <a:ext cx="5349240" cy="365760"/>
-          </a:xfrm>
-          <a:prstGeom prst="rect">
-            <a:avLst/>
-          </a:prstGeom>
-          <a:solidFill>
-            <a:srgbClr val="F0F4F5"/>
-          </a:solidFill>
-          <a:ln/>
-        </p:spPr>
-      </p:sp>
-      <p:sp>
-        <p:nvSpPr>
-          <p:cNvPr id="50" name="Text 48"/>
-          <p:cNvSpPr txBox="1"/>
-          <p:nvPr/>
-        </p:nvSpPr>
-        <p:spPr>
-          <a:xfrm>
-            <a:off x="6464808" y="3995928"/>
-            <a:ext cx="2995574" cy="365760"/>
-          </a:xfrm>
-          <a:prstGeom prst="rect">
-            <a:avLst/>
-          </a:prstGeom>
-          <a:noFill/>
-          <a:ln/>
-        </p:spPr>
-        <p:txBody>
-          <a:bodyPr wrap="square" lIns="0" tIns="0" rIns="0" bIns="0" rtlCol="0" anchor="ctr"/>
-          <a:lstStyle/>
-          <a:p>
-            <a:pPr indent="0" marL="0">
-              <a:buNone/>
-            </a:pPr>
-            <a:r>
-              <a:rPr lang="en-US" sz="1100" dirty="0">
-                <a:solidFill>
-                  <a:srgbClr val="1C2B33"/>
-                </a:solidFill>
-                <a:latin typeface="Calibri" pitchFamily="34" charset="0"/>
-                <a:ea typeface="Calibri" pitchFamily="34" charset="-122"/>
-                <a:cs typeface="Calibri" pitchFamily="34" charset="-120"/>
-              </a:rPr>
-              <a:t>Rotina Operacional</a:t>
-            </a:r>
-            <a:endParaRPr lang="en-US" sz="1100" dirty="0"/>
-          </a:p>
-        </p:txBody>
-      </p:sp>
-      <p:sp>
-        <p:nvSpPr>
-          <p:cNvPr id="51" name="Text 49"/>
-          <p:cNvSpPr txBox="1"/>
-          <p:nvPr/>
-        </p:nvSpPr>
-        <p:spPr>
-          <a:xfrm>
-            <a:off x="9350654" y="3995928"/>
-            <a:ext cx="1497787" cy="365760"/>
-          </a:xfrm>
-          <a:prstGeom prst="rect">
-            <a:avLst/>
-          </a:prstGeom>
-          <a:noFill/>
-          <a:ln/>
-        </p:spPr>
-        <p:txBody>
-          <a:bodyPr wrap="square" lIns="0" tIns="0" rIns="0" bIns="0" rtlCol="0" anchor="ctr"/>
-          <a:lstStyle/>
-          <a:p>
-            <a:pPr algn="r" indent="0" marL="0">
-              <a:buNone/>
-            </a:pPr>
-            <a:r>
-              <a:rPr lang="en-US" sz="1100" b="1" dirty="0">
-                <a:solidFill>
-                  <a:srgbClr val="0B2A3D"/>
-                </a:solidFill>
-                <a:latin typeface="Calibri" pitchFamily="34" charset="0"/>
-                <a:ea typeface="Calibri" pitchFamily="34" charset="-122"/>
-                <a:cs typeface="Calibri" pitchFamily="34" charset="-120"/>
-              </a:rPr>
-              <a:t>US$ 10,0 mil</a:t>
-            </a:r>
-            <a:endParaRPr lang="en-US" sz="1100" dirty="0"/>
-          </a:p>
-        </p:txBody>
-      </p:sp>
-      <p:sp>
-        <p:nvSpPr>
-          <p:cNvPr id="52" name="Text 50"/>
-          <p:cNvSpPr txBox="1"/>
-          <p:nvPr/>
-        </p:nvSpPr>
-        <p:spPr>
-          <a:xfrm>
-            <a:off x="10738714" y="3995928"/>
-            <a:ext cx="965606" cy="365760"/>
-          </a:xfrm>
-          <a:prstGeom prst="rect">
-            <a:avLst/>
-          </a:prstGeom>
-          <a:noFill/>
-          <a:ln/>
-        </p:spPr>
-        <p:txBody>
-          <a:bodyPr wrap="square" lIns="0" tIns="0" rIns="0" bIns="0" rtlCol="0" anchor="ctr"/>
-          <a:lstStyle/>
-          <a:p>
-            <a:pPr algn="r" indent="0" marL="0">
-              <a:buNone/>
-            </a:pPr>
-            <a:r>
-              <a:rPr lang="en-US" sz="850" dirty="0">
-                <a:solidFill>
-                  <a:srgbClr val="5B6B73"/>
-                </a:solidFill>
-                <a:latin typeface="Calibri" pitchFamily="34" charset="0"/>
-                <a:ea typeface="Calibri" pitchFamily="34" charset="-122"/>
-                <a:cs typeface="Calibri" pitchFamily="34" charset="-120"/>
-              </a:rPr>
-              <a:t>6 POB-dia</a:t>
-            </a:r>
-            <a:endParaRPr lang="en-US" sz="850" dirty="0"/>
-          </a:p>
-        </p:txBody>
-      </p:sp>
-      <p:sp>
-        <p:nvSpPr>
-          <p:cNvPr id="53" name="Text 51"/>
-          <p:cNvSpPr txBox="1"/>
-          <p:nvPr/>
-        </p:nvSpPr>
-        <p:spPr>
-          <a:xfrm>
-            <a:off x="6464808" y="4361688"/>
+            <a:off x="6464808" y="3630168"/>
             <a:ext cx="2995574" cy="365760"/>
           </a:xfrm>
           <a:prstGeom prst="rect">
@@ -4456,13 +3948,13 @@
       </p:sp>
       <p:sp>
         <p:nvSpPr>
-          <p:cNvPr id="54" name="Text 52"/>
+          <p:cNvPr id="40" name="Text 38"/>
           <p:cNvSpPr txBox="1"/>
           <p:nvPr/>
         </p:nvSpPr>
         <p:spPr>
           <a:xfrm>
-            <a:off x="9350654" y="4361688"/>
+            <a:off x="9350654" y="3630168"/>
             <a:ext cx="1497787" cy="365760"/>
           </a:xfrm>
           <a:prstGeom prst="rect">
@@ -4495,13 +3987,13 @@
       </p:sp>
       <p:sp>
         <p:nvSpPr>
-          <p:cNvPr id="55" name="Text 53"/>
+          <p:cNvPr id="41" name="Text 39"/>
           <p:cNvSpPr txBox="1"/>
           <p:nvPr/>
         </p:nvSpPr>
         <p:spPr>
           <a:xfrm>
-            <a:off x="10738714" y="4361688"/>
+            <a:off x="10738714" y="3630168"/>
             <a:ext cx="965606" cy="365760"/>
           </a:xfrm>
           <a:prstGeom prst="rect">
@@ -4518,7 +4010,7 @@
               <a:buNone/>
             </a:pPr>
             <a:r>
-              <a:rPr lang="en-US" sz="850" dirty="0">
+              <a:rPr lang="en-US" sz="900" dirty="0">
                 <a:solidFill>
                   <a:srgbClr val="5B6B73"/>
                 </a:solidFill>
@@ -4526,15 +4018,15 @@
                 <a:ea typeface="Calibri" pitchFamily="34" charset="-122"/>
                 <a:cs typeface="Calibri" pitchFamily="34" charset="-120"/>
               </a:rPr>
-              <a:t>0 POB-dia</a:t>
+              <a:t>0 POB</a:t>
             </a:r>
-            <a:endParaRPr lang="en-US" sz="850" dirty="0"/>
+            <a:endParaRPr lang="en-US" sz="900" dirty="0"/>
           </a:p>
         </p:txBody>
       </p:sp>
       <p:sp>
         <p:nvSpPr>
-          <p:cNvPr id="56" name="Text 54"/>
+          <p:cNvPr id="42" name="Text 40"/>
           <p:cNvSpPr txBox="1"/>
           <p:nvPr/>
         </p:nvSpPr>
@@ -4565,7 +4057,7 @@
                 <a:ea typeface="Calibri" pitchFamily="34" charset="-122"/>
                 <a:cs typeface="Calibri" pitchFamily="34" charset="-120"/>
               </a:rPr>
-              <a:t>Metodologia: soma de Custo de Serviço + Custo de Material (Jan–Dez), para itens de Cost Allocation = CAPEX com status 'Contar' ou 'TA'. POB em POB-dia (pessoas a bordo × dias). O total desconsidera a categoria Desenvolvimento de Produção (US$ 2,9 mi, mantida na lista de Categoria apenas para referência).</a:t>
+              <a:t>Metodologia: soma de Custo de Serviço + Custo de Material (Jan–Dez), para itens de Cost Allocation = CAPEX com status 'Contar' ou 'TA'. O total desconsidera a categoria Desenvolvimento de Produção (sem itens para este ativo).</a:t>
             </a:r>
             <a:endParaRPr lang="en-US" sz="850" dirty="0"/>
           </a:p>
@@ -8504,7 +7996,7 @@
                 <a:ea typeface="Calibri" pitchFamily="34" charset="-122"/>
                 <a:cs typeface="Calibri" pitchFamily="34" charset="-120"/>
               </a:rPr>
-              <a:t>Fonte: Plano Integrado · aba 'Geral - Em análise' · coluna 'Valor Total' · itens de Cost Allocation = CAPEX, status 'Contar' + 'TA'. Lista completa disponível na planilha em anexo. Extrato pendente de atualização — pode não somar exatamente ao total da Composição de Custo e POB.</a:t>
+              <a:t>Fonte: Plano Integrado · aba 'Geral - Em análise' · itens de Cost Allocation = CAPEX, status 'Contar' + 'TA'. Lista completa disponível na planilha em anexo.</a:t>
             </a:r>
             <a:endParaRPr lang="en-US" sz="850" dirty="0"/>
           </a:p>
@@ -8991,7 +8483,7 @@
                 <a:ea typeface="Cambria" pitchFamily="34" charset="-122"/>
                 <a:cs typeface="Cambria" pitchFamily="34" charset="-120"/>
               </a:rPr>
-              <a:t>US$ 5,9 mi</a:t>
+              <a:t>US$ 2,3 mi</a:t>
             </a:r>
             <a:endParaRPr lang="en-US" sz="2100" dirty="0"/>
           </a:p>
@@ -9091,7 +8583,7 @@
                 <a:ea typeface="Cambria" pitchFamily="34" charset="-122"/>
                 <a:cs typeface="Cambria" pitchFamily="34" charset="-120"/>
               </a:rPr>
-              <a:t>US$ 7,1 mi</a:t>
+              <a:t>US$ 1,1 mi</a:t>
             </a:r>
             <a:endParaRPr lang="en-US" sz="2100" dirty="0"/>
           </a:p>
@@ -9191,7 +8683,7 @@
                 <a:ea typeface="Cambria" pitchFamily="34" charset="-122"/>
                 <a:cs typeface="Cambria" pitchFamily="34" charset="-120"/>
               </a:rPr>
-              <a:t>US$ 4,5 mi</a:t>
+              <a:t>US$ 3,4 mi</a:t>
             </a:r>
             <a:endParaRPr lang="en-US" sz="2100" dirty="0"/>
           </a:p>
@@ -9291,7 +8783,7 @@
                 <a:ea typeface="Cambria" pitchFamily="34" charset="-122"/>
                 <a:cs typeface="Cambria" pitchFamily="34" charset="-120"/>
               </a:rPr>
-              <a:t>5.186</a:t>
+              <a:t>135</a:t>
             </a:r>
             <a:endParaRPr lang="en-US" sz="2100" dirty="0"/>
           </a:p>
@@ -9330,7 +8822,7 @@
                 <a:ea typeface="Calibri" pitchFamily="34" charset="-122"/>
                 <a:cs typeface="Calibri" pitchFamily="34" charset="-120"/>
               </a:rPr>
-              <a:t>POB TOTAL (POB-DIA)</a:t>
+              <a:t>POB TOTAL</a:t>
             </a:r>
             <a:endParaRPr lang="en-US" sz="850" dirty="0"/>
           </a:p>
@@ -9470,7 +8962,7 @@
                 <a:ea typeface="Calibri" pitchFamily="34" charset="-122"/>
                 <a:cs typeface="Calibri" pitchFamily="34" charset="-120"/>
               </a:rPr>
-              <a:t>US$ 10,1 mi</a:t>
+              <a:t>US$ 1,8 mi</a:t>
             </a:r>
             <a:endParaRPr lang="en-US" sz="1100" dirty="0"/>
           </a:p>
@@ -9501,7 +8993,7 @@
               <a:buNone/>
             </a:pPr>
             <a:r>
-              <a:rPr lang="en-US" sz="850" dirty="0">
+              <a:rPr lang="en-US" sz="900" dirty="0">
                 <a:solidFill>
                   <a:srgbClr val="5B6B73"/>
                 </a:solidFill>
@@ -9509,9 +9001,9 @@
                 <a:ea typeface="Calibri" pitchFamily="34" charset="-122"/>
                 <a:cs typeface="Calibri" pitchFamily="34" charset="-120"/>
               </a:rPr>
-              <a:t>3.036 POB-dia</a:t>
+              <a:t>41 POB</a:t>
             </a:r>
-            <a:endParaRPr lang="en-US" sz="850" dirty="0"/>
+            <a:endParaRPr lang="en-US" sz="900" dirty="0"/>
           </a:p>
         </p:txBody>
       </p:sp>
@@ -9607,7 +9099,7 @@
                 <a:ea typeface="Calibri" pitchFamily="34" charset="-122"/>
                 <a:cs typeface="Calibri" pitchFamily="34" charset="-120"/>
               </a:rPr>
-              <a:t>US$ 1,9 mi</a:t>
+              <a:t>US$ 889,8 mil</a:t>
             </a:r>
             <a:endParaRPr lang="en-US" sz="1100" dirty="0"/>
           </a:p>
@@ -9638,7 +9130,7 @@
               <a:buNone/>
             </a:pPr>
             <a:r>
-              <a:rPr lang="en-US" sz="850" dirty="0">
+              <a:rPr lang="en-US" sz="900" dirty="0">
                 <a:solidFill>
                   <a:srgbClr val="5B6B73"/>
                 </a:solidFill>
@@ -9646,9 +9138,9 @@
                 <a:ea typeface="Calibri" pitchFamily="34" charset="-122"/>
                 <a:cs typeface="Calibri" pitchFamily="34" charset="-120"/>
               </a:rPr>
-              <a:t>2.010 POB-dia</a:t>
+              <a:t>90 POB</a:t>
             </a:r>
-            <a:endParaRPr lang="en-US" sz="850" dirty="0"/>
+            <a:endParaRPr lang="en-US" sz="900" dirty="0"/>
           </a:p>
         </p:txBody>
       </p:sp>
@@ -9755,7 +9247,7 @@
               <a:buNone/>
             </a:pPr>
             <a:r>
-              <a:rPr lang="en-US" sz="850" dirty="0">
+              <a:rPr lang="en-US" sz="900" dirty="0">
                 <a:solidFill>
                   <a:srgbClr val="5B6B73"/>
                 </a:solidFill>
@@ -9763,9 +9255,9 @@
                 <a:ea typeface="Calibri" pitchFamily="34" charset="-122"/>
                 <a:cs typeface="Calibri" pitchFamily="34" charset="-120"/>
               </a:rPr>
-              <a:t>120 POB-dia</a:t>
+              <a:t>4 POB</a:t>
             </a:r>
-            <a:endParaRPr lang="en-US" sz="850" dirty="0"/>
+            <a:endParaRPr lang="en-US" sz="900" dirty="0"/>
           </a:p>
         </p:txBody>
       </p:sp>
@@ -9798,260 +9290,6 @@
         <p:spPr>
           <a:xfrm>
             <a:off x="566928" y="3995928"/>
-            <a:ext cx="2995574" cy="365760"/>
-          </a:xfrm>
-          <a:prstGeom prst="rect">
-            <a:avLst/>
-          </a:prstGeom>
-          <a:noFill/>
-          <a:ln/>
-        </p:spPr>
-        <p:txBody>
-          <a:bodyPr wrap="square" lIns="0" tIns="0" rIns="0" bIns="0" rtlCol="0" anchor="ctr"/>
-          <a:lstStyle/>
-          <a:p>
-            <a:pPr indent="0" marL="0">
-              <a:buNone/>
-            </a:pPr>
-            <a:r>
-              <a:rPr lang="en-US" sz="1100" dirty="0">
-                <a:solidFill>
-                  <a:srgbClr val="1C2B33"/>
-                </a:solidFill>
-                <a:latin typeface="Calibri" pitchFamily="34" charset="0"/>
-                <a:ea typeface="Calibri" pitchFamily="34" charset="-122"/>
-                <a:cs typeface="Calibri" pitchFamily="34" charset="-120"/>
-              </a:rPr>
-              <a:t>CON - Construção</a:t>
-            </a:r>
-            <a:endParaRPr lang="en-US" sz="1100" dirty="0"/>
-          </a:p>
-        </p:txBody>
-      </p:sp>
-      <p:sp>
-        <p:nvSpPr>
-          <p:cNvPr id="32" name="Text 30"/>
-          <p:cNvSpPr txBox="1"/>
-          <p:nvPr/>
-        </p:nvSpPr>
-        <p:spPr>
-          <a:xfrm>
-            <a:off x="3452774" y="3995928"/>
-            <a:ext cx="1497787" cy="365760"/>
-          </a:xfrm>
-          <a:prstGeom prst="rect">
-            <a:avLst/>
-          </a:prstGeom>
-          <a:noFill/>
-          <a:ln/>
-        </p:spPr>
-        <p:txBody>
-          <a:bodyPr wrap="square" lIns="0" tIns="0" rIns="0" bIns="0" rtlCol="0" anchor="ctr"/>
-          <a:lstStyle/>
-          <a:p>
-            <a:pPr algn="r" indent="0" marL="0">
-              <a:buNone/>
-            </a:pPr>
-            <a:r>
-              <a:rPr lang="en-US" sz="1100" b="1" dirty="0">
-                <a:solidFill>
-                  <a:srgbClr val="0B2A3D"/>
-                </a:solidFill>
-                <a:latin typeface="Calibri" pitchFamily="34" charset="0"/>
-                <a:ea typeface="Calibri" pitchFamily="34" charset="-122"/>
-                <a:cs typeface="Calibri" pitchFamily="34" charset="-120"/>
-              </a:rPr>
-              <a:t>US$ 150,5 mil</a:t>
-            </a:r>
-            <a:endParaRPr lang="en-US" sz="1100" dirty="0"/>
-          </a:p>
-        </p:txBody>
-      </p:sp>
-      <p:sp>
-        <p:nvSpPr>
-          <p:cNvPr id="33" name="Text 31"/>
-          <p:cNvSpPr txBox="1"/>
-          <p:nvPr/>
-        </p:nvSpPr>
-        <p:spPr>
-          <a:xfrm>
-            <a:off x="4840834" y="3995928"/>
-            <a:ext cx="965606" cy="365760"/>
-          </a:xfrm>
-          <a:prstGeom prst="rect">
-            <a:avLst/>
-          </a:prstGeom>
-          <a:noFill/>
-          <a:ln/>
-        </p:spPr>
-        <p:txBody>
-          <a:bodyPr wrap="square" lIns="0" tIns="0" rIns="0" bIns="0" rtlCol="0" anchor="ctr"/>
-          <a:lstStyle/>
-          <a:p>
-            <a:pPr algn="r" indent="0" marL="0">
-              <a:buNone/>
-            </a:pPr>
-            <a:r>
-              <a:rPr lang="en-US" sz="850" dirty="0">
-                <a:solidFill>
-                  <a:srgbClr val="5B6B73"/>
-                </a:solidFill>
-                <a:latin typeface="Calibri" pitchFamily="34" charset="0"/>
-                <a:ea typeface="Calibri" pitchFamily="34" charset="-122"/>
-                <a:cs typeface="Calibri" pitchFamily="34" charset="-120"/>
-              </a:rPr>
-              <a:t>14 POB-dia</a:t>
-            </a:r>
-            <a:endParaRPr lang="en-US" sz="850" dirty="0"/>
-          </a:p>
-        </p:txBody>
-      </p:sp>
-      <p:sp>
-        <p:nvSpPr>
-          <p:cNvPr id="34" name="Text 32"/>
-          <p:cNvSpPr txBox="1"/>
-          <p:nvPr/>
-        </p:nvSpPr>
-        <p:spPr>
-          <a:xfrm>
-            <a:off x="566928" y="4361688"/>
-            <a:ext cx="2995574" cy="365760"/>
-          </a:xfrm>
-          <a:prstGeom prst="rect">
-            <a:avLst/>
-          </a:prstGeom>
-          <a:noFill/>
-          <a:ln/>
-        </p:spPr>
-        <p:txBody>
-          <a:bodyPr wrap="square" lIns="0" tIns="0" rIns="0" bIns="0" rtlCol="0" anchor="ctr"/>
-          <a:lstStyle/>
-          <a:p>
-            <a:pPr indent="0" marL="0">
-              <a:buNone/>
-            </a:pPr>
-            <a:r>
-              <a:rPr lang="en-US" sz="1100" dirty="0">
-                <a:solidFill>
-                  <a:srgbClr val="1C2B33"/>
-                </a:solidFill>
-                <a:latin typeface="Calibri" pitchFamily="34" charset="0"/>
-                <a:ea typeface="Calibri" pitchFamily="34" charset="-122"/>
-                <a:cs typeface="Calibri" pitchFamily="34" charset="-120"/>
-              </a:rPr>
-              <a:t>P&amp;Q - Químicos</a:t>
-            </a:r>
-            <a:endParaRPr lang="en-US" sz="1100" dirty="0"/>
-          </a:p>
-        </p:txBody>
-      </p:sp>
-      <p:sp>
-        <p:nvSpPr>
-          <p:cNvPr id="35" name="Text 33"/>
-          <p:cNvSpPr txBox="1"/>
-          <p:nvPr/>
-        </p:nvSpPr>
-        <p:spPr>
-          <a:xfrm>
-            <a:off x="3452774" y="4361688"/>
-            <a:ext cx="1497787" cy="365760"/>
-          </a:xfrm>
-          <a:prstGeom prst="rect">
-            <a:avLst/>
-          </a:prstGeom>
-          <a:noFill/>
-          <a:ln/>
-        </p:spPr>
-        <p:txBody>
-          <a:bodyPr wrap="square" lIns="0" tIns="0" rIns="0" bIns="0" rtlCol="0" anchor="ctr"/>
-          <a:lstStyle/>
-          <a:p>
-            <a:pPr algn="r" indent="0" marL="0">
-              <a:buNone/>
-            </a:pPr>
-            <a:r>
-              <a:rPr lang="en-US" sz="1100" b="1" dirty="0">
-                <a:solidFill>
-                  <a:srgbClr val="0B2A3D"/>
-                </a:solidFill>
-                <a:latin typeface="Calibri" pitchFamily="34" charset="0"/>
-                <a:ea typeface="Calibri" pitchFamily="34" charset="-122"/>
-                <a:cs typeface="Calibri" pitchFamily="34" charset="-120"/>
-              </a:rPr>
-              <a:t>US$ 10,0 mil</a:t>
-            </a:r>
-            <a:endParaRPr lang="en-US" sz="1100" dirty="0"/>
-          </a:p>
-        </p:txBody>
-      </p:sp>
-      <p:sp>
-        <p:nvSpPr>
-          <p:cNvPr id="36" name="Text 34"/>
-          <p:cNvSpPr txBox="1"/>
-          <p:nvPr/>
-        </p:nvSpPr>
-        <p:spPr>
-          <a:xfrm>
-            <a:off x="4840834" y="4361688"/>
-            <a:ext cx="965606" cy="365760"/>
-          </a:xfrm>
-          <a:prstGeom prst="rect">
-            <a:avLst/>
-          </a:prstGeom>
-          <a:noFill/>
-          <a:ln/>
-        </p:spPr>
-        <p:txBody>
-          <a:bodyPr wrap="square" lIns="0" tIns="0" rIns="0" bIns="0" rtlCol="0" anchor="ctr"/>
-          <a:lstStyle/>
-          <a:p>
-            <a:pPr algn="r" indent="0" marL="0">
-              <a:buNone/>
-            </a:pPr>
-            <a:r>
-              <a:rPr lang="en-US" sz="850" dirty="0">
-                <a:solidFill>
-                  <a:srgbClr val="5B6B73"/>
-                </a:solidFill>
-                <a:latin typeface="Calibri" pitchFamily="34" charset="0"/>
-                <a:ea typeface="Calibri" pitchFamily="34" charset="-122"/>
-                <a:cs typeface="Calibri" pitchFamily="34" charset="-120"/>
-              </a:rPr>
-              <a:t>6 POB-dia</a:t>
-            </a:r>
-            <a:endParaRPr lang="en-US" sz="850" dirty="0"/>
-          </a:p>
-        </p:txBody>
-      </p:sp>
-      <p:sp>
-        <p:nvSpPr>
-          <p:cNvPr id="37" name="Shape 35"/>
-          <p:cNvSpPr/>
-          <p:nvPr/>
-        </p:nvSpPr>
-        <p:spPr>
-          <a:xfrm>
-            <a:off x="457200" y="4727448"/>
-            <a:ext cx="5349240" cy="365760"/>
-          </a:xfrm>
-          <a:prstGeom prst="rect">
-            <a:avLst/>
-          </a:prstGeom>
-          <a:solidFill>
-            <a:srgbClr val="F0F4F5"/>
-          </a:solidFill>
-          <a:ln/>
-        </p:spPr>
-      </p:sp>
-      <p:sp>
-        <p:nvSpPr>
-          <p:cNvPr id="38" name="Text 36"/>
-          <p:cNvSpPr txBox="1"/>
-          <p:nvPr/>
-        </p:nvSpPr>
-        <p:spPr>
-          <a:xfrm>
-            <a:off x="566928" y="4727448"/>
             <a:ext cx="2995574" cy="365760"/>
           </a:xfrm>
           <a:prstGeom prst="rect">
@@ -10084,13 +9322,13 @@
       </p:sp>
       <p:sp>
         <p:nvSpPr>
-          <p:cNvPr id="39" name="Text 37"/>
+          <p:cNvPr id="32" name="Text 30"/>
           <p:cNvSpPr txBox="1"/>
           <p:nvPr/>
         </p:nvSpPr>
         <p:spPr>
           <a:xfrm>
-            <a:off x="3452774" y="4727448"/>
+            <a:off x="3452774" y="3995928"/>
             <a:ext cx="1497787" cy="365760"/>
           </a:xfrm>
           <a:prstGeom prst="rect">
@@ -10123,13 +9361,13 @@
       </p:sp>
       <p:sp>
         <p:nvSpPr>
-          <p:cNvPr id="40" name="Text 38"/>
+          <p:cNvPr id="33" name="Text 31"/>
           <p:cNvSpPr txBox="1"/>
           <p:nvPr/>
         </p:nvSpPr>
         <p:spPr>
           <a:xfrm>
-            <a:off x="4840834" y="4727448"/>
+            <a:off x="4840834" y="3995928"/>
             <a:ext cx="965606" cy="365760"/>
           </a:xfrm>
           <a:prstGeom prst="rect">
@@ -10146,7 +9384,7 @@
               <a:buNone/>
             </a:pPr>
             <a:r>
-              <a:rPr lang="en-US" sz="850" dirty="0">
+              <a:rPr lang="en-US" sz="900" dirty="0">
                 <a:solidFill>
                   <a:srgbClr val="5B6B73"/>
                 </a:solidFill>
@@ -10154,15 +9392,15 @@
                 <a:ea typeface="Calibri" pitchFamily="34" charset="-122"/>
                 <a:cs typeface="Calibri" pitchFamily="34" charset="-120"/>
               </a:rPr>
-              <a:t>0 POB-dia</a:t>
+              <a:t>0 POB</a:t>
             </a:r>
-            <a:endParaRPr lang="en-US" sz="850" dirty="0"/>
+            <a:endParaRPr lang="en-US" sz="900" dirty="0"/>
           </a:p>
         </p:txBody>
       </p:sp>
       <p:sp>
         <p:nvSpPr>
-          <p:cNvPr id="41" name="Text 39"/>
+          <p:cNvPr id="34" name="Text 32"/>
           <p:cNvSpPr txBox="1"/>
           <p:nvPr/>
         </p:nvSpPr>
@@ -10201,7 +9439,7 @@
       </p:sp>
       <p:sp>
         <p:nvSpPr>
-          <p:cNvPr id="42" name="Shape 40"/>
+          <p:cNvPr id="35" name="Shape 33"/>
           <p:cNvSpPr/>
           <p:nvPr/>
         </p:nvSpPr>
@@ -10224,150 +9462,13 @@
       </p:sp>
       <p:sp>
         <p:nvSpPr>
-          <p:cNvPr id="43" name="Text 41"/>
+          <p:cNvPr id="36" name="Text 34"/>
           <p:cNvSpPr txBox="1"/>
           <p:nvPr/>
         </p:nvSpPr>
         <p:spPr>
           <a:xfrm>
             <a:off x="6464808" y="2898648"/>
-            <a:ext cx="2995574" cy="365760"/>
-          </a:xfrm>
-          <a:prstGeom prst="rect">
-            <a:avLst/>
-          </a:prstGeom>
-          <a:noFill/>
-          <a:ln/>
-        </p:spPr>
-        <p:txBody>
-          <a:bodyPr wrap="square" lIns="0" tIns="0" rIns="0" bIns="0" rtlCol="0" anchor="ctr"/>
-          <a:lstStyle/>
-          <a:p>
-            <a:pPr indent="0" marL="0">
-              <a:buNone/>
-            </a:pPr>
-            <a:r>
-              <a:rPr lang="en-US" sz="1100" dirty="0">
-                <a:solidFill>
-                  <a:srgbClr val="1C2B33"/>
-                </a:solidFill>
-                <a:latin typeface="Calibri" pitchFamily="34" charset="0"/>
-                <a:ea typeface="Calibri" pitchFamily="34" charset="-122"/>
-                <a:cs typeface="Calibri" pitchFamily="34" charset="-120"/>
-              </a:rPr>
-              <a:t>Desenvolvimento de Produção</a:t>
-            </a:r>
-            <a:endParaRPr lang="en-US" sz="1100" dirty="0"/>
-          </a:p>
-        </p:txBody>
-      </p:sp>
-      <p:sp>
-        <p:nvSpPr>
-          <p:cNvPr id="44" name="Text 42"/>
-          <p:cNvSpPr txBox="1"/>
-          <p:nvPr/>
-        </p:nvSpPr>
-        <p:spPr>
-          <a:xfrm>
-            <a:off x="9350654" y="2898648"/>
-            <a:ext cx="1497787" cy="365760"/>
-          </a:xfrm>
-          <a:prstGeom prst="rect">
-            <a:avLst/>
-          </a:prstGeom>
-          <a:noFill/>
-          <a:ln/>
-        </p:spPr>
-        <p:txBody>
-          <a:bodyPr wrap="square" lIns="0" tIns="0" rIns="0" bIns="0" rtlCol="0" anchor="ctr"/>
-          <a:lstStyle/>
-          <a:p>
-            <a:pPr algn="r" indent="0" marL="0">
-              <a:buNone/>
-            </a:pPr>
-            <a:r>
-              <a:rPr lang="en-US" sz="1100" b="1" dirty="0">
-                <a:solidFill>
-                  <a:srgbClr val="0B2A3D"/>
-                </a:solidFill>
-                <a:latin typeface="Calibri" pitchFamily="34" charset="0"/>
-                <a:ea typeface="Calibri" pitchFamily="34" charset="-122"/>
-                <a:cs typeface="Calibri" pitchFamily="34" charset="-120"/>
-              </a:rPr>
-              <a:t>US$ 8,4 mi</a:t>
-            </a:r>
-            <a:endParaRPr lang="en-US" sz="1100" dirty="0"/>
-          </a:p>
-        </p:txBody>
-      </p:sp>
-      <p:sp>
-        <p:nvSpPr>
-          <p:cNvPr id="45" name="Text 43"/>
-          <p:cNvSpPr txBox="1"/>
-          <p:nvPr/>
-        </p:nvSpPr>
-        <p:spPr>
-          <a:xfrm>
-            <a:off x="10738714" y="2898648"/>
-            <a:ext cx="965606" cy="365760"/>
-          </a:xfrm>
-          <a:prstGeom prst="rect">
-            <a:avLst/>
-          </a:prstGeom>
-          <a:noFill/>
-          <a:ln/>
-        </p:spPr>
-        <p:txBody>
-          <a:bodyPr wrap="square" lIns="0" tIns="0" rIns="0" bIns="0" rtlCol="0" anchor="ctr"/>
-          <a:lstStyle/>
-          <a:p>
-            <a:pPr algn="r" indent="0" marL="0">
-              <a:buNone/>
-            </a:pPr>
-            <a:r>
-              <a:rPr lang="en-US" sz="850" dirty="0">
-                <a:solidFill>
-                  <a:srgbClr val="5B6B73"/>
-                </a:solidFill>
-                <a:latin typeface="Calibri" pitchFamily="34" charset="0"/>
-                <a:ea typeface="Calibri" pitchFamily="34" charset="-122"/>
-                <a:cs typeface="Calibri" pitchFamily="34" charset="-120"/>
-              </a:rPr>
-              <a:t>2.284 POB-dia</a:t>
-            </a:r>
-            <a:endParaRPr lang="en-US" sz="850" dirty="0"/>
-          </a:p>
-        </p:txBody>
-      </p:sp>
-      <p:sp>
-        <p:nvSpPr>
-          <p:cNvPr id="46" name="Shape 44"/>
-          <p:cNvSpPr/>
-          <p:nvPr/>
-        </p:nvSpPr>
-        <p:spPr>
-          <a:xfrm>
-            <a:off x="6355080" y="3264408"/>
-            <a:ext cx="5349240" cy="365760"/>
-          </a:xfrm>
-          <a:prstGeom prst="rect">
-            <a:avLst/>
-          </a:prstGeom>
-          <a:solidFill>
-            <a:srgbClr val="F0F4F5"/>
-          </a:solidFill>
-          <a:ln/>
-        </p:spPr>
-      </p:sp>
-      <p:sp>
-        <p:nvSpPr>
-          <p:cNvPr id="47" name="Text 45"/>
-          <p:cNvSpPr txBox="1"/>
-          <p:nvPr/>
-        </p:nvSpPr>
-        <p:spPr>
-          <a:xfrm>
-            <a:off x="6464808" y="3264408"/>
             <a:ext cx="2995574" cy="365760"/>
           </a:xfrm>
           <a:prstGeom prst="rect">
@@ -10400,13 +9501,13 @@
       </p:sp>
       <p:sp>
         <p:nvSpPr>
-          <p:cNvPr id="48" name="Text 46"/>
+          <p:cNvPr id="37" name="Text 35"/>
           <p:cNvSpPr txBox="1"/>
           <p:nvPr/>
         </p:nvSpPr>
         <p:spPr>
           <a:xfrm>
-            <a:off x="9350654" y="3264408"/>
+            <a:off x="9350654" y="2898648"/>
             <a:ext cx="1497787" cy="365760"/>
           </a:xfrm>
           <a:prstGeom prst="rect">
@@ -10431,7 +9532,7 @@
                 <a:ea typeface="Calibri" pitchFamily="34" charset="-122"/>
                 <a:cs typeface="Calibri" pitchFamily="34" charset="-120"/>
               </a:rPr>
-              <a:t>US$ 3,9 mi</a:t>
+              <a:t>US$ 2,8 mi</a:t>
             </a:r>
             <a:endParaRPr lang="en-US" sz="1100" dirty="0"/>
           </a:p>
@@ -10439,13 +9540,13 @@
       </p:sp>
       <p:sp>
         <p:nvSpPr>
-          <p:cNvPr id="49" name="Text 47"/>
+          <p:cNvPr id="38" name="Text 36"/>
           <p:cNvSpPr txBox="1"/>
           <p:nvPr/>
         </p:nvSpPr>
         <p:spPr>
           <a:xfrm>
-            <a:off x="10738714" y="3264408"/>
+            <a:off x="10738714" y="2898648"/>
             <a:ext cx="965606" cy="365760"/>
           </a:xfrm>
           <a:prstGeom prst="rect">
@@ -10462,7 +9563,7 @@
               <a:buNone/>
             </a:pPr>
             <a:r>
-              <a:rPr lang="en-US" sz="850" dirty="0">
+              <a:rPr lang="en-US" sz="900" dirty="0">
                 <a:solidFill>
                   <a:srgbClr val="5B6B73"/>
                 </a:solidFill>
@@ -10470,21 +9571,41 @@
                 <a:ea typeface="Calibri" pitchFamily="34" charset="-122"/>
                 <a:cs typeface="Calibri" pitchFamily="34" charset="-120"/>
               </a:rPr>
-              <a:t>2.844 POB-dia</a:t>
+              <a:t>129 POB</a:t>
             </a:r>
-            <a:endParaRPr lang="en-US" sz="850" dirty="0"/>
+            <a:endParaRPr lang="en-US" sz="900" dirty="0"/>
           </a:p>
         </p:txBody>
       </p:sp>
       <p:sp>
         <p:nvSpPr>
-          <p:cNvPr id="50" name="Text 48"/>
+          <p:cNvPr id="39" name="Shape 37"/>
+          <p:cNvSpPr/>
+          <p:nvPr/>
+        </p:nvSpPr>
+        <p:spPr>
+          <a:xfrm>
+            <a:off x="6355080" y="3264408"/>
+            <a:ext cx="5349240" cy="365760"/>
+          </a:xfrm>
+          <a:prstGeom prst="rect">
+            <a:avLst/>
+          </a:prstGeom>
+          <a:solidFill>
+            <a:srgbClr val="F0F4F5"/>
+          </a:solidFill>
+          <a:ln/>
+        </p:spPr>
+      </p:sp>
+      <p:sp>
+        <p:nvSpPr>
+          <p:cNvPr id="40" name="Text 38"/>
           <p:cNvSpPr txBox="1"/>
           <p:nvPr/>
         </p:nvSpPr>
         <p:spPr>
           <a:xfrm>
-            <a:off x="6464808" y="3630168"/>
+            <a:off x="6464808" y="3264408"/>
             <a:ext cx="2995574" cy="365760"/>
           </a:xfrm>
           <a:prstGeom prst="rect">
@@ -10517,13 +9638,13 @@
       </p:sp>
       <p:sp>
         <p:nvSpPr>
-          <p:cNvPr id="51" name="Text 49"/>
+          <p:cNvPr id="41" name="Text 39"/>
           <p:cNvSpPr txBox="1"/>
           <p:nvPr/>
         </p:nvSpPr>
         <p:spPr>
           <a:xfrm>
-            <a:off x="9350654" y="3630168"/>
+            <a:off x="9350654" y="3264408"/>
             <a:ext cx="1497787" cy="365760"/>
           </a:xfrm>
           <a:prstGeom prst="rect">
@@ -10556,13 +9677,13 @@
       </p:sp>
       <p:sp>
         <p:nvSpPr>
-          <p:cNvPr id="52" name="Text 50"/>
+          <p:cNvPr id="42" name="Text 40"/>
           <p:cNvSpPr txBox="1"/>
           <p:nvPr/>
         </p:nvSpPr>
         <p:spPr>
           <a:xfrm>
-            <a:off x="10738714" y="3630168"/>
+            <a:off x="10738714" y="3264408"/>
             <a:ext cx="965606" cy="365760"/>
           </a:xfrm>
           <a:prstGeom prst="rect">
@@ -10579,7 +9700,7 @@
               <a:buNone/>
             </a:pPr>
             <a:r>
-              <a:rPr lang="en-US" sz="850" dirty="0">
+              <a:rPr lang="en-US" sz="900" dirty="0">
                 <a:solidFill>
                   <a:srgbClr val="5B6B73"/>
                 </a:solidFill>
@@ -10587,158 +9708,21 @@
                 <a:ea typeface="Calibri" pitchFamily="34" charset="-122"/>
                 <a:cs typeface="Calibri" pitchFamily="34" charset="-120"/>
               </a:rPr>
-              <a:t>52 POB-dia</a:t>
+              <a:t>6 POB</a:t>
             </a:r>
-            <a:endParaRPr lang="en-US" sz="850" dirty="0"/>
+            <a:endParaRPr lang="en-US" sz="900" dirty="0"/>
           </a:p>
         </p:txBody>
       </p:sp>
       <p:sp>
         <p:nvSpPr>
-          <p:cNvPr id="53" name="Shape 51"/>
-          <p:cNvSpPr/>
+          <p:cNvPr id="43" name="Text 41"/>
+          <p:cNvSpPr txBox="1"/>
           <p:nvPr/>
         </p:nvSpPr>
         <p:spPr>
           <a:xfrm>
-            <a:off x="6355080" y="3995928"/>
-            <a:ext cx="5349240" cy="365760"/>
-          </a:xfrm>
-          <a:prstGeom prst="rect">
-            <a:avLst/>
-          </a:prstGeom>
-          <a:solidFill>
-            <a:srgbClr val="F0F4F5"/>
-          </a:solidFill>
-          <a:ln/>
-        </p:spPr>
-      </p:sp>
-      <p:sp>
-        <p:nvSpPr>
-          <p:cNvPr id="54" name="Text 52"/>
-          <p:cNvSpPr txBox="1"/>
-          <p:nvPr/>
-        </p:nvSpPr>
-        <p:spPr>
-          <a:xfrm>
-            <a:off x="6464808" y="3995928"/>
-            <a:ext cx="2995574" cy="365760"/>
-          </a:xfrm>
-          <a:prstGeom prst="rect">
-            <a:avLst/>
-          </a:prstGeom>
-          <a:noFill/>
-          <a:ln/>
-        </p:spPr>
-        <p:txBody>
-          <a:bodyPr wrap="square" lIns="0" tIns="0" rIns="0" bIns="0" rtlCol="0" anchor="ctr"/>
-          <a:lstStyle/>
-          <a:p>
-            <a:pPr indent="0" marL="0">
-              <a:buNone/>
-            </a:pPr>
-            <a:r>
-              <a:rPr lang="en-US" sz="1100" dirty="0">
-                <a:solidFill>
-                  <a:srgbClr val="1C2B33"/>
-                </a:solidFill>
-                <a:latin typeface="Calibri" pitchFamily="34" charset="0"/>
-                <a:ea typeface="Calibri" pitchFamily="34" charset="-122"/>
-                <a:cs typeface="Calibri" pitchFamily="34" charset="-120"/>
-              </a:rPr>
-              <a:t>Rotina Operacional</a:t>
-            </a:r>
-            <a:endParaRPr lang="en-US" sz="1100" dirty="0"/>
-          </a:p>
-        </p:txBody>
-      </p:sp>
-      <p:sp>
-        <p:nvSpPr>
-          <p:cNvPr id="55" name="Text 53"/>
-          <p:cNvSpPr txBox="1"/>
-          <p:nvPr/>
-        </p:nvSpPr>
-        <p:spPr>
-          <a:xfrm>
-            <a:off x="9350654" y="3995928"/>
-            <a:ext cx="1497787" cy="365760"/>
-          </a:xfrm>
-          <a:prstGeom prst="rect">
-            <a:avLst/>
-          </a:prstGeom>
-          <a:noFill/>
-          <a:ln/>
-        </p:spPr>
-        <p:txBody>
-          <a:bodyPr wrap="square" lIns="0" tIns="0" rIns="0" bIns="0" rtlCol="0" anchor="ctr"/>
-          <a:lstStyle/>
-          <a:p>
-            <a:pPr algn="r" indent="0" marL="0">
-              <a:buNone/>
-            </a:pPr>
-            <a:r>
-              <a:rPr lang="en-US" sz="1100" b="1" dirty="0">
-                <a:solidFill>
-                  <a:srgbClr val="0B2A3D"/>
-                </a:solidFill>
-                <a:latin typeface="Calibri" pitchFamily="34" charset="0"/>
-                <a:ea typeface="Calibri" pitchFamily="34" charset="-122"/>
-                <a:cs typeface="Calibri" pitchFamily="34" charset="-120"/>
-              </a:rPr>
-              <a:t>US$ 10,0 mil</a:t>
-            </a:r>
-            <a:endParaRPr lang="en-US" sz="1100" dirty="0"/>
-          </a:p>
-        </p:txBody>
-      </p:sp>
-      <p:sp>
-        <p:nvSpPr>
-          <p:cNvPr id="56" name="Text 54"/>
-          <p:cNvSpPr txBox="1"/>
-          <p:nvPr/>
-        </p:nvSpPr>
-        <p:spPr>
-          <a:xfrm>
-            <a:off x="10738714" y="3995928"/>
-            <a:ext cx="965606" cy="365760"/>
-          </a:xfrm>
-          <a:prstGeom prst="rect">
-            <a:avLst/>
-          </a:prstGeom>
-          <a:noFill/>
-          <a:ln/>
-        </p:spPr>
-        <p:txBody>
-          <a:bodyPr wrap="square" lIns="0" tIns="0" rIns="0" bIns="0" rtlCol="0" anchor="ctr"/>
-          <a:lstStyle/>
-          <a:p>
-            <a:pPr algn="r" indent="0" marL="0">
-              <a:buNone/>
-            </a:pPr>
-            <a:r>
-              <a:rPr lang="en-US" sz="850" dirty="0">
-                <a:solidFill>
-                  <a:srgbClr val="5B6B73"/>
-                </a:solidFill>
-                <a:latin typeface="Calibri" pitchFamily="34" charset="0"/>
-                <a:ea typeface="Calibri" pitchFamily="34" charset="-122"/>
-                <a:cs typeface="Calibri" pitchFamily="34" charset="-120"/>
-              </a:rPr>
-              <a:t>6 POB-dia</a:t>
-            </a:r>
-            <a:endParaRPr lang="en-US" sz="850" dirty="0"/>
-          </a:p>
-        </p:txBody>
-      </p:sp>
-      <p:sp>
-        <p:nvSpPr>
-          <p:cNvPr id="57" name="Text 55"/>
-          <p:cNvSpPr txBox="1"/>
-          <p:nvPr/>
-        </p:nvSpPr>
-        <p:spPr>
-          <a:xfrm>
-            <a:off x="6464808" y="4361688"/>
+            <a:off x="6464808" y="3630168"/>
             <a:ext cx="2995574" cy="365760"/>
           </a:xfrm>
           <a:prstGeom prst="rect">
@@ -10771,13 +9755,13 @@
       </p:sp>
       <p:sp>
         <p:nvSpPr>
-          <p:cNvPr id="58" name="Text 56"/>
+          <p:cNvPr id="44" name="Text 42"/>
           <p:cNvSpPr txBox="1"/>
           <p:nvPr/>
         </p:nvSpPr>
         <p:spPr>
           <a:xfrm>
-            <a:off x="9350654" y="4361688"/>
+            <a:off x="9350654" y="3630168"/>
             <a:ext cx="1497787" cy="365760"/>
           </a:xfrm>
           <a:prstGeom prst="rect">
@@ -10810,13 +9794,13 @@
       </p:sp>
       <p:sp>
         <p:nvSpPr>
-          <p:cNvPr id="59" name="Text 57"/>
+          <p:cNvPr id="45" name="Text 43"/>
           <p:cNvSpPr txBox="1"/>
           <p:nvPr/>
         </p:nvSpPr>
         <p:spPr>
           <a:xfrm>
-            <a:off x="10738714" y="4361688"/>
+            <a:off x="10738714" y="3630168"/>
             <a:ext cx="965606" cy="365760"/>
           </a:xfrm>
           <a:prstGeom prst="rect">
@@ -10833,7 +9817,7 @@
               <a:buNone/>
             </a:pPr>
             <a:r>
-              <a:rPr lang="en-US" sz="850" dirty="0">
+              <a:rPr lang="en-US" sz="900" dirty="0">
                 <a:solidFill>
                   <a:srgbClr val="5B6B73"/>
                 </a:solidFill>
@@ -10841,15 +9825,15 @@
                 <a:ea typeface="Calibri" pitchFamily="34" charset="-122"/>
                 <a:cs typeface="Calibri" pitchFamily="34" charset="-120"/>
               </a:rPr>
-              <a:t>0 POB-dia</a:t>
+              <a:t>0 POB</a:t>
             </a:r>
-            <a:endParaRPr lang="en-US" sz="850" dirty="0"/>
+            <a:endParaRPr lang="en-US" sz="900" dirty="0"/>
           </a:p>
         </p:txBody>
       </p:sp>
       <p:sp>
         <p:nvSpPr>
-          <p:cNvPr id="60" name="Text 58"/>
+          <p:cNvPr id="46" name="Text 44"/>
           <p:cNvSpPr txBox="1"/>
           <p:nvPr/>
         </p:nvSpPr>
@@ -10880,7 +9864,7 @@
                 <a:ea typeface="Calibri" pitchFamily="34" charset="-122"/>
                 <a:cs typeface="Calibri" pitchFamily="34" charset="-120"/>
               </a:rPr>
-              <a:t>Metodologia: soma de Custo de Serviço + Custo de Material (Jan–Dez), para itens de Cost Allocation = CAPEX com status 'Contar' ou 'TA'. POB em POB-dia (pessoas a bordo × dias). O total desconsidera a categoria Desenvolvimento de Produção (US$ 8,4 mi, mantida na lista de Categoria apenas para referência).</a:t>
+              <a:t>Metodologia: soma de Custo de Serviço + Custo de Material (Jan–Dez), para itens de Cost Allocation = CAPEX com status 'Contar' ou 'TA'. O total desconsidera a categoria Desenvolvimento de Produção (sem itens para este ativo).</a:t>
             </a:r>
             <a:endParaRPr lang="en-US" sz="850" dirty="0"/>
           </a:p>
@@ -14819,7 +13803,7 @@
                 <a:ea typeface="Calibri" pitchFamily="34" charset="-122"/>
                 <a:cs typeface="Calibri" pitchFamily="34" charset="-120"/>
               </a:rPr>
-              <a:t>Fonte: Plano Integrado · aba 'Geral - Em análise' · coluna 'Valor Total' · itens de Cost Allocation = CAPEX, status 'Contar' + 'TA'. Lista completa disponível na planilha em anexo. Extrato pendente de atualização — pode não somar exatamente ao total da Composição de Custo e POB.</a:t>
+              <a:t>Fonte: Plano Integrado · aba 'Geral - Em análise' · itens de Cost Allocation = CAPEX, status 'Contar' + 'TA'. Lista completa disponível na planilha em anexo.</a:t>
             </a:r>
             <a:endParaRPr lang="en-US" sz="850" dirty="0"/>
           </a:p>
@@ -14983,7 +13967,7 @@
                 <a:ea typeface="Cambria" pitchFamily="34" charset="-122"/>
                 <a:cs typeface="Cambria" pitchFamily="34" charset="-120"/>
               </a:rPr>
-              <a:t>US$ 35,0 mi</a:t>
+              <a:t>US$ 29,5 mi</a:t>
             </a:r>
             <a:endParaRPr lang="en-US" sz="2600" dirty="0"/>
           </a:p>
@@ -15122,7 +14106,7 @@
                 <a:ea typeface="Cambria" pitchFamily="34" charset="-122"/>
                 <a:cs typeface="Cambria" pitchFamily="34" charset="-120"/>
               </a:rPr>
-              <a:t>19.668</a:t>
+              <a:t>706</a:t>
             </a:r>
             <a:endParaRPr lang="en-US" sz="2600" dirty="0"/>
           </a:p>
@@ -15161,7 +14145,7 @@
                 <a:ea typeface="Calibri" pitchFamily="34" charset="-122"/>
                 <a:cs typeface="Calibri" pitchFamily="34" charset="-120"/>
               </a:rPr>
-              <a:t>POB TOTAL (POB-DIA)</a:t>
+              <a:t>POB TOTAL</a:t>
             </a:r>
             <a:endParaRPr lang="en-US" sz="950" dirty="0"/>
           </a:p>
@@ -15200,7 +14184,7 @@
                 <a:ea typeface="Calibri" pitchFamily="34" charset="-122"/>
                 <a:cs typeface="Calibri" pitchFamily="34" charset="-120"/>
               </a:rPr>
-              <a:t>pessoas a bordo × dias, no ano</a:t>
+              <a:t>pessoas a bordo alocadas</a:t>
             </a:r>
             <a:endParaRPr lang="en-US" sz="850" dirty="0"/>
           </a:p>
@@ -15704,7 +14688,7 @@
                             <a:srgbClr val="FFFFFF"/>
                           </a:solidFill>
                         </a:rPr>
-                        <a:t>POB-DIA</a:t>
+                        <a:t>POB</a:t>
                       </a:r>
                       <a:endParaRPr lang="en-US" sz="1000" dirty="0"/>
                     </a:p>
@@ -15889,7 +14873,7 @@
                             <a:srgbClr val="1C2B33"/>
                           </a:solidFill>
                         </a:rPr>
-                        <a:t>US$ 18,1 mi</a:t>
+                        <a:t>US$ 16,0 mi</a:t>
                       </a:r>
                       <a:endParaRPr lang="en-US" sz="1050" dirty="0"/>
                     </a:p>
@@ -15950,7 +14934,7 @@
                             <a:srgbClr val="1C2B33"/>
                           </a:solidFill>
                         </a:rPr>
-                        <a:t>5.544</a:t>
+                        <a:t>268</a:t>
                       </a:r>
                       <a:endParaRPr lang="en-US" sz="1050" dirty="0"/>
                     </a:p>
@@ -16135,7 +15119,7 @@
                             <a:srgbClr val="1C2B33"/>
                           </a:solidFill>
                         </a:rPr>
-                        <a:t>US$ 8,8 mi</a:t>
+                        <a:t>US$ 7,2 mi</a:t>
                       </a:r>
                       <a:endParaRPr lang="en-US" sz="1050" dirty="0"/>
                     </a:p>
@@ -16196,7 +15180,7 @@
                             <a:srgbClr val="1C2B33"/>
                           </a:solidFill>
                         </a:rPr>
-                        <a:t>5.092</a:t>
+                        <a:t>182</a:t>
                       </a:r>
                       <a:endParaRPr lang="en-US" sz="1050" dirty="0"/>
                     </a:p>
@@ -16381,7 +15365,7 @@
                             <a:srgbClr val="1C2B33"/>
                           </a:solidFill>
                         </a:rPr>
-                        <a:t>US$ 3,5 mi</a:t>
+                        <a:t>US$ 2,9 mi</a:t>
                       </a:r>
                       <a:endParaRPr lang="en-US" sz="1050" dirty="0"/>
                     </a:p>
@@ -16442,7 +15426,7 @@
                             <a:srgbClr val="1C2B33"/>
                           </a:solidFill>
                         </a:rPr>
-                        <a:t>3.846</a:t>
+                        <a:t>121</a:t>
                       </a:r>
                       <a:endParaRPr lang="en-US" sz="1050" dirty="0"/>
                     </a:p>
@@ -16627,7 +15611,7 @@
                             <a:srgbClr val="1C2B33"/>
                           </a:solidFill>
                         </a:rPr>
-                        <a:t>US$ 4,5 mi</a:t>
+                        <a:t>US$ 3,4 mi</a:t>
                       </a:r>
                       <a:endParaRPr lang="en-US" sz="1050" dirty="0"/>
                     </a:p>
@@ -16688,7 +15672,7 @@
                             <a:srgbClr val="1C2B33"/>
                           </a:solidFill>
                         </a:rPr>
-                        <a:t>5.186</a:t>
+                        <a:t>135</a:t>
                       </a:r>
                       <a:endParaRPr lang="en-US" sz="1050" dirty="0"/>
                     </a:p>
@@ -16873,7 +15857,7 @@
                             <a:srgbClr val="0B2A3D"/>
                           </a:solidFill>
                         </a:rPr>
-                        <a:t>US$ 35,0 mi</a:t>
+                        <a:t>US$ 29,5 mi</a:t>
                       </a:r>
                       <a:endParaRPr lang="en-US" sz="1050" dirty="0"/>
                     </a:p>
@@ -16934,7 +15918,7 @@
                             <a:srgbClr val="0B2A3D"/>
                           </a:solidFill>
                         </a:rPr>
-                        <a:t>19.668</a:t>
+                        <a:t>706</a:t>
                       </a:r>
                       <a:endParaRPr lang="en-US" sz="1050" dirty="0"/>
                     </a:p>
@@ -17667,7 +16651,7 @@
                 <a:ea typeface="Cambria" pitchFamily="34" charset="-122"/>
                 <a:cs typeface="Cambria" pitchFamily="34" charset="-120"/>
               </a:rPr>
-              <a:t>US$ 12,0 mi</a:t>
+              <a:t>US$ 9,8 mi</a:t>
             </a:r>
             <a:endParaRPr lang="en-US" sz="2100" dirty="0"/>
           </a:p>
@@ -17767,7 +16751,7 @@
                 <a:ea typeface="Cambria" pitchFamily="34" charset="-122"/>
                 <a:cs typeface="Cambria" pitchFamily="34" charset="-120"/>
               </a:rPr>
-              <a:t>US$ 18,1 mi</a:t>
+              <a:t>US$ 16,0 mi</a:t>
             </a:r>
             <a:endParaRPr lang="en-US" sz="2100" dirty="0"/>
           </a:p>
@@ -17867,7 +16851,7 @@
                 <a:ea typeface="Cambria" pitchFamily="34" charset="-122"/>
                 <a:cs typeface="Cambria" pitchFamily="34" charset="-120"/>
               </a:rPr>
-              <a:t>5.544</a:t>
+              <a:t>268</a:t>
             </a:r>
             <a:endParaRPr lang="en-US" sz="2100" dirty="0"/>
           </a:p>
@@ -17906,7 +16890,7 @@
                 <a:ea typeface="Calibri" pitchFamily="34" charset="-122"/>
                 <a:cs typeface="Calibri" pitchFamily="34" charset="-120"/>
               </a:rPr>
-              <a:t>POB TOTAL (POB-DIA)</a:t>
+              <a:t>POB TOTAL</a:t>
             </a:r>
             <a:endParaRPr lang="en-US" sz="850" dirty="0"/>
           </a:p>
@@ -18077,7 +17061,7 @@
               <a:buNone/>
             </a:pPr>
             <a:r>
-              <a:rPr lang="en-US" sz="850" dirty="0">
+              <a:rPr lang="en-US" sz="900" dirty="0">
                 <a:solidFill>
                   <a:srgbClr val="5B6B73"/>
                 </a:solidFill>
@@ -18085,9 +17069,9 @@
                 <a:ea typeface="Calibri" pitchFamily="34" charset="-122"/>
                 <a:cs typeface="Calibri" pitchFamily="34" charset="-120"/>
               </a:rPr>
-              <a:t>1.611 POB-dia</a:t>
+              <a:t>92 POB</a:t>
             </a:r>
-            <a:endParaRPr lang="en-US" sz="850" dirty="0"/>
+            <a:endParaRPr lang="en-US" sz="900" dirty="0"/>
           </a:p>
         </p:txBody>
       </p:sp>
@@ -18214,7 +17198,7 @@
               <a:buNone/>
             </a:pPr>
             <a:r>
-              <a:rPr lang="en-US" sz="850" dirty="0">
+              <a:rPr lang="en-US" sz="900" dirty="0">
                 <a:solidFill>
                   <a:srgbClr val="5B6B73"/>
                 </a:solidFill>
@@ -18222,9 +17206,9 @@
                 <a:ea typeface="Calibri" pitchFamily="34" charset="-122"/>
                 <a:cs typeface="Calibri" pitchFamily="34" charset="-120"/>
               </a:rPr>
-              <a:t>224 POB-dia</a:t>
+              <a:t>16 POB</a:t>
             </a:r>
-            <a:endParaRPr lang="en-US" sz="850" dirty="0"/>
+            <a:endParaRPr lang="en-US" sz="900" dirty="0"/>
           </a:p>
         </p:txBody>
       </p:sp>
@@ -18237,6 +17221,143 @@
         <p:spPr>
           <a:xfrm>
             <a:off x="566928" y="3630168"/>
+            <a:ext cx="2995574" cy="365760"/>
+          </a:xfrm>
+          <a:prstGeom prst="rect">
+            <a:avLst/>
+          </a:prstGeom>
+          <a:noFill/>
+          <a:ln/>
+        </p:spPr>
+        <p:txBody>
+          <a:bodyPr wrap="square" lIns="0" tIns="0" rIns="0" bIns="0" rtlCol="0" anchor="ctr"/>
+          <a:lstStyle/>
+          <a:p>
+            <a:pPr indent="0" marL="0">
+              <a:buNone/>
+            </a:pPr>
+            <a:r>
+              <a:rPr lang="en-US" sz="1100" dirty="0">
+                <a:solidFill>
+                  <a:srgbClr val="1C2B33"/>
+                </a:solidFill>
+                <a:latin typeface="Calibri" pitchFamily="34" charset="0"/>
+                <a:ea typeface="Calibri" pitchFamily="34" charset="-122"/>
+                <a:cs typeface="Calibri" pitchFamily="34" charset="-120"/>
+              </a:rPr>
+              <a:t>MNT – Manutenção</a:t>
+            </a:r>
+            <a:endParaRPr lang="en-US" sz="1100" dirty="0"/>
+          </a:p>
+        </p:txBody>
+      </p:sp>
+      <p:sp>
+        <p:nvSpPr>
+          <p:cNvPr id="28" name="Text 26"/>
+          <p:cNvSpPr txBox="1"/>
+          <p:nvPr/>
+        </p:nvSpPr>
+        <p:spPr>
+          <a:xfrm>
+            <a:off x="3452774" y="3630168"/>
+            <a:ext cx="1497787" cy="365760"/>
+          </a:xfrm>
+          <a:prstGeom prst="rect">
+            <a:avLst/>
+          </a:prstGeom>
+          <a:noFill/>
+          <a:ln/>
+        </p:spPr>
+        <p:txBody>
+          <a:bodyPr wrap="square" lIns="0" tIns="0" rIns="0" bIns="0" rtlCol="0" anchor="ctr"/>
+          <a:lstStyle/>
+          <a:p>
+            <a:pPr algn="r" indent="0" marL="0">
+              <a:buNone/>
+            </a:pPr>
+            <a:r>
+              <a:rPr lang="en-US" sz="1100" b="1" dirty="0">
+                <a:solidFill>
+                  <a:srgbClr val="0B2A3D"/>
+                </a:solidFill>
+                <a:latin typeface="Calibri" pitchFamily="34" charset="0"/>
+                <a:ea typeface="Calibri" pitchFamily="34" charset="-122"/>
+                <a:cs typeface="Calibri" pitchFamily="34" charset="-120"/>
+              </a:rPr>
+              <a:t>US$ 2,4 mi</a:t>
+            </a:r>
+            <a:endParaRPr lang="en-US" sz="1100" dirty="0"/>
+          </a:p>
+        </p:txBody>
+      </p:sp>
+      <p:sp>
+        <p:nvSpPr>
+          <p:cNvPr id="29" name="Text 27"/>
+          <p:cNvSpPr txBox="1"/>
+          <p:nvPr/>
+        </p:nvSpPr>
+        <p:spPr>
+          <a:xfrm>
+            <a:off x="4840834" y="3630168"/>
+            <a:ext cx="965606" cy="365760"/>
+          </a:xfrm>
+          <a:prstGeom prst="rect">
+            <a:avLst/>
+          </a:prstGeom>
+          <a:noFill/>
+          <a:ln/>
+        </p:spPr>
+        <p:txBody>
+          <a:bodyPr wrap="square" lIns="0" tIns="0" rIns="0" bIns="0" rtlCol="0" anchor="ctr"/>
+          <a:lstStyle/>
+          <a:p>
+            <a:pPr algn="r" indent="0" marL="0">
+              <a:buNone/>
+            </a:pPr>
+            <a:r>
+              <a:rPr lang="en-US" sz="900" dirty="0">
+                <a:solidFill>
+                  <a:srgbClr val="5B6B73"/>
+                </a:solidFill>
+                <a:latin typeface="Calibri" pitchFamily="34" charset="0"/>
+                <a:ea typeface="Calibri" pitchFamily="34" charset="-122"/>
+                <a:cs typeface="Calibri" pitchFamily="34" charset="-120"/>
+              </a:rPr>
+              <a:t>14 POB</a:t>
+            </a:r>
+            <a:endParaRPr lang="en-US" sz="900" dirty="0"/>
+          </a:p>
+        </p:txBody>
+      </p:sp>
+      <p:sp>
+        <p:nvSpPr>
+          <p:cNvPr id="30" name="Shape 28"/>
+          <p:cNvSpPr/>
+          <p:nvPr/>
+        </p:nvSpPr>
+        <p:spPr>
+          <a:xfrm>
+            <a:off x="457200" y="3995928"/>
+            <a:ext cx="5349240" cy="365760"/>
+          </a:xfrm>
+          <a:prstGeom prst="rect">
+            <a:avLst/>
+          </a:prstGeom>
+          <a:solidFill>
+            <a:srgbClr val="F0F4F5"/>
+          </a:solidFill>
+          <a:ln/>
+        </p:spPr>
+      </p:sp>
+      <p:sp>
+        <p:nvSpPr>
+          <p:cNvPr id="31" name="Text 29"/>
+          <p:cNvSpPr txBox="1"/>
+          <p:nvPr/>
+        </p:nvSpPr>
+        <p:spPr>
+          <a:xfrm>
+            <a:off x="566928" y="3995928"/>
             <a:ext cx="2995574" cy="365760"/>
           </a:xfrm>
           <a:prstGeom prst="rect">
@@ -18269,143 +17390,6 @@
       </p:sp>
       <p:sp>
         <p:nvSpPr>
-          <p:cNvPr id="28" name="Text 26"/>
-          <p:cNvSpPr txBox="1"/>
-          <p:nvPr/>
-        </p:nvSpPr>
-        <p:spPr>
-          <a:xfrm>
-            <a:off x="3452774" y="3630168"/>
-            <a:ext cx="1497787" cy="365760"/>
-          </a:xfrm>
-          <a:prstGeom prst="rect">
-            <a:avLst/>
-          </a:prstGeom>
-          <a:noFill/>
-          <a:ln/>
-        </p:spPr>
-        <p:txBody>
-          <a:bodyPr wrap="square" lIns="0" tIns="0" rIns="0" bIns="0" rtlCol="0" anchor="ctr"/>
-          <a:lstStyle/>
-          <a:p>
-            <a:pPr algn="r" indent="0" marL="0">
-              <a:buNone/>
-            </a:pPr>
-            <a:r>
-              <a:rPr lang="en-US" sz="1100" b="1" dirty="0">
-                <a:solidFill>
-                  <a:srgbClr val="0B2A3D"/>
-                </a:solidFill>
-                <a:latin typeface="Calibri" pitchFamily="34" charset="0"/>
-                <a:ea typeface="Calibri" pitchFamily="34" charset="-122"/>
-                <a:cs typeface="Calibri" pitchFamily="34" charset="-120"/>
-              </a:rPr>
-              <a:t>US$ 3,3 mi</a:t>
-            </a:r>
-            <a:endParaRPr lang="en-US" sz="1100" dirty="0"/>
-          </a:p>
-        </p:txBody>
-      </p:sp>
-      <p:sp>
-        <p:nvSpPr>
-          <p:cNvPr id="29" name="Text 27"/>
-          <p:cNvSpPr txBox="1"/>
-          <p:nvPr/>
-        </p:nvSpPr>
-        <p:spPr>
-          <a:xfrm>
-            <a:off x="4840834" y="3630168"/>
-            <a:ext cx="965606" cy="365760"/>
-          </a:xfrm>
-          <a:prstGeom prst="rect">
-            <a:avLst/>
-          </a:prstGeom>
-          <a:noFill/>
-          <a:ln/>
-        </p:spPr>
-        <p:txBody>
-          <a:bodyPr wrap="square" lIns="0" tIns="0" rIns="0" bIns="0" rtlCol="0" anchor="ctr"/>
-          <a:lstStyle/>
-          <a:p>
-            <a:pPr algn="r" indent="0" marL="0">
-              <a:buNone/>
-            </a:pPr>
-            <a:r>
-              <a:rPr lang="en-US" sz="850" dirty="0">
-                <a:solidFill>
-                  <a:srgbClr val="5B6B73"/>
-                </a:solidFill>
-                <a:latin typeface="Calibri" pitchFamily="34" charset="0"/>
-                <a:ea typeface="Calibri" pitchFamily="34" charset="-122"/>
-                <a:cs typeface="Calibri" pitchFamily="34" charset="-120"/>
-              </a:rPr>
-              <a:t>2.865 POB-dia</a:t>
-            </a:r>
-            <a:endParaRPr lang="en-US" sz="850" dirty="0"/>
-          </a:p>
-        </p:txBody>
-      </p:sp>
-      <p:sp>
-        <p:nvSpPr>
-          <p:cNvPr id="30" name="Shape 28"/>
-          <p:cNvSpPr/>
-          <p:nvPr/>
-        </p:nvSpPr>
-        <p:spPr>
-          <a:xfrm>
-            <a:off x="457200" y="3995928"/>
-            <a:ext cx="5349240" cy="365760"/>
-          </a:xfrm>
-          <a:prstGeom prst="rect">
-            <a:avLst/>
-          </a:prstGeom>
-          <a:solidFill>
-            <a:srgbClr val="F0F4F5"/>
-          </a:solidFill>
-          <a:ln/>
-        </p:spPr>
-      </p:sp>
-      <p:sp>
-        <p:nvSpPr>
-          <p:cNvPr id="31" name="Text 29"/>
-          <p:cNvSpPr txBox="1"/>
-          <p:nvPr/>
-        </p:nvSpPr>
-        <p:spPr>
-          <a:xfrm>
-            <a:off x="566928" y="3995928"/>
-            <a:ext cx="2995574" cy="365760"/>
-          </a:xfrm>
-          <a:prstGeom prst="rect">
-            <a:avLst/>
-          </a:prstGeom>
-          <a:noFill/>
-          <a:ln/>
-        </p:spPr>
-        <p:txBody>
-          <a:bodyPr wrap="square" lIns="0" tIns="0" rIns="0" bIns="0" rtlCol="0" anchor="ctr"/>
-          <a:lstStyle/>
-          <a:p>
-            <a:pPr indent="0" marL="0">
-              <a:buNone/>
-            </a:pPr>
-            <a:r>
-              <a:rPr lang="en-US" sz="1100" dirty="0">
-                <a:solidFill>
-                  <a:srgbClr val="1C2B33"/>
-                </a:solidFill>
-                <a:latin typeface="Calibri" pitchFamily="34" charset="0"/>
-                <a:ea typeface="Calibri" pitchFamily="34" charset="-122"/>
-                <a:cs typeface="Calibri" pitchFamily="34" charset="-120"/>
-              </a:rPr>
-              <a:t>MNT – Manutenção</a:t>
-            </a:r>
-            <a:endParaRPr lang="en-US" sz="1100" dirty="0"/>
-          </a:p>
-        </p:txBody>
-      </p:sp>
-      <p:sp>
-        <p:nvSpPr>
           <p:cNvPr id="32" name="Text 30"/>
           <p:cNvSpPr txBox="1"/>
           <p:nvPr/>
@@ -18437,7 +17421,7 @@
                 <a:ea typeface="Calibri" pitchFamily="34" charset="-122"/>
                 <a:cs typeface="Calibri" pitchFamily="34" charset="-120"/>
               </a:rPr>
-              <a:t>US$ 2,4 mi</a:t>
+              <a:t>US$ 1,2 mi</a:t>
             </a:r>
             <a:endParaRPr lang="en-US" sz="1100" dirty="0"/>
           </a:p>
@@ -18468,7 +17452,7 @@
               <a:buNone/>
             </a:pPr>
             <a:r>
-              <a:rPr lang="en-US" sz="850" dirty="0">
+              <a:rPr lang="en-US" sz="900" dirty="0">
                 <a:solidFill>
                   <a:srgbClr val="5B6B73"/>
                 </a:solidFill>
@@ -18476,9 +17460,9 @@
                 <a:ea typeface="Calibri" pitchFamily="34" charset="-122"/>
                 <a:cs typeface="Calibri" pitchFamily="34" charset="-120"/>
               </a:rPr>
-              <a:t>248 POB-dia</a:t>
+              <a:t>127 POB</a:t>
             </a:r>
-            <a:endParaRPr lang="en-US" sz="850" dirty="0"/>
+            <a:endParaRPr lang="en-US" sz="900" dirty="0"/>
           </a:p>
         </p:txBody>
       </p:sp>
@@ -18585,7 +17569,7 @@
               <a:buNone/>
             </a:pPr>
             <a:r>
-              <a:rPr lang="en-US" sz="850" dirty="0">
+              <a:rPr lang="en-US" sz="900" dirty="0">
                 <a:solidFill>
                   <a:srgbClr val="5B6B73"/>
                 </a:solidFill>
@@ -18593,9 +17577,9 @@
                 <a:ea typeface="Calibri" pitchFamily="34" charset="-122"/>
                 <a:cs typeface="Calibri" pitchFamily="34" charset="-120"/>
               </a:rPr>
-              <a:t>540 POB-dia</a:t>
+              <a:t>18 POB</a:t>
             </a:r>
-            <a:endParaRPr lang="en-US" sz="850" dirty="0"/>
+            <a:endParaRPr lang="en-US" sz="900" dirty="0"/>
           </a:p>
         </p:txBody>
       </p:sp>
@@ -18628,6 +17612,123 @@
         <p:spPr>
           <a:xfrm>
             <a:off x="566928" y="4727448"/>
+            <a:ext cx="2995574" cy="365760"/>
+          </a:xfrm>
+          <a:prstGeom prst="rect">
+            <a:avLst/>
+          </a:prstGeom>
+          <a:noFill/>
+          <a:ln/>
+        </p:spPr>
+        <p:txBody>
+          <a:bodyPr wrap="square" lIns="0" tIns="0" rIns="0" bIns="0" rtlCol="0" anchor="ctr"/>
+          <a:lstStyle/>
+          <a:p>
+            <a:pPr indent="0" marL="0">
+              <a:buNone/>
+            </a:pPr>
+            <a:r>
+              <a:rPr lang="en-US" sz="1100" dirty="0">
+                <a:solidFill>
+                  <a:srgbClr val="1C2B33"/>
+                </a:solidFill>
+                <a:latin typeface="Calibri" pitchFamily="34" charset="0"/>
+                <a:ea typeface="Calibri" pitchFamily="34" charset="-122"/>
+                <a:cs typeface="Calibri" pitchFamily="34" charset="-120"/>
+              </a:rPr>
+              <a:t>Segurança de Processos</a:t>
+            </a:r>
+            <a:endParaRPr lang="en-US" sz="1100" dirty="0"/>
+          </a:p>
+        </p:txBody>
+      </p:sp>
+      <p:sp>
+        <p:nvSpPr>
+          <p:cNvPr id="39" name="Text 37"/>
+          <p:cNvSpPr txBox="1"/>
+          <p:nvPr/>
+        </p:nvSpPr>
+        <p:spPr>
+          <a:xfrm>
+            <a:off x="3452774" y="4727448"/>
+            <a:ext cx="1497787" cy="365760"/>
+          </a:xfrm>
+          <a:prstGeom prst="rect">
+            <a:avLst/>
+          </a:prstGeom>
+          <a:noFill/>
+          <a:ln/>
+        </p:spPr>
+        <p:txBody>
+          <a:bodyPr wrap="square" lIns="0" tIns="0" rIns="0" bIns="0" rtlCol="0" anchor="ctr"/>
+          <a:lstStyle/>
+          <a:p>
+            <a:pPr algn="r" indent="0" marL="0">
+              <a:buNone/>
+            </a:pPr>
+            <a:r>
+              <a:rPr lang="en-US" sz="1100" b="1" dirty="0">
+                <a:solidFill>
+                  <a:srgbClr val="0B2A3D"/>
+                </a:solidFill>
+                <a:latin typeface="Calibri" pitchFamily="34" charset="0"/>
+                <a:ea typeface="Calibri" pitchFamily="34" charset="-122"/>
+                <a:cs typeface="Calibri" pitchFamily="34" charset="-120"/>
+              </a:rPr>
+              <a:t>US$ 138,5 mil</a:t>
+            </a:r>
+            <a:endParaRPr lang="en-US" sz="1100" dirty="0"/>
+          </a:p>
+        </p:txBody>
+      </p:sp>
+      <p:sp>
+        <p:nvSpPr>
+          <p:cNvPr id="40" name="Text 38"/>
+          <p:cNvSpPr txBox="1"/>
+          <p:nvPr/>
+        </p:nvSpPr>
+        <p:spPr>
+          <a:xfrm>
+            <a:off x="4840834" y="4727448"/>
+            <a:ext cx="965606" cy="365760"/>
+          </a:xfrm>
+          <a:prstGeom prst="rect">
+            <a:avLst/>
+          </a:prstGeom>
+          <a:noFill/>
+          <a:ln/>
+        </p:spPr>
+        <p:txBody>
+          <a:bodyPr wrap="square" lIns="0" tIns="0" rIns="0" bIns="0" rtlCol="0" anchor="ctr"/>
+          <a:lstStyle/>
+          <a:p>
+            <a:pPr algn="r" indent="0" marL="0">
+              <a:buNone/>
+            </a:pPr>
+            <a:r>
+              <a:rPr lang="en-US" sz="900" dirty="0">
+                <a:solidFill>
+                  <a:srgbClr val="5B6B73"/>
+                </a:solidFill>
+                <a:latin typeface="Calibri" pitchFamily="34" charset="0"/>
+                <a:ea typeface="Calibri" pitchFamily="34" charset="-122"/>
+                <a:cs typeface="Calibri" pitchFamily="34" charset="-120"/>
+              </a:rPr>
+              <a:t>0 POB</a:t>
+            </a:r>
+            <a:endParaRPr lang="en-US" sz="900" dirty="0"/>
+          </a:p>
+        </p:txBody>
+      </p:sp>
+      <p:sp>
+        <p:nvSpPr>
+          <p:cNvPr id="41" name="Text 39"/>
+          <p:cNvSpPr txBox="1"/>
+          <p:nvPr/>
+        </p:nvSpPr>
+        <p:spPr>
+          <a:xfrm>
+            <a:off x="566928" y="5093208"/>
             <a:ext cx="2995574" cy="365760"/>
           </a:xfrm>
           <a:prstGeom prst="rect">
@@ -18660,123 +17761,6 @@
       </p:sp>
       <p:sp>
         <p:nvSpPr>
-          <p:cNvPr id="39" name="Text 37"/>
-          <p:cNvSpPr txBox="1"/>
-          <p:nvPr/>
-        </p:nvSpPr>
-        <p:spPr>
-          <a:xfrm>
-            <a:off x="3452774" y="4727448"/>
-            <a:ext cx="1497787" cy="365760"/>
-          </a:xfrm>
-          <a:prstGeom prst="rect">
-            <a:avLst/>
-          </a:prstGeom>
-          <a:noFill/>
-          <a:ln/>
-        </p:spPr>
-        <p:txBody>
-          <a:bodyPr wrap="square" lIns="0" tIns="0" rIns="0" bIns="0" rtlCol="0" anchor="ctr"/>
-          <a:lstStyle/>
-          <a:p>
-            <a:pPr algn="r" indent="0" marL="0">
-              <a:buNone/>
-            </a:pPr>
-            <a:r>
-              <a:rPr lang="en-US" sz="1100" b="1" dirty="0">
-                <a:solidFill>
-                  <a:srgbClr val="0B2A3D"/>
-                </a:solidFill>
-                <a:latin typeface="Calibri" pitchFamily="34" charset="0"/>
-                <a:ea typeface="Calibri" pitchFamily="34" charset="-122"/>
-                <a:cs typeface="Calibri" pitchFamily="34" charset="-120"/>
-              </a:rPr>
-              <a:t>US$ 140,5 mil</a:t>
-            </a:r>
-            <a:endParaRPr lang="en-US" sz="1100" dirty="0"/>
-          </a:p>
-        </p:txBody>
-      </p:sp>
-      <p:sp>
-        <p:nvSpPr>
-          <p:cNvPr id="40" name="Text 38"/>
-          <p:cNvSpPr txBox="1"/>
-          <p:nvPr/>
-        </p:nvSpPr>
-        <p:spPr>
-          <a:xfrm>
-            <a:off x="4840834" y="4727448"/>
-            <a:ext cx="965606" cy="365760"/>
-          </a:xfrm>
-          <a:prstGeom prst="rect">
-            <a:avLst/>
-          </a:prstGeom>
-          <a:noFill/>
-          <a:ln/>
-        </p:spPr>
-        <p:txBody>
-          <a:bodyPr wrap="square" lIns="0" tIns="0" rIns="0" bIns="0" rtlCol="0" anchor="ctr"/>
-          <a:lstStyle/>
-          <a:p>
-            <a:pPr algn="r" indent="0" marL="0">
-              <a:buNone/>
-            </a:pPr>
-            <a:r>
-              <a:rPr lang="en-US" sz="850" dirty="0">
-                <a:solidFill>
-                  <a:srgbClr val="5B6B73"/>
-                </a:solidFill>
-                <a:latin typeface="Calibri" pitchFamily="34" charset="0"/>
-                <a:ea typeface="Calibri" pitchFamily="34" charset="-122"/>
-                <a:cs typeface="Calibri" pitchFamily="34" charset="-120"/>
-              </a:rPr>
-              <a:t>56 POB-dia</a:t>
-            </a:r>
-            <a:endParaRPr lang="en-US" sz="850" dirty="0"/>
-          </a:p>
-        </p:txBody>
-      </p:sp>
-      <p:sp>
-        <p:nvSpPr>
-          <p:cNvPr id="41" name="Text 39"/>
-          <p:cNvSpPr txBox="1"/>
-          <p:nvPr/>
-        </p:nvSpPr>
-        <p:spPr>
-          <a:xfrm>
-            <a:off x="566928" y="5093208"/>
-            <a:ext cx="2995574" cy="365760"/>
-          </a:xfrm>
-          <a:prstGeom prst="rect">
-            <a:avLst/>
-          </a:prstGeom>
-          <a:noFill/>
-          <a:ln/>
-        </p:spPr>
-        <p:txBody>
-          <a:bodyPr wrap="square" lIns="0" tIns="0" rIns="0" bIns="0" rtlCol="0" anchor="ctr"/>
-          <a:lstStyle/>
-          <a:p>
-            <a:pPr indent="0" marL="0">
-              <a:buNone/>
-            </a:pPr>
-            <a:r>
-              <a:rPr lang="en-US" sz="1100" dirty="0">
-                <a:solidFill>
-                  <a:srgbClr val="1C2B33"/>
-                </a:solidFill>
-                <a:latin typeface="Calibri" pitchFamily="34" charset="0"/>
-                <a:ea typeface="Calibri" pitchFamily="34" charset="-122"/>
-                <a:cs typeface="Calibri" pitchFamily="34" charset="-120"/>
-              </a:rPr>
-              <a:t>Segurança de Processos</a:t>
-            </a:r>
-            <a:endParaRPr lang="en-US" sz="1100" dirty="0"/>
-          </a:p>
-        </p:txBody>
-      </p:sp>
-      <p:sp>
-        <p:nvSpPr>
           <p:cNvPr id="42" name="Text 40"/>
           <p:cNvSpPr txBox="1"/>
           <p:nvPr/>
@@ -18808,7 +17792,7 @@
                 <a:ea typeface="Calibri" pitchFamily="34" charset="-122"/>
                 <a:cs typeface="Calibri" pitchFamily="34" charset="-120"/>
               </a:rPr>
-              <a:t>US$ 138,5 mil</a:t>
+              <a:t>US$ 40,0 mil</a:t>
             </a:r>
             <a:endParaRPr lang="en-US" sz="1100" dirty="0"/>
           </a:p>
@@ -18839,7 +17823,7 @@
               <a:buNone/>
             </a:pPr>
             <a:r>
-              <a:rPr lang="en-US" sz="850" dirty="0">
+              <a:rPr lang="en-US" sz="900" dirty="0">
                 <a:solidFill>
                   <a:srgbClr val="5B6B73"/>
                 </a:solidFill>
@@ -18847,9 +17831,9 @@
                 <a:ea typeface="Calibri" pitchFamily="34" charset="-122"/>
                 <a:cs typeface="Calibri" pitchFamily="34" charset="-120"/>
               </a:rPr>
-              <a:t>0 POB-dia</a:t>
+              <a:t>1 POB</a:t>
             </a:r>
-            <a:endParaRPr lang="en-US" sz="850" dirty="0"/>
+            <a:endParaRPr lang="en-US" sz="900" dirty="0"/>
           </a:p>
         </p:txBody>
       </p:sp>
@@ -18987,7 +17971,7 @@
                 <a:ea typeface="Calibri" pitchFamily="34" charset="-122"/>
                 <a:cs typeface="Calibri" pitchFamily="34" charset="-120"/>
               </a:rPr>
-              <a:t>US$ 9,2 mi</a:t>
+              <a:t>US$ 7,0 mi</a:t>
             </a:r>
             <a:endParaRPr lang="en-US" sz="1100" dirty="0"/>
           </a:p>
@@ -19018,7 +18002,7 @@
               <a:buNone/>
             </a:pPr>
             <a:r>
-              <a:rPr lang="en-US" sz="850" dirty="0">
+              <a:rPr lang="en-US" sz="900" dirty="0">
                 <a:solidFill>
                   <a:srgbClr val="5B6B73"/>
                 </a:solidFill>
@@ -19026,9 +18010,9 @@
                 <a:ea typeface="Calibri" pitchFamily="34" charset="-122"/>
                 <a:cs typeface="Calibri" pitchFamily="34" charset="-120"/>
               </a:rPr>
-              <a:t>3.447 POB-dia</a:t>
+              <a:t>175 POB</a:t>
             </a:r>
-            <a:endParaRPr lang="en-US" sz="850" dirty="0"/>
+            <a:endParaRPr lang="en-US" sz="900" dirty="0"/>
           </a:p>
         </p:txBody>
       </p:sp>
@@ -19155,7 +18139,7 @@
               <a:buNone/>
             </a:pPr>
             <a:r>
-              <a:rPr lang="en-US" sz="850" dirty="0">
+              <a:rPr lang="en-US" sz="900" dirty="0">
                 <a:solidFill>
                   <a:srgbClr val="5B6B73"/>
                 </a:solidFill>
@@ -19163,9 +18147,9 @@
                 <a:ea typeface="Calibri" pitchFamily="34" charset="-122"/>
                 <a:cs typeface="Calibri" pitchFamily="34" charset="-120"/>
               </a:rPr>
-              <a:t>988 POB-dia</a:t>
+              <a:t>38 POB</a:t>
             </a:r>
-            <a:endParaRPr lang="en-US" sz="850" dirty="0"/>
+            <a:endParaRPr lang="en-US" sz="900" dirty="0"/>
           </a:p>
         </p:txBody>
       </p:sp>
@@ -19272,7 +18256,7 @@
               <a:buNone/>
             </a:pPr>
             <a:r>
-              <a:rPr lang="en-US" sz="850" dirty="0">
+              <a:rPr lang="en-US" sz="900" dirty="0">
                 <a:solidFill>
                   <a:srgbClr val="5B6B73"/>
                 </a:solidFill>
@@ -19280,9 +18264,9 @@
                 <a:ea typeface="Calibri" pitchFamily="34" charset="-122"/>
                 <a:cs typeface="Calibri" pitchFamily="34" charset="-120"/>
               </a:rPr>
-              <a:t>674 POB-dia</a:t>
+              <a:t>32 POB</a:t>
             </a:r>
-            <a:endParaRPr lang="en-US" sz="850" dirty="0"/>
+            <a:endParaRPr lang="en-US" sz="900" dirty="0"/>
           </a:p>
         </p:txBody>
       </p:sp>
@@ -19409,7 +18393,7 @@
               <a:buNone/>
             </a:pPr>
             <a:r>
-              <a:rPr lang="en-US" sz="850" dirty="0">
+              <a:rPr lang="en-US" sz="900" dirty="0">
                 <a:solidFill>
                   <a:srgbClr val="5B6B73"/>
                 </a:solidFill>
@@ -19417,132 +18401,15 @@
                 <a:ea typeface="Calibri" pitchFamily="34" charset="-122"/>
                 <a:cs typeface="Calibri" pitchFamily="34" charset="-120"/>
               </a:rPr>
-              <a:t>392 POB-dia</a:t>
+              <a:t>23 POB</a:t>
             </a:r>
-            <a:endParaRPr lang="en-US" sz="850" dirty="0"/>
+            <a:endParaRPr lang="en-US" sz="900" dirty="0"/>
           </a:p>
         </p:txBody>
       </p:sp>
       <p:sp>
         <p:nvSpPr>
           <p:cNvPr id="60" name="Text 58"/>
-          <p:cNvSpPr txBox="1"/>
-          <p:nvPr/>
-        </p:nvSpPr>
-        <p:spPr>
-          <a:xfrm>
-            <a:off x="6464808" y="4361688"/>
-            <a:ext cx="2995574" cy="365760"/>
-          </a:xfrm>
-          <a:prstGeom prst="rect">
-            <a:avLst/>
-          </a:prstGeom>
-          <a:noFill/>
-          <a:ln/>
-        </p:spPr>
-        <p:txBody>
-          <a:bodyPr wrap="square" lIns="0" tIns="0" rIns="0" bIns="0" rtlCol="0" anchor="ctr"/>
-          <a:lstStyle/>
-          <a:p>
-            <a:pPr indent="0" marL="0">
-              <a:buNone/>
-            </a:pPr>
-            <a:r>
-              <a:rPr lang="en-US" sz="1100" dirty="0">
-                <a:solidFill>
-                  <a:srgbClr val="1C2B33"/>
-                </a:solidFill>
-                <a:latin typeface="Calibri" pitchFamily="34" charset="0"/>
-                <a:ea typeface="Calibri" pitchFamily="34" charset="-122"/>
-                <a:cs typeface="Calibri" pitchFamily="34" charset="-120"/>
-              </a:rPr>
-              <a:t>Desenvolvimento de Produção</a:t>
-            </a:r>
-            <a:endParaRPr lang="en-US" sz="1100" dirty="0"/>
-          </a:p>
-        </p:txBody>
-      </p:sp>
-      <p:sp>
-        <p:nvSpPr>
-          <p:cNvPr id="61" name="Text 59"/>
-          <p:cNvSpPr txBox="1"/>
-          <p:nvPr/>
-        </p:nvSpPr>
-        <p:spPr>
-          <a:xfrm>
-            <a:off x="9350654" y="4361688"/>
-            <a:ext cx="1497787" cy="365760"/>
-          </a:xfrm>
-          <a:prstGeom prst="rect">
-            <a:avLst/>
-          </a:prstGeom>
-          <a:noFill/>
-          <a:ln/>
-        </p:spPr>
-        <p:txBody>
-          <a:bodyPr wrap="square" lIns="0" tIns="0" rIns="0" bIns="0" rtlCol="0" anchor="ctr"/>
-          <a:lstStyle/>
-          <a:p>
-            <a:pPr algn="r" indent="0" marL="0">
-              <a:buNone/>
-            </a:pPr>
-            <a:r>
-              <a:rPr lang="en-US" sz="1100" b="1" dirty="0">
-                <a:solidFill>
-                  <a:srgbClr val="0B2A3D"/>
-                </a:solidFill>
-                <a:latin typeface="Calibri" pitchFamily="34" charset="0"/>
-                <a:ea typeface="Calibri" pitchFamily="34" charset="-122"/>
-                <a:cs typeface="Calibri" pitchFamily="34" charset="-120"/>
-              </a:rPr>
-              <a:t>US$ 90,5 mil</a:t>
-            </a:r>
-            <a:endParaRPr lang="en-US" sz="1100" dirty="0"/>
-          </a:p>
-        </p:txBody>
-      </p:sp>
-      <p:sp>
-        <p:nvSpPr>
-          <p:cNvPr id="62" name="Text 60"/>
-          <p:cNvSpPr txBox="1"/>
-          <p:nvPr/>
-        </p:nvSpPr>
-        <p:spPr>
-          <a:xfrm>
-            <a:off x="10738714" y="4361688"/>
-            <a:ext cx="965606" cy="365760"/>
-          </a:xfrm>
-          <a:prstGeom prst="rect">
-            <a:avLst/>
-          </a:prstGeom>
-          <a:noFill/>
-          <a:ln/>
-        </p:spPr>
-        <p:txBody>
-          <a:bodyPr wrap="square" lIns="0" tIns="0" rIns="0" bIns="0" rtlCol="0" anchor="ctr"/>
-          <a:lstStyle/>
-          <a:p>
-            <a:pPr algn="r" indent="0" marL="0">
-              <a:buNone/>
-            </a:pPr>
-            <a:r>
-              <a:rPr lang="en-US" sz="850" dirty="0">
-                <a:solidFill>
-                  <a:srgbClr val="5B6B73"/>
-                </a:solidFill>
-                <a:latin typeface="Calibri" pitchFamily="34" charset="0"/>
-                <a:ea typeface="Calibri" pitchFamily="34" charset="-122"/>
-                <a:cs typeface="Calibri" pitchFamily="34" charset="-120"/>
-              </a:rPr>
-              <a:t>43 POB-dia</a:t>
-            </a:r>
-            <a:endParaRPr lang="en-US" sz="850" dirty="0"/>
-          </a:p>
-        </p:txBody>
-      </p:sp>
-      <p:sp>
-        <p:nvSpPr>
-          <p:cNvPr id="63" name="Text 61"/>
           <p:cNvSpPr txBox="1"/>
           <p:nvPr/>
         </p:nvSpPr>
@@ -19573,7 +18440,7 @@
                 <a:ea typeface="Calibri" pitchFamily="34" charset="-122"/>
                 <a:cs typeface="Calibri" pitchFamily="34" charset="-120"/>
               </a:rPr>
-              <a:t>Metodologia: soma de Custo de Serviço + Custo de Material (Jan–Dez), para itens de Cost Allocation = CAPEX com status 'Contar' ou 'TA'. POB em POB-dia (pessoas a bordo × dias). O total desconsidera a categoria Desenvolvimento de Produção (US$ 90,5 mil, mantida na lista de Categoria apenas para referência).</a:t>
+              <a:t>Metodologia: soma de Custo de Serviço + Custo de Material (Jan–Dez), para itens de Cost Allocation = CAPEX com status 'Contar' ou 'TA'. O total desconsidera a categoria Desenvolvimento de Produção (sem itens para este ativo).</a:t>
             </a:r>
             <a:endParaRPr lang="en-US" sz="850" dirty="0"/>
           </a:p>
@@ -23512,7 +22379,7 @@
                 <a:ea typeface="Calibri" pitchFamily="34" charset="-122"/>
                 <a:cs typeface="Calibri" pitchFamily="34" charset="-120"/>
               </a:rPr>
-              <a:t>Fonte: Plano Integrado · aba 'Geral - Em análise' · coluna 'Valor Total' · itens de Cost Allocation = CAPEX, status 'Contar' + 'TA'. Lista completa disponível na planilha em anexo. Extrato pendente de atualização — pode não somar exatamente ao total da Composição de Custo e POB.</a:t>
+              <a:t>Fonte: Plano Integrado · aba 'Geral - Em análise' · itens de Cost Allocation = CAPEX, status 'Contar' + 'TA'. Lista completa disponível na planilha em anexo.</a:t>
             </a:r>
             <a:endParaRPr lang="en-US" sz="850" dirty="0"/>
           </a:p>
@@ -23999,7 +22866,7 @@
                 <a:ea typeface="Cambria" pitchFamily="34" charset="-122"/>
                 <a:cs typeface="Cambria" pitchFamily="34" charset="-120"/>
               </a:rPr>
-              <a:t>US$ 7,2 mi</a:t>
+              <a:t>US$ 5,9 mi</a:t>
             </a:r>
             <a:endParaRPr lang="en-US" sz="2100" dirty="0"/>
           </a:p>
@@ -24099,7 +22966,7 @@
                 <a:ea typeface="Cambria" pitchFamily="34" charset="-122"/>
                 <a:cs typeface="Cambria" pitchFamily="34" charset="-120"/>
               </a:rPr>
-              <a:t>US$ 8,0 mi</a:t>
+              <a:t>US$ 1,3 mi</a:t>
             </a:r>
             <a:endParaRPr lang="en-US" sz="2100" dirty="0"/>
           </a:p>
@@ -24199,7 +23066,7 @@
                 <a:ea typeface="Cambria" pitchFamily="34" charset="-122"/>
                 <a:cs typeface="Cambria" pitchFamily="34" charset="-120"/>
               </a:rPr>
-              <a:t>US$ 8,8 mi</a:t>
+              <a:t>US$ 7,2 mi</a:t>
             </a:r>
             <a:endParaRPr lang="en-US" sz="2100" dirty="0"/>
           </a:p>
@@ -24299,7 +23166,7 @@
                 <a:ea typeface="Cambria" pitchFamily="34" charset="-122"/>
                 <a:cs typeface="Cambria" pitchFamily="34" charset="-120"/>
               </a:rPr>
-              <a:t>5.092</a:t>
+              <a:t>182</a:t>
             </a:r>
             <a:endParaRPr lang="en-US" sz="2100" dirty="0"/>
           </a:p>
@@ -24338,7 +23205,7 @@
                 <a:ea typeface="Calibri" pitchFamily="34" charset="-122"/>
                 <a:cs typeface="Calibri" pitchFamily="34" charset="-120"/>
               </a:rPr>
-              <a:t>POB TOTAL (POB-DIA)</a:t>
+              <a:t>POB TOTAL</a:t>
             </a:r>
             <a:endParaRPr lang="en-US" sz="850" dirty="0"/>
           </a:p>
@@ -24439,143 +23306,6 @@
                 <a:ea typeface="Calibri" pitchFamily="34" charset="-122"/>
                 <a:cs typeface="Calibri" pitchFamily="34" charset="-120"/>
               </a:rPr>
-              <a:t>Projetos</a:t>
-            </a:r>
-            <a:endParaRPr lang="en-US" sz="1100" dirty="0"/>
-          </a:p>
-        </p:txBody>
-      </p:sp>
-      <p:sp>
-        <p:nvSpPr>
-          <p:cNvPr id="21" name="Text 19"/>
-          <p:cNvSpPr txBox="1"/>
-          <p:nvPr/>
-        </p:nvSpPr>
-        <p:spPr>
-          <a:xfrm>
-            <a:off x="3452774" y="2898648"/>
-            <a:ext cx="1497787" cy="365760"/>
-          </a:xfrm>
-          <a:prstGeom prst="rect">
-            <a:avLst/>
-          </a:prstGeom>
-          <a:noFill/>
-          <a:ln/>
-        </p:spPr>
-        <p:txBody>
-          <a:bodyPr wrap="square" lIns="0" tIns="0" rIns="0" bIns="0" rtlCol="0" anchor="ctr"/>
-          <a:lstStyle/>
-          <a:p>
-            <a:pPr algn="r" indent="0" marL="0">
-              <a:buNone/>
-            </a:pPr>
-            <a:r>
-              <a:rPr lang="en-US" sz="1100" b="1" dirty="0">
-                <a:solidFill>
-                  <a:srgbClr val="0B2A3D"/>
-                </a:solidFill>
-                <a:latin typeface="Calibri" pitchFamily="34" charset="0"/>
-                <a:ea typeface="Calibri" pitchFamily="34" charset="-122"/>
-                <a:cs typeface="Calibri" pitchFamily="34" charset="-120"/>
-              </a:rPr>
-              <a:t>US$ 8,3 mi</a:t>
-            </a:r>
-            <a:endParaRPr lang="en-US" sz="1100" dirty="0"/>
-          </a:p>
-        </p:txBody>
-      </p:sp>
-      <p:sp>
-        <p:nvSpPr>
-          <p:cNvPr id="22" name="Text 20"/>
-          <p:cNvSpPr txBox="1"/>
-          <p:nvPr/>
-        </p:nvSpPr>
-        <p:spPr>
-          <a:xfrm>
-            <a:off x="4840834" y="2898648"/>
-            <a:ext cx="965606" cy="365760"/>
-          </a:xfrm>
-          <a:prstGeom prst="rect">
-            <a:avLst/>
-          </a:prstGeom>
-          <a:noFill/>
-          <a:ln/>
-        </p:spPr>
-        <p:txBody>
-          <a:bodyPr wrap="square" lIns="0" tIns="0" rIns="0" bIns="0" rtlCol="0" anchor="ctr"/>
-          <a:lstStyle/>
-          <a:p>
-            <a:pPr algn="r" indent="0" marL="0">
-              <a:buNone/>
-            </a:pPr>
-            <a:r>
-              <a:rPr lang="en-US" sz="850" dirty="0">
-                <a:solidFill>
-                  <a:srgbClr val="5B6B73"/>
-                </a:solidFill>
-                <a:latin typeface="Calibri" pitchFamily="34" charset="0"/>
-                <a:ea typeface="Calibri" pitchFamily="34" charset="-122"/>
-                <a:cs typeface="Calibri" pitchFamily="34" charset="-120"/>
-              </a:rPr>
-              <a:t>1.932 POB-dia</a:t>
-            </a:r>
-            <a:endParaRPr lang="en-US" sz="850" dirty="0"/>
-          </a:p>
-        </p:txBody>
-      </p:sp>
-      <p:sp>
-        <p:nvSpPr>
-          <p:cNvPr id="23" name="Shape 21"/>
-          <p:cNvSpPr/>
-          <p:nvPr/>
-        </p:nvSpPr>
-        <p:spPr>
-          <a:xfrm>
-            <a:off x="457200" y="3264408"/>
-            <a:ext cx="5349240" cy="365760"/>
-          </a:xfrm>
-          <a:prstGeom prst="rect">
-            <a:avLst/>
-          </a:prstGeom>
-          <a:solidFill>
-            <a:srgbClr val="F0F4F5"/>
-          </a:solidFill>
-          <a:ln/>
-        </p:spPr>
-      </p:sp>
-      <p:sp>
-        <p:nvSpPr>
-          <p:cNvPr id="24" name="Text 22"/>
-          <p:cNvSpPr txBox="1"/>
-          <p:nvPr/>
-        </p:nvSpPr>
-        <p:spPr>
-          <a:xfrm>
-            <a:off x="566928" y="3264408"/>
-            <a:ext cx="2995574" cy="365760"/>
-          </a:xfrm>
-          <a:prstGeom prst="rect">
-            <a:avLst/>
-          </a:prstGeom>
-          <a:noFill/>
-          <a:ln/>
-        </p:spPr>
-        <p:txBody>
-          <a:bodyPr wrap="square" lIns="0" tIns="0" rIns="0" bIns="0" rtlCol="0" anchor="ctr"/>
-          <a:lstStyle/>
-          <a:p>
-            <a:pPr indent="0" marL="0">
-              <a:buNone/>
-            </a:pPr>
-            <a:r>
-              <a:rPr lang="en-US" sz="1100" dirty="0">
-                <a:solidFill>
-                  <a:srgbClr val="1C2B33"/>
-                </a:solidFill>
-                <a:latin typeface="Calibri" pitchFamily="34" charset="0"/>
-                <a:ea typeface="Calibri" pitchFamily="34" charset="-122"/>
-                <a:cs typeface="Calibri" pitchFamily="34" charset="-120"/>
-              </a:rPr>
               <a:t>MNT – Manutenção</a:t>
             </a:r>
             <a:endParaRPr lang="en-US" sz="1100" dirty="0"/>
@@ -24584,13 +23314,13 @@
       </p:sp>
       <p:sp>
         <p:nvSpPr>
-          <p:cNvPr id="25" name="Text 23"/>
+          <p:cNvPr id="21" name="Text 19"/>
           <p:cNvSpPr txBox="1"/>
           <p:nvPr/>
         </p:nvSpPr>
         <p:spPr>
           <a:xfrm>
-            <a:off x="3452774" y="3264408"/>
+            <a:off x="3452774" y="2898648"/>
             <a:ext cx="1497787" cy="365760"/>
           </a:xfrm>
           <a:prstGeom prst="rect">
@@ -24623,6 +23353,143 @@
       </p:sp>
       <p:sp>
         <p:nvSpPr>
+          <p:cNvPr id="22" name="Text 20"/>
+          <p:cNvSpPr txBox="1"/>
+          <p:nvPr/>
+        </p:nvSpPr>
+        <p:spPr>
+          <a:xfrm>
+            <a:off x="4840834" y="2898648"/>
+            <a:ext cx="965606" cy="365760"/>
+          </a:xfrm>
+          <a:prstGeom prst="rect">
+            <a:avLst/>
+          </a:prstGeom>
+          <a:noFill/>
+          <a:ln/>
+        </p:spPr>
+        <p:txBody>
+          <a:bodyPr wrap="square" lIns="0" tIns="0" rIns="0" bIns="0" rtlCol="0" anchor="ctr"/>
+          <a:lstStyle/>
+          <a:p>
+            <a:pPr algn="r" indent="0" marL="0">
+              <a:buNone/>
+            </a:pPr>
+            <a:r>
+              <a:rPr lang="en-US" sz="900" dirty="0">
+                <a:solidFill>
+                  <a:srgbClr val="5B6B73"/>
+                </a:solidFill>
+                <a:latin typeface="Calibri" pitchFamily="34" charset="0"/>
+                <a:ea typeface="Calibri" pitchFamily="34" charset="-122"/>
+                <a:cs typeface="Calibri" pitchFamily="34" charset="-120"/>
+              </a:rPr>
+              <a:t>20 POB</a:t>
+            </a:r>
+            <a:endParaRPr lang="en-US" sz="900" dirty="0"/>
+          </a:p>
+        </p:txBody>
+      </p:sp>
+      <p:sp>
+        <p:nvSpPr>
+          <p:cNvPr id="23" name="Shape 21"/>
+          <p:cNvSpPr/>
+          <p:nvPr/>
+        </p:nvSpPr>
+        <p:spPr>
+          <a:xfrm>
+            <a:off x="457200" y="3264408"/>
+            <a:ext cx="5349240" cy="365760"/>
+          </a:xfrm>
+          <a:prstGeom prst="rect">
+            <a:avLst/>
+          </a:prstGeom>
+          <a:solidFill>
+            <a:srgbClr val="F0F4F5"/>
+          </a:solidFill>
+          <a:ln/>
+        </p:spPr>
+      </p:sp>
+      <p:sp>
+        <p:nvSpPr>
+          <p:cNvPr id="24" name="Text 22"/>
+          <p:cNvSpPr txBox="1"/>
+          <p:nvPr/>
+        </p:nvSpPr>
+        <p:spPr>
+          <a:xfrm>
+            <a:off x="566928" y="3264408"/>
+            <a:ext cx="2995574" cy="365760"/>
+          </a:xfrm>
+          <a:prstGeom prst="rect">
+            <a:avLst/>
+          </a:prstGeom>
+          <a:noFill/>
+          <a:ln/>
+        </p:spPr>
+        <p:txBody>
+          <a:bodyPr wrap="square" lIns="0" tIns="0" rIns="0" bIns="0" rtlCol="0" anchor="ctr"/>
+          <a:lstStyle/>
+          <a:p>
+            <a:pPr indent="0" marL="0">
+              <a:buNone/>
+            </a:pPr>
+            <a:r>
+              <a:rPr lang="en-US" sz="1100" dirty="0">
+                <a:solidFill>
+                  <a:srgbClr val="1C2B33"/>
+                </a:solidFill>
+                <a:latin typeface="Calibri" pitchFamily="34" charset="0"/>
+                <a:ea typeface="Calibri" pitchFamily="34" charset="-122"/>
+                <a:cs typeface="Calibri" pitchFamily="34" charset="-120"/>
+              </a:rPr>
+              <a:t>Projetos</a:t>
+            </a:r>
+            <a:endParaRPr lang="en-US" sz="1100" dirty="0"/>
+          </a:p>
+        </p:txBody>
+      </p:sp>
+      <p:sp>
+        <p:nvSpPr>
+          <p:cNvPr id="25" name="Text 23"/>
+          <p:cNvSpPr txBox="1"/>
+          <p:nvPr/>
+        </p:nvSpPr>
+        <p:spPr>
+          <a:xfrm>
+            <a:off x="3452774" y="3264408"/>
+            <a:ext cx="1497787" cy="365760"/>
+          </a:xfrm>
+          <a:prstGeom prst="rect">
+            <a:avLst/>
+          </a:prstGeom>
+          <a:noFill/>
+          <a:ln/>
+        </p:spPr>
+        <p:txBody>
+          <a:bodyPr wrap="square" lIns="0" tIns="0" rIns="0" bIns="0" rtlCol="0" anchor="ctr"/>
+          <a:lstStyle/>
+          <a:p>
+            <a:pPr algn="r" indent="0" marL="0">
+              <a:buNone/>
+            </a:pPr>
+            <a:r>
+              <a:rPr lang="en-US" sz="1100" b="1" dirty="0">
+                <a:solidFill>
+                  <a:srgbClr val="0B2A3D"/>
+                </a:solidFill>
+                <a:latin typeface="Calibri" pitchFamily="34" charset="0"/>
+                <a:ea typeface="Calibri" pitchFamily="34" charset="-122"/>
+                <a:cs typeface="Calibri" pitchFamily="34" charset="-120"/>
+              </a:rPr>
+              <a:t>US$ 2,2 mi</a:t>
+            </a:r>
+            <a:endParaRPr lang="en-US" sz="1100" dirty="0"/>
+          </a:p>
+        </p:txBody>
+      </p:sp>
+      <p:sp>
+        <p:nvSpPr>
           <p:cNvPr id="26" name="Text 24"/>
           <p:cNvSpPr txBox="1"/>
           <p:nvPr/>
@@ -24646,7 +23513,7 @@
               <a:buNone/>
             </a:pPr>
             <a:r>
-              <a:rPr lang="en-US" sz="850" dirty="0">
+              <a:rPr lang="en-US" sz="900" dirty="0">
                 <a:solidFill>
                   <a:srgbClr val="5B6B73"/>
                 </a:solidFill>
@@ -24654,9 +23521,9 @@
                 <a:ea typeface="Calibri" pitchFamily="34" charset="-122"/>
                 <a:cs typeface="Calibri" pitchFamily="34" charset="-120"/>
               </a:rPr>
-              <a:t>700 POB-dia</a:t>
+              <a:t>54 POB</a:t>
             </a:r>
-            <a:endParaRPr lang="en-US" sz="850" dirty="0"/>
+            <a:endParaRPr lang="en-US" sz="900" dirty="0"/>
           </a:p>
         </p:txBody>
       </p:sp>
@@ -24732,7 +23599,7 @@
                 <a:ea typeface="Calibri" pitchFamily="34" charset="-122"/>
                 <a:cs typeface="Calibri" pitchFamily="34" charset="-120"/>
               </a:rPr>
-              <a:t>US$ 2,5 mi</a:t>
+              <a:t>US$ 897,7 mil</a:t>
             </a:r>
             <a:endParaRPr lang="en-US" sz="1100" dirty="0"/>
           </a:p>
@@ -24763,7 +23630,7 @@
               <a:buNone/>
             </a:pPr>
             <a:r>
-              <a:rPr lang="en-US" sz="850" dirty="0">
+              <a:rPr lang="en-US" sz="900" dirty="0">
                 <a:solidFill>
                   <a:srgbClr val="5B6B73"/>
                 </a:solidFill>
@@ -24771,9 +23638,9 @@
                 <a:ea typeface="Calibri" pitchFamily="34" charset="-122"/>
                 <a:cs typeface="Calibri" pitchFamily="34" charset="-120"/>
               </a:rPr>
-              <a:t>2.280 POB-dia</a:t>
+              <a:t>101 POB</a:t>
             </a:r>
-            <a:endParaRPr lang="en-US" sz="850" dirty="0"/>
+            <a:endParaRPr lang="en-US" sz="900" dirty="0"/>
           </a:p>
         </p:txBody>
       </p:sp>
@@ -24900,7 +23767,7 @@
               <a:buNone/>
             </a:pPr>
             <a:r>
-              <a:rPr lang="en-US" sz="850" dirty="0">
+              <a:rPr lang="en-US" sz="900" dirty="0">
                 <a:solidFill>
                   <a:srgbClr val="5B6B73"/>
                 </a:solidFill>
@@ -24908,9 +23775,9 @@
                 <a:ea typeface="Calibri" pitchFamily="34" charset="-122"/>
                 <a:cs typeface="Calibri" pitchFamily="34" charset="-120"/>
               </a:rPr>
-              <a:t>150 POB-dia</a:t>
+              <a:t>5 POB</a:t>
             </a:r>
-            <a:endParaRPr lang="en-US" sz="850" dirty="0"/>
+            <a:endParaRPr lang="en-US" sz="900" dirty="0"/>
           </a:p>
         </p:txBody>
       </p:sp>
@@ -24923,143 +23790,6 @@
         <p:spPr>
           <a:xfrm>
             <a:off x="566928" y="4361688"/>
-            <a:ext cx="2995574" cy="365760"/>
-          </a:xfrm>
-          <a:prstGeom prst="rect">
-            <a:avLst/>
-          </a:prstGeom>
-          <a:noFill/>
-          <a:ln/>
-        </p:spPr>
-        <p:txBody>
-          <a:bodyPr wrap="square" lIns="0" tIns="0" rIns="0" bIns="0" rtlCol="0" anchor="ctr"/>
-          <a:lstStyle/>
-          <a:p>
-            <a:pPr indent="0" marL="0">
-              <a:buNone/>
-            </a:pPr>
-            <a:r>
-              <a:rPr lang="en-US" sz="1100" dirty="0">
-                <a:solidFill>
-                  <a:srgbClr val="1C2B33"/>
-                </a:solidFill>
-                <a:latin typeface="Calibri" pitchFamily="34" charset="0"/>
-                <a:ea typeface="Calibri" pitchFamily="34" charset="-122"/>
-                <a:cs typeface="Calibri" pitchFamily="34" charset="-120"/>
-              </a:rPr>
-              <a:t>P&amp;Q - Processos</a:t>
-            </a:r>
-            <a:endParaRPr lang="en-US" sz="1100" dirty="0"/>
-          </a:p>
-        </p:txBody>
-      </p:sp>
-      <p:sp>
-        <p:nvSpPr>
-          <p:cNvPr id="35" name="Text 33"/>
-          <p:cNvSpPr txBox="1"/>
-          <p:nvPr/>
-        </p:nvSpPr>
-        <p:spPr>
-          <a:xfrm>
-            <a:off x="3452774" y="4361688"/>
-            <a:ext cx="1497787" cy="365760"/>
-          </a:xfrm>
-          <a:prstGeom prst="rect">
-            <a:avLst/>
-          </a:prstGeom>
-          <a:noFill/>
-          <a:ln/>
-        </p:spPr>
-        <p:txBody>
-          <a:bodyPr wrap="square" lIns="0" tIns="0" rIns="0" bIns="0" rtlCol="0" anchor="ctr"/>
-          <a:lstStyle/>
-          <a:p>
-            <a:pPr algn="r" indent="0" marL="0">
-              <a:buNone/>
-            </a:pPr>
-            <a:r>
-              <a:rPr lang="en-US" sz="1100" b="1" dirty="0">
-                <a:solidFill>
-                  <a:srgbClr val="0B2A3D"/>
-                </a:solidFill>
-                <a:latin typeface="Calibri" pitchFamily="34" charset="0"/>
-                <a:ea typeface="Calibri" pitchFamily="34" charset="-122"/>
-                <a:cs typeface="Calibri" pitchFamily="34" charset="-120"/>
-              </a:rPr>
-              <a:t>US$ 150,5 mil</a:t>
-            </a:r>
-            <a:endParaRPr lang="en-US" sz="1100" dirty="0"/>
-          </a:p>
-        </p:txBody>
-      </p:sp>
-      <p:sp>
-        <p:nvSpPr>
-          <p:cNvPr id="36" name="Text 34"/>
-          <p:cNvSpPr txBox="1"/>
-          <p:nvPr/>
-        </p:nvSpPr>
-        <p:spPr>
-          <a:xfrm>
-            <a:off x="4840834" y="4361688"/>
-            <a:ext cx="965606" cy="365760"/>
-          </a:xfrm>
-          <a:prstGeom prst="rect">
-            <a:avLst/>
-          </a:prstGeom>
-          <a:noFill/>
-          <a:ln/>
-        </p:spPr>
-        <p:txBody>
-          <a:bodyPr wrap="square" lIns="0" tIns="0" rIns="0" bIns="0" rtlCol="0" anchor="ctr"/>
-          <a:lstStyle/>
-          <a:p>
-            <a:pPr algn="r" indent="0" marL="0">
-              <a:buNone/>
-            </a:pPr>
-            <a:r>
-              <a:rPr lang="en-US" sz="850" dirty="0">
-                <a:solidFill>
-                  <a:srgbClr val="5B6B73"/>
-                </a:solidFill>
-                <a:latin typeface="Calibri" pitchFamily="34" charset="0"/>
-                <a:ea typeface="Calibri" pitchFamily="34" charset="-122"/>
-                <a:cs typeface="Calibri" pitchFamily="34" charset="-120"/>
-              </a:rPr>
-              <a:t>14 POB-dia</a:t>
-            </a:r>
-            <a:endParaRPr lang="en-US" sz="850" dirty="0"/>
-          </a:p>
-        </p:txBody>
-      </p:sp>
-      <p:sp>
-        <p:nvSpPr>
-          <p:cNvPr id="37" name="Shape 35"/>
-          <p:cNvSpPr/>
-          <p:nvPr/>
-        </p:nvSpPr>
-        <p:spPr>
-          <a:xfrm>
-            <a:off x="457200" y="4727448"/>
-            <a:ext cx="5349240" cy="365760"/>
-          </a:xfrm>
-          <a:prstGeom prst="rect">
-            <a:avLst/>
-          </a:prstGeom>
-          <a:solidFill>
-            <a:srgbClr val="F0F4F5"/>
-          </a:solidFill>
-          <a:ln/>
-        </p:spPr>
-      </p:sp>
-      <p:sp>
-        <p:nvSpPr>
-          <p:cNvPr id="38" name="Text 36"/>
-          <p:cNvSpPr txBox="1"/>
-          <p:nvPr/>
-        </p:nvSpPr>
-        <p:spPr>
-          <a:xfrm>
-            <a:off x="566928" y="4727448"/>
             <a:ext cx="2995574" cy="365760"/>
           </a:xfrm>
           <a:prstGeom prst="rect">
@@ -25092,13 +23822,13 @@
       </p:sp>
       <p:sp>
         <p:nvSpPr>
-          <p:cNvPr id="39" name="Text 37"/>
+          <p:cNvPr id="35" name="Text 33"/>
           <p:cNvSpPr txBox="1"/>
           <p:nvPr/>
         </p:nvSpPr>
         <p:spPr>
           <a:xfrm>
-            <a:off x="3452774" y="4727448"/>
+            <a:off x="3452774" y="4361688"/>
             <a:ext cx="1497787" cy="365760"/>
           </a:xfrm>
           <a:prstGeom prst="rect">
@@ -25123,7 +23853,7 @@
                 <a:ea typeface="Calibri" pitchFamily="34" charset="-122"/>
                 <a:cs typeface="Calibri" pitchFamily="34" charset="-120"/>
               </a:rPr>
-              <a:t>US$ 40,0 mil</a:t>
+              <a:t>US$ 30,0 mil</a:t>
             </a:r>
             <a:endParaRPr lang="en-US" sz="1100" dirty="0"/>
           </a:p>
@@ -25131,13 +23861,13 @@
       </p:sp>
       <p:sp>
         <p:nvSpPr>
-          <p:cNvPr id="40" name="Text 38"/>
+          <p:cNvPr id="36" name="Text 34"/>
           <p:cNvSpPr txBox="1"/>
           <p:nvPr/>
         </p:nvSpPr>
         <p:spPr>
           <a:xfrm>
-            <a:off x="4840834" y="4727448"/>
+            <a:off x="4840834" y="4361688"/>
             <a:ext cx="965606" cy="365760"/>
           </a:xfrm>
           <a:prstGeom prst="rect">
@@ -25154,7 +23884,7 @@
               <a:buNone/>
             </a:pPr>
             <a:r>
-              <a:rPr lang="en-US" sz="850" dirty="0">
+              <a:rPr lang="en-US" sz="900" dirty="0">
                 <a:solidFill>
                   <a:srgbClr val="5B6B73"/>
                 </a:solidFill>
@@ -25162,21 +23892,41 @@
                 <a:ea typeface="Calibri" pitchFamily="34" charset="-122"/>
                 <a:cs typeface="Calibri" pitchFamily="34" charset="-120"/>
               </a:rPr>
-              <a:t>16 POB-dia</a:t>
+              <a:t>2 POB</a:t>
             </a:r>
-            <a:endParaRPr lang="en-US" sz="850" dirty="0"/>
+            <a:endParaRPr lang="en-US" sz="900" dirty="0"/>
           </a:p>
         </p:txBody>
       </p:sp>
       <p:sp>
         <p:nvSpPr>
-          <p:cNvPr id="41" name="Text 39"/>
+          <p:cNvPr id="37" name="Shape 35"/>
+          <p:cNvSpPr/>
+          <p:nvPr/>
+        </p:nvSpPr>
+        <p:spPr>
+          <a:xfrm>
+            <a:off x="457200" y="4727448"/>
+            <a:ext cx="5349240" cy="365760"/>
+          </a:xfrm>
+          <a:prstGeom prst="rect">
+            <a:avLst/>
+          </a:prstGeom>
+          <a:solidFill>
+            <a:srgbClr val="F0F4F5"/>
+          </a:solidFill>
+          <a:ln/>
+        </p:spPr>
+      </p:sp>
+      <p:sp>
+        <p:nvSpPr>
+          <p:cNvPr id="38" name="Text 36"/>
           <p:cNvSpPr txBox="1"/>
           <p:nvPr/>
         </p:nvSpPr>
         <p:spPr>
           <a:xfrm>
-            <a:off x="566928" y="5093208"/>
+            <a:off x="566928" y="4727448"/>
             <a:ext cx="2995574" cy="365760"/>
           </a:xfrm>
           <a:prstGeom prst="rect">
@@ -25209,13 +23959,13 @@
       </p:sp>
       <p:sp>
         <p:nvSpPr>
-          <p:cNvPr id="42" name="Text 40"/>
+          <p:cNvPr id="39" name="Text 37"/>
           <p:cNvSpPr txBox="1"/>
           <p:nvPr/>
         </p:nvSpPr>
         <p:spPr>
           <a:xfrm>
-            <a:off x="3452774" y="5093208"/>
+            <a:off x="3452774" y="4727448"/>
             <a:ext cx="1497787" cy="365760"/>
           </a:xfrm>
           <a:prstGeom prst="rect">
@@ -25248,13 +23998,13 @@
       </p:sp>
       <p:sp>
         <p:nvSpPr>
-          <p:cNvPr id="43" name="Text 41"/>
+          <p:cNvPr id="40" name="Text 38"/>
           <p:cNvSpPr txBox="1"/>
           <p:nvPr/>
         </p:nvSpPr>
         <p:spPr>
           <a:xfrm>
-            <a:off x="4840834" y="5093208"/>
+            <a:off x="4840834" y="4727448"/>
             <a:ext cx="965606" cy="365760"/>
           </a:xfrm>
           <a:prstGeom prst="rect">
@@ -25271,7 +24021,7 @@
               <a:buNone/>
             </a:pPr>
             <a:r>
-              <a:rPr lang="en-US" sz="850" dirty="0">
+              <a:rPr lang="en-US" sz="900" dirty="0">
                 <a:solidFill>
                   <a:srgbClr val="5B6B73"/>
                 </a:solidFill>
@@ -25279,15 +24029,15 @@
                 <a:ea typeface="Calibri" pitchFamily="34" charset="-122"/>
                 <a:cs typeface="Calibri" pitchFamily="34" charset="-120"/>
               </a:rPr>
-              <a:t>0 POB-dia</a:t>
+              <a:t>0 POB</a:t>
             </a:r>
-            <a:endParaRPr lang="en-US" sz="850" dirty="0"/>
+            <a:endParaRPr lang="en-US" sz="900" dirty="0"/>
           </a:p>
         </p:txBody>
       </p:sp>
       <p:sp>
         <p:nvSpPr>
-          <p:cNvPr id="44" name="Text 42"/>
+          <p:cNvPr id="41" name="Text 39"/>
           <p:cNvSpPr txBox="1"/>
           <p:nvPr/>
         </p:nvSpPr>
@@ -25326,7 +24076,7 @@
       </p:sp>
       <p:sp>
         <p:nvSpPr>
-          <p:cNvPr id="45" name="Shape 43"/>
+          <p:cNvPr id="42" name="Shape 40"/>
           <p:cNvSpPr/>
           <p:nvPr/>
         </p:nvSpPr>
@@ -25349,7 +24099,7 @@
       </p:sp>
       <p:sp>
         <p:nvSpPr>
-          <p:cNvPr id="46" name="Text 44"/>
+          <p:cNvPr id="43" name="Text 41"/>
           <p:cNvSpPr txBox="1"/>
           <p:nvPr/>
         </p:nvSpPr>
@@ -25380,7 +24130,7 @@
                 <a:ea typeface="Calibri" pitchFamily="34" charset="-122"/>
                 <a:cs typeface="Calibri" pitchFamily="34" charset="-120"/>
               </a:rPr>
-              <a:t>Desenvolvimento de Produção</a:t>
+              <a:t>Integridade e Regulatório</a:t>
             </a:r>
             <a:endParaRPr lang="en-US" sz="1100" dirty="0"/>
           </a:p>
@@ -25388,7 +24138,7 @@
       </p:sp>
       <p:sp>
         <p:nvSpPr>
-          <p:cNvPr id="47" name="Text 45"/>
+          <p:cNvPr id="44" name="Text 42"/>
           <p:cNvSpPr txBox="1"/>
           <p:nvPr/>
         </p:nvSpPr>
@@ -25419,7 +24169,7 @@
                 <a:ea typeface="Calibri" pitchFamily="34" charset="-122"/>
                 <a:cs typeface="Calibri" pitchFamily="34" charset="-120"/>
               </a:rPr>
-              <a:t>US$ 6,3 mi</a:t>
+              <a:t>US$ 3,5 mi</a:t>
             </a:r>
             <a:endParaRPr lang="en-US" sz="1100" dirty="0"/>
           </a:p>
@@ -25427,7 +24177,7 @@
       </p:sp>
       <p:sp>
         <p:nvSpPr>
-          <p:cNvPr id="48" name="Text 46"/>
+          <p:cNvPr id="45" name="Text 43"/>
           <p:cNvSpPr txBox="1"/>
           <p:nvPr/>
         </p:nvSpPr>
@@ -25450,7 +24200,7 @@
               <a:buNone/>
             </a:pPr>
             <a:r>
-              <a:rPr lang="en-US" sz="850" dirty="0">
+              <a:rPr lang="en-US" sz="900" dirty="0">
                 <a:solidFill>
                   <a:srgbClr val="5B6B73"/>
                 </a:solidFill>
@@ -25458,15 +24208,15 @@
                 <a:ea typeface="Calibri" pitchFamily="34" charset="-122"/>
                 <a:cs typeface="Calibri" pitchFamily="34" charset="-120"/>
               </a:rPr>
-              <a:t>990 POB-dia</a:t>
+              <a:t>20 POB</a:t>
             </a:r>
-            <a:endParaRPr lang="en-US" sz="850" dirty="0"/>
+            <a:endParaRPr lang="en-US" sz="900" dirty="0"/>
           </a:p>
         </p:txBody>
       </p:sp>
       <p:sp>
         <p:nvSpPr>
-          <p:cNvPr id="49" name="Shape 47"/>
+          <p:cNvPr id="46" name="Shape 44"/>
           <p:cNvSpPr/>
           <p:nvPr/>
         </p:nvSpPr>
@@ -25486,7 +24236,7 @@
       </p:sp>
       <p:sp>
         <p:nvSpPr>
-          <p:cNvPr id="50" name="Text 48"/>
+          <p:cNvPr id="47" name="Text 45"/>
           <p:cNvSpPr txBox="1"/>
           <p:nvPr/>
         </p:nvSpPr>
@@ -25525,7 +24275,7 @@
       </p:sp>
       <p:sp>
         <p:nvSpPr>
-          <p:cNvPr id="51" name="Text 49"/>
+          <p:cNvPr id="48" name="Text 46"/>
           <p:cNvSpPr txBox="1"/>
           <p:nvPr/>
         </p:nvSpPr>
@@ -25556,7 +24306,7 @@
                 <a:ea typeface="Calibri" pitchFamily="34" charset="-122"/>
                 <a:cs typeface="Calibri" pitchFamily="34" charset="-120"/>
               </a:rPr>
-              <a:t>US$ 3,7 mi</a:t>
+              <a:t>US$ 2,1 mi</a:t>
             </a:r>
             <a:endParaRPr lang="en-US" sz="1100" dirty="0"/>
           </a:p>
@@ -25564,7 +24314,7 @@
       </p:sp>
       <p:sp>
         <p:nvSpPr>
-          <p:cNvPr id="52" name="Text 50"/>
+          <p:cNvPr id="49" name="Text 47"/>
           <p:cNvSpPr txBox="1"/>
           <p:nvPr/>
         </p:nvSpPr>
@@ -25587,7 +24337,7 @@
               <a:buNone/>
             </a:pPr>
             <a:r>
-              <a:rPr lang="en-US" sz="850" dirty="0">
+              <a:rPr lang="en-US" sz="900" dirty="0">
                 <a:solidFill>
                   <a:srgbClr val="5B6B73"/>
                 </a:solidFill>
@@ -25595,158 +24345,21 @@
                 <a:ea typeface="Calibri" pitchFamily="34" charset="-122"/>
                 <a:cs typeface="Calibri" pitchFamily="34" charset="-120"/>
               </a:rPr>
-              <a:t>2.860 POB-dia</a:t>
+              <a:t>132 POB</a:t>
             </a:r>
-            <a:endParaRPr lang="en-US" sz="850" dirty="0"/>
+            <a:endParaRPr lang="en-US" sz="900" dirty="0"/>
           </a:p>
         </p:txBody>
       </p:sp>
       <p:sp>
         <p:nvSpPr>
-          <p:cNvPr id="53" name="Text 51"/>
+          <p:cNvPr id="50" name="Text 48"/>
           <p:cNvSpPr txBox="1"/>
           <p:nvPr/>
         </p:nvSpPr>
         <p:spPr>
           <a:xfrm>
             <a:off x="6464808" y="3630168"/>
-            <a:ext cx="2995574" cy="365760"/>
-          </a:xfrm>
-          <a:prstGeom prst="rect">
-            <a:avLst/>
-          </a:prstGeom>
-          <a:noFill/>
-          <a:ln/>
-        </p:spPr>
-        <p:txBody>
-          <a:bodyPr wrap="square" lIns="0" tIns="0" rIns="0" bIns="0" rtlCol="0" anchor="ctr"/>
-          <a:lstStyle/>
-          <a:p>
-            <a:pPr indent="0" marL="0">
-              <a:buNone/>
-            </a:pPr>
-            <a:r>
-              <a:rPr lang="en-US" sz="1100" dirty="0">
-                <a:solidFill>
-                  <a:srgbClr val="1C2B33"/>
-                </a:solidFill>
-                <a:latin typeface="Calibri" pitchFamily="34" charset="0"/>
-                <a:ea typeface="Calibri" pitchFamily="34" charset="-122"/>
-                <a:cs typeface="Calibri" pitchFamily="34" charset="-120"/>
-              </a:rPr>
-              <a:t>Integridade e Regulatório</a:t>
-            </a:r>
-            <a:endParaRPr lang="en-US" sz="1100" dirty="0"/>
-          </a:p>
-        </p:txBody>
-      </p:sp>
-      <p:sp>
-        <p:nvSpPr>
-          <p:cNvPr id="54" name="Text 52"/>
-          <p:cNvSpPr txBox="1"/>
-          <p:nvPr/>
-        </p:nvSpPr>
-        <p:spPr>
-          <a:xfrm>
-            <a:off x="9350654" y="3630168"/>
-            <a:ext cx="1497787" cy="365760"/>
-          </a:xfrm>
-          <a:prstGeom prst="rect">
-            <a:avLst/>
-          </a:prstGeom>
-          <a:noFill/>
-          <a:ln/>
-        </p:spPr>
-        <p:txBody>
-          <a:bodyPr wrap="square" lIns="0" tIns="0" rIns="0" bIns="0" rtlCol="0" anchor="ctr"/>
-          <a:lstStyle/>
-          <a:p>
-            <a:pPr algn="r" indent="0" marL="0">
-              <a:buNone/>
-            </a:pPr>
-            <a:r>
-              <a:rPr lang="en-US" sz="1100" b="1" dirty="0">
-                <a:solidFill>
-                  <a:srgbClr val="0B2A3D"/>
-                </a:solidFill>
-                <a:latin typeface="Calibri" pitchFamily="34" charset="0"/>
-                <a:ea typeface="Calibri" pitchFamily="34" charset="-122"/>
-                <a:cs typeface="Calibri" pitchFamily="34" charset="-120"/>
-              </a:rPr>
-              <a:t>US$ 3,5 mi</a:t>
-            </a:r>
-            <a:endParaRPr lang="en-US" sz="1100" dirty="0"/>
-          </a:p>
-        </p:txBody>
-      </p:sp>
-      <p:sp>
-        <p:nvSpPr>
-          <p:cNvPr id="55" name="Text 53"/>
-          <p:cNvSpPr txBox="1"/>
-          <p:nvPr/>
-        </p:nvSpPr>
-        <p:spPr>
-          <a:xfrm>
-            <a:off x="10738714" y="3630168"/>
-            <a:ext cx="965606" cy="365760"/>
-          </a:xfrm>
-          <a:prstGeom prst="rect">
-            <a:avLst/>
-          </a:prstGeom>
-          <a:noFill/>
-          <a:ln/>
-        </p:spPr>
-        <p:txBody>
-          <a:bodyPr wrap="square" lIns="0" tIns="0" rIns="0" bIns="0" rtlCol="0" anchor="ctr"/>
-          <a:lstStyle/>
-          <a:p>
-            <a:pPr algn="r" indent="0" marL="0">
-              <a:buNone/>
-            </a:pPr>
-            <a:r>
-              <a:rPr lang="en-US" sz="850" dirty="0">
-                <a:solidFill>
-                  <a:srgbClr val="5B6B73"/>
-                </a:solidFill>
-                <a:latin typeface="Calibri" pitchFamily="34" charset="0"/>
-                <a:ea typeface="Calibri" pitchFamily="34" charset="-122"/>
-                <a:cs typeface="Calibri" pitchFamily="34" charset="-120"/>
-              </a:rPr>
-              <a:t>700 POB-dia</a:t>
-            </a:r>
-            <a:endParaRPr lang="en-US" sz="850" dirty="0"/>
-          </a:p>
-        </p:txBody>
-      </p:sp>
-      <p:sp>
-        <p:nvSpPr>
-          <p:cNvPr id="56" name="Shape 54"/>
-          <p:cNvSpPr/>
-          <p:nvPr/>
-        </p:nvSpPr>
-        <p:spPr>
-          <a:xfrm>
-            <a:off x="6355080" y="3995928"/>
-            <a:ext cx="5349240" cy="365760"/>
-          </a:xfrm>
-          <a:prstGeom prst="rect">
-            <a:avLst/>
-          </a:prstGeom>
-          <a:solidFill>
-            <a:srgbClr val="F0F4F5"/>
-          </a:solidFill>
-          <a:ln/>
-        </p:spPr>
-      </p:sp>
-      <p:sp>
-        <p:nvSpPr>
-          <p:cNvPr id="57" name="Text 55"/>
-          <p:cNvSpPr txBox="1"/>
-          <p:nvPr/>
-        </p:nvSpPr>
-        <p:spPr>
-          <a:xfrm>
-            <a:off x="6464808" y="3995928"/>
             <a:ext cx="2995574" cy="365760"/>
           </a:xfrm>
           <a:prstGeom prst="rect">
@@ -25779,13 +24392,13 @@
       </p:sp>
       <p:sp>
         <p:nvSpPr>
-          <p:cNvPr id="58" name="Text 56"/>
+          <p:cNvPr id="51" name="Text 49"/>
           <p:cNvSpPr txBox="1"/>
           <p:nvPr/>
         </p:nvSpPr>
         <p:spPr>
           <a:xfrm>
-            <a:off x="9350654" y="3995928"/>
+            <a:off x="9350654" y="3630168"/>
             <a:ext cx="1497787" cy="365760"/>
           </a:xfrm>
           <a:prstGeom prst="rect">
@@ -25818,13 +24431,13 @@
       </p:sp>
       <p:sp>
         <p:nvSpPr>
-          <p:cNvPr id="59" name="Text 57"/>
+          <p:cNvPr id="52" name="Text 50"/>
           <p:cNvSpPr txBox="1"/>
           <p:nvPr/>
         </p:nvSpPr>
         <p:spPr>
           <a:xfrm>
-            <a:off x="10738714" y="3995928"/>
+            <a:off x="10738714" y="3630168"/>
             <a:ext cx="965606" cy="365760"/>
           </a:xfrm>
           <a:prstGeom prst="rect">
@@ -25841,7 +24454,7 @@
               <a:buNone/>
             </a:pPr>
             <a:r>
-              <a:rPr lang="en-US" sz="850" dirty="0">
+              <a:rPr lang="en-US" sz="900" dirty="0">
                 <a:solidFill>
                   <a:srgbClr val="5B6B73"/>
                 </a:solidFill>
@@ -25849,21 +24462,41 @@
                 <a:ea typeface="Calibri" pitchFamily="34" charset="-122"/>
                 <a:cs typeface="Calibri" pitchFamily="34" charset="-120"/>
               </a:rPr>
-              <a:t>116 POB-dia</a:t>
+              <a:t>12 POB</a:t>
             </a:r>
-            <a:endParaRPr lang="en-US" sz="850" dirty="0"/>
+            <a:endParaRPr lang="en-US" sz="900" dirty="0"/>
           </a:p>
         </p:txBody>
       </p:sp>
       <p:sp>
         <p:nvSpPr>
-          <p:cNvPr id="60" name="Text 58"/>
+          <p:cNvPr id="53" name="Shape 51"/>
+          <p:cNvSpPr/>
+          <p:nvPr/>
+        </p:nvSpPr>
+        <p:spPr>
+          <a:xfrm>
+            <a:off x="6355080" y="3995928"/>
+            <a:ext cx="5349240" cy="365760"/>
+          </a:xfrm>
+          <a:prstGeom prst="rect">
+            <a:avLst/>
+          </a:prstGeom>
+          <a:solidFill>
+            <a:srgbClr val="F0F4F5"/>
+          </a:solidFill>
+          <a:ln/>
+        </p:spPr>
+      </p:sp>
+      <p:sp>
+        <p:nvSpPr>
+          <p:cNvPr id="54" name="Text 52"/>
           <p:cNvSpPr txBox="1"/>
           <p:nvPr/>
         </p:nvSpPr>
         <p:spPr>
           <a:xfrm>
-            <a:off x="6464808" y="4361688"/>
+            <a:off x="6464808" y="3995928"/>
             <a:ext cx="2995574" cy="365760"/>
           </a:xfrm>
           <a:prstGeom prst="rect">
@@ -25896,13 +24529,13 @@
       </p:sp>
       <p:sp>
         <p:nvSpPr>
-          <p:cNvPr id="61" name="Text 59"/>
+          <p:cNvPr id="55" name="Text 53"/>
           <p:cNvSpPr txBox="1"/>
           <p:nvPr/>
         </p:nvSpPr>
         <p:spPr>
           <a:xfrm>
-            <a:off x="9350654" y="4361688"/>
+            <a:off x="9350654" y="3995928"/>
             <a:ext cx="1497787" cy="365760"/>
           </a:xfrm>
           <a:prstGeom prst="rect">
@@ -25927,7 +24560,7 @@
                 <a:ea typeface="Calibri" pitchFamily="34" charset="-122"/>
                 <a:cs typeface="Calibri" pitchFamily="34" charset="-120"/>
               </a:rPr>
-              <a:t>US$ 475,5 mil</a:t>
+              <a:t>US$ 465,5 mil</a:t>
             </a:r>
             <a:endParaRPr lang="en-US" sz="1100" dirty="0"/>
           </a:p>
@@ -25935,13 +24568,13 @@
       </p:sp>
       <p:sp>
         <p:nvSpPr>
-          <p:cNvPr id="62" name="Text 60"/>
+          <p:cNvPr id="56" name="Text 54"/>
           <p:cNvSpPr txBox="1"/>
           <p:nvPr/>
         </p:nvSpPr>
         <p:spPr>
           <a:xfrm>
-            <a:off x="10738714" y="4361688"/>
+            <a:off x="10738714" y="3995928"/>
             <a:ext cx="965606" cy="365760"/>
           </a:xfrm>
           <a:prstGeom prst="rect">
@@ -25958,7 +24591,7 @@
               <a:buNone/>
             </a:pPr>
             <a:r>
-              <a:rPr lang="en-US" sz="850" dirty="0">
+              <a:rPr lang="en-US" sz="900" dirty="0">
                 <a:solidFill>
                   <a:srgbClr val="5B6B73"/>
                 </a:solidFill>
@@ -25966,15 +24599,15 @@
                 <a:ea typeface="Calibri" pitchFamily="34" charset="-122"/>
                 <a:cs typeface="Calibri" pitchFamily="34" charset="-120"/>
               </a:rPr>
-              <a:t>426 POB-dia</a:t>
+              <a:t>18 POB</a:t>
             </a:r>
-            <a:endParaRPr lang="en-US" sz="850" dirty="0"/>
+            <a:endParaRPr lang="en-US" sz="900" dirty="0"/>
           </a:p>
         </p:txBody>
       </p:sp>
       <p:sp>
         <p:nvSpPr>
-          <p:cNvPr id="63" name="Text 61"/>
+          <p:cNvPr id="57" name="Text 55"/>
           <p:cNvSpPr txBox="1"/>
           <p:nvPr/>
         </p:nvSpPr>
@@ -26005,7 +24638,7 @@
                 <a:ea typeface="Calibri" pitchFamily="34" charset="-122"/>
                 <a:cs typeface="Calibri" pitchFamily="34" charset="-120"/>
               </a:rPr>
-              <a:t>Metodologia: soma de Custo de Serviço + Custo de Material (Jan–Dez), para itens de Cost Allocation = CAPEX com status 'Contar' ou 'TA'. POB em POB-dia (pessoas a bordo × dias). O total desconsidera a categoria Desenvolvimento de Produção (US$ 6,3 mi, mantida na lista de Categoria apenas para referência).</a:t>
+              <a:t>Metodologia: soma de Custo de Serviço + Custo de Material (Jan–Dez), para itens de Cost Allocation = CAPEX com status 'Contar' ou 'TA'. O total desconsidera a categoria Desenvolvimento de Produção (sem itens para este ativo).</a:t>
             </a:r>
             <a:endParaRPr lang="en-US" sz="850" dirty="0"/>
           </a:p>
@@ -29944,7 +28577,7 @@
                 <a:ea typeface="Calibri" pitchFamily="34" charset="-122"/>
                 <a:cs typeface="Calibri" pitchFamily="34" charset="-120"/>
               </a:rPr>
-              <a:t>Fonte: Plano Integrado · aba 'Geral - Em análise' · coluna 'Valor Total' · itens de Cost Allocation = CAPEX, status 'Contar' + 'TA'. Lista completa disponível na planilha em anexo. Extrato pendente de atualização — pode não somar exatamente ao total da Composição de Custo e POB.</a:t>
+              <a:t>Fonte: Plano Integrado · aba 'Geral - Em análise' · itens de Cost Allocation = CAPEX, status 'Contar' + 'TA'. Lista completa disponível na planilha em anexo.</a:t>
             </a:r>
             <a:endParaRPr lang="en-US" sz="850" dirty="0"/>
           </a:p>

</xml_diff>

<commit_message>
Remove POB Total from Executive Overview slide
Último lugar onde POB ainda aparecia no deck: KPI 'POB TOTAL' e coluna
'POB' da tabela por ativo na Visão Executiva. Removidos; a Visão
Executiva fica com 3 KPIs (CAPEX Total, Escopos de CAPEX, Atividades
no Plano) e a tabela com 3 colunas (Ativo, CAPEX, Escopos).

Co-Authored-By: Claude Sonnet 5 <noreply@anthropic.com>
Claude-Session: https://claude.ai/code/session_01QXLKdFvqaqrRbUKxEFJW9L
</commit_message>
<xml_diff>
--- a/PRIO_Plano_Trabalho_CAPEX_2027.pptx
+++ b/PRIO_Plano_Trabalho_CAPEX_2027.pptx
@@ -10362,7 +10362,7 @@
         <p:spPr>
           <a:xfrm>
             <a:off x="457200" y="1417320"/>
-            <a:ext cx="2615184" cy="1234440"/>
+            <a:ext cx="3627120" cy="1234440"/>
           </a:xfrm>
           <a:prstGeom prst="roundRect">
             <a:avLst>
@@ -10384,7 +10384,7 @@
         <p:spPr>
           <a:xfrm>
             <a:off x="621792" y="1563624"/>
-            <a:ext cx="2286000" cy="548640"/>
+            <a:ext cx="3297936" cy="548640"/>
           </a:xfrm>
           <a:prstGeom prst="rect">
             <a:avLst/>
@@ -10423,7 +10423,7 @@
         <p:spPr>
           <a:xfrm>
             <a:off x="621792" y="2093976"/>
-            <a:ext cx="2286000" cy="228600"/>
+            <a:ext cx="3297936" cy="228600"/>
           </a:xfrm>
           <a:prstGeom prst="rect">
             <a:avLst/>
@@ -10462,7 +10462,7 @@
         <p:spPr>
           <a:xfrm>
             <a:off x="621792" y="2313432"/>
-            <a:ext cx="2286000" cy="274320"/>
+            <a:ext cx="3297936" cy="274320"/>
           </a:xfrm>
           <a:prstGeom prst="rect">
             <a:avLst/>
@@ -10486,7 +10486,7 @@
                 <a:ea typeface="Calibri" pitchFamily="34" charset="-122"/>
                 <a:cs typeface="Calibri" pitchFamily="34" charset="-120"/>
               </a:rPr>
-              <a:t>excl. Desenvolvimento de Produção</a:t>
+              <a:t>excl. Desenvolvimento de Produção e TA</a:t>
             </a:r>
             <a:endParaRPr lang="en-US" sz="850" dirty="0"/>
           </a:p>
@@ -10500,8 +10500,8 @@
         </p:nvSpPr>
         <p:spPr>
           <a:xfrm>
-            <a:off x="3255264" y="1417320"/>
-            <a:ext cx="2615184" cy="1234440"/>
+            <a:off x="4267200" y="1417320"/>
+            <a:ext cx="3627120" cy="1234440"/>
           </a:xfrm>
           <a:prstGeom prst="roundRect">
             <a:avLst>
@@ -10522,147 +10522,8 @@
         </p:nvSpPr>
         <p:spPr>
           <a:xfrm>
-            <a:off x="3419856" y="1563624"/>
-            <a:ext cx="2286000" cy="548640"/>
-          </a:xfrm>
-          <a:prstGeom prst="rect">
-            <a:avLst/>
-          </a:prstGeom>
-          <a:noFill/>
-          <a:ln/>
-        </p:spPr>
-        <p:txBody>
-          <a:bodyPr wrap="square" lIns="0" tIns="0" rIns="0" bIns="0" rtlCol="0" anchor="ctr"/>
-          <a:lstStyle/>
-          <a:p>
-            <a:pPr indent="0" marL="0">
-              <a:buNone/>
-            </a:pPr>
-            <a:r>
-              <a:rPr lang="en-US" sz="2600" b="1" dirty="0">
-                <a:solidFill>
-                  <a:srgbClr val="0B2A3D"/>
-                </a:solidFill>
-                <a:latin typeface="Cambria" pitchFamily="34" charset="0"/>
-                <a:ea typeface="Cambria" pitchFamily="34" charset="-122"/>
-                <a:cs typeface="Cambria" pitchFamily="34" charset="-120"/>
-              </a:rPr>
-              <a:t>318</a:t>
-            </a:r>
-            <a:endParaRPr lang="en-US" sz="2600" dirty="0"/>
-          </a:p>
-        </p:txBody>
-      </p:sp>
-      <p:sp>
-        <p:nvSpPr>
-          <p:cNvPr id="10" name="Text 8"/>
-          <p:cNvSpPr txBox="1"/>
-          <p:nvPr/>
-        </p:nvSpPr>
-        <p:spPr>
-          <a:xfrm>
-            <a:off x="3419856" y="2093976"/>
-            <a:ext cx="2286000" cy="228600"/>
-          </a:xfrm>
-          <a:prstGeom prst="rect">
-            <a:avLst/>
-          </a:prstGeom>
-          <a:noFill/>
-          <a:ln/>
-        </p:spPr>
-        <p:txBody>
-          <a:bodyPr wrap="square" lIns="0" tIns="0" rIns="0" bIns="0" rtlCol="0" anchor="ctr"/>
-          <a:lstStyle/>
-          <a:p>
-            <a:pPr indent="0" marL="0">
-              <a:buNone/>
-            </a:pPr>
-            <a:r>
-              <a:rPr lang="en-US" sz="950" b="1" spc="100" kern="0" dirty="0">
-                <a:solidFill>
-                  <a:srgbClr val="145C68"/>
-                </a:solidFill>
-                <a:latin typeface="Calibri" pitchFamily="34" charset="0"/>
-                <a:ea typeface="Calibri" pitchFamily="34" charset="-122"/>
-                <a:cs typeface="Calibri" pitchFamily="34" charset="-120"/>
-              </a:rPr>
-              <a:t>POB TOTAL</a:t>
-            </a:r>
-            <a:endParaRPr lang="en-US" sz="950" dirty="0"/>
-          </a:p>
-        </p:txBody>
-      </p:sp>
-      <p:sp>
-        <p:nvSpPr>
-          <p:cNvPr id="11" name="Text 9"/>
-          <p:cNvSpPr txBox="1"/>
-          <p:nvPr/>
-        </p:nvSpPr>
-        <p:spPr>
-          <a:xfrm>
-            <a:off x="3419856" y="2313432"/>
-            <a:ext cx="2286000" cy="274320"/>
-          </a:xfrm>
-          <a:prstGeom prst="rect">
-            <a:avLst/>
-          </a:prstGeom>
-          <a:noFill/>
-          <a:ln/>
-        </p:spPr>
-        <p:txBody>
-          <a:bodyPr wrap="square" lIns="0" tIns="0" rIns="0" bIns="0" rtlCol="0" anchor="ctr"/>
-          <a:lstStyle/>
-          <a:p>
-            <a:pPr indent="0" marL="0">
-              <a:buNone/>
-            </a:pPr>
-            <a:r>
-              <a:rPr lang="en-US" sz="850" dirty="0">
-                <a:solidFill>
-                  <a:srgbClr val="5B6B73"/>
-                </a:solidFill>
-                <a:latin typeface="Calibri" pitchFamily="34" charset="0"/>
-                <a:ea typeface="Calibri" pitchFamily="34" charset="-122"/>
-                <a:cs typeface="Calibri" pitchFamily="34" charset="-120"/>
-              </a:rPr>
-              <a:t>pessoas a bordo alocadas</a:t>
-            </a:r>
-            <a:endParaRPr lang="en-US" sz="850" dirty="0"/>
-          </a:p>
-        </p:txBody>
-      </p:sp>
-      <p:sp>
-        <p:nvSpPr>
-          <p:cNvPr id="12" name="Shape 10"/>
-          <p:cNvSpPr/>
-          <p:nvPr/>
-        </p:nvSpPr>
-        <p:spPr>
-          <a:xfrm>
-            <a:off x="6053328" y="1417320"/>
-            <a:ext cx="2615184" cy="1234440"/>
-          </a:xfrm>
-          <a:prstGeom prst="roundRect">
-            <a:avLst>
-              <a:gd name="adj" fmla="val 5926"/>
-            </a:avLst>
-          </a:prstGeom>
-          <a:solidFill>
-            <a:srgbClr val="F0F4F5"/>
-          </a:solidFill>
-          <a:ln/>
-        </p:spPr>
-      </p:sp>
-      <p:sp>
-        <p:nvSpPr>
-          <p:cNvPr id="13" name="Text 11"/>
-          <p:cNvSpPr txBox="1"/>
-          <p:nvPr/>
-        </p:nvSpPr>
-        <p:spPr>
-          <a:xfrm>
-            <a:off x="6217920" y="1563624"/>
-            <a:ext cx="2286000" cy="548640"/>
+            <a:off x="4431792" y="1563624"/>
+            <a:ext cx="3297936" cy="548640"/>
           </a:xfrm>
           <a:prstGeom prst="rect">
             <a:avLst/>
@@ -10694,14 +10555,14 @@
       </p:sp>
       <p:sp>
         <p:nvSpPr>
-          <p:cNvPr id="14" name="Text 12"/>
+          <p:cNvPr id="10" name="Text 8"/>
           <p:cNvSpPr txBox="1"/>
           <p:nvPr/>
         </p:nvSpPr>
         <p:spPr>
           <a:xfrm>
-            <a:off x="6217920" y="2093976"/>
-            <a:ext cx="2286000" cy="228600"/>
+            <a:off x="4431792" y="2093976"/>
+            <a:ext cx="3297936" cy="228600"/>
           </a:xfrm>
           <a:prstGeom prst="rect">
             <a:avLst/>
@@ -10733,14 +10594,14 @@
       </p:sp>
       <p:sp>
         <p:nvSpPr>
-          <p:cNvPr id="15" name="Text 13"/>
+          <p:cNvPr id="11" name="Text 9"/>
           <p:cNvSpPr txBox="1"/>
           <p:nvPr/>
         </p:nvSpPr>
         <p:spPr>
           <a:xfrm>
-            <a:off x="6217920" y="2313432"/>
-            <a:ext cx="2286000" cy="274320"/>
+            <a:off x="4431792" y="2313432"/>
+            <a:ext cx="3297936" cy="274320"/>
           </a:xfrm>
           <a:prstGeom prst="rect">
             <a:avLst/>
@@ -10772,14 +10633,14 @@
       </p:sp>
       <p:sp>
         <p:nvSpPr>
-          <p:cNvPr id="16" name="Shape 14"/>
+          <p:cNvPr id="12" name="Shape 10"/>
           <p:cNvSpPr/>
           <p:nvPr/>
         </p:nvSpPr>
         <p:spPr>
           <a:xfrm>
-            <a:off x="8851392" y="1417320"/>
-            <a:ext cx="2615184" cy="1234440"/>
+            <a:off x="8077200" y="1417320"/>
+            <a:ext cx="3627120" cy="1234440"/>
           </a:xfrm>
           <a:prstGeom prst="roundRect">
             <a:avLst>
@@ -10794,14 +10655,14 @@
       </p:sp>
       <p:sp>
         <p:nvSpPr>
-          <p:cNvPr id="17" name="Text 15"/>
+          <p:cNvPr id="13" name="Text 11"/>
           <p:cNvSpPr txBox="1"/>
           <p:nvPr/>
         </p:nvSpPr>
         <p:spPr>
           <a:xfrm>
-            <a:off x="9015984" y="1563624"/>
-            <a:ext cx="2286000" cy="548640"/>
+            <a:off x="8241792" y="1563624"/>
+            <a:ext cx="3297936" cy="548640"/>
           </a:xfrm>
           <a:prstGeom prst="rect">
             <a:avLst/>
@@ -10833,14 +10694,14 @@
       </p:sp>
       <p:sp>
         <p:nvSpPr>
-          <p:cNvPr id="18" name="Text 16"/>
+          <p:cNvPr id="14" name="Text 12"/>
           <p:cNvSpPr txBox="1"/>
           <p:nvPr/>
         </p:nvSpPr>
         <p:spPr>
           <a:xfrm>
-            <a:off x="9015984" y="2093976"/>
-            <a:ext cx="2286000" cy="228600"/>
+            <a:off x="8241792" y="2093976"/>
+            <a:ext cx="3297936" cy="228600"/>
           </a:xfrm>
           <a:prstGeom prst="rect">
             <a:avLst/>
@@ -10872,14 +10733,14 @@
       </p:sp>
       <p:sp>
         <p:nvSpPr>
-          <p:cNvPr id="19" name="Text 17"/>
+          <p:cNvPr id="15" name="Text 13"/>
           <p:cNvSpPr txBox="1"/>
           <p:nvPr/>
         </p:nvSpPr>
         <p:spPr>
           <a:xfrm>
-            <a:off x="9015984" y="2313432"/>
-            <a:ext cx="2286000" cy="274320"/>
+            <a:off x="8241792" y="2313432"/>
+            <a:ext cx="3297936" cy="274320"/>
           </a:xfrm>
           <a:prstGeom prst="rect">
             <a:avLst/>
@@ -10911,7 +10772,7 @@
       </p:sp>
       <p:sp>
         <p:nvSpPr>
-          <p:cNvPr id="20" name="Text 18"/>
+          <p:cNvPr id="16" name="Text 14"/>
           <p:cNvSpPr txBox="1"/>
           <p:nvPr/>
         </p:nvSpPr>
@@ -10950,7 +10811,7 @@
       </p:sp>
       <p:graphicFrame>
         <p:nvGraphicFramePr>
-          <p:cNvPr id="21" name="Chart 0" descr=""/>
+          <p:cNvPr id="17" name="Chart 0" descr=""/>
           <p:cNvGraphicFramePr/>
           <p:nvPr/>
         </p:nvGraphicFramePr>
@@ -10987,10 +10848,9 @@
             <a:tbl>
               <a:tblPr/>
               <a:tblGrid>
-                <a:gridCol w="1797912"/>
+                <a:gridCol w="2220950"/>
+                <a:gridCol w="1692152"/>
                 <a:gridCol w="1374874"/>
-                <a:gridCol w="1057595"/>
-                <a:gridCol w="1057595"/>
               </a:tblGrid>
               <a:tr h="329184">
                 <a:tc>
@@ -11069,67 +10929,6 @@
                           </a:solidFill>
                         </a:rPr>
                         <a:t>CAPEX</a:t>
-                      </a:r>
-                      <a:endParaRPr lang="en-US" sz="1000" dirty="0"/>
-                    </a:p>
-                  </a:txBody>
-                  <a:tcPr marL="91440" marR="91440" marT="45720" marB="45720" anchor="ctr">
-                    <a:lnL w="6350" cap="flat" cmpd="sng" algn="ctr">
-                      <a:solidFill>
-                        <a:srgbClr val="E3E8E9"/>
-                      </a:solidFill>
-                      <a:prstDash val="solid"/>
-                      <a:round/>
-                      <a:headEnd type="none" w="med" len="med"/>
-                      <a:tailEnd type="none" w="med" len="med"/>
-                    </a:lnL>
-                    <a:lnR w="6350" cap="flat" cmpd="sng" algn="ctr">
-                      <a:solidFill>
-                        <a:srgbClr val="E3E8E9"/>
-                      </a:solidFill>
-                      <a:prstDash val="solid"/>
-                      <a:round/>
-                      <a:headEnd type="none" w="med" len="med"/>
-                      <a:tailEnd type="none" w="med" len="med"/>
-                    </a:lnR>
-                    <a:lnT w="6350" cap="flat" cmpd="sng" algn="ctr">
-                      <a:solidFill>
-                        <a:srgbClr val="E3E8E9"/>
-                      </a:solidFill>
-                      <a:prstDash val="solid"/>
-                      <a:round/>
-                      <a:headEnd type="none" w="med" len="med"/>
-                      <a:tailEnd type="none" w="med" len="med"/>
-                    </a:lnT>
-                    <a:lnB w="6350" cap="flat" cmpd="sng" algn="ctr">
-                      <a:solidFill>
-                        <a:srgbClr val="E3E8E9"/>
-                      </a:solidFill>
-                      <a:prstDash val="solid"/>
-                      <a:round/>
-                      <a:headEnd type="none" w="med" len="med"/>
-                      <a:tailEnd type="none" w="med" len="med"/>
-                    </a:lnB>
-                    <a:solidFill>
-                      <a:srgbClr val="0B2A3D"/>
-                    </a:solidFill>
-                  </a:tcPr>
-                </a:tc>
-                <a:tc>
-                  <a:txBody>
-                    <a:bodyPr/>
-                    <a:lstStyle/>
-                    <a:p>
-                      <a:pPr algn="r" indent="0" marL="0">
-                        <a:buNone/>
-                      </a:pPr>
-                      <a:r>
-                        <a:rPr lang="en-US" sz="1000" b="1" dirty="0">
-                          <a:solidFill>
-                            <a:srgbClr val="FFFFFF"/>
-                          </a:solidFill>
-                        </a:rPr>
-                        <a:t>POB</a:t>
                       </a:r>
                       <a:endParaRPr lang="en-US" sz="1000" dirty="0"/>
                     </a:p>
@@ -11375,67 +11174,6 @@
                             <a:srgbClr val="1C2B33"/>
                           </a:solidFill>
                         </a:rPr>
-                        <a:t>141</a:t>
-                      </a:r>
-                      <a:endParaRPr lang="en-US" sz="1050" dirty="0"/>
-                    </a:p>
-                  </a:txBody>
-                  <a:tcPr marL="91440" marR="91440" marT="45720" marB="45720" anchor="ctr">
-                    <a:lnL w="6350" cap="flat" cmpd="sng" algn="ctr">
-                      <a:solidFill>
-                        <a:srgbClr val="E3E8E9"/>
-                      </a:solidFill>
-                      <a:prstDash val="solid"/>
-                      <a:round/>
-                      <a:headEnd type="none" w="med" len="med"/>
-                      <a:tailEnd type="none" w="med" len="med"/>
-                    </a:lnL>
-                    <a:lnR w="6350" cap="flat" cmpd="sng" algn="ctr">
-                      <a:solidFill>
-                        <a:srgbClr val="E3E8E9"/>
-                      </a:solidFill>
-                      <a:prstDash val="solid"/>
-                      <a:round/>
-                      <a:headEnd type="none" w="med" len="med"/>
-                      <a:tailEnd type="none" w="med" len="med"/>
-                    </a:lnR>
-                    <a:lnT w="6350" cap="flat" cmpd="sng" algn="ctr">
-                      <a:solidFill>
-                        <a:srgbClr val="E3E8E9"/>
-                      </a:solidFill>
-                      <a:prstDash val="solid"/>
-                      <a:round/>
-                      <a:headEnd type="none" w="med" len="med"/>
-                      <a:tailEnd type="none" w="med" len="med"/>
-                    </a:lnT>
-                    <a:lnB w="6350" cap="flat" cmpd="sng" algn="ctr">
-                      <a:solidFill>
-                        <a:srgbClr val="E3E8E9"/>
-                      </a:solidFill>
-                      <a:prstDash val="solid"/>
-                      <a:round/>
-                      <a:headEnd type="none" w="med" len="med"/>
-                      <a:tailEnd type="none" w="med" len="med"/>
-                    </a:lnB>
-                    <a:solidFill>
-                      <a:srgbClr val="FFFFFF"/>
-                    </a:solidFill>
-                  </a:tcPr>
-                </a:tc>
-                <a:tc>
-                  <a:txBody>
-                    <a:bodyPr/>
-                    <a:lstStyle/>
-                    <a:p>
-                      <a:pPr algn="r" indent="0" marL="0">
-                        <a:buNone/>
-                      </a:pPr>
-                      <a:r>
-                        <a:rPr lang="en-US" sz="1050" dirty="0">
-                          <a:solidFill>
-                            <a:srgbClr val="1C2B33"/>
-                          </a:solidFill>
-                        </a:rPr>
                         <a:t>23</a:t>
                       </a:r>
                       <a:endParaRPr lang="en-US" sz="1050" dirty="0"/>
@@ -11621,67 +11359,6 @@
                             <a:srgbClr val="1C2B33"/>
                           </a:solidFill>
                         </a:rPr>
-                        <a:t>81</a:t>
-                      </a:r>
-                      <a:endParaRPr lang="en-US" sz="1050" dirty="0"/>
-                    </a:p>
-                  </a:txBody>
-                  <a:tcPr marL="91440" marR="91440" marT="45720" marB="45720" anchor="ctr">
-                    <a:lnL w="6350" cap="flat" cmpd="sng" algn="ctr">
-                      <a:solidFill>
-                        <a:srgbClr val="E3E8E9"/>
-                      </a:solidFill>
-                      <a:prstDash val="solid"/>
-                      <a:round/>
-                      <a:headEnd type="none" w="med" len="med"/>
-                      <a:tailEnd type="none" w="med" len="med"/>
-                    </a:lnL>
-                    <a:lnR w="6350" cap="flat" cmpd="sng" algn="ctr">
-                      <a:solidFill>
-                        <a:srgbClr val="E3E8E9"/>
-                      </a:solidFill>
-                      <a:prstDash val="solid"/>
-                      <a:round/>
-                      <a:headEnd type="none" w="med" len="med"/>
-                      <a:tailEnd type="none" w="med" len="med"/>
-                    </a:lnR>
-                    <a:lnT w="6350" cap="flat" cmpd="sng" algn="ctr">
-                      <a:solidFill>
-                        <a:srgbClr val="E3E8E9"/>
-                      </a:solidFill>
-                      <a:prstDash val="solid"/>
-                      <a:round/>
-                      <a:headEnd type="none" w="med" len="med"/>
-                      <a:tailEnd type="none" w="med" len="med"/>
-                    </a:lnT>
-                    <a:lnB w="6350" cap="flat" cmpd="sng" algn="ctr">
-                      <a:solidFill>
-                        <a:srgbClr val="E3E8E9"/>
-                      </a:solidFill>
-                      <a:prstDash val="solid"/>
-                      <a:round/>
-                      <a:headEnd type="none" w="med" len="med"/>
-                      <a:tailEnd type="none" w="med" len="med"/>
-                    </a:lnB>
-                    <a:solidFill>
-                      <a:srgbClr val="F0F4F5"/>
-                    </a:solidFill>
-                  </a:tcPr>
-                </a:tc>
-                <a:tc>
-                  <a:txBody>
-                    <a:bodyPr/>
-                    <a:lstStyle/>
-                    <a:p>
-                      <a:pPr algn="r" indent="0" marL="0">
-                        <a:buNone/>
-                      </a:pPr>
-                      <a:r>
-                        <a:rPr lang="en-US" sz="1050" dirty="0">
-                          <a:solidFill>
-                            <a:srgbClr val="1C2B33"/>
-                          </a:solidFill>
-                        </a:rPr>
                         <a:t>10</a:t>
                       </a:r>
                       <a:endParaRPr lang="en-US" sz="1050" dirty="0"/>
@@ -11867,67 +11544,6 @@
                             <a:srgbClr val="1C2B33"/>
                           </a:solidFill>
                         </a:rPr>
-                        <a:t>51</a:t>
-                      </a:r>
-                      <a:endParaRPr lang="en-US" sz="1050" dirty="0"/>
-                    </a:p>
-                  </a:txBody>
-                  <a:tcPr marL="91440" marR="91440" marT="45720" marB="45720" anchor="ctr">
-                    <a:lnL w="6350" cap="flat" cmpd="sng" algn="ctr">
-                      <a:solidFill>
-                        <a:srgbClr val="E3E8E9"/>
-                      </a:solidFill>
-                      <a:prstDash val="solid"/>
-                      <a:round/>
-                      <a:headEnd type="none" w="med" len="med"/>
-                      <a:tailEnd type="none" w="med" len="med"/>
-                    </a:lnL>
-                    <a:lnR w="6350" cap="flat" cmpd="sng" algn="ctr">
-                      <a:solidFill>
-                        <a:srgbClr val="E3E8E9"/>
-                      </a:solidFill>
-                      <a:prstDash val="solid"/>
-                      <a:round/>
-                      <a:headEnd type="none" w="med" len="med"/>
-                      <a:tailEnd type="none" w="med" len="med"/>
-                    </a:lnR>
-                    <a:lnT w="6350" cap="flat" cmpd="sng" algn="ctr">
-                      <a:solidFill>
-                        <a:srgbClr val="E3E8E9"/>
-                      </a:solidFill>
-                      <a:prstDash val="solid"/>
-                      <a:round/>
-                      <a:headEnd type="none" w="med" len="med"/>
-                      <a:tailEnd type="none" w="med" len="med"/>
-                    </a:lnT>
-                    <a:lnB w="6350" cap="flat" cmpd="sng" algn="ctr">
-                      <a:solidFill>
-                        <a:srgbClr val="E3E8E9"/>
-                      </a:solidFill>
-                      <a:prstDash val="solid"/>
-                      <a:round/>
-                      <a:headEnd type="none" w="med" len="med"/>
-                      <a:tailEnd type="none" w="med" len="med"/>
-                    </a:lnB>
-                    <a:solidFill>
-                      <a:srgbClr val="FFFFFF"/>
-                    </a:solidFill>
-                  </a:tcPr>
-                </a:tc>
-                <a:tc>
-                  <a:txBody>
-                    <a:bodyPr/>
-                    <a:lstStyle/>
-                    <a:p>
-                      <a:pPr algn="r" indent="0" marL="0">
-                        <a:buNone/>
-                      </a:pPr>
-                      <a:r>
-                        <a:rPr lang="en-US" sz="1050" dirty="0">
-                          <a:solidFill>
-                            <a:srgbClr val="1C2B33"/>
-                          </a:solidFill>
-                        </a:rPr>
                         <a:t>7</a:t>
                       </a:r>
                       <a:endParaRPr lang="en-US" sz="1050" dirty="0"/>
@@ -12113,67 +11729,6 @@
                             <a:srgbClr val="1C2B33"/>
                           </a:solidFill>
                         </a:rPr>
-                        <a:t>45</a:t>
-                      </a:r>
-                      <a:endParaRPr lang="en-US" sz="1050" dirty="0"/>
-                    </a:p>
-                  </a:txBody>
-                  <a:tcPr marL="91440" marR="91440" marT="45720" marB="45720" anchor="ctr">
-                    <a:lnL w="6350" cap="flat" cmpd="sng" algn="ctr">
-                      <a:solidFill>
-                        <a:srgbClr val="E3E8E9"/>
-                      </a:solidFill>
-                      <a:prstDash val="solid"/>
-                      <a:round/>
-                      <a:headEnd type="none" w="med" len="med"/>
-                      <a:tailEnd type="none" w="med" len="med"/>
-                    </a:lnL>
-                    <a:lnR w="6350" cap="flat" cmpd="sng" algn="ctr">
-                      <a:solidFill>
-                        <a:srgbClr val="E3E8E9"/>
-                      </a:solidFill>
-                      <a:prstDash val="solid"/>
-                      <a:round/>
-                      <a:headEnd type="none" w="med" len="med"/>
-                      <a:tailEnd type="none" w="med" len="med"/>
-                    </a:lnR>
-                    <a:lnT w="6350" cap="flat" cmpd="sng" algn="ctr">
-                      <a:solidFill>
-                        <a:srgbClr val="E3E8E9"/>
-                      </a:solidFill>
-                      <a:prstDash val="solid"/>
-                      <a:round/>
-                      <a:headEnd type="none" w="med" len="med"/>
-                      <a:tailEnd type="none" w="med" len="med"/>
-                    </a:lnT>
-                    <a:lnB w="6350" cap="flat" cmpd="sng" algn="ctr">
-                      <a:solidFill>
-                        <a:srgbClr val="E3E8E9"/>
-                      </a:solidFill>
-                      <a:prstDash val="solid"/>
-                      <a:round/>
-                      <a:headEnd type="none" w="med" len="med"/>
-                      <a:tailEnd type="none" w="med" len="med"/>
-                    </a:lnB>
-                    <a:solidFill>
-                      <a:srgbClr val="F0F4F5"/>
-                    </a:solidFill>
-                  </a:tcPr>
-                </a:tc>
-                <a:tc>
-                  <a:txBody>
-                    <a:bodyPr/>
-                    <a:lstStyle/>
-                    <a:p>
-                      <a:pPr algn="r" indent="0" marL="0">
-                        <a:buNone/>
-                      </a:pPr>
-                      <a:r>
-                        <a:rPr lang="en-US" sz="1050" dirty="0">
-                          <a:solidFill>
-                            <a:srgbClr val="1C2B33"/>
-                          </a:solidFill>
-                        </a:rPr>
                         <a:t>8</a:t>
                       </a:r>
                       <a:endParaRPr lang="en-US" sz="1050" dirty="0"/>
@@ -12359,67 +11914,6 @@
                             <a:srgbClr val="0B2A3D"/>
                           </a:solidFill>
                         </a:rPr>
-                        <a:t>318</a:t>
-                      </a:r>
-                      <a:endParaRPr lang="en-US" sz="1050" dirty="0"/>
-                    </a:p>
-                  </a:txBody>
-                  <a:tcPr marL="91440" marR="91440" marT="45720" marB="45720" anchor="ctr">
-                    <a:lnL w="6350" cap="flat" cmpd="sng" algn="ctr">
-                      <a:solidFill>
-                        <a:srgbClr val="E3E8E9"/>
-                      </a:solidFill>
-                      <a:prstDash val="solid"/>
-                      <a:round/>
-                      <a:headEnd type="none" w="med" len="med"/>
-                      <a:tailEnd type="none" w="med" len="med"/>
-                    </a:lnL>
-                    <a:lnR w="6350" cap="flat" cmpd="sng" algn="ctr">
-                      <a:solidFill>
-                        <a:srgbClr val="E3E8E9"/>
-                      </a:solidFill>
-                      <a:prstDash val="solid"/>
-                      <a:round/>
-                      <a:headEnd type="none" w="med" len="med"/>
-                      <a:tailEnd type="none" w="med" len="med"/>
-                    </a:lnR>
-                    <a:lnT w="6350" cap="flat" cmpd="sng" algn="ctr">
-                      <a:solidFill>
-                        <a:srgbClr val="E3E8E9"/>
-                      </a:solidFill>
-                      <a:prstDash val="solid"/>
-                      <a:round/>
-                      <a:headEnd type="none" w="med" len="med"/>
-                      <a:tailEnd type="none" w="med" len="med"/>
-                    </a:lnT>
-                    <a:lnB w="6350" cap="flat" cmpd="sng" algn="ctr">
-                      <a:solidFill>
-                        <a:srgbClr val="E3E8E9"/>
-                      </a:solidFill>
-                      <a:prstDash val="solid"/>
-                      <a:round/>
-                      <a:headEnd type="none" w="med" len="med"/>
-                      <a:tailEnd type="none" w="med" len="med"/>
-                    </a:lnB>
-                    <a:solidFill>
-                      <a:srgbClr val="DCE8E2"/>
-                    </a:solidFill>
-                  </a:tcPr>
-                </a:tc>
-                <a:tc>
-                  <a:txBody>
-                    <a:bodyPr/>
-                    <a:lstStyle/>
-                    <a:p>
-                      <a:pPr algn="r" indent="0" marL="0">
-                        <a:buNone/>
-                      </a:pPr>
-                      <a:r>
-                        <a:rPr lang="en-US" sz="1050" b="1" dirty="0">
-                          <a:solidFill>
-                            <a:srgbClr val="0B2A3D"/>
-                          </a:solidFill>
-                        </a:rPr>
                         <a:t>48</a:t>
                       </a:r>
                       <a:endParaRPr lang="en-US" sz="1050" dirty="0"/>
@@ -12474,7 +11968,7 @@
       </p:graphicFrame>
       <p:sp>
         <p:nvSpPr>
-          <p:cNvPr id="23" name="Text 19"/>
+          <p:cNvPr id="19" name="Text 15"/>
           <p:cNvSpPr txBox="1"/>
           <p:nvPr/>
         </p:nvSpPr>

</xml_diff>

<commit_message>
Update FPSO Frade figures from revised Cluster spreadsheet
Recalcula Composição de Custo, Escopos do CAPEX e a Visão Executiva
do FPSO Frade a partir da planilha revisada. CAPEX Total do Frade cai
de US$ 82,2 mi para US$ 66,3 mi (confere com a aba Overview do novo
arquivo). CAPEX consolidado do portfólio: US$ 110,5 mi.

Co-Authored-By: Claude Sonnet 5 <noreply@anthropic.com>
Claude-Session: https://claude.ai/code/session_01QXLKdFvqaqrRbUKxEFJW9L
</commit_message>
<xml_diff>
--- a/PRIO_Plano_Trabalho_CAPEX_2027.pptx
+++ b/PRIO_Plano_Trabalho_CAPEX_2027.pptx
@@ -319,7 +319,7 @@
                   <c:v>4.28</c:v>
                 </c:pt>
                 <c:pt idx="6">
-                  <c:v>82.16</c:v>
+                  <c:v>66.26</c:v>
                 </c:pt>
               </c:numCache>
             </c:numRef>
@@ -19019,7 +19019,7 @@
                 <a:ea typeface="Cambria" pitchFamily="34" charset="-122"/>
                 <a:cs typeface="Cambria" pitchFamily="34" charset="-120"/>
               </a:rPr>
-              <a:t>US$ 126,4 mi</a:t>
+              <a:t>US$ 110,5 mi</a:t>
             </a:r>
             <a:endParaRPr lang="en-US" sz="2600" dirty="0"/>
           </a:p>
@@ -19158,7 +19158,7 @@
                 <a:ea typeface="Cambria" pitchFamily="34" charset="-122"/>
                 <a:cs typeface="Cambria" pitchFamily="34" charset="-120"/>
               </a:rPr>
-              <a:t>230</a:t>
+              <a:t>231</a:t>
             </a:r>
             <a:endParaRPr lang="en-US" sz="2600" dirty="0"/>
           </a:p>
@@ -20834,7 +20834,7 @@
                             <a:srgbClr val="1C2B33"/>
                           </a:solidFill>
                         </a:rPr>
-                        <a:t>US$ 82,2 mi</a:t>
+                        <a:t>US$ 66,3 mi</a:t>
                       </a:r>
                       <a:endParaRPr lang="en-US" sz="1050" dirty="0"/>
                     </a:p>
@@ -20895,7 +20895,7 @@
                             <a:srgbClr val="1C2B33"/>
                           </a:solidFill>
                         </a:rPr>
-                        <a:t>88</a:t>
+                        <a:t>89</a:t>
                       </a:r>
                       <a:endParaRPr lang="en-US" sz="1050" dirty="0"/>
                     </a:p>
@@ -21019,7 +21019,7 @@
                             <a:srgbClr val="0B2A3D"/>
                           </a:solidFill>
                         </a:rPr>
-                        <a:t>US$ 126,4 mi</a:t>
+                        <a:t>US$ 110,5 mi</a:t>
                       </a:r>
                       <a:endParaRPr lang="en-US" sz="1050" dirty="0"/>
                     </a:p>
@@ -21080,7 +21080,7 @@
                             <a:srgbClr val="0B2A3D"/>
                           </a:solidFill>
                         </a:rPr>
-                        <a:t>230</a:t>
+                        <a:t>231</a:t>
                       </a:r>
                       <a:endParaRPr lang="en-US" sz="1050" dirty="0"/>
                     </a:p>
@@ -25591,7 +25591,7 @@
                 <a:ea typeface="Cambria" pitchFamily="34" charset="-122"/>
                 <a:cs typeface="Cambria" pitchFamily="34" charset="-120"/>
               </a:rPr>
-              <a:t>US$ 82,2 mi</a:t>
+              <a:t>US$ 66,3 mi</a:t>
             </a:r>
             <a:endParaRPr lang="en-US" sz="3300" dirty="0"/>
           </a:p>
@@ -25730,7 +25730,7 @@
                 <a:ea typeface="Cambria" pitchFamily="34" charset="-122"/>
                 <a:cs typeface="Cambria" pitchFamily="34" charset="-120"/>
               </a:rPr>
-              <a:t>US$ 35,3 mi</a:t>
+              <a:t>US$ 30,4 mi</a:t>
             </a:r>
             <a:endParaRPr lang="en-US" sz="2600" dirty="0"/>
           </a:p>
@@ -25830,7 +25830,7 @@
                 <a:ea typeface="Cambria" pitchFamily="34" charset="-122"/>
                 <a:cs typeface="Cambria" pitchFamily="34" charset="-120"/>
               </a:rPr>
-              <a:t>US$ 46,8 mi</a:t>
+              <a:t>US$ 35,9 mi</a:t>
             </a:r>
             <a:endParaRPr lang="en-US" sz="2600" dirty="0"/>
           </a:p>
@@ -26009,7 +26009,7 @@
                 <a:ea typeface="Calibri" pitchFamily="34" charset="-122"/>
                 <a:cs typeface="Calibri" pitchFamily="34" charset="-120"/>
               </a:rPr>
-              <a:t>US$ 29,9 mi</a:t>
+              <a:t>US$ 24,9 mi</a:t>
             </a:r>
             <a:endParaRPr lang="en-US" sz="950" dirty="0"/>
           </a:p>
@@ -26107,7 +26107,7 @@
                 <a:ea typeface="Calibri" pitchFamily="34" charset="-122"/>
                 <a:cs typeface="Calibri" pitchFamily="34" charset="-120"/>
               </a:rPr>
-              <a:t>US$ 21,7 mi</a:t>
+              <a:t>US$ 15,7 mi</a:t>
             </a:r>
             <a:endParaRPr lang="en-US" sz="950" dirty="0"/>
           </a:p>
@@ -26185,7 +26185,7 @@
                 <a:ea typeface="Calibri" pitchFamily="34" charset="-122"/>
                 <a:cs typeface="Calibri" pitchFamily="34" charset="-120"/>
               </a:rPr>
-              <a:t>US$ 18,0 mi</a:t>
+              <a:t>US$ 13,6 mi</a:t>
             </a:r>
             <a:endParaRPr lang="en-US" sz="950" dirty="0"/>
           </a:p>
@@ -26322,7 +26322,7 @@
                 <a:ea typeface="Calibri" pitchFamily="34" charset="-122"/>
                 <a:cs typeface="Calibri" pitchFamily="34" charset="-120"/>
               </a:rPr>
-              <a:t>ADM - Administrativo</a:t>
+              <a:t>INT - Integridade</a:t>
             </a:r>
             <a:endParaRPr lang="en-US" sz="950" dirty="0"/>
           </a:p>
@@ -26361,7 +26361,7 @@
                 <a:ea typeface="Calibri" pitchFamily="34" charset="-122"/>
                 <a:cs typeface="Calibri" pitchFamily="34" charset="-120"/>
               </a:rPr>
-              <a:t>US$ 2,9 mi</a:t>
+              <a:t>US$ 2,1 mi</a:t>
             </a:r>
             <a:endParaRPr lang="en-US" sz="950" dirty="0"/>
           </a:p>
@@ -26420,7 +26420,7 @@
                 <a:ea typeface="Calibri" pitchFamily="34" charset="-122"/>
                 <a:cs typeface="Calibri" pitchFamily="34" charset="-120"/>
               </a:rPr>
-              <a:t>INT - Integridade</a:t>
+              <a:t>ADM - Administrativo</a:t>
             </a:r>
             <a:endParaRPr lang="en-US" sz="950" dirty="0"/>
           </a:p>
@@ -26537,7 +26537,7 @@
                 <a:ea typeface="Calibri" pitchFamily="34" charset="-122"/>
                 <a:cs typeface="Calibri" pitchFamily="34" charset="-120"/>
               </a:rPr>
-              <a:t>US$ 1,8 mi</a:t>
+              <a:t>US$ 2,0 mi</a:t>
             </a:r>
             <a:endParaRPr lang="en-US" sz="950" dirty="0"/>
           </a:p>
@@ -26912,7 +26912,7 @@
                 <a:ea typeface="Calibri" pitchFamily="34" charset="-122"/>
                 <a:cs typeface="Calibri" pitchFamily="34" charset="-120"/>
               </a:rPr>
-              <a:t>Rotina Operacional</a:t>
+              <a:t>Bem Estar/Segurança</a:t>
             </a:r>
             <a:endParaRPr lang="en-US" sz="950" dirty="0"/>
           </a:p>
@@ -26951,7 +26951,7 @@
                 <a:ea typeface="Calibri" pitchFamily="34" charset="-122"/>
                 <a:cs typeface="Calibri" pitchFamily="34" charset="-120"/>
               </a:rPr>
-              <a:t>US$ 24,8 mi</a:t>
+              <a:t>US$ 22,7 mi</a:t>
             </a:r>
             <a:endParaRPr lang="en-US" sz="950" dirty="0"/>
           </a:p>
@@ -27010,7 +27010,7 @@
                 <a:ea typeface="Calibri" pitchFamily="34" charset="-122"/>
                 <a:cs typeface="Calibri" pitchFamily="34" charset="-120"/>
               </a:rPr>
-              <a:t>Bem Estar/Segurança</a:t>
+              <a:t>Rotina Operacional</a:t>
             </a:r>
             <a:endParaRPr lang="en-US" sz="950" dirty="0"/>
           </a:p>
@@ -27049,7 +27049,7 @@
                 <a:ea typeface="Calibri" pitchFamily="34" charset="-122"/>
                 <a:cs typeface="Calibri" pitchFamily="34" charset="-120"/>
               </a:rPr>
-              <a:t>US$ 23,5 mi</a:t>
+              <a:t>US$ 17,4 mi</a:t>
             </a:r>
             <a:endParaRPr lang="en-US" sz="950" dirty="0"/>
           </a:p>
@@ -27127,7 +27127,7 @@
                 <a:ea typeface="Calibri" pitchFamily="34" charset="-122"/>
                 <a:cs typeface="Calibri" pitchFamily="34" charset="-120"/>
               </a:rPr>
-              <a:t>US$ 17,8 mi</a:t>
+              <a:t>US$ 15,0 mi</a:t>
             </a:r>
             <a:endParaRPr lang="en-US" sz="950" dirty="0"/>
           </a:p>
@@ -27225,7 +27225,7 @@
                 <a:ea typeface="Calibri" pitchFamily="34" charset="-122"/>
                 <a:cs typeface="Calibri" pitchFamily="34" charset="-120"/>
               </a:rPr>
-              <a:t>US$ 16,1 mi</a:t>
+              <a:t>US$ 11,2 mi</a:t>
             </a:r>
             <a:endParaRPr lang="en-US" sz="950" dirty="0"/>
           </a:p>
@@ -27426,7 +27426,7 @@
                 <a:ea typeface="Calibri" pitchFamily="34" charset="-122"/>
                 <a:cs typeface="Calibri" pitchFamily="34" charset="-120"/>
               </a:rPr>
-              <a:t>Principais escopos por valor · 88 itens no total</a:t>
+              <a:t>Principais escopos por valor · 89 itens no total</a:t>
             </a:r>
             <a:endParaRPr lang="en-US" sz="1250" dirty="0"/>
           </a:p>
@@ -28300,7 +28300,7 @@
                           <a:ea typeface="Calibri" pitchFamily="34" charset="-122"/>
                           <a:cs typeface="Calibri" pitchFamily="34" charset="-120"/>
                         </a:rPr>
-                        <a:t>SPARE PARTS RECONDICIONAMENTO DOS BOOGIES</a:t>
+                        <a:t>L3 - TURBINA</a:t>
                       </a:r>
                       <a:endParaRPr lang="en-US" sz="1000" dirty="0">
                         <a:latin typeface="Calibri" charset="0"/>
@@ -28436,280 +28436,6 @@
                           <a:ea typeface="Calibri" pitchFamily="34" charset="-122"/>
                           <a:cs typeface="Calibri" pitchFamily="34" charset="-120"/>
                         </a:rPr>
-                        <a:t>NAV - Naval</a:t>
-                      </a:r>
-                      <a:endParaRPr lang="en-US" sz="950" dirty="0">
-                        <a:latin typeface="Calibri" charset="0"/>
-                        <a:ea typeface="Calibri" charset="0"/>
-                        <a:cs typeface="Calibri" charset="0"/>
-                      </a:endParaRPr>
-                    </a:p>
-                  </a:txBody>
-                  <a:tcPr marL="91440" marR="91440" marT="45720" marB="45720" anchor="ctr">
-                    <a:lnL w="6350" cap="flat" cmpd="sng" algn="ctr">
-                      <a:solidFill>
-                        <a:srgbClr val="E3E8E9"/>
-                      </a:solidFill>
-                      <a:prstDash val="solid"/>
-                      <a:round/>
-                      <a:headEnd type="none" w="med" len="med"/>
-                      <a:tailEnd type="none" w="med" len="med"/>
-                    </a:lnL>
-                    <a:lnR w="6350" cap="flat" cmpd="sng" algn="ctr">
-                      <a:solidFill>
-                        <a:srgbClr val="E3E8E9"/>
-                      </a:solidFill>
-                      <a:prstDash val="solid"/>
-                      <a:round/>
-                      <a:headEnd type="none" w="med" len="med"/>
-                      <a:tailEnd type="none" w="med" len="med"/>
-                    </a:lnR>
-                    <a:lnT w="6350" cap="flat" cmpd="sng" algn="ctr">
-                      <a:solidFill>
-                        <a:srgbClr val="E3E8E9"/>
-                      </a:solidFill>
-                      <a:prstDash val="solid"/>
-                      <a:round/>
-                      <a:headEnd type="none" w="med" len="med"/>
-                      <a:tailEnd type="none" w="med" len="med"/>
-                    </a:lnT>
-                    <a:lnB w="6350" cap="flat" cmpd="sng" algn="ctr">
-                      <a:solidFill>
-                        <a:srgbClr val="E3E8E9"/>
-                      </a:solidFill>
-                      <a:prstDash val="solid"/>
-                      <a:round/>
-                      <a:headEnd type="none" w="med" len="med"/>
-                      <a:tailEnd type="none" w="med" len="med"/>
-                    </a:lnB>
-                    <a:solidFill>
-                      <a:srgbClr val="FFFFFF"/>
-                    </a:solidFill>
-                  </a:tcPr>
-                </a:tc>
-                <a:tc>
-                  <a:txBody>
-                    <a:bodyPr/>
-                    <a:lstStyle/>
-                    <a:p>
-                      <a:pPr algn="r" indent="0" marL="0">
-                        <a:buNone/>
-                      </a:pPr>
-                      <a:r>
-                        <a:rPr lang="en-US" sz="1000" b="1" dirty="0">
-                          <a:solidFill>
-                            <a:srgbClr val="0B2A3D"/>
-                          </a:solidFill>
-                          <a:latin typeface="Calibri" pitchFamily="34" charset="0"/>
-                          <a:ea typeface="Calibri" pitchFamily="34" charset="-122"/>
-                          <a:cs typeface="Calibri" pitchFamily="34" charset="-120"/>
-                        </a:rPr>
-                        <a:t>US$ 6,3 mi</a:t>
-                      </a:r>
-                      <a:endParaRPr lang="en-US" sz="1000" dirty="0">
-                        <a:latin typeface="Calibri" charset="0"/>
-                        <a:ea typeface="Calibri" charset="0"/>
-                        <a:cs typeface="Calibri" charset="0"/>
-                      </a:endParaRPr>
-                    </a:p>
-                  </a:txBody>
-                  <a:tcPr marL="91440" marR="91440" marT="45720" marB="45720" anchor="ctr">
-                    <a:lnL w="6350" cap="flat" cmpd="sng" algn="ctr">
-                      <a:solidFill>
-                        <a:srgbClr val="E3E8E9"/>
-                      </a:solidFill>
-                      <a:prstDash val="solid"/>
-                      <a:round/>
-                      <a:headEnd type="none" w="med" len="med"/>
-                      <a:tailEnd type="none" w="med" len="med"/>
-                    </a:lnL>
-                    <a:lnR w="6350" cap="flat" cmpd="sng" algn="ctr">
-                      <a:solidFill>
-                        <a:srgbClr val="E3E8E9"/>
-                      </a:solidFill>
-                      <a:prstDash val="solid"/>
-                      <a:round/>
-                      <a:headEnd type="none" w="med" len="med"/>
-                      <a:tailEnd type="none" w="med" len="med"/>
-                    </a:lnR>
-                    <a:lnT w="6350" cap="flat" cmpd="sng" algn="ctr">
-                      <a:solidFill>
-                        <a:srgbClr val="E3E8E9"/>
-                      </a:solidFill>
-                      <a:prstDash val="solid"/>
-                      <a:round/>
-                      <a:headEnd type="none" w="med" len="med"/>
-                      <a:tailEnd type="none" w="med" len="med"/>
-                    </a:lnT>
-                    <a:lnB w="6350" cap="flat" cmpd="sng" algn="ctr">
-                      <a:solidFill>
-                        <a:srgbClr val="E3E8E9"/>
-                      </a:solidFill>
-                      <a:prstDash val="solid"/>
-                      <a:round/>
-                      <a:headEnd type="none" w="med" len="med"/>
-                      <a:tailEnd type="none" w="med" len="med"/>
-                    </a:lnB>
-                    <a:solidFill>
-                      <a:srgbClr val="FFFFFF"/>
-                    </a:solidFill>
-                  </a:tcPr>
-                </a:tc>
-              </a:tr>
-              <a:tr h="288036">
-                <a:tc>
-                  <a:txBody>
-                    <a:bodyPr/>
-                    <a:lstStyle/>
-                    <a:p>
-                      <a:pPr indent="0" marL="0">
-                        <a:buNone/>
-                      </a:pPr>
-                      <a:r>
-                        <a:rPr lang="en-US" sz="1000" dirty="0">
-                          <a:solidFill>
-                            <a:srgbClr val="1C2B33"/>
-                          </a:solidFill>
-                          <a:latin typeface="Calibri" pitchFamily="34" charset="0"/>
-                          <a:ea typeface="Calibri" pitchFamily="34" charset="-122"/>
-                          <a:cs typeface="Calibri" pitchFamily="34" charset="-120"/>
-                        </a:rPr>
-                        <a:t>L3 - TURBINA</a:t>
-                      </a:r>
-                      <a:endParaRPr lang="en-US" sz="1000" dirty="0">
-                        <a:latin typeface="Calibri" charset="0"/>
-                        <a:ea typeface="Calibri" charset="0"/>
-                        <a:cs typeface="Calibri" charset="0"/>
-                      </a:endParaRPr>
-                    </a:p>
-                  </a:txBody>
-                  <a:tcPr marL="91440" marR="91440" marT="45720" marB="45720" anchor="ctr">
-                    <a:lnL w="6350" cap="flat" cmpd="sng" algn="ctr">
-                      <a:solidFill>
-                        <a:srgbClr val="E3E8E9"/>
-                      </a:solidFill>
-                      <a:prstDash val="solid"/>
-                      <a:round/>
-                      <a:headEnd type="none" w="med" len="med"/>
-                      <a:tailEnd type="none" w="med" len="med"/>
-                    </a:lnL>
-                    <a:lnR w="6350" cap="flat" cmpd="sng" algn="ctr">
-                      <a:solidFill>
-                        <a:srgbClr val="E3E8E9"/>
-                      </a:solidFill>
-                      <a:prstDash val="solid"/>
-                      <a:round/>
-                      <a:headEnd type="none" w="med" len="med"/>
-                      <a:tailEnd type="none" w="med" len="med"/>
-                    </a:lnR>
-                    <a:lnT w="6350" cap="flat" cmpd="sng" algn="ctr">
-                      <a:solidFill>
-                        <a:srgbClr val="E3E8E9"/>
-                      </a:solidFill>
-                      <a:prstDash val="solid"/>
-                      <a:round/>
-                      <a:headEnd type="none" w="med" len="med"/>
-                      <a:tailEnd type="none" w="med" len="med"/>
-                    </a:lnT>
-                    <a:lnB w="6350" cap="flat" cmpd="sng" algn="ctr">
-                      <a:solidFill>
-                        <a:srgbClr val="E3E8E9"/>
-                      </a:solidFill>
-                      <a:prstDash val="solid"/>
-                      <a:round/>
-                      <a:headEnd type="none" w="med" len="med"/>
-                      <a:tailEnd type="none" w="med" len="med"/>
-                    </a:lnB>
-                    <a:solidFill>
-                      <a:srgbClr val="F0F4F5"/>
-                    </a:solidFill>
-                  </a:tcPr>
-                </a:tc>
-                <a:tc>
-                  <a:txBody>
-                    <a:bodyPr/>
-                    <a:lstStyle/>
-                    <a:p>
-                      <a:pPr indent="0" marL="0">
-                        <a:buNone/>
-                      </a:pPr>
-                      <a:r>
-                        <a:rPr lang="en-US" sz="950" dirty="0">
-                          <a:solidFill>
-                            <a:srgbClr val="5B6B73"/>
-                          </a:solidFill>
-                          <a:latin typeface="Calibri" pitchFamily="34" charset="0"/>
-                          <a:ea typeface="Calibri" pitchFamily="34" charset="-122"/>
-                          <a:cs typeface="Calibri" pitchFamily="34" charset="-120"/>
-                        </a:rPr>
-                        <a:t>Rotina Operacional</a:t>
-                      </a:r>
-                      <a:endParaRPr lang="en-US" sz="950" dirty="0">
-                        <a:latin typeface="Calibri" charset="0"/>
-                        <a:ea typeface="Calibri" charset="0"/>
-                        <a:cs typeface="Calibri" charset="0"/>
-                      </a:endParaRPr>
-                    </a:p>
-                  </a:txBody>
-                  <a:tcPr marL="91440" marR="91440" marT="45720" marB="45720" anchor="ctr">
-                    <a:lnL w="6350" cap="flat" cmpd="sng" algn="ctr">
-                      <a:solidFill>
-                        <a:srgbClr val="E3E8E9"/>
-                      </a:solidFill>
-                      <a:prstDash val="solid"/>
-                      <a:round/>
-                      <a:headEnd type="none" w="med" len="med"/>
-                      <a:tailEnd type="none" w="med" len="med"/>
-                    </a:lnL>
-                    <a:lnR w="6350" cap="flat" cmpd="sng" algn="ctr">
-                      <a:solidFill>
-                        <a:srgbClr val="E3E8E9"/>
-                      </a:solidFill>
-                      <a:prstDash val="solid"/>
-                      <a:round/>
-                      <a:headEnd type="none" w="med" len="med"/>
-                      <a:tailEnd type="none" w="med" len="med"/>
-                    </a:lnR>
-                    <a:lnT w="6350" cap="flat" cmpd="sng" algn="ctr">
-                      <a:solidFill>
-                        <a:srgbClr val="E3E8E9"/>
-                      </a:solidFill>
-                      <a:prstDash val="solid"/>
-                      <a:round/>
-                      <a:headEnd type="none" w="med" len="med"/>
-                      <a:tailEnd type="none" w="med" len="med"/>
-                    </a:lnT>
-                    <a:lnB w="6350" cap="flat" cmpd="sng" algn="ctr">
-                      <a:solidFill>
-                        <a:srgbClr val="E3E8E9"/>
-                      </a:solidFill>
-                      <a:prstDash val="solid"/>
-                      <a:round/>
-                      <a:headEnd type="none" w="med" len="med"/>
-                      <a:tailEnd type="none" w="med" len="med"/>
-                    </a:lnB>
-                    <a:solidFill>
-                      <a:srgbClr val="F0F4F5"/>
-                    </a:solidFill>
-                  </a:tcPr>
-                </a:tc>
-                <a:tc>
-                  <a:txBody>
-                    <a:bodyPr/>
-                    <a:lstStyle/>
-                    <a:p>
-                      <a:pPr indent="0" marL="0">
-                        <a:buNone/>
-                      </a:pPr>
-                      <a:r>
-                        <a:rPr lang="en-US" sz="950" dirty="0">
-                          <a:solidFill>
-                            <a:srgbClr val="5B6B73"/>
-                          </a:solidFill>
-                          <a:latin typeface="Calibri" pitchFamily="34" charset="0"/>
-                          <a:ea typeface="Calibri" pitchFamily="34" charset="-122"/>
-                          <a:cs typeface="Calibri" pitchFamily="34" charset="-120"/>
-                        </a:rPr>
                         <a:t>MNT – Manutenção</a:t>
                       </a:r>
                       <a:endParaRPr lang="en-US" sz="950" dirty="0">
@@ -28757,7 +28483,7 @@
                       <a:tailEnd type="none" w="med" len="med"/>
                     </a:lnB>
                     <a:solidFill>
-                      <a:srgbClr val="F0F4F5"/>
+                      <a:srgbClr val="FFFFFF"/>
                     </a:solidFill>
                   </a:tcPr>
                 </a:tc>
@@ -28825,7 +28551,7 @@
                       <a:tailEnd type="none" w="med" len="med"/>
                     </a:lnB>
                     <a:solidFill>
-                      <a:srgbClr val="F0F4F5"/>
+                      <a:srgbClr val="FFFFFF"/>
                     </a:solidFill>
                   </a:tcPr>
                 </a:tc>
@@ -28849,280 +28575,6 @@
                           <a:cs typeface="Calibri" pitchFamily="34" charset="-120"/>
                         </a:rPr>
                         <a:t>Frade 100K (Fase 2)</a:t>
-                      </a:r>
-                      <a:endParaRPr lang="en-US" sz="1000" dirty="0">
-                        <a:latin typeface="Calibri" charset="0"/>
-                        <a:ea typeface="Calibri" charset="0"/>
-                        <a:cs typeface="Calibri" charset="0"/>
-                      </a:endParaRPr>
-                    </a:p>
-                  </a:txBody>
-                  <a:tcPr marL="91440" marR="91440" marT="45720" marB="45720" anchor="ctr">
-                    <a:lnL w="6350" cap="flat" cmpd="sng" algn="ctr">
-                      <a:solidFill>
-                        <a:srgbClr val="E3E8E9"/>
-                      </a:solidFill>
-                      <a:prstDash val="solid"/>
-                      <a:round/>
-                      <a:headEnd type="none" w="med" len="med"/>
-                      <a:tailEnd type="none" w="med" len="med"/>
-                    </a:lnL>
-                    <a:lnR w="6350" cap="flat" cmpd="sng" algn="ctr">
-                      <a:solidFill>
-                        <a:srgbClr val="E3E8E9"/>
-                      </a:solidFill>
-                      <a:prstDash val="solid"/>
-                      <a:round/>
-                      <a:headEnd type="none" w="med" len="med"/>
-                      <a:tailEnd type="none" w="med" len="med"/>
-                    </a:lnR>
-                    <a:lnT w="6350" cap="flat" cmpd="sng" algn="ctr">
-                      <a:solidFill>
-                        <a:srgbClr val="E3E8E9"/>
-                      </a:solidFill>
-                      <a:prstDash val="solid"/>
-                      <a:round/>
-                      <a:headEnd type="none" w="med" len="med"/>
-                      <a:tailEnd type="none" w="med" len="med"/>
-                    </a:lnT>
-                    <a:lnB w="6350" cap="flat" cmpd="sng" algn="ctr">
-                      <a:solidFill>
-                        <a:srgbClr val="E3E8E9"/>
-                      </a:solidFill>
-                      <a:prstDash val="solid"/>
-                      <a:round/>
-                      <a:headEnd type="none" w="med" len="med"/>
-                      <a:tailEnd type="none" w="med" len="med"/>
-                    </a:lnB>
-                    <a:solidFill>
-                      <a:srgbClr val="FFFFFF"/>
-                    </a:solidFill>
-                  </a:tcPr>
-                </a:tc>
-                <a:tc>
-                  <a:txBody>
-                    <a:bodyPr/>
-                    <a:lstStyle/>
-                    <a:p>
-                      <a:pPr indent="0" marL="0">
-                        <a:buNone/>
-                      </a:pPr>
-                      <a:r>
-                        <a:rPr lang="en-US" sz="950" dirty="0">
-                          <a:solidFill>
-                            <a:srgbClr val="5B6B73"/>
-                          </a:solidFill>
-                          <a:latin typeface="Calibri" pitchFamily="34" charset="0"/>
-                          <a:ea typeface="Calibri" pitchFamily="34" charset="-122"/>
-                          <a:cs typeface="Calibri" pitchFamily="34" charset="-120"/>
-                        </a:rPr>
-                        <a:t>Eficiência de Produção</a:t>
-                      </a:r>
-                      <a:endParaRPr lang="en-US" sz="950" dirty="0">
-                        <a:latin typeface="Calibri" charset="0"/>
-                        <a:ea typeface="Calibri" charset="0"/>
-                        <a:cs typeface="Calibri" charset="0"/>
-                      </a:endParaRPr>
-                    </a:p>
-                  </a:txBody>
-                  <a:tcPr marL="91440" marR="91440" marT="45720" marB="45720" anchor="ctr">
-                    <a:lnL w="6350" cap="flat" cmpd="sng" algn="ctr">
-                      <a:solidFill>
-                        <a:srgbClr val="E3E8E9"/>
-                      </a:solidFill>
-                      <a:prstDash val="solid"/>
-                      <a:round/>
-                      <a:headEnd type="none" w="med" len="med"/>
-                      <a:tailEnd type="none" w="med" len="med"/>
-                    </a:lnL>
-                    <a:lnR w="6350" cap="flat" cmpd="sng" algn="ctr">
-                      <a:solidFill>
-                        <a:srgbClr val="E3E8E9"/>
-                      </a:solidFill>
-                      <a:prstDash val="solid"/>
-                      <a:round/>
-                      <a:headEnd type="none" w="med" len="med"/>
-                      <a:tailEnd type="none" w="med" len="med"/>
-                    </a:lnR>
-                    <a:lnT w="6350" cap="flat" cmpd="sng" algn="ctr">
-                      <a:solidFill>
-                        <a:srgbClr val="E3E8E9"/>
-                      </a:solidFill>
-                      <a:prstDash val="solid"/>
-                      <a:round/>
-                      <a:headEnd type="none" w="med" len="med"/>
-                      <a:tailEnd type="none" w="med" len="med"/>
-                    </a:lnT>
-                    <a:lnB w="6350" cap="flat" cmpd="sng" algn="ctr">
-                      <a:solidFill>
-                        <a:srgbClr val="E3E8E9"/>
-                      </a:solidFill>
-                      <a:prstDash val="solid"/>
-                      <a:round/>
-                      <a:headEnd type="none" w="med" len="med"/>
-                      <a:tailEnd type="none" w="med" len="med"/>
-                    </a:lnB>
-                    <a:solidFill>
-                      <a:srgbClr val="FFFFFF"/>
-                    </a:solidFill>
-                  </a:tcPr>
-                </a:tc>
-                <a:tc>
-                  <a:txBody>
-                    <a:bodyPr/>
-                    <a:lstStyle/>
-                    <a:p>
-                      <a:pPr indent="0" marL="0">
-                        <a:buNone/>
-                      </a:pPr>
-                      <a:r>
-                        <a:rPr lang="en-US" sz="950" dirty="0">
-                          <a:solidFill>
-                            <a:srgbClr val="5B6B73"/>
-                          </a:solidFill>
-                          <a:latin typeface="Calibri" pitchFamily="34" charset="0"/>
-                          <a:ea typeface="Calibri" pitchFamily="34" charset="-122"/>
-                          <a:cs typeface="Calibri" pitchFamily="34" charset="-120"/>
-                        </a:rPr>
-                        <a:t>Projetos</a:t>
-                      </a:r>
-                      <a:endParaRPr lang="en-US" sz="950" dirty="0">
-                        <a:latin typeface="Calibri" charset="0"/>
-                        <a:ea typeface="Calibri" charset="0"/>
-                        <a:cs typeface="Calibri" charset="0"/>
-                      </a:endParaRPr>
-                    </a:p>
-                  </a:txBody>
-                  <a:tcPr marL="91440" marR="91440" marT="45720" marB="45720" anchor="ctr">
-                    <a:lnL w="6350" cap="flat" cmpd="sng" algn="ctr">
-                      <a:solidFill>
-                        <a:srgbClr val="E3E8E9"/>
-                      </a:solidFill>
-                      <a:prstDash val="solid"/>
-                      <a:round/>
-                      <a:headEnd type="none" w="med" len="med"/>
-                      <a:tailEnd type="none" w="med" len="med"/>
-                    </a:lnL>
-                    <a:lnR w="6350" cap="flat" cmpd="sng" algn="ctr">
-                      <a:solidFill>
-                        <a:srgbClr val="E3E8E9"/>
-                      </a:solidFill>
-                      <a:prstDash val="solid"/>
-                      <a:round/>
-                      <a:headEnd type="none" w="med" len="med"/>
-                      <a:tailEnd type="none" w="med" len="med"/>
-                    </a:lnR>
-                    <a:lnT w="6350" cap="flat" cmpd="sng" algn="ctr">
-                      <a:solidFill>
-                        <a:srgbClr val="E3E8E9"/>
-                      </a:solidFill>
-                      <a:prstDash val="solid"/>
-                      <a:round/>
-                      <a:headEnd type="none" w="med" len="med"/>
-                      <a:tailEnd type="none" w="med" len="med"/>
-                    </a:lnT>
-                    <a:lnB w="6350" cap="flat" cmpd="sng" algn="ctr">
-                      <a:solidFill>
-                        <a:srgbClr val="E3E8E9"/>
-                      </a:solidFill>
-                      <a:prstDash val="solid"/>
-                      <a:round/>
-                      <a:headEnd type="none" w="med" len="med"/>
-                      <a:tailEnd type="none" w="med" len="med"/>
-                    </a:lnB>
-                    <a:solidFill>
-                      <a:srgbClr val="FFFFFF"/>
-                    </a:solidFill>
-                  </a:tcPr>
-                </a:tc>
-                <a:tc>
-                  <a:txBody>
-                    <a:bodyPr/>
-                    <a:lstStyle/>
-                    <a:p>
-                      <a:pPr algn="r" indent="0" marL="0">
-                        <a:buNone/>
-                      </a:pPr>
-                      <a:r>
-                        <a:rPr lang="en-US" sz="1000" b="1" dirty="0">
-                          <a:solidFill>
-                            <a:srgbClr val="0B2A3D"/>
-                          </a:solidFill>
-                          <a:latin typeface="Calibri" pitchFamily="34" charset="0"/>
-                          <a:ea typeface="Calibri" pitchFamily="34" charset="-122"/>
-                          <a:cs typeface="Calibri" pitchFamily="34" charset="-120"/>
-                        </a:rPr>
-                        <a:t>US$ 5,4 mi</a:t>
-                      </a:r>
-                      <a:endParaRPr lang="en-US" sz="1000" dirty="0">
-                        <a:latin typeface="Calibri" charset="0"/>
-                        <a:ea typeface="Calibri" charset="0"/>
-                        <a:cs typeface="Calibri" charset="0"/>
-                      </a:endParaRPr>
-                    </a:p>
-                  </a:txBody>
-                  <a:tcPr marL="91440" marR="91440" marT="45720" marB="45720" anchor="ctr">
-                    <a:lnL w="6350" cap="flat" cmpd="sng" algn="ctr">
-                      <a:solidFill>
-                        <a:srgbClr val="E3E8E9"/>
-                      </a:solidFill>
-                      <a:prstDash val="solid"/>
-                      <a:round/>
-                      <a:headEnd type="none" w="med" len="med"/>
-                      <a:tailEnd type="none" w="med" len="med"/>
-                    </a:lnL>
-                    <a:lnR w="6350" cap="flat" cmpd="sng" algn="ctr">
-                      <a:solidFill>
-                        <a:srgbClr val="E3E8E9"/>
-                      </a:solidFill>
-                      <a:prstDash val="solid"/>
-                      <a:round/>
-                      <a:headEnd type="none" w="med" len="med"/>
-                      <a:tailEnd type="none" w="med" len="med"/>
-                    </a:lnR>
-                    <a:lnT w="6350" cap="flat" cmpd="sng" algn="ctr">
-                      <a:solidFill>
-                        <a:srgbClr val="E3E8E9"/>
-                      </a:solidFill>
-                      <a:prstDash val="solid"/>
-                      <a:round/>
-                      <a:headEnd type="none" w="med" len="med"/>
-                      <a:tailEnd type="none" w="med" len="med"/>
-                    </a:lnT>
-                    <a:lnB w="6350" cap="flat" cmpd="sng" algn="ctr">
-                      <a:solidFill>
-                        <a:srgbClr val="E3E8E9"/>
-                      </a:solidFill>
-                      <a:prstDash val="solid"/>
-                      <a:round/>
-                      <a:headEnd type="none" w="med" len="med"/>
-                      <a:tailEnd type="none" w="med" len="med"/>
-                    </a:lnB>
-                    <a:solidFill>
-                      <a:srgbClr val="FFFFFF"/>
-                    </a:solidFill>
-                  </a:tcPr>
-                </a:tc>
-              </a:tr>
-              <a:tr h="288036">
-                <a:tc>
-                  <a:txBody>
-                    <a:bodyPr/>
-                    <a:lstStyle/>
-                    <a:p>
-                      <a:pPr indent="0" marL="0">
-                        <a:buNone/>
-                      </a:pPr>
-                      <a:r>
-                        <a:rPr lang="en-US" sz="1000" dirty="0">
-                          <a:solidFill>
-                            <a:srgbClr val="1C2B33"/>
-                          </a:solidFill>
-                          <a:latin typeface="Calibri" pitchFamily="34" charset="0"/>
-                          <a:ea typeface="Calibri" pitchFamily="34" charset="-122"/>
-                          <a:cs typeface="Calibri" pitchFamily="34" charset="-120"/>
-                        </a:rPr>
-                        <a:t>Atualização Tecnológica das GTGs</a:t>
                       </a:r>
                       <a:endParaRPr lang="en-US" sz="1000" dirty="0">
                         <a:latin typeface="Calibri" charset="0"/>
@@ -29326,7 +28778,7 @@
                           <a:ea typeface="Calibri" pitchFamily="34" charset="-122"/>
                           <a:cs typeface="Calibri" pitchFamily="34" charset="-120"/>
                         </a:rPr>
-                        <a:t>US$ 3,6 mi</a:t>
+                        <a:t>US$ 5,4 mi</a:t>
                       </a:r>
                       <a:endParaRPr lang="en-US" sz="1000" dirty="0">
                         <a:latin typeface="Calibri" charset="0"/>
@@ -29396,7 +28848,7 @@
                           <a:ea typeface="Calibri" pitchFamily="34" charset="-122"/>
                           <a:cs typeface="Calibri" pitchFamily="34" charset="-120"/>
                         </a:rPr>
-                        <a:t>REVAMP IGG</a:t>
+                        <a:t>SPARE PARTS RECONDICIONAMENTO DOS BOOGIES</a:t>
                       </a:r>
                       <a:endParaRPr lang="en-US" sz="1000" dirty="0">
                         <a:latin typeface="Calibri" charset="0"/>
@@ -29532,7 +28984,7 @@
                           <a:ea typeface="Calibri" pitchFamily="34" charset="-122"/>
                           <a:cs typeface="Calibri" pitchFamily="34" charset="-120"/>
                         </a:rPr>
-                        <a:t>MNT – Manutenção</a:t>
+                        <a:t>NAV - Naval</a:t>
                       </a:r>
                       <a:endParaRPr lang="en-US" sz="950" dirty="0">
                         <a:latin typeface="Calibri" charset="0"/>
@@ -29600,7 +29052,7 @@
                           <a:ea typeface="Calibri" pitchFamily="34" charset="-122"/>
                           <a:cs typeface="Calibri" pitchFamily="34" charset="-120"/>
                         </a:rPr>
-                        <a:t>US$ 3,6 mi</a:t>
+                        <a:t>US$ 3,2 mi</a:t>
                       </a:r>
                       <a:endParaRPr lang="en-US" sz="1000" dirty="0">
                         <a:latin typeface="Calibri" charset="0"/>
@@ -29874,7 +29326,7 @@
                           <a:ea typeface="Calibri" pitchFamily="34" charset="-122"/>
                           <a:cs typeface="Calibri" pitchFamily="34" charset="-120"/>
                         </a:rPr>
-                        <a:t>US$ 2,9 mi</a:t>
+                        <a:t>US$ 2,1 mi</a:t>
                       </a:r>
                       <a:endParaRPr lang="en-US" sz="1000" dirty="0">
                         <a:latin typeface="Calibri" charset="0"/>
@@ -29944,7 +29396,7 @@
                           <a:ea typeface="Calibri" pitchFamily="34" charset="-122"/>
                           <a:cs typeface="Calibri" pitchFamily="34" charset="-120"/>
                         </a:rPr>
-                        <a:t>SUBSTITUIÇÃO DA AMARRA 06</a:t>
+                        <a:t>Instalação linha offloading </a:t>
                       </a:r>
                       <a:endParaRPr lang="en-US" sz="1000" dirty="0">
                         <a:latin typeface="Calibri" charset="0"/>
@@ -30080,7 +29532,7 @@
                           <a:ea typeface="Calibri" pitchFamily="34" charset="-122"/>
                           <a:cs typeface="Calibri" pitchFamily="34" charset="-120"/>
                         </a:rPr>
-                        <a:t>NAV - Naval</a:t>
+                        <a:t>INT - Integridade</a:t>
                       </a:r>
                       <a:endParaRPr lang="en-US" sz="950" dirty="0">
                         <a:latin typeface="Calibri" charset="0"/>
@@ -30148,7 +29600,7 @@
                           <a:ea typeface="Calibri" pitchFamily="34" charset="-122"/>
                           <a:cs typeface="Calibri" pitchFamily="34" charset="-120"/>
                         </a:rPr>
-                        <a:t>US$ 2,8 mi</a:t>
+                        <a:t>US$ 1,7 mi</a:t>
                       </a:r>
                       <a:endParaRPr lang="en-US" sz="1000" dirty="0">
                         <a:latin typeface="Calibri" charset="0"/>
@@ -30218,7 +29670,7 @@
                           <a:ea typeface="Calibri" pitchFamily="34" charset="-122"/>
                           <a:cs typeface="Calibri" pitchFamily="34" charset="-120"/>
                         </a:rPr>
-                        <a:t>Instalação linha offloading </a:t>
+                        <a:t>REVAMP IGG</a:t>
                       </a:r>
                       <a:endParaRPr lang="en-US" sz="1000" dirty="0">
                         <a:latin typeface="Calibri" charset="0"/>
@@ -30286,7 +29738,7 @@
                           <a:ea typeface="Calibri" pitchFamily="34" charset="-122"/>
                           <a:cs typeface="Calibri" pitchFamily="34" charset="-120"/>
                         </a:rPr>
-                        <a:t>Integridade e Regulatório</a:t>
+                        <a:t>Rotina Operacional</a:t>
                       </a:r>
                       <a:endParaRPr lang="en-US" sz="950" dirty="0">
                         <a:latin typeface="Calibri" charset="0"/>
@@ -30354,7 +29806,7 @@
                           <a:ea typeface="Calibri" pitchFamily="34" charset="-122"/>
                           <a:cs typeface="Calibri" pitchFamily="34" charset="-120"/>
                         </a:rPr>
-                        <a:t>INT - Integridade</a:t>
+                        <a:t>MNT – Manutenção</a:t>
                       </a:r>
                       <a:endParaRPr lang="en-US" sz="950" dirty="0">
                         <a:latin typeface="Calibri" charset="0"/>
@@ -30422,7 +29874,7 @@
                           <a:ea typeface="Calibri" pitchFamily="34" charset="-122"/>
                           <a:cs typeface="Calibri" pitchFamily="34" charset="-120"/>
                         </a:rPr>
-                        <a:t>US$ 1,7 mi</a:t>
+                        <a:t>US$ 1,6 mi</a:t>
                       </a:r>
                       <a:endParaRPr lang="en-US" sz="1000" dirty="0">
                         <a:latin typeface="Calibri" charset="0"/>
@@ -30766,7 +30218,7 @@
                           <a:ea typeface="Calibri" pitchFamily="34" charset="-122"/>
                           <a:cs typeface="Calibri" pitchFamily="34" charset="-120"/>
                         </a:rPr>
-                        <a:t>REPARO E INSTALAÇÃO DA PIGGING PUMP</a:t>
+                        <a:t>Sensores de H2S</a:t>
                       </a:r>
                       <a:endParaRPr lang="en-US" sz="1000" dirty="0">
                         <a:latin typeface="Calibri" charset="0"/>
@@ -30834,7 +30286,7 @@
                           <a:ea typeface="Calibri" pitchFamily="34" charset="-122"/>
                           <a:cs typeface="Calibri" pitchFamily="34" charset="-120"/>
                         </a:rPr>
-                        <a:t>Eficiência de Produção</a:t>
+                        <a:t>Bem Estar/Segurança</a:t>
                       </a:r>
                       <a:endParaRPr lang="en-US" sz="950" dirty="0">
                         <a:latin typeface="Calibri" charset="0"/>
@@ -30902,7 +30354,7 @@
                           <a:ea typeface="Calibri" pitchFamily="34" charset="-122"/>
                           <a:cs typeface="Calibri" pitchFamily="34" charset="-120"/>
                         </a:rPr>
-                        <a:t>MNT – Manutenção</a:t>
+                        <a:t>Projetos</a:t>
                       </a:r>
                       <a:endParaRPr lang="en-US" sz="950" dirty="0">
                         <a:latin typeface="Calibri" charset="0"/>
@@ -30970,7 +30422,555 @@
                           <a:ea typeface="Calibri" pitchFamily="34" charset="-122"/>
                           <a:cs typeface="Calibri" pitchFamily="34" charset="-120"/>
                         </a:rPr>
-                        <a:t>US$ 1,5 mi</a:t>
+                        <a:t>US$ 1,4 mi</a:t>
+                      </a:r>
+                      <a:endParaRPr lang="en-US" sz="1000" dirty="0">
+                        <a:latin typeface="Calibri" charset="0"/>
+                        <a:ea typeface="Calibri" charset="0"/>
+                        <a:cs typeface="Calibri" charset="0"/>
+                      </a:endParaRPr>
+                    </a:p>
+                  </a:txBody>
+                  <a:tcPr marL="91440" marR="91440" marT="45720" marB="45720" anchor="ctr">
+                    <a:lnL w="6350" cap="flat" cmpd="sng" algn="ctr">
+                      <a:solidFill>
+                        <a:srgbClr val="E3E8E9"/>
+                      </a:solidFill>
+                      <a:prstDash val="solid"/>
+                      <a:round/>
+                      <a:headEnd type="none" w="med" len="med"/>
+                      <a:tailEnd type="none" w="med" len="med"/>
+                    </a:lnL>
+                    <a:lnR w="6350" cap="flat" cmpd="sng" algn="ctr">
+                      <a:solidFill>
+                        <a:srgbClr val="E3E8E9"/>
+                      </a:solidFill>
+                      <a:prstDash val="solid"/>
+                      <a:round/>
+                      <a:headEnd type="none" w="med" len="med"/>
+                      <a:tailEnd type="none" w="med" len="med"/>
+                    </a:lnR>
+                    <a:lnT w="6350" cap="flat" cmpd="sng" algn="ctr">
+                      <a:solidFill>
+                        <a:srgbClr val="E3E8E9"/>
+                      </a:solidFill>
+                      <a:prstDash val="solid"/>
+                      <a:round/>
+                      <a:headEnd type="none" w="med" len="med"/>
+                      <a:tailEnd type="none" w="med" len="med"/>
+                    </a:lnT>
+                    <a:lnB w="6350" cap="flat" cmpd="sng" algn="ctr">
+                      <a:solidFill>
+                        <a:srgbClr val="E3E8E9"/>
+                      </a:solidFill>
+                      <a:prstDash val="solid"/>
+                      <a:round/>
+                      <a:headEnd type="none" w="med" len="med"/>
+                      <a:tailEnd type="none" w="med" len="med"/>
+                    </a:lnB>
+                    <a:solidFill>
+                      <a:srgbClr val="F0F4F5"/>
+                    </a:solidFill>
+                  </a:tcPr>
+                </a:tc>
+              </a:tr>
+              <a:tr h="288036">
+                <a:tc>
+                  <a:txBody>
+                    <a:bodyPr/>
+                    <a:lstStyle/>
+                    <a:p>
+                      <a:pPr indent="0" marL="0">
+                        <a:buNone/>
+                      </a:pPr>
+                      <a:r>
+                        <a:rPr lang="en-US" sz="1000" dirty="0">
+                          <a:solidFill>
+                            <a:srgbClr val="1C2B33"/>
+                          </a:solidFill>
+                          <a:latin typeface="Calibri" pitchFamily="34" charset="0"/>
+                          <a:ea typeface="Calibri" pitchFamily="34" charset="-122"/>
+                          <a:cs typeface="Calibri" pitchFamily="34" charset="-120"/>
+                        </a:rPr>
+                        <a:t>Skids de Dilúvio</a:t>
+                      </a:r>
+                      <a:endParaRPr lang="en-US" sz="1000" dirty="0">
+                        <a:latin typeface="Calibri" charset="0"/>
+                        <a:ea typeface="Calibri" charset="0"/>
+                        <a:cs typeface="Calibri" charset="0"/>
+                      </a:endParaRPr>
+                    </a:p>
+                  </a:txBody>
+                  <a:tcPr marL="91440" marR="91440" marT="45720" marB="45720" anchor="ctr">
+                    <a:lnL w="6350" cap="flat" cmpd="sng" algn="ctr">
+                      <a:solidFill>
+                        <a:srgbClr val="E3E8E9"/>
+                      </a:solidFill>
+                      <a:prstDash val="solid"/>
+                      <a:round/>
+                      <a:headEnd type="none" w="med" len="med"/>
+                      <a:tailEnd type="none" w="med" len="med"/>
+                    </a:lnL>
+                    <a:lnR w="6350" cap="flat" cmpd="sng" algn="ctr">
+                      <a:solidFill>
+                        <a:srgbClr val="E3E8E9"/>
+                      </a:solidFill>
+                      <a:prstDash val="solid"/>
+                      <a:round/>
+                      <a:headEnd type="none" w="med" len="med"/>
+                      <a:tailEnd type="none" w="med" len="med"/>
+                    </a:lnR>
+                    <a:lnT w="6350" cap="flat" cmpd="sng" algn="ctr">
+                      <a:solidFill>
+                        <a:srgbClr val="E3E8E9"/>
+                      </a:solidFill>
+                      <a:prstDash val="solid"/>
+                      <a:round/>
+                      <a:headEnd type="none" w="med" len="med"/>
+                      <a:tailEnd type="none" w="med" len="med"/>
+                    </a:lnT>
+                    <a:lnB w="6350" cap="flat" cmpd="sng" algn="ctr">
+                      <a:solidFill>
+                        <a:srgbClr val="E3E8E9"/>
+                      </a:solidFill>
+                      <a:prstDash val="solid"/>
+                      <a:round/>
+                      <a:headEnd type="none" w="med" len="med"/>
+                      <a:tailEnd type="none" w="med" len="med"/>
+                    </a:lnB>
+                    <a:solidFill>
+                      <a:srgbClr val="FFFFFF"/>
+                    </a:solidFill>
+                  </a:tcPr>
+                </a:tc>
+                <a:tc>
+                  <a:txBody>
+                    <a:bodyPr/>
+                    <a:lstStyle/>
+                    <a:p>
+                      <a:pPr indent="0" marL="0">
+                        <a:buNone/>
+                      </a:pPr>
+                      <a:r>
+                        <a:rPr lang="en-US" sz="950" dirty="0">
+                          <a:solidFill>
+                            <a:srgbClr val="5B6B73"/>
+                          </a:solidFill>
+                          <a:latin typeface="Calibri" pitchFamily="34" charset="0"/>
+                          <a:ea typeface="Calibri" pitchFamily="34" charset="-122"/>
+                          <a:cs typeface="Calibri" pitchFamily="34" charset="-120"/>
+                        </a:rPr>
+                        <a:t>Bem Estar/Segurança</a:t>
+                      </a:r>
+                      <a:endParaRPr lang="en-US" sz="950" dirty="0">
+                        <a:latin typeface="Calibri" charset="0"/>
+                        <a:ea typeface="Calibri" charset="0"/>
+                        <a:cs typeface="Calibri" charset="0"/>
+                      </a:endParaRPr>
+                    </a:p>
+                  </a:txBody>
+                  <a:tcPr marL="91440" marR="91440" marT="45720" marB="45720" anchor="ctr">
+                    <a:lnL w="6350" cap="flat" cmpd="sng" algn="ctr">
+                      <a:solidFill>
+                        <a:srgbClr val="E3E8E9"/>
+                      </a:solidFill>
+                      <a:prstDash val="solid"/>
+                      <a:round/>
+                      <a:headEnd type="none" w="med" len="med"/>
+                      <a:tailEnd type="none" w="med" len="med"/>
+                    </a:lnL>
+                    <a:lnR w="6350" cap="flat" cmpd="sng" algn="ctr">
+                      <a:solidFill>
+                        <a:srgbClr val="E3E8E9"/>
+                      </a:solidFill>
+                      <a:prstDash val="solid"/>
+                      <a:round/>
+                      <a:headEnd type="none" w="med" len="med"/>
+                      <a:tailEnd type="none" w="med" len="med"/>
+                    </a:lnR>
+                    <a:lnT w="6350" cap="flat" cmpd="sng" algn="ctr">
+                      <a:solidFill>
+                        <a:srgbClr val="E3E8E9"/>
+                      </a:solidFill>
+                      <a:prstDash val="solid"/>
+                      <a:round/>
+                      <a:headEnd type="none" w="med" len="med"/>
+                      <a:tailEnd type="none" w="med" len="med"/>
+                    </a:lnT>
+                    <a:lnB w="6350" cap="flat" cmpd="sng" algn="ctr">
+                      <a:solidFill>
+                        <a:srgbClr val="E3E8E9"/>
+                      </a:solidFill>
+                      <a:prstDash val="solid"/>
+                      <a:round/>
+                      <a:headEnd type="none" w="med" len="med"/>
+                      <a:tailEnd type="none" w="med" len="med"/>
+                    </a:lnB>
+                    <a:solidFill>
+                      <a:srgbClr val="FFFFFF"/>
+                    </a:solidFill>
+                  </a:tcPr>
+                </a:tc>
+                <a:tc>
+                  <a:txBody>
+                    <a:bodyPr/>
+                    <a:lstStyle/>
+                    <a:p>
+                      <a:pPr indent="0" marL="0">
+                        <a:buNone/>
+                      </a:pPr>
+                      <a:r>
+                        <a:rPr lang="en-US" sz="950" dirty="0">
+                          <a:solidFill>
+                            <a:srgbClr val="5B6B73"/>
+                          </a:solidFill>
+                          <a:latin typeface="Calibri" pitchFamily="34" charset="0"/>
+                          <a:ea typeface="Calibri" pitchFamily="34" charset="-122"/>
+                          <a:cs typeface="Calibri" pitchFamily="34" charset="-120"/>
+                        </a:rPr>
+                        <a:t>Projetos</a:t>
+                      </a:r>
+                      <a:endParaRPr lang="en-US" sz="950" dirty="0">
+                        <a:latin typeface="Calibri" charset="0"/>
+                        <a:ea typeface="Calibri" charset="0"/>
+                        <a:cs typeface="Calibri" charset="0"/>
+                      </a:endParaRPr>
+                    </a:p>
+                  </a:txBody>
+                  <a:tcPr marL="91440" marR="91440" marT="45720" marB="45720" anchor="ctr">
+                    <a:lnL w="6350" cap="flat" cmpd="sng" algn="ctr">
+                      <a:solidFill>
+                        <a:srgbClr val="E3E8E9"/>
+                      </a:solidFill>
+                      <a:prstDash val="solid"/>
+                      <a:round/>
+                      <a:headEnd type="none" w="med" len="med"/>
+                      <a:tailEnd type="none" w="med" len="med"/>
+                    </a:lnL>
+                    <a:lnR w="6350" cap="flat" cmpd="sng" algn="ctr">
+                      <a:solidFill>
+                        <a:srgbClr val="E3E8E9"/>
+                      </a:solidFill>
+                      <a:prstDash val="solid"/>
+                      <a:round/>
+                      <a:headEnd type="none" w="med" len="med"/>
+                      <a:tailEnd type="none" w="med" len="med"/>
+                    </a:lnR>
+                    <a:lnT w="6350" cap="flat" cmpd="sng" algn="ctr">
+                      <a:solidFill>
+                        <a:srgbClr val="E3E8E9"/>
+                      </a:solidFill>
+                      <a:prstDash val="solid"/>
+                      <a:round/>
+                      <a:headEnd type="none" w="med" len="med"/>
+                      <a:tailEnd type="none" w="med" len="med"/>
+                    </a:lnT>
+                    <a:lnB w="6350" cap="flat" cmpd="sng" algn="ctr">
+                      <a:solidFill>
+                        <a:srgbClr val="E3E8E9"/>
+                      </a:solidFill>
+                      <a:prstDash val="solid"/>
+                      <a:round/>
+                      <a:headEnd type="none" w="med" len="med"/>
+                      <a:tailEnd type="none" w="med" len="med"/>
+                    </a:lnB>
+                    <a:solidFill>
+                      <a:srgbClr val="FFFFFF"/>
+                    </a:solidFill>
+                  </a:tcPr>
+                </a:tc>
+                <a:tc>
+                  <a:txBody>
+                    <a:bodyPr/>
+                    <a:lstStyle/>
+                    <a:p>
+                      <a:pPr algn="r" indent="0" marL="0">
+                        <a:buNone/>
+                      </a:pPr>
+                      <a:r>
+                        <a:rPr lang="en-US" sz="1000" b="1" dirty="0">
+                          <a:solidFill>
+                            <a:srgbClr val="0B2A3D"/>
+                          </a:solidFill>
+                          <a:latin typeface="Calibri" pitchFamily="34" charset="0"/>
+                          <a:ea typeface="Calibri" pitchFamily="34" charset="-122"/>
+                          <a:cs typeface="Calibri" pitchFamily="34" charset="-120"/>
+                        </a:rPr>
+                        <a:t>US$ 1,3 mi</a:t>
+                      </a:r>
+                      <a:endParaRPr lang="en-US" sz="1000" dirty="0">
+                        <a:latin typeface="Calibri" charset="0"/>
+                        <a:ea typeface="Calibri" charset="0"/>
+                        <a:cs typeface="Calibri" charset="0"/>
+                      </a:endParaRPr>
+                    </a:p>
+                  </a:txBody>
+                  <a:tcPr marL="91440" marR="91440" marT="45720" marB="45720" anchor="ctr">
+                    <a:lnL w="6350" cap="flat" cmpd="sng" algn="ctr">
+                      <a:solidFill>
+                        <a:srgbClr val="E3E8E9"/>
+                      </a:solidFill>
+                      <a:prstDash val="solid"/>
+                      <a:round/>
+                      <a:headEnd type="none" w="med" len="med"/>
+                      <a:tailEnd type="none" w="med" len="med"/>
+                    </a:lnL>
+                    <a:lnR w="6350" cap="flat" cmpd="sng" algn="ctr">
+                      <a:solidFill>
+                        <a:srgbClr val="E3E8E9"/>
+                      </a:solidFill>
+                      <a:prstDash val="solid"/>
+                      <a:round/>
+                      <a:headEnd type="none" w="med" len="med"/>
+                      <a:tailEnd type="none" w="med" len="med"/>
+                    </a:lnR>
+                    <a:lnT w="6350" cap="flat" cmpd="sng" algn="ctr">
+                      <a:solidFill>
+                        <a:srgbClr val="E3E8E9"/>
+                      </a:solidFill>
+                      <a:prstDash val="solid"/>
+                      <a:round/>
+                      <a:headEnd type="none" w="med" len="med"/>
+                      <a:tailEnd type="none" w="med" len="med"/>
+                    </a:lnT>
+                    <a:lnB w="6350" cap="flat" cmpd="sng" algn="ctr">
+                      <a:solidFill>
+                        <a:srgbClr val="E3E8E9"/>
+                      </a:solidFill>
+                      <a:prstDash val="solid"/>
+                      <a:round/>
+                      <a:headEnd type="none" w="med" len="med"/>
+                      <a:tailEnd type="none" w="med" len="med"/>
+                    </a:lnB>
+                    <a:solidFill>
+                      <a:srgbClr val="FFFFFF"/>
+                    </a:solidFill>
+                  </a:tcPr>
+                </a:tc>
+              </a:tr>
+              <a:tr h="288036">
+                <a:tc>
+                  <a:txBody>
+                    <a:bodyPr/>
+                    <a:lstStyle/>
+                    <a:p>
+                      <a:pPr indent="0" marL="0">
+                        <a:buNone/>
+                      </a:pPr>
+                      <a:r>
+                        <a:rPr lang="en-US" sz="1000" dirty="0">
+                          <a:solidFill>
+                            <a:srgbClr val="1C2B33"/>
+                          </a:solidFill>
+                          <a:latin typeface="Calibri" pitchFamily="34" charset="0"/>
+                          <a:ea typeface="Calibri" pitchFamily="34" charset="-122"/>
+                          <a:cs typeface="Calibri" pitchFamily="34" charset="-120"/>
+                        </a:rPr>
+                        <a:t>Combate a Incêndio - Compra e Instalação de Cabines de Dilúvio</a:t>
+                      </a:r>
+                      <a:endParaRPr lang="en-US" sz="1000" dirty="0">
+                        <a:latin typeface="Calibri" charset="0"/>
+                        <a:ea typeface="Calibri" charset="0"/>
+                        <a:cs typeface="Calibri" charset="0"/>
+                      </a:endParaRPr>
+                    </a:p>
+                  </a:txBody>
+                  <a:tcPr marL="91440" marR="91440" marT="45720" marB="45720" anchor="ctr">
+                    <a:lnL w="6350" cap="flat" cmpd="sng" algn="ctr">
+                      <a:solidFill>
+                        <a:srgbClr val="E3E8E9"/>
+                      </a:solidFill>
+                      <a:prstDash val="solid"/>
+                      <a:round/>
+                      <a:headEnd type="none" w="med" len="med"/>
+                      <a:tailEnd type="none" w="med" len="med"/>
+                    </a:lnL>
+                    <a:lnR w="6350" cap="flat" cmpd="sng" algn="ctr">
+                      <a:solidFill>
+                        <a:srgbClr val="E3E8E9"/>
+                      </a:solidFill>
+                      <a:prstDash val="solid"/>
+                      <a:round/>
+                      <a:headEnd type="none" w="med" len="med"/>
+                      <a:tailEnd type="none" w="med" len="med"/>
+                    </a:lnR>
+                    <a:lnT w="6350" cap="flat" cmpd="sng" algn="ctr">
+                      <a:solidFill>
+                        <a:srgbClr val="E3E8E9"/>
+                      </a:solidFill>
+                      <a:prstDash val="solid"/>
+                      <a:round/>
+                      <a:headEnd type="none" w="med" len="med"/>
+                      <a:tailEnd type="none" w="med" len="med"/>
+                    </a:lnT>
+                    <a:lnB w="6350" cap="flat" cmpd="sng" algn="ctr">
+                      <a:solidFill>
+                        <a:srgbClr val="E3E8E9"/>
+                      </a:solidFill>
+                      <a:prstDash val="solid"/>
+                      <a:round/>
+                      <a:headEnd type="none" w="med" len="med"/>
+                      <a:tailEnd type="none" w="med" len="med"/>
+                    </a:lnB>
+                    <a:solidFill>
+                      <a:srgbClr val="F0F4F5"/>
+                    </a:solidFill>
+                  </a:tcPr>
+                </a:tc>
+                <a:tc>
+                  <a:txBody>
+                    <a:bodyPr/>
+                    <a:lstStyle/>
+                    <a:p>
+                      <a:pPr indent="0" marL="0">
+                        <a:buNone/>
+                      </a:pPr>
+                      <a:r>
+                        <a:rPr lang="en-US" sz="950" dirty="0">
+                          <a:solidFill>
+                            <a:srgbClr val="5B6B73"/>
+                          </a:solidFill>
+                          <a:latin typeface="Calibri" pitchFamily="34" charset="0"/>
+                          <a:ea typeface="Calibri" pitchFamily="34" charset="-122"/>
+                          <a:cs typeface="Calibri" pitchFamily="34" charset="-120"/>
+                        </a:rPr>
+                        <a:t>Bem Estar/Segurança</a:t>
+                      </a:r>
+                      <a:endParaRPr lang="en-US" sz="950" dirty="0">
+                        <a:latin typeface="Calibri" charset="0"/>
+                        <a:ea typeface="Calibri" charset="0"/>
+                        <a:cs typeface="Calibri" charset="0"/>
+                      </a:endParaRPr>
+                    </a:p>
+                  </a:txBody>
+                  <a:tcPr marL="91440" marR="91440" marT="45720" marB="45720" anchor="ctr">
+                    <a:lnL w="6350" cap="flat" cmpd="sng" algn="ctr">
+                      <a:solidFill>
+                        <a:srgbClr val="E3E8E9"/>
+                      </a:solidFill>
+                      <a:prstDash val="solid"/>
+                      <a:round/>
+                      <a:headEnd type="none" w="med" len="med"/>
+                      <a:tailEnd type="none" w="med" len="med"/>
+                    </a:lnL>
+                    <a:lnR w="6350" cap="flat" cmpd="sng" algn="ctr">
+                      <a:solidFill>
+                        <a:srgbClr val="E3E8E9"/>
+                      </a:solidFill>
+                      <a:prstDash val="solid"/>
+                      <a:round/>
+                      <a:headEnd type="none" w="med" len="med"/>
+                      <a:tailEnd type="none" w="med" len="med"/>
+                    </a:lnR>
+                    <a:lnT w="6350" cap="flat" cmpd="sng" algn="ctr">
+                      <a:solidFill>
+                        <a:srgbClr val="E3E8E9"/>
+                      </a:solidFill>
+                      <a:prstDash val="solid"/>
+                      <a:round/>
+                      <a:headEnd type="none" w="med" len="med"/>
+                      <a:tailEnd type="none" w="med" len="med"/>
+                    </a:lnT>
+                    <a:lnB w="6350" cap="flat" cmpd="sng" algn="ctr">
+                      <a:solidFill>
+                        <a:srgbClr val="E3E8E9"/>
+                      </a:solidFill>
+                      <a:prstDash val="solid"/>
+                      <a:round/>
+                      <a:headEnd type="none" w="med" len="med"/>
+                      <a:tailEnd type="none" w="med" len="med"/>
+                    </a:lnB>
+                    <a:solidFill>
+                      <a:srgbClr val="F0F4F5"/>
+                    </a:solidFill>
+                  </a:tcPr>
+                </a:tc>
+                <a:tc>
+                  <a:txBody>
+                    <a:bodyPr/>
+                    <a:lstStyle/>
+                    <a:p>
+                      <a:pPr indent="0" marL="0">
+                        <a:buNone/>
+                      </a:pPr>
+                      <a:r>
+                        <a:rPr lang="en-US" sz="950" dirty="0">
+                          <a:solidFill>
+                            <a:srgbClr val="5B6B73"/>
+                          </a:solidFill>
+                          <a:latin typeface="Calibri" pitchFamily="34" charset="0"/>
+                          <a:ea typeface="Calibri" pitchFamily="34" charset="-122"/>
+                          <a:cs typeface="Calibri" pitchFamily="34" charset="-120"/>
+                        </a:rPr>
+                        <a:t>Saúde e Segurança Ocupacional</a:t>
+                      </a:r>
+                      <a:endParaRPr lang="en-US" sz="950" dirty="0">
+                        <a:latin typeface="Calibri" charset="0"/>
+                        <a:ea typeface="Calibri" charset="0"/>
+                        <a:cs typeface="Calibri" charset="0"/>
+                      </a:endParaRPr>
+                    </a:p>
+                  </a:txBody>
+                  <a:tcPr marL="91440" marR="91440" marT="45720" marB="45720" anchor="ctr">
+                    <a:lnL w="6350" cap="flat" cmpd="sng" algn="ctr">
+                      <a:solidFill>
+                        <a:srgbClr val="E3E8E9"/>
+                      </a:solidFill>
+                      <a:prstDash val="solid"/>
+                      <a:round/>
+                      <a:headEnd type="none" w="med" len="med"/>
+                      <a:tailEnd type="none" w="med" len="med"/>
+                    </a:lnL>
+                    <a:lnR w="6350" cap="flat" cmpd="sng" algn="ctr">
+                      <a:solidFill>
+                        <a:srgbClr val="E3E8E9"/>
+                      </a:solidFill>
+                      <a:prstDash val="solid"/>
+                      <a:round/>
+                      <a:headEnd type="none" w="med" len="med"/>
+                      <a:tailEnd type="none" w="med" len="med"/>
+                    </a:lnR>
+                    <a:lnT w="6350" cap="flat" cmpd="sng" algn="ctr">
+                      <a:solidFill>
+                        <a:srgbClr val="E3E8E9"/>
+                      </a:solidFill>
+                      <a:prstDash val="solid"/>
+                      <a:round/>
+                      <a:headEnd type="none" w="med" len="med"/>
+                      <a:tailEnd type="none" w="med" len="med"/>
+                    </a:lnT>
+                    <a:lnB w="6350" cap="flat" cmpd="sng" algn="ctr">
+                      <a:solidFill>
+                        <a:srgbClr val="E3E8E9"/>
+                      </a:solidFill>
+                      <a:prstDash val="solid"/>
+                      <a:round/>
+                      <a:headEnd type="none" w="med" len="med"/>
+                      <a:tailEnd type="none" w="med" len="med"/>
+                    </a:lnB>
+                    <a:solidFill>
+                      <a:srgbClr val="F0F4F5"/>
+                    </a:solidFill>
+                  </a:tcPr>
+                </a:tc>
+                <a:tc>
+                  <a:txBody>
+                    <a:bodyPr/>
+                    <a:lstStyle/>
+                    <a:p>
+                      <a:pPr algn="r" indent="0" marL="0">
+                        <a:buNone/>
+                      </a:pPr>
+                      <a:r>
+                        <a:rPr lang="en-US" sz="1000" b="1" dirty="0">
+                          <a:solidFill>
+                            <a:srgbClr val="0B2A3D"/>
+                          </a:solidFill>
+                          <a:latin typeface="Calibri" pitchFamily="34" charset="0"/>
+                          <a:ea typeface="Calibri" pitchFamily="34" charset="-122"/>
+                          <a:cs typeface="Calibri" pitchFamily="34" charset="-120"/>
+                        </a:rPr>
+                        <a:t>US$ 1,1 mi</a:t>
                       </a:r>
                       <a:endParaRPr lang="en-US" sz="1000" dirty="0">
                         <a:latin typeface="Calibri" charset="0"/>
@@ -31040,7 +31040,7 @@
                           <a:ea typeface="Calibri" pitchFamily="34" charset="-122"/>
                           <a:cs typeface="Calibri" pitchFamily="34" charset="-120"/>
                         </a:rPr>
-                        <a:t>Outros 76 escopos (itens de menor valor individual)</a:t>
+                        <a:t>Outros 77 escopos (itens de menor valor individual)</a:t>
                       </a:r>
                       <a:endParaRPr lang="en-US" sz="950" dirty="0">
                         <a:latin typeface="Calibri" charset="0"/>
@@ -31114,7 +31114,7 @@
                           <a:ea typeface="Calibri" pitchFamily="34" charset="-122"/>
                           <a:cs typeface="Calibri" pitchFamily="34" charset="-120"/>
                         </a:rPr>
-                        <a:t>US$ 23,7 mi</a:t>
+                        <a:t>US$ 17,9 mi</a:t>
                       </a:r>
                       <a:endParaRPr lang="en-US" sz="1000" dirty="0">
                         <a:latin typeface="Calibri" charset="0"/>

</xml_diff>

<commit_message>
Add continuation slide with more FPSO Frade scopes
Novo slide 'Escopos que Compõem o CAPEX · FPSO Frade (continuação)'
logo após a tabela principal, listando mais 15 escopos (itens 13 a
27 por valor) que antes ficavam agregados em 'Outros'. A tabela
principal continua com os 12 maiores; o restante (62 itens) fica
agregado na linha 'Outros' desse novo slide. Soma das duas tabelas +
'Outros' continua batendo exatamente com o CAPEX Total do Frade
(US$ 66,3 mi). Aplica ao deck completo e ao arquivo isolado do Frade.

Co-Authored-By: Claude Sonnet 5 <noreply@anthropic.com>
Claude-Session: https://claude.ai/code/session_01QXLKdFvqaqrRbUKxEFJW9L
</commit_message>
<xml_diff>
--- a/PRIO_Plano_Trabalho_CAPEX_2027.pptx
+++ b/PRIO_Plano_Trabalho_CAPEX_2027.pptx
@@ -28,9 +28,10 @@
     <p:sldId id="276" r:id="rId22"/>
     <p:sldId id="277" r:id="rId23"/>
     <p:sldId id="278" r:id="rId24"/>
+    <p:sldId id="279" r:id="rId25"/>
   </p:sldIdLst>
   <p:notesMasterIdLst>
-    <p:notesMasterId r:id="rId25"/>
+    <p:notesMasterId r:id="rId26"/>
   </p:notesMasterIdLst>
   <p:sldSz cx="12192000" cy="6858000"/>
   <p:notesSz cx="6858000" cy="12192000"/>
@@ -2227,6 +2228,94 @@
 </p:notes>
 </file>
 
+<file path=ppt/notesSlides/notesSlide24.xml><?xml version="1.0" encoding="utf-8"?>
+<p:notes xmlns:a="http://schemas.openxmlformats.org/drawingml/2006/main" xmlns:r="http://schemas.openxmlformats.org/officeDocument/2006/relationships" xmlns:p="http://schemas.openxmlformats.org/presentationml/2006/main">
+  <p:cSld>
+    <p:spTree>
+      <p:nvGrpSpPr>
+        <p:cNvPr id="1" name=""/>
+        <p:cNvGrpSpPr/>
+        <p:nvPr/>
+      </p:nvGrpSpPr>
+      <p:grpSpPr>
+        <a:xfrm>
+          <a:off x="0" y="0"/>
+          <a:ext cx="0" cy="0"/>
+          <a:chOff x="0" y="0"/>
+          <a:chExt cx="0" cy="0"/>
+        </a:xfrm>
+      </p:grpSpPr>
+      <p:sp>
+        <p:nvSpPr>
+          <p:cNvPr id="2" name="Slide Image Placeholder 1"/>
+          <p:cNvSpPr>
+            <a:spLocks noGrp="1" noRot="1" noChangeAspect="1"/>
+          </p:cNvSpPr>
+          <p:nvPr>
+            <p:ph type="sldImg"/>
+          </p:nvPr>
+        </p:nvSpPr>
+        <p:spPr/>
+      </p:sp>
+      <p:sp>
+        <p:nvSpPr>
+          <p:cNvPr id="3" name="Notes Placeholder 2"/>
+          <p:cNvSpPr>
+            <a:spLocks noGrp="1"/>
+          </p:cNvSpPr>
+          <p:nvPr>
+            <p:ph type="body" idx="1"/>
+          </p:nvPr>
+        </p:nvSpPr>
+        <p:spPr/>
+        <p:txBody>
+          <a:bodyPr/>
+          <a:lstStyle/>
+          <a:p>
+            <a:r>
+              <a:rPr lang="en-US" dirty="0"/>
+              <a:t/>
+            </a:r>
+            <a:endParaRPr lang="en-US" dirty="0"/>
+          </a:p>
+        </p:txBody>
+      </p:sp>
+      <p:sp>
+        <p:nvSpPr>
+          <p:cNvPr id="4" name="Slide Number Placeholder 3"/>
+          <p:cNvSpPr>
+            <a:spLocks noGrp="1"/>
+          </p:cNvSpPr>
+          <p:nvPr>
+            <p:ph type="sldNum" sz="quarter" idx="10"/>
+          </p:nvPr>
+        </p:nvSpPr>
+        <p:spPr/>
+        <p:txBody>
+          <a:bodyPr/>
+          <a:lstStyle/>
+          <a:p>
+            <a:fld id="{F7021451-1387-4CA6-816F-3879F97B5CBC}" type="slidenum">
+              <a:rPr lang="en-US"/>
+              <a:t>24</a:t>
+            </a:fld>
+            <a:endParaRPr lang="en-US"/>
+          </a:p>
+        </p:txBody>
+      </p:sp>
+    </p:spTree>
+    <p:extLst>
+      <p:ext uri="{BB962C8B-B14F-4D97-AF65-F5344CB8AC3E}">
+        <p14:creationId xmlns:p14="http://schemas.microsoft.com/office/powerpoint/2010/main" val="1024086991"/>
+      </p:ext>
+    </p:extLst>
+  </p:cSld>
+  <p:clrMapOvr>
+    <a:masterClrMapping/>
+  </p:clrMapOvr>
+</p:notes>
+</file>
+
 <file path=ppt/notesSlides/notesSlide3.xml><?xml version="1.0" encoding="utf-8"?>
 <p:notes xmlns:a="http://schemas.openxmlformats.org/drawingml/2006/main" xmlns:r="http://schemas.openxmlformats.org/officeDocument/2006/relationships" xmlns:p="http://schemas.openxmlformats.org/presentationml/2006/main">
   <p:cSld>
@@ -31217,6 +31306,4767 @@
 </p:sld>
 </file>
 
+<file path=ppt/slides/slide24.xml><?xml version="1.0" encoding="utf-8"?>
+<p:sld xmlns:a="http://schemas.openxmlformats.org/drawingml/2006/main" xmlns:r="http://schemas.openxmlformats.org/officeDocument/2006/relationships" xmlns:p="http://schemas.openxmlformats.org/presentationml/2006/main">
+  <p:cSld name="Slide 24">
+    <p:spTree>
+      <p:nvGrpSpPr>
+        <p:cNvPr id="1" name=""/>
+        <p:cNvGrpSpPr/>
+        <p:nvPr/>
+      </p:nvGrpSpPr>
+      <p:grpSpPr>
+        <a:xfrm>
+          <a:off x="0" y="0"/>
+          <a:ext cx="0" cy="0"/>
+          <a:chOff x="0" y="0"/>
+          <a:chExt cx="0" cy="0"/>
+        </a:xfrm>
+      </p:grpSpPr>
+      <p:sp>
+        <p:nvSpPr>
+          <p:cNvPr id="2" name="Shape 0"/>
+          <p:cNvSpPr/>
+          <p:nvPr/>
+        </p:nvSpPr>
+        <p:spPr>
+          <a:xfrm>
+            <a:off x="457200" y="384048"/>
+            <a:ext cx="566928" cy="566928"/>
+          </a:xfrm>
+          <a:prstGeom prst="ellipse">
+            <a:avLst/>
+          </a:prstGeom>
+          <a:solidFill>
+            <a:srgbClr val="7A2E2E"/>
+          </a:solidFill>
+          <a:ln/>
+        </p:spPr>
+      </p:sp>
+      <p:sp>
+        <p:nvSpPr>
+          <p:cNvPr id="3" name="Text 1"/>
+          <p:cNvSpPr txBox="1"/>
+          <p:nvPr/>
+        </p:nvSpPr>
+        <p:spPr>
+          <a:xfrm>
+            <a:off x="457200" y="384048"/>
+            <a:ext cx="566928" cy="566928"/>
+          </a:xfrm>
+          <a:prstGeom prst="rect">
+            <a:avLst/>
+          </a:prstGeom>
+          <a:noFill/>
+          <a:ln/>
+        </p:spPr>
+        <p:txBody>
+          <a:bodyPr wrap="square" lIns="0" tIns="0" rIns="0" bIns="0" rtlCol="0" anchor="ctr"/>
+          <a:lstStyle/>
+          <a:p>
+            <a:pPr algn="ctr" indent="0" marL="0">
+              <a:buNone/>
+            </a:pPr>
+            <a:r>
+              <a:rPr lang="en-US" sz="1500" b="1" dirty="0">
+                <a:solidFill>
+                  <a:srgbClr val="FFFFFF"/>
+                </a:solidFill>
+                <a:latin typeface="Calibri" pitchFamily="34" charset="0"/>
+                <a:ea typeface="Calibri" pitchFamily="34" charset="-122"/>
+                <a:cs typeface="Calibri" pitchFamily="34" charset="-120"/>
+              </a:rPr>
+              <a:t>FF</a:t>
+            </a:r>
+            <a:endParaRPr lang="en-US" sz="1500" dirty="0"/>
+          </a:p>
+        </p:txBody>
+      </p:sp>
+      <p:sp>
+        <p:nvSpPr>
+          <p:cNvPr id="4" name="Text 2"/>
+          <p:cNvSpPr txBox="1"/>
+          <p:nvPr/>
+        </p:nvSpPr>
+        <p:spPr>
+          <a:xfrm>
+            <a:off x="1170432" y="329184"/>
+            <a:ext cx="10515600" cy="411480"/>
+          </a:xfrm>
+          <a:prstGeom prst="rect">
+            <a:avLst/>
+          </a:prstGeom>
+          <a:noFill/>
+          <a:ln/>
+        </p:spPr>
+        <p:txBody>
+          <a:bodyPr wrap="square" lIns="0" tIns="0" rIns="0" bIns="0" rtlCol="0" anchor="ctr"/>
+          <a:lstStyle/>
+          <a:p>
+            <a:pPr indent="0" marL="0">
+              <a:buNone/>
+            </a:pPr>
+            <a:r>
+              <a:rPr lang="en-US" sz="2400" b="1" dirty="0">
+                <a:solidFill>
+                  <a:srgbClr val="0B2A3D"/>
+                </a:solidFill>
+                <a:latin typeface="Cambria" pitchFamily="34" charset="0"/>
+                <a:ea typeface="Cambria" pitchFamily="34" charset="-122"/>
+                <a:cs typeface="Cambria" pitchFamily="34" charset="-120"/>
+              </a:rPr>
+              <a:t>Escopos que Compõem o CAPEX · FPSO Frade</a:t>
+            </a:r>
+            <a:endParaRPr lang="en-US" sz="2400" dirty="0"/>
+          </a:p>
+        </p:txBody>
+      </p:sp>
+      <p:sp>
+        <p:nvSpPr>
+          <p:cNvPr id="5" name="Text 3"/>
+          <p:cNvSpPr txBox="1"/>
+          <p:nvPr/>
+        </p:nvSpPr>
+        <p:spPr>
+          <a:xfrm>
+            <a:off x="1170432" y="731520"/>
+            <a:ext cx="10515600" cy="274320"/>
+          </a:xfrm>
+          <a:prstGeom prst="rect">
+            <a:avLst/>
+          </a:prstGeom>
+          <a:noFill/>
+          <a:ln/>
+        </p:spPr>
+        <p:txBody>
+          <a:bodyPr wrap="square" lIns="0" tIns="0" rIns="0" bIns="0" rtlCol="0" anchor="ctr"/>
+          <a:lstStyle/>
+          <a:p>
+            <a:pPr indent="0" marL="0">
+              <a:buNone/>
+            </a:pPr>
+            <a:r>
+              <a:rPr lang="en-US" sz="1250" dirty="0">
+                <a:solidFill>
+                  <a:srgbClr val="5B6B73"/>
+                </a:solidFill>
+                <a:latin typeface="Calibri" pitchFamily="34" charset="0"/>
+                <a:ea typeface="Calibri" pitchFamily="34" charset="-122"/>
+                <a:cs typeface="Calibri" pitchFamily="34" charset="-120"/>
+              </a:rPr>
+              <a:t>Continuação · próximos escopos por valor (parte 2)</a:t>
+            </a:r>
+            <a:endParaRPr lang="en-US" sz="1250" dirty="0"/>
+          </a:p>
+        </p:txBody>
+      </p:sp>
+      <p:graphicFrame>
+        <p:nvGraphicFramePr>
+          <p:cNvPr id="25" name="Table 0"/>
+          <p:cNvGraphicFramePr>
+            <a:graphicFrameLocks noGrp="1"/>
+          </p:cNvGraphicFramePr>
+          <p:nvPr>
+            <p:extLst>
+              <p:ext uri="{D42A27DB-BD31-4B8C-83A1-F6EECF244321}">
+                <p14:modId xmlns:p14="http://schemas.microsoft.com/office/powerpoint/2010/main" val="1579011935"/>
+              </p:ext>
+            </p:extLst>
+          </p:nvPr>
+        </p:nvGraphicFramePr>
+        <p:xfrm>
+          <a:off x="457200" y="1188720"/>
+          <a:ext cx="11247120" cy="914400"/>
+        </p:xfrm>
+        <a:graphic>
+          <a:graphicData uri="http://schemas.openxmlformats.org/drawingml/2006/table">
+            <a:tbl>
+              <a:tblPr/>
+              <a:tblGrid>
+                <a:gridCol w="4723790"/>
+                <a:gridCol w="2249424"/>
+                <a:gridCol w="2474366"/>
+                <a:gridCol w="1799539"/>
+              </a:tblGrid>
+              <a:tr h="288036">
+                <a:tc>
+                  <a:txBody>
+                    <a:bodyPr/>
+                    <a:lstStyle/>
+                    <a:p>
+                      <a:pPr indent="0" marL="0">
+                        <a:buNone/>
+                      </a:pPr>
+                      <a:r>
+                        <a:rPr lang="en-US" sz="1000" b="1" dirty="0">
+                          <a:solidFill>
+                            <a:srgbClr val="FFFFFF"/>
+                          </a:solidFill>
+                          <a:latin typeface="Calibri" pitchFamily="34" charset="0"/>
+                          <a:ea typeface="Calibri" pitchFamily="34" charset="-122"/>
+                          <a:cs typeface="Calibri" pitchFamily="34" charset="-120"/>
+                        </a:rPr>
+                        <a:t>DESCRIÇÃO DO ESCOPO</a:t>
+                      </a:r>
+                      <a:endParaRPr lang="en-US" sz="1000" dirty="0">
+                        <a:latin typeface="Calibri" charset="0"/>
+                        <a:ea typeface="Calibri" charset="0"/>
+                        <a:cs typeface="Calibri" charset="0"/>
+                      </a:endParaRPr>
+                    </a:p>
+                  </a:txBody>
+                  <a:tcPr marL="91440" marR="91440" marT="45720" marB="45720" anchor="ctr">
+                    <a:lnL w="6350" cap="flat" cmpd="sng" algn="ctr">
+                      <a:solidFill>
+                        <a:srgbClr val="E3E8E9"/>
+                      </a:solidFill>
+                      <a:prstDash val="solid"/>
+                      <a:round/>
+                      <a:headEnd type="none" w="med" len="med"/>
+                      <a:tailEnd type="none" w="med" len="med"/>
+                    </a:lnL>
+                    <a:lnR w="6350" cap="flat" cmpd="sng" algn="ctr">
+                      <a:solidFill>
+                        <a:srgbClr val="E3E8E9"/>
+                      </a:solidFill>
+                      <a:prstDash val="solid"/>
+                      <a:round/>
+                      <a:headEnd type="none" w="med" len="med"/>
+                      <a:tailEnd type="none" w="med" len="med"/>
+                    </a:lnR>
+                    <a:lnT w="6350" cap="flat" cmpd="sng" algn="ctr">
+                      <a:solidFill>
+                        <a:srgbClr val="E3E8E9"/>
+                      </a:solidFill>
+                      <a:prstDash val="solid"/>
+                      <a:round/>
+                      <a:headEnd type="none" w="med" len="med"/>
+                      <a:tailEnd type="none" w="med" len="med"/>
+                    </a:lnT>
+                    <a:lnB w="6350" cap="flat" cmpd="sng" algn="ctr">
+                      <a:solidFill>
+                        <a:srgbClr val="E3E8E9"/>
+                      </a:solidFill>
+                      <a:prstDash val="solid"/>
+                      <a:round/>
+                      <a:headEnd type="none" w="med" len="med"/>
+                      <a:tailEnd type="none" w="med" len="med"/>
+                    </a:lnB>
+                    <a:solidFill>
+                      <a:srgbClr val="0B2A3D"/>
+                    </a:solidFill>
+                  </a:tcPr>
+                </a:tc>
+                <a:tc>
+                  <a:txBody>
+                    <a:bodyPr/>
+                    <a:lstStyle/>
+                    <a:p>
+                      <a:pPr indent="0" marL="0">
+                        <a:buNone/>
+                      </a:pPr>
+                      <a:r>
+                        <a:rPr lang="en-US" sz="1000" b="1" dirty="0">
+                          <a:solidFill>
+                            <a:srgbClr val="FFFFFF"/>
+                          </a:solidFill>
+                          <a:latin typeface="Calibri" pitchFamily="34" charset="0"/>
+                          <a:ea typeface="Calibri" pitchFamily="34" charset="-122"/>
+                          <a:cs typeface="Calibri" pitchFamily="34" charset="-120"/>
+                        </a:rPr>
+                        <a:t>CATEGORIA</a:t>
+                      </a:r>
+                      <a:endParaRPr lang="en-US" sz="1000" dirty="0">
+                        <a:latin typeface="Calibri" charset="0"/>
+                        <a:ea typeface="Calibri" charset="0"/>
+                        <a:cs typeface="Calibri" charset="0"/>
+                      </a:endParaRPr>
+                    </a:p>
+                  </a:txBody>
+                  <a:tcPr marL="91440" marR="91440" marT="45720" marB="45720" anchor="ctr">
+                    <a:lnL w="6350" cap="flat" cmpd="sng" algn="ctr">
+                      <a:solidFill>
+                        <a:srgbClr val="E3E8E9"/>
+                      </a:solidFill>
+                      <a:prstDash val="solid"/>
+                      <a:round/>
+                      <a:headEnd type="none" w="med" len="med"/>
+                      <a:tailEnd type="none" w="med" len="med"/>
+                    </a:lnL>
+                    <a:lnR w="6350" cap="flat" cmpd="sng" algn="ctr">
+                      <a:solidFill>
+                        <a:srgbClr val="E3E8E9"/>
+                      </a:solidFill>
+                      <a:prstDash val="solid"/>
+                      <a:round/>
+                      <a:headEnd type="none" w="med" len="med"/>
+                      <a:tailEnd type="none" w="med" len="med"/>
+                    </a:lnR>
+                    <a:lnT w="6350" cap="flat" cmpd="sng" algn="ctr">
+                      <a:solidFill>
+                        <a:srgbClr val="E3E8E9"/>
+                      </a:solidFill>
+                      <a:prstDash val="solid"/>
+                      <a:round/>
+                      <a:headEnd type="none" w="med" len="med"/>
+                      <a:tailEnd type="none" w="med" len="med"/>
+                    </a:lnT>
+                    <a:lnB w="6350" cap="flat" cmpd="sng" algn="ctr">
+                      <a:solidFill>
+                        <a:srgbClr val="E3E8E9"/>
+                      </a:solidFill>
+                      <a:prstDash val="solid"/>
+                      <a:round/>
+                      <a:headEnd type="none" w="med" len="med"/>
+                      <a:tailEnd type="none" w="med" len="med"/>
+                    </a:lnB>
+                    <a:solidFill>
+                      <a:srgbClr val="0B2A3D"/>
+                    </a:solidFill>
+                  </a:tcPr>
+                </a:tc>
+                <a:tc>
+                  <a:txBody>
+                    <a:bodyPr/>
+                    <a:lstStyle/>
+                    <a:p>
+                      <a:pPr indent="0" marL="0">
+                        <a:buNone/>
+                      </a:pPr>
+                      <a:r>
+                        <a:rPr lang="en-US" sz="1000" b="1" dirty="0">
+                          <a:solidFill>
+                            <a:srgbClr val="FFFFFF"/>
+                          </a:solidFill>
+                          <a:latin typeface="Calibri" pitchFamily="34" charset="0"/>
+                          <a:ea typeface="Calibri" pitchFamily="34" charset="-122"/>
+                          <a:cs typeface="Calibri" pitchFamily="34" charset="-120"/>
+                        </a:rPr>
+                        <a:t>ÁREA REQUISITANTE</a:t>
+                      </a:r>
+                      <a:endParaRPr lang="en-US" sz="1000" dirty="0">
+                        <a:latin typeface="Calibri" charset="0"/>
+                        <a:ea typeface="Calibri" charset="0"/>
+                        <a:cs typeface="Calibri" charset="0"/>
+                      </a:endParaRPr>
+                    </a:p>
+                  </a:txBody>
+                  <a:tcPr marL="91440" marR="91440" marT="45720" marB="45720" anchor="ctr">
+                    <a:lnL w="6350" cap="flat" cmpd="sng" algn="ctr">
+                      <a:solidFill>
+                        <a:srgbClr val="E3E8E9"/>
+                      </a:solidFill>
+                      <a:prstDash val="solid"/>
+                      <a:round/>
+                      <a:headEnd type="none" w="med" len="med"/>
+                      <a:tailEnd type="none" w="med" len="med"/>
+                    </a:lnL>
+                    <a:lnR w="6350" cap="flat" cmpd="sng" algn="ctr">
+                      <a:solidFill>
+                        <a:srgbClr val="E3E8E9"/>
+                      </a:solidFill>
+                      <a:prstDash val="solid"/>
+                      <a:round/>
+                      <a:headEnd type="none" w="med" len="med"/>
+                      <a:tailEnd type="none" w="med" len="med"/>
+                    </a:lnR>
+                    <a:lnT w="6350" cap="flat" cmpd="sng" algn="ctr">
+                      <a:solidFill>
+                        <a:srgbClr val="E3E8E9"/>
+                      </a:solidFill>
+                      <a:prstDash val="solid"/>
+                      <a:round/>
+                      <a:headEnd type="none" w="med" len="med"/>
+                      <a:tailEnd type="none" w="med" len="med"/>
+                    </a:lnT>
+                    <a:lnB w="6350" cap="flat" cmpd="sng" algn="ctr">
+                      <a:solidFill>
+                        <a:srgbClr val="E3E8E9"/>
+                      </a:solidFill>
+                      <a:prstDash val="solid"/>
+                      <a:round/>
+                      <a:headEnd type="none" w="med" len="med"/>
+                      <a:tailEnd type="none" w="med" len="med"/>
+                    </a:lnB>
+                    <a:solidFill>
+                      <a:srgbClr val="0B2A3D"/>
+                    </a:solidFill>
+                  </a:tcPr>
+                </a:tc>
+                <a:tc>
+                  <a:txBody>
+                    <a:bodyPr/>
+                    <a:lstStyle/>
+                    <a:p>
+                      <a:pPr algn="r" indent="0" marL="0">
+                        <a:buNone/>
+                      </a:pPr>
+                      <a:r>
+                        <a:rPr lang="en-US" sz="1000" b="1" dirty="0">
+                          <a:solidFill>
+                            <a:srgbClr val="FFFFFF"/>
+                          </a:solidFill>
+                          <a:latin typeface="Calibri" pitchFamily="34" charset="0"/>
+                          <a:ea typeface="Calibri" pitchFamily="34" charset="-122"/>
+                          <a:cs typeface="Calibri" pitchFamily="34" charset="-120"/>
+                        </a:rPr>
+                        <a:t>VALOR TOTAL</a:t>
+                      </a:r>
+                      <a:endParaRPr lang="en-US" sz="1000" dirty="0">
+                        <a:latin typeface="Calibri" charset="0"/>
+                        <a:ea typeface="Calibri" charset="0"/>
+                        <a:cs typeface="Calibri" charset="0"/>
+                      </a:endParaRPr>
+                    </a:p>
+                  </a:txBody>
+                  <a:tcPr marL="91440" marR="91440" marT="45720" marB="45720" anchor="ctr">
+                    <a:lnL w="6350" cap="flat" cmpd="sng" algn="ctr">
+                      <a:solidFill>
+                        <a:srgbClr val="E3E8E9"/>
+                      </a:solidFill>
+                      <a:prstDash val="solid"/>
+                      <a:round/>
+                      <a:headEnd type="none" w="med" len="med"/>
+                      <a:tailEnd type="none" w="med" len="med"/>
+                    </a:lnL>
+                    <a:lnR w="6350" cap="flat" cmpd="sng" algn="ctr">
+                      <a:solidFill>
+                        <a:srgbClr val="E3E8E9"/>
+                      </a:solidFill>
+                      <a:prstDash val="solid"/>
+                      <a:round/>
+                      <a:headEnd type="none" w="med" len="med"/>
+                      <a:tailEnd type="none" w="med" len="med"/>
+                    </a:lnR>
+                    <a:lnT w="6350" cap="flat" cmpd="sng" algn="ctr">
+                      <a:solidFill>
+                        <a:srgbClr val="E3E8E9"/>
+                      </a:solidFill>
+                      <a:prstDash val="solid"/>
+                      <a:round/>
+                      <a:headEnd type="none" w="med" len="med"/>
+                      <a:tailEnd type="none" w="med" len="med"/>
+                    </a:lnT>
+                    <a:lnB w="6350" cap="flat" cmpd="sng" algn="ctr">
+                      <a:solidFill>
+                        <a:srgbClr val="E3E8E9"/>
+                      </a:solidFill>
+                      <a:prstDash val="solid"/>
+                      <a:round/>
+                      <a:headEnd type="none" w="med" len="med"/>
+                      <a:tailEnd type="none" w="med" len="med"/>
+                    </a:lnB>
+                    <a:solidFill>
+                      <a:srgbClr val="0B2A3D"/>
+                    </a:solidFill>
+                  </a:tcPr>
+                </a:tc>
+              </a:tr>
+              <a:tr h="288036">
+                <a:tc>
+                  <a:txBody>
+                    <a:bodyPr/>
+                    <a:lstStyle/>
+                    <a:p>
+                      <a:pPr indent="0" marL="0">
+                        <a:buNone/>
+                      </a:pPr>
+                      <a:r>
+                        <a:rPr lang="en-US" sz="1000" dirty="0">
+                          <a:solidFill>
+                            <a:srgbClr val="1C2B33"/>
+                          </a:solidFill>
+                          <a:latin typeface="Calibri" pitchFamily="34" charset="0"/>
+                          <a:ea typeface="Calibri" pitchFamily="34" charset="-122"/>
+                          <a:cs typeface="Calibri" pitchFamily="34" charset="-120"/>
+                        </a:rPr>
+                        <a:t>TROCADOR DE CALOR DO GERADOR - GT4</a:t>
+                      </a:r>
+                      <a:endParaRPr lang="en-US" sz="1000" dirty="0">
+                        <a:latin typeface="Calibri" charset="0"/>
+                        <a:ea typeface="Calibri" charset="0"/>
+                        <a:cs typeface="Calibri" charset="0"/>
+                      </a:endParaRPr>
+                    </a:p>
+                  </a:txBody>
+                  <a:tcPr marL="91440" marR="91440" marT="45720" marB="45720" anchor="ctr">
+                    <a:lnL w="6350" cap="flat" cmpd="sng" algn="ctr">
+                      <a:solidFill>
+                        <a:srgbClr val="E3E8E9"/>
+                      </a:solidFill>
+                      <a:prstDash val="solid"/>
+                      <a:round/>
+                      <a:headEnd type="none" w="med" len="med"/>
+                      <a:tailEnd type="none" w="med" len="med"/>
+                    </a:lnL>
+                    <a:lnR w="6350" cap="flat" cmpd="sng" algn="ctr">
+                      <a:solidFill>
+                        <a:srgbClr val="E3E8E9"/>
+                      </a:solidFill>
+                      <a:prstDash val="solid"/>
+                      <a:round/>
+                      <a:headEnd type="none" w="med" len="med"/>
+                      <a:tailEnd type="none" w="med" len="med"/>
+                    </a:lnR>
+                    <a:lnT w="6350" cap="flat" cmpd="sng" algn="ctr">
+                      <a:solidFill>
+                        <a:srgbClr val="E3E8E9"/>
+                      </a:solidFill>
+                      <a:prstDash val="solid"/>
+                      <a:round/>
+                      <a:headEnd type="none" w="med" len="med"/>
+                      <a:tailEnd type="none" w="med" len="med"/>
+                    </a:lnT>
+                    <a:lnB w="6350" cap="flat" cmpd="sng" algn="ctr">
+                      <a:solidFill>
+                        <a:srgbClr val="E3E8E9"/>
+                      </a:solidFill>
+                      <a:prstDash val="solid"/>
+                      <a:round/>
+                      <a:headEnd type="none" w="med" len="med"/>
+                      <a:tailEnd type="none" w="med" len="med"/>
+                    </a:lnB>
+                    <a:solidFill>
+                      <a:srgbClr val="FFFFFF"/>
+                    </a:solidFill>
+                  </a:tcPr>
+                </a:tc>
+                <a:tc>
+                  <a:txBody>
+                    <a:bodyPr/>
+                    <a:lstStyle/>
+                    <a:p>
+                      <a:pPr indent="0" marL="0">
+                        <a:buNone/>
+                      </a:pPr>
+                      <a:r>
+                        <a:rPr lang="en-US" sz="950" dirty="0">
+                          <a:solidFill>
+                            <a:srgbClr val="5B6B73"/>
+                          </a:solidFill>
+                          <a:latin typeface="Calibri" pitchFamily="34" charset="0"/>
+                          <a:ea typeface="Calibri" pitchFamily="34" charset="-122"/>
+                          <a:cs typeface="Calibri" pitchFamily="34" charset="-120"/>
+                        </a:rPr>
+                        <a:t>Rotina Operacional</a:t>
+                      </a:r>
+                      <a:endParaRPr lang="en-US" sz="950" dirty="0">
+                        <a:latin typeface="Calibri" charset="0"/>
+                        <a:ea typeface="Calibri" charset="0"/>
+                        <a:cs typeface="Calibri" charset="0"/>
+                      </a:endParaRPr>
+                    </a:p>
+                  </a:txBody>
+                  <a:tcPr marL="91440" marR="91440" marT="45720" marB="45720" anchor="ctr">
+                    <a:lnL w="6350" cap="flat" cmpd="sng" algn="ctr">
+                      <a:solidFill>
+                        <a:srgbClr val="E3E8E9"/>
+                      </a:solidFill>
+                      <a:prstDash val="solid"/>
+                      <a:round/>
+                      <a:headEnd type="none" w="med" len="med"/>
+                      <a:tailEnd type="none" w="med" len="med"/>
+                    </a:lnL>
+                    <a:lnR w="6350" cap="flat" cmpd="sng" algn="ctr">
+                      <a:solidFill>
+                        <a:srgbClr val="E3E8E9"/>
+                      </a:solidFill>
+                      <a:prstDash val="solid"/>
+                      <a:round/>
+                      <a:headEnd type="none" w="med" len="med"/>
+                      <a:tailEnd type="none" w="med" len="med"/>
+                    </a:lnR>
+                    <a:lnT w="6350" cap="flat" cmpd="sng" algn="ctr">
+                      <a:solidFill>
+                        <a:srgbClr val="E3E8E9"/>
+                      </a:solidFill>
+                      <a:prstDash val="solid"/>
+                      <a:round/>
+                      <a:headEnd type="none" w="med" len="med"/>
+                      <a:tailEnd type="none" w="med" len="med"/>
+                    </a:lnT>
+                    <a:lnB w="6350" cap="flat" cmpd="sng" algn="ctr">
+                      <a:solidFill>
+                        <a:srgbClr val="E3E8E9"/>
+                      </a:solidFill>
+                      <a:prstDash val="solid"/>
+                      <a:round/>
+                      <a:headEnd type="none" w="med" len="med"/>
+                      <a:tailEnd type="none" w="med" len="med"/>
+                    </a:lnB>
+                    <a:solidFill>
+                      <a:srgbClr val="FFFFFF"/>
+                    </a:solidFill>
+                  </a:tcPr>
+                </a:tc>
+                <a:tc>
+                  <a:txBody>
+                    <a:bodyPr/>
+                    <a:lstStyle/>
+                    <a:p>
+                      <a:pPr indent="0" marL="0">
+                        <a:buNone/>
+                      </a:pPr>
+                      <a:r>
+                        <a:rPr lang="en-US" sz="950" dirty="0">
+                          <a:solidFill>
+                            <a:srgbClr val="5B6B73"/>
+                          </a:solidFill>
+                          <a:latin typeface="Calibri" pitchFamily="34" charset="0"/>
+                          <a:ea typeface="Calibri" pitchFamily="34" charset="-122"/>
+                          <a:cs typeface="Calibri" pitchFamily="34" charset="-120"/>
+                        </a:rPr>
+                        <a:t>MNT – Manutenção</a:t>
+                      </a:r>
+                      <a:endParaRPr lang="en-US" sz="950" dirty="0">
+                        <a:latin typeface="Calibri" charset="0"/>
+                        <a:ea typeface="Calibri" charset="0"/>
+                        <a:cs typeface="Calibri" charset="0"/>
+                      </a:endParaRPr>
+                    </a:p>
+                  </a:txBody>
+                  <a:tcPr marL="91440" marR="91440" marT="45720" marB="45720" anchor="ctr">
+                    <a:lnL w="6350" cap="flat" cmpd="sng" algn="ctr">
+                      <a:solidFill>
+                        <a:srgbClr val="E3E8E9"/>
+                      </a:solidFill>
+                      <a:prstDash val="solid"/>
+                      <a:round/>
+                      <a:headEnd type="none" w="med" len="med"/>
+                      <a:tailEnd type="none" w="med" len="med"/>
+                    </a:lnL>
+                    <a:lnR w="6350" cap="flat" cmpd="sng" algn="ctr">
+                      <a:solidFill>
+                        <a:srgbClr val="E3E8E9"/>
+                      </a:solidFill>
+                      <a:prstDash val="solid"/>
+                      <a:round/>
+                      <a:headEnd type="none" w="med" len="med"/>
+                      <a:tailEnd type="none" w="med" len="med"/>
+                    </a:lnR>
+                    <a:lnT w="6350" cap="flat" cmpd="sng" algn="ctr">
+                      <a:solidFill>
+                        <a:srgbClr val="E3E8E9"/>
+                      </a:solidFill>
+                      <a:prstDash val="solid"/>
+                      <a:round/>
+                      <a:headEnd type="none" w="med" len="med"/>
+                      <a:tailEnd type="none" w="med" len="med"/>
+                    </a:lnT>
+                    <a:lnB w="6350" cap="flat" cmpd="sng" algn="ctr">
+                      <a:solidFill>
+                        <a:srgbClr val="E3E8E9"/>
+                      </a:solidFill>
+                      <a:prstDash val="solid"/>
+                      <a:round/>
+                      <a:headEnd type="none" w="med" len="med"/>
+                      <a:tailEnd type="none" w="med" len="med"/>
+                    </a:lnB>
+                    <a:solidFill>
+                      <a:srgbClr val="FFFFFF"/>
+                    </a:solidFill>
+                  </a:tcPr>
+                </a:tc>
+                <a:tc>
+                  <a:txBody>
+                    <a:bodyPr/>
+                    <a:lstStyle/>
+                    <a:p>
+                      <a:pPr algn="r" indent="0" marL="0">
+                        <a:buNone/>
+                      </a:pPr>
+                      <a:r>
+                        <a:rPr lang="en-US" sz="1000" b="1" dirty="0">
+                          <a:solidFill>
+                            <a:srgbClr val="0B2A3D"/>
+                          </a:solidFill>
+                          <a:latin typeface="Calibri" pitchFamily="34" charset="0"/>
+                          <a:ea typeface="Calibri" pitchFamily="34" charset="-122"/>
+                          <a:cs typeface="Calibri" pitchFamily="34" charset="-120"/>
+                        </a:rPr>
+                        <a:t>US$ 1,1 mi</a:t>
+                      </a:r>
+                      <a:endParaRPr lang="en-US" sz="1000" dirty="0">
+                        <a:latin typeface="Calibri" charset="0"/>
+                        <a:ea typeface="Calibri" charset="0"/>
+                        <a:cs typeface="Calibri" charset="0"/>
+                      </a:endParaRPr>
+                    </a:p>
+                  </a:txBody>
+                  <a:tcPr marL="91440" marR="91440" marT="45720" marB="45720" anchor="ctr">
+                    <a:lnL w="6350" cap="flat" cmpd="sng" algn="ctr">
+                      <a:solidFill>
+                        <a:srgbClr val="E3E8E9"/>
+                      </a:solidFill>
+                      <a:prstDash val="solid"/>
+                      <a:round/>
+                      <a:headEnd type="none" w="med" len="med"/>
+                      <a:tailEnd type="none" w="med" len="med"/>
+                    </a:lnL>
+                    <a:lnR w="6350" cap="flat" cmpd="sng" algn="ctr">
+                      <a:solidFill>
+                        <a:srgbClr val="E3E8E9"/>
+                      </a:solidFill>
+                      <a:prstDash val="solid"/>
+                      <a:round/>
+                      <a:headEnd type="none" w="med" len="med"/>
+                      <a:tailEnd type="none" w="med" len="med"/>
+                    </a:lnR>
+                    <a:lnT w="6350" cap="flat" cmpd="sng" algn="ctr">
+                      <a:solidFill>
+                        <a:srgbClr val="E3E8E9"/>
+                      </a:solidFill>
+                      <a:prstDash val="solid"/>
+                      <a:round/>
+                      <a:headEnd type="none" w="med" len="med"/>
+                      <a:tailEnd type="none" w="med" len="med"/>
+                    </a:lnT>
+                    <a:lnB w="6350" cap="flat" cmpd="sng" algn="ctr">
+                      <a:solidFill>
+                        <a:srgbClr val="E3E8E9"/>
+                      </a:solidFill>
+                      <a:prstDash val="solid"/>
+                      <a:round/>
+                      <a:headEnd type="none" w="med" len="med"/>
+                      <a:tailEnd type="none" w="med" len="med"/>
+                    </a:lnB>
+                    <a:solidFill>
+                      <a:srgbClr val="FFFFFF"/>
+                    </a:solidFill>
+                  </a:tcPr>
+                </a:tc>
+              </a:tr>
+              <a:tr h="288036">
+                <a:tc>
+                  <a:txBody>
+                    <a:bodyPr/>
+                    <a:lstStyle/>
+                    <a:p>
+                      <a:pPr indent="0" marL="0">
+                        <a:buNone/>
+                      </a:pPr>
+                      <a:r>
+                        <a:rPr lang="en-US" sz="1000" dirty="0">
+                          <a:solidFill>
+                            <a:srgbClr val="1C2B33"/>
+                          </a:solidFill>
+                          <a:latin typeface="Calibri" pitchFamily="34" charset="0"/>
+                          <a:ea typeface="Calibri" pitchFamily="34" charset="-122"/>
+                          <a:cs typeface="Calibri" pitchFamily="34" charset="-120"/>
+                        </a:rPr>
+                        <a:t>RO</a:t>
+                      </a:r>
+                      <a:endParaRPr lang="en-US" sz="1000" dirty="0">
+                        <a:latin typeface="Calibri" charset="0"/>
+                        <a:ea typeface="Calibri" charset="0"/>
+                        <a:cs typeface="Calibri" charset="0"/>
+                      </a:endParaRPr>
+                    </a:p>
+                  </a:txBody>
+                  <a:tcPr marL="91440" marR="91440" marT="45720" marB="45720" anchor="ctr">
+                    <a:lnL w="6350" cap="flat" cmpd="sng" algn="ctr">
+                      <a:solidFill>
+                        <a:srgbClr val="E3E8E9"/>
+                      </a:solidFill>
+                      <a:prstDash val="solid"/>
+                      <a:round/>
+                      <a:headEnd type="none" w="med" len="med"/>
+                      <a:tailEnd type="none" w="med" len="med"/>
+                    </a:lnL>
+                    <a:lnR w="6350" cap="flat" cmpd="sng" algn="ctr">
+                      <a:solidFill>
+                        <a:srgbClr val="E3E8E9"/>
+                      </a:solidFill>
+                      <a:prstDash val="solid"/>
+                      <a:round/>
+                      <a:headEnd type="none" w="med" len="med"/>
+                      <a:tailEnd type="none" w="med" len="med"/>
+                    </a:lnR>
+                    <a:lnT w="6350" cap="flat" cmpd="sng" algn="ctr">
+                      <a:solidFill>
+                        <a:srgbClr val="E3E8E9"/>
+                      </a:solidFill>
+                      <a:prstDash val="solid"/>
+                      <a:round/>
+                      <a:headEnd type="none" w="med" len="med"/>
+                      <a:tailEnd type="none" w="med" len="med"/>
+                    </a:lnT>
+                    <a:lnB w="6350" cap="flat" cmpd="sng" algn="ctr">
+                      <a:solidFill>
+                        <a:srgbClr val="E3E8E9"/>
+                      </a:solidFill>
+                      <a:prstDash val="solid"/>
+                      <a:round/>
+                      <a:headEnd type="none" w="med" len="med"/>
+                      <a:tailEnd type="none" w="med" len="med"/>
+                    </a:lnB>
+                    <a:solidFill>
+                      <a:srgbClr val="F0F4F5"/>
+                    </a:solidFill>
+                  </a:tcPr>
+                </a:tc>
+                <a:tc>
+                  <a:txBody>
+                    <a:bodyPr/>
+                    <a:lstStyle/>
+                    <a:p>
+                      <a:pPr indent="0" marL="0">
+                        <a:buNone/>
+                      </a:pPr>
+                      <a:r>
+                        <a:rPr lang="en-US" sz="950" dirty="0">
+                          <a:solidFill>
+                            <a:srgbClr val="5B6B73"/>
+                          </a:solidFill>
+                          <a:latin typeface="Calibri" pitchFamily="34" charset="0"/>
+                          <a:ea typeface="Calibri" pitchFamily="34" charset="-122"/>
+                          <a:cs typeface="Calibri" pitchFamily="34" charset="-120"/>
+                        </a:rPr>
+                        <a:t>Bem Estar/Segurança</a:t>
+                      </a:r>
+                      <a:endParaRPr lang="en-US" sz="950" dirty="0">
+                        <a:latin typeface="Calibri" charset="0"/>
+                        <a:ea typeface="Calibri" charset="0"/>
+                        <a:cs typeface="Calibri" charset="0"/>
+                      </a:endParaRPr>
+                    </a:p>
+                  </a:txBody>
+                  <a:tcPr marL="91440" marR="91440" marT="45720" marB="45720" anchor="ctr">
+                    <a:lnL w="6350" cap="flat" cmpd="sng" algn="ctr">
+                      <a:solidFill>
+                        <a:srgbClr val="E3E8E9"/>
+                      </a:solidFill>
+                      <a:prstDash val="solid"/>
+                      <a:round/>
+                      <a:headEnd type="none" w="med" len="med"/>
+                      <a:tailEnd type="none" w="med" len="med"/>
+                    </a:lnL>
+                    <a:lnR w="6350" cap="flat" cmpd="sng" algn="ctr">
+                      <a:solidFill>
+                        <a:srgbClr val="E3E8E9"/>
+                      </a:solidFill>
+                      <a:prstDash val="solid"/>
+                      <a:round/>
+                      <a:headEnd type="none" w="med" len="med"/>
+                      <a:tailEnd type="none" w="med" len="med"/>
+                    </a:lnR>
+                    <a:lnT w="6350" cap="flat" cmpd="sng" algn="ctr">
+                      <a:solidFill>
+                        <a:srgbClr val="E3E8E9"/>
+                      </a:solidFill>
+                      <a:prstDash val="solid"/>
+                      <a:round/>
+                      <a:headEnd type="none" w="med" len="med"/>
+                      <a:tailEnd type="none" w="med" len="med"/>
+                    </a:lnT>
+                    <a:lnB w="6350" cap="flat" cmpd="sng" algn="ctr">
+                      <a:solidFill>
+                        <a:srgbClr val="E3E8E9"/>
+                      </a:solidFill>
+                      <a:prstDash val="solid"/>
+                      <a:round/>
+                      <a:headEnd type="none" w="med" len="med"/>
+                      <a:tailEnd type="none" w="med" len="med"/>
+                    </a:lnB>
+                    <a:solidFill>
+                      <a:srgbClr val="F0F4F5"/>
+                    </a:solidFill>
+                  </a:tcPr>
+                </a:tc>
+                <a:tc>
+                  <a:txBody>
+                    <a:bodyPr/>
+                    <a:lstStyle/>
+                    <a:p>
+                      <a:pPr indent="0" marL="0">
+                        <a:buNone/>
+                      </a:pPr>
+                      <a:r>
+                        <a:rPr lang="en-US" sz="950" dirty="0">
+                          <a:solidFill>
+                            <a:srgbClr val="5B6B73"/>
+                          </a:solidFill>
+                          <a:latin typeface="Calibri" pitchFamily="34" charset="0"/>
+                          <a:ea typeface="Calibri" pitchFamily="34" charset="-122"/>
+                          <a:cs typeface="Calibri" pitchFamily="34" charset="-120"/>
+                        </a:rPr>
+                        <a:t>Projetos</a:t>
+                      </a:r>
+                      <a:endParaRPr lang="en-US" sz="950" dirty="0">
+                        <a:latin typeface="Calibri" charset="0"/>
+                        <a:ea typeface="Calibri" charset="0"/>
+                        <a:cs typeface="Calibri" charset="0"/>
+                      </a:endParaRPr>
+                    </a:p>
+                  </a:txBody>
+                  <a:tcPr marL="91440" marR="91440" marT="45720" marB="45720" anchor="ctr">
+                    <a:lnL w="6350" cap="flat" cmpd="sng" algn="ctr">
+                      <a:solidFill>
+                        <a:srgbClr val="E3E8E9"/>
+                      </a:solidFill>
+                      <a:prstDash val="solid"/>
+                      <a:round/>
+                      <a:headEnd type="none" w="med" len="med"/>
+                      <a:tailEnd type="none" w="med" len="med"/>
+                    </a:lnL>
+                    <a:lnR w="6350" cap="flat" cmpd="sng" algn="ctr">
+                      <a:solidFill>
+                        <a:srgbClr val="E3E8E9"/>
+                      </a:solidFill>
+                      <a:prstDash val="solid"/>
+                      <a:round/>
+                      <a:headEnd type="none" w="med" len="med"/>
+                      <a:tailEnd type="none" w="med" len="med"/>
+                    </a:lnR>
+                    <a:lnT w="6350" cap="flat" cmpd="sng" algn="ctr">
+                      <a:solidFill>
+                        <a:srgbClr val="E3E8E9"/>
+                      </a:solidFill>
+                      <a:prstDash val="solid"/>
+                      <a:round/>
+                      <a:headEnd type="none" w="med" len="med"/>
+                      <a:tailEnd type="none" w="med" len="med"/>
+                    </a:lnT>
+                    <a:lnB w="6350" cap="flat" cmpd="sng" algn="ctr">
+                      <a:solidFill>
+                        <a:srgbClr val="E3E8E9"/>
+                      </a:solidFill>
+                      <a:prstDash val="solid"/>
+                      <a:round/>
+                      <a:headEnd type="none" w="med" len="med"/>
+                      <a:tailEnd type="none" w="med" len="med"/>
+                    </a:lnB>
+                    <a:solidFill>
+                      <a:srgbClr val="F0F4F5"/>
+                    </a:solidFill>
+                  </a:tcPr>
+                </a:tc>
+                <a:tc>
+                  <a:txBody>
+                    <a:bodyPr/>
+                    <a:lstStyle/>
+                    <a:p>
+                      <a:pPr algn="r" indent="0" marL="0">
+                        <a:buNone/>
+                      </a:pPr>
+                      <a:r>
+                        <a:rPr lang="en-US" sz="1000" b="1" dirty="0">
+                          <a:solidFill>
+                            <a:srgbClr val="0B2A3D"/>
+                          </a:solidFill>
+                          <a:latin typeface="Calibri" pitchFamily="34" charset="0"/>
+                          <a:ea typeface="Calibri" pitchFamily="34" charset="-122"/>
+                          <a:cs typeface="Calibri" pitchFamily="34" charset="-120"/>
+                        </a:rPr>
+                        <a:t>US$ 876,9 mil</a:t>
+                      </a:r>
+                      <a:endParaRPr lang="en-US" sz="1000" dirty="0">
+                        <a:latin typeface="Calibri" charset="0"/>
+                        <a:ea typeface="Calibri" charset="0"/>
+                        <a:cs typeface="Calibri" charset="0"/>
+                      </a:endParaRPr>
+                    </a:p>
+                  </a:txBody>
+                  <a:tcPr marL="91440" marR="91440" marT="45720" marB="45720" anchor="ctr">
+                    <a:lnL w="6350" cap="flat" cmpd="sng" algn="ctr">
+                      <a:solidFill>
+                        <a:srgbClr val="E3E8E9"/>
+                      </a:solidFill>
+                      <a:prstDash val="solid"/>
+                      <a:round/>
+                      <a:headEnd type="none" w="med" len="med"/>
+                      <a:tailEnd type="none" w="med" len="med"/>
+                    </a:lnL>
+                    <a:lnR w="6350" cap="flat" cmpd="sng" algn="ctr">
+                      <a:solidFill>
+                        <a:srgbClr val="E3E8E9"/>
+                      </a:solidFill>
+                      <a:prstDash val="solid"/>
+                      <a:round/>
+                      <a:headEnd type="none" w="med" len="med"/>
+                      <a:tailEnd type="none" w="med" len="med"/>
+                    </a:lnR>
+                    <a:lnT w="6350" cap="flat" cmpd="sng" algn="ctr">
+                      <a:solidFill>
+                        <a:srgbClr val="E3E8E9"/>
+                      </a:solidFill>
+                      <a:prstDash val="solid"/>
+                      <a:round/>
+                      <a:headEnd type="none" w="med" len="med"/>
+                      <a:tailEnd type="none" w="med" len="med"/>
+                    </a:lnT>
+                    <a:lnB w="6350" cap="flat" cmpd="sng" algn="ctr">
+                      <a:solidFill>
+                        <a:srgbClr val="E3E8E9"/>
+                      </a:solidFill>
+                      <a:prstDash val="solid"/>
+                      <a:round/>
+                      <a:headEnd type="none" w="med" len="med"/>
+                      <a:tailEnd type="none" w="med" len="med"/>
+                    </a:lnB>
+                    <a:solidFill>
+                      <a:srgbClr val="F0F4F5"/>
+                    </a:solidFill>
+                  </a:tcPr>
+                </a:tc>
+              </a:tr>
+              <a:tr h="288036">
+                <a:tc>
+                  <a:txBody>
+                    <a:bodyPr/>
+                    <a:lstStyle/>
+                    <a:p>
+                      <a:pPr indent="0" marL="0">
+                        <a:buNone/>
+                      </a:pPr>
+                      <a:r>
+                        <a:rPr lang="en-US" sz="1000" dirty="0">
+                          <a:solidFill>
+                            <a:srgbClr val="1C2B33"/>
+                          </a:solidFill>
+                          <a:latin typeface="Calibri" pitchFamily="34" charset="0"/>
+                          <a:ea typeface="Calibri" pitchFamily="34" charset="-122"/>
+                          <a:cs typeface="Calibri" pitchFamily="34" charset="-120"/>
+                        </a:rPr>
+                        <a:t>Detectores de Chama</a:t>
+                      </a:r>
+                      <a:endParaRPr lang="en-US" sz="1000" dirty="0">
+                        <a:latin typeface="Calibri" charset="0"/>
+                        <a:ea typeface="Calibri" charset="0"/>
+                        <a:cs typeface="Calibri" charset="0"/>
+                      </a:endParaRPr>
+                    </a:p>
+                  </a:txBody>
+                  <a:tcPr marL="91440" marR="91440" marT="45720" marB="45720" anchor="ctr">
+                    <a:lnL w="6350" cap="flat" cmpd="sng" algn="ctr">
+                      <a:solidFill>
+                        <a:srgbClr val="E3E8E9"/>
+                      </a:solidFill>
+                      <a:prstDash val="solid"/>
+                      <a:round/>
+                      <a:headEnd type="none" w="med" len="med"/>
+                      <a:tailEnd type="none" w="med" len="med"/>
+                    </a:lnL>
+                    <a:lnR w="6350" cap="flat" cmpd="sng" algn="ctr">
+                      <a:solidFill>
+                        <a:srgbClr val="E3E8E9"/>
+                      </a:solidFill>
+                      <a:prstDash val="solid"/>
+                      <a:round/>
+                      <a:headEnd type="none" w="med" len="med"/>
+                      <a:tailEnd type="none" w="med" len="med"/>
+                    </a:lnR>
+                    <a:lnT w="6350" cap="flat" cmpd="sng" algn="ctr">
+                      <a:solidFill>
+                        <a:srgbClr val="E3E8E9"/>
+                      </a:solidFill>
+                      <a:prstDash val="solid"/>
+                      <a:round/>
+                      <a:headEnd type="none" w="med" len="med"/>
+                      <a:tailEnd type="none" w="med" len="med"/>
+                    </a:lnT>
+                    <a:lnB w="6350" cap="flat" cmpd="sng" algn="ctr">
+                      <a:solidFill>
+                        <a:srgbClr val="E3E8E9"/>
+                      </a:solidFill>
+                      <a:prstDash val="solid"/>
+                      <a:round/>
+                      <a:headEnd type="none" w="med" len="med"/>
+                      <a:tailEnd type="none" w="med" len="med"/>
+                    </a:lnB>
+                    <a:solidFill>
+                      <a:srgbClr val="FFFFFF"/>
+                    </a:solidFill>
+                  </a:tcPr>
+                </a:tc>
+                <a:tc>
+                  <a:txBody>
+                    <a:bodyPr/>
+                    <a:lstStyle/>
+                    <a:p>
+                      <a:pPr indent="0" marL="0">
+                        <a:buNone/>
+                      </a:pPr>
+                      <a:r>
+                        <a:rPr lang="en-US" sz="950" dirty="0">
+                          <a:solidFill>
+                            <a:srgbClr val="5B6B73"/>
+                          </a:solidFill>
+                          <a:latin typeface="Calibri" pitchFamily="34" charset="0"/>
+                          <a:ea typeface="Calibri" pitchFamily="34" charset="-122"/>
+                          <a:cs typeface="Calibri" pitchFamily="34" charset="-120"/>
+                        </a:rPr>
+                        <a:t>Bem Estar/Segurança</a:t>
+                      </a:r>
+                      <a:endParaRPr lang="en-US" sz="950" dirty="0">
+                        <a:latin typeface="Calibri" charset="0"/>
+                        <a:ea typeface="Calibri" charset="0"/>
+                        <a:cs typeface="Calibri" charset="0"/>
+                      </a:endParaRPr>
+                    </a:p>
+                  </a:txBody>
+                  <a:tcPr marL="91440" marR="91440" marT="45720" marB="45720" anchor="ctr">
+                    <a:lnL w="6350" cap="flat" cmpd="sng" algn="ctr">
+                      <a:solidFill>
+                        <a:srgbClr val="E3E8E9"/>
+                      </a:solidFill>
+                      <a:prstDash val="solid"/>
+                      <a:round/>
+                      <a:headEnd type="none" w="med" len="med"/>
+                      <a:tailEnd type="none" w="med" len="med"/>
+                    </a:lnL>
+                    <a:lnR w="6350" cap="flat" cmpd="sng" algn="ctr">
+                      <a:solidFill>
+                        <a:srgbClr val="E3E8E9"/>
+                      </a:solidFill>
+                      <a:prstDash val="solid"/>
+                      <a:round/>
+                      <a:headEnd type="none" w="med" len="med"/>
+                      <a:tailEnd type="none" w="med" len="med"/>
+                    </a:lnR>
+                    <a:lnT w="6350" cap="flat" cmpd="sng" algn="ctr">
+                      <a:solidFill>
+                        <a:srgbClr val="E3E8E9"/>
+                      </a:solidFill>
+                      <a:prstDash val="solid"/>
+                      <a:round/>
+                      <a:headEnd type="none" w="med" len="med"/>
+                      <a:tailEnd type="none" w="med" len="med"/>
+                    </a:lnT>
+                    <a:lnB w="6350" cap="flat" cmpd="sng" algn="ctr">
+                      <a:solidFill>
+                        <a:srgbClr val="E3E8E9"/>
+                      </a:solidFill>
+                      <a:prstDash val="solid"/>
+                      <a:round/>
+                      <a:headEnd type="none" w="med" len="med"/>
+                      <a:tailEnd type="none" w="med" len="med"/>
+                    </a:lnB>
+                    <a:solidFill>
+                      <a:srgbClr val="FFFFFF"/>
+                    </a:solidFill>
+                  </a:tcPr>
+                </a:tc>
+                <a:tc>
+                  <a:txBody>
+                    <a:bodyPr/>
+                    <a:lstStyle/>
+                    <a:p>
+                      <a:pPr indent="0" marL="0">
+                        <a:buNone/>
+                      </a:pPr>
+                      <a:r>
+                        <a:rPr lang="en-US" sz="950" dirty="0">
+                          <a:solidFill>
+                            <a:srgbClr val="5B6B73"/>
+                          </a:solidFill>
+                          <a:latin typeface="Calibri" pitchFamily="34" charset="0"/>
+                          <a:ea typeface="Calibri" pitchFamily="34" charset="-122"/>
+                          <a:cs typeface="Calibri" pitchFamily="34" charset="-120"/>
+                        </a:rPr>
+                        <a:t>Projetos</a:t>
+                      </a:r>
+                      <a:endParaRPr lang="en-US" sz="950" dirty="0">
+                        <a:latin typeface="Calibri" charset="0"/>
+                        <a:ea typeface="Calibri" charset="0"/>
+                        <a:cs typeface="Calibri" charset="0"/>
+                      </a:endParaRPr>
+                    </a:p>
+                  </a:txBody>
+                  <a:tcPr marL="91440" marR="91440" marT="45720" marB="45720" anchor="ctr">
+                    <a:lnL w="6350" cap="flat" cmpd="sng" algn="ctr">
+                      <a:solidFill>
+                        <a:srgbClr val="E3E8E9"/>
+                      </a:solidFill>
+                      <a:prstDash val="solid"/>
+                      <a:round/>
+                      <a:headEnd type="none" w="med" len="med"/>
+                      <a:tailEnd type="none" w="med" len="med"/>
+                    </a:lnL>
+                    <a:lnR w="6350" cap="flat" cmpd="sng" algn="ctr">
+                      <a:solidFill>
+                        <a:srgbClr val="E3E8E9"/>
+                      </a:solidFill>
+                      <a:prstDash val="solid"/>
+                      <a:round/>
+                      <a:headEnd type="none" w="med" len="med"/>
+                      <a:tailEnd type="none" w="med" len="med"/>
+                    </a:lnR>
+                    <a:lnT w="6350" cap="flat" cmpd="sng" algn="ctr">
+                      <a:solidFill>
+                        <a:srgbClr val="E3E8E9"/>
+                      </a:solidFill>
+                      <a:prstDash val="solid"/>
+                      <a:round/>
+                      <a:headEnd type="none" w="med" len="med"/>
+                      <a:tailEnd type="none" w="med" len="med"/>
+                    </a:lnT>
+                    <a:lnB w="6350" cap="flat" cmpd="sng" algn="ctr">
+                      <a:solidFill>
+                        <a:srgbClr val="E3E8E9"/>
+                      </a:solidFill>
+                      <a:prstDash val="solid"/>
+                      <a:round/>
+                      <a:headEnd type="none" w="med" len="med"/>
+                      <a:tailEnd type="none" w="med" len="med"/>
+                    </a:lnB>
+                    <a:solidFill>
+                      <a:srgbClr val="FFFFFF"/>
+                    </a:solidFill>
+                  </a:tcPr>
+                </a:tc>
+                <a:tc>
+                  <a:txBody>
+                    <a:bodyPr/>
+                    <a:lstStyle/>
+                    <a:p>
+                      <a:pPr algn="r" indent="0" marL="0">
+                        <a:buNone/>
+                      </a:pPr>
+                      <a:r>
+                        <a:rPr lang="en-US" sz="1000" b="1" dirty="0">
+                          <a:solidFill>
+                            <a:srgbClr val="0B2A3D"/>
+                          </a:solidFill>
+                          <a:latin typeface="Calibri" pitchFamily="34" charset="0"/>
+                          <a:ea typeface="Calibri" pitchFamily="34" charset="-122"/>
+                          <a:cs typeface="Calibri" pitchFamily="34" charset="-120"/>
+                        </a:rPr>
+                        <a:t>US$ 826,2 mil</a:t>
+                      </a:r>
+                      <a:endParaRPr lang="en-US" sz="1000" dirty="0">
+                        <a:latin typeface="Calibri" charset="0"/>
+                        <a:ea typeface="Calibri" charset="0"/>
+                        <a:cs typeface="Calibri" charset="0"/>
+                      </a:endParaRPr>
+                    </a:p>
+                  </a:txBody>
+                  <a:tcPr marL="91440" marR="91440" marT="45720" marB="45720" anchor="ctr">
+                    <a:lnL w="6350" cap="flat" cmpd="sng" algn="ctr">
+                      <a:solidFill>
+                        <a:srgbClr val="E3E8E9"/>
+                      </a:solidFill>
+                      <a:prstDash val="solid"/>
+                      <a:round/>
+                      <a:headEnd type="none" w="med" len="med"/>
+                      <a:tailEnd type="none" w="med" len="med"/>
+                    </a:lnL>
+                    <a:lnR w="6350" cap="flat" cmpd="sng" algn="ctr">
+                      <a:solidFill>
+                        <a:srgbClr val="E3E8E9"/>
+                      </a:solidFill>
+                      <a:prstDash val="solid"/>
+                      <a:round/>
+                      <a:headEnd type="none" w="med" len="med"/>
+                      <a:tailEnd type="none" w="med" len="med"/>
+                    </a:lnR>
+                    <a:lnT w="6350" cap="flat" cmpd="sng" algn="ctr">
+                      <a:solidFill>
+                        <a:srgbClr val="E3E8E9"/>
+                      </a:solidFill>
+                      <a:prstDash val="solid"/>
+                      <a:round/>
+                      <a:headEnd type="none" w="med" len="med"/>
+                      <a:tailEnd type="none" w="med" len="med"/>
+                    </a:lnT>
+                    <a:lnB w="6350" cap="flat" cmpd="sng" algn="ctr">
+                      <a:solidFill>
+                        <a:srgbClr val="E3E8E9"/>
+                      </a:solidFill>
+                      <a:prstDash val="solid"/>
+                      <a:round/>
+                      <a:headEnd type="none" w="med" len="med"/>
+                      <a:tailEnd type="none" w="med" len="med"/>
+                    </a:lnB>
+                    <a:solidFill>
+                      <a:srgbClr val="FFFFFF"/>
+                    </a:solidFill>
+                  </a:tcPr>
+                </a:tc>
+              </a:tr>
+              <a:tr h="288036">
+                <a:tc>
+                  <a:txBody>
+                    <a:bodyPr/>
+                    <a:lstStyle/>
+                    <a:p>
+                      <a:pPr indent="0" marL="0">
+                        <a:buNone/>
+                      </a:pPr>
+                      <a:r>
+                        <a:rPr lang="en-US" sz="1000" dirty="0">
+                          <a:solidFill>
+                            <a:srgbClr val="1C2B33"/>
+                          </a:solidFill>
+                          <a:latin typeface="Calibri" pitchFamily="34" charset="0"/>
+                          <a:ea typeface="Calibri" pitchFamily="34" charset="-122"/>
+                          <a:cs typeface="Calibri" pitchFamily="34" charset="-120"/>
+                        </a:rPr>
+                        <a:t>REPARO E INSTALAÇÃO DA PIGGING PUMP</a:t>
+                      </a:r>
+                      <a:endParaRPr lang="en-US" sz="1000" dirty="0">
+                        <a:latin typeface="Calibri" charset="0"/>
+                        <a:ea typeface="Calibri" charset="0"/>
+                        <a:cs typeface="Calibri" charset="0"/>
+                      </a:endParaRPr>
+                    </a:p>
+                  </a:txBody>
+                  <a:tcPr marL="91440" marR="91440" marT="45720" marB="45720" anchor="ctr">
+                    <a:lnL w="6350" cap="flat" cmpd="sng" algn="ctr">
+                      <a:solidFill>
+                        <a:srgbClr val="E3E8E9"/>
+                      </a:solidFill>
+                      <a:prstDash val="solid"/>
+                      <a:round/>
+                      <a:headEnd type="none" w="med" len="med"/>
+                      <a:tailEnd type="none" w="med" len="med"/>
+                    </a:lnL>
+                    <a:lnR w="6350" cap="flat" cmpd="sng" algn="ctr">
+                      <a:solidFill>
+                        <a:srgbClr val="E3E8E9"/>
+                      </a:solidFill>
+                      <a:prstDash val="solid"/>
+                      <a:round/>
+                      <a:headEnd type="none" w="med" len="med"/>
+                      <a:tailEnd type="none" w="med" len="med"/>
+                    </a:lnR>
+                    <a:lnT w="6350" cap="flat" cmpd="sng" algn="ctr">
+                      <a:solidFill>
+                        <a:srgbClr val="E3E8E9"/>
+                      </a:solidFill>
+                      <a:prstDash val="solid"/>
+                      <a:round/>
+                      <a:headEnd type="none" w="med" len="med"/>
+                      <a:tailEnd type="none" w="med" len="med"/>
+                    </a:lnT>
+                    <a:lnB w="6350" cap="flat" cmpd="sng" algn="ctr">
+                      <a:solidFill>
+                        <a:srgbClr val="E3E8E9"/>
+                      </a:solidFill>
+                      <a:prstDash val="solid"/>
+                      <a:round/>
+                      <a:headEnd type="none" w="med" len="med"/>
+                      <a:tailEnd type="none" w="med" len="med"/>
+                    </a:lnB>
+                    <a:solidFill>
+                      <a:srgbClr val="F0F4F5"/>
+                    </a:solidFill>
+                  </a:tcPr>
+                </a:tc>
+                <a:tc>
+                  <a:txBody>
+                    <a:bodyPr/>
+                    <a:lstStyle/>
+                    <a:p>
+                      <a:pPr indent="0" marL="0">
+                        <a:buNone/>
+                      </a:pPr>
+                      <a:r>
+                        <a:rPr lang="en-US" sz="950" dirty="0">
+                          <a:solidFill>
+                            <a:srgbClr val="5B6B73"/>
+                          </a:solidFill>
+                          <a:latin typeface="Calibri" pitchFamily="34" charset="0"/>
+                          <a:ea typeface="Calibri" pitchFamily="34" charset="-122"/>
+                          <a:cs typeface="Calibri" pitchFamily="34" charset="-120"/>
+                        </a:rPr>
+                        <a:t>Eficiência de Produção</a:t>
+                      </a:r>
+                      <a:endParaRPr lang="en-US" sz="950" dirty="0">
+                        <a:latin typeface="Calibri" charset="0"/>
+                        <a:ea typeface="Calibri" charset="0"/>
+                        <a:cs typeface="Calibri" charset="0"/>
+                      </a:endParaRPr>
+                    </a:p>
+                  </a:txBody>
+                  <a:tcPr marL="91440" marR="91440" marT="45720" marB="45720" anchor="ctr">
+                    <a:lnL w="6350" cap="flat" cmpd="sng" algn="ctr">
+                      <a:solidFill>
+                        <a:srgbClr val="E3E8E9"/>
+                      </a:solidFill>
+                      <a:prstDash val="solid"/>
+                      <a:round/>
+                      <a:headEnd type="none" w="med" len="med"/>
+                      <a:tailEnd type="none" w="med" len="med"/>
+                    </a:lnL>
+                    <a:lnR w="6350" cap="flat" cmpd="sng" algn="ctr">
+                      <a:solidFill>
+                        <a:srgbClr val="E3E8E9"/>
+                      </a:solidFill>
+                      <a:prstDash val="solid"/>
+                      <a:round/>
+                      <a:headEnd type="none" w="med" len="med"/>
+                      <a:tailEnd type="none" w="med" len="med"/>
+                    </a:lnR>
+                    <a:lnT w="6350" cap="flat" cmpd="sng" algn="ctr">
+                      <a:solidFill>
+                        <a:srgbClr val="E3E8E9"/>
+                      </a:solidFill>
+                      <a:prstDash val="solid"/>
+                      <a:round/>
+                      <a:headEnd type="none" w="med" len="med"/>
+                      <a:tailEnd type="none" w="med" len="med"/>
+                    </a:lnT>
+                    <a:lnB w="6350" cap="flat" cmpd="sng" algn="ctr">
+                      <a:solidFill>
+                        <a:srgbClr val="E3E8E9"/>
+                      </a:solidFill>
+                      <a:prstDash val="solid"/>
+                      <a:round/>
+                      <a:headEnd type="none" w="med" len="med"/>
+                      <a:tailEnd type="none" w="med" len="med"/>
+                    </a:lnB>
+                    <a:solidFill>
+                      <a:srgbClr val="F0F4F5"/>
+                    </a:solidFill>
+                  </a:tcPr>
+                </a:tc>
+                <a:tc>
+                  <a:txBody>
+                    <a:bodyPr/>
+                    <a:lstStyle/>
+                    <a:p>
+                      <a:pPr indent="0" marL="0">
+                        <a:buNone/>
+                      </a:pPr>
+                      <a:r>
+                        <a:rPr lang="en-US" sz="950" dirty="0">
+                          <a:solidFill>
+                            <a:srgbClr val="5B6B73"/>
+                          </a:solidFill>
+                          <a:latin typeface="Calibri" pitchFamily="34" charset="0"/>
+                          <a:ea typeface="Calibri" pitchFamily="34" charset="-122"/>
+                          <a:cs typeface="Calibri" pitchFamily="34" charset="-120"/>
+                        </a:rPr>
+                        <a:t>MNT – Manutenção</a:t>
+                      </a:r>
+                      <a:endParaRPr lang="en-US" sz="950" dirty="0">
+                        <a:latin typeface="Calibri" charset="0"/>
+                        <a:ea typeface="Calibri" charset="0"/>
+                        <a:cs typeface="Calibri" charset="0"/>
+                      </a:endParaRPr>
+                    </a:p>
+                  </a:txBody>
+                  <a:tcPr marL="91440" marR="91440" marT="45720" marB="45720" anchor="ctr">
+                    <a:lnL w="6350" cap="flat" cmpd="sng" algn="ctr">
+                      <a:solidFill>
+                        <a:srgbClr val="E3E8E9"/>
+                      </a:solidFill>
+                      <a:prstDash val="solid"/>
+                      <a:round/>
+                      <a:headEnd type="none" w="med" len="med"/>
+                      <a:tailEnd type="none" w="med" len="med"/>
+                    </a:lnL>
+                    <a:lnR w="6350" cap="flat" cmpd="sng" algn="ctr">
+                      <a:solidFill>
+                        <a:srgbClr val="E3E8E9"/>
+                      </a:solidFill>
+                      <a:prstDash val="solid"/>
+                      <a:round/>
+                      <a:headEnd type="none" w="med" len="med"/>
+                      <a:tailEnd type="none" w="med" len="med"/>
+                    </a:lnR>
+                    <a:lnT w="6350" cap="flat" cmpd="sng" algn="ctr">
+                      <a:solidFill>
+                        <a:srgbClr val="E3E8E9"/>
+                      </a:solidFill>
+                      <a:prstDash val="solid"/>
+                      <a:round/>
+                      <a:headEnd type="none" w="med" len="med"/>
+                      <a:tailEnd type="none" w="med" len="med"/>
+                    </a:lnT>
+                    <a:lnB w="6350" cap="flat" cmpd="sng" algn="ctr">
+                      <a:solidFill>
+                        <a:srgbClr val="E3E8E9"/>
+                      </a:solidFill>
+                      <a:prstDash val="solid"/>
+                      <a:round/>
+                      <a:headEnd type="none" w="med" len="med"/>
+                      <a:tailEnd type="none" w="med" len="med"/>
+                    </a:lnB>
+                    <a:solidFill>
+                      <a:srgbClr val="F0F4F5"/>
+                    </a:solidFill>
+                  </a:tcPr>
+                </a:tc>
+                <a:tc>
+                  <a:txBody>
+                    <a:bodyPr/>
+                    <a:lstStyle/>
+                    <a:p>
+                      <a:pPr algn="r" indent="0" marL="0">
+                        <a:buNone/>
+                      </a:pPr>
+                      <a:r>
+                        <a:rPr lang="en-US" sz="1000" b="1" dirty="0">
+                          <a:solidFill>
+                            <a:srgbClr val="0B2A3D"/>
+                          </a:solidFill>
+                          <a:latin typeface="Calibri" pitchFamily="34" charset="0"/>
+                          <a:ea typeface="Calibri" pitchFamily="34" charset="-122"/>
+                          <a:cs typeface="Calibri" pitchFamily="34" charset="-120"/>
+                        </a:rPr>
+                        <a:t>US$ 773,5 mil</a:t>
+                      </a:r>
+                      <a:endParaRPr lang="en-US" sz="1000" dirty="0">
+                        <a:latin typeface="Calibri" charset="0"/>
+                        <a:ea typeface="Calibri" charset="0"/>
+                        <a:cs typeface="Calibri" charset="0"/>
+                      </a:endParaRPr>
+                    </a:p>
+                  </a:txBody>
+                  <a:tcPr marL="91440" marR="91440" marT="45720" marB="45720" anchor="ctr">
+                    <a:lnL w="6350" cap="flat" cmpd="sng" algn="ctr">
+                      <a:solidFill>
+                        <a:srgbClr val="E3E8E9"/>
+                      </a:solidFill>
+                      <a:prstDash val="solid"/>
+                      <a:round/>
+                      <a:headEnd type="none" w="med" len="med"/>
+                      <a:tailEnd type="none" w="med" len="med"/>
+                    </a:lnL>
+                    <a:lnR w="6350" cap="flat" cmpd="sng" algn="ctr">
+                      <a:solidFill>
+                        <a:srgbClr val="E3E8E9"/>
+                      </a:solidFill>
+                      <a:prstDash val="solid"/>
+                      <a:round/>
+                      <a:headEnd type="none" w="med" len="med"/>
+                      <a:tailEnd type="none" w="med" len="med"/>
+                    </a:lnR>
+                    <a:lnT w="6350" cap="flat" cmpd="sng" algn="ctr">
+                      <a:solidFill>
+                        <a:srgbClr val="E3E8E9"/>
+                      </a:solidFill>
+                      <a:prstDash val="solid"/>
+                      <a:round/>
+                      <a:headEnd type="none" w="med" len="med"/>
+                      <a:tailEnd type="none" w="med" len="med"/>
+                    </a:lnT>
+                    <a:lnB w="6350" cap="flat" cmpd="sng" algn="ctr">
+                      <a:solidFill>
+                        <a:srgbClr val="E3E8E9"/>
+                      </a:solidFill>
+                      <a:prstDash val="solid"/>
+                      <a:round/>
+                      <a:headEnd type="none" w="med" len="med"/>
+                      <a:tailEnd type="none" w="med" len="med"/>
+                    </a:lnB>
+                    <a:solidFill>
+                      <a:srgbClr val="F0F4F5"/>
+                    </a:solidFill>
+                  </a:tcPr>
+                </a:tc>
+              </a:tr>
+              <a:tr h="288036">
+                <a:tc>
+                  <a:txBody>
+                    <a:bodyPr/>
+                    <a:lstStyle/>
+                    <a:p>
+                      <a:pPr indent="0" marL="0">
+                        <a:buNone/>
+                      </a:pPr>
+                      <a:r>
+                        <a:rPr lang="en-US" sz="1000" dirty="0">
+                          <a:solidFill>
+                            <a:srgbClr val="1C2B33"/>
+                          </a:solidFill>
+                          <a:latin typeface="Calibri" pitchFamily="34" charset="0"/>
+                          <a:ea typeface="Calibri" pitchFamily="34" charset="-122"/>
+                          <a:cs typeface="Calibri" pitchFamily="34" charset="-120"/>
+                        </a:rPr>
+                        <a:t>Combate a Incêndio - Retrofit do sistema fixo de CO2</a:t>
+                      </a:r>
+                      <a:endParaRPr lang="en-US" sz="1000" dirty="0">
+                        <a:latin typeface="Calibri" charset="0"/>
+                        <a:ea typeface="Calibri" charset="0"/>
+                        <a:cs typeface="Calibri" charset="0"/>
+                      </a:endParaRPr>
+                    </a:p>
+                  </a:txBody>
+                  <a:tcPr marL="91440" marR="91440" marT="45720" marB="45720" anchor="ctr">
+                    <a:lnL w="6350" cap="flat" cmpd="sng" algn="ctr">
+                      <a:solidFill>
+                        <a:srgbClr val="E3E8E9"/>
+                      </a:solidFill>
+                      <a:prstDash val="solid"/>
+                      <a:round/>
+                      <a:headEnd type="none" w="med" len="med"/>
+                      <a:tailEnd type="none" w="med" len="med"/>
+                    </a:lnL>
+                    <a:lnR w="6350" cap="flat" cmpd="sng" algn="ctr">
+                      <a:solidFill>
+                        <a:srgbClr val="E3E8E9"/>
+                      </a:solidFill>
+                      <a:prstDash val="solid"/>
+                      <a:round/>
+                      <a:headEnd type="none" w="med" len="med"/>
+                      <a:tailEnd type="none" w="med" len="med"/>
+                    </a:lnR>
+                    <a:lnT w="6350" cap="flat" cmpd="sng" algn="ctr">
+                      <a:solidFill>
+                        <a:srgbClr val="E3E8E9"/>
+                      </a:solidFill>
+                      <a:prstDash val="solid"/>
+                      <a:round/>
+                      <a:headEnd type="none" w="med" len="med"/>
+                      <a:tailEnd type="none" w="med" len="med"/>
+                    </a:lnT>
+                    <a:lnB w="6350" cap="flat" cmpd="sng" algn="ctr">
+                      <a:solidFill>
+                        <a:srgbClr val="E3E8E9"/>
+                      </a:solidFill>
+                      <a:prstDash val="solid"/>
+                      <a:round/>
+                      <a:headEnd type="none" w="med" len="med"/>
+                      <a:tailEnd type="none" w="med" len="med"/>
+                    </a:lnB>
+                    <a:solidFill>
+                      <a:srgbClr val="FFFFFF"/>
+                    </a:solidFill>
+                  </a:tcPr>
+                </a:tc>
+                <a:tc>
+                  <a:txBody>
+                    <a:bodyPr/>
+                    <a:lstStyle/>
+                    <a:p>
+                      <a:pPr indent="0" marL="0">
+                        <a:buNone/>
+                      </a:pPr>
+                      <a:r>
+                        <a:rPr lang="en-US" sz="950" dirty="0">
+                          <a:solidFill>
+                            <a:srgbClr val="5B6B73"/>
+                          </a:solidFill>
+                          <a:latin typeface="Calibri" pitchFamily="34" charset="0"/>
+                          <a:ea typeface="Calibri" pitchFamily="34" charset="-122"/>
+                          <a:cs typeface="Calibri" pitchFamily="34" charset="-120"/>
+                        </a:rPr>
+                        <a:t>Bem Estar/Segurança</a:t>
+                      </a:r>
+                      <a:endParaRPr lang="en-US" sz="950" dirty="0">
+                        <a:latin typeface="Calibri" charset="0"/>
+                        <a:ea typeface="Calibri" charset="0"/>
+                        <a:cs typeface="Calibri" charset="0"/>
+                      </a:endParaRPr>
+                    </a:p>
+                  </a:txBody>
+                  <a:tcPr marL="91440" marR="91440" marT="45720" marB="45720" anchor="ctr">
+                    <a:lnL w="6350" cap="flat" cmpd="sng" algn="ctr">
+                      <a:solidFill>
+                        <a:srgbClr val="E3E8E9"/>
+                      </a:solidFill>
+                      <a:prstDash val="solid"/>
+                      <a:round/>
+                      <a:headEnd type="none" w="med" len="med"/>
+                      <a:tailEnd type="none" w="med" len="med"/>
+                    </a:lnL>
+                    <a:lnR w="6350" cap="flat" cmpd="sng" algn="ctr">
+                      <a:solidFill>
+                        <a:srgbClr val="E3E8E9"/>
+                      </a:solidFill>
+                      <a:prstDash val="solid"/>
+                      <a:round/>
+                      <a:headEnd type="none" w="med" len="med"/>
+                      <a:tailEnd type="none" w="med" len="med"/>
+                    </a:lnR>
+                    <a:lnT w="6350" cap="flat" cmpd="sng" algn="ctr">
+                      <a:solidFill>
+                        <a:srgbClr val="E3E8E9"/>
+                      </a:solidFill>
+                      <a:prstDash val="solid"/>
+                      <a:round/>
+                      <a:headEnd type="none" w="med" len="med"/>
+                      <a:tailEnd type="none" w="med" len="med"/>
+                    </a:lnT>
+                    <a:lnB w="6350" cap="flat" cmpd="sng" algn="ctr">
+                      <a:solidFill>
+                        <a:srgbClr val="E3E8E9"/>
+                      </a:solidFill>
+                      <a:prstDash val="solid"/>
+                      <a:round/>
+                      <a:headEnd type="none" w="med" len="med"/>
+                      <a:tailEnd type="none" w="med" len="med"/>
+                    </a:lnB>
+                    <a:solidFill>
+                      <a:srgbClr val="FFFFFF"/>
+                    </a:solidFill>
+                  </a:tcPr>
+                </a:tc>
+                <a:tc>
+                  <a:txBody>
+                    <a:bodyPr/>
+                    <a:lstStyle/>
+                    <a:p>
+                      <a:pPr indent="0" marL="0">
+                        <a:buNone/>
+                      </a:pPr>
+                      <a:r>
+                        <a:rPr lang="en-US" sz="950" dirty="0">
+                          <a:solidFill>
+                            <a:srgbClr val="5B6B73"/>
+                          </a:solidFill>
+                          <a:latin typeface="Calibri" pitchFamily="34" charset="0"/>
+                          <a:ea typeface="Calibri" pitchFamily="34" charset="-122"/>
+                          <a:cs typeface="Calibri" pitchFamily="34" charset="-120"/>
+                        </a:rPr>
+                        <a:t>Saúde e Segurança Ocupacional</a:t>
+                      </a:r>
+                      <a:endParaRPr lang="en-US" sz="950" dirty="0">
+                        <a:latin typeface="Calibri" charset="0"/>
+                        <a:ea typeface="Calibri" charset="0"/>
+                        <a:cs typeface="Calibri" charset="0"/>
+                      </a:endParaRPr>
+                    </a:p>
+                  </a:txBody>
+                  <a:tcPr marL="91440" marR="91440" marT="45720" marB="45720" anchor="ctr">
+                    <a:lnL w="6350" cap="flat" cmpd="sng" algn="ctr">
+                      <a:solidFill>
+                        <a:srgbClr val="E3E8E9"/>
+                      </a:solidFill>
+                      <a:prstDash val="solid"/>
+                      <a:round/>
+                      <a:headEnd type="none" w="med" len="med"/>
+                      <a:tailEnd type="none" w="med" len="med"/>
+                    </a:lnL>
+                    <a:lnR w="6350" cap="flat" cmpd="sng" algn="ctr">
+                      <a:solidFill>
+                        <a:srgbClr val="E3E8E9"/>
+                      </a:solidFill>
+                      <a:prstDash val="solid"/>
+                      <a:round/>
+                      <a:headEnd type="none" w="med" len="med"/>
+                      <a:tailEnd type="none" w="med" len="med"/>
+                    </a:lnR>
+                    <a:lnT w="6350" cap="flat" cmpd="sng" algn="ctr">
+                      <a:solidFill>
+                        <a:srgbClr val="E3E8E9"/>
+                      </a:solidFill>
+                      <a:prstDash val="solid"/>
+                      <a:round/>
+                      <a:headEnd type="none" w="med" len="med"/>
+                      <a:tailEnd type="none" w="med" len="med"/>
+                    </a:lnT>
+                    <a:lnB w="6350" cap="flat" cmpd="sng" algn="ctr">
+                      <a:solidFill>
+                        <a:srgbClr val="E3E8E9"/>
+                      </a:solidFill>
+                      <a:prstDash val="solid"/>
+                      <a:round/>
+                      <a:headEnd type="none" w="med" len="med"/>
+                      <a:tailEnd type="none" w="med" len="med"/>
+                    </a:lnB>
+                    <a:solidFill>
+                      <a:srgbClr val="FFFFFF"/>
+                    </a:solidFill>
+                  </a:tcPr>
+                </a:tc>
+                <a:tc>
+                  <a:txBody>
+                    <a:bodyPr/>
+                    <a:lstStyle/>
+                    <a:p>
+                      <a:pPr algn="r" indent="0" marL="0">
+                        <a:buNone/>
+                      </a:pPr>
+                      <a:r>
+                        <a:rPr lang="en-US" sz="1000" b="1" dirty="0">
+                          <a:solidFill>
+                            <a:srgbClr val="0B2A3D"/>
+                          </a:solidFill>
+                          <a:latin typeface="Calibri" pitchFamily="34" charset="0"/>
+                          <a:ea typeface="Calibri" pitchFamily="34" charset="-122"/>
+                          <a:cs typeface="Calibri" pitchFamily="34" charset="-120"/>
+                        </a:rPr>
+                        <a:t>US$ 600,0 mil</a:t>
+                      </a:r>
+                      <a:endParaRPr lang="en-US" sz="1000" dirty="0">
+                        <a:latin typeface="Calibri" charset="0"/>
+                        <a:ea typeface="Calibri" charset="0"/>
+                        <a:cs typeface="Calibri" charset="0"/>
+                      </a:endParaRPr>
+                    </a:p>
+                  </a:txBody>
+                  <a:tcPr marL="91440" marR="91440" marT="45720" marB="45720" anchor="ctr">
+                    <a:lnL w="6350" cap="flat" cmpd="sng" algn="ctr">
+                      <a:solidFill>
+                        <a:srgbClr val="E3E8E9"/>
+                      </a:solidFill>
+                      <a:prstDash val="solid"/>
+                      <a:round/>
+                      <a:headEnd type="none" w="med" len="med"/>
+                      <a:tailEnd type="none" w="med" len="med"/>
+                    </a:lnL>
+                    <a:lnR w="6350" cap="flat" cmpd="sng" algn="ctr">
+                      <a:solidFill>
+                        <a:srgbClr val="E3E8E9"/>
+                      </a:solidFill>
+                      <a:prstDash val="solid"/>
+                      <a:round/>
+                      <a:headEnd type="none" w="med" len="med"/>
+                      <a:tailEnd type="none" w="med" len="med"/>
+                    </a:lnR>
+                    <a:lnT w="6350" cap="flat" cmpd="sng" algn="ctr">
+                      <a:solidFill>
+                        <a:srgbClr val="E3E8E9"/>
+                      </a:solidFill>
+                      <a:prstDash val="solid"/>
+                      <a:round/>
+                      <a:headEnd type="none" w="med" len="med"/>
+                      <a:tailEnd type="none" w="med" len="med"/>
+                    </a:lnT>
+                    <a:lnB w="6350" cap="flat" cmpd="sng" algn="ctr">
+                      <a:solidFill>
+                        <a:srgbClr val="E3E8E9"/>
+                      </a:solidFill>
+                      <a:prstDash val="solid"/>
+                      <a:round/>
+                      <a:headEnd type="none" w="med" len="med"/>
+                      <a:tailEnd type="none" w="med" len="med"/>
+                    </a:lnB>
+                    <a:solidFill>
+                      <a:srgbClr val="FFFFFF"/>
+                    </a:solidFill>
+                  </a:tcPr>
+                </a:tc>
+              </a:tr>
+              <a:tr h="288036">
+                <a:tc>
+                  <a:txBody>
+                    <a:bodyPr/>
+                    <a:lstStyle/>
+                    <a:p>
+                      <a:pPr indent="0" marL="0">
+                        <a:buNone/>
+                      </a:pPr>
+                      <a:r>
+                        <a:rPr lang="en-US" sz="1000" dirty="0">
+                          <a:solidFill>
+                            <a:srgbClr val="1C2B33"/>
+                          </a:solidFill>
+                          <a:latin typeface="Calibri" pitchFamily="34" charset="0"/>
+                          <a:ea typeface="Calibri" pitchFamily="34" charset="-122"/>
+                          <a:cs typeface="Calibri" pitchFamily="34" charset="-120"/>
+                        </a:rPr>
+                        <a:t>COMPRA BOMBA DE AMINA</a:t>
+                      </a:r>
+                      <a:endParaRPr lang="en-US" sz="1000" dirty="0">
+                        <a:latin typeface="Calibri" charset="0"/>
+                        <a:ea typeface="Calibri" charset="0"/>
+                        <a:cs typeface="Calibri" charset="0"/>
+                      </a:endParaRPr>
+                    </a:p>
+                  </a:txBody>
+                  <a:tcPr marL="91440" marR="91440" marT="45720" marB="45720" anchor="ctr">
+                    <a:lnL w="6350" cap="flat" cmpd="sng" algn="ctr">
+                      <a:solidFill>
+                        <a:srgbClr val="E3E8E9"/>
+                      </a:solidFill>
+                      <a:prstDash val="solid"/>
+                      <a:round/>
+                      <a:headEnd type="none" w="med" len="med"/>
+                      <a:tailEnd type="none" w="med" len="med"/>
+                    </a:lnL>
+                    <a:lnR w="6350" cap="flat" cmpd="sng" algn="ctr">
+                      <a:solidFill>
+                        <a:srgbClr val="E3E8E9"/>
+                      </a:solidFill>
+                      <a:prstDash val="solid"/>
+                      <a:round/>
+                      <a:headEnd type="none" w="med" len="med"/>
+                      <a:tailEnd type="none" w="med" len="med"/>
+                    </a:lnR>
+                    <a:lnT w="6350" cap="flat" cmpd="sng" algn="ctr">
+                      <a:solidFill>
+                        <a:srgbClr val="E3E8E9"/>
+                      </a:solidFill>
+                      <a:prstDash val="solid"/>
+                      <a:round/>
+                      <a:headEnd type="none" w="med" len="med"/>
+                      <a:tailEnd type="none" w="med" len="med"/>
+                    </a:lnT>
+                    <a:lnB w="6350" cap="flat" cmpd="sng" algn="ctr">
+                      <a:solidFill>
+                        <a:srgbClr val="E3E8E9"/>
+                      </a:solidFill>
+                      <a:prstDash val="solid"/>
+                      <a:round/>
+                      <a:headEnd type="none" w="med" len="med"/>
+                      <a:tailEnd type="none" w="med" len="med"/>
+                    </a:lnB>
+                    <a:solidFill>
+                      <a:srgbClr val="F0F4F5"/>
+                    </a:solidFill>
+                  </a:tcPr>
+                </a:tc>
+                <a:tc>
+                  <a:txBody>
+                    <a:bodyPr/>
+                    <a:lstStyle/>
+                    <a:p>
+                      <a:pPr indent="0" marL="0">
+                        <a:buNone/>
+                      </a:pPr>
+                      <a:r>
+                        <a:rPr lang="en-US" sz="950" dirty="0">
+                          <a:solidFill>
+                            <a:srgbClr val="5B6B73"/>
+                          </a:solidFill>
+                          <a:latin typeface="Calibri" pitchFamily="34" charset="0"/>
+                          <a:ea typeface="Calibri" pitchFamily="34" charset="-122"/>
+                          <a:cs typeface="Calibri" pitchFamily="34" charset="-120"/>
+                        </a:rPr>
+                        <a:t>Rotina Operacional</a:t>
+                      </a:r>
+                      <a:endParaRPr lang="en-US" sz="950" dirty="0">
+                        <a:latin typeface="Calibri" charset="0"/>
+                        <a:ea typeface="Calibri" charset="0"/>
+                        <a:cs typeface="Calibri" charset="0"/>
+                      </a:endParaRPr>
+                    </a:p>
+                  </a:txBody>
+                  <a:tcPr marL="91440" marR="91440" marT="45720" marB="45720" anchor="ctr">
+                    <a:lnL w="6350" cap="flat" cmpd="sng" algn="ctr">
+                      <a:solidFill>
+                        <a:srgbClr val="E3E8E9"/>
+                      </a:solidFill>
+                      <a:prstDash val="solid"/>
+                      <a:round/>
+                      <a:headEnd type="none" w="med" len="med"/>
+                      <a:tailEnd type="none" w="med" len="med"/>
+                    </a:lnL>
+                    <a:lnR w="6350" cap="flat" cmpd="sng" algn="ctr">
+                      <a:solidFill>
+                        <a:srgbClr val="E3E8E9"/>
+                      </a:solidFill>
+                      <a:prstDash val="solid"/>
+                      <a:round/>
+                      <a:headEnd type="none" w="med" len="med"/>
+                      <a:tailEnd type="none" w="med" len="med"/>
+                    </a:lnR>
+                    <a:lnT w="6350" cap="flat" cmpd="sng" algn="ctr">
+                      <a:solidFill>
+                        <a:srgbClr val="E3E8E9"/>
+                      </a:solidFill>
+                      <a:prstDash val="solid"/>
+                      <a:round/>
+                      <a:headEnd type="none" w="med" len="med"/>
+                      <a:tailEnd type="none" w="med" len="med"/>
+                    </a:lnT>
+                    <a:lnB w="6350" cap="flat" cmpd="sng" algn="ctr">
+                      <a:solidFill>
+                        <a:srgbClr val="E3E8E9"/>
+                      </a:solidFill>
+                      <a:prstDash val="solid"/>
+                      <a:round/>
+                      <a:headEnd type="none" w="med" len="med"/>
+                      <a:tailEnd type="none" w="med" len="med"/>
+                    </a:lnB>
+                    <a:solidFill>
+                      <a:srgbClr val="F0F4F5"/>
+                    </a:solidFill>
+                  </a:tcPr>
+                </a:tc>
+                <a:tc>
+                  <a:txBody>
+                    <a:bodyPr/>
+                    <a:lstStyle/>
+                    <a:p>
+                      <a:pPr indent="0" marL="0">
+                        <a:buNone/>
+                      </a:pPr>
+                      <a:r>
+                        <a:rPr lang="en-US" sz="950" dirty="0">
+                          <a:solidFill>
+                            <a:srgbClr val="5B6B73"/>
+                          </a:solidFill>
+                          <a:latin typeface="Calibri" pitchFamily="34" charset="0"/>
+                          <a:ea typeface="Calibri" pitchFamily="34" charset="-122"/>
+                          <a:cs typeface="Calibri" pitchFamily="34" charset="-120"/>
+                        </a:rPr>
+                        <a:t>MNT – Manutenção</a:t>
+                      </a:r>
+                      <a:endParaRPr lang="en-US" sz="950" dirty="0">
+                        <a:latin typeface="Calibri" charset="0"/>
+                        <a:ea typeface="Calibri" charset="0"/>
+                        <a:cs typeface="Calibri" charset="0"/>
+                      </a:endParaRPr>
+                    </a:p>
+                  </a:txBody>
+                  <a:tcPr marL="91440" marR="91440" marT="45720" marB="45720" anchor="ctr">
+                    <a:lnL w="6350" cap="flat" cmpd="sng" algn="ctr">
+                      <a:solidFill>
+                        <a:srgbClr val="E3E8E9"/>
+                      </a:solidFill>
+                      <a:prstDash val="solid"/>
+                      <a:round/>
+                      <a:headEnd type="none" w="med" len="med"/>
+                      <a:tailEnd type="none" w="med" len="med"/>
+                    </a:lnL>
+                    <a:lnR w="6350" cap="flat" cmpd="sng" algn="ctr">
+                      <a:solidFill>
+                        <a:srgbClr val="E3E8E9"/>
+                      </a:solidFill>
+                      <a:prstDash val="solid"/>
+                      <a:round/>
+                      <a:headEnd type="none" w="med" len="med"/>
+                      <a:tailEnd type="none" w="med" len="med"/>
+                    </a:lnR>
+                    <a:lnT w="6350" cap="flat" cmpd="sng" algn="ctr">
+                      <a:solidFill>
+                        <a:srgbClr val="E3E8E9"/>
+                      </a:solidFill>
+                      <a:prstDash val="solid"/>
+                      <a:round/>
+                      <a:headEnd type="none" w="med" len="med"/>
+                      <a:tailEnd type="none" w="med" len="med"/>
+                    </a:lnT>
+                    <a:lnB w="6350" cap="flat" cmpd="sng" algn="ctr">
+                      <a:solidFill>
+                        <a:srgbClr val="E3E8E9"/>
+                      </a:solidFill>
+                      <a:prstDash val="solid"/>
+                      <a:round/>
+                      <a:headEnd type="none" w="med" len="med"/>
+                      <a:tailEnd type="none" w="med" len="med"/>
+                    </a:lnB>
+                    <a:solidFill>
+                      <a:srgbClr val="F0F4F5"/>
+                    </a:solidFill>
+                  </a:tcPr>
+                </a:tc>
+                <a:tc>
+                  <a:txBody>
+                    <a:bodyPr/>
+                    <a:lstStyle/>
+                    <a:p>
+                      <a:pPr algn="r" indent="0" marL="0">
+                        <a:buNone/>
+                      </a:pPr>
+                      <a:r>
+                        <a:rPr lang="en-US" sz="1000" b="1" dirty="0">
+                          <a:solidFill>
+                            <a:srgbClr val="0B2A3D"/>
+                          </a:solidFill>
+                          <a:latin typeface="Calibri" pitchFamily="34" charset="0"/>
+                          <a:ea typeface="Calibri" pitchFamily="34" charset="-122"/>
+                          <a:cs typeface="Calibri" pitchFamily="34" charset="-120"/>
+                        </a:rPr>
+                        <a:t>US$ 600,0 mil</a:t>
+                      </a:r>
+                      <a:endParaRPr lang="en-US" sz="1000" dirty="0">
+                        <a:latin typeface="Calibri" charset="0"/>
+                        <a:ea typeface="Calibri" charset="0"/>
+                        <a:cs typeface="Calibri" charset="0"/>
+                      </a:endParaRPr>
+                    </a:p>
+                  </a:txBody>
+                  <a:tcPr marL="91440" marR="91440" marT="45720" marB="45720" anchor="ctr">
+                    <a:lnL w="6350" cap="flat" cmpd="sng" algn="ctr">
+                      <a:solidFill>
+                        <a:srgbClr val="E3E8E9"/>
+                      </a:solidFill>
+                      <a:prstDash val="solid"/>
+                      <a:round/>
+                      <a:headEnd type="none" w="med" len="med"/>
+                      <a:tailEnd type="none" w="med" len="med"/>
+                    </a:lnL>
+                    <a:lnR w="6350" cap="flat" cmpd="sng" algn="ctr">
+                      <a:solidFill>
+                        <a:srgbClr val="E3E8E9"/>
+                      </a:solidFill>
+                      <a:prstDash val="solid"/>
+                      <a:round/>
+                      <a:headEnd type="none" w="med" len="med"/>
+                      <a:tailEnd type="none" w="med" len="med"/>
+                    </a:lnR>
+                    <a:lnT w="6350" cap="flat" cmpd="sng" algn="ctr">
+                      <a:solidFill>
+                        <a:srgbClr val="E3E8E9"/>
+                      </a:solidFill>
+                      <a:prstDash val="solid"/>
+                      <a:round/>
+                      <a:headEnd type="none" w="med" len="med"/>
+                      <a:tailEnd type="none" w="med" len="med"/>
+                    </a:lnT>
+                    <a:lnB w="6350" cap="flat" cmpd="sng" algn="ctr">
+                      <a:solidFill>
+                        <a:srgbClr val="E3E8E9"/>
+                      </a:solidFill>
+                      <a:prstDash val="solid"/>
+                      <a:round/>
+                      <a:headEnd type="none" w="med" len="med"/>
+                      <a:tailEnd type="none" w="med" len="med"/>
+                    </a:lnB>
+                    <a:solidFill>
+                      <a:srgbClr val="F0F4F5"/>
+                    </a:solidFill>
+                  </a:tcPr>
+                </a:tc>
+              </a:tr>
+              <a:tr h="288036">
+                <a:tc>
+                  <a:txBody>
+                    <a:bodyPr/>
+                    <a:lstStyle/>
+                    <a:p>
+                      <a:pPr indent="0" marL="0">
+                        <a:buNone/>
+                      </a:pPr>
+                      <a:r>
+                        <a:rPr lang="en-US" sz="1000" dirty="0">
+                          <a:solidFill>
+                            <a:srgbClr val="1C2B33"/>
+                          </a:solidFill>
+                          <a:latin typeface="Calibri" pitchFamily="34" charset="0"/>
+                          <a:ea typeface="Calibri" pitchFamily="34" charset="-122"/>
+                          <a:cs typeface="Calibri" pitchFamily="34" charset="-120"/>
+                        </a:rPr>
+                        <a:t>Revamp SWRO A: Recuperação do sistema de WW</a:t>
+                      </a:r>
+                      <a:endParaRPr lang="en-US" sz="1000" dirty="0">
+                        <a:latin typeface="Calibri" charset="0"/>
+                        <a:ea typeface="Calibri" charset="0"/>
+                        <a:cs typeface="Calibri" charset="0"/>
+                      </a:endParaRPr>
+                    </a:p>
+                  </a:txBody>
+                  <a:tcPr marL="91440" marR="91440" marT="45720" marB="45720" anchor="ctr">
+                    <a:lnL w="6350" cap="flat" cmpd="sng" algn="ctr">
+                      <a:solidFill>
+                        <a:srgbClr val="E3E8E9"/>
+                      </a:solidFill>
+                      <a:prstDash val="solid"/>
+                      <a:round/>
+                      <a:headEnd type="none" w="med" len="med"/>
+                      <a:tailEnd type="none" w="med" len="med"/>
+                    </a:lnL>
+                    <a:lnR w="6350" cap="flat" cmpd="sng" algn="ctr">
+                      <a:solidFill>
+                        <a:srgbClr val="E3E8E9"/>
+                      </a:solidFill>
+                      <a:prstDash val="solid"/>
+                      <a:round/>
+                      <a:headEnd type="none" w="med" len="med"/>
+                      <a:tailEnd type="none" w="med" len="med"/>
+                    </a:lnR>
+                    <a:lnT w="6350" cap="flat" cmpd="sng" algn="ctr">
+                      <a:solidFill>
+                        <a:srgbClr val="E3E8E9"/>
+                      </a:solidFill>
+                      <a:prstDash val="solid"/>
+                      <a:round/>
+                      <a:headEnd type="none" w="med" len="med"/>
+                      <a:tailEnd type="none" w="med" len="med"/>
+                    </a:lnT>
+                    <a:lnB w="6350" cap="flat" cmpd="sng" algn="ctr">
+                      <a:solidFill>
+                        <a:srgbClr val="E3E8E9"/>
+                      </a:solidFill>
+                      <a:prstDash val="solid"/>
+                      <a:round/>
+                      <a:headEnd type="none" w="med" len="med"/>
+                      <a:tailEnd type="none" w="med" len="med"/>
+                    </a:lnB>
+                    <a:solidFill>
+                      <a:srgbClr val="FFFFFF"/>
+                    </a:solidFill>
+                  </a:tcPr>
+                </a:tc>
+                <a:tc>
+                  <a:txBody>
+                    <a:bodyPr/>
+                    <a:lstStyle/>
+                    <a:p>
+                      <a:pPr indent="0" marL="0">
+                        <a:buNone/>
+                      </a:pPr>
+                      <a:r>
+                        <a:rPr lang="en-US" sz="950" dirty="0">
+                          <a:solidFill>
+                            <a:srgbClr val="5B6B73"/>
+                          </a:solidFill>
+                          <a:latin typeface="Calibri" pitchFamily="34" charset="0"/>
+                          <a:ea typeface="Calibri" pitchFamily="34" charset="-122"/>
+                          <a:cs typeface="Calibri" pitchFamily="34" charset="-120"/>
+                        </a:rPr>
+                        <a:t>Eficiência de Produção</a:t>
+                      </a:r>
+                      <a:endParaRPr lang="en-US" sz="950" dirty="0">
+                        <a:latin typeface="Calibri" charset="0"/>
+                        <a:ea typeface="Calibri" charset="0"/>
+                        <a:cs typeface="Calibri" charset="0"/>
+                      </a:endParaRPr>
+                    </a:p>
+                  </a:txBody>
+                  <a:tcPr marL="91440" marR="91440" marT="45720" marB="45720" anchor="ctr">
+                    <a:lnL w="6350" cap="flat" cmpd="sng" algn="ctr">
+                      <a:solidFill>
+                        <a:srgbClr val="E3E8E9"/>
+                      </a:solidFill>
+                      <a:prstDash val="solid"/>
+                      <a:round/>
+                      <a:headEnd type="none" w="med" len="med"/>
+                      <a:tailEnd type="none" w="med" len="med"/>
+                    </a:lnL>
+                    <a:lnR w="6350" cap="flat" cmpd="sng" algn="ctr">
+                      <a:solidFill>
+                        <a:srgbClr val="E3E8E9"/>
+                      </a:solidFill>
+                      <a:prstDash val="solid"/>
+                      <a:round/>
+                      <a:headEnd type="none" w="med" len="med"/>
+                      <a:tailEnd type="none" w="med" len="med"/>
+                    </a:lnR>
+                    <a:lnT w="6350" cap="flat" cmpd="sng" algn="ctr">
+                      <a:solidFill>
+                        <a:srgbClr val="E3E8E9"/>
+                      </a:solidFill>
+                      <a:prstDash val="solid"/>
+                      <a:round/>
+                      <a:headEnd type="none" w="med" len="med"/>
+                      <a:tailEnd type="none" w="med" len="med"/>
+                    </a:lnT>
+                    <a:lnB w="6350" cap="flat" cmpd="sng" algn="ctr">
+                      <a:solidFill>
+                        <a:srgbClr val="E3E8E9"/>
+                      </a:solidFill>
+                      <a:prstDash val="solid"/>
+                      <a:round/>
+                      <a:headEnd type="none" w="med" len="med"/>
+                      <a:tailEnd type="none" w="med" len="med"/>
+                    </a:lnB>
+                    <a:solidFill>
+                      <a:srgbClr val="FFFFFF"/>
+                    </a:solidFill>
+                  </a:tcPr>
+                </a:tc>
+                <a:tc>
+                  <a:txBody>
+                    <a:bodyPr/>
+                    <a:lstStyle/>
+                    <a:p>
+                      <a:pPr indent="0" marL="0">
+                        <a:buNone/>
+                      </a:pPr>
+                      <a:r>
+                        <a:rPr lang="en-US" sz="950" dirty="0">
+                          <a:solidFill>
+                            <a:srgbClr val="5B6B73"/>
+                          </a:solidFill>
+                          <a:latin typeface="Calibri" pitchFamily="34" charset="0"/>
+                          <a:ea typeface="Calibri" pitchFamily="34" charset="-122"/>
+                          <a:cs typeface="Calibri" pitchFamily="34" charset="-120"/>
+                        </a:rPr>
+                        <a:t>P&amp;Q - Processos</a:t>
+                      </a:r>
+                      <a:endParaRPr lang="en-US" sz="950" dirty="0">
+                        <a:latin typeface="Calibri" charset="0"/>
+                        <a:ea typeface="Calibri" charset="0"/>
+                        <a:cs typeface="Calibri" charset="0"/>
+                      </a:endParaRPr>
+                    </a:p>
+                  </a:txBody>
+                  <a:tcPr marL="91440" marR="91440" marT="45720" marB="45720" anchor="ctr">
+                    <a:lnL w="6350" cap="flat" cmpd="sng" algn="ctr">
+                      <a:solidFill>
+                        <a:srgbClr val="E3E8E9"/>
+                      </a:solidFill>
+                      <a:prstDash val="solid"/>
+                      <a:round/>
+                      <a:headEnd type="none" w="med" len="med"/>
+                      <a:tailEnd type="none" w="med" len="med"/>
+                    </a:lnL>
+                    <a:lnR w="6350" cap="flat" cmpd="sng" algn="ctr">
+                      <a:solidFill>
+                        <a:srgbClr val="E3E8E9"/>
+                      </a:solidFill>
+                      <a:prstDash val="solid"/>
+                      <a:round/>
+                      <a:headEnd type="none" w="med" len="med"/>
+                      <a:tailEnd type="none" w="med" len="med"/>
+                    </a:lnR>
+                    <a:lnT w="6350" cap="flat" cmpd="sng" algn="ctr">
+                      <a:solidFill>
+                        <a:srgbClr val="E3E8E9"/>
+                      </a:solidFill>
+                      <a:prstDash val="solid"/>
+                      <a:round/>
+                      <a:headEnd type="none" w="med" len="med"/>
+                      <a:tailEnd type="none" w="med" len="med"/>
+                    </a:lnT>
+                    <a:lnB w="6350" cap="flat" cmpd="sng" algn="ctr">
+                      <a:solidFill>
+                        <a:srgbClr val="E3E8E9"/>
+                      </a:solidFill>
+                      <a:prstDash val="solid"/>
+                      <a:round/>
+                      <a:headEnd type="none" w="med" len="med"/>
+                      <a:tailEnd type="none" w="med" len="med"/>
+                    </a:lnB>
+                    <a:solidFill>
+                      <a:srgbClr val="FFFFFF"/>
+                    </a:solidFill>
+                  </a:tcPr>
+                </a:tc>
+                <a:tc>
+                  <a:txBody>
+                    <a:bodyPr/>
+                    <a:lstStyle/>
+                    <a:p>
+                      <a:pPr algn="r" indent="0" marL="0">
+                        <a:buNone/>
+                      </a:pPr>
+                      <a:r>
+                        <a:rPr lang="en-US" sz="1000" b="1" dirty="0">
+                          <a:solidFill>
+                            <a:srgbClr val="0B2A3D"/>
+                          </a:solidFill>
+                          <a:latin typeface="Calibri" pitchFamily="34" charset="0"/>
+                          <a:ea typeface="Calibri" pitchFamily="34" charset="-122"/>
+                          <a:cs typeface="Calibri" pitchFamily="34" charset="-120"/>
+                        </a:rPr>
+                        <a:t>US$ 571,9 mil</a:t>
+                      </a:r>
+                      <a:endParaRPr lang="en-US" sz="1000" dirty="0">
+                        <a:latin typeface="Calibri" charset="0"/>
+                        <a:ea typeface="Calibri" charset="0"/>
+                        <a:cs typeface="Calibri" charset="0"/>
+                      </a:endParaRPr>
+                    </a:p>
+                  </a:txBody>
+                  <a:tcPr marL="91440" marR="91440" marT="45720" marB="45720" anchor="ctr">
+                    <a:lnL w="6350" cap="flat" cmpd="sng" algn="ctr">
+                      <a:solidFill>
+                        <a:srgbClr val="E3E8E9"/>
+                      </a:solidFill>
+                      <a:prstDash val="solid"/>
+                      <a:round/>
+                      <a:headEnd type="none" w="med" len="med"/>
+                      <a:tailEnd type="none" w="med" len="med"/>
+                    </a:lnL>
+                    <a:lnR w="6350" cap="flat" cmpd="sng" algn="ctr">
+                      <a:solidFill>
+                        <a:srgbClr val="E3E8E9"/>
+                      </a:solidFill>
+                      <a:prstDash val="solid"/>
+                      <a:round/>
+                      <a:headEnd type="none" w="med" len="med"/>
+                      <a:tailEnd type="none" w="med" len="med"/>
+                    </a:lnR>
+                    <a:lnT w="6350" cap="flat" cmpd="sng" algn="ctr">
+                      <a:solidFill>
+                        <a:srgbClr val="E3E8E9"/>
+                      </a:solidFill>
+                      <a:prstDash val="solid"/>
+                      <a:round/>
+                      <a:headEnd type="none" w="med" len="med"/>
+                      <a:tailEnd type="none" w="med" len="med"/>
+                    </a:lnT>
+                    <a:lnB w="6350" cap="flat" cmpd="sng" algn="ctr">
+                      <a:solidFill>
+                        <a:srgbClr val="E3E8E9"/>
+                      </a:solidFill>
+                      <a:prstDash val="solid"/>
+                      <a:round/>
+                      <a:headEnd type="none" w="med" len="med"/>
+                      <a:tailEnd type="none" w="med" len="med"/>
+                    </a:lnB>
+                    <a:solidFill>
+                      <a:srgbClr val="FFFFFF"/>
+                    </a:solidFill>
+                  </a:tcPr>
+                </a:tc>
+              </a:tr>
+              <a:tr h="288036">
+                <a:tc>
+                  <a:txBody>
+                    <a:bodyPr/>
+                    <a:lstStyle/>
+                    <a:p>
+                      <a:pPr indent="0" marL="0">
+                        <a:buNone/>
+                      </a:pPr>
+                      <a:r>
+                        <a:rPr lang="en-US" sz="1000" dirty="0">
+                          <a:solidFill>
+                            <a:srgbClr val="1C2B33"/>
+                          </a:solidFill>
+                          <a:latin typeface="Calibri" pitchFamily="34" charset="0"/>
+                          <a:ea typeface="Calibri" pitchFamily="34" charset="-122"/>
+                          <a:cs typeface="Calibri" pitchFamily="34" charset="-120"/>
+                        </a:rPr>
+                        <a:t>TBM - Junta de expansão exhaust - TURBINAS</a:t>
+                      </a:r>
+                      <a:endParaRPr lang="en-US" sz="1000" dirty="0">
+                        <a:latin typeface="Calibri" charset="0"/>
+                        <a:ea typeface="Calibri" charset="0"/>
+                        <a:cs typeface="Calibri" charset="0"/>
+                      </a:endParaRPr>
+                    </a:p>
+                  </a:txBody>
+                  <a:tcPr marL="91440" marR="91440" marT="45720" marB="45720" anchor="ctr">
+                    <a:lnL w="6350" cap="flat" cmpd="sng" algn="ctr">
+                      <a:solidFill>
+                        <a:srgbClr val="E3E8E9"/>
+                      </a:solidFill>
+                      <a:prstDash val="solid"/>
+                      <a:round/>
+                      <a:headEnd type="none" w="med" len="med"/>
+                      <a:tailEnd type="none" w="med" len="med"/>
+                    </a:lnL>
+                    <a:lnR w="6350" cap="flat" cmpd="sng" algn="ctr">
+                      <a:solidFill>
+                        <a:srgbClr val="E3E8E9"/>
+                      </a:solidFill>
+                      <a:prstDash val="solid"/>
+                      <a:round/>
+                      <a:headEnd type="none" w="med" len="med"/>
+                      <a:tailEnd type="none" w="med" len="med"/>
+                    </a:lnR>
+                    <a:lnT w="6350" cap="flat" cmpd="sng" algn="ctr">
+                      <a:solidFill>
+                        <a:srgbClr val="E3E8E9"/>
+                      </a:solidFill>
+                      <a:prstDash val="solid"/>
+                      <a:round/>
+                      <a:headEnd type="none" w="med" len="med"/>
+                      <a:tailEnd type="none" w="med" len="med"/>
+                    </a:lnT>
+                    <a:lnB w="6350" cap="flat" cmpd="sng" algn="ctr">
+                      <a:solidFill>
+                        <a:srgbClr val="E3E8E9"/>
+                      </a:solidFill>
+                      <a:prstDash val="solid"/>
+                      <a:round/>
+                      <a:headEnd type="none" w="med" len="med"/>
+                      <a:tailEnd type="none" w="med" len="med"/>
+                    </a:lnB>
+                    <a:solidFill>
+                      <a:srgbClr val="F0F4F5"/>
+                    </a:solidFill>
+                  </a:tcPr>
+                </a:tc>
+                <a:tc>
+                  <a:txBody>
+                    <a:bodyPr/>
+                    <a:lstStyle/>
+                    <a:p>
+                      <a:pPr indent="0" marL="0">
+                        <a:buNone/>
+                      </a:pPr>
+                      <a:r>
+                        <a:rPr lang="en-US" sz="950" dirty="0">
+                          <a:solidFill>
+                            <a:srgbClr val="5B6B73"/>
+                          </a:solidFill>
+                          <a:latin typeface="Calibri" pitchFamily="34" charset="0"/>
+                          <a:ea typeface="Calibri" pitchFamily="34" charset="-122"/>
+                          <a:cs typeface="Calibri" pitchFamily="34" charset="-120"/>
+                        </a:rPr>
+                        <a:t>Rotina Operacional</a:t>
+                      </a:r>
+                      <a:endParaRPr lang="en-US" sz="950" dirty="0">
+                        <a:latin typeface="Calibri" charset="0"/>
+                        <a:ea typeface="Calibri" charset="0"/>
+                        <a:cs typeface="Calibri" charset="0"/>
+                      </a:endParaRPr>
+                    </a:p>
+                  </a:txBody>
+                  <a:tcPr marL="91440" marR="91440" marT="45720" marB="45720" anchor="ctr">
+                    <a:lnL w="6350" cap="flat" cmpd="sng" algn="ctr">
+                      <a:solidFill>
+                        <a:srgbClr val="E3E8E9"/>
+                      </a:solidFill>
+                      <a:prstDash val="solid"/>
+                      <a:round/>
+                      <a:headEnd type="none" w="med" len="med"/>
+                      <a:tailEnd type="none" w="med" len="med"/>
+                    </a:lnL>
+                    <a:lnR w="6350" cap="flat" cmpd="sng" algn="ctr">
+                      <a:solidFill>
+                        <a:srgbClr val="E3E8E9"/>
+                      </a:solidFill>
+                      <a:prstDash val="solid"/>
+                      <a:round/>
+                      <a:headEnd type="none" w="med" len="med"/>
+                      <a:tailEnd type="none" w="med" len="med"/>
+                    </a:lnR>
+                    <a:lnT w="6350" cap="flat" cmpd="sng" algn="ctr">
+                      <a:solidFill>
+                        <a:srgbClr val="E3E8E9"/>
+                      </a:solidFill>
+                      <a:prstDash val="solid"/>
+                      <a:round/>
+                      <a:headEnd type="none" w="med" len="med"/>
+                      <a:tailEnd type="none" w="med" len="med"/>
+                    </a:lnT>
+                    <a:lnB w="6350" cap="flat" cmpd="sng" algn="ctr">
+                      <a:solidFill>
+                        <a:srgbClr val="E3E8E9"/>
+                      </a:solidFill>
+                      <a:prstDash val="solid"/>
+                      <a:round/>
+                      <a:headEnd type="none" w="med" len="med"/>
+                      <a:tailEnd type="none" w="med" len="med"/>
+                    </a:lnB>
+                    <a:solidFill>
+                      <a:srgbClr val="F0F4F5"/>
+                    </a:solidFill>
+                  </a:tcPr>
+                </a:tc>
+                <a:tc>
+                  <a:txBody>
+                    <a:bodyPr/>
+                    <a:lstStyle/>
+                    <a:p>
+                      <a:pPr indent="0" marL="0">
+                        <a:buNone/>
+                      </a:pPr>
+                      <a:r>
+                        <a:rPr lang="en-US" sz="950" dirty="0">
+                          <a:solidFill>
+                            <a:srgbClr val="5B6B73"/>
+                          </a:solidFill>
+                          <a:latin typeface="Calibri" pitchFamily="34" charset="0"/>
+                          <a:ea typeface="Calibri" pitchFamily="34" charset="-122"/>
+                          <a:cs typeface="Calibri" pitchFamily="34" charset="-120"/>
+                        </a:rPr>
+                        <a:t>MNT – Manutenção</a:t>
+                      </a:r>
+                      <a:endParaRPr lang="en-US" sz="950" dirty="0">
+                        <a:latin typeface="Calibri" charset="0"/>
+                        <a:ea typeface="Calibri" charset="0"/>
+                        <a:cs typeface="Calibri" charset="0"/>
+                      </a:endParaRPr>
+                    </a:p>
+                  </a:txBody>
+                  <a:tcPr marL="91440" marR="91440" marT="45720" marB="45720" anchor="ctr">
+                    <a:lnL w="6350" cap="flat" cmpd="sng" algn="ctr">
+                      <a:solidFill>
+                        <a:srgbClr val="E3E8E9"/>
+                      </a:solidFill>
+                      <a:prstDash val="solid"/>
+                      <a:round/>
+                      <a:headEnd type="none" w="med" len="med"/>
+                      <a:tailEnd type="none" w="med" len="med"/>
+                    </a:lnL>
+                    <a:lnR w="6350" cap="flat" cmpd="sng" algn="ctr">
+                      <a:solidFill>
+                        <a:srgbClr val="E3E8E9"/>
+                      </a:solidFill>
+                      <a:prstDash val="solid"/>
+                      <a:round/>
+                      <a:headEnd type="none" w="med" len="med"/>
+                      <a:tailEnd type="none" w="med" len="med"/>
+                    </a:lnR>
+                    <a:lnT w="6350" cap="flat" cmpd="sng" algn="ctr">
+                      <a:solidFill>
+                        <a:srgbClr val="E3E8E9"/>
+                      </a:solidFill>
+                      <a:prstDash val="solid"/>
+                      <a:round/>
+                      <a:headEnd type="none" w="med" len="med"/>
+                      <a:tailEnd type="none" w="med" len="med"/>
+                    </a:lnT>
+                    <a:lnB w="6350" cap="flat" cmpd="sng" algn="ctr">
+                      <a:solidFill>
+                        <a:srgbClr val="E3E8E9"/>
+                      </a:solidFill>
+                      <a:prstDash val="solid"/>
+                      <a:round/>
+                      <a:headEnd type="none" w="med" len="med"/>
+                      <a:tailEnd type="none" w="med" len="med"/>
+                    </a:lnB>
+                    <a:solidFill>
+                      <a:srgbClr val="F0F4F5"/>
+                    </a:solidFill>
+                  </a:tcPr>
+                </a:tc>
+                <a:tc>
+                  <a:txBody>
+                    <a:bodyPr/>
+                    <a:lstStyle/>
+                    <a:p>
+                      <a:pPr algn="r" indent="0" marL="0">
+                        <a:buNone/>
+                      </a:pPr>
+                      <a:r>
+                        <a:rPr lang="en-US" sz="1000" b="1" dirty="0">
+                          <a:solidFill>
+                            <a:srgbClr val="0B2A3D"/>
+                          </a:solidFill>
+                          <a:latin typeface="Calibri" pitchFamily="34" charset="0"/>
+                          <a:ea typeface="Calibri" pitchFamily="34" charset="-122"/>
+                          <a:cs typeface="Calibri" pitchFamily="34" charset="-120"/>
+                        </a:rPr>
+                        <a:t>US$ 560,7 mil</a:t>
+                      </a:r>
+                      <a:endParaRPr lang="en-US" sz="1000" dirty="0">
+                        <a:latin typeface="Calibri" charset="0"/>
+                        <a:ea typeface="Calibri" charset="0"/>
+                        <a:cs typeface="Calibri" charset="0"/>
+                      </a:endParaRPr>
+                    </a:p>
+                  </a:txBody>
+                  <a:tcPr marL="91440" marR="91440" marT="45720" marB="45720" anchor="ctr">
+                    <a:lnL w="6350" cap="flat" cmpd="sng" algn="ctr">
+                      <a:solidFill>
+                        <a:srgbClr val="E3E8E9"/>
+                      </a:solidFill>
+                      <a:prstDash val="solid"/>
+                      <a:round/>
+                      <a:headEnd type="none" w="med" len="med"/>
+                      <a:tailEnd type="none" w="med" len="med"/>
+                    </a:lnL>
+                    <a:lnR w="6350" cap="flat" cmpd="sng" algn="ctr">
+                      <a:solidFill>
+                        <a:srgbClr val="E3E8E9"/>
+                      </a:solidFill>
+                      <a:prstDash val="solid"/>
+                      <a:round/>
+                      <a:headEnd type="none" w="med" len="med"/>
+                      <a:tailEnd type="none" w="med" len="med"/>
+                    </a:lnR>
+                    <a:lnT w="6350" cap="flat" cmpd="sng" algn="ctr">
+                      <a:solidFill>
+                        <a:srgbClr val="E3E8E9"/>
+                      </a:solidFill>
+                      <a:prstDash val="solid"/>
+                      <a:round/>
+                      <a:headEnd type="none" w="med" len="med"/>
+                      <a:tailEnd type="none" w="med" len="med"/>
+                    </a:lnT>
+                    <a:lnB w="6350" cap="flat" cmpd="sng" algn="ctr">
+                      <a:solidFill>
+                        <a:srgbClr val="E3E8E9"/>
+                      </a:solidFill>
+                      <a:prstDash val="solid"/>
+                      <a:round/>
+                      <a:headEnd type="none" w="med" len="med"/>
+                      <a:tailEnd type="none" w="med" len="med"/>
+                    </a:lnB>
+                    <a:solidFill>
+                      <a:srgbClr val="F0F4F5"/>
+                    </a:solidFill>
+                  </a:tcPr>
+                </a:tc>
+              </a:tr>
+              <a:tr h="288036">
+                <a:tc>
+                  <a:txBody>
+                    <a:bodyPr/>
+                    <a:lstStyle/>
+                    <a:p>
+                      <a:pPr indent="0" marL="0">
+                        <a:buNone/>
+                      </a:pPr>
+                      <a:r>
+                        <a:rPr lang="en-US" sz="1000" dirty="0">
+                          <a:solidFill>
+                            <a:srgbClr val="1C2B33"/>
+                          </a:solidFill>
+                          <a:latin typeface="Calibri" pitchFamily="34" charset="0"/>
+                          <a:ea typeface="Calibri" pitchFamily="34" charset="-122"/>
+                          <a:cs typeface="Calibri" pitchFamily="34" charset="-120"/>
+                        </a:rPr>
+                        <a:t>Combate a Incêndio - Revamp das cabines de water mist</a:t>
+                      </a:r>
+                      <a:endParaRPr lang="en-US" sz="1000" dirty="0">
+                        <a:latin typeface="Calibri" charset="0"/>
+                        <a:ea typeface="Calibri" charset="0"/>
+                        <a:cs typeface="Calibri" charset="0"/>
+                      </a:endParaRPr>
+                    </a:p>
+                  </a:txBody>
+                  <a:tcPr marL="91440" marR="91440" marT="45720" marB="45720" anchor="ctr">
+                    <a:lnL w="6350" cap="flat" cmpd="sng" algn="ctr">
+                      <a:solidFill>
+                        <a:srgbClr val="E3E8E9"/>
+                      </a:solidFill>
+                      <a:prstDash val="solid"/>
+                      <a:round/>
+                      <a:headEnd type="none" w="med" len="med"/>
+                      <a:tailEnd type="none" w="med" len="med"/>
+                    </a:lnL>
+                    <a:lnR w="6350" cap="flat" cmpd="sng" algn="ctr">
+                      <a:solidFill>
+                        <a:srgbClr val="E3E8E9"/>
+                      </a:solidFill>
+                      <a:prstDash val="solid"/>
+                      <a:round/>
+                      <a:headEnd type="none" w="med" len="med"/>
+                      <a:tailEnd type="none" w="med" len="med"/>
+                    </a:lnR>
+                    <a:lnT w="6350" cap="flat" cmpd="sng" algn="ctr">
+                      <a:solidFill>
+                        <a:srgbClr val="E3E8E9"/>
+                      </a:solidFill>
+                      <a:prstDash val="solid"/>
+                      <a:round/>
+                      <a:headEnd type="none" w="med" len="med"/>
+                      <a:tailEnd type="none" w="med" len="med"/>
+                    </a:lnT>
+                    <a:lnB w="6350" cap="flat" cmpd="sng" algn="ctr">
+                      <a:solidFill>
+                        <a:srgbClr val="E3E8E9"/>
+                      </a:solidFill>
+                      <a:prstDash val="solid"/>
+                      <a:round/>
+                      <a:headEnd type="none" w="med" len="med"/>
+                      <a:tailEnd type="none" w="med" len="med"/>
+                    </a:lnB>
+                    <a:solidFill>
+                      <a:srgbClr val="FFFFFF"/>
+                    </a:solidFill>
+                  </a:tcPr>
+                </a:tc>
+                <a:tc>
+                  <a:txBody>
+                    <a:bodyPr/>
+                    <a:lstStyle/>
+                    <a:p>
+                      <a:pPr indent="0" marL="0">
+                        <a:buNone/>
+                      </a:pPr>
+                      <a:r>
+                        <a:rPr lang="en-US" sz="950" dirty="0">
+                          <a:solidFill>
+                            <a:srgbClr val="5B6B73"/>
+                          </a:solidFill>
+                          <a:latin typeface="Calibri" pitchFamily="34" charset="0"/>
+                          <a:ea typeface="Calibri" pitchFamily="34" charset="-122"/>
+                          <a:cs typeface="Calibri" pitchFamily="34" charset="-120"/>
+                        </a:rPr>
+                        <a:t>Bem Estar/Segurança</a:t>
+                      </a:r>
+                      <a:endParaRPr lang="en-US" sz="950" dirty="0">
+                        <a:latin typeface="Calibri" charset="0"/>
+                        <a:ea typeface="Calibri" charset="0"/>
+                        <a:cs typeface="Calibri" charset="0"/>
+                      </a:endParaRPr>
+                    </a:p>
+                  </a:txBody>
+                  <a:tcPr marL="91440" marR="91440" marT="45720" marB="45720" anchor="ctr">
+                    <a:lnL w="6350" cap="flat" cmpd="sng" algn="ctr">
+                      <a:solidFill>
+                        <a:srgbClr val="E3E8E9"/>
+                      </a:solidFill>
+                      <a:prstDash val="solid"/>
+                      <a:round/>
+                      <a:headEnd type="none" w="med" len="med"/>
+                      <a:tailEnd type="none" w="med" len="med"/>
+                    </a:lnL>
+                    <a:lnR w="6350" cap="flat" cmpd="sng" algn="ctr">
+                      <a:solidFill>
+                        <a:srgbClr val="E3E8E9"/>
+                      </a:solidFill>
+                      <a:prstDash val="solid"/>
+                      <a:round/>
+                      <a:headEnd type="none" w="med" len="med"/>
+                      <a:tailEnd type="none" w="med" len="med"/>
+                    </a:lnR>
+                    <a:lnT w="6350" cap="flat" cmpd="sng" algn="ctr">
+                      <a:solidFill>
+                        <a:srgbClr val="E3E8E9"/>
+                      </a:solidFill>
+                      <a:prstDash val="solid"/>
+                      <a:round/>
+                      <a:headEnd type="none" w="med" len="med"/>
+                      <a:tailEnd type="none" w="med" len="med"/>
+                    </a:lnT>
+                    <a:lnB w="6350" cap="flat" cmpd="sng" algn="ctr">
+                      <a:solidFill>
+                        <a:srgbClr val="E3E8E9"/>
+                      </a:solidFill>
+                      <a:prstDash val="solid"/>
+                      <a:round/>
+                      <a:headEnd type="none" w="med" len="med"/>
+                      <a:tailEnd type="none" w="med" len="med"/>
+                    </a:lnB>
+                    <a:solidFill>
+                      <a:srgbClr val="FFFFFF"/>
+                    </a:solidFill>
+                  </a:tcPr>
+                </a:tc>
+                <a:tc>
+                  <a:txBody>
+                    <a:bodyPr/>
+                    <a:lstStyle/>
+                    <a:p>
+                      <a:pPr indent="0" marL="0">
+                        <a:buNone/>
+                      </a:pPr>
+                      <a:r>
+                        <a:rPr lang="en-US" sz="950" dirty="0">
+                          <a:solidFill>
+                            <a:srgbClr val="5B6B73"/>
+                          </a:solidFill>
+                          <a:latin typeface="Calibri" pitchFamily="34" charset="0"/>
+                          <a:ea typeface="Calibri" pitchFamily="34" charset="-122"/>
+                          <a:cs typeface="Calibri" pitchFamily="34" charset="-120"/>
+                        </a:rPr>
+                        <a:t>Saúde e Segurança Ocupacional</a:t>
+                      </a:r>
+                      <a:endParaRPr lang="en-US" sz="950" dirty="0">
+                        <a:latin typeface="Calibri" charset="0"/>
+                        <a:ea typeface="Calibri" charset="0"/>
+                        <a:cs typeface="Calibri" charset="0"/>
+                      </a:endParaRPr>
+                    </a:p>
+                  </a:txBody>
+                  <a:tcPr marL="91440" marR="91440" marT="45720" marB="45720" anchor="ctr">
+                    <a:lnL w="6350" cap="flat" cmpd="sng" algn="ctr">
+                      <a:solidFill>
+                        <a:srgbClr val="E3E8E9"/>
+                      </a:solidFill>
+                      <a:prstDash val="solid"/>
+                      <a:round/>
+                      <a:headEnd type="none" w="med" len="med"/>
+                      <a:tailEnd type="none" w="med" len="med"/>
+                    </a:lnL>
+                    <a:lnR w="6350" cap="flat" cmpd="sng" algn="ctr">
+                      <a:solidFill>
+                        <a:srgbClr val="E3E8E9"/>
+                      </a:solidFill>
+                      <a:prstDash val="solid"/>
+                      <a:round/>
+                      <a:headEnd type="none" w="med" len="med"/>
+                      <a:tailEnd type="none" w="med" len="med"/>
+                    </a:lnR>
+                    <a:lnT w="6350" cap="flat" cmpd="sng" algn="ctr">
+                      <a:solidFill>
+                        <a:srgbClr val="E3E8E9"/>
+                      </a:solidFill>
+                      <a:prstDash val="solid"/>
+                      <a:round/>
+                      <a:headEnd type="none" w="med" len="med"/>
+                      <a:tailEnd type="none" w="med" len="med"/>
+                    </a:lnT>
+                    <a:lnB w="6350" cap="flat" cmpd="sng" algn="ctr">
+                      <a:solidFill>
+                        <a:srgbClr val="E3E8E9"/>
+                      </a:solidFill>
+                      <a:prstDash val="solid"/>
+                      <a:round/>
+                      <a:headEnd type="none" w="med" len="med"/>
+                      <a:tailEnd type="none" w="med" len="med"/>
+                    </a:lnB>
+                    <a:solidFill>
+                      <a:srgbClr val="FFFFFF"/>
+                    </a:solidFill>
+                  </a:tcPr>
+                </a:tc>
+                <a:tc>
+                  <a:txBody>
+                    <a:bodyPr/>
+                    <a:lstStyle/>
+                    <a:p>
+                      <a:pPr algn="r" indent="0" marL="0">
+                        <a:buNone/>
+                      </a:pPr>
+                      <a:r>
+                        <a:rPr lang="en-US" sz="1000" b="1" dirty="0">
+                          <a:solidFill>
+                            <a:srgbClr val="0B2A3D"/>
+                          </a:solidFill>
+                          <a:latin typeface="Calibri" pitchFamily="34" charset="0"/>
+                          <a:ea typeface="Calibri" pitchFamily="34" charset="-122"/>
+                          <a:cs typeface="Calibri" pitchFamily="34" charset="-120"/>
+                        </a:rPr>
+                        <a:t>US$ 500,0 mil</a:t>
+                      </a:r>
+                      <a:endParaRPr lang="en-US" sz="1000" dirty="0">
+                        <a:latin typeface="Calibri" charset="0"/>
+                        <a:ea typeface="Calibri" charset="0"/>
+                        <a:cs typeface="Calibri" charset="0"/>
+                      </a:endParaRPr>
+                    </a:p>
+                  </a:txBody>
+                  <a:tcPr marL="91440" marR="91440" marT="45720" marB="45720" anchor="ctr">
+                    <a:lnL w="6350" cap="flat" cmpd="sng" algn="ctr">
+                      <a:solidFill>
+                        <a:srgbClr val="E3E8E9"/>
+                      </a:solidFill>
+                      <a:prstDash val="solid"/>
+                      <a:round/>
+                      <a:headEnd type="none" w="med" len="med"/>
+                      <a:tailEnd type="none" w="med" len="med"/>
+                    </a:lnL>
+                    <a:lnR w="6350" cap="flat" cmpd="sng" algn="ctr">
+                      <a:solidFill>
+                        <a:srgbClr val="E3E8E9"/>
+                      </a:solidFill>
+                      <a:prstDash val="solid"/>
+                      <a:round/>
+                      <a:headEnd type="none" w="med" len="med"/>
+                      <a:tailEnd type="none" w="med" len="med"/>
+                    </a:lnR>
+                    <a:lnT w="6350" cap="flat" cmpd="sng" algn="ctr">
+                      <a:solidFill>
+                        <a:srgbClr val="E3E8E9"/>
+                      </a:solidFill>
+                      <a:prstDash val="solid"/>
+                      <a:round/>
+                      <a:headEnd type="none" w="med" len="med"/>
+                      <a:tailEnd type="none" w="med" len="med"/>
+                    </a:lnT>
+                    <a:lnB w="6350" cap="flat" cmpd="sng" algn="ctr">
+                      <a:solidFill>
+                        <a:srgbClr val="E3E8E9"/>
+                      </a:solidFill>
+                      <a:prstDash val="solid"/>
+                      <a:round/>
+                      <a:headEnd type="none" w="med" len="med"/>
+                      <a:tailEnd type="none" w="med" len="med"/>
+                    </a:lnB>
+                    <a:solidFill>
+                      <a:srgbClr val="FFFFFF"/>
+                    </a:solidFill>
+                  </a:tcPr>
+                </a:tc>
+              </a:tr>
+              <a:tr h="288036">
+                <a:tc>
+                  <a:txBody>
+                    <a:bodyPr/>
+                    <a:lstStyle/>
+                    <a:p>
+                      <a:pPr indent="0" marL="0">
+                        <a:buNone/>
+                      </a:pPr>
+                      <a:r>
+                        <a:rPr lang="en-US" sz="1000" dirty="0">
+                          <a:solidFill>
+                            <a:srgbClr val="1C2B33"/>
+                          </a:solidFill>
+                          <a:latin typeface="Calibri" pitchFamily="34" charset="0"/>
+                          <a:ea typeface="Calibri" pitchFamily="34" charset="-122"/>
+                          <a:cs typeface="Calibri" pitchFamily="34" charset="-120"/>
+                        </a:rPr>
+                        <a:t>Water Mist</a:t>
+                      </a:r>
+                      <a:endParaRPr lang="en-US" sz="1000" dirty="0">
+                        <a:latin typeface="Calibri" charset="0"/>
+                        <a:ea typeface="Calibri" charset="0"/>
+                        <a:cs typeface="Calibri" charset="0"/>
+                      </a:endParaRPr>
+                    </a:p>
+                  </a:txBody>
+                  <a:tcPr marL="91440" marR="91440" marT="45720" marB="45720" anchor="ctr">
+                    <a:lnL w="6350" cap="flat" cmpd="sng" algn="ctr">
+                      <a:solidFill>
+                        <a:srgbClr val="E3E8E9"/>
+                      </a:solidFill>
+                      <a:prstDash val="solid"/>
+                      <a:round/>
+                      <a:headEnd type="none" w="med" len="med"/>
+                      <a:tailEnd type="none" w="med" len="med"/>
+                    </a:lnL>
+                    <a:lnR w="6350" cap="flat" cmpd="sng" algn="ctr">
+                      <a:solidFill>
+                        <a:srgbClr val="E3E8E9"/>
+                      </a:solidFill>
+                      <a:prstDash val="solid"/>
+                      <a:round/>
+                      <a:headEnd type="none" w="med" len="med"/>
+                      <a:tailEnd type="none" w="med" len="med"/>
+                    </a:lnR>
+                    <a:lnT w="6350" cap="flat" cmpd="sng" algn="ctr">
+                      <a:solidFill>
+                        <a:srgbClr val="E3E8E9"/>
+                      </a:solidFill>
+                      <a:prstDash val="solid"/>
+                      <a:round/>
+                      <a:headEnd type="none" w="med" len="med"/>
+                      <a:tailEnd type="none" w="med" len="med"/>
+                    </a:lnT>
+                    <a:lnB w="6350" cap="flat" cmpd="sng" algn="ctr">
+                      <a:solidFill>
+                        <a:srgbClr val="E3E8E9"/>
+                      </a:solidFill>
+                      <a:prstDash val="solid"/>
+                      <a:round/>
+                      <a:headEnd type="none" w="med" len="med"/>
+                      <a:tailEnd type="none" w="med" len="med"/>
+                    </a:lnB>
+                    <a:solidFill>
+                      <a:srgbClr val="F0F4F5"/>
+                    </a:solidFill>
+                  </a:tcPr>
+                </a:tc>
+                <a:tc>
+                  <a:txBody>
+                    <a:bodyPr/>
+                    <a:lstStyle/>
+                    <a:p>
+                      <a:pPr indent="0" marL="0">
+                        <a:buNone/>
+                      </a:pPr>
+                      <a:r>
+                        <a:rPr lang="en-US" sz="950" dirty="0">
+                          <a:solidFill>
+                            <a:srgbClr val="5B6B73"/>
+                          </a:solidFill>
+                          <a:latin typeface="Calibri" pitchFamily="34" charset="0"/>
+                          <a:ea typeface="Calibri" pitchFamily="34" charset="-122"/>
+                          <a:cs typeface="Calibri" pitchFamily="34" charset="-120"/>
+                        </a:rPr>
+                        <a:t>Bem Estar/Segurança</a:t>
+                      </a:r>
+                      <a:endParaRPr lang="en-US" sz="950" dirty="0">
+                        <a:latin typeface="Calibri" charset="0"/>
+                        <a:ea typeface="Calibri" charset="0"/>
+                        <a:cs typeface="Calibri" charset="0"/>
+                      </a:endParaRPr>
+                    </a:p>
+                  </a:txBody>
+                  <a:tcPr marL="91440" marR="91440" marT="45720" marB="45720" anchor="ctr">
+                    <a:lnL w="6350" cap="flat" cmpd="sng" algn="ctr">
+                      <a:solidFill>
+                        <a:srgbClr val="E3E8E9"/>
+                      </a:solidFill>
+                      <a:prstDash val="solid"/>
+                      <a:round/>
+                      <a:headEnd type="none" w="med" len="med"/>
+                      <a:tailEnd type="none" w="med" len="med"/>
+                    </a:lnL>
+                    <a:lnR w="6350" cap="flat" cmpd="sng" algn="ctr">
+                      <a:solidFill>
+                        <a:srgbClr val="E3E8E9"/>
+                      </a:solidFill>
+                      <a:prstDash val="solid"/>
+                      <a:round/>
+                      <a:headEnd type="none" w="med" len="med"/>
+                      <a:tailEnd type="none" w="med" len="med"/>
+                    </a:lnR>
+                    <a:lnT w="6350" cap="flat" cmpd="sng" algn="ctr">
+                      <a:solidFill>
+                        <a:srgbClr val="E3E8E9"/>
+                      </a:solidFill>
+                      <a:prstDash val="solid"/>
+                      <a:round/>
+                      <a:headEnd type="none" w="med" len="med"/>
+                      <a:tailEnd type="none" w="med" len="med"/>
+                    </a:lnT>
+                    <a:lnB w="6350" cap="flat" cmpd="sng" algn="ctr">
+                      <a:solidFill>
+                        <a:srgbClr val="E3E8E9"/>
+                      </a:solidFill>
+                      <a:prstDash val="solid"/>
+                      <a:round/>
+                      <a:headEnd type="none" w="med" len="med"/>
+                      <a:tailEnd type="none" w="med" len="med"/>
+                    </a:lnB>
+                    <a:solidFill>
+                      <a:srgbClr val="F0F4F5"/>
+                    </a:solidFill>
+                  </a:tcPr>
+                </a:tc>
+                <a:tc>
+                  <a:txBody>
+                    <a:bodyPr/>
+                    <a:lstStyle/>
+                    <a:p>
+                      <a:pPr indent="0" marL="0">
+                        <a:buNone/>
+                      </a:pPr>
+                      <a:r>
+                        <a:rPr lang="en-US" sz="950" dirty="0">
+                          <a:solidFill>
+                            <a:srgbClr val="5B6B73"/>
+                          </a:solidFill>
+                          <a:latin typeface="Calibri" pitchFamily="34" charset="0"/>
+                          <a:ea typeface="Calibri" pitchFamily="34" charset="-122"/>
+                          <a:cs typeface="Calibri" pitchFamily="34" charset="-120"/>
+                        </a:rPr>
+                        <a:t>Projetos</a:t>
+                      </a:r>
+                      <a:endParaRPr lang="en-US" sz="950" dirty="0">
+                        <a:latin typeface="Calibri" charset="0"/>
+                        <a:ea typeface="Calibri" charset="0"/>
+                        <a:cs typeface="Calibri" charset="0"/>
+                      </a:endParaRPr>
+                    </a:p>
+                  </a:txBody>
+                  <a:tcPr marL="91440" marR="91440" marT="45720" marB="45720" anchor="ctr">
+                    <a:lnL w="6350" cap="flat" cmpd="sng" algn="ctr">
+                      <a:solidFill>
+                        <a:srgbClr val="E3E8E9"/>
+                      </a:solidFill>
+                      <a:prstDash val="solid"/>
+                      <a:round/>
+                      <a:headEnd type="none" w="med" len="med"/>
+                      <a:tailEnd type="none" w="med" len="med"/>
+                    </a:lnL>
+                    <a:lnR w="6350" cap="flat" cmpd="sng" algn="ctr">
+                      <a:solidFill>
+                        <a:srgbClr val="E3E8E9"/>
+                      </a:solidFill>
+                      <a:prstDash val="solid"/>
+                      <a:round/>
+                      <a:headEnd type="none" w="med" len="med"/>
+                      <a:tailEnd type="none" w="med" len="med"/>
+                    </a:lnR>
+                    <a:lnT w="6350" cap="flat" cmpd="sng" algn="ctr">
+                      <a:solidFill>
+                        <a:srgbClr val="E3E8E9"/>
+                      </a:solidFill>
+                      <a:prstDash val="solid"/>
+                      <a:round/>
+                      <a:headEnd type="none" w="med" len="med"/>
+                      <a:tailEnd type="none" w="med" len="med"/>
+                    </a:lnT>
+                    <a:lnB w="6350" cap="flat" cmpd="sng" algn="ctr">
+                      <a:solidFill>
+                        <a:srgbClr val="E3E8E9"/>
+                      </a:solidFill>
+                      <a:prstDash val="solid"/>
+                      <a:round/>
+                      <a:headEnd type="none" w="med" len="med"/>
+                      <a:tailEnd type="none" w="med" len="med"/>
+                    </a:lnB>
+                    <a:solidFill>
+                      <a:srgbClr val="F0F4F5"/>
+                    </a:solidFill>
+                  </a:tcPr>
+                </a:tc>
+                <a:tc>
+                  <a:txBody>
+                    <a:bodyPr/>
+                    <a:lstStyle/>
+                    <a:p>
+                      <a:pPr algn="r" indent="0" marL="0">
+                        <a:buNone/>
+                      </a:pPr>
+                      <a:r>
+                        <a:rPr lang="en-US" sz="1000" b="1" dirty="0">
+                          <a:solidFill>
+                            <a:srgbClr val="0B2A3D"/>
+                          </a:solidFill>
+                          <a:latin typeface="Calibri" pitchFamily="34" charset="0"/>
+                          <a:ea typeface="Calibri" pitchFamily="34" charset="-122"/>
+                          <a:cs typeface="Calibri" pitchFamily="34" charset="-120"/>
+                        </a:rPr>
+                        <a:t>US$ 500,0 mil</a:t>
+                      </a:r>
+                      <a:endParaRPr lang="en-US" sz="1000" dirty="0">
+                        <a:latin typeface="Calibri" charset="0"/>
+                        <a:ea typeface="Calibri" charset="0"/>
+                        <a:cs typeface="Calibri" charset="0"/>
+                      </a:endParaRPr>
+                    </a:p>
+                  </a:txBody>
+                  <a:tcPr marL="91440" marR="91440" marT="45720" marB="45720" anchor="ctr">
+                    <a:lnL w="6350" cap="flat" cmpd="sng" algn="ctr">
+                      <a:solidFill>
+                        <a:srgbClr val="E3E8E9"/>
+                      </a:solidFill>
+                      <a:prstDash val="solid"/>
+                      <a:round/>
+                      <a:headEnd type="none" w="med" len="med"/>
+                      <a:tailEnd type="none" w="med" len="med"/>
+                    </a:lnL>
+                    <a:lnR w="6350" cap="flat" cmpd="sng" algn="ctr">
+                      <a:solidFill>
+                        <a:srgbClr val="E3E8E9"/>
+                      </a:solidFill>
+                      <a:prstDash val="solid"/>
+                      <a:round/>
+                      <a:headEnd type="none" w="med" len="med"/>
+                      <a:tailEnd type="none" w="med" len="med"/>
+                    </a:lnR>
+                    <a:lnT w="6350" cap="flat" cmpd="sng" algn="ctr">
+                      <a:solidFill>
+                        <a:srgbClr val="E3E8E9"/>
+                      </a:solidFill>
+                      <a:prstDash val="solid"/>
+                      <a:round/>
+                      <a:headEnd type="none" w="med" len="med"/>
+                      <a:tailEnd type="none" w="med" len="med"/>
+                    </a:lnT>
+                    <a:lnB w="6350" cap="flat" cmpd="sng" algn="ctr">
+                      <a:solidFill>
+                        <a:srgbClr val="E3E8E9"/>
+                      </a:solidFill>
+                      <a:prstDash val="solid"/>
+                      <a:round/>
+                      <a:headEnd type="none" w="med" len="med"/>
+                      <a:tailEnd type="none" w="med" len="med"/>
+                    </a:lnB>
+                    <a:solidFill>
+                      <a:srgbClr val="F0F4F5"/>
+                    </a:solidFill>
+                  </a:tcPr>
+                </a:tc>
+              </a:tr>
+              <a:tr h="288036">
+                <a:tc>
+                  <a:txBody>
+                    <a:bodyPr/>
+                    <a:lstStyle/>
+                    <a:p>
+                      <a:pPr indent="0" marL="0">
+                        <a:buNone/>
+                      </a:pPr>
+                      <a:r>
+                        <a:rPr lang="en-US" sz="1000" dirty="0">
+                          <a:solidFill>
+                            <a:srgbClr val="1C2B33"/>
+                          </a:solidFill>
+                          <a:latin typeface="Calibri" pitchFamily="34" charset="0"/>
+                          <a:ea typeface="Calibri" pitchFamily="34" charset="-122"/>
+                          <a:cs typeface="Calibri" pitchFamily="34" charset="-120"/>
+                        </a:rPr>
+                        <a:t>Troca dos trocadores HBG 1040. (Material)</a:t>
+                      </a:r>
+                      <a:endParaRPr lang="en-US" sz="1000" dirty="0">
+                        <a:latin typeface="Calibri" charset="0"/>
+                        <a:ea typeface="Calibri" charset="0"/>
+                        <a:cs typeface="Calibri" charset="0"/>
+                      </a:endParaRPr>
+                    </a:p>
+                  </a:txBody>
+                  <a:tcPr marL="91440" marR="91440" marT="45720" marB="45720" anchor="ctr">
+                    <a:lnL w="6350" cap="flat" cmpd="sng" algn="ctr">
+                      <a:solidFill>
+                        <a:srgbClr val="E3E8E9"/>
+                      </a:solidFill>
+                      <a:prstDash val="solid"/>
+                      <a:round/>
+                      <a:headEnd type="none" w="med" len="med"/>
+                      <a:tailEnd type="none" w="med" len="med"/>
+                    </a:lnL>
+                    <a:lnR w="6350" cap="flat" cmpd="sng" algn="ctr">
+                      <a:solidFill>
+                        <a:srgbClr val="E3E8E9"/>
+                      </a:solidFill>
+                      <a:prstDash val="solid"/>
+                      <a:round/>
+                      <a:headEnd type="none" w="med" len="med"/>
+                      <a:tailEnd type="none" w="med" len="med"/>
+                    </a:lnR>
+                    <a:lnT w="6350" cap="flat" cmpd="sng" algn="ctr">
+                      <a:solidFill>
+                        <a:srgbClr val="E3E8E9"/>
+                      </a:solidFill>
+                      <a:prstDash val="solid"/>
+                      <a:round/>
+                      <a:headEnd type="none" w="med" len="med"/>
+                      <a:tailEnd type="none" w="med" len="med"/>
+                    </a:lnT>
+                    <a:lnB w="6350" cap="flat" cmpd="sng" algn="ctr">
+                      <a:solidFill>
+                        <a:srgbClr val="E3E8E9"/>
+                      </a:solidFill>
+                      <a:prstDash val="solid"/>
+                      <a:round/>
+                      <a:headEnd type="none" w="med" len="med"/>
+                      <a:tailEnd type="none" w="med" len="med"/>
+                    </a:lnB>
+                    <a:solidFill>
+                      <a:srgbClr val="FFFFFF"/>
+                    </a:solidFill>
+                  </a:tcPr>
+                </a:tc>
+                <a:tc>
+                  <a:txBody>
+                    <a:bodyPr/>
+                    <a:lstStyle/>
+                    <a:p>
+                      <a:pPr indent="0" marL="0">
+                        <a:buNone/>
+                      </a:pPr>
+                      <a:r>
+                        <a:rPr lang="en-US" sz="950" dirty="0">
+                          <a:solidFill>
+                            <a:srgbClr val="5B6B73"/>
+                          </a:solidFill>
+                          <a:latin typeface="Calibri" pitchFamily="34" charset="0"/>
+                          <a:ea typeface="Calibri" pitchFamily="34" charset="-122"/>
+                          <a:cs typeface="Calibri" pitchFamily="34" charset="-120"/>
+                        </a:rPr>
+                        <a:t>Eficiência de Produção</a:t>
+                      </a:r>
+                      <a:endParaRPr lang="en-US" sz="950" dirty="0">
+                        <a:latin typeface="Calibri" charset="0"/>
+                        <a:ea typeface="Calibri" charset="0"/>
+                        <a:cs typeface="Calibri" charset="0"/>
+                      </a:endParaRPr>
+                    </a:p>
+                  </a:txBody>
+                  <a:tcPr marL="91440" marR="91440" marT="45720" marB="45720" anchor="ctr">
+                    <a:lnL w="6350" cap="flat" cmpd="sng" algn="ctr">
+                      <a:solidFill>
+                        <a:srgbClr val="E3E8E9"/>
+                      </a:solidFill>
+                      <a:prstDash val="solid"/>
+                      <a:round/>
+                      <a:headEnd type="none" w="med" len="med"/>
+                      <a:tailEnd type="none" w="med" len="med"/>
+                    </a:lnL>
+                    <a:lnR w="6350" cap="flat" cmpd="sng" algn="ctr">
+                      <a:solidFill>
+                        <a:srgbClr val="E3E8E9"/>
+                      </a:solidFill>
+                      <a:prstDash val="solid"/>
+                      <a:round/>
+                      <a:headEnd type="none" w="med" len="med"/>
+                      <a:tailEnd type="none" w="med" len="med"/>
+                    </a:lnR>
+                    <a:lnT w="6350" cap="flat" cmpd="sng" algn="ctr">
+                      <a:solidFill>
+                        <a:srgbClr val="E3E8E9"/>
+                      </a:solidFill>
+                      <a:prstDash val="solid"/>
+                      <a:round/>
+                      <a:headEnd type="none" w="med" len="med"/>
+                      <a:tailEnd type="none" w="med" len="med"/>
+                    </a:lnT>
+                    <a:lnB w="6350" cap="flat" cmpd="sng" algn="ctr">
+                      <a:solidFill>
+                        <a:srgbClr val="E3E8E9"/>
+                      </a:solidFill>
+                      <a:prstDash val="solid"/>
+                      <a:round/>
+                      <a:headEnd type="none" w="med" len="med"/>
+                      <a:tailEnd type="none" w="med" len="med"/>
+                    </a:lnB>
+                    <a:solidFill>
+                      <a:srgbClr val="FFFFFF"/>
+                    </a:solidFill>
+                  </a:tcPr>
+                </a:tc>
+                <a:tc>
+                  <a:txBody>
+                    <a:bodyPr/>
+                    <a:lstStyle/>
+                    <a:p>
+                      <a:pPr indent="0" marL="0">
+                        <a:buNone/>
+                      </a:pPr>
+                      <a:r>
+                        <a:rPr lang="en-US" sz="950" dirty="0">
+                          <a:solidFill>
+                            <a:srgbClr val="5B6B73"/>
+                          </a:solidFill>
+                          <a:latin typeface="Calibri" pitchFamily="34" charset="0"/>
+                          <a:ea typeface="Calibri" pitchFamily="34" charset="-122"/>
+                          <a:cs typeface="Calibri" pitchFamily="34" charset="-120"/>
+                        </a:rPr>
+                        <a:t>P&amp;Q - Processos</a:t>
+                      </a:r>
+                      <a:endParaRPr lang="en-US" sz="950" dirty="0">
+                        <a:latin typeface="Calibri" charset="0"/>
+                        <a:ea typeface="Calibri" charset="0"/>
+                        <a:cs typeface="Calibri" charset="0"/>
+                      </a:endParaRPr>
+                    </a:p>
+                  </a:txBody>
+                  <a:tcPr marL="91440" marR="91440" marT="45720" marB="45720" anchor="ctr">
+                    <a:lnL w="6350" cap="flat" cmpd="sng" algn="ctr">
+                      <a:solidFill>
+                        <a:srgbClr val="E3E8E9"/>
+                      </a:solidFill>
+                      <a:prstDash val="solid"/>
+                      <a:round/>
+                      <a:headEnd type="none" w="med" len="med"/>
+                      <a:tailEnd type="none" w="med" len="med"/>
+                    </a:lnL>
+                    <a:lnR w="6350" cap="flat" cmpd="sng" algn="ctr">
+                      <a:solidFill>
+                        <a:srgbClr val="E3E8E9"/>
+                      </a:solidFill>
+                      <a:prstDash val="solid"/>
+                      <a:round/>
+                      <a:headEnd type="none" w="med" len="med"/>
+                      <a:tailEnd type="none" w="med" len="med"/>
+                    </a:lnR>
+                    <a:lnT w="6350" cap="flat" cmpd="sng" algn="ctr">
+                      <a:solidFill>
+                        <a:srgbClr val="E3E8E9"/>
+                      </a:solidFill>
+                      <a:prstDash val="solid"/>
+                      <a:round/>
+                      <a:headEnd type="none" w="med" len="med"/>
+                      <a:tailEnd type="none" w="med" len="med"/>
+                    </a:lnT>
+                    <a:lnB w="6350" cap="flat" cmpd="sng" algn="ctr">
+                      <a:solidFill>
+                        <a:srgbClr val="E3E8E9"/>
+                      </a:solidFill>
+                      <a:prstDash val="solid"/>
+                      <a:round/>
+                      <a:headEnd type="none" w="med" len="med"/>
+                      <a:tailEnd type="none" w="med" len="med"/>
+                    </a:lnB>
+                    <a:solidFill>
+                      <a:srgbClr val="FFFFFF"/>
+                    </a:solidFill>
+                  </a:tcPr>
+                </a:tc>
+                <a:tc>
+                  <a:txBody>
+                    <a:bodyPr/>
+                    <a:lstStyle/>
+                    <a:p>
+                      <a:pPr algn="r" indent="0" marL="0">
+                        <a:buNone/>
+                      </a:pPr>
+                      <a:r>
+                        <a:rPr lang="en-US" sz="1000" b="1" dirty="0">
+                          <a:solidFill>
+                            <a:srgbClr val="0B2A3D"/>
+                          </a:solidFill>
+                          <a:latin typeface="Calibri" pitchFamily="34" charset="0"/>
+                          <a:ea typeface="Calibri" pitchFamily="34" charset="-122"/>
+                          <a:cs typeface="Calibri" pitchFamily="34" charset="-120"/>
+                        </a:rPr>
+                        <a:t>US$ 470,4 mil</a:t>
+                      </a:r>
+                      <a:endParaRPr lang="en-US" sz="1000" dirty="0">
+                        <a:latin typeface="Calibri" charset="0"/>
+                        <a:ea typeface="Calibri" charset="0"/>
+                        <a:cs typeface="Calibri" charset="0"/>
+                      </a:endParaRPr>
+                    </a:p>
+                  </a:txBody>
+                  <a:tcPr marL="91440" marR="91440" marT="45720" marB="45720" anchor="ctr">
+                    <a:lnL w="6350" cap="flat" cmpd="sng" algn="ctr">
+                      <a:solidFill>
+                        <a:srgbClr val="E3E8E9"/>
+                      </a:solidFill>
+                      <a:prstDash val="solid"/>
+                      <a:round/>
+                      <a:headEnd type="none" w="med" len="med"/>
+                      <a:tailEnd type="none" w="med" len="med"/>
+                    </a:lnL>
+                    <a:lnR w="6350" cap="flat" cmpd="sng" algn="ctr">
+                      <a:solidFill>
+                        <a:srgbClr val="E3E8E9"/>
+                      </a:solidFill>
+                      <a:prstDash val="solid"/>
+                      <a:round/>
+                      <a:headEnd type="none" w="med" len="med"/>
+                      <a:tailEnd type="none" w="med" len="med"/>
+                    </a:lnR>
+                    <a:lnT w="6350" cap="flat" cmpd="sng" algn="ctr">
+                      <a:solidFill>
+                        <a:srgbClr val="E3E8E9"/>
+                      </a:solidFill>
+                      <a:prstDash val="solid"/>
+                      <a:round/>
+                      <a:headEnd type="none" w="med" len="med"/>
+                      <a:tailEnd type="none" w="med" len="med"/>
+                    </a:lnT>
+                    <a:lnB w="6350" cap="flat" cmpd="sng" algn="ctr">
+                      <a:solidFill>
+                        <a:srgbClr val="E3E8E9"/>
+                      </a:solidFill>
+                      <a:prstDash val="solid"/>
+                      <a:round/>
+                      <a:headEnd type="none" w="med" len="med"/>
+                      <a:tailEnd type="none" w="med" len="med"/>
+                    </a:lnB>
+                    <a:solidFill>
+                      <a:srgbClr val="FFFFFF"/>
+                    </a:solidFill>
+                  </a:tcPr>
+                </a:tc>
+              </a:tr>
+              <a:tr h="288036">
+                <a:tc>
+                  <a:txBody>
+                    <a:bodyPr/>
+                    <a:lstStyle/>
+                    <a:p>
+                      <a:pPr indent="0" marL="0">
+                        <a:buNone/>
+                      </a:pPr>
+                      <a:r>
+                        <a:rPr lang="en-US" sz="1000" dirty="0">
+                          <a:solidFill>
+                            <a:srgbClr val="1C2B33"/>
+                          </a:solidFill>
+                          <a:latin typeface="Calibri" pitchFamily="34" charset="0"/>
+                          <a:ea typeface="Calibri" pitchFamily="34" charset="-122"/>
+                          <a:cs typeface="Calibri" pitchFamily="34" charset="-120"/>
+                        </a:rPr>
+                        <a:t>R&amp;R - REPARO DE SELOS DGS</a:t>
+                      </a:r>
+                      <a:endParaRPr lang="en-US" sz="1000" dirty="0">
+                        <a:latin typeface="Calibri" charset="0"/>
+                        <a:ea typeface="Calibri" charset="0"/>
+                        <a:cs typeface="Calibri" charset="0"/>
+                      </a:endParaRPr>
+                    </a:p>
+                  </a:txBody>
+                  <a:tcPr marL="91440" marR="91440" marT="45720" marB="45720" anchor="ctr">
+                    <a:lnL w="6350" cap="flat" cmpd="sng" algn="ctr">
+                      <a:solidFill>
+                        <a:srgbClr val="E3E8E9"/>
+                      </a:solidFill>
+                      <a:prstDash val="solid"/>
+                      <a:round/>
+                      <a:headEnd type="none" w="med" len="med"/>
+                      <a:tailEnd type="none" w="med" len="med"/>
+                    </a:lnL>
+                    <a:lnR w="6350" cap="flat" cmpd="sng" algn="ctr">
+                      <a:solidFill>
+                        <a:srgbClr val="E3E8E9"/>
+                      </a:solidFill>
+                      <a:prstDash val="solid"/>
+                      <a:round/>
+                      <a:headEnd type="none" w="med" len="med"/>
+                      <a:tailEnd type="none" w="med" len="med"/>
+                    </a:lnR>
+                    <a:lnT w="6350" cap="flat" cmpd="sng" algn="ctr">
+                      <a:solidFill>
+                        <a:srgbClr val="E3E8E9"/>
+                      </a:solidFill>
+                      <a:prstDash val="solid"/>
+                      <a:round/>
+                      <a:headEnd type="none" w="med" len="med"/>
+                      <a:tailEnd type="none" w="med" len="med"/>
+                    </a:lnT>
+                    <a:lnB w="6350" cap="flat" cmpd="sng" algn="ctr">
+                      <a:solidFill>
+                        <a:srgbClr val="E3E8E9"/>
+                      </a:solidFill>
+                      <a:prstDash val="solid"/>
+                      <a:round/>
+                      <a:headEnd type="none" w="med" len="med"/>
+                      <a:tailEnd type="none" w="med" len="med"/>
+                    </a:lnB>
+                    <a:solidFill>
+                      <a:srgbClr val="F0F4F5"/>
+                    </a:solidFill>
+                  </a:tcPr>
+                </a:tc>
+                <a:tc>
+                  <a:txBody>
+                    <a:bodyPr/>
+                    <a:lstStyle/>
+                    <a:p>
+                      <a:pPr indent="0" marL="0">
+                        <a:buNone/>
+                      </a:pPr>
+                      <a:r>
+                        <a:rPr lang="en-US" sz="950" dirty="0">
+                          <a:solidFill>
+                            <a:srgbClr val="5B6B73"/>
+                          </a:solidFill>
+                          <a:latin typeface="Calibri" pitchFamily="34" charset="0"/>
+                          <a:ea typeface="Calibri" pitchFamily="34" charset="-122"/>
+                          <a:cs typeface="Calibri" pitchFamily="34" charset="-120"/>
+                        </a:rPr>
+                        <a:t>Rotina Operacional</a:t>
+                      </a:r>
+                      <a:endParaRPr lang="en-US" sz="950" dirty="0">
+                        <a:latin typeface="Calibri" charset="0"/>
+                        <a:ea typeface="Calibri" charset="0"/>
+                        <a:cs typeface="Calibri" charset="0"/>
+                      </a:endParaRPr>
+                    </a:p>
+                  </a:txBody>
+                  <a:tcPr marL="91440" marR="91440" marT="45720" marB="45720" anchor="ctr">
+                    <a:lnL w="6350" cap="flat" cmpd="sng" algn="ctr">
+                      <a:solidFill>
+                        <a:srgbClr val="E3E8E9"/>
+                      </a:solidFill>
+                      <a:prstDash val="solid"/>
+                      <a:round/>
+                      <a:headEnd type="none" w="med" len="med"/>
+                      <a:tailEnd type="none" w="med" len="med"/>
+                    </a:lnL>
+                    <a:lnR w="6350" cap="flat" cmpd="sng" algn="ctr">
+                      <a:solidFill>
+                        <a:srgbClr val="E3E8E9"/>
+                      </a:solidFill>
+                      <a:prstDash val="solid"/>
+                      <a:round/>
+                      <a:headEnd type="none" w="med" len="med"/>
+                      <a:tailEnd type="none" w="med" len="med"/>
+                    </a:lnR>
+                    <a:lnT w="6350" cap="flat" cmpd="sng" algn="ctr">
+                      <a:solidFill>
+                        <a:srgbClr val="E3E8E9"/>
+                      </a:solidFill>
+                      <a:prstDash val="solid"/>
+                      <a:round/>
+                      <a:headEnd type="none" w="med" len="med"/>
+                      <a:tailEnd type="none" w="med" len="med"/>
+                    </a:lnT>
+                    <a:lnB w="6350" cap="flat" cmpd="sng" algn="ctr">
+                      <a:solidFill>
+                        <a:srgbClr val="E3E8E9"/>
+                      </a:solidFill>
+                      <a:prstDash val="solid"/>
+                      <a:round/>
+                      <a:headEnd type="none" w="med" len="med"/>
+                      <a:tailEnd type="none" w="med" len="med"/>
+                    </a:lnB>
+                    <a:solidFill>
+                      <a:srgbClr val="F0F4F5"/>
+                    </a:solidFill>
+                  </a:tcPr>
+                </a:tc>
+                <a:tc>
+                  <a:txBody>
+                    <a:bodyPr/>
+                    <a:lstStyle/>
+                    <a:p>
+                      <a:pPr indent="0" marL="0">
+                        <a:buNone/>
+                      </a:pPr>
+                      <a:r>
+                        <a:rPr lang="en-US" sz="950" dirty="0">
+                          <a:solidFill>
+                            <a:srgbClr val="5B6B73"/>
+                          </a:solidFill>
+                          <a:latin typeface="Calibri" pitchFamily="34" charset="0"/>
+                          <a:ea typeface="Calibri" pitchFamily="34" charset="-122"/>
+                          <a:cs typeface="Calibri" pitchFamily="34" charset="-120"/>
+                        </a:rPr>
+                        <a:t>MNT – Manutenção</a:t>
+                      </a:r>
+                      <a:endParaRPr lang="en-US" sz="950" dirty="0">
+                        <a:latin typeface="Calibri" charset="0"/>
+                        <a:ea typeface="Calibri" charset="0"/>
+                        <a:cs typeface="Calibri" charset="0"/>
+                      </a:endParaRPr>
+                    </a:p>
+                  </a:txBody>
+                  <a:tcPr marL="91440" marR="91440" marT="45720" marB="45720" anchor="ctr">
+                    <a:lnL w="6350" cap="flat" cmpd="sng" algn="ctr">
+                      <a:solidFill>
+                        <a:srgbClr val="E3E8E9"/>
+                      </a:solidFill>
+                      <a:prstDash val="solid"/>
+                      <a:round/>
+                      <a:headEnd type="none" w="med" len="med"/>
+                      <a:tailEnd type="none" w="med" len="med"/>
+                    </a:lnL>
+                    <a:lnR w="6350" cap="flat" cmpd="sng" algn="ctr">
+                      <a:solidFill>
+                        <a:srgbClr val="E3E8E9"/>
+                      </a:solidFill>
+                      <a:prstDash val="solid"/>
+                      <a:round/>
+                      <a:headEnd type="none" w="med" len="med"/>
+                      <a:tailEnd type="none" w="med" len="med"/>
+                    </a:lnR>
+                    <a:lnT w="6350" cap="flat" cmpd="sng" algn="ctr">
+                      <a:solidFill>
+                        <a:srgbClr val="E3E8E9"/>
+                      </a:solidFill>
+                      <a:prstDash val="solid"/>
+                      <a:round/>
+                      <a:headEnd type="none" w="med" len="med"/>
+                      <a:tailEnd type="none" w="med" len="med"/>
+                    </a:lnT>
+                    <a:lnB w="6350" cap="flat" cmpd="sng" algn="ctr">
+                      <a:solidFill>
+                        <a:srgbClr val="E3E8E9"/>
+                      </a:solidFill>
+                      <a:prstDash val="solid"/>
+                      <a:round/>
+                      <a:headEnd type="none" w="med" len="med"/>
+                      <a:tailEnd type="none" w="med" len="med"/>
+                    </a:lnB>
+                    <a:solidFill>
+                      <a:srgbClr val="F0F4F5"/>
+                    </a:solidFill>
+                  </a:tcPr>
+                </a:tc>
+                <a:tc>
+                  <a:txBody>
+                    <a:bodyPr/>
+                    <a:lstStyle/>
+                    <a:p>
+                      <a:pPr algn="r" indent="0" marL="0">
+                        <a:buNone/>
+                      </a:pPr>
+                      <a:r>
+                        <a:rPr lang="en-US" sz="1000" b="1" dirty="0">
+                          <a:solidFill>
+                            <a:srgbClr val="0B2A3D"/>
+                          </a:solidFill>
+                          <a:latin typeface="Calibri" pitchFamily="34" charset="0"/>
+                          <a:ea typeface="Calibri" pitchFamily="34" charset="-122"/>
+                          <a:cs typeface="Calibri" pitchFamily="34" charset="-120"/>
+                        </a:rPr>
+                        <a:t>US$ 463,5 mil</a:t>
+                      </a:r>
+                      <a:endParaRPr lang="en-US" sz="1000" dirty="0">
+                        <a:latin typeface="Calibri" charset="0"/>
+                        <a:ea typeface="Calibri" charset="0"/>
+                        <a:cs typeface="Calibri" charset="0"/>
+                      </a:endParaRPr>
+                    </a:p>
+                  </a:txBody>
+                  <a:tcPr marL="91440" marR="91440" marT="45720" marB="45720" anchor="ctr">
+                    <a:lnL w="6350" cap="flat" cmpd="sng" algn="ctr">
+                      <a:solidFill>
+                        <a:srgbClr val="E3E8E9"/>
+                      </a:solidFill>
+                      <a:prstDash val="solid"/>
+                      <a:round/>
+                      <a:headEnd type="none" w="med" len="med"/>
+                      <a:tailEnd type="none" w="med" len="med"/>
+                    </a:lnL>
+                    <a:lnR w="6350" cap="flat" cmpd="sng" algn="ctr">
+                      <a:solidFill>
+                        <a:srgbClr val="E3E8E9"/>
+                      </a:solidFill>
+                      <a:prstDash val="solid"/>
+                      <a:round/>
+                      <a:headEnd type="none" w="med" len="med"/>
+                      <a:tailEnd type="none" w="med" len="med"/>
+                    </a:lnR>
+                    <a:lnT w="6350" cap="flat" cmpd="sng" algn="ctr">
+                      <a:solidFill>
+                        <a:srgbClr val="E3E8E9"/>
+                      </a:solidFill>
+                      <a:prstDash val="solid"/>
+                      <a:round/>
+                      <a:headEnd type="none" w="med" len="med"/>
+                      <a:tailEnd type="none" w="med" len="med"/>
+                    </a:lnT>
+                    <a:lnB w="6350" cap="flat" cmpd="sng" algn="ctr">
+                      <a:solidFill>
+                        <a:srgbClr val="E3E8E9"/>
+                      </a:solidFill>
+                      <a:prstDash val="solid"/>
+                      <a:round/>
+                      <a:headEnd type="none" w="med" len="med"/>
+                      <a:tailEnd type="none" w="med" len="med"/>
+                    </a:lnB>
+                    <a:solidFill>
+                      <a:srgbClr val="F0F4F5"/>
+                    </a:solidFill>
+                  </a:tcPr>
+                </a:tc>
+              </a:tr>
+              <a:tr h="288036">
+                <a:tc>
+                  <a:txBody>
+                    <a:bodyPr/>
+                    <a:lstStyle/>
+                    <a:p>
+                      <a:pPr indent="0" marL="0">
+                        <a:buNone/>
+                      </a:pPr>
+                      <a:r>
+                        <a:rPr lang="en-US" sz="1000" dirty="0">
+                          <a:solidFill>
+                            <a:srgbClr val="1C2B33"/>
+                          </a:solidFill>
+                          <a:latin typeface="Calibri" pitchFamily="34" charset="0"/>
+                          <a:ea typeface="Calibri" pitchFamily="34" charset="-122"/>
+                          <a:cs typeface="Calibri" pitchFamily="34" charset="-120"/>
+                        </a:rPr>
+                        <a:t>18- Aquisição de transformadores de melhor tecnologia dos tratadores eletrostáticos (Óleo - 1º TRI)</a:t>
+                      </a:r>
+                      <a:endParaRPr lang="en-US" sz="1000" dirty="0">
+                        <a:latin typeface="Calibri" charset="0"/>
+                        <a:ea typeface="Calibri" charset="0"/>
+                        <a:cs typeface="Calibri" charset="0"/>
+                      </a:endParaRPr>
+                    </a:p>
+                  </a:txBody>
+                  <a:tcPr marL="91440" marR="91440" marT="45720" marB="45720" anchor="ctr">
+                    <a:lnL w="6350" cap="flat" cmpd="sng" algn="ctr">
+                      <a:solidFill>
+                        <a:srgbClr val="E3E8E9"/>
+                      </a:solidFill>
+                      <a:prstDash val="solid"/>
+                      <a:round/>
+                      <a:headEnd type="none" w="med" len="med"/>
+                      <a:tailEnd type="none" w="med" len="med"/>
+                    </a:lnL>
+                    <a:lnR w="6350" cap="flat" cmpd="sng" algn="ctr">
+                      <a:solidFill>
+                        <a:srgbClr val="E3E8E9"/>
+                      </a:solidFill>
+                      <a:prstDash val="solid"/>
+                      <a:round/>
+                      <a:headEnd type="none" w="med" len="med"/>
+                      <a:tailEnd type="none" w="med" len="med"/>
+                    </a:lnR>
+                    <a:lnT w="6350" cap="flat" cmpd="sng" algn="ctr">
+                      <a:solidFill>
+                        <a:srgbClr val="E3E8E9"/>
+                      </a:solidFill>
+                      <a:prstDash val="solid"/>
+                      <a:round/>
+                      <a:headEnd type="none" w="med" len="med"/>
+                      <a:tailEnd type="none" w="med" len="med"/>
+                    </a:lnT>
+                    <a:lnB w="6350" cap="flat" cmpd="sng" algn="ctr">
+                      <a:solidFill>
+                        <a:srgbClr val="E3E8E9"/>
+                      </a:solidFill>
+                      <a:prstDash val="solid"/>
+                      <a:round/>
+                      <a:headEnd type="none" w="med" len="med"/>
+                      <a:tailEnd type="none" w="med" len="med"/>
+                    </a:lnB>
+                    <a:solidFill>
+                      <a:srgbClr val="FFFFFF"/>
+                    </a:solidFill>
+                  </a:tcPr>
+                </a:tc>
+                <a:tc>
+                  <a:txBody>
+                    <a:bodyPr/>
+                    <a:lstStyle/>
+                    <a:p>
+                      <a:pPr indent="0" marL="0">
+                        <a:buNone/>
+                      </a:pPr>
+                      <a:r>
+                        <a:rPr lang="en-US" sz="950" dirty="0">
+                          <a:solidFill>
+                            <a:srgbClr val="5B6B73"/>
+                          </a:solidFill>
+                          <a:latin typeface="Calibri" pitchFamily="34" charset="0"/>
+                          <a:ea typeface="Calibri" pitchFamily="34" charset="-122"/>
+                          <a:cs typeface="Calibri" pitchFamily="34" charset="-120"/>
+                        </a:rPr>
+                        <a:t>Eficiência de Produção</a:t>
+                      </a:r>
+                      <a:endParaRPr lang="en-US" sz="950" dirty="0">
+                        <a:latin typeface="Calibri" charset="0"/>
+                        <a:ea typeface="Calibri" charset="0"/>
+                        <a:cs typeface="Calibri" charset="0"/>
+                      </a:endParaRPr>
+                    </a:p>
+                  </a:txBody>
+                  <a:tcPr marL="91440" marR="91440" marT="45720" marB="45720" anchor="ctr">
+                    <a:lnL w="6350" cap="flat" cmpd="sng" algn="ctr">
+                      <a:solidFill>
+                        <a:srgbClr val="E3E8E9"/>
+                      </a:solidFill>
+                      <a:prstDash val="solid"/>
+                      <a:round/>
+                      <a:headEnd type="none" w="med" len="med"/>
+                      <a:tailEnd type="none" w="med" len="med"/>
+                    </a:lnL>
+                    <a:lnR w="6350" cap="flat" cmpd="sng" algn="ctr">
+                      <a:solidFill>
+                        <a:srgbClr val="E3E8E9"/>
+                      </a:solidFill>
+                      <a:prstDash val="solid"/>
+                      <a:round/>
+                      <a:headEnd type="none" w="med" len="med"/>
+                      <a:tailEnd type="none" w="med" len="med"/>
+                    </a:lnR>
+                    <a:lnT w="6350" cap="flat" cmpd="sng" algn="ctr">
+                      <a:solidFill>
+                        <a:srgbClr val="E3E8E9"/>
+                      </a:solidFill>
+                      <a:prstDash val="solid"/>
+                      <a:round/>
+                      <a:headEnd type="none" w="med" len="med"/>
+                      <a:tailEnd type="none" w="med" len="med"/>
+                    </a:lnT>
+                    <a:lnB w="6350" cap="flat" cmpd="sng" algn="ctr">
+                      <a:solidFill>
+                        <a:srgbClr val="E3E8E9"/>
+                      </a:solidFill>
+                      <a:prstDash val="solid"/>
+                      <a:round/>
+                      <a:headEnd type="none" w="med" len="med"/>
+                      <a:tailEnd type="none" w="med" len="med"/>
+                    </a:lnB>
+                    <a:solidFill>
+                      <a:srgbClr val="FFFFFF"/>
+                    </a:solidFill>
+                  </a:tcPr>
+                </a:tc>
+                <a:tc>
+                  <a:txBody>
+                    <a:bodyPr/>
+                    <a:lstStyle/>
+                    <a:p>
+                      <a:pPr indent="0" marL="0">
+                        <a:buNone/>
+                      </a:pPr>
+                      <a:r>
+                        <a:rPr lang="en-US" sz="950" dirty="0">
+                          <a:solidFill>
+                            <a:srgbClr val="5B6B73"/>
+                          </a:solidFill>
+                          <a:latin typeface="Calibri" pitchFamily="34" charset="0"/>
+                          <a:ea typeface="Calibri" pitchFamily="34" charset="-122"/>
+                          <a:cs typeface="Calibri" pitchFamily="34" charset="-120"/>
+                        </a:rPr>
+                        <a:t>P&amp;Q - Processos</a:t>
+                      </a:r>
+                      <a:endParaRPr lang="en-US" sz="950" dirty="0">
+                        <a:latin typeface="Calibri" charset="0"/>
+                        <a:ea typeface="Calibri" charset="0"/>
+                        <a:cs typeface="Calibri" charset="0"/>
+                      </a:endParaRPr>
+                    </a:p>
+                  </a:txBody>
+                  <a:tcPr marL="91440" marR="91440" marT="45720" marB="45720" anchor="ctr">
+                    <a:lnL w="6350" cap="flat" cmpd="sng" algn="ctr">
+                      <a:solidFill>
+                        <a:srgbClr val="E3E8E9"/>
+                      </a:solidFill>
+                      <a:prstDash val="solid"/>
+                      <a:round/>
+                      <a:headEnd type="none" w="med" len="med"/>
+                      <a:tailEnd type="none" w="med" len="med"/>
+                    </a:lnL>
+                    <a:lnR w="6350" cap="flat" cmpd="sng" algn="ctr">
+                      <a:solidFill>
+                        <a:srgbClr val="E3E8E9"/>
+                      </a:solidFill>
+                      <a:prstDash val="solid"/>
+                      <a:round/>
+                      <a:headEnd type="none" w="med" len="med"/>
+                      <a:tailEnd type="none" w="med" len="med"/>
+                    </a:lnR>
+                    <a:lnT w="6350" cap="flat" cmpd="sng" algn="ctr">
+                      <a:solidFill>
+                        <a:srgbClr val="E3E8E9"/>
+                      </a:solidFill>
+                      <a:prstDash val="solid"/>
+                      <a:round/>
+                      <a:headEnd type="none" w="med" len="med"/>
+                      <a:tailEnd type="none" w="med" len="med"/>
+                    </a:lnT>
+                    <a:lnB w="6350" cap="flat" cmpd="sng" algn="ctr">
+                      <a:solidFill>
+                        <a:srgbClr val="E3E8E9"/>
+                      </a:solidFill>
+                      <a:prstDash val="solid"/>
+                      <a:round/>
+                      <a:headEnd type="none" w="med" len="med"/>
+                      <a:tailEnd type="none" w="med" len="med"/>
+                    </a:lnB>
+                    <a:solidFill>
+                      <a:srgbClr val="FFFFFF"/>
+                    </a:solidFill>
+                  </a:tcPr>
+                </a:tc>
+                <a:tc>
+                  <a:txBody>
+                    <a:bodyPr/>
+                    <a:lstStyle/>
+                    <a:p>
+                      <a:pPr algn="r" indent="0" marL="0">
+                        <a:buNone/>
+                      </a:pPr>
+                      <a:r>
+                        <a:rPr lang="en-US" sz="1000" b="1" dirty="0">
+                          <a:solidFill>
+                            <a:srgbClr val="0B2A3D"/>
+                          </a:solidFill>
+                          <a:latin typeface="Calibri" pitchFamily="34" charset="0"/>
+                          <a:ea typeface="Calibri" pitchFamily="34" charset="-122"/>
+                          <a:cs typeface="Calibri" pitchFamily="34" charset="-120"/>
+                        </a:rPr>
+                        <a:t>US$ 460,2 mil</a:t>
+                      </a:r>
+                      <a:endParaRPr lang="en-US" sz="1000" dirty="0">
+                        <a:latin typeface="Calibri" charset="0"/>
+                        <a:ea typeface="Calibri" charset="0"/>
+                        <a:cs typeface="Calibri" charset="0"/>
+                      </a:endParaRPr>
+                    </a:p>
+                  </a:txBody>
+                  <a:tcPr marL="91440" marR="91440" marT="45720" marB="45720" anchor="ctr">
+                    <a:lnL w="6350" cap="flat" cmpd="sng" algn="ctr">
+                      <a:solidFill>
+                        <a:srgbClr val="E3E8E9"/>
+                      </a:solidFill>
+                      <a:prstDash val="solid"/>
+                      <a:round/>
+                      <a:headEnd type="none" w="med" len="med"/>
+                      <a:tailEnd type="none" w="med" len="med"/>
+                    </a:lnL>
+                    <a:lnR w="6350" cap="flat" cmpd="sng" algn="ctr">
+                      <a:solidFill>
+                        <a:srgbClr val="E3E8E9"/>
+                      </a:solidFill>
+                      <a:prstDash val="solid"/>
+                      <a:round/>
+                      <a:headEnd type="none" w="med" len="med"/>
+                      <a:tailEnd type="none" w="med" len="med"/>
+                    </a:lnR>
+                    <a:lnT w="6350" cap="flat" cmpd="sng" algn="ctr">
+                      <a:solidFill>
+                        <a:srgbClr val="E3E8E9"/>
+                      </a:solidFill>
+                      <a:prstDash val="solid"/>
+                      <a:round/>
+                      <a:headEnd type="none" w="med" len="med"/>
+                      <a:tailEnd type="none" w="med" len="med"/>
+                    </a:lnT>
+                    <a:lnB w="6350" cap="flat" cmpd="sng" algn="ctr">
+                      <a:solidFill>
+                        <a:srgbClr val="E3E8E9"/>
+                      </a:solidFill>
+                      <a:prstDash val="solid"/>
+                      <a:round/>
+                      <a:headEnd type="none" w="med" len="med"/>
+                      <a:tailEnd type="none" w="med" len="med"/>
+                    </a:lnB>
+                    <a:solidFill>
+                      <a:srgbClr val="FFFFFF"/>
+                    </a:solidFill>
+                  </a:tcPr>
+                </a:tc>
+              </a:tr>
+              <a:tr h="288036">
+                <a:tc>
+                  <a:txBody>
+                    <a:bodyPr/>
+                    <a:lstStyle/>
+                    <a:p>
+                      <a:pPr indent="0" marL="0">
+                        <a:buNone/>
+                      </a:pPr>
+                      <a:r>
+                        <a:rPr lang="en-US" sz="1000" dirty="0">
+                          <a:solidFill>
+                            <a:srgbClr val="1C2B33"/>
+                          </a:solidFill>
+                          <a:latin typeface="Calibri" pitchFamily="34" charset="0"/>
+                          <a:ea typeface="Calibri" pitchFamily="34" charset="-122"/>
+                          <a:cs typeface="Calibri" pitchFamily="34" charset="-120"/>
+                        </a:rPr>
+                        <a:t>ESTUDOS DE ENGENHARIA</a:t>
+                      </a:r>
+                      <a:endParaRPr lang="en-US" sz="1000" dirty="0">
+                        <a:latin typeface="Calibri" charset="0"/>
+                        <a:ea typeface="Calibri" charset="0"/>
+                        <a:cs typeface="Calibri" charset="0"/>
+                      </a:endParaRPr>
+                    </a:p>
+                  </a:txBody>
+                  <a:tcPr marL="91440" marR="91440" marT="45720" marB="45720" anchor="ctr">
+                    <a:lnL w="6350" cap="flat" cmpd="sng" algn="ctr">
+                      <a:solidFill>
+                        <a:srgbClr val="E3E8E9"/>
+                      </a:solidFill>
+                      <a:prstDash val="solid"/>
+                      <a:round/>
+                      <a:headEnd type="none" w="med" len="med"/>
+                      <a:tailEnd type="none" w="med" len="med"/>
+                    </a:lnL>
+                    <a:lnR w="6350" cap="flat" cmpd="sng" algn="ctr">
+                      <a:solidFill>
+                        <a:srgbClr val="E3E8E9"/>
+                      </a:solidFill>
+                      <a:prstDash val="solid"/>
+                      <a:round/>
+                      <a:headEnd type="none" w="med" len="med"/>
+                      <a:tailEnd type="none" w="med" len="med"/>
+                    </a:lnR>
+                    <a:lnT w="6350" cap="flat" cmpd="sng" algn="ctr">
+                      <a:solidFill>
+                        <a:srgbClr val="E3E8E9"/>
+                      </a:solidFill>
+                      <a:prstDash val="solid"/>
+                      <a:round/>
+                      <a:headEnd type="none" w="med" len="med"/>
+                      <a:tailEnd type="none" w="med" len="med"/>
+                    </a:lnT>
+                    <a:lnB w="6350" cap="flat" cmpd="sng" algn="ctr">
+                      <a:solidFill>
+                        <a:srgbClr val="E3E8E9"/>
+                      </a:solidFill>
+                      <a:prstDash val="solid"/>
+                      <a:round/>
+                      <a:headEnd type="none" w="med" len="med"/>
+                      <a:tailEnd type="none" w="med" len="med"/>
+                    </a:lnB>
+                    <a:solidFill>
+                      <a:srgbClr val="F0F4F5"/>
+                    </a:solidFill>
+                  </a:tcPr>
+                </a:tc>
+                <a:tc>
+                  <a:txBody>
+                    <a:bodyPr/>
+                    <a:lstStyle/>
+                    <a:p>
+                      <a:pPr indent="0" marL="0">
+                        <a:buNone/>
+                      </a:pPr>
+                      <a:r>
+                        <a:rPr lang="en-US" sz="950" dirty="0">
+                          <a:solidFill>
+                            <a:srgbClr val="5B6B73"/>
+                          </a:solidFill>
+                          <a:latin typeface="Calibri" pitchFamily="34" charset="0"/>
+                          <a:ea typeface="Calibri" pitchFamily="34" charset="-122"/>
+                          <a:cs typeface="Calibri" pitchFamily="34" charset="-120"/>
+                        </a:rPr>
+                        <a:t>Eficiência de Produção</a:t>
+                      </a:r>
+                      <a:endParaRPr lang="en-US" sz="950" dirty="0">
+                        <a:latin typeface="Calibri" charset="0"/>
+                        <a:ea typeface="Calibri" charset="0"/>
+                        <a:cs typeface="Calibri" charset="0"/>
+                      </a:endParaRPr>
+                    </a:p>
+                  </a:txBody>
+                  <a:tcPr marL="91440" marR="91440" marT="45720" marB="45720" anchor="ctr">
+                    <a:lnL w="6350" cap="flat" cmpd="sng" algn="ctr">
+                      <a:solidFill>
+                        <a:srgbClr val="E3E8E9"/>
+                      </a:solidFill>
+                      <a:prstDash val="solid"/>
+                      <a:round/>
+                      <a:headEnd type="none" w="med" len="med"/>
+                      <a:tailEnd type="none" w="med" len="med"/>
+                    </a:lnL>
+                    <a:lnR w="6350" cap="flat" cmpd="sng" algn="ctr">
+                      <a:solidFill>
+                        <a:srgbClr val="E3E8E9"/>
+                      </a:solidFill>
+                      <a:prstDash val="solid"/>
+                      <a:round/>
+                      <a:headEnd type="none" w="med" len="med"/>
+                      <a:tailEnd type="none" w="med" len="med"/>
+                    </a:lnR>
+                    <a:lnT w="6350" cap="flat" cmpd="sng" algn="ctr">
+                      <a:solidFill>
+                        <a:srgbClr val="E3E8E9"/>
+                      </a:solidFill>
+                      <a:prstDash val="solid"/>
+                      <a:round/>
+                      <a:headEnd type="none" w="med" len="med"/>
+                      <a:tailEnd type="none" w="med" len="med"/>
+                    </a:lnT>
+                    <a:lnB w="6350" cap="flat" cmpd="sng" algn="ctr">
+                      <a:solidFill>
+                        <a:srgbClr val="E3E8E9"/>
+                      </a:solidFill>
+                      <a:prstDash val="solid"/>
+                      <a:round/>
+                      <a:headEnd type="none" w="med" len="med"/>
+                      <a:tailEnd type="none" w="med" len="med"/>
+                    </a:lnB>
+                    <a:solidFill>
+                      <a:srgbClr val="F0F4F5"/>
+                    </a:solidFill>
+                  </a:tcPr>
+                </a:tc>
+                <a:tc>
+                  <a:txBody>
+                    <a:bodyPr/>
+                    <a:lstStyle/>
+                    <a:p>
+                      <a:pPr indent="0" marL="0">
+                        <a:buNone/>
+                      </a:pPr>
+                      <a:r>
+                        <a:rPr lang="en-US" sz="950" dirty="0">
+                          <a:solidFill>
+                            <a:srgbClr val="5B6B73"/>
+                          </a:solidFill>
+                          <a:latin typeface="Calibri" pitchFamily="34" charset="0"/>
+                          <a:ea typeface="Calibri" pitchFamily="34" charset="-122"/>
+                          <a:cs typeface="Calibri" pitchFamily="34" charset="-120"/>
+                        </a:rPr>
+                        <a:t>Projetos</a:t>
+                      </a:r>
+                      <a:endParaRPr lang="en-US" sz="950" dirty="0">
+                        <a:latin typeface="Calibri" charset="0"/>
+                        <a:ea typeface="Calibri" charset="0"/>
+                        <a:cs typeface="Calibri" charset="0"/>
+                      </a:endParaRPr>
+                    </a:p>
+                  </a:txBody>
+                  <a:tcPr marL="91440" marR="91440" marT="45720" marB="45720" anchor="ctr">
+                    <a:lnL w="6350" cap="flat" cmpd="sng" algn="ctr">
+                      <a:solidFill>
+                        <a:srgbClr val="E3E8E9"/>
+                      </a:solidFill>
+                      <a:prstDash val="solid"/>
+                      <a:round/>
+                      <a:headEnd type="none" w="med" len="med"/>
+                      <a:tailEnd type="none" w="med" len="med"/>
+                    </a:lnL>
+                    <a:lnR w="6350" cap="flat" cmpd="sng" algn="ctr">
+                      <a:solidFill>
+                        <a:srgbClr val="E3E8E9"/>
+                      </a:solidFill>
+                      <a:prstDash val="solid"/>
+                      <a:round/>
+                      <a:headEnd type="none" w="med" len="med"/>
+                      <a:tailEnd type="none" w="med" len="med"/>
+                    </a:lnR>
+                    <a:lnT w="6350" cap="flat" cmpd="sng" algn="ctr">
+                      <a:solidFill>
+                        <a:srgbClr val="E3E8E9"/>
+                      </a:solidFill>
+                      <a:prstDash val="solid"/>
+                      <a:round/>
+                      <a:headEnd type="none" w="med" len="med"/>
+                      <a:tailEnd type="none" w="med" len="med"/>
+                    </a:lnT>
+                    <a:lnB w="6350" cap="flat" cmpd="sng" algn="ctr">
+                      <a:solidFill>
+                        <a:srgbClr val="E3E8E9"/>
+                      </a:solidFill>
+                      <a:prstDash val="solid"/>
+                      <a:round/>
+                      <a:headEnd type="none" w="med" len="med"/>
+                      <a:tailEnd type="none" w="med" len="med"/>
+                    </a:lnB>
+                    <a:solidFill>
+                      <a:srgbClr val="F0F4F5"/>
+                    </a:solidFill>
+                  </a:tcPr>
+                </a:tc>
+                <a:tc>
+                  <a:txBody>
+                    <a:bodyPr/>
+                    <a:lstStyle/>
+                    <a:p>
+                      <a:pPr algn="r" indent="0" marL="0">
+                        <a:buNone/>
+                      </a:pPr>
+                      <a:r>
+                        <a:rPr lang="en-US" sz="1000" b="1" dirty="0">
+                          <a:solidFill>
+                            <a:srgbClr val="0B2A3D"/>
+                          </a:solidFill>
+                          <a:latin typeface="Calibri" pitchFamily="34" charset="0"/>
+                          <a:ea typeface="Calibri" pitchFamily="34" charset="-122"/>
+                          <a:cs typeface="Calibri" pitchFamily="34" charset="-120"/>
+                        </a:rPr>
+                        <a:t>US$ 430,5 mil</a:t>
+                      </a:r>
+                      <a:endParaRPr lang="en-US" sz="1000" dirty="0">
+                        <a:latin typeface="Calibri" charset="0"/>
+                        <a:ea typeface="Calibri" charset="0"/>
+                        <a:cs typeface="Calibri" charset="0"/>
+                      </a:endParaRPr>
+                    </a:p>
+                  </a:txBody>
+                  <a:tcPr marL="91440" marR="91440" marT="45720" marB="45720" anchor="ctr">
+                    <a:lnL w="6350" cap="flat" cmpd="sng" algn="ctr">
+                      <a:solidFill>
+                        <a:srgbClr val="E3E8E9"/>
+                      </a:solidFill>
+                      <a:prstDash val="solid"/>
+                      <a:round/>
+                      <a:headEnd type="none" w="med" len="med"/>
+                      <a:tailEnd type="none" w="med" len="med"/>
+                    </a:lnL>
+                    <a:lnR w="6350" cap="flat" cmpd="sng" algn="ctr">
+                      <a:solidFill>
+                        <a:srgbClr val="E3E8E9"/>
+                      </a:solidFill>
+                      <a:prstDash val="solid"/>
+                      <a:round/>
+                      <a:headEnd type="none" w="med" len="med"/>
+                      <a:tailEnd type="none" w="med" len="med"/>
+                    </a:lnR>
+                    <a:lnT w="6350" cap="flat" cmpd="sng" algn="ctr">
+                      <a:solidFill>
+                        <a:srgbClr val="E3E8E9"/>
+                      </a:solidFill>
+                      <a:prstDash val="solid"/>
+                      <a:round/>
+                      <a:headEnd type="none" w="med" len="med"/>
+                      <a:tailEnd type="none" w="med" len="med"/>
+                    </a:lnT>
+                    <a:lnB w="6350" cap="flat" cmpd="sng" algn="ctr">
+                      <a:solidFill>
+                        <a:srgbClr val="E3E8E9"/>
+                      </a:solidFill>
+                      <a:prstDash val="solid"/>
+                      <a:round/>
+                      <a:headEnd type="none" w="med" len="med"/>
+                      <a:tailEnd type="none" w="med" len="med"/>
+                    </a:lnB>
+                    <a:solidFill>
+                      <a:srgbClr val="F0F4F5"/>
+                    </a:solidFill>
+                  </a:tcPr>
+                </a:tc>
+              </a:tr>
+              <a:tr h="288036">
+                <a:tc>
+                  <a:txBody>
+                    <a:bodyPr/>
+                    <a:lstStyle/>
+                    <a:p>
+                      <a:pPr indent="0" marL="0">
+                        <a:buNone/>
+                      </a:pPr>
+                      <a:r>
+                        <a:rPr lang="en-US" sz="1000" dirty="0">
+                          <a:solidFill>
+                            <a:srgbClr val="1C2B33"/>
+                          </a:solidFill>
+                          <a:latin typeface="Calibri" pitchFamily="34" charset="0"/>
+                          <a:ea typeface="Calibri" pitchFamily="34" charset="-122"/>
+                          <a:cs typeface="Calibri" pitchFamily="34" charset="-120"/>
+                        </a:rPr>
+                        <a:t>SUBSTITUIÇÃO CABO SANSO - HAWSER WINCH</a:t>
+                      </a:r>
+                      <a:endParaRPr lang="en-US" sz="1000" dirty="0">
+                        <a:latin typeface="Calibri" charset="0"/>
+                        <a:ea typeface="Calibri" charset="0"/>
+                        <a:cs typeface="Calibri" charset="0"/>
+                      </a:endParaRPr>
+                    </a:p>
+                  </a:txBody>
+                  <a:tcPr marL="91440" marR="91440" marT="45720" marB="45720" anchor="ctr">
+                    <a:lnL w="6350" cap="flat" cmpd="sng" algn="ctr">
+                      <a:solidFill>
+                        <a:srgbClr val="E3E8E9"/>
+                      </a:solidFill>
+                      <a:prstDash val="solid"/>
+                      <a:round/>
+                      <a:headEnd type="none" w="med" len="med"/>
+                      <a:tailEnd type="none" w="med" len="med"/>
+                    </a:lnL>
+                    <a:lnR w="6350" cap="flat" cmpd="sng" algn="ctr">
+                      <a:solidFill>
+                        <a:srgbClr val="E3E8E9"/>
+                      </a:solidFill>
+                      <a:prstDash val="solid"/>
+                      <a:round/>
+                      <a:headEnd type="none" w="med" len="med"/>
+                      <a:tailEnd type="none" w="med" len="med"/>
+                    </a:lnR>
+                    <a:lnT w="6350" cap="flat" cmpd="sng" algn="ctr">
+                      <a:solidFill>
+                        <a:srgbClr val="E3E8E9"/>
+                      </a:solidFill>
+                      <a:prstDash val="solid"/>
+                      <a:round/>
+                      <a:headEnd type="none" w="med" len="med"/>
+                      <a:tailEnd type="none" w="med" len="med"/>
+                    </a:lnT>
+                    <a:lnB w="6350" cap="flat" cmpd="sng" algn="ctr">
+                      <a:solidFill>
+                        <a:srgbClr val="E3E8E9"/>
+                      </a:solidFill>
+                      <a:prstDash val="solid"/>
+                      <a:round/>
+                      <a:headEnd type="none" w="med" len="med"/>
+                      <a:tailEnd type="none" w="med" len="med"/>
+                    </a:lnB>
+                    <a:solidFill>
+                      <a:srgbClr val="FFFFFF"/>
+                    </a:solidFill>
+                  </a:tcPr>
+                </a:tc>
+                <a:tc>
+                  <a:txBody>
+                    <a:bodyPr/>
+                    <a:lstStyle/>
+                    <a:p>
+                      <a:pPr indent="0" marL="0">
+                        <a:buNone/>
+                      </a:pPr>
+                      <a:r>
+                        <a:rPr lang="en-US" sz="950" dirty="0">
+                          <a:solidFill>
+                            <a:srgbClr val="5B6B73"/>
+                          </a:solidFill>
+                          <a:latin typeface="Calibri" pitchFamily="34" charset="0"/>
+                          <a:ea typeface="Calibri" pitchFamily="34" charset="-122"/>
+                          <a:cs typeface="Calibri" pitchFamily="34" charset="-120"/>
+                        </a:rPr>
+                        <a:t>Rotina Operacional</a:t>
+                      </a:r>
+                      <a:endParaRPr lang="en-US" sz="950" dirty="0">
+                        <a:latin typeface="Calibri" charset="0"/>
+                        <a:ea typeface="Calibri" charset="0"/>
+                        <a:cs typeface="Calibri" charset="0"/>
+                      </a:endParaRPr>
+                    </a:p>
+                  </a:txBody>
+                  <a:tcPr marL="91440" marR="91440" marT="45720" marB="45720" anchor="ctr">
+                    <a:lnL w="6350" cap="flat" cmpd="sng" algn="ctr">
+                      <a:solidFill>
+                        <a:srgbClr val="E3E8E9"/>
+                      </a:solidFill>
+                      <a:prstDash val="solid"/>
+                      <a:round/>
+                      <a:headEnd type="none" w="med" len="med"/>
+                      <a:tailEnd type="none" w="med" len="med"/>
+                    </a:lnL>
+                    <a:lnR w="6350" cap="flat" cmpd="sng" algn="ctr">
+                      <a:solidFill>
+                        <a:srgbClr val="E3E8E9"/>
+                      </a:solidFill>
+                      <a:prstDash val="solid"/>
+                      <a:round/>
+                      <a:headEnd type="none" w="med" len="med"/>
+                      <a:tailEnd type="none" w="med" len="med"/>
+                    </a:lnR>
+                    <a:lnT w="6350" cap="flat" cmpd="sng" algn="ctr">
+                      <a:solidFill>
+                        <a:srgbClr val="E3E8E9"/>
+                      </a:solidFill>
+                      <a:prstDash val="solid"/>
+                      <a:round/>
+                      <a:headEnd type="none" w="med" len="med"/>
+                      <a:tailEnd type="none" w="med" len="med"/>
+                    </a:lnT>
+                    <a:lnB w="6350" cap="flat" cmpd="sng" algn="ctr">
+                      <a:solidFill>
+                        <a:srgbClr val="E3E8E9"/>
+                      </a:solidFill>
+                      <a:prstDash val="solid"/>
+                      <a:round/>
+                      <a:headEnd type="none" w="med" len="med"/>
+                      <a:tailEnd type="none" w="med" len="med"/>
+                    </a:lnB>
+                    <a:solidFill>
+                      <a:srgbClr val="FFFFFF"/>
+                    </a:solidFill>
+                  </a:tcPr>
+                </a:tc>
+                <a:tc>
+                  <a:txBody>
+                    <a:bodyPr/>
+                    <a:lstStyle/>
+                    <a:p>
+                      <a:pPr indent="0" marL="0">
+                        <a:buNone/>
+                      </a:pPr>
+                      <a:r>
+                        <a:rPr lang="en-US" sz="950" dirty="0">
+                          <a:solidFill>
+                            <a:srgbClr val="5B6B73"/>
+                          </a:solidFill>
+                          <a:latin typeface="Calibri" pitchFamily="34" charset="0"/>
+                          <a:ea typeface="Calibri" pitchFamily="34" charset="-122"/>
+                          <a:cs typeface="Calibri" pitchFamily="34" charset="-120"/>
+                        </a:rPr>
+                        <a:t>NAV - Naval</a:t>
+                      </a:r>
+                      <a:endParaRPr lang="en-US" sz="950" dirty="0">
+                        <a:latin typeface="Calibri" charset="0"/>
+                        <a:ea typeface="Calibri" charset="0"/>
+                        <a:cs typeface="Calibri" charset="0"/>
+                      </a:endParaRPr>
+                    </a:p>
+                  </a:txBody>
+                  <a:tcPr marL="91440" marR="91440" marT="45720" marB="45720" anchor="ctr">
+                    <a:lnL w="6350" cap="flat" cmpd="sng" algn="ctr">
+                      <a:solidFill>
+                        <a:srgbClr val="E3E8E9"/>
+                      </a:solidFill>
+                      <a:prstDash val="solid"/>
+                      <a:round/>
+                      <a:headEnd type="none" w="med" len="med"/>
+                      <a:tailEnd type="none" w="med" len="med"/>
+                    </a:lnL>
+                    <a:lnR w="6350" cap="flat" cmpd="sng" algn="ctr">
+                      <a:solidFill>
+                        <a:srgbClr val="E3E8E9"/>
+                      </a:solidFill>
+                      <a:prstDash val="solid"/>
+                      <a:round/>
+                      <a:headEnd type="none" w="med" len="med"/>
+                      <a:tailEnd type="none" w="med" len="med"/>
+                    </a:lnR>
+                    <a:lnT w="6350" cap="flat" cmpd="sng" algn="ctr">
+                      <a:solidFill>
+                        <a:srgbClr val="E3E8E9"/>
+                      </a:solidFill>
+                      <a:prstDash val="solid"/>
+                      <a:round/>
+                      <a:headEnd type="none" w="med" len="med"/>
+                      <a:tailEnd type="none" w="med" len="med"/>
+                    </a:lnT>
+                    <a:lnB w="6350" cap="flat" cmpd="sng" algn="ctr">
+                      <a:solidFill>
+                        <a:srgbClr val="E3E8E9"/>
+                      </a:solidFill>
+                      <a:prstDash val="solid"/>
+                      <a:round/>
+                      <a:headEnd type="none" w="med" len="med"/>
+                      <a:tailEnd type="none" w="med" len="med"/>
+                    </a:lnB>
+                    <a:solidFill>
+                      <a:srgbClr val="FFFFFF"/>
+                    </a:solidFill>
+                  </a:tcPr>
+                </a:tc>
+                <a:tc>
+                  <a:txBody>
+                    <a:bodyPr/>
+                    <a:lstStyle/>
+                    <a:p>
+                      <a:pPr algn="r" indent="0" marL="0">
+                        <a:buNone/>
+                      </a:pPr>
+                      <a:r>
+                        <a:rPr lang="en-US" sz="1000" b="1" dirty="0">
+                          <a:solidFill>
+                            <a:srgbClr val="0B2A3D"/>
+                          </a:solidFill>
+                          <a:latin typeface="Calibri" pitchFamily="34" charset="0"/>
+                          <a:ea typeface="Calibri" pitchFamily="34" charset="-122"/>
+                          <a:cs typeface="Calibri" pitchFamily="34" charset="-120"/>
+                        </a:rPr>
+                        <a:t>US$ 429,7 mil</a:t>
+                      </a:r>
+                      <a:endParaRPr lang="en-US" sz="1000" dirty="0">
+                        <a:latin typeface="Calibri" charset="0"/>
+                        <a:ea typeface="Calibri" charset="0"/>
+                        <a:cs typeface="Calibri" charset="0"/>
+                      </a:endParaRPr>
+                    </a:p>
+                  </a:txBody>
+                  <a:tcPr marL="91440" marR="91440" marT="45720" marB="45720" anchor="ctr">
+                    <a:lnL w="6350" cap="flat" cmpd="sng" algn="ctr">
+                      <a:solidFill>
+                        <a:srgbClr val="E3E8E9"/>
+                      </a:solidFill>
+                      <a:prstDash val="solid"/>
+                      <a:round/>
+                      <a:headEnd type="none" w="med" len="med"/>
+                      <a:tailEnd type="none" w="med" len="med"/>
+                    </a:lnL>
+                    <a:lnR w="6350" cap="flat" cmpd="sng" algn="ctr">
+                      <a:solidFill>
+                        <a:srgbClr val="E3E8E9"/>
+                      </a:solidFill>
+                      <a:prstDash val="solid"/>
+                      <a:round/>
+                      <a:headEnd type="none" w="med" len="med"/>
+                      <a:tailEnd type="none" w="med" len="med"/>
+                    </a:lnR>
+                    <a:lnT w="6350" cap="flat" cmpd="sng" algn="ctr">
+                      <a:solidFill>
+                        <a:srgbClr val="E3E8E9"/>
+                      </a:solidFill>
+                      <a:prstDash val="solid"/>
+                      <a:round/>
+                      <a:headEnd type="none" w="med" len="med"/>
+                      <a:tailEnd type="none" w="med" len="med"/>
+                    </a:lnT>
+                    <a:lnB w="6350" cap="flat" cmpd="sng" algn="ctr">
+                      <a:solidFill>
+                        <a:srgbClr val="E3E8E9"/>
+                      </a:solidFill>
+                      <a:prstDash val="solid"/>
+                      <a:round/>
+                      <a:headEnd type="none" w="med" len="med"/>
+                      <a:tailEnd type="none" w="med" len="med"/>
+                    </a:lnB>
+                    <a:solidFill>
+                      <a:srgbClr val="FFFFFF"/>
+                    </a:solidFill>
+                  </a:tcPr>
+                </a:tc>
+              </a:tr>
+              <a:tr h="288036">
+                <a:tc gridSpan="3">
+                  <a:txBody>
+                    <a:bodyPr/>
+                    <a:lstStyle/>
+                    <a:p>
+                      <a:pPr indent="0" marL="0">
+                        <a:buNone/>
+                      </a:pPr>
+                      <a:r>
+                        <a:rPr lang="en-US" sz="950" i="1" dirty="0">
+                          <a:solidFill>
+                            <a:srgbClr val="145C68"/>
+                          </a:solidFill>
+                          <a:latin typeface="Calibri" pitchFamily="34" charset="0"/>
+                          <a:ea typeface="Calibri" pitchFamily="34" charset="-122"/>
+                          <a:cs typeface="Calibri" pitchFamily="34" charset="-120"/>
+                        </a:rPr>
+                        <a:t>Outros 62 escopos (itens de menor valor individual)</a:t>
+                      </a:r>
+                      <a:endParaRPr lang="en-US" sz="950" dirty="0">
+                        <a:latin typeface="Calibri" charset="0"/>
+                        <a:ea typeface="Calibri" charset="0"/>
+                        <a:cs typeface="Calibri" charset="0"/>
+                      </a:endParaRPr>
+                    </a:p>
+                  </a:txBody>
+                  <a:tcPr marL="91440" marR="91440" marT="45720" marB="45720" anchor="ctr">
+                    <a:lnL w="6350" cap="flat" cmpd="sng" algn="ctr">
+                      <a:solidFill>
+                        <a:srgbClr val="E3E8E9"/>
+                      </a:solidFill>
+                      <a:prstDash val="solid"/>
+                      <a:round/>
+                      <a:headEnd type="none" w="med" len="med"/>
+                      <a:tailEnd type="none" w="med" len="med"/>
+                    </a:lnL>
+                    <a:lnR w="6350" cap="flat" cmpd="sng" algn="ctr">
+                      <a:solidFill>
+                        <a:srgbClr val="E3E8E9"/>
+                      </a:solidFill>
+                      <a:prstDash val="solid"/>
+                      <a:round/>
+                      <a:headEnd type="none" w="med" len="med"/>
+                      <a:tailEnd type="none" w="med" len="med"/>
+                    </a:lnR>
+                    <a:lnT w="6350" cap="flat" cmpd="sng" algn="ctr">
+                      <a:solidFill>
+                        <a:srgbClr val="E3E8E9"/>
+                      </a:solidFill>
+                      <a:prstDash val="solid"/>
+                      <a:round/>
+                      <a:headEnd type="none" w="med" len="med"/>
+                      <a:tailEnd type="none" w="med" len="med"/>
+                    </a:lnT>
+                    <a:lnB w="6350" cap="flat" cmpd="sng" algn="ctr">
+                      <a:solidFill>
+                        <a:srgbClr val="E3E8E9"/>
+                      </a:solidFill>
+                      <a:prstDash val="solid"/>
+                      <a:round/>
+                      <a:headEnd type="none" w="med" len="med"/>
+                      <a:tailEnd type="none" w="med" len="med"/>
+                    </a:lnB>
+                    <a:solidFill>
+                      <a:srgbClr val="DCE8E2"/>
+                    </a:solidFill>
+                  </a:tcPr>
+                </a:tc>
+                <a:tc hMerge="1">
+                  <a:tcPr/>
+                </a:tc>
+                <a:tc hMerge="1">
+                  <a:tcPr/>
+                </a:tc>
+                <a:tc>
+                  <a:txBody>
+                    <a:bodyPr/>
+                    <a:lstStyle/>
+                    <a:p>
+                      <a:pPr algn="r" indent="0" marL="0">
+                        <a:buNone/>
+                      </a:pPr>
+                      <a:r>
+                        <a:rPr lang="en-US" sz="1000" b="1" i="1" dirty="0">
+                          <a:solidFill>
+                            <a:srgbClr val="0B2A3D"/>
+                          </a:solidFill>
+                          <a:latin typeface="Calibri" pitchFamily="34" charset="0"/>
+                          <a:ea typeface="Calibri" pitchFamily="34" charset="-122"/>
+                          <a:cs typeface="Calibri" pitchFamily="34" charset="-120"/>
+                        </a:rPr>
+                        <a:t>US$ 8,7 mi</a:t>
+                      </a:r>
+                      <a:endParaRPr lang="en-US" sz="1000" dirty="0">
+                        <a:latin typeface="Calibri" charset="0"/>
+                        <a:ea typeface="Calibri" charset="0"/>
+                        <a:cs typeface="Calibri" charset="0"/>
+                      </a:endParaRPr>
+                    </a:p>
+                  </a:txBody>
+                  <a:tcPr marL="91440" marR="91440" marT="45720" marB="45720" anchor="ctr">
+                    <a:lnL w="6350" cap="flat" cmpd="sng" algn="ctr">
+                      <a:solidFill>
+                        <a:srgbClr val="E3E8E9"/>
+                      </a:solidFill>
+                      <a:prstDash val="solid"/>
+                      <a:round/>
+                      <a:headEnd type="none" w="med" len="med"/>
+                      <a:tailEnd type="none" w="med" len="med"/>
+                    </a:lnL>
+                    <a:lnR w="6350" cap="flat" cmpd="sng" algn="ctr">
+                      <a:solidFill>
+                        <a:srgbClr val="E3E8E9"/>
+                      </a:solidFill>
+                      <a:prstDash val="solid"/>
+                      <a:round/>
+                      <a:headEnd type="none" w="med" len="med"/>
+                      <a:tailEnd type="none" w="med" len="med"/>
+                    </a:lnR>
+                    <a:lnT w="6350" cap="flat" cmpd="sng" algn="ctr">
+                      <a:solidFill>
+                        <a:srgbClr val="E3E8E9"/>
+                      </a:solidFill>
+                      <a:prstDash val="solid"/>
+                      <a:round/>
+                      <a:headEnd type="none" w="med" len="med"/>
+                      <a:tailEnd type="none" w="med" len="med"/>
+                    </a:lnT>
+                    <a:lnB w="6350" cap="flat" cmpd="sng" algn="ctr">
+                      <a:solidFill>
+                        <a:srgbClr val="E3E8E9"/>
+                      </a:solidFill>
+                      <a:prstDash val="solid"/>
+                      <a:round/>
+                      <a:headEnd type="none" w="med" len="med"/>
+                      <a:tailEnd type="none" w="med" len="med"/>
+                    </a:lnB>
+                    <a:solidFill>
+                      <a:srgbClr val="DCE8E2"/>
+                    </a:solidFill>
+                  </a:tcPr>
+                </a:tc>
+              </a:tr>
+            </a:tbl>
+          </a:graphicData>
+        </a:graphic>
+      </p:graphicFrame>
+      <p:sp>
+        <p:nvSpPr>
+          <p:cNvPr id="7" name="Text 4"/>
+          <p:cNvSpPr txBox="1"/>
+          <p:nvPr/>
+        </p:nvSpPr>
+        <p:spPr>
+          <a:xfrm>
+            <a:off x="457200" y="6355080"/>
+            <a:ext cx="11247120" cy="365760"/>
+          </a:xfrm>
+          <a:prstGeom prst="rect">
+            <a:avLst/>
+          </a:prstGeom>
+          <a:noFill/>
+          <a:ln/>
+        </p:spPr>
+        <p:txBody>
+          <a:bodyPr wrap="square" lIns="0" tIns="0" rIns="0" bIns="0" rtlCol="0" anchor="ctr"/>
+          <a:lstStyle/>
+          <a:p>
+            <a:pPr indent="0" marL="0">
+              <a:buNone/>
+            </a:pPr>
+            <a:r>
+              <a:rPr lang="en-US" sz="850" i="1" dirty="0">
+                <a:solidFill>
+                  <a:srgbClr val="8A979D"/>
+                </a:solidFill>
+                <a:latin typeface="Calibri" pitchFamily="34" charset="0"/>
+                <a:ea typeface="Calibri" pitchFamily="34" charset="-122"/>
+                <a:cs typeface="Calibri" pitchFamily="34" charset="-120"/>
+              </a:rPr>
+              <a:t>Fonte: Plano Integrado · aba 'Geral - Em análise' · coluna 'Valor Total' · itens de Cost Allocation = CAPEX, status 'Contar' (não inclui Parada Programada, status 'TA'). Lista completa disponível na planilha em anexo.</a:t>
+            </a:r>
+            <a:endParaRPr lang="en-US" sz="850" dirty="0"/>
+          </a:p>
+        </p:txBody>
+      </p:sp>
+    </p:spTree>
+  </p:cSld>
+  <p:clrMapOvr>
+    <a:masterClrMapping/>
+  </p:clrMapOvr>
+</p:sld>
+</file>
+
 <file path=ppt/slides/slide3.xml><?xml version="1.0" encoding="utf-8"?>
 <p:sld xmlns:a="http://schemas.openxmlformats.org/drawingml/2006/main" xmlns:r="http://schemas.openxmlformats.org/officeDocument/2006/relationships" xmlns:p="http://schemas.openxmlformats.org/presentationml/2006/main">
   <p:cSld name="Slide 3">

</xml_diff>

<commit_message>
Update FPSO Bravo and Polvo A from revised Cluster Sul spreadsheet
Recalcula Composição de Custo, Escopos do CAPEX e a Visão Executiva
de FPSO Bravo e Polvo A a partir da planilha 'CLUSTER SUL' revisada.

- FPSO Bravo: CAPEX Total US$ 14,0 mi -> US$ 19,1 mi (Custo sem TA
  US$ 14,0 mi + Custo TA US$ 5,0 mi)
- Polvo A: CAPEX Total US$ 4,3 mi -> US$ 3,6 mi (Custo sem TA
  US$ 3,0 mi + Custo TA US$ 592,3 mil)

Ambos batem com a aba Overview do arquivo revisado (cluster:
US$ 22,7 mi). Atualiza o deck completo (7 ativos, novo total
US$ 115,0 mi) e o arquivo isolado do Cluster Sul.

Co-Authored-By: Claude Sonnet 5 <noreply@anthropic.com>
Claude-Session: https://claude.ai/code/session_01QXLKdFvqaqrRbUKxEFJW9L
</commit_message>
<xml_diff>
--- a/PRIO_Plano_Trabalho_CAPEX_2027.pptx
+++ b/PRIO_Plano_Trabalho_CAPEX_2027.pptx
@@ -314,10 +314,10 @@
                   <c:v>2.55</c:v>
                 </c:pt>
                 <c:pt idx="4">
-                  <c:v>13.98</c:v>
+                  <c:v>19.05</c:v>
                 </c:pt>
                 <c:pt idx="5">
-                  <c:v>4.28</c:v>
+                  <c:v>3.64</c:v>
                 </c:pt>
                 <c:pt idx="6">
                   <c:v>66.26</c:v>
@@ -11672,7 +11672,7 @@
                 <a:ea typeface="Cambria" pitchFamily="34" charset="-122"/>
                 <a:cs typeface="Cambria" pitchFamily="34" charset="-120"/>
               </a:rPr>
-              <a:t>US$ 14,0 mi</a:t>
+              <a:t>US$ 19,1 mi</a:t>
             </a:r>
             <a:endParaRPr lang="en-US" sz="3300" dirty="0"/>
           </a:p>
@@ -11811,7 +11811,7 @@
                 <a:ea typeface="Cambria" pitchFamily="34" charset="-122"/>
                 <a:cs typeface="Cambria" pitchFamily="34" charset="-120"/>
               </a:rPr>
-              <a:t>US$ 9,0 mi</a:t>
+              <a:t>US$ 14,0 mi</a:t>
             </a:r>
             <a:endParaRPr lang="en-US" sz="1800" dirty="0"/>
           </a:p>
@@ -12011,7 +12011,7 @@
                 <a:ea typeface="Cambria" pitchFamily="34" charset="-122"/>
                 <a:cs typeface="Cambria" pitchFamily="34" charset="-120"/>
               </a:rPr>
-              <a:t>US$ 3,8 mi</a:t>
+              <a:t>US$ 6,0 mi</a:t>
             </a:r>
             <a:endParaRPr lang="en-US" sz="1800" dirty="0"/>
           </a:p>
@@ -12111,7 +12111,7 @@
                 <a:ea typeface="Cambria" pitchFamily="34" charset="-122"/>
                 <a:cs typeface="Cambria" pitchFamily="34" charset="-120"/>
               </a:rPr>
-              <a:t>US$ 10,2 mi</a:t>
+              <a:t>US$ 13,1 mi</a:t>
             </a:r>
             <a:endParaRPr lang="en-US" sz="1800" dirty="0"/>
           </a:p>
@@ -12290,7 +12290,7 @@
                 <a:ea typeface="Calibri" pitchFamily="34" charset="-122"/>
                 <a:cs typeface="Calibri" pitchFamily="34" charset="-120"/>
               </a:rPr>
-              <a:t>US$ 5,6 mi</a:t>
+              <a:t>US$ 8,6 mi</a:t>
             </a:r>
             <a:endParaRPr lang="en-US" sz="1100" dirty="0"/>
           </a:p>
@@ -12427,6 +12427,104 @@
                 <a:ea typeface="Calibri" pitchFamily="34" charset="-122"/>
                 <a:cs typeface="Calibri" pitchFamily="34" charset="-120"/>
               </a:rPr>
+              <a:t>P&amp;Q - Processos</a:t>
+            </a:r>
+            <a:endParaRPr lang="en-US" sz="1100" dirty="0"/>
+          </a:p>
+        </p:txBody>
+      </p:sp>
+      <p:sp>
+        <p:nvSpPr>
+          <p:cNvPr id="30" name="Text 28"/>
+          <p:cNvSpPr txBox="1"/>
+          <p:nvPr/>
+        </p:nvSpPr>
+        <p:spPr>
+          <a:xfrm>
+            <a:off x="3773729" y="4133088"/>
+            <a:ext cx="1815998" cy="365760"/>
+          </a:xfrm>
+          <a:prstGeom prst="rect">
+            <a:avLst/>
+          </a:prstGeom>
+          <a:noFill/>
+          <a:ln/>
+        </p:spPr>
+        <p:txBody>
+          <a:bodyPr wrap="square" lIns="0" tIns="0" rIns="0" bIns="0" rtlCol="0" anchor="ctr"/>
+          <a:lstStyle/>
+          <a:p>
+            <a:pPr algn="r" indent="0" marL="0">
+              <a:buNone/>
+            </a:pPr>
+            <a:r>
+              <a:rPr lang="en-US" sz="1100" b="1" dirty="0">
+                <a:solidFill>
+                  <a:srgbClr val="0B2A3D"/>
+                </a:solidFill>
+                <a:latin typeface="Calibri" pitchFamily="34" charset="0"/>
+                <a:ea typeface="Calibri" pitchFamily="34" charset="-122"/>
+                <a:cs typeface="Calibri" pitchFamily="34" charset="-120"/>
+              </a:rPr>
+              <a:t>US$ 2,1 mi</a:t>
+            </a:r>
+            <a:endParaRPr lang="en-US" sz="1100" dirty="0"/>
+          </a:p>
+        </p:txBody>
+      </p:sp>
+      <p:sp>
+        <p:nvSpPr>
+          <p:cNvPr id="31" name="Shape 29"/>
+          <p:cNvSpPr/>
+          <p:nvPr/>
+        </p:nvSpPr>
+        <p:spPr>
+          <a:xfrm>
+            <a:off x="457200" y="4498848"/>
+            <a:ext cx="5349240" cy="365760"/>
+          </a:xfrm>
+          <a:prstGeom prst="rect">
+            <a:avLst/>
+          </a:prstGeom>
+          <a:solidFill>
+            <a:srgbClr val="F0F4F5"/>
+          </a:solidFill>
+          <a:ln/>
+        </p:spPr>
+      </p:sp>
+      <p:sp>
+        <p:nvSpPr>
+          <p:cNvPr id="32" name="Text 30"/>
+          <p:cNvSpPr txBox="1"/>
+          <p:nvPr/>
+        </p:nvSpPr>
+        <p:spPr>
+          <a:xfrm>
+            <a:off x="566928" y="4498848"/>
+            <a:ext cx="3316529" cy="365760"/>
+          </a:xfrm>
+          <a:prstGeom prst="rect">
+            <a:avLst/>
+          </a:prstGeom>
+          <a:noFill/>
+          <a:ln/>
+        </p:spPr>
+        <p:txBody>
+          <a:bodyPr wrap="square" lIns="0" tIns="0" rIns="0" bIns="0" rtlCol="0" anchor="ctr"/>
+          <a:lstStyle/>
+          <a:p>
+            <a:pPr indent="0" marL="0">
+              <a:buNone/>
+            </a:pPr>
+            <a:r>
+              <a:rPr lang="en-US" sz="1100" dirty="0">
+                <a:solidFill>
+                  <a:srgbClr val="1C2B33"/>
+                </a:solidFill>
+                <a:latin typeface="Calibri" pitchFamily="34" charset="0"/>
+                <a:ea typeface="Calibri" pitchFamily="34" charset="-122"/>
+                <a:cs typeface="Calibri" pitchFamily="34" charset="-120"/>
+              </a:rPr>
               <a:t>Projetos</a:t>
             </a:r>
             <a:endParaRPr lang="en-US" sz="1100" dirty="0"/>
@@ -12435,13 +12533,13 @@
       </p:sp>
       <p:sp>
         <p:nvSpPr>
-          <p:cNvPr id="30" name="Text 28"/>
+          <p:cNvPr id="33" name="Text 31"/>
           <p:cNvSpPr txBox="1"/>
           <p:nvPr/>
         </p:nvSpPr>
         <p:spPr>
           <a:xfrm>
-            <a:off x="3773729" y="4133088"/>
+            <a:off x="3773729" y="4498848"/>
             <a:ext cx="1815998" cy="365760"/>
           </a:xfrm>
           <a:prstGeom prst="rect">
@@ -12474,33 +12572,13 @@
       </p:sp>
       <p:sp>
         <p:nvSpPr>
-          <p:cNvPr id="31" name="Shape 29"/>
-          <p:cNvSpPr/>
+          <p:cNvPr id="34" name="Text 32"/>
+          <p:cNvSpPr txBox="1"/>
           <p:nvPr/>
         </p:nvSpPr>
         <p:spPr>
           <a:xfrm>
-            <a:off x="457200" y="4498848"/>
-            <a:ext cx="5349240" cy="365760"/>
-          </a:xfrm>
-          <a:prstGeom prst="rect">
-            <a:avLst/>
-          </a:prstGeom>
-          <a:solidFill>
-            <a:srgbClr val="F0F4F5"/>
-          </a:solidFill>
-          <a:ln/>
-        </p:spPr>
-      </p:sp>
-      <p:sp>
-        <p:nvSpPr>
-          <p:cNvPr id="32" name="Text 30"/>
-          <p:cNvSpPr txBox="1"/>
-          <p:nvPr/>
-        </p:nvSpPr>
-        <p:spPr>
-          <a:xfrm>
-            <a:off x="566928" y="4498848"/>
+            <a:off x="566928" y="4864608"/>
             <a:ext cx="3316529" cy="365760"/>
           </a:xfrm>
           <a:prstGeom prst="rect">
@@ -12533,13 +12611,13 @@
       </p:sp>
       <p:sp>
         <p:nvSpPr>
-          <p:cNvPr id="33" name="Text 31"/>
+          <p:cNvPr id="35" name="Text 33"/>
           <p:cNvSpPr txBox="1"/>
           <p:nvPr/>
         </p:nvSpPr>
         <p:spPr>
           <a:xfrm>
-            <a:off x="3773729" y="4498848"/>
+            <a:off x="3773729" y="4864608"/>
             <a:ext cx="1815998" cy="365760"/>
           </a:xfrm>
           <a:prstGeom prst="rect">
@@ -12572,13 +12650,33 @@
       </p:sp>
       <p:sp>
         <p:nvSpPr>
-          <p:cNvPr id="34" name="Text 32"/>
+          <p:cNvPr id="36" name="Shape 34"/>
+          <p:cNvSpPr/>
+          <p:nvPr/>
+        </p:nvSpPr>
+        <p:spPr>
+          <a:xfrm>
+            <a:off x="457200" y="5230368"/>
+            <a:ext cx="5349240" cy="365760"/>
+          </a:xfrm>
+          <a:prstGeom prst="rect">
+            <a:avLst/>
+          </a:prstGeom>
+          <a:solidFill>
+            <a:srgbClr val="F0F4F5"/>
+          </a:solidFill>
+          <a:ln/>
+        </p:spPr>
+      </p:sp>
+      <p:sp>
+        <p:nvSpPr>
+          <p:cNvPr id="37" name="Text 35"/>
           <p:cNvSpPr txBox="1"/>
           <p:nvPr/>
         </p:nvSpPr>
         <p:spPr>
           <a:xfrm>
-            <a:off x="566928" y="4864608"/>
+            <a:off x="566928" y="5230368"/>
             <a:ext cx="3316529" cy="365760"/>
           </a:xfrm>
           <a:prstGeom prst="rect">
@@ -12611,13 +12709,13 @@
       </p:sp>
       <p:sp>
         <p:nvSpPr>
-          <p:cNvPr id="35" name="Text 33"/>
+          <p:cNvPr id="38" name="Text 36"/>
           <p:cNvSpPr txBox="1"/>
           <p:nvPr/>
         </p:nvSpPr>
         <p:spPr>
           <a:xfrm>
-            <a:off x="3773729" y="4864608"/>
+            <a:off x="3773729" y="5230368"/>
             <a:ext cx="1815998" cy="365760"/>
           </a:xfrm>
           <a:prstGeom prst="rect">
@@ -12650,33 +12748,13 @@
       </p:sp>
       <p:sp>
         <p:nvSpPr>
-          <p:cNvPr id="36" name="Shape 34"/>
-          <p:cNvSpPr/>
+          <p:cNvPr id="39" name="Text 37"/>
+          <p:cNvSpPr txBox="1"/>
           <p:nvPr/>
         </p:nvSpPr>
         <p:spPr>
           <a:xfrm>
-            <a:off x="457200" y="5230368"/>
-            <a:ext cx="5349240" cy="365760"/>
-          </a:xfrm>
-          <a:prstGeom prst="rect">
-            <a:avLst/>
-          </a:prstGeom>
-          <a:solidFill>
-            <a:srgbClr val="F0F4F5"/>
-          </a:solidFill>
-          <a:ln/>
-        </p:spPr>
-      </p:sp>
-      <p:sp>
-        <p:nvSpPr>
-          <p:cNvPr id="37" name="Text 35"/>
-          <p:cNvSpPr txBox="1"/>
-          <p:nvPr/>
-        </p:nvSpPr>
-        <p:spPr>
-          <a:xfrm>
-            <a:off x="566928" y="5230368"/>
+            <a:off x="566928" y="5596128"/>
             <a:ext cx="3316529" cy="365760"/>
           </a:xfrm>
           <a:prstGeom prst="rect">
@@ -12709,84 +12787,6 @@
       </p:sp>
       <p:sp>
         <p:nvSpPr>
-          <p:cNvPr id="38" name="Text 36"/>
-          <p:cNvSpPr txBox="1"/>
-          <p:nvPr/>
-        </p:nvSpPr>
-        <p:spPr>
-          <a:xfrm>
-            <a:off x="3773729" y="5230368"/>
-            <a:ext cx="1815998" cy="365760"/>
-          </a:xfrm>
-          <a:prstGeom prst="rect">
-            <a:avLst/>
-          </a:prstGeom>
-          <a:noFill/>
-          <a:ln/>
-        </p:spPr>
-        <p:txBody>
-          <a:bodyPr wrap="square" lIns="0" tIns="0" rIns="0" bIns="0" rtlCol="0" anchor="ctr"/>
-          <a:lstStyle/>
-          <a:p>
-            <a:pPr algn="r" indent="0" marL="0">
-              <a:buNone/>
-            </a:pPr>
-            <a:r>
-              <a:rPr lang="en-US" sz="1100" b="1" dirty="0">
-                <a:solidFill>
-                  <a:srgbClr val="0B2A3D"/>
-                </a:solidFill>
-                <a:latin typeface="Calibri" pitchFamily="34" charset="0"/>
-                <a:ea typeface="Calibri" pitchFamily="34" charset="-122"/>
-                <a:cs typeface="Calibri" pitchFamily="34" charset="-120"/>
-              </a:rPr>
-              <a:t>US$ 192,5 mil</a:t>
-            </a:r>
-            <a:endParaRPr lang="en-US" sz="1100" dirty="0"/>
-          </a:p>
-        </p:txBody>
-      </p:sp>
-      <p:sp>
-        <p:nvSpPr>
-          <p:cNvPr id="39" name="Text 37"/>
-          <p:cNvSpPr txBox="1"/>
-          <p:nvPr/>
-        </p:nvSpPr>
-        <p:spPr>
-          <a:xfrm>
-            <a:off x="566928" y="5596128"/>
-            <a:ext cx="3316529" cy="365760"/>
-          </a:xfrm>
-          <a:prstGeom prst="rect">
-            <a:avLst/>
-          </a:prstGeom>
-          <a:noFill/>
-          <a:ln/>
-        </p:spPr>
-        <p:txBody>
-          <a:bodyPr wrap="square" lIns="0" tIns="0" rIns="0" bIns="0" rtlCol="0" anchor="ctr"/>
-          <a:lstStyle/>
-          <a:p>
-            <a:pPr indent="0" marL="0">
-              <a:buNone/>
-            </a:pPr>
-            <a:r>
-              <a:rPr lang="en-US" sz="1100" dirty="0">
-                <a:solidFill>
-                  <a:srgbClr val="1C2B33"/>
-                </a:solidFill>
-                <a:latin typeface="Calibri" pitchFamily="34" charset="0"/>
-                <a:ea typeface="Calibri" pitchFamily="34" charset="-122"/>
-                <a:cs typeface="Calibri" pitchFamily="34" charset="-120"/>
-              </a:rPr>
-              <a:t>P&amp;Q - Processos</a:t>
-            </a:r>
-            <a:endParaRPr lang="en-US" sz="1100" dirty="0"/>
-          </a:p>
-        </p:txBody>
-      </p:sp>
-      <p:sp>
-        <p:nvSpPr>
           <p:cNvPr id="40" name="Text 38"/>
           <p:cNvSpPr txBox="1"/>
           <p:nvPr/>
@@ -12818,7 +12818,7 @@
                 <a:ea typeface="Calibri" pitchFamily="34" charset="-122"/>
                 <a:cs typeface="Calibri" pitchFamily="34" charset="-120"/>
               </a:rPr>
-              <a:t>US$ 113,7 mil</a:t>
+              <a:t>US$ 192,5 mil</a:t>
             </a:r>
             <a:endParaRPr lang="en-US" sz="1100" dirty="0"/>
           </a:p>
@@ -12919,7 +12919,7 @@
                 <a:ea typeface="Calibri" pitchFamily="34" charset="-122"/>
                 <a:cs typeface="Calibri" pitchFamily="34" charset="-120"/>
               </a:rPr>
-              <a:t>Eficiência de Produção</a:t>
+              <a:t>Rotina Operacional</a:t>
             </a:r>
             <a:endParaRPr lang="en-US" sz="1100" dirty="0"/>
           </a:p>
@@ -12958,7 +12958,7 @@
                 <a:ea typeface="Calibri" pitchFamily="34" charset="-122"/>
                 <a:cs typeface="Calibri" pitchFamily="34" charset="-120"/>
               </a:rPr>
-              <a:t>US$ 6,0 mi</a:t>
+              <a:t>US$ 8,5 mi</a:t>
             </a:r>
             <a:endParaRPr lang="en-US" sz="1100" dirty="0"/>
           </a:p>
@@ -13017,7 +13017,7 @@
                 <a:ea typeface="Calibri" pitchFamily="34" charset="-122"/>
                 <a:cs typeface="Calibri" pitchFamily="34" charset="-120"/>
               </a:rPr>
-              <a:t>Rotina Operacional</a:t>
+              <a:t>Eficiência de Produção</a:t>
             </a:r>
             <a:endParaRPr lang="en-US" sz="1100" dirty="0"/>
           </a:p>
@@ -13056,7 +13056,7 @@
                 <a:ea typeface="Calibri" pitchFamily="34" charset="-122"/>
                 <a:cs typeface="Calibri" pitchFamily="34" charset="-120"/>
               </a:rPr>
-              <a:t>US$ 5,6 mi</a:t>
+              <a:t>US$ 6,1 mi</a:t>
             </a:r>
             <a:endParaRPr lang="en-US" sz="1100" dirty="0"/>
           </a:p>
@@ -13134,7 +13134,7 @@
                 <a:ea typeface="Calibri" pitchFamily="34" charset="-122"/>
                 <a:cs typeface="Calibri" pitchFamily="34" charset="-120"/>
               </a:rPr>
-              <a:t>US$ 1,3 mi</a:t>
+              <a:t>US$ 3,3 mi</a:t>
             </a:r>
             <a:endParaRPr lang="en-US" sz="1100" dirty="0"/>
           </a:p>
@@ -13433,7 +13433,7 @@
                 <a:ea typeface="Calibri" pitchFamily="34" charset="-122"/>
                 <a:cs typeface="Calibri" pitchFamily="34" charset="-120"/>
               </a:rPr>
-              <a:t>Principais escopos por valor · 59 itens no total</a:t>
+              <a:t>Principais escopos por valor · 70 itens no total</a:t>
             </a:r>
             <a:endParaRPr lang="en-US" sz="1250" dirty="0"/>
           </a:p>
@@ -14033,6 +14033,280 @@
                           <a:ea typeface="Calibri" pitchFamily="34" charset="-122"/>
                           <a:cs typeface="Calibri" pitchFamily="34" charset="-120"/>
                         </a:rPr>
+                        <a:t>Upgrade metering de gás e Diesel- GTGs</a:t>
+                      </a:r>
+                      <a:endParaRPr lang="en-US" sz="1000" dirty="0">
+                        <a:latin typeface="Calibri" charset="0"/>
+                        <a:ea typeface="Calibri" charset="0"/>
+                        <a:cs typeface="Calibri" charset="0"/>
+                      </a:endParaRPr>
+                    </a:p>
+                  </a:txBody>
+                  <a:tcPr marL="91440" marR="91440" marT="45720" marB="45720" anchor="ctr">
+                    <a:lnL w="6350" cap="flat" cmpd="sng" algn="ctr">
+                      <a:solidFill>
+                        <a:srgbClr val="E3E8E9"/>
+                      </a:solidFill>
+                      <a:prstDash val="solid"/>
+                      <a:round/>
+                      <a:headEnd type="none" w="med" len="med"/>
+                      <a:tailEnd type="none" w="med" len="med"/>
+                    </a:lnL>
+                    <a:lnR w="6350" cap="flat" cmpd="sng" algn="ctr">
+                      <a:solidFill>
+                        <a:srgbClr val="E3E8E9"/>
+                      </a:solidFill>
+                      <a:prstDash val="solid"/>
+                      <a:round/>
+                      <a:headEnd type="none" w="med" len="med"/>
+                      <a:tailEnd type="none" w="med" len="med"/>
+                    </a:lnR>
+                    <a:lnT w="6350" cap="flat" cmpd="sng" algn="ctr">
+                      <a:solidFill>
+                        <a:srgbClr val="E3E8E9"/>
+                      </a:solidFill>
+                      <a:prstDash val="solid"/>
+                      <a:round/>
+                      <a:headEnd type="none" w="med" len="med"/>
+                      <a:tailEnd type="none" w="med" len="med"/>
+                    </a:lnT>
+                    <a:lnB w="6350" cap="flat" cmpd="sng" algn="ctr">
+                      <a:solidFill>
+                        <a:srgbClr val="E3E8E9"/>
+                      </a:solidFill>
+                      <a:prstDash val="solid"/>
+                      <a:round/>
+                      <a:headEnd type="none" w="med" len="med"/>
+                      <a:tailEnd type="none" w="med" len="med"/>
+                    </a:lnB>
+                    <a:solidFill>
+                      <a:srgbClr val="F0F4F5"/>
+                    </a:solidFill>
+                  </a:tcPr>
+                </a:tc>
+                <a:tc>
+                  <a:txBody>
+                    <a:bodyPr/>
+                    <a:lstStyle/>
+                    <a:p>
+                      <a:pPr indent="0" marL="0">
+                        <a:buNone/>
+                      </a:pPr>
+                      <a:r>
+                        <a:rPr lang="en-US" sz="950" dirty="0">
+                          <a:solidFill>
+                            <a:srgbClr val="5B6B73"/>
+                          </a:solidFill>
+                          <a:latin typeface="Calibri" pitchFamily="34" charset="0"/>
+                          <a:ea typeface="Calibri" pitchFamily="34" charset="-122"/>
+                          <a:cs typeface="Calibri" pitchFamily="34" charset="-120"/>
+                        </a:rPr>
+                        <a:t>Rotina Operacional</a:t>
+                      </a:r>
+                      <a:endParaRPr lang="en-US" sz="950" dirty="0">
+                        <a:latin typeface="Calibri" charset="0"/>
+                        <a:ea typeface="Calibri" charset="0"/>
+                        <a:cs typeface="Calibri" charset="0"/>
+                      </a:endParaRPr>
+                    </a:p>
+                  </a:txBody>
+                  <a:tcPr marL="91440" marR="91440" marT="45720" marB="45720" anchor="ctr">
+                    <a:lnL w="6350" cap="flat" cmpd="sng" algn="ctr">
+                      <a:solidFill>
+                        <a:srgbClr val="E3E8E9"/>
+                      </a:solidFill>
+                      <a:prstDash val="solid"/>
+                      <a:round/>
+                      <a:headEnd type="none" w="med" len="med"/>
+                      <a:tailEnd type="none" w="med" len="med"/>
+                    </a:lnL>
+                    <a:lnR w="6350" cap="flat" cmpd="sng" algn="ctr">
+                      <a:solidFill>
+                        <a:srgbClr val="E3E8E9"/>
+                      </a:solidFill>
+                      <a:prstDash val="solid"/>
+                      <a:round/>
+                      <a:headEnd type="none" w="med" len="med"/>
+                      <a:tailEnd type="none" w="med" len="med"/>
+                    </a:lnR>
+                    <a:lnT w="6350" cap="flat" cmpd="sng" algn="ctr">
+                      <a:solidFill>
+                        <a:srgbClr val="E3E8E9"/>
+                      </a:solidFill>
+                      <a:prstDash val="solid"/>
+                      <a:round/>
+                      <a:headEnd type="none" w="med" len="med"/>
+                      <a:tailEnd type="none" w="med" len="med"/>
+                    </a:lnT>
+                    <a:lnB w="6350" cap="flat" cmpd="sng" algn="ctr">
+                      <a:solidFill>
+                        <a:srgbClr val="E3E8E9"/>
+                      </a:solidFill>
+                      <a:prstDash val="solid"/>
+                      <a:round/>
+                      <a:headEnd type="none" w="med" len="med"/>
+                      <a:tailEnd type="none" w="med" len="med"/>
+                    </a:lnB>
+                    <a:solidFill>
+                      <a:srgbClr val="F0F4F5"/>
+                    </a:solidFill>
+                  </a:tcPr>
+                </a:tc>
+                <a:tc>
+                  <a:txBody>
+                    <a:bodyPr/>
+                    <a:lstStyle/>
+                    <a:p>
+                      <a:pPr indent="0" marL="0">
+                        <a:buNone/>
+                      </a:pPr>
+                      <a:r>
+                        <a:rPr lang="en-US" sz="950" dirty="0">
+                          <a:solidFill>
+                            <a:srgbClr val="5B6B73"/>
+                          </a:solidFill>
+                          <a:latin typeface="Calibri" pitchFamily="34" charset="0"/>
+                          <a:ea typeface="Calibri" pitchFamily="34" charset="-122"/>
+                          <a:cs typeface="Calibri" pitchFamily="34" charset="-120"/>
+                        </a:rPr>
+                        <a:t>EIM - Manutenção &amp; Integridade</a:t>
+                      </a:r>
+                      <a:endParaRPr lang="en-US" sz="950" dirty="0">
+                        <a:latin typeface="Calibri" charset="0"/>
+                        <a:ea typeface="Calibri" charset="0"/>
+                        <a:cs typeface="Calibri" charset="0"/>
+                      </a:endParaRPr>
+                    </a:p>
+                  </a:txBody>
+                  <a:tcPr marL="91440" marR="91440" marT="45720" marB="45720" anchor="ctr">
+                    <a:lnL w="6350" cap="flat" cmpd="sng" algn="ctr">
+                      <a:solidFill>
+                        <a:srgbClr val="E3E8E9"/>
+                      </a:solidFill>
+                      <a:prstDash val="solid"/>
+                      <a:round/>
+                      <a:headEnd type="none" w="med" len="med"/>
+                      <a:tailEnd type="none" w="med" len="med"/>
+                    </a:lnL>
+                    <a:lnR w="6350" cap="flat" cmpd="sng" algn="ctr">
+                      <a:solidFill>
+                        <a:srgbClr val="E3E8E9"/>
+                      </a:solidFill>
+                      <a:prstDash val="solid"/>
+                      <a:round/>
+                      <a:headEnd type="none" w="med" len="med"/>
+                      <a:tailEnd type="none" w="med" len="med"/>
+                    </a:lnR>
+                    <a:lnT w="6350" cap="flat" cmpd="sng" algn="ctr">
+                      <a:solidFill>
+                        <a:srgbClr val="E3E8E9"/>
+                      </a:solidFill>
+                      <a:prstDash val="solid"/>
+                      <a:round/>
+                      <a:headEnd type="none" w="med" len="med"/>
+                      <a:tailEnd type="none" w="med" len="med"/>
+                    </a:lnT>
+                    <a:lnB w="6350" cap="flat" cmpd="sng" algn="ctr">
+                      <a:solidFill>
+                        <a:srgbClr val="E3E8E9"/>
+                      </a:solidFill>
+                      <a:prstDash val="solid"/>
+                      <a:round/>
+                      <a:headEnd type="none" w="med" len="med"/>
+                      <a:tailEnd type="none" w="med" len="med"/>
+                    </a:lnB>
+                    <a:solidFill>
+                      <a:srgbClr val="F0F4F5"/>
+                    </a:solidFill>
+                  </a:tcPr>
+                </a:tc>
+                <a:tc>
+                  <a:txBody>
+                    <a:bodyPr/>
+                    <a:lstStyle/>
+                    <a:p>
+                      <a:pPr algn="r" indent="0" marL="0">
+                        <a:buNone/>
+                      </a:pPr>
+                      <a:r>
+                        <a:rPr lang="en-US" sz="1000" b="1" dirty="0">
+                          <a:solidFill>
+                            <a:srgbClr val="0B2A3D"/>
+                          </a:solidFill>
+                          <a:latin typeface="Calibri" pitchFamily="34" charset="0"/>
+                          <a:ea typeface="Calibri" pitchFamily="34" charset="-122"/>
+                          <a:cs typeface="Calibri" pitchFamily="34" charset="-120"/>
+                        </a:rPr>
+                        <a:t>US$ 1,7 mi</a:t>
+                      </a:r>
+                      <a:endParaRPr lang="en-US" sz="1000" dirty="0">
+                        <a:latin typeface="Calibri" charset="0"/>
+                        <a:ea typeface="Calibri" charset="0"/>
+                        <a:cs typeface="Calibri" charset="0"/>
+                      </a:endParaRPr>
+                    </a:p>
+                  </a:txBody>
+                  <a:tcPr marL="91440" marR="91440" marT="45720" marB="45720" anchor="ctr">
+                    <a:lnL w="6350" cap="flat" cmpd="sng" algn="ctr">
+                      <a:solidFill>
+                        <a:srgbClr val="E3E8E9"/>
+                      </a:solidFill>
+                      <a:prstDash val="solid"/>
+                      <a:round/>
+                      <a:headEnd type="none" w="med" len="med"/>
+                      <a:tailEnd type="none" w="med" len="med"/>
+                    </a:lnL>
+                    <a:lnR w="6350" cap="flat" cmpd="sng" algn="ctr">
+                      <a:solidFill>
+                        <a:srgbClr val="E3E8E9"/>
+                      </a:solidFill>
+                      <a:prstDash val="solid"/>
+                      <a:round/>
+                      <a:headEnd type="none" w="med" len="med"/>
+                      <a:tailEnd type="none" w="med" len="med"/>
+                    </a:lnR>
+                    <a:lnT w="6350" cap="flat" cmpd="sng" algn="ctr">
+                      <a:solidFill>
+                        <a:srgbClr val="E3E8E9"/>
+                      </a:solidFill>
+                      <a:prstDash val="solid"/>
+                      <a:round/>
+                      <a:headEnd type="none" w="med" len="med"/>
+                      <a:tailEnd type="none" w="med" len="med"/>
+                    </a:lnT>
+                    <a:lnB w="6350" cap="flat" cmpd="sng" algn="ctr">
+                      <a:solidFill>
+                        <a:srgbClr val="E3E8E9"/>
+                      </a:solidFill>
+                      <a:prstDash val="solid"/>
+                      <a:round/>
+                      <a:headEnd type="none" w="med" len="med"/>
+                      <a:tailEnd type="none" w="med" len="med"/>
+                    </a:lnB>
+                    <a:solidFill>
+                      <a:srgbClr val="F0F4F5"/>
+                    </a:solidFill>
+                  </a:tcPr>
+                </a:tc>
+              </a:tr>
+              <a:tr h="288036">
+                <a:tc>
+                  <a:txBody>
+                    <a:bodyPr/>
+                    <a:lstStyle/>
+                    <a:p>
+                      <a:pPr indent="0" marL="0">
+                        <a:buNone/>
+                      </a:pPr>
+                      <a:r>
+                        <a:rPr lang="en-US" sz="1000" dirty="0">
+                          <a:solidFill>
+                            <a:srgbClr val="1C2B33"/>
+                          </a:solidFill>
+                          <a:latin typeface="Calibri" pitchFamily="34" charset="0"/>
+                          <a:ea typeface="Calibri" pitchFamily="34" charset="-122"/>
+                          <a:cs typeface="Calibri" pitchFamily="34" charset="-120"/>
+                        </a:rPr>
                         <a:t>TA - Mecânica</a:t>
                       </a:r>
                       <a:endParaRPr lang="en-US" sz="1000" dirty="0">
@@ -14080,7 +14354,7 @@
                       <a:tailEnd type="none" w="med" len="med"/>
                     </a:lnB>
                     <a:solidFill>
-                      <a:srgbClr val="F0F4F5"/>
+                      <a:srgbClr val="FFFFFF"/>
                     </a:solidFill>
                   </a:tcPr>
                 </a:tc>
@@ -14148,7 +14422,7 @@
                       <a:tailEnd type="none" w="med" len="med"/>
                     </a:lnB>
                     <a:solidFill>
-                      <a:srgbClr val="F0F4F5"/>
+                      <a:srgbClr val="FFFFFF"/>
                     </a:solidFill>
                   </a:tcPr>
                 </a:tc>
@@ -14216,6 +14490,280 @@
                       <a:tailEnd type="none" w="med" len="med"/>
                     </a:lnB>
                     <a:solidFill>
+                      <a:srgbClr val="FFFFFF"/>
+                    </a:solidFill>
+                  </a:tcPr>
+                </a:tc>
+                <a:tc>
+                  <a:txBody>
+                    <a:bodyPr/>
+                    <a:lstStyle/>
+                    <a:p>
+                      <a:pPr algn="r" indent="0" marL="0">
+                        <a:buNone/>
+                      </a:pPr>
+                      <a:r>
+                        <a:rPr lang="en-US" sz="1000" b="1" dirty="0">
+                          <a:solidFill>
+                            <a:srgbClr val="0B2A3D"/>
+                          </a:solidFill>
+                          <a:latin typeface="Calibri" pitchFamily="34" charset="0"/>
+                          <a:ea typeface="Calibri" pitchFamily="34" charset="-122"/>
+                          <a:cs typeface="Calibri" pitchFamily="34" charset="-120"/>
+                        </a:rPr>
+                        <a:t>US$ 1,5 mi</a:t>
+                      </a:r>
+                      <a:endParaRPr lang="en-US" sz="1000" dirty="0">
+                        <a:latin typeface="Calibri" charset="0"/>
+                        <a:ea typeface="Calibri" charset="0"/>
+                        <a:cs typeface="Calibri" charset="0"/>
+                      </a:endParaRPr>
+                    </a:p>
+                  </a:txBody>
+                  <a:tcPr marL="91440" marR="91440" marT="45720" marB="45720" anchor="ctr">
+                    <a:lnL w="6350" cap="flat" cmpd="sng" algn="ctr">
+                      <a:solidFill>
+                        <a:srgbClr val="E3E8E9"/>
+                      </a:solidFill>
+                      <a:prstDash val="solid"/>
+                      <a:round/>
+                      <a:headEnd type="none" w="med" len="med"/>
+                      <a:tailEnd type="none" w="med" len="med"/>
+                    </a:lnL>
+                    <a:lnR w="6350" cap="flat" cmpd="sng" algn="ctr">
+                      <a:solidFill>
+                        <a:srgbClr val="E3E8E9"/>
+                      </a:solidFill>
+                      <a:prstDash val="solid"/>
+                      <a:round/>
+                      <a:headEnd type="none" w="med" len="med"/>
+                      <a:tailEnd type="none" w="med" len="med"/>
+                    </a:lnR>
+                    <a:lnT w="6350" cap="flat" cmpd="sng" algn="ctr">
+                      <a:solidFill>
+                        <a:srgbClr val="E3E8E9"/>
+                      </a:solidFill>
+                      <a:prstDash val="solid"/>
+                      <a:round/>
+                      <a:headEnd type="none" w="med" len="med"/>
+                      <a:tailEnd type="none" w="med" len="med"/>
+                    </a:lnT>
+                    <a:lnB w="6350" cap="flat" cmpd="sng" algn="ctr">
+                      <a:solidFill>
+                        <a:srgbClr val="E3E8E9"/>
+                      </a:solidFill>
+                      <a:prstDash val="solid"/>
+                      <a:round/>
+                      <a:headEnd type="none" w="med" len="med"/>
+                      <a:tailEnd type="none" w="med" len="med"/>
+                    </a:lnB>
+                    <a:solidFill>
+                      <a:srgbClr val="FFFFFF"/>
+                    </a:solidFill>
+                  </a:tcPr>
+                </a:tc>
+              </a:tr>
+              <a:tr h="288036">
+                <a:tc>
+                  <a:txBody>
+                    <a:bodyPr/>
+                    <a:lstStyle/>
+                    <a:p>
+                      <a:pPr indent="0" marL="0">
+                        <a:buNone/>
+                      </a:pPr>
+                      <a:r>
+                        <a:rPr lang="en-US" sz="1000" dirty="0">
+                          <a:solidFill>
+                            <a:srgbClr val="1C2B33"/>
+                          </a:solidFill>
+                          <a:latin typeface="Calibri" pitchFamily="34" charset="0"/>
+                          <a:ea typeface="Calibri" pitchFamily="34" charset="-122"/>
+                          <a:cs typeface="Calibri" pitchFamily="34" charset="-120"/>
+                        </a:rPr>
+                        <a:t>TA - Swivel - Pacote Hidráulico (OneSubsea)</a:t>
+                      </a:r>
+                      <a:endParaRPr lang="en-US" sz="1000" dirty="0">
+                        <a:latin typeface="Calibri" charset="0"/>
+                        <a:ea typeface="Calibri" charset="0"/>
+                        <a:cs typeface="Calibri" charset="0"/>
+                      </a:endParaRPr>
+                    </a:p>
+                  </a:txBody>
+                  <a:tcPr marL="91440" marR="91440" marT="45720" marB="45720" anchor="ctr">
+                    <a:lnL w="6350" cap="flat" cmpd="sng" algn="ctr">
+                      <a:solidFill>
+                        <a:srgbClr val="E3E8E9"/>
+                      </a:solidFill>
+                      <a:prstDash val="solid"/>
+                      <a:round/>
+                      <a:headEnd type="none" w="med" len="med"/>
+                      <a:tailEnd type="none" w="med" len="med"/>
+                    </a:lnL>
+                    <a:lnR w="6350" cap="flat" cmpd="sng" algn="ctr">
+                      <a:solidFill>
+                        <a:srgbClr val="E3E8E9"/>
+                      </a:solidFill>
+                      <a:prstDash val="solid"/>
+                      <a:round/>
+                      <a:headEnd type="none" w="med" len="med"/>
+                      <a:tailEnd type="none" w="med" len="med"/>
+                    </a:lnR>
+                    <a:lnT w="6350" cap="flat" cmpd="sng" algn="ctr">
+                      <a:solidFill>
+                        <a:srgbClr val="E3E8E9"/>
+                      </a:solidFill>
+                      <a:prstDash val="solid"/>
+                      <a:round/>
+                      <a:headEnd type="none" w="med" len="med"/>
+                      <a:tailEnd type="none" w="med" len="med"/>
+                    </a:lnT>
+                    <a:lnB w="6350" cap="flat" cmpd="sng" algn="ctr">
+                      <a:solidFill>
+                        <a:srgbClr val="E3E8E9"/>
+                      </a:solidFill>
+                      <a:prstDash val="solid"/>
+                      <a:round/>
+                      <a:headEnd type="none" w="med" len="med"/>
+                      <a:tailEnd type="none" w="med" len="med"/>
+                    </a:lnB>
+                    <a:solidFill>
+                      <a:srgbClr val="F0F4F5"/>
+                    </a:solidFill>
+                  </a:tcPr>
+                </a:tc>
+                <a:tc>
+                  <a:txBody>
+                    <a:bodyPr/>
+                    <a:lstStyle/>
+                    <a:p>
+                      <a:pPr indent="0" marL="0">
+                        <a:buNone/>
+                      </a:pPr>
+                      <a:r>
+                        <a:rPr lang="en-US" sz="950" dirty="0">
+                          <a:solidFill>
+                            <a:srgbClr val="5B6B73"/>
+                          </a:solidFill>
+                          <a:latin typeface="Calibri" pitchFamily="34" charset="0"/>
+                          <a:ea typeface="Calibri" pitchFamily="34" charset="-122"/>
+                          <a:cs typeface="Calibri" pitchFamily="34" charset="-120"/>
+                        </a:rPr>
+                        <a:t>Integridade e Regulatório</a:t>
+                      </a:r>
+                      <a:endParaRPr lang="en-US" sz="950" dirty="0">
+                        <a:latin typeface="Calibri" charset="0"/>
+                        <a:ea typeface="Calibri" charset="0"/>
+                        <a:cs typeface="Calibri" charset="0"/>
+                      </a:endParaRPr>
+                    </a:p>
+                  </a:txBody>
+                  <a:tcPr marL="91440" marR="91440" marT="45720" marB="45720" anchor="ctr">
+                    <a:lnL w="6350" cap="flat" cmpd="sng" algn="ctr">
+                      <a:solidFill>
+                        <a:srgbClr val="E3E8E9"/>
+                      </a:solidFill>
+                      <a:prstDash val="solid"/>
+                      <a:round/>
+                      <a:headEnd type="none" w="med" len="med"/>
+                      <a:tailEnd type="none" w="med" len="med"/>
+                    </a:lnL>
+                    <a:lnR w="6350" cap="flat" cmpd="sng" algn="ctr">
+                      <a:solidFill>
+                        <a:srgbClr val="E3E8E9"/>
+                      </a:solidFill>
+                      <a:prstDash val="solid"/>
+                      <a:round/>
+                      <a:headEnd type="none" w="med" len="med"/>
+                      <a:tailEnd type="none" w="med" len="med"/>
+                    </a:lnR>
+                    <a:lnT w="6350" cap="flat" cmpd="sng" algn="ctr">
+                      <a:solidFill>
+                        <a:srgbClr val="E3E8E9"/>
+                      </a:solidFill>
+                      <a:prstDash val="solid"/>
+                      <a:round/>
+                      <a:headEnd type="none" w="med" len="med"/>
+                      <a:tailEnd type="none" w="med" len="med"/>
+                    </a:lnT>
+                    <a:lnB w="6350" cap="flat" cmpd="sng" algn="ctr">
+                      <a:solidFill>
+                        <a:srgbClr val="E3E8E9"/>
+                      </a:solidFill>
+                      <a:prstDash val="solid"/>
+                      <a:round/>
+                      <a:headEnd type="none" w="med" len="med"/>
+                      <a:tailEnd type="none" w="med" len="med"/>
+                    </a:lnB>
+                    <a:solidFill>
+                      <a:srgbClr val="F0F4F5"/>
+                    </a:solidFill>
+                  </a:tcPr>
+                </a:tc>
+                <a:tc>
+                  <a:txBody>
+                    <a:bodyPr/>
+                    <a:lstStyle/>
+                    <a:p>
+                      <a:pPr indent="0" marL="0">
+                        <a:buNone/>
+                      </a:pPr>
+                      <a:r>
+                        <a:rPr lang="en-US" sz="950" dirty="0">
+                          <a:solidFill>
+                            <a:srgbClr val="5B6B73"/>
+                          </a:solidFill>
+                          <a:latin typeface="Calibri" pitchFamily="34" charset="0"/>
+                          <a:ea typeface="Calibri" pitchFamily="34" charset="-122"/>
+                          <a:cs typeface="Calibri" pitchFamily="34" charset="-120"/>
+                        </a:rPr>
+                        <a:t>P&amp;Q - Processos</a:t>
+                      </a:r>
+                      <a:endParaRPr lang="en-US" sz="950" dirty="0">
+                        <a:latin typeface="Calibri" charset="0"/>
+                        <a:ea typeface="Calibri" charset="0"/>
+                        <a:cs typeface="Calibri" charset="0"/>
+                      </a:endParaRPr>
+                    </a:p>
+                  </a:txBody>
+                  <a:tcPr marL="91440" marR="91440" marT="45720" marB="45720" anchor="ctr">
+                    <a:lnL w="6350" cap="flat" cmpd="sng" algn="ctr">
+                      <a:solidFill>
+                        <a:srgbClr val="E3E8E9"/>
+                      </a:solidFill>
+                      <a:prstDash val="solid"/>
+                      <a:round/>
+                      <a:headEnd type="none" w="med" len="med"/>
+                      <a:tailEnd type="none" w="med" len="med"/>
+                    </a:lnL>
+                    <a:lnR w="6350" cap="flat" cmpd="sng" algn="ctr">
+                      <a:solidFill>
+                        <a:srgbClr val="E3E8E9"/>
+                      </a:solidFill>
+                      <a:prstDash val="solid"/>
+                      <a:round/>
+                      <a:headEnd type="none" w="med" len="med"/>
+                      <a:tailEnd type="none" w="med" len="med"/>
+                    </a:lnR>
+                    <a:lnT w="6350" cap="flat" cmpd="sng" algn="ctr">
+                      <a:solidFill>
+                        <a:srgbClr val="E3E8E9"/>
+                      </a:solidFill>
+                      <a:prstDash val="solid"/>
+                      <a:round/>
+                      <a:headEnd type="none" w="med" len="med"/>
+                      <a:tailEnd type="none" w="med" len="med"/>
+                    </a:lnT>
+                    <a:lnB w="6350" cap="flat" cmpd="sng" algn="ctr">
+                      <a:solidFill>
+                        <a:srgbClr val="E3E8E9"/>
+                      </a:solidFill>
+                      <a:prstDash val="solid"/>
+                      <a:round/>
+                      <a:headEnd type="none" w="med" len="med"/>
+                      <a:tailEnd type="none" w="med" len="med"/>
+                    </a:lnB>
+                    <a:solidFill>
                       <a:srgbClr val="F0F4F5"/>
                     </a:solidFill>
                   </a:tcPr>
@@ -14237,7 +14785,7 @@
                           <a:ea typeface="Calibri" pitchFamily="34" charset="-122"/>
                           <a:cs typeface="Calibri" pitchFamily="34" charset="-120"/>
                         </a:rPr>
-                        <a:t>US$ 1,5 mi</a:t>
+                        <a:t>US$ 1,4 mi</a:t>
                       </a:r>
                       <a:endParaRPr lang="en-US" sz="1000" dirty="0">
                         <a:latin typeface="Calibri" charset="0"/>
@@ -14855,7 +15403,7 @@
                           <a:ea typeface="Calibri" pitchFamily="34" charset="-122"/>
                           <a:cs typeface="Calibri" pitchFamily="34" charset="-120"/>
                         </a:rPr>
-                        <a:t>INSTALAÇÃO DA CARGO PUMP</a:t>
+                        <a:t>REVAMP CARGO PUMP - Nº 2</a:t>
                       </a:r>
                       <a:endParaRPr lang="en-US" sz="1000" dirty="0">
                         <a:latin typeface="Calibri" charset="0"/>
@@ -15677,6 +16225,554 @@
                           <a:ea typeface="Calibri" pitchFamily="34" charset="-122"/>
                           <a:cs typeface="Calibri" pitchFamily="34" charset="-120"/>
                         </a:rPr>
+                        <a:t>TA - Ignitor do Flare</a:t>
+                      </a:r>
+                      <a:endParaRPr lang="en-US" sz="1000" dirty="0">
+                        <a:latin typeface="Calibri" charset="0"/>
+                        <a:ea typeface="Calibri" charset="0"/>
+                        <a:cs typeface="Calibri" charset="0"/>
+                      </a:endParaRPr>
+                    </a:p>
+                  </a:txBody>
+                  <a:tcPr marL="91440" marR="91440" marT="45720" marB="45720" anchor="ctr">
+                    <a:lnL w="6350" cap="flat" cmpd="sng" algn="ctr">
+                      <a:solidFill>
+                        <a:srgbClr val="E3E8E9"/>
+                      </a:solidFill>
+                      <a:prstDash val="solid"/>
+                      <a:round/>
+                      <a:headEnd type="none" w="med" len="med"/>
+                      <a:tailEnd type="none" w="med" len="med"/>
+                    </a:lnL>
+                    <a:lnR w="6350" cap="flat" cmpd="sng" algn="ctr">
+                      <a:solidFill>
+                        <a:srgbClr val="E3E8E9"/>
+                      </a:solidFill>
+                      <a:prstDash val="solid"/>
+                      <a:round/>
+                      <a:headEnd type="none" w="med" len="med"/>
+                      <a:tailEnd type="none" w="med" len="med"/>
+                    </a:lnR>
+                    <a:lnT w="6350" cap="flat" cmpd="sng" algn="ctr">
+                      <a:solidFill>
+                        <a:srgbClr val="E3E8E9"/>
+                      </a:solidFill>
+                      <a:prstDash val="solid"/>
+                      <a:round/>
+                      <a:headEnd type="none" w="med" len="med"/>
+                      <a:tailEnd type="none" w="med" len="med"/>
+                    </a:lnT>
+                    <a:lnB w="6350" cap="flat" cmpd="sng" algn="ctr">
+                      <a:solidFill>
+                        <a:srgbClr val="E3E8E9"/>
+                      </a:solidFill>
+                      <a:prstDash val="solid"/>
+                      <a:round/>
+                      <a:headEnd type="none" w="med" len="med"/>
+                      <a:tailEnd type="none" w="med" len="med"/>
+                    </a:lnB>
+                    <a:solidFill>
+                      <a:srgbClr val="F0F4F5"/>
+                    </a:solidFill>
+                  </a:tcPr>
+                </a:tc>
+                <a:tc>
+                  <a:txBody>
+                    <a:bodyPr/>
+                    <a:lstStyle/>
+                    <a:p>
+                      <a:pPr indent="0" marL="0">
+                        <a:buNone/>
+                      </a:pPr>
+                      <a:r>
+                        <a:rPr lang="en-US" sz="950" dirty="0">
+                          <a:solidFill>
+                            <a:srgbClr val="5B6B73"/>
+                          </a:solidFill>
+                          <a:latin typeface="Calibri" pitchFamily="34" charset="0"/>
+                          <a:ea typeface="Calibri" pitchFamily="34" charset="-122"/>
+                          <a:cs typeface="Calibri" pitchFamily="34" charset="-120"/>
+                        </a:rPr>
+                        <a:t>Integridade e Regulatório</a:t>
+                      </a:r>
+                      <a:endParaRPr lang="en-US" sz="950" dirty="0">
+                        <a:latin typeface="Calibri" charset="0"/>
+                        <a:ea typeface="Calibri" charset="0"/>
+                        <a:cs typeface="Calibri" charset="0"/>
+                      </a:endParaRPr>
+                    </a:p>
+                  </a:txBody>
+                  <a:tcPr marL="91440" marR="91440" marT="45720" marB="45720" anchor="ctr">
+                    <a:lnL w="6350" cap="flat" cmpd="sng" algn="ctr">
+                      <a:solidFill>
+                        <a:srgbClr val="E3E8E9"/>
+                      </a:solidFill>
+                      <a:prstDash val="solid"/>
+                      <a:round/>
+                      <a:headEnd type="none" w="med" len="med"/>
+                      <a:tailEnd type="none" w="med" len="med"/>
+                    </a:lnL>
+                    <a:lnR w="6350" cap="flat" cmpd="sng" algn="ctr">
+                      <a:solidFill>
+                        <a:srgbClr val="E3E8E9"/>
+                      </a:solidFill>
+                      <a:prstDash val="solid"/>
+                      <a:round/>
+                      <a:headEnd type="none" w="med" len="med"/>
+                      <a:tailEnd type="none" w="med" len="med"/>
+                    </a:lnR>
+                    <a:lnT w="6350" cap="flat" cmpd="sng" algn="ctr">
+                      <a:solidFill>
+                        <a:srgbClr val="E3E8E9"/>
+                      </a:solidFill>
+                      <a:prstDash val="solid"/>
+                      <a:round/>
+                      <a:headEnd type="none" w="med" len="med"/>
+                      <a:tailEnd type="none" w="med" len="med"/>
+                    </a:lnT>
+                    <a:lnB w="6350" cap="flat" cmpd="sng" algn="ctr">
+                      <a:solidFill>
+                        <a:srgbClr val="E3E8E9"/>
+                      </a:solidFill>
+                      <a:prstDash val="solid"/>
+                      <a:round/>
+                      <a:headEnd type="none" w="med" len="med"/>
+                      <a:tailEnd type="none" w="med" len="med"/>
+                    </a:lnB>
+                    <a:solidFill>
+                      <a:srgbClr val="F0F4F5"/>
+                    </a:solidFill>
+                  </a:tcPr>
+                </a:tc>
+                <a:tc>
+                  <a:txBody>
+                    <a:bodyPr/>
+                    <a:lstStyle/>
+                    <a:p>
+                      <a:pPr indent="0" marL="0">
+                        <a:buNone/>
+                      </a:pPr>
+                      <a:r>
+                        <a:rPr lang="en-US" sz="950" dirty="0">
+                          <a:solidFill>
+                            <a:srgbClr val="5B6B73"/>
+                          </a:solidFill>
+                          <a:latin typeface="Calibri" pitchFamily="34" charset="0"/>
+                          <a:ea typeface="Calibri" pitchFamily="34" charset="-122"/>
+                          <a:cs typeface="Calibri" pitchFamily="34" charset="-120"/>
+                        </a:rPr>
+                        <a:t>P&amp;Q - Processos</a:t>
+                      </a:r>
+                      <a:endParaRPr lang="en-US" sz="950" dirty="0">
+                        <a:latin typeface="Calibri" charset="0"/>
+                        <a:ea typeface="Calibri" charset="0"/>
+                        <a:cs typeface="Calibri" charset="0"/>
+                      </a:endParaRPr>
+                    </a:p>
+                  </a:txBody>
+                  <a:tcPr marL="91440" marR="91440" marT="45720" marB="45720" anchor="ctr">
+                    <a:lnL w="6350" cap="flat" cmpd="sng" algn="ctr">
+                      <a:solidFill>
+                        <a:srgbClr val="E3E8E9"/>
+                      </a:solidFill>
+                      <a:prstDash val="solid"/>
+                      <a:round/>
+                      <a:headEnd type="none" w="med" len="med"/>
+                      <a:tailEnd type="none" w="med" len="med"/>
+                    </a:lnL>
+                    <a:lnR w="6350" cap="flat" cmpd="sng" algn="ctr">
+                      <a:solidFill>
+                        <a:srgbClr val="E3E8E9"/>
+                      </a:solidFill>
+                      <a:prstDash val="solid"/>
+                      <a:round/>
+                      <a:headEnd type="none" w="med" len="med"/>
+                      <a:tailEnd type="none" w="med" len="med"/>
+                    </a:lnR>
+                    <a:lnT w="6350" cap="flat" cmpd="sng" algn="ctr">
+                      <a:solidFill>
+                        <a:srgbClr val="E3E8E9"/>
+                      </a:solidFill>
+                      <a:prstDash val="solid"/>
+                      <a:round/>
+                      <a:headEnd type="none" w="med" len="med"/>
+                      <a:tailEnd type="none" w="med" len="med"/>
+                    </a:lnT>
+                    <a:lnB w="6350" cap="flat" cmpd="sng" algn="ctr">
+                      <a:solidFill>
+                        <a:srgbClr val="E3E8E9"/>
+                      </a:solidFill>
+                      <a:prstDash val="solid"/>
+                      <a:round/>
+                      <a:headEnd type="none" w="med" len="med"/>
+                      <a:tailEnd type="none" w="med" len="med"/>
+                    </a:lnB>
+                    <a:solidFill>
+                      <a:srgbClr val="F0F4F5"/>
+                    </a:solidFill>
+                  </a:tcPr>
+                </a:tc>
+                <a:tc>
+                  <a:txBody>
+                    <a:bodyPr/>
+                    <a:lstStyle/>
+                    <a:p>
+                      <a:pPr algn="r" indent="0" marL="0">
+                        <a:buNone/>
+                      </a:pPr>
+                      <a:r>
+                        <a:rPr lang="en-US" sz="1000" b="1" dirty="0">
+                          <a:solidFill>
+                            <a:srgbClr val="0B2A3D"/>
+                          </a:solidFill>
+                          <a:latin typeface="Calibri" pitchFamily="34" charset="0"/>
+                          <a:ea typeface="Calibri" pitchFamily="34" charset="-122"/>
+                          <a:cs typeface="Calibri" pitchFamily="34" charset="-120"/>
+                        </a:rPr>
+                        <a:t>US$ 616,8 mil</a:t>
+                      </a:r>
+                      <a:endParaRPr lang="en-US" sz="1000" dirty="0">
+                        <a:latin typeface="Calibri" charset="0"/>
+                        <a:ea typeface="Calibri" charset="0"/>
+                        <a:cs typeface="Calibri" charset="0"/>
+                      </a:endParaRPr>
+                    </a:p>
+                  </a:txBody>
+                  <a:tcPr marL="91440" marR="91440" marT="45720" marB="45720" anchor="ctr">
+                    <a:lnL w="6350" cap="flat" cmpd="sng" algn="ctr">
+                      <a:solidFill>
+                        <a:srgbClr val="E3E8E9"/>
+                      </a:solidFill>
+                      <a:prstDash val="solid"/>
+                      <a:round/>
+                      <a:headEnd type="none" w="med" len="med"/>
+                      <a:tailEnd type="none" w="med" len="med"/>
+                    </a:lnL>
+                    <a:lnR w="6350" cap="flat" cmpd="sng" algn="ctr">
+                      <a:solidFill>
+                        <a:srgbClr val="E3E8E9"/>
+                      </a:solidFill>
+                      <a:prstDash val="solid"/>
+                      <a:round/>
+                      <a:headEnd type="none" w="med" len="med"/>
+                      <a:tailEnd type="none" w="med" len="med"/>
+                    </a:lnR>
+                    <a:lnT w="6350" cap="flat" cmpd="sng" algn="ctr">
+                      <a:solidFill>
+                        <a:srgbClr val="E3E8E9"/>
+                      </a:solidFill>
+                      <a:prstDash val="solid"/>
+                      <a:round/>
+                      <a:headEnd type="none" w="med" len="med"/>
+                      <a:tailEnd type="none" w="med" len="med"/>
+                    </a:lnT>
+                    <a:lnB w="6350" cap="flat" cmpd="sng" algn="ctr">
+                      <a:solidFill>
+                        <a:srgbClr val="E3E8E9"/>
+                      </a:solidFill>
+                      <a:prstDash val="solid"/>
+                      <a:round/>
+                      <a:headEnd type="none" w="med" len="med"/>
+                      <a:tailEnd type="none" w="med" len="med"/>
+                    </a:lnB>
+                    <a:solidFill>
+                      <a:srgbClr val="F0F4F5"/>
+                    </a:solidFill>
+                  </a:tcPr>
+                </a:tc>
+              </a:tr>
+              <a:tr h="288036">
+                <a:tc>
+                  <a:txBody>
+                    <a:bodyPr/>
+                    <a:lstStyle/>
+                    <a:p>
+                      <a:pPr indent="0" marL="0">
+                        <a:buNone/>
+                      </a:pPr>
+                      <a:r>
+                        <a:rPr lang="en-US" sz="1000" dirty="0">
+                          <a:solidFill>
+                            <a:srgbClr val="1C2B33"/>
+                          </a:solidFill>
+                          <a:latin typeface="Calibri" pitchFamily="34" charset="0"/>
+                          <a:ea typeface="Calibri" pitchFamily="34" charset="-122"/>
+                          <a:cs typeface="Calibri" pitchFamily="34" charset="-120"/>
+                        </a:rPr>
+                        <a:t>TA - Manutenção no Swivel elétrico</a:t>
+                      </a:r>
+                      <a:endParaRPr lang="en-US" sz="1000" dirty="0">
+                        <a:latin typeface="Calibri" charset="0"/>
+                        <a:ea typeface="Calibri" charset="0"/>
+                        <a:cs typeface="Calibri" charset="0"/>
+                      </a:endParaRPr>
+                    </a:p>
+                  </a:txBody>
+                  <a:tcPr marL="91440" marR="91440" marT="45720" marB="45720" anchor="ctr">
+                    <a:lnL w="6350" cap="flat" cmpd="sng" algn="ctr">
+                      <a:solidFill>
+                        <a:srgbClr val="E3E8E9"/>
+                      </a:solidFill>
+                      <a:prstDash val="solid"/>
+                      <a:round/>
+                      <a:headEnd type="none" w="med" len="med"/>
+                      <a:tailEnd type="none" w="med" len="med"/>
+                    </a:lnL>
+                    <a:lnR w="6350" cap="flat" cmpd="sng" algn="ctr">
+                      <a:solidFill>
+                        <a:srgbClr val="E3E8E9"/>
+                      </a:solidFill>
+                      <a:prstDash val="solid"/>
+                      <a:round/>
+                      <a:headEnd type="none" w="med" len="med"/>
+                      <a:tailEnd type="none" w="med" len="med"/>
+                    </a:lnR>
+                    <a:lnT w="6350" cap="flat" cmpd="sng" algn="ctr">
+                      <a:solidFill>
+                        <a:srgbClr val="E3E8E9"/>
+                      </a:solidFill>
+                      <a:prstDash val="solid"/>
+                      <a:round/>
+                      <a:headEnd type="none" w="med" len="med"/>
+                      <a:tailEnd type="none" w="med" len="med"/>
+                    </a:lnT>
+                    <a:lnB w="6350" cap="flat" cmpd="sng" algn="ctr">
+                      <a:solidFill>
+                        <a:srgbClr val="E3E8E9"/>
+                      </a:solidFill>
+                      <a:prstDash val="solid"/>
+                      <a:round/>
+                      <a:headEnd type="none" w="med" len="med"/>
+                      <a:tailEnd type="none" w="med" len="med"/>
+                    </a:lnB>
+                    <a:solidFill>
+                      <a:srgbClr val="FFFFFF"/>
+                    </a:solidFill>
+                  </a:tcPr>
+                </a:tc>
+                <a:tc>
+                  <a:txBody>
+                    <a:bodyPr/>
+                    <a:lstStyle/>
+                    <a:p>
+                      <a:pPr indent="0" marL="0">
+                        <a:buNone/>
+                      </a:pPr>
+                      <a:r>
+                        <a:rPr lang="en-US" sz="950" dirty="0">
+                          <a:solidFill>
+                            <a:srgbClr val="5B6B73"/>
+                          </a:solidFill>
+                          <a:latin typeface="Calibri" pitchFamily="34" charset="0"/>
+                          <a:ea typeface="Calibri" pitchFamily="34" charset="-122"/>
+                          <a:cs typeface="Calibri" pitchFamily="34" charset="-120"/>
+                        </a:rPr>
+                        <a:t>Rotina Operacional</a:t>
+                      </a:r>
+                      <a:endParaRPr lang="en-US" sz="950" dirty="0">
+                        <a:latin typeface="Calibri" charset="0"/>
+                        <a:ea typeface="Calibri" charset="0"/>
+                        <a:cs typeface="Calibri" charset="0"/>
+                      </a:endParaRPr>
+                    </a:p>
+                  </a:txBody>
+                  <a:tcPr marL="91440" marR="91440" marT="45720" marB="45720" anchor="ctr">
+                    <a:lnL w="6350" cap="flat" cmpd="sng" algn="ctr">
+                      <a:solidFill>
+                        <a:srgbClr val="E3E8E9"/>
+                      </a:solidFill>
+                      <a:prstDash val="solid"/>
+                      <a:round/>
+                      <a:headEnd type="none" w="med" len="med"/>
+                      <a:tailEnd type="none" w="med" len="med"/>
+                    </a:lnL>
+                    <a:lnR w="6350" cap="flat" cmpd="sng" algn="ctr">
+                      <a:solidFill>
+                        <a:srgbClr val="E3E8E9"/>
+                      </a:solidFill>
+                      <a:prstDash val="solid"/>
+                      <a:round/>
+                      <a:headEnd type="none" w="med" len="med"/>
+                      <a:tailEnd type="none" w="med" len="med"/>
+                    </a:lnR>
+                    <a:lnT w="6350" cap="flat" cmpd="sng" algn="ctr">
+                      <a:solidFill>
+                        <a:srgbClr val="E3E8E9"/>
+                      </a:solidFill>
+                      <a:prstDash val="solid"/>
+                      <a:round/>
+                      <a:headEnd type="none" w="med" len="med"/>
+                      <a:tailEnd type="none" w="med" len="med"/>
+                    </a:lnT>
+                    <a:lnB w="6350" cap="flat" cmpd="sng" algn="ctr">
+                      <a:solidFill>
+                        <a:srgbClr val="E3E8E9"/>
+                      </a:solidFill>
+                      <a:prstDash val="solid"/>
+                      <a:round/>
+                      <a:headEnd type="none" w="med" len="med"/>
+                      <a:tailEnd type="none" w="med" len="med"/>
+                    </a:lnB>
+                    <a:solidFill>
+                      <a:srgbClr val="FFFFFF"/>
+                    </a:solidFill>
+                  </a:tcPr>
+                </a:tc>
+                <a:tc>
+                  <a:txBody>
+                    <a:bodyPr/>
+                    <a:lstStyle/>
+                    <a:p>
+                      <a:pPr indent="0" marL="0">
+                        <a:buNone/>
+                      </a:pPr>
+                      <a:r>
+                        <a:rPr lang="en-US" sz="950" dirty="0">
+                          <a:solidFill>
+                            <a:srgbClr val="5B6B73"/>
+                          </a:solidFill>
+                          <a:latin typeface="Calibri" pitchFamily="34" charset="0"/>
+                          <a:ea typeface="Calibri" pitchFamily="34" charset="-122"/>
+                          <a:cs typeface="Calibri" pitchFamily="34" charset="-120"/>
+                        </a:rPr>
+                        <a:t>EIM - Manutenção &amp; Integridade</a:t>
+                      </a:r>
+                      <a:endParaRPr lang="en-US" sz="950" dirty="0">
+                        <a:latin typeface="Calibri" charset="0"/>
+                        <a:ea typeface="Calibri" charset="0"/>
+                        <a:cs typeface="Calibri" charset="0"/>
+                      </a:endParaRPr>
+                    </a:p>
+                  </a:txBody>
+                  <a:tcPr marL="91440" marR="91440" marT="45720" marB="45720" anchor="ctr">
+                    <a:lnL w="6350" cap="flat" cmpd="sng" algn="ctr">
+                      <a:solidFill>
+                        <a:srgbClr val="E3E8E9"/>
+                      </a:solidFill>
+                      <a:prstDash val="solid"/>
+                      <a:round/>
+                      <a:headEnd type="none" w="med" len="med"/>
+                      <a:tailEnd type="none" w="med" len="med"/>
+                    </a:lnL>
+                    <a:lnR w="6350" cap="flat" cmpd="sng" algn="ctr">
+                      <a:solidFill>
+                        <a:srgbClr val="E3E8E9"/>
+                      </a:solidFill>
+                      <a:prstDash val="solid"/>
+                      <a:round/>
+                      <a:headEnd type="none" w="med" len="med"/>
+                      <a:tailEnd type="none" w="med" len="med"/>
+                    </a:lnR>
+                    <a:lnT w="6350" cap="flat" cmpd="sng" algn="ctr">
+                      <a:solidFill>
+                        <a:srgbClr val="E3E8E9"/>
+                      </a:solidFill>
+                      <a:prstDash val="solid"/>
+                      <a:round/>
+                      <a:headEnd type="none" w="med" len="med"/>
+                      <a:tailEnd type="none" w="med" len="med"/>
+                    </a:lnT>
+                    <a:lnB w="6350" cap="flat" cmpd="sng" algn="ctr">
+                      <a:solidFill>
+                        <a:srgbClr val="E3E8E9"/>
+                      </a:solidFill>
+                      <a:prstDash val="solid"/>
+                      <a:round/>
+                      <a:headEnd type="none" w="med" len="med"/>
+                      <a:tailEnd type="none" w="med" len="med"/>
+                    </a:lnB>
+                    <a:solidFill>
+                      <a:srgbClr val="FFFFFF"/>
+                    </a:solidFill>
+                  </a:tcPr>
+                </a:tc>
+                <a:tc>
+                  <a:txBody>
+                    <a:bodyPr/>
+                    <a:lstStyle/>
+                    <a:p>
+                      <a:pPr algn="r" indent="0" marL="0">
+                        <a:buNone/>
+                      </a:pPr>
+                      <a:r>
+                        <a:rPr lang="en-US" sz="1000" b="1" dirty="0">
+                          <a:solidFill>
+                            <a:srgbClr val="0B2A3D"/>
+                          </a:solidFill>
+                          <a:latin typeface="Calibri" pitchFamily="34" charset="0"/>
+                          <a:ea typeface="Calibri" pitchFamily="34" charset="-122"/>
+                          <a:cs typeface="Calibri" pitchFamily="34" charset="-120"/>
+                        </a:rPr>
+                        <a:t>US$ 414,5 mil</a:t>
+                      </a:r>
+                      <a:endParaRPr lang="en-US" sz="1000" dirty="0">
+                        <a:latin typeface="Calibri" charset="0"/>
+                        <a:ea typeface="Calibri" charset="0"/>
+                        <a:cs typeface="Calibri" charset="0"/>
+                      </a:endParaRPr>
+                    </a:p>
+                  </a:txBody>
+                  <a:tcPr marL="91440" marR="91440" marT="45720" marB="45720" anchor="ctr">
+                    <a:lnL w="6350" cap="flat" cmpd="sng" algn="ctr">
+                      <a:solidFill>
+                        <a:srgbClr val="E3E8E9"/>
+                      </a:solidFill>
+                      <a:prstDash val="solid"/>
+                      <a:round/>
+                      <a:headEnd type="none" w="med" len="med"/>
+                      <a:tailEnd type="none" w="med" len="med"/>
+                    </a:lnL>
+                    <a:lnR w="6350" cap="flat" cmpd="sng" algn="ctr">
+                      <a:solidFill>
+                        <a:srgbClr val="E3E8E9"/>
+                      </a:solidFill>
+                      <a:prstDash val="solid"/>
+                      <a:round/>
+                      <a:headEnd type="none" w="med" len="med"/>
+                      <a:tailEnd type="none" w="med" len="med"/>
+                    </a:lnR>
+                    <a:lnT w="6350" cap="flat" cmpd="sng" algn="ctr">
+                      <a:solidFill>
+                        <a:srgbClr val="E3E8E9"/>
+                      </a:solidFill>
+                      <a:prstDash val="solid"/>
+                      <a:round/>
+                      <a:headEnd type="none" w="med" len="med"/>
+                      <a:tailEnd type="none" w="med" len="med"/>
+                    </a:lnT>
+                    <a:lnB w="6350" cap="flat" cmpd="sng" algn="ctr">
+                      <a:solidFill>
+                        <a:srgbClr val="E3E8E9"/>
+                      </a:solidFill>
+                      <a:prstDash val="solid"/>
+                      <a:round/>
+                      <a:headEnd type="none" w="med" len="med"/>
+                      <a:tailEnd type="none" w="med" len="med"/>
+                    </a:lnB>
+                    <a:solidFill>
+                      <a:srgbClr val="FFFFFF"/>
+                    </a:solidFill>
+                  </a:tcPr>
+                </a:tc>
+              </a:tr>
+              <a:tr h="288036">
+                <a:tc>
+                  <a:txBody>
+                    <a:bodyPr/>
+                    <a:lstStyle/>
+                    <a:p>
+                      <a:pPr indent="0" marL="0">
+                        <a:buNone/>
+                      </a:pPr>
+                      <a:r>
+                        <a:rPr lang="en-US" sz="1000" dirty="0">
+                          <a:solidFill>
+                            <a:srgbClr val="1C2B33"/>
+                          </a:solidFill>
+                          <a:latin typeface="Calibri" pitchFamily="34" charset="0"/>
+                          <a:ea typeface="Calibri" pitchFamily="34" charset="-122"/>
+                          <a:cs typeface="Calibri" pitchFamily="34" charset="-120"/>
+                        </a:rPr>
                         <a:t>Novas Destiladoras</a:t>
                       </a:r>
                       <a:endParaRPr lang="en-US" sz="1000" dirty="0">
@@ -15934,1102 +17030,6 @@
                 </a:tc>
               </a:tr>
               <a:tr h="288036">
-                <a:tc>
-                  <a:txBody>
-                    <a:bodyPr/>
-                    <a:lstStyle/>
-                    <a:p>
-                      <a:pPr indent="0" marL="0">
-                        <a:buNone/>
-                      </a:pPr>
-                      <a:r>
-                        <a:rPr lang="en-US" sz="1000" dirty="0">
-                          <a:solidFill>
-                            <a:srgbClr val="1C2B33"/>
-                          </a:solidFill>
-                          <a:latin typeface="Calibri" pitchFamily="34" charset="0"/>
-                          <a:ea typeface="Calibri" pitchFamily="34" charset="-122"/>
-                          <a:cs typeface="Calibri" pitchFamily="34" charset="-120"/>
-                        </a:rPr>
-                        <a:t>Instalação de Sensores de Hidrogênio nas Salas de Baterias</a:t>
-                      </a:r>
-                      <a:endParaRPr lang="en-US" sz="1000" dirty="0">
-                        <a:latin typeface="Calibri" charset="0"/>
-                        <a:ea typeface="Calibri" charset="0"/>
-                        <a:cs typeface="Calibri" charset="0"/>
-                      </a:endParaRPr>
-                    </a:p>
-                  </a:txBody>
-                  <a:tcPr marL="91440" marR="91440" marT="45720" marB="45720" anchor="ctr">
-                    <a:lnL w="6350" cap="flat" cmpd="sng" algn="ctr">
-                      <a:solidFill>
-                        <a:srgbClr val="E3E8E9"/>
-                      </a:solidFill>
-                      <a:prstDash val="solid"/>
-                      <a:round/>
-                      <a:headEnd type="none" w="med" len="med"/>
-                      <a:tailEnd type="none" w="med" len="med"/>
-                    </a:lnL>
-                    <a:lnR w="6350" cap="flat" cmpd="sng" algn="ctr">
-                      <a:solidFill>
-                        <a:srgbClr val="E3E8E9"/>
-                      </a:solidFill>
-                      <a:prstDash val="solid"/>
-                      <a:round/>
-                      <a:headEnd type="none" w="med" len="med"/>
-                      <a:tailEnd type="none" w="med" len="med"/>
-                    </a:lnR>
-                    <a:lnT w="6350" cap="flat" cmpd="sng" algn="ctr">
-                      <a:solidFill>
-                        <a:srgbClr val="E3E8E9"/>
-                      </a:solidFill>
-                      <a:prstDash val="solid"/>
-                      <a:round/>
-                      <a:headEnd type="none" w="med" len="med"/>
-                      <a:tailEnd type="none" w="med" len="med"/>
-                    </a:lnT>
-                    <a:lnB w="6350" cap="flat" cmpd="sng" algn="ctr">
-                      <a:solidFill>
-                        <a:srgbClr val="E3E8E9"/>
-                      </a:solidFill>
-                      <a:prstDash val="solid"/>
-                      <a:round/>
-                      <a:headEnd type="none" w="med" len="med"/>
-                      <a:tailEnd type="none" w="med" len="med"/>
-                    </a:lnB>
-                    <a:solidFill>
-                      <a:srgbClr val="FFFFFF"/>
-                    </a:solidFill>
-                  </a:tcPr>
-                </a:tc>
-                <a:tc>
-                  <a:txBody>
-                    <a:bodyPr/>
-                    <a:lstStyle/>
-                    <a:p>
-                      <a:pPr indent="0" marL="0">
-                        <a:buNone/>
-                      </a:pPr>
-                      <a:r>
-                        <a:rPr lang="en-US" sz="950" dirty="0">
-                          <a:solidFill>
-                            <a:srgbClr val="5B6B73"/>
-                          </a:solidFill>
-                          <a:latin typeface="Calibri" pitchFamily="34" charset="0"/>
-                          <a:ea typeface="Calibri" pitchFamily="34" charset="-122"/>
-                          <a:cs typeface="Calibri" pitchFamily="34" charset="-120"/>
-                        </a:rPr>
-                        <a:t>Integridade e Regulatório</a:t>
-                      </a:r>
-                      <a:endParaRPr lang="en-US" sz="950" dirty="0">
-                        <a:latin typeface="Calibri" charset="0"/>
-                        <a:ea typeface="Calibri" charset="0"/>
-                        <a:cs typeface="Calibri" charset="0"/>
-                      </a:endParaRPr>
-                    </a:p>
-                  </a:txBody>
-                  <a:tcPr marL="91440" marR="91440" marT="45720" marB="45720" anchor="ctr">
-                    <a:lnL w="6350" cap="flat" cmpd="sng" algn="ctr">
-                      <a:solidFill>
-                        <a:srgbClr val="E3E8E9"/>
-                      </a:solidFill>
-                      <a:prstDash val="solid"/>
-                      <a:round/>
-                      <a:headEnd type="none" w="med" len="med"/>
-                      <a:tailEnd type="none" w="med" len="med"/>
-                    </a:lnL>
-                    <a:lnR w="6350" cap="flat" cmpd="sng" algn="ctr">
-                      <a:solidFill>
-                        <a:srgbClr val="E3E8E9"/>
-                      </a:solidFill>
-                      <a:prstDash val="solid"/>
-                      <a:round/>
-                      <a:headEnd type="none" w="med" len="med"/>
-                      <a:tailEnd type="none" w="med" len="med"/>
-                    </a:lnR>
-                    <a:lnT w="6350" cap="flat" cmpd="sng" algn="ctr">
-                      <a:solidFill>
-                        <a:srgbClr val="E3E8E9"/>
-                      </a:solidFill>
-                      <a:prstDash val="solid"/>
-                      <a:round/>
-                      <a:headEnd type="none" w="med" len="med"/>
-                      <a:tailEnd type="none" w="med" len="med"/>
-                    </a:lnT>
-                    <a:lnB w="6350" cap="flat" cmpd="sng" algn="ctr">
-                      <a:solidFill>
-                        <a:srgbClr val="E3E8E9"/>
-                      </a:solidFill>
-                      <a:prstDash val="solid"/>
-                      <a:round/>
-                      <a:headEnd type="none" w="med" len="med"/>
-                      <a:tailEnd type="none" w="med" len="med"/>
-                    </a:lnB>
-                    <a:solidFill>
-                      <a:srgbClr val="FFFFFF"/>
-                    </a:solidFill>
-                  </a:tcPr>
-                </a:tc>
-                <a:tc>
-                  <a:txBody>
-                    <a:bodyPr/>
-                    <a:lstStyle/>
-                    <a:p>
-                      <a:pPr indent="0" marL="0">
-                        <a:buNone/>
-                      </a:pPr>
-                      <a:r>
-                        <a:rPr lang="en-US" sz="950" dirty="0">
-                          <a:solidFill>
-                            <a:srgbClr val="5B6B73"/>
-                          </a:solidFill>
-                          <a:latin typeface="Calibri" pitchFamily="34" charset="0"/>
-                          <a:ea typeface="Calibri" pitchFamily="34" charset="-122"/>
-                          <a:cs typeface="Calibri" pitchFamily="34" charset="-120"/>
-                        </a:rPr>
-                        <a:t>Projetos</a:t>
-                      </a:r>
-                      <a:endParaRPr lang="en-US" sz="950" dirty="0">
-                        <a:latin typeface="Calibri" charset="0"/>
-                        <a:ea typeface="Calibri" charset="0"/>
-                        <a:cs typeface="Calibri" charset="0"/>
-                      </a:endParaRPr>
-                    </a:p>
-                  </a:txBody>
-                  <a:tcPr marL="91440" marR="91440" marT="45720" marB="45720" anchor="ctr">
-                    <a:lnL w="6350" cap="flat" cmpd="sng" algn="ctr">
-                      <a:solidFill>
-                        <a:srgbClr val="E3E8E9"/>
-                      </a:solidFill>
-                      <a:prstDash val="solid"/>
-                      <a:round/>
-                      <a:headEnd type="none" w="med" len="med"/>
-                      <a:tailEnd type="none" w="med" len="med"/>
-                    </a:lnL>
-                    <a:lnR w="6350" cap="flat" cmpd="sng" algn="ctr">
-                      <a:solidFill>
-                        <a:srgbClr val="E3E8E9"/>
-                      </a:solidFill>
-                      <a:prstDash val="solid"/>
-                      <a:round/>
-                      <a:headEnd type="none" w="med" len="med"/>
-                      <a:tailEnd type="none" w="med" len="med"/>
-                    </a:lnR>
-                    <a:lnT w="6350" cap="flat" cmpd="sng" algn="ctr">
-                      <a:solidFill>
-                        <a:srgbClr val="E3E8E9"/>
-                      </a:solidFill>
-                      <a:prstDash val="solid"/>
-                      <a:round/>
-                      <a:headEnd type="none" w="med" len="med"/>
-                      <a:tailEnd type="none" w="med" len="med"/>
-                    </a:lnT>
-                    <a:lnB w="6350" cap="flat" cmpd="sng" algn="ctr">
-                      <a:solidFill>
-                        <a:srgbClr val="E3E8E9"/>
-                      </a:solidFill>
-                      <a:prstDash val="solid"/>
-                      <a:round/>
-                      <a:headEnd type="none" w="med" len="med"/>
-                      <a:tailEnd type="none" w="med" len="med"/>
-                    </a:lnB>
-                    <a:solidFill>
-                      <a:srgbClr val="FFFFFF"/>
-                    </a:solidFill>
-                  </a:tcPr>
-                </a:tc>
-                <a:tc>
-                  <a:txBody>
-                    <a:bodyPr/>
-                    <a:lstStyle/>
-                    <a:p>
-                      <a:pPr algn="r" indent="0" marL="0">
-                        <a:buNone/>
-                      </a:pPr>
-                      <a:r>
-                        <a:rPr lang="en-US" sz="1000" b="1" dirty="0">
-                          <a:solidFill>
-                            <a:srgbClr val="0B2A3D"/>
-                          </a:solidFill>
-                          <a:latin typeface="Calibri" pitchFamily="34" charset="0"/>
-                          <a:ea typeface="Calibri" pitchFamily="34" charset="-122"/>
-                          <a:cs typeface="Calibri" pitchFamily="34" charset="-120"/>
-                        </a:rPr>
-                        <a:t>US$ 281,8 mil</a:t>
-                      </a:r>
-                      <a:endParaRPr lang="en-US" sz="1000" dirty="0">
-                        <a:latin typeface="Calibri" charset="0"/>
-                        <a:ea typeface="Calibri" charset="0"/>
-                        <a:cs typeface="Calibri" charset="0"/>
-                      </a:endParaRPr>
-                    </a:p>
-                  </a:txBody>
-                  <a:tcPr marL="91440" marR="91440" marT="45720" marB="45720" anchor="ctr">
-                    <a:lnL w="6350" cap="flat" cmpd="sng" algn="ctr">
-                      <a:solidFill>
-                        <a:srgbClr val="E3E8E9"/>
-                      </a:solidFill>
-                      <a:prstDash val="solid"/>
-                      <a:round/>
-                      <a:headEnd type="none" w="med" len="med"/>
-                      <a:tailEnd type="none" w="med" len="med"/>
-                    </a:lnL>
-                    <a:lnR w="6350" cap="flat" cmpd="sng" algn="ctr">
-                      <a:solidFill>
-                        <a:srgbClr val="E3E8E9"/>
-                      </a:solidFill>
-                      <a:prstDash val="solid"/>
-                      <a:round/>
-                      <a:headEnd type="none" w="med" len="med"/>
-                      <a:tailEnd type="none" w="med" len="med"/>
-                    </a:lnR>
-                    <a:lnT w="6350" cap="flat" cmpd="sng" algn="ctr">
-                      <a:solidFill>
-                        <a:srgbClr val="E3E8E9"/>
-                      </a:solidFill>
-                      <a:prstDash val="solid"/>
-                      <a:round/>
-                      <a:headEnd type="none" w="med" len="med"/>
-                      <a:tailEnd type="none" w="med" len="med"/>
-                    </a:lnT>
-                    <a:lnB w="6350" cap="flat" cmpd="sng" algn="ctr">
-                      <a:solidFill>
-                        <a:srgbClr val="E3E8E9"/>
-                      </a:solidFill>
-                      <a:prstDash val="solid"/>
-                      <a:round/>
-                      <a:headEnd type="none" w="med" len="med"/>
-                      <a:tailEnd type="none" w="med" len="med"/>
-                    </a:lnB>
-                    <a:solidFill>
-                      <a:srgbClr val="FFFFFF"/>
-                    </a:solidFill>
-                  </a:tcPr>
-                </a:tc>
-              </a:tr>
-              <a:tr h="288036">
-                <a:tc>
-                  <a:txBody>
-                    <a:bodyPr/>
-                    <a:lstStyle/>
-                    <a:p>
-                      <a:pPr indent="0" marL="0">
-                        <a:buNone/>
-                      </a:pPr>
-                      <a:r>
-                        <a:rPr lang="en-US" sz="1000" dirty="0">
-                          <a:solidFill>
-                            <a:srgbClr val="1C2B33"/>
-                          </a:solidFill>
-                          <a:latin typeface="Calibri" pitchFamily="34" charset="0"/>
-                          <a:ea typeface="Calibri" pitchFamily="34" charset="-122"/>
-                          <a:cs typeface="Calibri" pitchFamily="34" charset="-120"/>
-                        </a:rPr>
-                        <a:t>Desmobilização TA</a:t>
-                      </a:r>
-                      <a:endParaRPr lang="en-US" sz="1000" dirty="0">
-                        <a:latin typeface="Calibri" charset="0"/>
-                        <a:ea typeface="Calibri" charset="0"/>
-                        <a:cs typeface="Calibri" charset="0"/>
-                      </a:endParaRPr>
-                    </a:p>
-                  </a:txBody>
-                  <a:tcPr marL="91440" marR="91440" marT="45720" marB="45720" anchor="ctr">
-                    <a:lnL w="6350" cap="flat" cmpd="sng" algn="ctr">
-                      <a:solidFill>
-                        <a:srgbClr val="E3E8E9"/>
-                      </a:solidFill>
-                      <a:prstDash val="solid"/>
-                      <a:round/>
-                      <a:headEnd type="none" w="med" len="med"/>
-                      <a:tailEnd type="none" w="med" len="med"/>
-                    </a:lnL>
-                    <a:lnR w="6350" cap="flat" cmpd="sng" algn="ctr">
-                      <a:solidFill>
-                        <a:srgbClr val="E3E8E9"/>
-                      </a:solidFill>
-                      <a:prstDash val="solid"/>
-                      <a:round/>
-                      <a:headEnd type="none" w="med" len="med"/>
-                      <a:tailEnd type="none" w="med" len="med"/>
-                    </a:lnR>
-                    <a:lnT w="6350" cap="flat" cmpd="sng" algn="ctr">
-                      <a:solidFill>
-                        <a:srgbClr val="E3E8E9"/>
-                      </a:solidFill>
-                      <a:prstDash val="solid"/>
-                      <a:round/>
-                      <a:headEnd type="none" w="med" len="med"/>
-                      <a:tailEnd type="none" w="med" len="med"/>
-                    </a:lnT>
-                    <a:lnB w="6350" cap="flat" cmpd="sng" algn="ctr">
-                      <a:solidFill>
-                        <a:srgbClr val="E3E8E9"/>
-                      </a:solidFill>
-                      <a:prstDash val="solid"/>
-                      <a:round/>
-                      <a:headEnd type="none" w="med" len="med"/>
-                      <a:tailEnd type="none" w="med" len="med"/>
-                    </a:lnB>
-                    <a:solidFill>
-                      <a:srgbClr val="F0F4F5"/>
-                    </a:solidFill>
-                  </a:tcPr>
-                </a:tc>
-                <a:tc>
-                  <a:txBody>
-                    <a:bodyPr/>
-                    <a:lstStyle/>
-                    <a:p>
-                      <a:pPr indent="0" marL="0">
-                        <a:buNone/>
-                      </a:pPr>
-                      <a:r>
-                        <a:rPr lang="en-US" sz="950" dirty="0">
-                          <a:solidFill>
-                            <a:srgbClr val="5B6B73"/>
-                          </a:solidFill>
-                          <a:latin typeface="Calibri" pitchFamily="34" charset="0"/>
-                          <a:ea typeface="Calibri" pitchFamily="34" charset="-122"/>
-                          <a:cs typeface="Calibri" pitchFamily="34" charset="-120"/>
-                        </a:rPr>
-                        <a:t>Eficiência de Produção</a:t>
-                      </a:r>
-                      <a:endParaRPr lang="en-US" sz="950" dirty="0">
-                        <a:latin typeface="Calibri" charset="0"/>
-                        <a:ea typeface="Calibri" charset="0"/>
-                        <a:cs typeface="Calibri" charset="0"/>
-                      </a:endParaRPr>
-                    </a:p>
-                  </a:txBody>
-                  <a:tcPr marL="91440" marR="91440" marT="45720" marB="45720" anchor="ctr">
-                    <a:lnL w="6350" cap="flat" cmpd="sng" algn="ctr">
-                      <a:solidFill>
-                        <a:srgbClr val="E3E8E9"/>
-                      </a:solidFill>
-                      <a:prstDash val="solid"/>
-                      <a:round/>
-                      <a:headEnd type="none" w="med" len="med"/>
-                      <a:tailEnd type="none" w="med" len="med"/>
-                    </a:lnL>
-                    <a:lnR w="6350" cap="flat" cmpd="sng" algn="ctr">
-                      <a:solidFill>
-                        <a:srgbClr val="E3E8E9"/>
-                      </a:solidFill>
-                      <a:prstDash val="solid"/>
-                      <a:round/>
-                      <a:headEnd type="none" w="med" len="med"/>
-                      <a:tailEnd type="none" w="med" len="med"/>
-                    </a:lnR>
-                    <a:lnT w="6350" cap="flat" cmpd="sng" algn="ctr">
-                      <a:solidFill>
-                        <a:srgbClr val="E3E8E9"/>
-                      </a:solidFill>
-                      <a:prstDash val="solid"/>
-                      <a:round/>
-                      <a:headEnd type="none" w="med" len="med"/>
-                      <a:tailEnd type="none" w="med" len="med"/>
-                    </a:lnT>
-                    <a:lnB w="6350" cap="flat" cmpd="sng" algn="ctr">
-                      <a:solidFill>
-                        <a:srgbClr val="E3E8E9"/>
-                      </a:solidFill>
-                      <a:prstDash val="solid"/>
-                      <a:round/>
-                      <a:headEnd type="none" w="med" len="med"/>
-                      <a:tailEnd type="none" w="med" len="med"/>
-                    </a:lnB>
-                    <a:solidFill>
-                      <a:srgbClr val="F0F4F5"/>
-                    </a:solidFill>
-                  </a:tcPr>
-                </a:tc>
-                <a:tc>
-                  <a:txBody>
-                    <a:bodyPr/>
-                    <a:lstStyle/>
-                    <a:p>
-                      <a:pPr indent="0" marL="0">
-                        <a:buNone/>
-                      </a:pPr>
-                      <a:r>
-                        <a:rPr lang="en-US" sz="950" dirty="0">
-                          <a:solidFill>
-                            <a:srgbClr val="5B6B73"/>
-                          </a:solidFill>
-                          <a:latin typeface="Calibri" pitchFamily="34" charset="0"/>
-                          <a:ea typeface="Calibri" pitchFamily="34" charset="-122"/>
-                          <a:cs typeface="Calibri" pitchFamily="34" charset="-120"/>
-                        </a:rPr>
-                        <a:t>TA - Parada Programada</a:t>
-                      </a:r>
-                      <a:endParaRPr lang="en-US" sz="950" dirty="0">
-                        <a:latin typeface="Calibri" charset="0"/>
-                        <a:ea typeface="Calibri" charset="0"/>
-                        <a:cs typeface="Calibri" charset="0"/>
-                      </a:endParaRPr>
-                    </a:p>
-                  </a:txBody>
-                  <a:tcPr marL="91440" marR="91440" marT="45720" marB="45720" anchor="ctr">
-                    <a:lnL w="6350" cap="flat" cmpd="sng" algn="ctr">
-                      <a:solidFill>
-                        <a:srgbClr val="E3E8E9"/>
-                      </a:solidFill>
-                      <a:prstDash val="solid"/>
-                      <a:round/>
-                      <a:headEnd type="none" w="med" len="med"/>
-                      <a:tailEnd type="none" w="med" len="med"/>
-                    </a:lnL>
-                    <a:lnR w="6350" cap="flat" cmpd="sng" algn="ctr">
-                      <a:solidFill>
-                        <a:srgbClr val="E3E8E9"/>
-                      </a:solidFill>
-                      <a:prstDash val="solid"/>
-                      <a:round/>
-                      <a:headEnd type="none" w="med" len="med"/>
-                      <a:tailEnd type="none" w="med" len="med"/>
-                    </a:lnR>
-                    <a:lnT w="6350" cap="flat" cmpd="sng" algn="ctr">
-                      <a:solidFill>
-                        <a:srgbClr val="E3E8E9"/>
-                      </a:solidFill>
-                      <a:prstDash val="solid"/>
-                      <a:round/>
-                      <a:headEnd type="none" w="med" len="med"/>
-                      <a:tailEnd type="none" w="med" len="med"/>
-                    </a:lnT>
-                    <a:lnB w="6350" cap="flat" cmpd="sng" algn="ctr">
-                      <a:solidFill>
-                        <a:srgbClr val="E3E8E9"/>
-                      </a:solidFill>
-                      <a:prstDash val="solid"/>
-                      <a:round/>
-                      <a:headEnd type="none" w="med" len="med"/>
-                      <a:tailEnd type="none" w="med" len="med"/>
-                    </a:lnB>
-                    <a:solidFill>
-                      <a:srgbClr val="F0F4F5"/>
-                    </a:solidFill>
-                  </a:tcPr>
-                </a:tc>
-                <a:tc>
-                  <a:txBody>
-                    <a:bodyPr/>
-                    <a:lstStyle/>
-                    <a:p>
-                      <a:pPr algn="r" indent="0" marL="0">
-                        <a:buNone/>
-                      </a:pPr>
-                      <a:r>
-                        <a:rPr lang="en-US" sz="1000" b="1" dirty="0">
-                          <a:solidFill>
-                            <a:srgbClr val="0B2A3D"/>
-                          </a:solidFill>
-                          <a:latin typeface="Calibri" pitchFamily="34" charset="0"/>
-                          <a:ea typeface="Calibri" pitchFamily="34" charset="-122"/>
-                          <a:cs typeface="Calibri" pitchFamily="34" charset="-120"/>
-                        </a:rPr>
-                        <a:t>US$ 247,6 mil</a:t>
-                      </a:r>
-                      <a:endParaRPr lang="en-US" sz="1000" dirty="0">
-                        <a:latin typeface="Calibri" charset="0"/>
-                        <a:ea typeface="Calibri" charset="0"/>
-                        <a:cs typeface="Calibri" charset="0"/>
-                      </a:endParaRPr>
-                    </a:p>
-                  </a:txBody>
-                  <a:tcPr marL="91440" marR="91440" marT="45720" marB="45720" anchor="ctr">
-                    <a:lnL w="6350" cap="flat" cmpd="sng" algn="ctr">
-                      <a:solidFill>
-                        <a:srgbClr val="E3E8E9"/>
-                      </a:solidFill>
-                      <a:prstDash val="solid"/>
-                      <a:round/>
-                      <a:headEnd type="none" w="med" len="med"/>
-                      <a:tailEnd type="none" w="med" len="med"/>
-                    </a:lnL>
-                    <a:lnR w="6350" cap="flat" cmpd="sng" algn="ctr">
-                      <a:solidFill>
-                        <a:srgbClr val="E3E8E9"/>
-                      </a:solidFill>
-                      <a:prstDash val="solid"/>
-                      <a:round/>
-                      <a:headEnd type="none" w="med" len="med"/>
-                      <a:tailEnd type="none" w="med" len="med"/>
-                    </a:lnR>
-                    <a:lnT w="6350" cap="flat" cmpd="sng" algn="ctr">
-                      <a:solidFill>
-                        <a:srgbClr val="E3E8E9"/>
-                      </a:solidFill>
-                      <a:prstDash val="solid"/>
-                      <a:round/>
-                      <a:headEnd type="none" w="med" len="med"/>
-                      <a:tailEnd type="none" w="med" len="med"/>
-                    </a:lnT>
-                    <a:lnB w="6350" cap="flat" cmpd="sng" algn="ctr">
-                      <a:solidFill>
-                        <a:srgbClr val="E3E8E9"/>
-                      </a:solidFill>
-                      <a:prstDash val="solid"/>
-                      <a:round/>
-                      <a:headEnd type="none" w="med" len="med"/>
-                      <a:tailEnd type="none" w="med" len="med"/>
-                    </a:lnB>
-                    <a:solidFill>
-                      <a:srgbClr val="F0F4F5"/>
-                    </a:solidFill>
-                  </a:tcPr>
-                </a:tc>
-              </a:tr>
-              <a:tr h="288036">
-                <a:tc>
-                  <a:txBody>
-                    <a:bodyPr/>
-                    <a:lstStyle/>
-                    <a:p>
-                      <a:pPr indent="0" marL="0">
-                        <a:buNone/>
-                      </a:pPr>
-                      <a:r>
-                        <a:rPr lang="en-US" sz="1000" dirty="0">
-                          <a:solidFill>
-                            <a:srgbClr val="1C2B33"/>
-                          </a:solidFill>
-                          <a:latin typeface="Calibri" pitchFamily="34" charset="0"/>
-                          <a:ea typeface="Calibri" pitchFamily="34" charset="-122"/>
-                          <a:cs typeface="Calibri" pitchFamily="34" charset="-120"/>
-                        </a:rPr>
-                        <a:t>Mobilização TA</a:t>
-                      </a:r>
-                      <a:endParaRPr lang="en-US" sz="1000" dirty="0">
-                        <a:latin typeface="Calibri" charset="0"/>
-                        <a:ea typeface="Calibri" charset="0"/>
-                        <a:cs typeface="Calibri" charset="0"/>
-                      </a:endParaRPr>
-                    </a:p>
-                  </a:txBody>
-                  <a:tcPr marL="91440" marR="91440" marT="45720" marB="45720" anchor="ctr">
-                    <a:lnL w="6350" cap="flat" cmpd="sng" algn="ctr">
-                      <a:solidFill>
-                        <a:srgbClr val="E3E8E9"/>
-                      </a:solidFill>
-                      <a:prstDash val="solid"/>
-                      <a:round/>
-                      <a:headEnd type="none" w="med" len="med"/>
-                      <a:tailEnd type="none" w="med" len="med"/>
-                    </a:lnL>
-                    <a:lnR w="6350" cap="flat" cmpd="sng" algn="ctr">
-                      <a:solidFill>
-                        <a:srgbClr val="E3E8E9"/>
-                      </a:solidFill>
-                      <a:prstDash val="solid"/>
-                      <a:round/>
-                      <a:headEnd type="none" w="med" len="med"/>
-                      <a:tailEnd type="none" w="med" len="med"/>
-                    </a:lnR>
-                    <a:lnT w="6350" cap="flat" cmpd="sng" algn="ctr">
-                      <a:solidFill>
-                        <a:srgbClr val="E3E8E9"/>
-                      </a:solidFill>
-                      <a:prstDash val="solid"/>
-                      <a:round/>
-                      <a:headEnd type="none" w="med" len="med"/>
-                      <a:tailEnd type="none" w="med" len="med"/>
-                    </a:lnT>
-                    <a:lnB w="6350" cap="flat" cmpd="sng" algn="ctr">
-                      <a:solidFill>
-                        <a:srgbClr val="E3E8E9"/>
-                      </a:solidFill>
-                      <a:prstDash val="solid"/>
-                      <a:round/>
-                      <a:headEnd type="none" w="med" len="med"/>
-                      <a:tailEnd type="none" w="med" len="med"/>
-                    </a:lnB>
-                    <a:solidFill>
-                      <a:srgbClr val="FFFFFF"/>
-                    </a:solidFill>
-                  </a:tcPr>
-                </a:tc>
-                <a:tc>
-                  <a:txBody>
-                    <a:bodyPr/>
-                    <a:lstStyle/>
-                    <a:p>
-                      <a:pPr indent="0" marL="0">
-                        <a:buNone/>
-                      </a:pPr>
-                      <a:r>
-                        <a:rPr lang="en-US" sz="950" dirty="0">
-                          <a:solidFill>
-                            <a:srgbClr val="5B6B73"/>
-                          </a:solidFill>
-                          <a:latin typeface="Calibri" pitchFamily="34" charset="0"/>
-                          <a:ea typeface="Calibri" pitchFamily="34" charset="-122"/>
-                          <a:cs typeface="Calibri" pitchFamily="34" charset="-120"/>
-                        </a:rPr>
-                        <a:t>Eficiência de Produção</a:t>
-                      </a:r>
-                      <a:endParaRPr lang="en-US" sz="950" dirty="0">
-                        <a:latin typeface="Calibri" charset="0"/>
-                        <a:ea typeface="Calibri" charset="0"/>
-                        <a:cs typeface="Calibri" charset="0"/>
-                      </a:endParaRPr>
-                    </a:p>
-                  </a:txBody>
-                  <a:tcPr marL="91440" marR="91440" marT="45720" marB="45720" anchor="ctr">
-                    <a:lnL w="6350" cap="flat" cmpd="sng" algn="ctr">
-                      <a:solidFill>
-                        <a:srgbClr val="E3E8E9"/>
-                      </a:solidFill>
-                      <a:prstDash val="solid"/>
-                      <a:round/>
-                      <a:headEnd type="none" w="med" len="med"/>
-                      <a:tailEnd type="none" w="med" len="med"/>
-                    </a:lnL>
-                    <a:lnR w="6350" cap="flat" cmpd="sng" algn="ctr">
-                      <a:solidFill>
-                        <a:srgbClr val="E3E8E9"/>
-                      </a:solidFill>
-                      <a:prstDash val="solid"/>
-                      <a:round/>
-                      <a:headEnd type="none" w="med" len="med"/>
-                      <a:tailEnd type="none" w="med" len="med"/>
-                    </a:lnR>
-                    <a:lnT w="6350" cap="flat" cmpd="sng" algn="ctr">
-                      <a:solidFill>
-                        <a:srgbClr val="E3E8E9"/>
-                      </a:solidFill>
-                      <a:prstDash val="solid"/>
-                      <a:round/>
-                      <a:headEnd type="none" w="med" len="med"/>
-                      <a:tailEnd type="none" w="med" len="med"/>
-                    </a:lnT>
-                    <a:lnB w="6350" cap="flat" cmpd="sng" algn="ctr">
-                      <a:solidFill>
-                        <a:srgbClr val="E3E8E9"/>
-                      </a:solidFill>
-                      <a:prstDash val="solid"/>
-                      <a:round/>
-                      <a:headEnd type="none" w="med" len="med"/>
-                      <a:tailEnd type="none" w="med" len="med"/>
-                    </a:lnB>
-                    <a:solidFill>
-                      <a:srgbClr val="FFFFFF"/>
-                    </a:solidFill>
-                  </a:tcPr>
-                </a:tc>
-                <a:tc>
-                  <a:txBody>
-                    <a:bodyPr/>
-                    <a:lstStyle/>
-                    <a:p>
-                      <a:pPr indent="0" marL="0">
-                        <a:buNone/>
-                      </a:pPr>
-                      <a:r>
-                        <a:rPr lang="en-US" sz="950" dirty="0">
-                          <a:solidFill>
-                            <a:srgbClr val="5B6B73"/>
-                          </a:solidFill>
-                          <a:latin typeface="Calibri" pitchFamily="34" charset="0"/>
-                          <a:ea typeface="Calibri" pitchFamily="34" charset="-122"/>
-                          <a:cs typeface="Calibri" pitchFamily="34" charset="-120"/>
-                        </a:rPr>
-                        <a:t>TA - Parada Programada</a:t>
-                      </a:r>
-                      <a:endParaRPr lang="en-US" sz="950" dirty="0">
-                        <a:latin typeface="Calibri" charset="0"/>
-                        <a:ea typeface="Calibri" charset="0"/>
-                        <a:cs typeface="Calibri" charset="0"/>
-                      </a:endParaRPr>
-                    </a:p>
-                  </a:txBody>
-                  <a:tcPr marL="91440" marR="91440" marT="45720" marB="45720" anchor="ctr">
-                    <a:lnL w="6350" cap="flat" cmpd="sng" algn="ctr">
-                      <a:solidFill>
-                        <a:srgbClr val="E3E8E9"/>
-                      </a:solidFill>
-                      <a:prstDash val="solid"/>
-                      <a:round/>
-                      <a:headEnd type="none" w="med" len="med"/>
-                      <a:tailEnd type="none" w="med" len="med"/>
-                    </a:lnL>
-                    <a:lnR w="6350" cap="flat" cmpd="sng" algn="ctr">
-                      <a:solidFill>
-                        <a:srgbClr val="E3E8E9"/>
-                      </a:solidFill>
-                      <a:prstDash val="solid"/>
-                      <a:round/>
-                      <a:headEnd type="none" w="med" len="med"/>
-                      <a:tailEnd type="none" w="med" len="med"/>
-                    </a:lnR>
-                    <a:lnT w="6350" cap="flat" cmpd="sng" algn="ctr">
-                      <a:solidFill>
-                        <a:srgbClr val="E3E8E9"/>
-                      </a:solidFill>
-                      <a:prstDash val="solid"/>
-                      <a:round/>
-                      <a:headEnd type="none" w="med" len="med"/>
-                      <a:tailEnd type="none" w="med" len="med"/>
-                    </a:lnT>
-                    <a:lnB w="6350" cap="flat" cmpd="sng" algn="ctr">
-                      <a:solidFill>
-                        <a:srgbClr val="E3E8E9"/>
-                      </a:solidFill>
-                      <a:prstDash val="solid"/>
-                      <a:round/>
-                      <a:headEnd type="none" w="med" len="med"/>
-                      <a:tailEnd type="none" w="med" len="med"/>
-                    </a:lnB>
-                    <a:solidFill>
-                      <a:srgbClr val="FFFFFF"/>
-                    </a:solidFill>
-                  </a:tcPr>
-                </a:tc>
-                <a:tc>
-                  <a:txBody>
-                    <a:bodyPr/>
-                    <a:lstStyle/>
-                    <a:p>
-                      <a:pPr algn="r" indent="0" marL="0">
-                        <a:buNone/>
-                      </a:pPr>
-                      <a:r>
-                        <a:rPr lang="en-US" sz="1000" b="1" dirty="0">
-                          <a:solidFill>
-                            <a:srgbClr val="0B2A3D"/>
-                          </a:solidFill>
-                          <a:latin typeface="Calibri" pitchFamily="34" charset="0"/>
-                          <a:ea typeface="Calibri" pitchFamily="34" charset="-122"/>
-                          <a:cs typeface="Calibri" pitchFamily="34" charset="-120"/>
-                        </a:rPr>
-                        <a:t>US$ 247,6 mil</a:t>
-                      </a:r>
-                      <a:endParaRPr lang="en-US" sz="1000" dirty="0">
-                        <a:latin typeface="Calibri" charset="0"/>
-                        <a:ea typeface="Calibri" charset="0"/>
-                        <a:cs typeface="Calibri" charset="0"/>
-                      </a:endParaRPr>
-                    </a:p>
-                  </a:txBody>
-                  <a:tcPr marL="91440" marR="91440" marT="45720" marB="45720" anchor="ctr">
-                    <a:lnL w="6350" cap="flat" cmpd="sng" algn="ctr">
-                      <a:solidFill>
-                        <a:srgbClr val="E3E8E9"/>
-                      </a:solidFill>
-                      <a:prstDash val="solid"/>
-                      <a:round/>
-                      <a:headEnd type="none" w="med" len="med"/>
-                      <a:tailEnd type="none" w="med" len="med"/>
-                    </a:lnL>
-                    <a:lnR w="6350" cap="flat" cmpd="sng" algn="ctr">
-                      <a:solidFill>
-                        <a:srgbClr val="E3E8E9"/>
-                      </a:solidFill>
-                      <a:prstDash val="solid"/>
-                      <a:round/>
-                      <a:headEnd type="none" w="med" len="med"/>
-                      <a:tailEnd type="none" w="med" len="med"/>
-                    </a:lnR>
-                    <a:lnT w="6350" cap="flat" cmpd="sng" algn="ctr">
-                      <a:solidFill>
-                        <a:srgbClr val="E3E8E9"/>
-                      </a:solidFill>
-                      <a:prstDash val="solid"/>
-                      <a:round/>
-                      <a:headEnd type="none" w="med" len="med"/>
-                      <a:tailEnd type="none" w="med" len="med"/>
-                    </a:lnT>
-                    <a:lnB w="6350" cap="flat" cmpd="sng" algn="ctr">
-                      <a:solidFill>
-                        <a:srgbClr val="E3E8E9"/>
-                      </a:solidFill>
-                      <a:prstDash val="solid"/>
-                      <a:round/>
-                      <a:headEnd type="none" w="med" len="med"/>
-                      <a:tailEnd type="none" w="med" len="med"/>
-                    </a:lnB>
-                    <a:solidFill>
-                      <a:srgbClr val="FFFFFF"/>
-                    </a:solidFill>
-                  </a:tcPr>
-                </a:tc>
-              </a:tr>
-              <a:tr h="288036">
-                <a:tc>
-                  <a:txBody>
-                    <a:bodyPr/>
-                    <a:lstStyle/>
-                    <a:p>
-                      <a:pPr indent="0" marL="0">
-                        <a:buNone/>
-                      </a:pPr>
-                      <a:r>
-                        <a:rPr lang="en-US" sz="1000" dirty="0">
-                          <a:solidFill>
-                            <a:srgbClr val="1C2B33"/>
-                          </a:solidFill>
-                          <a:latin typeface="Calibri" pitchFamily="34" charset="0"/>
-                          <a:ea typeface="Calibri" pitchFamily="34" charset="-122"/>
-                          <a:cs typeface="Calibri" pitchFamily="34" charset="-120"/>
-                        </a:rPr>
-                        <a:t>Comutação tanques de diesel (tanque e sedimentação e serviço)</a:t>
-                      </a:r>
-                      <a:endParaRPr lang="en-US" sz="1000" dirty="0">
-                        <a:latin typeface="Calibri" charset="0"/>
-                        <a:ea typeface="Calibri" charset="0"/>
-                        <a:cs typeface="Calibri" charset="0"/>
-                      </a:endParaRPr>
-                    </a:p>
-                  </a:txBody>
-                  <a:tcPr marL="91440" marR="91440" marT="45720" marB="45720" anchor="ctr">
-                    <a:lnL w="6350" cap="flat" cmpd="sng" algn="ctr">
-                      <a:solidFill>
-                        <a:srgbClr val="E3E8E9"/>
-                      </a:solidFill>
-                      <a:prstDash val="solid"/>
-                      <a:round/>
-                      <a:headEnd type="none" w="med" len="med"/>
-                      <a:tailEnd type="none" w="med" len="med"/>
-                    </a:lnL>
-                    <a:lnR w="6350" cap="flat" cmpd="sng" algn="ctr">
-                      <a:solidFill>
-                        <a:srgbClr val="E3E8E9"/>
-                      </a:solidFill>
-                      <a:prstDash val="solid"/>
-                      <a:round/>
-                      <a:headEnd type="none" w="med" len="med"/>
-                      <a:tailEnd type="none" w="med" len="med"/>
-                    </a:lnR>
-                    <a:lnT w="6350" cap="flat" cmpd="sng" algn="ctr">
-                      <a:solidFill>
-                        <a:srgbClr val="E3E8E9"/>
-                      </a:solidFill>
-                      <a:prstDash val="solid"/>
-                      <a:round/>
-                      <a:headEnd type="none" w="med" len="med"/>
-                      <a:tailEnd type="none" w="med" len="med"/>
-                    </a:lnT>
-                    <a:lnB w="6350" cap="flat" cmpd="sng" algn="ctr">
-                      <a:solidFill>
-                        <a:srgbClr val="E3E8E9"/>
-                      </a:solidFill>
-                      <a:prstDash val="solid"/>
-                      <a:round/>
-                      <a:headEnd type="none" w="med" len="med"/>
-                      <a:tailEnd type="none" w="med" len="med"/>
-                    </a:lnB>
-                    <a:solidFill>
-                      <a:srgbClr val="F0F4F5"/>
-                    </a:solidFill>
-                  </a:tcPr>
-                </a:tc>
-                <a:tc>
-                  <a:txBody>
-                    <a:bodyPr/>
-                    <a:lstStyle/>
-                    <a:p>
-                      <a:pPr indent="0" marL="0">
-                        <a:buNone/>
-                      </a:pPr>
-                      <a:r>
-                        <a:rPr lang="en-US" sz="950" dirty="0">
-                          <a:solidFill>
-                            <a:srgbClr val="5B6B73"/>
-                          </a:solidFill>
-                          <a:latin typeface="Calibri" pitchFamily="34" charset="0"/>
-                          <a:ea typeface="Calibri" pitchFamily="34" charset="-122"/>
-                          <a:cs typeface="Calibri" pitchFamily="34" charset="-120"/>
-                        </a:rPr>
-                        <a:t>Eficiência de Produção</a:t>
-                      </a:r>
-                      <a:endParaRPr lang="en-US" sz="950" dirty="0">
-                        <a:latin typeface="Calibri" charset="0"/>
-                        <a:ea typeface="Calibri" charset="0"/>
-                        <a:cs typeface="Calibri" charset="0"/>
-                      </a:endParaRPr>
-                    </a:p>
-                  </a:txBody>
-                  <a:tcPr marL="91440" marR="91440" marT="45720" marB="45720" anchor="ctr">
-                    <a:lnL w="6350" cap="flat" cmpd="sng" algn="ctr">
-                      <a:solidFill>
-                        <a:srgbClr val="E3E8E9"/>
-                      </a:solidFill>
-                      <a:prstDash val="solid"/>
-                      <a:round/>
-                      <a:headEnd type="none" w="med" len="med"/>
-                      <a:tailEnd type="none" w="med" len="med"/>
-                    </a:lnL>
-                    <a:lnR w="6350" cap="flat" cmpd="sng" algn="ctr">
-                      <a:solidFill>
-                        <a:srgbClr val="E3E8E9"/>
-                      </a:solidFill>
-                      <a:prstDash val="solid"/>
-                      <a:round/>
-                      <a:headEnd type="none" w="med" len="med"/>
-                      <a:tailEnd type="none" w="med" len="med"/>
-                    </a:lnR>
-                    <a:lnT w="6350" cap="flat" cmpd="sng" algn="ctr">
-                      <a:solidFill>
-                        <a:srgbClr val="E3E8E9"/>
-                      </a:solidFill>
-                      <a:prstDash val="solid"/>
-                      <a:round/>
-                      <a:headEnd type="none" w="med" len="med"/>
-                      <a:tailEnd type="none" w="med" len="med"/>
-                    </a:lnT>
-                    <a:lnB w="6350" cap="flat" cmpd="sng" algn="ctr">
-                      <a:solidFill>
-                        <a:srgbClr val="E3E8E9"/>
-                      </a:solidFill>
-                      <a:prstDash val="solid"/>
-                      <a:round/>
-                      <a:headEnd type="none" w="med" len="med"/>
-                      <a:tailEnd type="none" w="med" len="med"/>
-                    </a:lnB>
-                    <a:solidFill>
-                      <a:srgbClr val="F0F4F5"/>
-                    </a:solidFill>
-                  </a:tcPr>
-                </a:tc>
-                <a:tc>
-                  <a:txBody>
-                    <a:bodyPr/>
-                    <a:lstStyle/>
-                    <a:p>
-                      <a:pPr indent="0" marL="0">
-                        <a:buNone/>
-                      </a:pPr>
-                      <a:r>
-                        <a:rPr lang="en-US" sz="950" dirty="0">
-                          <a:solidFill>
-                            <a:srgbClr val="5B6B73"/>
-                          </a:solidFill>
-                          <a:latin typeface="Calibri" pitchFamily="34" charset="0"/>
-                          <a:ea typeface="Calibri" pitchFamily="34" charset="-122"/>
-                          <a:cs typeface="Calibri" pitchFamily="34" charset="-120"/>
-                        </a:rPr>
-                        <a:t>Projetos</a:t>
-                      </a:r>
-                      <a:endParaRPr lang="en-US" sz="950" dirty="0">
-                        <a:latin typeface="Calibri" charset="0"/>
-                        <a:ea typeface="Calibri" charset="0"/>
-                        <a:cs typeface="Calibri" charset="0"/>
-                      </a:endParaRPr>
-                    </a:p>
-                  </a:txBody>
-                  <a:tcPr marL="91440" marR="91440" marT="45720" marB="45720" anchor="ctr">
-                    <a:lnL w="6350" cap="flat" cmpd="sng" algn="ctr">
-                      <a:solidFill>
-                        <a:srgbClr val="E3E8E9"/>
-                      </a:solidFill>
-                      <a:prstDash val="solid"/>
-                      <a:round/>
-                      <a:headEnd type="none" w="med" len="med"/>
-                      <a:tailEnd type="none" w="med" len="med"/>
-                    </a:lnL>
-                    <a:lnR w="6350" cap="flat" cmpd="sng" algn="ctr">
-                      <a:solidFill>
-                        <a:srgbClr val="E3E8E9"/>
-                      </a:solidFill>
-                      <a:prstDash val="solid"/>
-                      <a:round/>
-                      <a:headEnd type="none" w="med" len="med"/>
-                      <a:tailEnd type="none" w="med" len="med"/>
-                    </a:lnR>
-                    <a:lnT w="6350" cap="flat" cmpd="sng" algn="ctr">
-                      <a:solidFill>
-                        <a:srgbClr val="E3E8E9"/>
-                      </a:solidFill>
-                      <a:prstDash val="solid"/>
-                      <a:round/>
-                      <a:headEnd type="none" w="med" len="med"/>
-                      <a:tailEnd type="none" w="med" len="med"/>
-                    </a:lnT>
-                    <a:lnB w="6350" cap="flat" cmpd="sng" algn="ctr">
-                      <a:solidFill>
-                        <a:srgbClr val="E3E8E9"/>
-                      </a:solidFill>
-                      <a:prstDash val="solid"/>
-                      <a:round/>
-                      <a:headEnd type="none" w="med" len="med"/>
-                      <a:tailEnd type="none" w="med" len="med"/>
-                    </a:lnB>
-                    <a:solidFill>
-                      <a:srgbClr val="F0F4F5"/>
-                    </a:solidFill>
-                  </a:tcPr>
-                </a:tc>
-                <a:tc>
-                  <a:txBody>
-                    <a:bodyPr/>
-                    <a:lstStyle/>
-                    <a:p>
-                      <a:pPr algn="r" indent="0" marL="0">
-                        <a:buNone/>
-                      </a:pPr>
-                      <a:r>
-                        <a:rPr lang="en-US" sz="1000" b="1" dirty="0">
-                          <a:solidFill>
-                            <a:srgbClr val="0B2A3D"/>
-                          </a:solidFill>
-                          <a:latin typeface="Calibri" pitchFamily="34" charset="0"/>
-                          <a:ea typeface="Calibri" pitchFamily="34" charset="-122"/>
-                          <a:cs typeface="Calibri" pitchFamily="34" charset="-120"/>
-                        </a:rPr>
-                        <a:t>US$ 236,6 mil</a:t>
-                      </a:r>
-                      <a:endParaRPr lang="en-US" sz="1000" dirty="0">
-                        <a:latin typeface="Calibri" charset="0"/>
-                        <a:ea typeface="Calibri" charset="0"/>
-                        <a:cs typeface="Calibri" charset="0"/>
-                      </a:endParaRPr>
-                    </a:p>
-                  </a:txBody>
-                  <a:tcPr marL="91440" marR="91440" marT="45720" marB="45720" anchor="ctr">
-                    <a:lnL w="6350" cap="flat" cmpd="sng" algn="ctr">
-                      <a:solidFill>
-                        <a:srgbClr val="E3E8E9"/>
-                      </a:solidFill>
-                      <a:prstDash val="solid"/>
-                      <a:round/>
-                      <a:headEnd type="none" w="med" len="med"/>
-                      <a:tailEnd type="none" w="med" len="med"/>
-                    </a:lnL>
-                    <a:lnR w="6350" cap="flat" cmpd="sng" algn="ctr">
-                      <a:solidFill>
-                        <a:srgbClr val="E3E8E9"/>
-                      </a:solidFill>
-                      <a:prstDash val="solid"/>
-                      <a:round/>
-                      <a:headEnd type="none" w="med" len="med"/>
-                      <a:tailEnd type="none" w="med" len="med"/>
-                    </a:lnR>
-                    <a:lnT w="6350" cap="flat" cmpd="sng" algn="ctr">
-                      <a:solidFill>
-                        <a:srgbClr val="E3E8E9"/>
-                      </a:solidFill>
-                      <a:prstDash val="solid"/>
-                      <a:round/>
-                      <a:headEnd type="none" w="med" len="med"/>
-                      <a:tailEnd type="none" w="med" len="med"/>
-                    </a:lnT>
-                    <a:lnB w="6350" cap="flat" cmpd="sng" algn="ctr">
-                      <a:solidFill>
-                        <a:srgbClr val="E3E8E9"/>
-                      </a:solidFill>
-                      <a:prstDash val="solid"/>
-                      <a:round/>
-                      <a:headEnd type="none" w="med" len="med"/>
-                      <a:tailEnd type="none" w="med" len="med"/>
-                    </a:lnB>
-                    <a:solidFill>
-                      <a:srgbClr val="F0F4F5"/>
-                    </a:solidFill>
-                  </a:tcPr>
-                </a:tc>
-              </a:tr>
-              <a:tr h="288036">
                 <a:tc gridSpan="3">
                   <a:txBody>
                     <a:bodyPr/>
@@ -17047,7 +17047,7 @@
                           <a:ea typeface="Calibri" pitchFamily="34" charset="-122"/>
                           <a:cs typeface="Calibri" pitchFamily="34" charset="-120"/>
                         </a:rPr>
-                        <a:t>Outros 47 escopos (itens de menor valor individual)</a:t>
+                        <a:t>Outros 58 escopos (itens de menor valor individual)</a:t>
                       </a:r>
                       <a:endParaRPr lang="en-US" sz="950" dirty="0">
                         <a:latin typeface="Calibri" charset="0"/>
@@ -17121,7 +17121,7 @@
                           <a:ea typeface="Calibri" pitchFamily="34" charset="-122"/>
                           <a:cs typeface="Calibri" pitchFamily="34" charset="-120"/>
                         </a:rPr>
-                        <a:t>US$ 2,4 mi</a:t>
+                        <a:t>US$ 4,3 mi</a:t>
                       </a:r>
                       <a:endParaRPr lang="en-US" sz="1000" dirty="0">
                         <a:latin typeface="Calibri" charset="0"/>
@@ -17697,7 +17697,7 @@
                 <a:ea typeface="Cambria" pitchFamily="34" charset="-122"/>
                 <a:cs typeface="Cambria" pitchFamily="34" charset="-120"/>
               </a:rPr>
-              <a:t>US$ 4,3 mi</a:t>
+              <a:t>US$ 3,6 mi</a:t>
             </a:r>
             <a:endParaRPr lang="en-US" sz="3300" dirty="0"/>
           </a:p>
@@ -17836,7 +17836,7 @@
                 <a:ea typeface="Cambria" pitchFamily="34" charset="-122"/>
                 <a:cs typeface="Cambria" pitchFamily="34" charset="-120"/>
               </a:rPr>
-              <a:t>US$ 2,7 mi</a:t>
+              <a:t>US$ 3,0 mi</a:t>
             </a:r>
             <a:endParaRPr lang="en-US" sz="1800" dirty="0"/>
           </a:p>
@@ -17936,7 +17936,7 @@
                 <a:ea typeface="Cambria" pitchFamily="34" charset="-122"/>
                 <a:cs typeface="Cambria" pitchFamily="34" charset="-120"/>
               </a:rPr>
-              <a:t>US$ 1,6 mi</a:t>
+              <a:t>US$ 592,3 mil</a:t>
             </a:r>
             <a:endParaRPr lang="en-US" sz="1800" dirty="0"/>
           </a:p>
@@ -18036,7 +18036,7 @@
                 <a:ea typeface="Cambria" pitchFamily="34" charset="-122"/>
                 <a:cs typeface="Cambria" pitchFamily="34" charset="-120"/>
               </a:rPr>
-              <a:t>US$ 2,3 mi</a:t>
+              <a:t>US$ 2,5 mi</a:t>
             </a:r>
             <a:endParaRPr lang="en-US" sz="1800" dirty="0"/>
           </a:p>
@@ -18136,7 +18136,7 @@
                 <a:ea typeface="Cambria" pitchFamily="34" charset="-122"/>
                 <a:cs typeface="Cambria" pitchFamily="34" charset="-120"/>
               </a:rPr>
-              <a:t>US$ 2,0 mi</a:t>
+              <a:t>US$ 1,1 mi</a:t>
             </a:r>
             <a:endParaRPr lang="en-US" sz="1800" dirty="0"/>
           </a:p>
@@ -18315,7 +18315,7 @@
                 <a:ea typeface="Calibri" pitchFamily="34" charset="-122"/>
                 <a:cs typeface="Calibri" pitchFamily="34" charset="-120"/>
               </a:rPr>
-              <a:t>US$ 2,4 mi</a:t>
+              <a:t>US$ 2,2 mi</a:t>
             </a:r>
             <a:endParaRPr lang="en-US" sz="1100" dirty="0"/>
           </a:p>
@@ -18413,7 +18413,7 @@
                 <a:ea typeface="Calibri" pitchFamily="34" charset="-122"/>
                 <a:cs typeface="Calibri" pitchFamily="34" charset="-120"/>
               </a:rPr>
-              <a:t>US$ 1,6 mi</a:t>
+              <a:t>US$ 592,3 mil</a:t>
             </a:r>
             <a:endParaRPr lang="en-US" sz="1100" dirty="0"/>
           </a:p>
@@ -18428,6 +18428,104 @@
         <p:spPr>
           <a:xfrm>
             <a:off x="566928" y="4133088"/>
+            <a:ext cx="3316529" cy="365760"/>
+          </a:xfrm>
+          <a:prstGeom prst="rect">
+            <a:avLst/>
+          </a:prstGeom>
+          <a:noFill/>
+          <a:ln/>
+        </p:spPr>
+        <p:txBody>
+          <a:bodyPr wrap="square" lIns="0" tIns="0" rIns="0" bIns="0" rtlCol="0" anchor="ctr"/>
+          <a:lstStyle/>
+          <a:p>
+            <a:pPr indent="0" marL="0">
+              <a:buNone/>
+            </a:pPr>
+            <a:r>
+              <a:rPr lang="en-US" sz="1100" dirty="0">
+                <a:solidFill>
+                  <a:srgbClr val="1C2B33"/>
+                </a:solidFill>
+                <a:latin typeface="Calibri" pitchFamily="34" charset="0"/>
+                <a:ea typeface="Calibri" pitchFamily="34" charset="-122"/>
+                <a:cs typeface="Calibri" pitchFamily="34" charset="-120"/>
+              </a:rPr>
+              <a:t>EIM - Manutenção &amp; Integridade</a:t>
+            </a:r>
+            <a:endParaRPr lang="en-US" sz="1100" dirty="0"/>
+          </a:p>
+        </p:txBody>
+      </p:sp>
+      <p:sp>
+        <p:nvSpPr>
+          <p:cNvPr id="30" name="Text 28"/>
+          <p:cNvSpPr txBox="1"/>
+          <p:nvPr/>
+        </p:nvSpPr>
+        <p:spPr>
+          <a:xfrm>
+            <a:off x="3773729" y="4133088"/>
+            <a:ext cx="1815998" cy="365760"/>
+          </a:xfrm>
+          <a:prstGeom prst="rect">
+            <a:avLst/>
+          </a:prstGeom>
+          <a:noFill/>
+          <a:ln/>
+        </p:spPr>
+        <p:txBody>
+          <a:bodyPr wrap="square" lIns="0" tIns="0" rIns="0" bIns="0" rtlCol="0" anchor="ctr"/>
+          <a:lstStyle/>
+          <a:p>
+            <a:pPr algn="r" indent="0" marL="0">
+              <a:buNone/>
+            </a:pPr>
+            <a:r>
+              <a:rPr lang="en-US" sz="1100" b="1" dirty="0">
+                <a:solidFill>
+                  <a:srgbClr val="0B2A3D"/>
+                </a:solidFill>
+                <a:latin typeface="Calibri" pitchFamily="34" charset="0"/>
+                <a:ea typeface="Calibri" pitchFamily="34" charset="-122"/>
+                <a:cs typeface="Calibri" pitchFamily="34" charset="-120"/>
+              </a:rPr>
+              <a:t>US$ 519,2 mil</a:t>
+            </a:r>
+            <a:endParaRPr lang="en-US" sz="1100" dirty="0"/>
+          </a:p>
+        </p:txBody>
+      </p:sp>
+      <p:sp>
+        <p:nvSpPr>
+          <p:cNvPr id="31" name="Shape 29"/>
+          <p:cNvSpPr/>
+          <p:nvPr/>
+        </p:nvSpPr>
+        <p:spPr>
+          <a:xfrm>
+            <a:off x="457200" y="4498848"/>
+            <a:ext cx="5349240" cy="365760"/>
+          </a:xfrm>
+          <a:prstGeom prst="rect">
+            <a:avLst/>
+          </a:prstGeom>
+          <a:solidFill>
+            <a:srgbClr val="F0F4F5"/>
+          </a:solidFill>
+          <a:ln/>
+        </p:spPr>
+      </p:sp>
+      <p:sp>
+        <p:nvSpPr>
+          <p:cNvPr id="32" name="Text 30"/>
+          <p:cNvSpPr txBox="1"/>
+          <p:nvPr/>
+        </p:nvSpPr>
+        <p:spPr>
+          <a:xfrm>
+            <a:off x="566928" y="4498848"/>
             <a:ext cx="3316529" cy="365760"/>
           </a:xfrm>
           <a:prstGeom prst="rect">
@@ -18460,13 +18558,13 @@
       </p:sp>
       <p:sp>
         <p:nvSpPr>
-          <p:cNvPr id="30" name="Text 28"/>
+          <p:cNvPr id="33" name="Text 31"/>
           <p:cNvSpPr txBox="1"/>
           <p:nvPr/>
         </p:nvSpPr>
         <p:spPr>
           <a:xfrm>
-            <a:off x="3773729" y="4133088"/>
+            <a:off x="3773729" y="4498848"/>
             <a:ext cx="1815998" cy="365760"/>
           </a:xfrm>
           <a:prstGeom prst="rect">
@@ -18499,33 +18597,13 @@
       </p:sp>
       <p:sp>
         <p:nvSpPr>
-          <p:cNvPr id="31" name="Shape 29"/>
-          <p:cNvSpPr/>
+          <p:cNvPr id="34" name="Text 32"/>
+          <p:cNvSpPr txBox="1"/>
           <p:nvPr/>
         </p:nvSpPr>
         <p:spPr>
           <a:xfrm>
-            <a:off x="457200" y="4498848"/>
-            <a:ext cx="5349240" cy="365760"/>
-          </a:xfrm>
-          <a:prstGeom prst="rect">
-            <a:avLst/>
-          </a:prstGeom>
-          <a:solidFill>
-            <a:srgbClr val="F0F4F5"/>
-          </a:solidFill>
-          <a:ln/>
-        </p:spPr>
-      </p:sp>
-      <p:sp>
-        <p:nvSpPr>
-          <p:cNvPr id="32" name="Text 30"/>
-          <p:cNvSpPr txBox="1"/>
-          <p:nvPr/>
-        </p:nvSpPr>
-        <p:spPr>
-          <a:xfrm>
-            <a:off x="566928" y="4498848"/>
+            <a:off x="566928" y="4864608"/>
             <a:ext cx="3316529" cy="365760"/>
           </a:xfrm>
           <a:prstGeom prst="rect">
@@ -18558,13 +18636,13 @@
       </p:sp>
       <p:sp>
         <p:nvSpPr>
-          <p:cNvPr id="33" name="Text 31"/>
+          <p:cNvPr id="35" name="Text 33"/>
           <p:cNvSpPr txBox="1"/>
           <p:nvPr/>
         </p:nvSpPr>
         <p:spPr>
           <a:xfrm>
-            <a:off x="3773729" y="4498848"/>
+            <a:off x="3773729" y="4864608"/>
             <a:ext cx="1815998" cy="365760"/>
           </a:xfrm>
           <a:prstGeom prst="rect">
@@ -18597,7 +18675,7 @@
       </p:sp>
       <p:sp>
         <p:nvSpPr>
-          <p:cNvPr id="34" name="Text 32"/>
+          <p:cNvPr id="36" name="Text 34"/>
           <p:cNvSpPr txBox="1"/>
           <p:nvPr/>
         </p:nvSpPr>
@@ -18636,7 +18714,7 @@
       </p:sp>
       <p:sp>
         <p:nvSpPr>
-          <p:cNvPr id="35" name="Shape 33"/>
+          <p:cNvPr id="37" name="Shape 35"/>
           <p:cNvSpPr/>
           <p:nvPr/>
         </p:nvSpPr>
@@ -18659,7 +18737,7 @@
       </p:sp>
       <p:sp>
         <p:nvSpPr>
-          <p:cNvPr id="36" name="Text 34"/>
+          <p:cNvPr id="38" name="Text 36"/>
           <p:cNvSpPr txBox="1"/>
           <p:nvPr/>
         </p:nvSpPr>
@@ -18698,7 +18776,7 @@
       </p:sp>
       <p:sp>
         <p:nvSpPr>
-          <p:cNvPr id="37" name="Text 35"/>
+          <p:cNvPr id="39" name="Text 37"/>
           <p:cNvSpPr txBox="1"/>
           <p:nvPr/>
         </p:nvSpPr>
@@ -18729,7 +18807,7 @@
                 <a:ea typeface="Calibri" pitchFamily="34" charset="-122"/>
                 <a:cs typeface="Calibri" pitchFamily="34" charset="-120"/>
               </a:rPr>
-              <a:t>US$ 2,5 mi</a:t>
+              <a:t>US$ 1,5 mi</a:t>
             </a:r>
             <a:endParaRPr lang="en-US" sz="1100" dirty="0"/>
           </a:p>
@@ -18737,7 +18815,7 @@
       </p:sp>
       <p:sp>
         <p:nvSpPr>
-          <p:cNvPr id="38" name="Shape 36"/>
+          <p:cNvPr id="40" name="Shape 38"/>
           <p:cNvSpPr/>
           <p:nvPr/>
         </p:nvSpPr>
@@ -18757,7 +18835,7 @@
       </p:sp>
       <p:sp>
         <p:nvSpPr>
-          <p:cNvPr id="39" name="Text 37"/>
+          <p:cNvPr id="41" name="Text 39"/>
           <p:cNvSpPr txBox="1"/>
           <p:nvPr/>
         </p:nvSpPr>
@@ -18796,7 +18874,7 @@
       </p:sp>
       <p:sp>
         <p:nvSpPr>
-          <p:cNvPr id="40" name="Text 38"/>
+          <p:cNvPr id="42" name="Text 40"/>
           <p:cNvSpPr txBox="1"/>
           <p:nvPr/>
         </p:nvSpPr>
@@ -18827,7 +18905,7 @@
                 <a:ea typeface="Calibri" pitchFamily="34" charset="-122"/>
                 <a:cs typeface="Calibri" pitchFamily="34" charset="-120"/>
               </a:rPr>
-              <a:t>US$ 1,6 mi</a:t>
+              <a:t>US$ 1,4 mi</a:t>
             </a:r>
             <a:endParaRPr lang="en-US" sz="1100" dirty="0"/>
           </a:p>
@@ -18835,13 +18913,111 @@
       </p:sp>
       <p:sp>
         <p:nvSpPr>
-          <p:cNvPr id="41" name="Text 39"/>
+          <p:cNvPr id="43" name="Text 41"/>
           <p:cNvSpPr txBox="1"/>
           <p:nvPr/>
         </p:nvSpPr>
         <p:spPr>
           <a:xfrm>
             <a:off x="6464808" y="4133088"/>
+            <a:ext cx="3316529" cy="365760"/>
+          </a:xfrm>
+          <a:prstGeom prst="rect">
+            <a:avLst/>
+          </a:prstGeom>
+          <a:noFill/>
+          <a:ln/>
+        </p:spPr>
+        <p:txBody>
+          <a:bodyPr wrap="square" lIns="0" tIns="0" rIns="0" bIns="0" rtlCol="0" anchor="ctr"/>
+          <a:lstStyle/>
+          <a:p>
+            <a:pPr indent="0" marL="0">
+              <a:buNone/>
+            </a:pPr>
+            <a:r>
+              <a:rPr lang="en-US" sz="1100" dirty="0">
+                <a:solidFill>
+                  <a:srgbClr val="1C2B33"/>
+                </a:solidFill>
+                <a:latin typeface="Calibri" pitchFamily="34" charset="0"/>
+                <a:ea typeface="Calibri" pitchFamily="34" charset="-122"/>
+                <a:cs typeface="Calibri" pitchFamily="34" charset="-120"/>
+              </a:rPr>
+              <a:t>Rotina Operacional</a:t>
+            </a:r>
+            <a:endParaRPr lang="en-US" sz="1100" dirty="0"/>
+          </a:p>
+        </p:txBody>
+      </p:sp>
+      <p:sp>
+        <p:nvSpPr>
+          <p:cNvPr id="44" name="Text 42"/>
+          <p:cNvSpPr txBox="1"/>
+          <p:nvPr/>
+        </p:nvSpPr>
+        <p:spPr>
+          <a:xfrm>
+            <a:off x="9671609" y="4133088"/>
+            <a:ext cx="1815998" cy="365760"/>
+          </a:xfrm>
+          <a:prstGeom prst="rect">
+            <a:avLst/>
+          </a:prstGeom>
+          <a:noFill/>
+          <a:ln/>
+        </p:spPr>
+        <p:txBody>
+          <a:bodyPr wrap="square" lIns="0" tIns="0" rIns="0" bIns="0" rtlCol="0" anchor="ctr"/>
+          <a:lstStyle/>
+          <a:p>
+            <a:pPr algn="r" indent="0" marL="0">
+              <a:buNone/>
+            </a:pPr>
+            <a:r>
+              <a:rPr lang="en-US" sz="1100" b="1" dirty="0">
+                <a:solidFill>
+                  <a:srgbClr val="0B2A3D"/>
+                </a:solidFill>
+                <a:latin typeface="Calibri" pitchFamily="34" charset="0"/>
+                <a:ea typeface="Calibri" pitchFamily="34" charset="-122"/>
+                <a:cs typeface="Calibri" pitchFamily="34" charset="-120"/>
+              </a:rPr>
+              <a:t>US$ 519,2 mil</a:t>
+            </a:r>
+            <a:endParaRPr lang="en-US" sz="1100" dirty="0"/>
+          </a:p>
+        </p:txBody>
+      </p:sp>
+      <p:sp>
+        <p:nvSpPr>
+          <p:cNvPr id="45" name="Shape 43"/>
+          <p:cNvSpPr/>
+          <p:nvPr/>
+        </p:nvSpPr>
+        <p:spPr>
+          <a:xfrm>
+            <a:off x="6355080" y="4498848"/>
+            <a:ext cx="5349240" cy="365760"/>
+          </a:xfrm>
+          <a:prstGeom prst="rect">
+            <a:avLst/>
+          </a:prstGeom>
+          <a:solidFill>
+            <a:srgbClr val="F0F4F5"/>
+          </a:solidFill>
+          <a:ln/>
+        </p:spPr>
+      </p:sp>
+      <p:sp>
+        <p:nvSpPr>
+          <p:cNvPr id="46" name="Text 44"/>
+          <p:cNvSpPr txBox="1"/>
+          <p:nvPr/>
+        </p:nvSpPr>
+        <p:spPr>
+          <a:xfrm>
+            <a:off x="6464808" y="4498848"/>
             <a:ext cx="3316529" cy="365760"/>
           </a:xfrm>
           <a:prstGeom prst="rect">
@@ -18874,13 +19050,13 @@
       </p:sp>
       <p:sp>
         <p:nvSpPr>
-          <p:cNvPr id="42" name="Text 40"/>
+          <p:cNvPr id="47" name="Text 45"/>
           <p:cNvSpPr txBox="1"/>
           <p:nvPr/>
         </p:nvSpPr>
         <p:spPr>
           <a:xfrm>
-            <a:off x="9671609" y="4133088"/>
+            <a:off x="9671609" y="4498848"/>
             <a:ext cx="1815998" cy="365760"/>
           </a:xfrm>
           <a:prstGeom prst="rect">
@@ -18913,7 +19089,7 @@
       </p:sp>
       <p:sp>
         <p:nvSpPr>
-          <p:cNvPr id="43" name="Text 41"/>
+          <p:cNvPr id="48" name="Text 46"/>
           <p:cNvSpPr txBox="1"/>
           <p:nvPr/>
         </p:nvSpPr>
@@ -19108,7 +19284,7 @@
                 <a:ea typeface="Cambria" pitchFamily="34" charset="-122"/>
                 <a:cs typeface="Cambria" pitchFamily="34" charset="-120"/>
               </a:rPr>
-              <a:t>US$ 110,5 mi</a:t>
+              <a:t>US$ 115,0 mi</a:t>
             </a:r>
             <a:endParaRPr lang="en-US" sz="2600" dirty="0"/>
           </a:p>
@@ -19247,7 +19423,7 @@
                 <a:ea typeface="Cambria" pitchFamily="34" charset="-122"/>
                 <a:cs typeface="Cambria" pitchFamily="34" charset="-120"/>
               </a:rPr>
-              <a:t>231</a:t>
+              <a:t>234</a:t>
             </a:r>
             <a:endParaRPr lang="en-US" sz="2600" dirty="0"/>
           </a:p>
@@ -20553,7 +20729,7 @@
                             <a:srgbClr val="1C2B33"/>
                           </a:solidFill>
                         </a:rPr>
-                        <a:t>US$ 14,0 mi</a:t>
+                        <a:t>US$ 19,1 mi</a:t>
                       </a:r>
                       <a:endParaRPr lang="en-US" sz="1050" dirty="0"/>
                     </a:p>
@@ -20614,7 +20790,7 @@
                             <a:srgbClr val="1C2B33"/>
                           </a:solidFill>
                         </a:rPr>
-                        <a:t>59</a:t>
+                        <a:t>70</a:t>
                       </a:r>
                       <a:endParaRPr lang="en-US" sz="1050" dirty="0"/>
                     </a:p>
@@ -20738,7 +20914,7 @@
                             <a:srgbClr val="1C2B33"/>
                           </a:solidFill>
                         </a:rPr>
-                        <a:t>US$ 4,3 mi</a:t>
+                        <a:t>US$ 3,6 mi</a:t>
                       </a:r>
                       <a:endParaRPr lang="en-US" sz="1050" dirty="0"/>
                     </a:p>
@@ -20799,7 +20975,7 @@
                             <a:srgbClr val="1C2B33"/>
                           </a:solidFill>
                         </a:rPr>
-                        <a:t>35</a:t>
+                        <a:t>27</a:t>
                       </a:r>
                       <a:endParaRPr lang="en-US" sz="1050" dirty="0"/>
                     </a:p>
@@ -21108,7 +21284,7 @@
                             <a:srgbClr val="0B2A3D"/>
                           </a:solidFill>
                         </a:rPr>
-                        <a:t>US$ 110,5 mi</a:t>
+                        <a:t>US$ 115,0 mi</a:t>
                       </a:r>
                       <a:endParaRPr lang="en-US" sz="1050" dirty="0"/>
                     </a:p>
@@ -21169,7 +21345,7 @@
                             <a:srgbClr val="0B2A3D"/>
                           </a:solidFill>
                         </a:rPr>
-                        <a:t>231</a:t>
+                        <a:t>234</a:t>
                       </a:r>
                       <a:endParaRPr lang="en-US" sz="1050" dirty="0"/>
                     </a:p>
@@ -21416,7 +21592,7 @@
                 <a:ea typeface="Calibri" pitchFamily="34" charset="-122"/>
                 <a:cs typeface="Calibri" pitchFamily="34" charset="-120"/>
               </a:rPr>
-              <a:t>Principais escopos por valor · 35 itens no total</a:t>
+              <a:t>Principais escopos por valor · 27 itens no total</a:t>
             </a:r>
             <a:endParaRPr lang="en-US" sz="1250" dirty="0"/>
           </a:p>
@@ -22290,7 +22466,7 @@
                           <a:ea typeface="Calibri" pitchFamily="34" charset="-122"/>
                           <a:cs typeface="Calibri" pitchFamily="34" charset="-120"/>
                         </a:rPr>
-                        <a:t>TA - Caldeiraria</a:t>
+                        <a:t>MPP - Adequação do sistema de Selagem Multifásica</a:t>
                       </a:r>
                       <a:endParaRPr lang="en-US" sz="1000" dirty="0">
                         <a:latin typeface="Calibri" charset="0"/>
@@ -22358,7 +22534,7 @@
                           <a:ea typeface="Calibri" pitchFamily="34" charset="-122"/>
                           <a:cs typeface="Calibri" pitchFamily="34" charset="-120"/>
                         </a:rPr>
-                        <a:t>Eficiência de Produção</a:t>
+                        <a:t>Rotina Operacional</a:t>
                       </a:r>
                       <a:endParaRPr lang="en-US" sz="950" dirty="0">
                         <a:latin typeface="Calibri" charset="0"/>
@@ -22426,7 +22602,7 @@
                           <a:ea typeface="Calibri" pitchFamily="34" charset="-122"/>
                           <a:cs typeface="Calibri" pitchFamily="34" charset="-120"/>
                         </a:rPr>
-                        <a:t>TA - Parada Programada</a:t>
+                        <a:t>EIM - Manutenção &amp; Integridade</a:t>
                       </a:r>
                       <a:endParaRPr lang="en-US" sz="950" dirty="0">
                         <a:latin typeface="Calibri" charset="0"/>
@@ -22494,7 +22670,7 @@
                           <a:ea typeface="Calibri" pitchFamily="34" charset="-122"/>
                           <a:cs typeface="Calibri" pitchFamily="34" charset="-120"/>
                         </a:rPr>
-                        <a:t>US$ 484,9 mil</a:t>
+                        <a:t>US$ 519,2 mil</a:t>
                       </a:r>
                       <a:endParaRPr lang="en-US" sz="1000" dirty="0">
                         <a:latin typeface="Calibri" charset="0"/>
@@ -23112,7 +23288,7 @@
                           <a:ea typeface="Calibri" pitchFamily="34" charset="-122"/>
                           <a:cs typeface="Calibri" pitchFamily="34" charset="-120"/>
                         </a:rPr>
-                        <a:t>TA - NR13</a:t>
+                        <a:t>Mobilização TA</a:t>
                       </a:r>
                       <a:endParaRPr lang="en-US" sz="1000" dirty="0">
                         <a:latin typeface="Calibri" charset="0"/>
@@ -23316,7 +23492,7 @@
                           <a:ea typeface="Calibri" pitchFamily="34" charset="-122"/>
                           <a:cs typeface="Calibri" pitchFamily="34" charset="-120"/>
                         </a:rPr>
-                        <a:t>US$ 173,2 mil</a:t>
+                        <a:t>US$ 162,1 mil</a:t>
                       </a:r>
                       <a:endParaRPr lang="en-US" sz="1000" dirty="0">
                         <a:latin typeface="Calibri" charset="0"/>
@@ -23386,7 +23562,7 @@
                           <a:ea typeface="Calibri" pitchFamily="34" charset="-122"/>
                           <a:cs typeface="Calibri" pitchFamily="34" charset="-120"/>
                         </a:rPr>
-                        <a:t>Troca da Estação Meteorológica</a:t>
+                        <a:t>Implantação do projeto 'Muster Digital'</a:t>
                       </a:r>
                       <a:endParaRPr lang="en-US" sz="1000" dirty="0">
                         <a:latin typeface="Calibri" charset="0"/>
@@ -23454,7 +23630,7 @@
                           <a:ea typeface="Calibri" pitchFamily="34" charset="-122"/>
                           <a:cs typeface="Calibri" pitchFamily="34" charset="-120"/>
                         </a:rPr>
-                        <a:t>Integridade e Regulatório</a:t>
+                        <a:t>Bem Estar/Segurança</a:t>
                       </a:r>
                       <a:endParaRPr lang="en-US" sz="950" dirty="0">
                         <a:latin typeface="Calibri" charset="0"/>
@@ -23522,7 +23698,7 @@
                           <a:ea typeface="Calibri" pitchFamily="34" charset="-122"/>
                           <a:cs typeface="Calibri" pitchFamily="34" charset="-120"/>
                         </a:rPr>
-                        <a:t>Projetos</a:t>
+                        <a:t>Saúde e Segurança Ocupacional</a:t>
                       </a:r>
                       <a:endParaRPr lang="en-US" sz="950" dirty="0">
                         <a:latin typeface="Calibri" charset="0"/>
@@ -23590,7 +23766,7 @@
                           <a:ea typeface="Calibri" pitchFamily="34" charset="-122"/>
                           <a:cs typeface="Calibri" pitchFamily="34" charset="-120"/>
                         </a:rPr>
-                        <a:t>US$ 169,1 mil</a:t>
+                        <a:t>US$ 150,0 mil</a:t>
                       </a:r>
                       <a:endParaRPr lang="en-US" sz="1000" dirty="0">
                         <a:latin typeface="Calibri" charset="0"/>
@@ -23660,7 +23836,7 @@
                           <a:ea typeface="Calibri" pitchFamily="34" charset="-122"/>
                           <a:cs typeface="Calibri" pitchFamily="34" charset="-120"/>
                         </a:rPr>
-                        <a:t>Desmobilização TA</a:t>
+                        <a:t>PÓS TA - NR13</a:t>
                       </a:r>
                       <a:endParaRPr lang="en-US" sz="1000" dirty="0">
                         <a:latin typeface="Calibri" charset="0"/>
@@ -23864,7 +24040,7 @@
                           <a:ea typeface="Calibri" pitchFamily="34" charset="-122"/>
                           <a:cs typeface="Calibri" pitchFamily="34" charset="-120"/>
                         </a:rPr>
-                        <a:t>US$ 162,1 mil</a:t>
+                        <a:t>US$ 135,6 mil</a:t>
                       </a:r>
                       <a:endParaRPr lang="en-US" sz="1000" dirty="0">
                         <a:latin typeface="Calibri" charset="0"/>
@@ -23934,7 +24110,7 @@
                           <a:ea typeface="Calibri" pitchFamily="34" charset="-122"/>
                           <a:cs typeface="Calibri" pitchFamily="34" charset="-120"/>
                         </a:rPr>
-                        <a:t>Mobilização TA</a:t>
+                        <a:t>PRÉ TA - Caldeiraria</a:t>
                       </a:r>
                       <a:endParaRPr lang="en-US" sz="1000" dirty="0">
                         <a:latin typeface="Calibri" charset="0"/>
@@ -24138,7 +24314,7 @@
                           <a:ea typeface="Calibri" pitchFamily="34" charset="-122"/>
                           <a:cs typeface="Calibri" pitchFamily="34" charset="-120"/>
                         </a:rPr>
-                        <a:t>US$ 162,1 mil</a:t>
+                        <a:t>US$ 132,9 mil</a:t>
                       </a:r>
                       <a:endParaRPr lang="en-US" sz="1000" dirty="0">
                         <a:latin typeface="Calibri" charset="0"/>
@@ -24208,7 +24384,7 @@
                           <a:ea typeface="Calibri" pitchFamily="34" charset="-122"/>
                           <a:cs typeface="Calibri" pitchFamily="34" charset="-120"/>
                         </a:rPr>
-                        <a:t>Implantação do projeto 'Muster Digital'</a:t>
+                        <a:t>ESTUDO DE ENGENHARIA</a:t>
                       </a:r>
                       <a:endParaRPr lang="en-US" sz="1000" dirty="0">
                         <a:latin typeface="Calibri" charset="0"/>
@@ -24276,7 +24452,7 @@
                           <a:ea typeface="Calibri" pitchFamily="34" charset="-122"/>
                           <a:cs typeface="Calibri" pitchFamily="34" charset="-120"/>
                         </a:rPr>
-                        <a:t>Bem Estar/Segurança</a:t>
+                        <a:t>Eficiência de Produção</a:t>
                       </a:r>
                       <a:endParaRPr lang="en-US" sz="950" dirty="0">
                         <a:latin typeface="Calibri" charset="0"/>
@@ -24344,7 +24520,7 @@
                           <a:ea typeface="Calibri" pitchFamily="34" charset="-122"/>
                           <a:cs typeface="Calibri" pitchFamily="34" charset="-120"/>
                         </a:rPr>
-                        <a:t>Saúde e Segurança Ocupacional</a:t>
+                        <a:t>Projetos</a:t>
                       </a:r>
                       <a:endParaRPr lang="en-US" sz="950" dirty="0">
                         <a:latin typeface="Calibri" charset="0"/>
@@ -24412,7 +24588,7 @@
                           <a:ea typeface="Calibri" pitchFamily="34" charset="-122"/>
                           <a:cs typeface="Calibri" pitchFamily="34" charset="-120"/>
                         </a:rPr>
-                        <a:t>US$ 150,0 mil</a:t>
+                        <a:t>US$ 120,0 mil</a:t>
                       </a:r>
                       <a:endParaRPr lang="en-US" sz="1000" dirty="0">
                         <a:latin typeface="Calibri" charset="0"/>
@@ -24482,7 +24658,7 @@
                           <a:ea typeface="Calibri" pitchFamily="34" charset="-122"/>
                           <a:cs typeface="Calibri" pitchFamily="34" charset="-120"/>
                         </a:rPr>
-                        <a:t>PÓS TA - NR13</a:t>
+                        <a:t>PRÉ TA - NR13</a:t>
                       </a:r>
                       <a:endParaRPr lang="en-US" sz="1000" dirty="0">
                         <a:latin typeface="Calibri" charset="0"/>
@@ -24686,7 +24862,7 @@
                           <a:ea typeface="Calibri" pitchFamily="34" charset="-122"/>
                           <a:cs typeface="Calibri" pitchFamily="34" charset="-120"/>
                         </a:rPr>
-                        <a:t>US$ 135,6 mil</a:t>
+                        <a:t>US$ 65,1 mil</a:t>
                       </a:r>
                       <a:endParaRPr lang="en-US" sz="1000" dirty="0">
                         <a:latin typeface="Calibri" charset="0"/>
@@ -24756,7 +24932,7 @@
                           <a:ea typeface="Calibri" pitchFamily="34" charset="-122"/>
                           <a:cs typeface="Calibri" pitchFamily="34" charset="-120"/>
                         </a:rPr>
-                        <a:t>PRÉ TA - Caldeiraria</a:t>
+                        <a:t>Obstrução Sistema de Águas Cinzas</a:t>
                       </a:r>
                       <a:endParaRPr lang="en-US" sz="1000" dirty="0">
                         <a:latin typeface="Calibri" charset="0"/>
@@ -24824,7 +25000,7 @@
                           <a:ea typeface="Calibri" pitchFamily="34" charset="-122"/>
                           <a:cs typeface="Calibri" pitchFamily="34" charset="-120"/>
                         </a:rPr>
-                        <a:t>Eficiência de Produção</a:t>
+                        <a:t>Integridade e Regulatório</a:t>
                       </a:r>
                       <a:endParaRPr lang="en-US" sz="950" dirty="0">
                         <a:latin typeface="Calibri" charset="0"/>
@@ -24892,7 +25068,7 @@
                           <a:ea typeface="Calibri" pitchFamily="34" charset="-122"/>
                           <a:cs typeface="Calibri" pitchFamily="34" charset="-120"/>
                         </a:rPr>
-                        <a:t>TA - Parada Programada</a:t>
+                        <a:t>Projetos</a:t>
                       </a:r>
                       <a:endParaRPr lang="en-US" sz="950" dirty="0">
                         <a:latin typeface="Calibri" charset="0"/>
@@ -24960,7 +25136,7 @@
                           <a:ea typeface="Calibri" pitchFamily="34" charset="-122"/>
                           <a:cs typeface="Calibri" pitchFamily="34" charset="-120"/>
                         </a:rPr>
-                        <a:t>US$ 132,9 mil</a:t>
+                        <a:t>US$ 50,9 mil</a:t>
                       </a:r>
                       <a:endParaRPr lang="en-US" sz="1000" dirty="0">
                         <a:latin typeface="Calibri" charset="0"/>
@@ -25030,7 +25206,7 @@
                           <a:ea typeface="Calibri" pitchFamily="34" charset="-122"/>
                           <a:cs typeface="Calibri" pitchFamily="34" charset="-120"/>
                         </a:rPr>
-                        <a:t>Outros 23 escopos (itens de menor valor individual)</a:t>
+                        <a:t>Outros 15 escopos (itens de menor valor individual)</a:t>
                       </a:r>
                       <a:endParaRPr lang="en-US" sz="950" dirty="0">
                         <a:latin typeface="Calibri" charset="0"/>
@@ -25104,7 +25280,7 @@
                           <a:ea typeface="Calibri" pitchFamily="34" charset="-122"/>
                           <a:cs typeface="Calibri" pitchFamily="34" charset="-120"/>
                         </a:rPr>
-                        <a:t>US$ 640,4 mil</a:t>
+                        <a:t>US$ 228,0 mil</a:t>
                       </a:r>
                       <a:endParaRPr lang="en-US" sz="1000" dirty="0">
                         <a:latin typeface="Calibri" charset="0"/>

</xml_diff>

<commit_message>
Update FPSO Bravo and Polvo A from latest Cluster Sul spreadsheet
Recalcula Composição de Custo, Escopos do CAPEX e a Visão Executiva
de FPSO Bravo e Polvo A a partir da nova revisão da planilha
'CLUSTER SUL'.

- FPSO Bravo: CAPEX Total US$ 19,1 mi -> US$ 18,8 mi
- Polvo A: CAPEX Total US$ 3,6 mi -> US$ 5,1 mi

Ambos batem com a aba Overview do arquivo (cluster: US$ 23,9 mi).
Atualiza o deck completo (novo total US$ 116,2 mi) e o arquivo
isolado do Cluster Sul.

Co-Authored-By: Claude Sonnet 5 <noreply@anthropic.com>
Claude-Session: https://claude.ai/code/session_01QXLKdFvqaqrRbUKxEFJW9L
</commit_message>
<xml_diff>
--- a/PRIO_Plano_Trabalho_CAPEX_2027.pptx
+++ b/PRIO_Plano_Trabalho_CAPEX_2027.pptx
@@ -314,10 +314,10 @@
                   <c:v>2.55</c:v>
                 </c:pt>
                 <c:pt idx="4">
-                  <c:v>19.05</c:v>
+                  <c:v>18.82</c:v>
                 </c:pt>
                 <c:pt idx="5">
-                  <c:v>3.64</c:v>
+                  <c:v>5.12</c:v>
                 </c:pt>
                 <c:pt idx="6">
                   <c:v>66.26</c:v>
@@ -11672,7 +11672,7 @@
                 <a:ea typeface="Cambria" pitchFamily="34" charset="-122"/>
                 <a:cs typeface="Cambria" pitchFamily="34" charset="-120"/>
               </a:rPr>
-              <a:t>US$ 19,1 mi</a:t>
+              <a:t>US$ 18,8 mi</a:t>
             </a:r>
             <a:endParaRPr lang="en-US" sz="3300" dirty="0"/>
           </a:p>
@@ -11811,7 +11811,7 @@
                 <a:ea typeface="Cambria" pitchFamily="34" charset="-122"/>
                 <a:cs typeface="Cambria" pitchFamily="34" charset="-120"/>
               </a:rPr>
-              <a:t>US$ 14,0 mi</a:t>
+              <a:t>US$ 13,8 mi</a:t>
             </a:r>
             <a:endParaRPr lang="en-US" sz="1800" dirty="0"/>
           </a:p>
@@ -12011,7 +12011,7 @@
                 <a:ea typeface="Cambria" pitchFamily="34" charset="-122"/>
                 <a:cs typeface="Cambria" pitchFamily="34" charset="-120"/>
               </a:rPr>
-              <a:t>US$ 6,0 mi</a:t>
+              <a:t>US$ 5,8 mi</a:t>
             </a:r>
             <a:endParaRPr lang="en-US" sz="1800" dirty="0"/>
           </a:p>
@@ -12111,7 +12111,7 @@
                 <a:ea typeface="Cambria" pitchFamily="34" charset="-122"/>
                 <a:cs typeface="Cambria" pitchFamily="34" charset="-120"/>
               </a:rPr>
-              <a:t>US$ 13,1 mi</a:t>
+              <a:t>US$ 13,0 mi</a:t>
             </a:r>
             <a:endParaRPr lang="en-US" sz="1800" dirty="0"/>
           </a:p>
@@ -12525,84 +12525,6 @@
                 <a:ea typeface="Calibri" pitchFamily="34" charset="-122"/>
                 <a:cs typeface="Calibri" pitchFamily="34" charset="-120"/>
               </a:rPr>
-              <a:t>Projetos</a:t>
-            </a:r>
-            <a:endParaRPr lang="en-US" sz="1100" dirty="0"/>
-          </a:p>
-        </p:txBody>
-      </p:sp>
-      <p:sp>
-        <p:nvSpPr>
-          <p:cNvPr id="33" name="Text 31"/>
-          <p:cNvSpPr txBox="1"/>
-          <p:nvPr/>
-        </p:nvSpPr>
-        <p:spPr>
-          <a:xfrm>
-            <a:off x="3773729" y="4498848"/>
-            <a:ext cx="1815998" cy="365760"/>
-          </a:xfrm>
-          <a:prstGeom prst="rect">
-            <a:avLst/>
-          </a:prstGeom>
-          <a:noFill/>
-          <a:ln/>
-        </p:spPr>
-        <p:txBody>
-          <a:bodyPr wrap="square" lIns="0" tIns="0" rIns="0" bIns="0" rtlCol="0" anchor="ctr"/>
-          <a:lstStyle/>
-          <a:p>
-            <a:pPr algn="r" indent="0" marL="0">
-              <a:buNone/>
-            </a:pPr>
-            <a:r>
-              <a:rPr lang="en-US" sz="1100" b="1" dirty="0">
-                <a:solidFill>
-                  <a:srgbClr val="0B2A3D"/>
-                </a:solidFill>
-                <a:latin typeface="Calibri" pitchFamily="34" charset="0"/>
-                <a:ea typeface="Calibri" pitchFamily="34" charset="-122"/>
-                <a:cs typeface="Calibri" pitchFamily="34" charset="-120"/>
-              </a:rPr>
-              <a:t>US$ 1,2 mi</a:t>
-            </a:r>
-            <a:endParaRPr lang="en-US" sz="1100" dirty="0"/>
-          </a:p>
-        </p:txBody>
-      </p:sp>
-      <p:sp>
-        <p:nvSpPr>
-          <p:cNvPr id="34" name="Text 32"/>
-          <p:cNvSpPr txBox="1"/>
-          <p:nvPr/>
-        </p:nvSpPr>
-        <p:spPr>
-          <a:xfrm>
-            <a:off x="566928" y="4864608"/>
-            <a:ext cx="3316529" cy="365760"/>
-          </a:xfrm>
-          <a:prstGeom prst="rect">
-            <a:avLst/>
-          </a:prstGeom>
-          <a:noFill/>
-          <a:ln/>
-        </p:spPr>
-        <p:txBody>
-          <a:bodyPr wrap="square" lIns="0" tIns="0" rIns="0" bIns="0" rtlCol="0" anchor="ctr"/>
-          <a:lstStyle/>
-          <a:p>
-            <a:pPr indent="0" marL="0">
-              <a:buNone/>
-            </a:pPr>
-            <a:r>
-              <a:rPr lang="en-US" sz="1100" dirty="0">
-                <a:solidFill>
-                  <a:srgbClr val="1C2B33"/>
-                </a:solidFill>
-                <a:latin typeface="Calibri" pitchFamily="34" charset="0"/>
-                <a:ea typeface="Calibri" pitchFamily="34" charset="-122"/>
-                <a:cs typeface="Calibri" pitchFamily="34" charset="-120"/>
-              </a:rPr>
               <a:t>Saúde e Segurança Ocupacional</a:t>
             </a:r>
             <a:endParaRPr lang="en-US" sz="1100" dirty="0"/>
@@ -12611,13 +12533,13 @@
       </p:sp>
       <p:sp>
         <p:nvSpPr>
-          <p:cNvPr id="35" name="Text 33"/>
+          <p:cNvPr id="33" name="Text 31"/>
           <p:cNvSpPr txBox="1"/>
           <p:nvPr/>
         </p:nvSpPr>
         <p:spPr>
           <a:xfrm>
-            <a:off x="3773729" y="4864608"/>
+            <a:off x="3773729" y="4498848"/>
             <a:ext cx="1815998" cy="365760"/>
           </a:xfrm>
           <a:prstGeom prst="rect">
@@ -12650,33 +12572,13 @@
       </p:sp>
       <p:sp>
         <p:nvSpPr>
-          <p:cNvPr id="36" name="Shape 34"/>
-          <p:cNvSpPr/>
+          <p:cNvPr id="34" name="Text 32"/>
+          <p:cNvSpPr txBox="1"/>
           <p:nvPr/>
         </p:nvSpPr>
         <p:spPr>
           <a:xfrm>
-            <a:off x="457200" y="5230368"/>
-            <a:ext cx="5349240" cy="365760"/>
-          </a:xfrm>
-          <a:prstGeom prst="rect">
-            <a:avLst/>
-          </a:prstGeom>
-          <a:solidFill>
-            <a:srgbClr val="F0F4F5"/>
-          </a:solidFill>
-          <a:ln/>
-        </p:spPr>
-      </p:sp>
-      <p:sp>
-        <p:nvSpPr>
-          <p:cNvPr id="37" name="Text 35"/>
-          <p:cNvSpPr txBox="1"/>
-          <p:nvPr/>
-        </p:nvSpPr>
-        <p:spPr>
-          <a:xfrm>
-            <a:off x="566928" y="5230368"/>
+            <a:off x="566928" y="4864608"/>
             <a:ext cx="3316529" cy="365760"/>
           </a:xfrm>
           <a:prstGeom prst="rect">
@@ -12709,6 +12611,104 @@
       </p:sp>
       <p:sp>
         <p:nvSpPr>
+          <p:cNvPr id="35" name="Text 33"/>
+          <p:cNvSpPr txBox="1"/>
+          <p:nvPr/>
+        </p:nvSpPr>
+        <p:spPr>
+          <a:xfrm>
+            <a:off x="3773729" y="4864608"/>
+            <a:ext cx="1815998" cy="365760"/>
+          </a:xfrm>
+          <a:prstGeom prst="rect">
+            <a:avLst/>
+          </a:prstGeom>
+          <a:noFill/>
+          <a:ln/>
+        </p:spPr>
+        <p:txBody>
+          <a:bodyPr wrap="square" lIns="0" tIns="0" rIns="0" bIns="0" rtlCol="0" anchor="ctr"/>
+          <a:lstStyle/>
+          <a:p>
+            <a:pPr algn="r" indent="0" marL="0">
+              <a:buNone/>
+            </a:pPr>
+            <a:r>
+              <a:rPr lang="en-US" sz="1100" b="1" dirty="0">
+                <a:solidFill>
+                  <a:srgbClr val="0B2A3D"/>
+                </a:solidFill>
+                <a:latin typeface="Calibri" pitchFamily="34" charset="0"/>
+                <a:ea typeface="Calibri" pitchFamily="34" charset="-122"/>
+                <a:cs typeface="Calibri" pitchFamily="34" charset="-120"/>
+              </a:rPr>
+              <a:t>US$ 955,5 mil</a:t>
+            </a:r>
+            <a:endParaRPr lang="en-US" sz="1100" dirty="0"/>
+          </a:p>
+        </p:txBody>
+      </p:sp>
+      <p:sp>
+        <p:nvSpPr>
+          <p:cNvPr id="36" name="Shape 34"/>
+          <p:cNvSpPr/>
+          <p:nvPr/>
+        </p:nvSpPr>
+        <p:spPr>
+          <a:xfrm>
+            <a:off x="457200" y="5230368"/>
+            <a:ext cx="5349240" cy="365760"/>
+          </a:xfrm>
+          <a:prstGeom prst="rect">
+            <a:avLst/>
+          </a:prstGeom>
+          <a:solidFill>
+            <a:srgbClr val="F0F4F5"/>
+          </a:solidFill>
+          <a:ln/>
+        </p:spPr>
+      </p:sp>
+      <p:sp>
+        <p:nvSpPr>
+          <p:cNvPr id="37" name="Text 35"/>
+          <p:cNvSpPr txBox="1"/>
+          <p:nvPr/>
+        </p:nvSpPr>
+        <p:spPr>
+          <a:xfrm>
+            <a:off x="566928" y="5230368"/>
+            <a:ext cx="3316529" cy="365760"/>
+          </a:xfrm>
+          <a:prstGeom prst="rect">
+            <a:avLst/>
+          </a:prstGeom>
+          <a:noFill/>
+          <a:ln/>
+        </p:spPr>
+        <p:txBody>
+          <a:bodyPr wrap="square" lIns="0" tIns="0" rIns="0" bIns="0" rtlCol="0" anchor="ctr"/>
+          <a:lstStyle/>
+          <a:p>
+            <a:pPr indent="0" marL="0">
+              <a:buNone/>
+            </a:pPr>
+            <a:r>
+              <a:rPr lang="en-US" sz="1100" dirty="0">
+                <a:solidFill>
+                  <a:srgbClr val="1C2B33"/>
+                </a:solidFill>
+                <a:latin typeface="Calibri" pitchFamily="34" charset="0"/>
+                <a:ea typeface="Calibri" pitchFamily="34" charset="-122"/>
+                <a:cs typeface="Calibri" pitchFamily="34" charset="-120"/>
+              </a:rPr>
+              <a:t>Projetos</a:t>
+            </a:r>
+            <a:endParaRPr lang="en-US" sz="1100" dirty="0"/>
+          </a:p>
+        </p:txBody>
+      </p:sp>
+      <p:sp>
+        <p:nvSpPr>
           <p:cNvPr id="38" name="Text 36"/>
           <p:cNvSpPr txBox="1"/>
           <p:nvPr/>
@@ -12740,7 +12740,7 @@
                 <a:ea typeface="Calibri" pitchFamily="34" charset="-122"/>
                 <a:cs typeface="Calibri" pitchFamily="34" charset="-120"/>
               </a:rPr>
-              <a:t>US$ 955,5 mil</a:t>
+              <a:t>US$ 926,4 mil</a:t>
             </a:r>
             <a:endParaRPr lang="en-US" sz="1100" dirty="0"/>
           </a:p>
@@ -13056,7 +13056,7 @@
                 <a:ea typeface="Calibri" pitchFamily="34" charset="-122"/>
                 <a:cs typeface="Calibri" pitchFamily="34" charset="-120"/>
               </a:rPr>
-              <a:t>US$ 6,1 mi</a:t>
+              <a:t>US$ 5,9 mi</a:t>
             </a:r>
             <a:endParaRPr lang="en-US" sz="1100" dirty="0"/>
           </a:p>
@@ -13433,7 +13433,7 @@
                 <a:ea typeface="Calibri" pitchFamily="34" charset="-122"/>
                 <a:cs typeface="Calibri" pitchFamily="34" charset="-120"/>
               </a:rPr>
-              <a:t>Principais escopos por valor · 70 itens no total</a:t>
+              <a:t>Principais escopos por valor · 69 itens no total</a:t>
             </a:r>
             <a:endParaRPr lang="en-US" sz="1250" dirty="0"/>
           </a:p>
@@ -17047,7 +17047,7 @@
                           <a:ea typeface="Calibri" pitchFamily="34" charset="-122"/>
                           <a:cs typeface="Calibri" pitchFamily="34" charset="-120"/>
                         </a:rPr>
-                        <a:t>Outros 58 escopos (itens de menor valor individual)</a:t>
+                        <a:t>Outros 57 escopos (itens de menor valor individual)</a:t>
                       </a:r>
                       <a:endParaRPr lang="en-US" sz="950" dirty="0">
                         <a:latin typeface="Calibri" charset="0"/>
@@ -17121,7 +17121,7 @@
                           <a:ea typeface="Calibri" pitchFamily="34" charset="-122"/>
                           <a:cs typeface="Calibri" pitchFamily="34" charset="-120"/>
                         </a:rPr>
-                        <a:t>US$ 4,3 mi</a:t>
+                        <a:t>US$ 4,1 mi</a:t>
                       </a:r>
                       <a:endParaRPr lang="en-US" sz="1000" dirty="0">
                         <a:latin typeface="Calibri" charset="0"/>
@@ -17697,7 +17697,7 @@
                 <a:ea typeface="Cambria" pitchFamily="34" charset="-122"/>
                 <a:cs typeface="Cambria" pitchFamily="34" charset="-120"/>
               </a:rPr>
-              <a:t>US$ 3,6 mi</a:t>
+              <a:t>US$ 5,1 mi</a:t>
             </a:r>
             <a:endParaRPr lang="en-US" sz="3300" dirty="0"/>
           </a:p>
@@ -17836,7 +17836,7 @@
                 <a:ea typeface="Cambria" pitchFamily="34" charset="-122"/>
                 <a:cs typeface="Cambria" pitchFamily="34" charset="-120"/>
               </a:rPr>
-              <a:t>US$ 3,0 mi</a:t>
+              <a:t>US$ 3,5 mi</a:t>
             </a:r>
             <a:endParaRPr lang="en-US" sz="1800" dirty="0"/>
           </a:p>
@@ -17936,7 +17936,7 @@
                 <a:ea typeface="Cambria" pitchFamily="34" charset="-122"/>
                 <a:cs typeface="Cambria" pitchFamily="34" charset="-120"/>
               </a:rPr>
-              <a:t>US$ 592,3 mil</a:t>
+              <a:t>US$ 1,6 mi</a:t>
             </a:r>
             <a:endParaRPr lang="en-US" sz="1800" dirty="0"/>
           </a:p>
@@ -18036,7 +18036,7 @@
                 <a:ea typeface="Cambria" pitchFamily="34" charset="-122"/>
                 <a:cs typeface="Cambria" pitchFamily="34" charset="-120"/>
               </a:rPr>
-              <a:t>US$ 2,5 mi</a:t>
+              <a:t>US$ 3,1 mi</a:t>
             </a:r>
             <a:endParaRPr lang="en-US" sz="1800" dirty="0"/>
           </a:p>
@@ -18136,7 +18136,7 @@
                 <a:ea typeface="Cambria" pitchFamily="34" charset="-122"/>
                 <a:cs typeface="Cambria" pitchFamily="34" charset="-120"/>
               </a:rPr>
-              <a:t>US$ 1,1 mi</a:t>
+              <a:t>US$ 2,0 mi</a:t>
             </a:r>
             <a:endParaRPr lang="en-US" sz="1800" dirty="0"/>
           </a:p>
@@ -18315,7 +18315,7 @@
                 <a:ea typeface="Calibri" pitchFamily="34" charset="-122"/>
                 <a:cs typeface="Calibri" pitchFamily="34" charset="-120"/>
               </a:rPr>
-              <a:t>US$ 2,2 mi</a:t>
+              <a:t>US$ 2,4 mi</a:t>
             </a:r>
             <a:endParaRPr lang="en-US" sz="1100" dirty="0"/>
           </a:p>
@@ -18413,7 +18413,7 @@
                 <a:ea typeface="Calibri" pitchFamily="34" charset="-122"/>
                 <a:cs typeface="Calibri" pitchFamily="34" charset="-120"/>
               </a:rPr>
-              <a:t>US$ 592,3 mil</a:t>
+              <a:t>US$ 1,6 mi</a:t>
             </a:r>
             <a:endParaRPr lang="en-US" sz="1100" dirty="0"/>
           </a:p>
@@ -18491,7 +18491,7 @@
                 <a:ea typeface="Calibri" pitchFamily="34" charset="-122"/>
                 <a:cs typeface="Calibri" pitchFamily="34" charset="-120"/>
               </a:rPr>
-              <a:t>US$ 519,2 mil</a:t>
+              <a:t>US$ 634,0 mil</a:t>
             </a:r>
             <a:endParaRPr lang="en-US" sz="1100" dirty="0"/>
           </a:p>
@@ -18526,6 +18526,84 @@
         <p:spPr>
           <a:xfrm>
             <a:off x="566928" y="4498848"/>
+            <a:ext cx="3316529" cy="365760"/>
+          </a:xfrm>
+          <a:prstGeom prst="rect">
+            <a:avLst/>
+          </a:prstGeom>
+          <a:noFill/>
+          <a:ln/>
+        </p:spPr>
+        <p:txBody>
+          <a:bodyPr wrap="square" lIns="0" tIns="0" rIns="0" bIns="0" rtlCol="0" anchor="ctr"/>
+          <a:lstStyle/>
+          <a:p>
+            <a:pPr indent="0" marL="0">
+              <a:buNone/>
+            </a:pPr>
+            <a:r>
+              <a:rPr lang="en-US" sz="1100" dirty="0">
+                <a:solidFill>
+                  <a:srgbClr val="1C2B33"/>
+                </a:solidFill>
+                <a:latin typeface="Calibri" pitchFamily="34" charset="0"/>
+                <a:ea typeface="Calibri" pitchFamily="34" charset="-122"/>
+                <a:cs typeface="Calibri" pitchFamily="34" charset="-120"/>
+              </a:rPr>
+              <a:t>P&amp;Q - Processos</a:t>
+            </a:r>
+            <a:endParaRPr lang="en-US" sz="1100" dirty="0"/>
+          </a:p>
+        </p:txBody>
+      </p:sp>
+      <p:sp>
+        <p:nvSpPr>
+          <p:cNvPr id="33" name="Text 31"/>
+          <p:cNvSpPr txBox="1"/>
+          <p:nvPr/>
+        </p:nvSpPr>
+        <p:spPr>
+          <a:xfrm>
+            <a:off x="3773729" y="4498848"/>
+            <a:ext cx="1815998" cy="365760"/>
+          </a:xfrm>
+          <a:prstGeom prst="rect">
+            <a:avLst/>
+          </a:prstGeom>
+          <a:noFill/>
+          <a:ln/>
+        </p:spPr>
+        <p:txBody>
+          <a:bodyPr wrap="square" lIns="0" tIns="0" rIns="0" bIns="0" rtlCol="0" anchor="ctr"/>
+          <a:lstStyle/>
+          <a:p>
+            <a:pPr algn="r" indent="0" marL="0">
+              <a:buNone/>
+            </a:pPr>
+            <a:r>
+              <a:rPr lang="en-US" sz="1100" b="1" dirty="0">
+                <a:solidFill>
+                  <a:srgbClr val="0B2A3D"/>
+                </a:solidFill>
+                <a:latin typeface="Calibri" pitchFamily="34" charset="0"/>
+                <a:ea typeface="Calibri" pitchFamily="34" charset="-122"/>
+                <a:cs typeface="Calibri" pitchFamily="34" charset="-120"/>
+              </a:rPr>
+              <a:t>US$ 206,8 mil</a:t>
+            </a:r>
+            <a:endParaRPr lang="en-US" sz="1100" dirty="0"/>
+          </a:p>
+        </p:txBody>
+      </p:sp>
+      <p:sp>
+        <p:nvSpPr>
+          <p:cNvPr id="34" name="Text 32"/>
+          <p:cNvSpPr txBox="1"/>
+          <p:nvPr/>
+        </p:nvSpPr>
+        <p:spPr>
+          <a:xfrm>
+            <a:off x="566928" y="4864608"/>
             <a:ext cx="3316529" cy="365760"/>
           </a:xfrm>
           <a:prstGeom prst="rect">
@@ -18558,13 +18636,13 @@
       </p:sp>
       <p:sp>
         <p:nvSpPr>
-          <p:cNvPr id="33" name="Text 31"/>
+          <p:cNvPr id="35" name="Text 33"/>
           <p:cNvSpPr txBox="1"/>
           <p:nvPr/>
         </p:nvSpPr>
         <p:spPr>
           <a:xfrm>
-            <a:off x="3773729" y="4498848"/>
+            <a:off x="3773729" y="4864608"/>
             <a:ext cx="1815998" cy="365760"/>
           </a:xfrm>
           <a:prstGeom prst="rect">
@@ -18597,13 +18675,33 @@
       </p:sp>
       <p:sp>
         <p:nvSpPr>
-          <p:cNvPr id="34" name="Text 32"/>
+          <p:cNvPr id="36" name="Shape 34"/>
+          <p:cNvSpPr/>
+          <p:nvPr/>
+        </p:nvSpPr>
+        <p:spPr>
+          <a:xfrm>
+            <a:off x="457200" y="5230368"/>
+            <a:ext cx="5349240" cy="365760"/>
+          </a:xfrm>
+          <a:prstGeom prst="rect">
+            <a:avLst/>
+          </a:prstGeom>
+          <a:solidFill>
+            <a:srgbClr val="F0F4F5"/>
+          </a:solidFill>
+          <a:ln/>
+        </p:spPr>
+      </p:sp>
+      <p:sp>
+        <p:nvSpPr>
+          <p:cNvPr id="37" name="Text 35"/>
           <p:cNvSpPr txBox="1"/>
           <p:nvPr/>
         </p:nvSpPr>
         <p:spPr>
           <a:xfrm>
-            <a:off x="566928" y="4864608"/>
+            <a:off x="566928" y="5230368"/>
             <a:ext cx="3316529" cy="365760"/>
           </a:xfrm>
           <a:prstGeom prst="rect">
@@ -18636,13 +18734,13 @@
       </p:sp>
       <p:sp>
         <p:nvSpPr>
-          <p:cNvPr id="35" name="Text 33"/>
+          <p:cNvPr id="38" name="Text 36"/>
           <p:cNvSpPr txBox="1"/>
           <p:nvPr/>
         </p:nvSpPr>
         <p:spPr>
           <a:xfrm>
-            <a:off x="3773729" y="4864608"/>
+            <a:off x="3773729" y="5230368"/>
             <a:ext cx="1815998" cy="365760"/>
           </a:xfrm>
           <a:prstGeom prst="rect">
@@ -18675,7 +18773,7 @@
       </p:sp>
       <p:sp>
         <p:nvSpPr>
-          <p:cNvPr id="36" name="Text 34"/>
+          <p:cNvPr id="39" name="Text 37"/>
           <p:cNvSpPr txBox="1"/>
           <p:nvPr/>
         </p:nvSpPr>
@@ -18714,7 +18812,7 @@
       </p:sp>
       <p:sp>
         <p:nvSpPr>
-          <p:cNvPr id="37" name="Shape 35"/>
+          <p:cNvPr id="40" name="Shape 38"/>
           <p:cNvSpPr/>
           <p:nvPr/>
         </p:nvSpPr>
@@ -18737,7 +18835,7 @@
       </p:sp>
       <p:sp>
         <p:nvSpPr>
-          <p:cNvPr id="38" name="Text 36"/>
+          <p:cNvPr id="41" name="Text 39"/>
           <p:cNvSpPr txBox="1"/>
           <p:nvPr/>
         </p:nvSpPr>
@@ -18776,7 +18874,7 @@
       </p:sp>
       <p:sp>
         <p:nvSpPr>
-          <p:cNvPr id="39" name="Text 37"/>
+          <p:cNvPr id="42" name="Text 40"/>
           <p:cNvSpPr txBox="1"/>
           <p:nvPr/>
         </p:nvSpPr>
@@ -18807,7 +18905,7 @@
                 <a:ea typeface="Calibri" pitchFamily="34" charset="-122"/>
                 <a:cs typeface="Calibri" pitchFamily="34" charset="-120"/>
               </a:rPr>
-              <a:t>US$ 1,5 mi</a:t>
+              <a:t>US$ 2,5 mi</a:t>
             </a:r>
             <a:endParaRPr lang="en-US" sz="1100" dirty="0"/>
           </a:p>
@@ -18815,7 +18913,7 @@
       </p:sp>
       <p:sp>
         <p:nvSpPr>
-          <p:cNvPr id="40" name="Shape 38"/>
+          <p:cNvPr id="43" name="Shape 41"/>
           <p:cNvSpPr/>
           <p:nvPr/>
         </p:nvSpPr>
@@ -18835,7 +18933,7 @@
       </p:sp>
       <p:sp>
         <p:nvSpPr>
-          <p:cNvPr id="41" name="Text 39"/>
+          <p:cNvPr id="44" name="Text 42"/>
           <p:cNvSpPr txBox="1"/>
           <p:nvPr/>
         </p:nvSpPr>
@@ -18874,7 +18972,7 @@
       </p:sp>
       <p:sp>
         <p:nvSpPr>
-          <p:cNvPr id="42" name="Text 40"/>
+          <p:cNvPr id="45" name="Text 43"/>
           <p:cNvSpPr txBox="1"/>
           <p:nvPr/>
         </p:nvSpPr>
@@ -18905,7 +19003,7 @@
                 <a:ea typeface="Calibri" pitchFamily="34" charset="-122"/>
                 <a:cs typeface="Calibri" pitchFamily="34" charset="-120"/>
               </a:rPr>
-              <a:t>US$ 1,4 mi</a:t>
+              <a:t>US$ 1,8 mi</a:t>
             </a:r>
             <a:endParaRPr lang="en-US" sz="1100" dirty="0"/>
           </a:p>
@@ -18913,7 +19011,7 @@
       </p:sp>
       <p:sp>
         <p:nvSpPr>
-          <p:cNvPr id="43" name="Text 41"/>
+          <p:cNvPr id="46" name="Text 44"/>
           <p:cNvSpPr txBox="1"/>
           <p:nvPr/>
         </p:nvSpPr>
@@ -18952,7 +19050,7 @@
       </p:sp>
       <p:sp>
         <p:nvSpPr>
-          <p:cNvPr id="44" name="Text 42"/>
+          <p:cNvPr id="47" name="Text 45"/>
           <p:cNvSpPr txBox="1"/>
           <p:nvPr/>
         </p:nvSpPr>
@@ -18983,7 +19081,7 @@
                 <a:ea typeface="Calibri" pitchFamily="34" charset="-122"/>
                 <a:cs typeface="Calibri" pitchFamily="34" charset="-120"/>
               </a:rPr>
-              <a:t>US$ 519,2 mil</a:t>
+              <a:t>US$ 634,0 mil</a:t>
             </a:r>
             <a:endParaRPr lang="en-US" sz="1100" dirty="0"/>
           </a:p>
@@ -18991,7 +19089,7 @@
       </p:sp>
       <p:sp>
         <p:nvSpPr>
-          <p:cNvPr id="45" name="Shape 43"/>
+          <p:cNvPr id="48" name="Shape 46"/>
           <p:cNvSpPr/>
           <p:nvPr/>
         </p:nvSpPr>
@@ -19011,7 +19109,7 @@
       </p:sp>
       <p:sp>
         <p:nvSpPr>
-          <p:cNvPr id="46" name="Text 44"/>
+          <p:cNvPr id="49" name="Text 47"/>
           <p:cNvSpPr txBox="1"/>
           <p:nvPr/>
         </p:nvSpPr>
@@ -19050,7 +19148,7 @@
       </p:sp>
       <p:sp>
         <p:nvSpPr>
-          <p:cNvPr id="47" name="Text 45"/>
+          <p:cNvPr id="50" name="Text 48"/>
           <p:cNvSpPr txBox="1"/>
           <p:nvPr/>
         </p:nvSpPr>
@@ -19089,7 +19187,7 @@
       </p:sp>
       <p:sp>
         <p:nvSpPr>
-          <p:cNvPr id="48" name="Text 46"/>
+          <p:cNvPr id="51" name="Text 49"/>
           <p:cNvSpPr txBox="1"/>
           <p:nvPr/>
         </p:nvSpPr>
@@ -19284,7 +19382,7 @@
                 <a:ea typeface="Cambria" pitchFamily="34" charset="-122"/>
                 <a:cs typeface="Cambria" pitchFamily="34" charset="-120"/>
               </a:rPr>
-              <a:t>US$ 115,0 mi</a:t>
+              <a:t>US$ 116,2 mi</a:t>
             </a:r>
             <a:endParaRPr lang="en-US" sz="2600" dirty="0"/>
           </a:p>
@@ -19423,7 +19521,7 @@
                 <a:ea typeface="Cambria" pitchFamily="34" charset="-122"/>
                 <a:cs typeface="Cambria" pitchFamily="34" charset="-120"/>
               </a:rPr>
-              <a:t>234</a:t>
+              <a:t>244</a:t>
             </a:r>
             <a:endParaRPr lang="en-US" sz="2600" dirty="0"/>
           </a:p>
@@ -20729,7 +20827,7 @@
                             <a:srgbClr val="1C2B33"/>
                           </a:solidFill>
                         </a:rPr>
-                        <a:t>US$ 19,1 mi</a:t>
+                        <a:t>US$ 18,8 mi</a:t>
                       </a:r>
                       <a:endParaRPr lang="en-US" sz="1050" dirty="0"/>
                     </a:p>
@@ -20790,7 +20888,7 @@
                             <a:srgbClr val="1C2B33"/>
                           </a:solidFill>
                         </a:rPr>
-                        <a:t>70</a:t>
+                        <a:t>69</a:t>
                       </a:r>
                       <a:endParaRPr lang="en-US" sz="1050" dirty="0"/>
                     </a:p>
@@ -20914,7 +21012,7 @@
                             <a:srgbClr val="1C2B33"/>
                           </a:solidFill>
                         </a:rPr>
-                        <a:t>US$ 3,6 mi</a:t>
+                        <a:t>US$ 5,1 mi</a:t>
                       </a:r>
                       <a:endParaRPr lang="en-US" sz="1050" dirty="0"/>
                     </a:p>
@@ -20975,7 +21073,7 @@
                             <a:srgbClr val="1C2B33"/>
                           </a:solidFill>
                         </a:rPr>
-                        <a:t>27</a:t>
+                        <a:t>38</a:t>
                       </a:r>
                       <a:endParaRPr lang="en-US" sz="1050" dirty="0"/>
                     </a:p>
@@ -21284,7 +21382,7 @@
                             <a:srgbClr val="0B2A3D"/>
                           </a:solidFill>
                         </a:rPr>
-                        <a:t>US$ 115,0 mi</a:t>
+                        <a:t>US$ 116,2 mi</a:t>
                       </a:r>
                       <a:endParaRPr lang="en-US" sz="1050" dirty="0"/>
                     </a:p>
@@ -21345,7 +21443,7 @@
                             <a:srgbClr val="0B2A3D"/>
                           </a:solidFill>
                         </a:rPr>
-                        <a:t>234</a:t>
+                        <a:t>244</a:t>
                       </a:r>
                       <a:endParaRPr lang="en-US" sz="1050" dirty="0"/>
                     </a:p>
@@ -21592,7 +21690,7 @@
                 <a:ea typeface="Calibri" pitchFamily="34" charset="-122"/>
                 <a:cs typeface="Calibri" pitchFamily="34" charset="-120"/>
               </a:rPr>
-              <a:t>Principais escopos por valor · 27 itens no total</a:t>
+              <a:t>Principais escopos por valor · 38 itens no total</a:t>
             </a:r>
             <a:endParaRPr lang="en-US" sz="1250" dirty="0"/>
           </a:p>
@@ -22740,7 +22838,7 @@
                           <a:ea typeface="Calibri" pitchFamily="34" charset="-122"/>
                           <a:cs typeface="Calibri" pitchFamily="34" charset="-120"/>
                         </a:rPr>
-                        <a:t>Instalação de novos Detectores de Gás</a:t>
+                        <a:t>TA - Caldeiraria</a:t>
                       </a:r>
                       <a:endParaRPr lang="en-US" sz="1000" dirty="0">
                         <a:latin typeface="Calibri" charset="0"/>
@@ -22808,7 +22906,555 @@
                           <a:ea typeface="Calibri" pitchFamily="34" charset="-122"/>
                           <a:cs typeface="Calibri" pitchFamily="34" charset="-120"/>
                         </a:rPr>
+                        <a:t>Eficiência de Produção</a:t>
+                      </a:r>
+                      <a:endParaRPr lang="en-US" sz="950" dirty="0">
+                        <a:latin typeface="Calibri" charset="0"/>
+                        <a:ea typeface="Calibri" charset="0"/>
+                        <a:cs typeface="Calibri" charset="0"/>
+                      </a:endParaRPr>
+                    </a:p>
+                  </a:txBody>
+                  <a:tcPr marL="91440" marR="91440" marT="45720" marB="45720" anchor="ctr">
+                    <a:lnL w="6350" cap="flat" cmpd="sng" algn="ctr">
+                      <a:solidFill>
+                        <a:srgbClr val="E3E8E9"/>
+                      </a:solidFill>
+                      <a:prstDash val="solid"/>
+                      <a:round/>
+                      <a:headEnd type="none" w="med" len="med"/>
+                      <a:tailEnd type="none" w="med" len="med"/>
+                    </a:lnL>
+                    <a:lnR w="6350" cap="flat" cmpd="sng" algn="ctr">
+                      <a:solidFill>
+                        <a:srgbClr val="E3E8E9"/>
+                      </a:solidFill>
+                      <a:prstDash val="solid"/>
+                      <a:round/>
+                      <a:headEnd type="none" w="med" len="med"/>
+                      <a:tailEnd type="none" w="med" len="med"/>
+                    </a:lnR>
+                    <a:lnT w="6350" cap="flat" cmpd="sng" algn="ctr">
+                      <a:solidFill>
+                        <a:srgbClr val="E3E8E9"/>
+                      </a:solidFill>
+                      <a:prstDash val="solid"/>
+                      <a:round/>
+                      <a:headEnd type="none" w="med" len="med"/>
+                      <a:tailEnd type="none" w="med" len="med"/>
+                    </a:lnT>
+                    <a:lnB w="6350" cap="flat" cmpd="sng" algn="ctr">
+                      <a:solidFill>
+                        <a:srgbClr val="E3E8E9"/>
+                      </a:solidFill>
+                      <a:prstDash val="solid"/>
+                      <a:round/>
+                      <a:headEnd type="none" w="med" len="med"/>
+                      <a:tailEnd type="none" w="med" len="med"/>
+                    </a:lnB>
+                    <a:solidFill>
+                      <a:srgbClr val="F0F4F5"/>
+                    </a:solidFill>
+                  </a:tcPr>
+                </a:tc>
+                <a:tc>
+                  <a:txBody>
+                    <a:bodyPr/>
+                    <a:lstStyle/>
+                    <a:p>
+                      <a:pPr indent="0" marL="0">
+                        <a:buNone/>
+                      </a:pPr>
+                      <a:r>
+                        <a:rPr lang="en-US" sz="950" dirty="0">
+                          <a:solidFill>
+                            <a:srgbClr val="5B6B73"/>
+                          </a:solidFill>
+                          <a:latin typeface="Calibri" pitchFamily="34" charset="0"/>
+                          <a:ea typeface="Calibri" pitchFamily="34" charset="-122"/>
+                          <a:cs typeface="Calibri" pitchFamily="34" charset="-120"/>
+                        </a:rPr>
+                        <a:t>TA - Parada Programada</a:t>
+                      </a:r>
+                      <a:endParaRPr lang="en-US" sz="950" dirty="0">
+                        <a:latin typeface="Calibri" charset="0"/>
+                        <a:ea typeface="Calibri" charset="0"/>
+                        <a:cs typeface="Calibri" charset="0"/>
+                      </a:endParaRPr>
+                    </a:p>
+                  </a:txBody>
+                  <a:tcPr marL="91440" marR="91440" marT="45720" marB="45720" anchor="ctr">
+                    <a:lnL w="6350" cap="flat" cmpd="sng" algn="ctr">
+                      <a:solidFill>
+                        <a:srgbClr val="E3E8E9"/>
+                      </a:solidFill>
+                      <a:prstDash val="solid"/>
+                      <a:round/>
+                      <a:headEnd type="none" w="med" len="med"/>
+                      <a:tailEnd type="none" w="med" len="med"/>
+                    </a:lnL>
+                    <a:lnR w="6350" cap="flat" cmpd="sng" algn="ctr">
+                      <a:solidFill>
+                        <a:srgbClr val="E3E8E9"/>
+                      </a:solidFill>
+                      <a:prstDash val="solid"/>
+                      <a:round/>
+                      <a:headEnd type="none" w="med" len="med"/>
+                      <a:tailEnd type="none" w="med" len="med"/>
+                    </a:lnR>
+                    <a:lnT w="6350" cap="flat" cmpd="sng" algn="ctr">
+                      <a:solidFill>
+                        <a:srgbClr val="E3E8E9"/>
+                      </a:solidFill>
+                      <a:prstDash val="solid"/>
+                      <a:round/>
+                      <a:headEnd type="none" w="med" len="med"/>
+                      <a:tailEnd type="none" w="med" len="med"/>
+                    </a:lnT>
+                    <a:lnB w="6350" cap="flat" cmpd="sng" algn="ctr">
+                      <a:solidFill>
+                        <a:srgbClr val="E3E8E9"/>
+                      </a:solidFill>
+                      <a:prstDash val="solid"/>
+                      <a:round/>
+                      <a:headEnd type="none" w="med" len="med"/>
+                      <a:tailEnd type="none" w="med" len="med"/>
+                    </a:lnB>
+                    <a:solidFill>
+                      <a:srgbClr val="F0F4F5"/>
+                    </a:solidFill>
+                  </a:tcPr>
+                </a:tc>
+                <a:tc>
+                  <a:txBody>
+                    <a:bodyPr/>
+                    <a:lstStyle/>
+                    <a:p>
+                      <a:pPr algn="r" indent="0" marL="0">
+                        <a:buNone/>
+                      </a:pPr>
+                      <a:r>
+                        <a:rPr lang="en-US" sz="1000" b="1" dirty="0">
+                          <a:solidFill>
+                            <a:srgbClr val="0B2A3D"/>
+                          </a:solidFill>
+                          <a:latin typeface="Calibri" pitchFamily="34" charset="0"/>
+                          <a:ea typeface="Calibri" pitchFamily="34" charset="-122"/>
+                          <a:cs typeface="Calibri" pitchFamily="34" charset="-120"/>
+                        </a:rPr>
+                        <a:t>US$ 484,9 mil</a:t>
+                      </a:r>
+                      <a:endParaRPr lang="en-US" sz="1000" dirty="0">
+                        <a:latin typeface="Calibri" charset="0"/>
+                        <a:ea typeface="Calibri" charset="0"/>
+                        <a:cs typeface="Calibri" charset="0"/>
+                      </a:endParaRPr>
+                    </a:p>
+                  </a:txBody>
+                  <a:tcPr marL="91440" marR="91440" marT="45720" marB="45720" anchor="ctr">
+                    <a:lnL w="6350" cap="flat" cmpd="sng" algn="ctr">
+                      <a:solidFill>
+                        <a:srgbClr val="E3E8E9"/>
+                      </a:solidFill>
+                      <a:prstDash val="solid"/>
+                      <a:round/>
+                      <a:headEnd type="none" w="med" len="med"/>
+                      <a:tailEnd type="none" w="med" len="med"/>
+                    </a:lnL>
+                    <a:lnR w="6350" cap="flat" cmpd="sng" algn="ctr">
+                      <a:solidFill>
+                        <a:srgbClr val="E3E8E9"/>
+                      </a:solidFill>
+                      <a:prstDash val="solid"/>
+                      <a:round/>
+                      <a:headEnd type="none" w="med" len="med"/>
+                      <a:tailEnd type="none" w="med" len="med"/>
+                    </a:lnR>
+                    <a:lnT w="6350" cap="flat" cmpd="sng" algn="ctr">
+                      <a:solidFill>
+                        <a:srgbClr val="E3E8E9"/>
+                      </a:solidFill>
+                      <a:prstDash val="solid"/>
+                      <a:round/>
+                      <a:headEnd type="none" w="med" len="med"/>
+                      <a:tailEnd type="none" w="med" len="med"/>
+                    </a:lnT>
+                    <a:lnB w="6350" cap="flat" cmpd="sng" algn="ctr">
+                      <a:solidFill>
+                        <a:srgbClr val="E3E8E9"/>
+                      </a:solidFill>
+                      <a:prstDash val="solid"/>
+                      <a:round/>
+                      <a:headEnd type="none" w="med" len="med"/>
+                      <a:tailEnd type="none" w="med" len="med"/>
+                    </a:lnB>
+                    <a:solidFill>
+                      <a:srgbClr val="F0F4F5"/>
+                    </a:solidFill>
+                  </a:tcPr>
+                </a:tc>
+              </a:tr>
+              <a:tr h="288036">
+                <a:tc>
+                  <a:txBody>
+                    <a:bodyPr/>
+                    <a:lstStyle/>
+                    <a:p>
+                      <a:pPr indent="0" marL="0">
+                        <a:buNone/>
+                      </a:pPr>
+                      <a:r>
+                        <a:rPr lang="en-US" sz="1000" dirty="0">
+                          <a:solidFill>
+                            <a:srgbClr val="1C2B33"/>
+                          </a:solidFill>
+                          <a:latin typeface="Calibri" pitchFamily="34" charset="0"/>
+                          <a:ea typeface="Calibri" pitchFamily="34" charset="-122"/>
+                          <a:cs typeface="Calibri" pitchFamily="34" charset="-120"/>
+                        </a:rPr>
+                        <a:t>Instalação de novos Detectores de Gás</a:t>
+                      </a:r>
+                      <a:endParaRPr lang="en-US" sz="1000" dirty="0">
+                        <a:latin typeface="Calibri" charset="0"/>
+                        <a:ea typeface="Calibri" charset="0"/>
+                        <a:cs typeface="Calibri" charset="0"/>
+                      </a:endParaRPr>
+                    </a:p>
+                  </a:txBody>
+                  <a:tcPr marL="91440" marR="91440" marT="45720" marB="45720" anchor="ctr">
+                    <a:lnL w="6350" cap="flat" cmpd="sng" algn="ctr">
+                      <a:solidFill>
+                        <a:srgbClr val="E3E8E9"/>
+                      </a:solidFill>
+                      <a:prstDash val="solid"/>
+                      <a:round/>
+                      <a:headEnd type="none" w="med" len="med"/>
+                      <a:tailEnd type="none" w="med" len="med"/>
+                    </a:lnL>
+                    <a:lnR w="6350" cap="flat" cmpd="sng" algn="ctr">
+                      <a:solidFill>
+                        <a:srgbClr val="E3E8E9"/>
+                      </a:solidFill>
+                      <a:prstDash val="solid"/>
+                      <a:round/>
+                      <a:headEnd type="none" w="med" len="med"/>
+                      <a:tailEnd type="none" w="med" len="med"/>
+                    </a:lnR>
+                    <a:lnT w="6350" cap="flat" cmpd="sng" algn="ctr">
+                      <a:solidFill>
+                        <a:srgbClr val="E3E8E9"/>
+                      </a:solidFill>
+                      <a:prstDash val="solid"/>
+                      <a:round/>
+                      <a:headEnd type="none" w="med" len="med"/>
+                      <a:tailEnd type="none" w="med" len="med"/>
+                    </a:lnT>
+                    <a:lnB w="6350" cap="flat" cmpd="sng" algn="ctr">
+                      <a:solidFill>
+                        <a:srgbClr val="E3E8E9"/>
+                      </a:solidFill>
+                      <a:prstDash val="solid"/>
+                      <a:round/>
+                      <a:headEnd type="none" w="med" len="med"/>
+                      <a:tailEnd type="none" w="med" len="med"/>
+                    </a:lnB>
+                    <a:solidFill>
+                      <a:srgbClr val="FFFFFF"/>
+                    </a:solidFill>
+                  </a:tcPr>
+                </a:tc>
+                <a:tc>
+                  <a:txBody>
+                    <a:bodyPr/>
+                    <a:lstStyle/>
+                    <a:p>
+                      <a:pPr indent="0" marL="0">
+                        <a:buNone/>
+                      </a:pPr>
+                      <a:r>
+                        <a:rPr lang="en-US" sz="950" dirty="0">
+                          <a:solidFill>
+                            <a:srgbClr val="5B6B73"/>
+                          </a:solidFill>
+                          <a:latin typeface="Calibri" pitchFamily="34" charset="0"/>
+                          <a:ea typeface="Calibri" pitchFamily="34" charset="-122"/>
+                          <a:cs typeface="Calibri" pitchFamily="34" charset="-120"/>
+                        </a:rPr>
                         <a:t>Integridade e Regulatório</a:t>
+                      </a:r>
+                      <a:endParaRPr lang="en-US" sz="950" dirty="0">
+                        <a:latin typeface="Calibri" charset="0"/>
+                        <a:ea typeface="Calibri" charset="0"/>
+                        <a:cs typeface="Calibri" charset="0"/>
+                      </a:endParaRPr>
+                    </a:p>
+                  </a:txBody>
+                  <a:tcPr marL="91440" marR="91440" marT="45720" marB="45720" anchor="ctr">
+                    <a:lnL w="6350" cap="flat" cmpd="sng" algn="ctr">
+                      <a:solidFill>
+                        <a:srgbClr val="E3E8E9"/>
+                      </a:solidFill>
+                      <a:prstDash val="solid"/>
+                      <a:round/>
+                      <a:headEnd type="none" w="med" len="med"/>
+                      <a:tailEnd type="none" w="med" len="med"/>
+                    </a:lnL>
+                    <a:lnR w="6350" cap="flat" cmpd="sng" algn="ctr">
+                      <a:solidFill>
+                        <a:srgbClr val="E3E8E9"/>
+                      </a:solidFill>
+                      <a:prstDash val="solid"/>
+                      <a:round/>
+                      <a:headEnd type="none" w="med" len="med"/>
+                      <a:tailEnd type="none" w="med" len="med"/>
+                    </a:lnR>
+                    <a:lnT w="6350" cap="flat" cmpd="sng" algn="ctr">
+                      <a:solidFill>
+                        <a:srgbClr val="E3E8E9"/>
+                      </a:solidFill>
+                      <a:prstDash val="solid"/>
+                      <a:round/>
+                      <a:headEnd type="none" w="med" len="med"/>
+                      <a:tailEnd type="none" w="med" len="med"/>
+                    </a:lnT>
+                    <a:lnB w="6350" cap="flat" cmpd="sng" algn="ctr">
+                      <a:solidFill>
+                        <a:srgbClr val="E3E8E9"/>
+                      </a:solidFill>
+                      <a:prstDash val="solid"/>
+                      <a:round/>
+                      <a:headEnd type="none" w="med" len="med"/>
+                      <a:tailEnd type="none" w="med" len="med"/>
+                    </a:lnB>
+                    <a:solidFill>
+                      <a:srgbClr val="FFFFFF"/>
+                    </a:solidFill>
+                  </a:tcPr>
+                </a:tc>
+                <a:tc>
+                  <a:txBody>
+                    <a:bodyPr/>
+                    <a:lstStyle/>
+                    <a:p>
+                      <a:pPr indent="0" marL="0">
+                        <a:buNone/>
+                      </a:pPr>
+                      <a:r>
+                        <a:rPr lang="en-US" sz="950" dirty="0">
+                          <a:solidFill>
+                            <a:srgbClr val="5B6B73"/>
+                          </a:solidFill>
+                          <a:latin typeface="Calibri" pitchFamily="34" charset="0"/>
+                          <a:ea typeface="Calibri" pitchFamily="34" charset="-122"/>
+                          <a:cs typeface="Calibri" pitchFamily="34" charset="-120"/>
+                        </a:rPr>
+                        <a:t>Projetos</a:t>
+                      </a:r>
+                      <a:endParaRPr lang="en-US" sz="950" dirty="0">
+                        <a:latin typeface="Calibri" charset="0"/>
+                        <a:ea typeface="Calibri" charset="0"/>
+                        <a:cs typeface="Calibri" charset="0"/>
+                      </a:endParaRPr>
+                    </a:p>
+                  </a:txBody>
+                  <a:tcPr marL="91440" marR="91440" marT="45720" marB="45720" anchor="ctr">
+                    <a:lnL w="6350" cap="flat" cmpd="sng" algn="ctr">
+                      <a:solidFill>
+                        <a:srgbClr val="E3E8E9"/>
+                      </a:solidFill>
+                      <a:prstDash val="solid"/>
+                      <a:round/>
+                      <a:headEnd type="none" w="med" len="med"/>
+                      <a:tailEnd type="none" w="med" len="med"/>
+                    </a:lnL>
+                    <a:lnR w="6350" cap="flat" cmpd="sng" algn="ctr">
+                      <a:solidFill>
+                        <a:srgbClr val="E3E8E9"/>
+                      </a:solidFill>
+                      <a:prstDash val="solid"/>
+                      <a:round/>
+                      <a:headEnd type="none" w="med" len="med"/>
+                      <a:tailEnd type="none" w="med" len="med"/>
+                    </a:lnR>
+                    <a:lnT w="6350" cap="flat" cmpd="sng" algn="ctr">
+                      <a:solidFill>
+                        <a:srgbClr val="E3E8E9"/>
+                      </a:solidFill>
+                      <a:prstDash val="solid"/>
+                      <a:round/>
+                      <a:headEnd type="none" w="med" len="med"/>
+                      <a:tailEnd type="none" w="med" len="med"/>
+                    </a:lnT>
+                    <a:lnB w="6350" cap="flat" cmpd="sng" algn="ctr">
+                      <a:solidFill>
+                        <a:srgbClr val="E3E8E9"/>
+                      </a:solidFill>
+                      <a:prstDash val="solid"/>
+                      <a:round/>
+                      <a:headEnd type="none" w="med" len="med"/>
+                      <a:tailEnd type="none" w="med" len="med"/>
+                    </a:lnB>
+                    <a:solidFill>
+                      <a:srgbClr val="FFFFFF"/>
+                    </a:solidFill>
+                  </a:tcPr>
+                </a:tc>
+                <a:tc>
+                  <a:txBody>
+                    <a:bodyPr/>
+                    <a:lstStyle/>
+                    <a:p>
+                      <a:pPr algn="r" indent="0" marL="0">
+                        <a:buNone/>
+                      </a:pPr>
+                      <a:r>
+                        <a:rPr lang="en-US" sz="1000" b="1" dirty="0">
+                          <a:solidFill>
+                            <a:srgbClr val="0B2A3D"/>
+                          </a:solidFill>
+                          <a:latin typeface="Calibri" pitchFamily="34" charset="0"/>
+                          <a:ea typeface="Calibri" pitchFamily="34" charset="-122"/>
+                          <a:cs typeface="Calibri" pitchFamily="34" charset="-120"/>
+                        </a:rPr>
+                        <a:t>US$ 447,3 mil</a:t>
+                      </a:r>
+                      <a:endParaRPr lang="en-US" sz="1000" dirty="0">
+                        <a:latin typeface="Calibri" charset="0"/>
+                        <a:ea typeface="Calibri" charset="0"/>
+                        <a:cs typeface="Calibri" charset="0"/>
+                      </a:endParaRPr>
+                    </a:p>
+                  </a:txBody>
+                  <a:tcPr marL="91440" marR="91440" marT="45720" marB="45720" anchor="ctr">
+                    <a:lnL w="6350" cap="flat" cmpd="sng" algn="ctr">
+                      <a:solidFill>
+                        <a:srgbClr val="E3E8E9"/>
+                      </a:solidFill>
+                      <a:prstDash val="solid"/>
+                      <a:round/>
+                      <a:headEnd type="none" w="med" len="med"/>
+                      <a:tailEnd type="none" w="med" len="med"/>
+                    </a:lnL>
+                    <a:lnR w="6350" cap="flat" cmpd="sng" algn="ctr">
+                      <a:solidFill>
+                        <a:srgbClr val="E3E8E9"/>
+                      </a:solidFill>
+                      <a:prstDash val="solid"/>
+                      <a:round/>
+                      <a:headEnd type="none" w="med" len="med"/>
+                      <a:tailEnd type="none" w="med" len="med"/>
+                    </a:lnR>
+                    <a:lnT w="6350" cap="flat" cmpd="sng" algn="ctr">
+                      <a:solidFill>
+                        <a:srgbClr val="E3E8E9"/>
+                      </a:solidFill>
+                      <a:prstDash val="solid"/>
+                      <a:round/>
+                      <a:headEnd type="none" w="med" len="med"/>
+                      <a:tailEnd type="none" w="med" len="med"/>
+                    </a:lnT>
+                    <a:lnB w="6350" cap="flat" cmpd="sng" algn="ctr">
+                      <a:solidFill>
+                        <a:srgbClr val="E3E8E9"/>
+                      </a:solidFill>
+                      <a:prstDash val="solid"/>
+                      <a:round/>
+                      <a:headEnd type="none" w="med" len="med"/>
+                      <a:tailEnd type="none" w="med" len="med"/>
+                    </a:lnB>
+                    <a:solidFill>
+                      <a:srgbClr val="FFFFFF"/>
+                    </a:solidFill>
+                  </a:tcPr>
+                </a:tc>
+              </a:tr>
+              <a:tr h="288036">
+                <a:tc>
+                  <a:txBody>
+                    <a:bodyPr/>
+                    <a:lstStyle/>
+                    <a:p>
+                      <a:pPr indent="0" marL="0">
+                        <a:buNone/>
+                      </a:pPr>
+                      <a:r>
+                        <a:rPr lang="en-US" sz="1000" dirty="0">
+                          <a:solidFill>
+                            <a:srgbClr val="1C2B33"/>
+                          </a:solidFill>
+                          <a:latin typeface="Calibri" pitchFamily="34" charset="0"/>
+                          <a:ea typeface="Calibri" pitchFamily="34" charset="-122"/>
+                          <a:cs typeface="Calibri" pitchFamily="34" charset="-120"/>
+                        </a:rPr>
+                        <a:t>Repetidoras de Rádio</a:t>
+                      </a:r>
+                      <a:endParaRPr lang="en-US" sz="1000" dirty="0">
+                        <a:latin typeface="Calibri" charset="0"/>
+                        <a:ea typeface="Calibri" charset="0"/>
+                        <a:cs typeface="Calibri" charset="0"/>
+                      </a:endParaRPr>
+                    </a:p>
+                  </a:txBody>
+                  <a:tcPr marL="91440" marR="91440" marT="45720" marB="45720" anchor="ctr">
+                    <a:lnL w="6350" cap="flat" cmpd="sng" algn="ctr">
+                      <a:solidFill>
+                        <a:srgbClr val="E3E8E9"/>
+                      </a:solidFill>
+                      <a:prstDash val="solid"/>
+                      <a:round/>
+                      <a:headEnd type="none" w="med" len="med"/>
+                      <a:tailEnd type="none" w="med" len="med"/>
+                    </a:lnL>
+                    <a:lnR w="6350" cap="flat" cmpd="sng" algn="ctr">
+                      <a:solidFill>
+                        <a:srgbClr val="E3E8E9"/>
+                      </a:solidFill>
+                      <a:prstDash val="solid"/>
+                      <a:round/>
+                      <a:headEnd type="none" w="med" len="med"/>
+                      <a:tailEnd type="none" w="med" len="med"/>
+                    </a:lnR>
+                    <a:lnT w="6350" cap="flat" cmpd="sng" algn="ctr">
+                      <a:solidFill>
+                        <a:srgbClr val="E3E8E9"/>
+                      </a:solidFill>
+                      <a:prstDash val="solid"/>
+                      <a:round/>
+                      <a:headEnd type="none" w="med" len="med"/>
+                      <a:tailEnd type="none" w="med" len="med"/>
+                    </a:lnT>
+                    <a:lnB w="6350" cap="flat" cmpd="sng" algn="ctr">
+                      <a:solidFill>
+                        <a:srgbClr val="E3E8E9"/>
+                      </a:solidFill>
+                      <a:prstDash val="solid"/>
+                      <a:round/>
+                      <a:headEnd type="none" w="med" len="med"/>
+                      <a:tailEnd type="none" w="med" len="med"/>
+                    </a:lnB>
+                    <a:solidFill>
+                      <a:srgbClr val="F0F4F5"/>
+                    </a:solidFill>
+                  </a:tcPr>
+                </a:tc>
+                <a:tc>
+                  <a:txBody>
+                    <a:bodyPr/>
+                    <a:lstStyle/>
+                    <a:p>
+                      <a:pPr indent="0" marL="0">
+                        <a:buNone/>
+                      </a:pPr>
+                      <a:r>
+                        <a:rPr lang="en-US" sz="950" dirty="0">
+                          <a:solidFill>
+                            <a:srgbClr val="5B6B73"/>
+                          </a:solidFill>
+                          <a:latin typeface="Calibri" pitchFamily="34" charset="0"/>
+                          <a:ea typeface="Calibri" pitchFamily="34" charset="-122"/>
+                          <a:cs typeface="Calibri" pitchFamily="34" charset="-120"/>
+                        </a:rPr>
+                        <a:t>Eficiência de Produção</a:t>
                       </a:r>
                       <a:endParaRPr lang="en-US" sz="950" dirty="0">
                         <a:latin typeface="Calibri" charset="0"/>
@@ -22944,7 +23590,7 @@
                           <a:ea typeface="Calibri" pitchFamily="34" charset="-122"/>
                           <a:cs typeface="Calibri" pitchFamily="34" charset="-120"/>
                         </a:rPr>
-                        <a:t>US$ 447,3 mil</a:t>
+                        <a:t>US$ 217,9 mil</a:t>
                       </a:r>
                       <a:endParaRPr lang="en-US" sz="1000" dirty="0">
                         <a:latin typeface="Calibri" charset="0"/>
@@ -23014,7 +23660,7 @@
                           <a:ea typeface="Calibri" pitchFamily="34" charset="-122"/>
                           <a:cs typeface="Calibri" pitchFamily="34" charset="-120"/>
                         </a:rPr>
-                        <a:t>Repetidoras de Rádio</a:t>
+                        <a:t>TA - Flowline - Passagem de PIG</a:t>
                       </a:r>
                       <a:endParaRPr lang="en-US" sz="1000" dirty="0">
                         <a:latin typeface="Calibri" charset="0"/>
@@ -23082,7 +23728,555 @@
                           <a:ea typeface="Calibri" pitchFamily="34" charset="-122"/>
                           <a:cs typeface="Calibri" pitchFamily="34" charset="-120"/>
                         </a:rPr>
+                        <a:t>Integridade e Regulatório</a:t>
+                      </a:r>
+                      <a:endParaRPr lang="en-US" sz="950" dirty="0">
+                        <a:latin typeface="Calibri" charset="0"/>
+                        <a:ea typeface="Calibri" charset="0"/>
+                        <a:cs typeface="Calibri" charset="0"/>
+                      </a:endParaRPr>
+                    </a:p>
+                  </a:txBody>
+                  <a:tcPr marL="91440" marR="91440" marT="45720" marB="45720" anchor="ctr">
+                    <a:lnL w="6350" cap="flat" cmpd="sng" algn="ctr">
+                      <a:solidFill>
+                        <a:srgbClr val="E3E8E9"/>
+                      </a:solidFill>
+                      <a:prstDash val="solid"/>
+                      <a:round/>
+                      <a:headEnd type="none" w="med" len="med"/>
+                      <a:tailEnd type="none" w="med" len="med"/>
+                    </a:lnL>
+                    <a:lnR w="6350" cap="flat" cmpd="sng" algn="ctr">
+                      <a:solidFill>
+                        <a:srgbClr val="E3E8E9"/>
+                      </a:solidFill>
+                      <a:prstDash val="solid"/>
+                      <a:round/>
+                      <a:headEnd type="none" w="med" len="med"/>
+                      <a:tailEnd type="none" w="med" len="med"/>
+                    </a:lnR>
+                    <a:lnT w="6350" cap="flat" cmpd="sng" algn="ctr">
+                      <a:solidFill>
+                        <a:srgbClr val="E3E8E9"/>
+                      </a:solidFill>
+                      <a:prstDash val="solid"/>
+                      <a:round/>
+                      <a:headEnd type="none" w="med" len="med"/>
+                      <a:tailEnd type="none" w="med" len="med"/>
+                    </a:lnT>
+                    <a:lnB w="6350" cap="flat" cmpd="sng" algn="ctr">
+                      <a:solidFill>
+                        <a:srgbClr val="E3E8E9"/>
+                      </a:solidFill>
+                      <a:prstDash val="solid"/>
+                      <a:round/>
+                      <a:headEnd type="none" w="med" len="med"/>
+                      <a:tailEnd type="none" w="med" len="med"/>
+                    </a:lnB>
+                    <a:solidFill>
+                      <a:srgbClr val="FFFFFF"/>
+                    </a:solidFill>
+                  </a:tcPr>
+                </a:tc>
+                <a:tc>
+                  <a:txBody>
+                    <a:bodyPr/>
+                    <a:lstStyle/>
+                    <a:p>
+                      <a:pPr indent="0" marL="0">
+                        <a:buNone/>
+                      </a:pPr>
+                      <a:r>
+                        <a:rPr lang="en-US" sz="950" dirty="0">
+                          <a:solidFill>
+                            <a:srgbClr val="5B6B73"/>
+                          </a:solidFill>
+                          <a:latin typeface="Calibri" pitchFamily="34" charset="0"/>
+                          <a:ea typeface="Calibri" pitchFamily="34" charset="-122"/>
+                          <a:cs typeface="Calibri" pitchFamily="34" charset="-120"/>
+                        </a:rPr>
+                        <a:t>P&amp;Q - Processos</a:t>
+                      </a:r>
+                      <a:endParaRPr lang="en-US" sz="950" dirty="0">
+                        <a:latin typeface="Calibri" charset="0"/>
+                        <a:ea typeface="Calibri" charset="0"/>
+                        <a:cs typeface="Calibri" charset="0"/>
+                      </a:endParaRPr>
+                    </a:p>
+                  </a:txBody>
+                  <a:tcPr marL="91440" marR="91440" marT="45720" marB="45720" anchor="ctr">
+                    <a:lnL w="6350" cap="flat" cmpd="sng" algn="ctr">
+                      <a:solidFill>
+                        <a:srgbClr val="E3E8E9"/>
+                      </a:solidFill>
+                      <a:prstDash val="solid"/>
+                      <a:round/>
+                      <a:headEnd type="none" w="med" len="med"/>
+                      <a:tailEnd type="none" w="med" len="med"/>
+                    </a:lnL>
+                    <a:lnR w="6350" cap="flat" cmpd="sng" algn="ctr">
+                      <a:solidFill>
+                        <a:srgbClr val="E3E8E9"/>
+                      </a:solidFill>
+                      <a:prstDash val="solid"/>
+                      <a:round/>
+                      <a:headEnd type="none" w="med" len="med"/>
+                      <a:tailEnd type="none" w="med" len="med"/>
+                    </a:lnR>
+                    <a:lnT w="6350" cap="flat" cmpd="sng" algn="ctr">
+                      <a:solidFill>
+                        <a:srgbClr val="E3E8E9"/>
+                      </a:solidFill>
+                      <a:prstDash val="solid"/>
+                      <a:round/>
+                      <a:headEnd type="none" w="med" len="med"/>
+                      <a:tailEnd type="none" w="med" len="med"/>
+                    </a:lnT>
+                    <a:lnB w="6350" cap="flat" cmpd="sng" algn="ctr">
+                      <a:solidFill>
+                        <a:srgbClr val="E3E8E9"/>
+                      </a:solidFill>
+                      <a:prstDash val="solid"/>
+                      <a:round/>
+                      <a:headEnd type="none" w="med" len="med"/>
+                      <a:tailEnd type="none" w="med" len="med"/>
+                    </a:lnB>
+                    <a:solidFill>
+                      <a:srgbClr val="FFFFFF"/>
+                    </a:solidFill>
+                  </a:tcPr>
+                </a:tc>
+                <a:tc>
+                  <a:txBody>
+                    <a:bodyPr/>
+                    <a:lstStyle/>
+                    <a:p>
+                      <a:pPr algn="r" indent="0" marL="0">
+                        <a:buNone/>
+                      </a:pPr>
+                      <a:r>
+                        <a:rPr lang="en-US" sz="1000" b="1" dirty="0">
+                          <a:solidFill>
+                            <a:srgbClr val="0B2A3D"/>
+                          </a:solidFill>
+                          <a:latin typeface="Calibri" pitchFamily="34" charset="0"/>
+                          <a:ea typeface="Calibri" pitchFamily="34" charset="-122"/>
+                          <a:cs typeface="Calibri" pitchFamily="34" charset="-120"/>
+                        </a:rPr>
+                        <a:t>US$ 206,8 mil</a:t>
+                      </a:r>
+                      <a:endParaRPr lang="en-US" sz="1000" dirty="0">
+                        <a:latin typeface="Calibri" charset="0"/>
+                        <a:ea typeface="Calibri" charset="0"/>
+                        <a:cs typeface="Calibri" charset="0"/>
+                      </a:endParaRPr>
+                    </a:p>
+                  </a:txBody>
+                  <a:tcPr marL="91440" marR="91440" marT="45720" marB="45720" anchor="ctr">
+                    <a:lnL w="6350" cap="flat" cmpd="sng" algn="ctr">
+                      <a:solidFill>
+                        <a:srgbClr val="E3E8E9"/>
+                      </a:solidFill>
+                      <a:prstDash val="solid"/>
+                      <a:round/>
+                      <a:headEnd type="none" w="med" len="med"/>
+                      <a:tailEnd type="none" w="med" len="med"/>
+                    </a:lnL>
+                    <a:lnR w="6350" cap="flat" cmpd="sng" algn="ctr">
+                      <a:solidFill>
+                        <a:srgbClr val="E3E8E9"/>
+                      </a:solidFill>
+                      <a:prstDash val="solid"/>
+                      <a:round/>
+                      <a:headEnd type="none" w="med" len="med"/>
+                      <a:tailEnd type="none" w="med" len="med"/>
+                    </a:lnR>
+                    <a:lnT w="6350" cap="flat" cmpd="sng" algn="ctr">
+                      <a:solidFill>
+                        <a:srgbClr val="E3E8E9"/>
+                      </a:solidFill>
+                      <a:prstDash val="solid"/>
+                      <a:round/>
+                      <a:headEnd type="none" w="med" len="med"/>
+                      <a:tailEnd type="none" w="med" len="med"/>
+                    </a:lnT>
+                    <a:lnB w="6350" cap="flat" cmpd="sng" algn="ctr">
+                      <a:solidFill>
+                        <a:srgbClr val="E3E8E9"/>
+                      </a:solidFill>
+                      <a:prstDash val="solid"/>
+                      <a:round/>
+                      <a:headEnd type="none" w="med" len="med"/>
+                      <a:tailEnd type="none" w="med" len="med"/>
+                    </a:lnB>
+                    <a:solidFill>
+                      <a:srgbClr val="FFFFFF"/>
+                    </a:solidFill>
+                  </a:tcPr>
+                </a:tc>
+              </a:tr>
+              <a:tr h="288036">
+                <a:tc>
+                  <a:txBody>
+                    <a:bodyPr/>
+                    <a:lstStyle/>
+                    <a:p>
+                      <a:pPr indent="0" marL="0">
+                        <a:buNone/>
+                      </a:pPr>
+                      <a:r>
+                        <a:rPr lang="en-US" sz="1000" dirty="0">
+                          <a:solidFill>
+                            <a:srgbClr val="1C2B33"/>
+                          </a:solidFill>
+                          <a:latin typeface="Calibri" pitchFamily="34" charset="0"/>
+                          <a:ea typeface="Calibri" pitchFamily="34" charset="-122"/>
+                          <a:cs typeface="Calibri" pitchFamily="34" charset="-120"/>
+                        </a:rPr>
+                        <a:t>TA - NR13</a:t>
+                      </a:r>
+                      <a:endParaRPr lang="en-US" sz="1000" dirty="0">
+                        <a:latin typeface="Calibri" charset="0"/>
+                        <a:ea typeface="Calibri" charset="0"/>
+                        <a:cs typeface="Calibri" charset="0"/>
+                      </a:endParaRPr>
+                    </a:p>
+                  </a:txBody>
+                  <a:tcPr marL="91440" marR="91440" marT="45720" marB="45720" anchor="ctr">
+                    <a:lnL w="6350" cap="flat" cmpd="sng" algn="ctr">
+                      <a:solidFill>
+                        <a:srgbClr val="E3E8E9"/>
+                      </a:solidFill>
+                      <a:prstDash val="solid"/>
+                      <a:round/>
+                      <a:headEnd type="none" w="med" len="med"/>
+                      <a:tailEnd type="none" w="med" len="med"/>
+                    </a:lnL>
+                    <a:lnR w="6350" cap="flat" cmpd="sng" algn="ctr">
+                      <a:solidFill>
+                        <a:srgbClr val="E3E8E9"/>
+                      </a:solidFill>
+                      <a:prstDash val="solid"/>
+                      <a:round/>
+                      <a:headEnd type="none" w="med" len="med"/>
+                      <a:tailEnd type="none" w="med" len="med"/>
+                    </a:lnR>
+                    <a:lnT w="6350" cap="flat" cmpd="sng" algn="ctr">
+                      <a:solidFill>
+                        <a:srgbClr val="E3E8E9"/>
+                      </a:solidFill>
+                      <a:prstDash val="solid"/>
+                      <a:round/>
+                      <a:headEnd type="none" w="med" len="med"/>
+                      <a:tailEnd type="none" w="med" len="med"/>
+                    </a:lnT>
+                    <a:lnB w="6350" cap="flat" cmpd="sng" algn="ctr">
+                      <a:solidFill>
+                        <a:srgbClr val="E3E8E9"/>
+                      </a:solidFill>
+                      <a:prstDash val="solid"/>
+                      <a:round/>
+                      <a:headEnd type="none" w="med" len="med"/>
+                      <a:tailEnd type="none" w="med" len="med"/>
+                    </a:lnB>
+                    <a:solidFill>
+                      <a:srgbClr val="F0F4F5"/>
+                    </a:solidFill>
+                  </a:tcPr>
+                </a:tc>
+                <a:tc>
+                  <a:txBody>
+                    <a:bodyPr/>
+                    <a:lstStyle/>
+                    <a:p>
+                      <a:pPr indent="0" marL="0">
+                        <a:buNone/>
+                      </a:pPr>
+                      <a:r>
+                        <a:rPr lang="en-US" sz="950" dirty="0">
+                          <a:solidFill>
+                            <a:srgbClr val="5B6B73"/>
+                          </a:solidFill>
+                          <a:latin typeface="Calibri" pitchFamily="34" charset="0"/>
+                          <a:ea typeface="Calibri" pitchFamily="34" charset="-122"/>
+                          <a:cs typeface="Calibri" pitchFamily="34" charset="-120"/>
+                        </a:rPr>
                         <a:t>Eficiência de Produção</a:t>
+                      </a:r>
+                      <a:endParaRPr lang="en-US" sz="950" dirty="0">
+                        <a:latin typeface="Calibri" charset="0"/>
+                        <a:ea typeface="Calibri" charset="0"/>
+                        <a:cs typeface="Calibri" charset="0"/>
+                      </a:endParaRPr>
+                    </a:p>
+                  </a:txBody>
+                  <a:tcPr marL="91440" marR="91440" marT="45720" marB="45720" anchor="ctr">
+                    <a:lnL w="6350" cap="flat" cmpd="sng" algn="ctr">
+                      <a:solidFill>
+                        <a:srgbClr val="E3E8E9"/>
+                      </a:solidFill>
+                      <a:prstDash val="solid"/>
+                      <a:round/>
+                      <a:headEnd type="none" w="med" len="med"/>
+                      <a:tailEnd type="none" w="med" len="med"/>
+                    </a:lnL>
+                    <a:lnR w="6350" cap="flat" cmpd="sng" algn="ctr">
+                      <a:solidFill>
+                        <a:srgbClr val="E3E8E9"/>
+                      </a:solidFill>
+                      <a:prstDash val="solid"/>
+                      <a:round/>
+                      <a:headEnd type="none" w="med" len="med"/>
+                      <a:tailEnd type="none" w="med" len="med"/>
+                    </a:lnR>
+                    <a:lnT w="6350" cap="flat" cmpd="sng" algn="ctr">
+                      <a:solidFill>
+                        <a:srgbClr val="E3E8E9"/>
+                      </a:solidFill>
+                      <a:prstDash val="solid"/>
+                      <a:round/>
+                      <a:headEnd type="none" w="med" len="med"/>
+                      <a:tailEnd type="none" w="med" len="med"/>
+                    </a:lnT>
+                    <a:lnB w="6350" cap="flat" cmpd="sng" algn="ctr">
+                      <a:solidFill>
+                        <a:srgbClr val="E3E8E9"/>
+                      </a:solidFill>
+                      <a:prstDash val="solid"/>
+                      <a:round/>
+                      <a:headEnd type="none" w="med" len="med"/>
+                      <a:tailEnd type="none" w="med" len="med"/>
+                    </a:lnB>
+                    <a:solidFill>
+                      <a:srgbClr val="F0F4F5"/>
+                    </a:solidFill>
+                  </a:tcPr>
+                </a:tc>
+                <a:tc>
+                  <a:txBody>
+                    <a:bodyPr/>
+                    <a:lstStyle/>
+                    <a:p>
+                      <a:pPr indent="0" marL="0">
+                        <a:buNone/>
+                      </a:pPr>
+                      <a:r>
+                        <a:rPr lang="en-US" sz="950" dirty="0">
+                          <a:solidFill>
+                            <a:srgbClr val="5B6B73"/>
+                          </a:solidFill>
+                          <a:latin typeface="Calibri" pitchFamily="34" charset="0"/>
+                          <a:ea typeface="Calibri" pitchFamily="34" charset="-122"/>
+                          <a:cs typeface="Calibri" pitchFamily="34" charset="-120"/>
+                        </a:rPr>
+                        <a:t>TA - Parada Programada</a:t>
+                      </a:r>
+                      <a:endParaRPr lang="en-US" sz="950" dirty="0">
+                        <a:latin typeface="Calibri" charset="0"/>
+                        <a:ea typeface="Calibri" charset="0"/>
+                        <a:cs typeface="Calibri" charset="0"/>
+                      </a:endParaRPr>
+                    </a:p>
+                  </a:txBody>
+                  <a:tcPr marL="91440" marR="91440" marT="45720" marB="45720" anchor="ctr">
+                    <a:lnL w="6350" cap="flat" cmpd="sng" algn="ctr">
+                      <a:solidFill>
+                        <a:srgbClr val="E3E8E9"/>
+                      </a:solidFill>
+                      <a:prstDash val="solid"/>
+                      <a:round/>
+                      <a:headEnd type="none" w="med" len="med"/>
+                      <a:tailEnd type="none" w="med" len="med"/>
+                    </a:lnL>
+                    <a:lnR w="6350" cap="flat" cmpd="sng" algn="ctr">
+                      <a:solidFill>
+                        <a:srgbClr val="E3E8E9"/>
+                      </a:solidFill>
+                      <a:prstDash val="solid"/>
+                      <a:round/>
+                      <a:headEnd type="none" w="med" len="med"/>
+                      <a:tailEnd type="none" w="med" len="med"/>
+                    </a:lnR>
+                    <a:lnT w="6350" cap="flat" cmpd="sng" algn="ctr">
+                      <a:solidFill>
+                        <a:srgbClr val="E3E8E9"/>
+                      </a:solidFill>
+                      <a:prstDash val="solid"/>
+                      <a:round/>
+                      <a:headEnd type="none" w="med" len="med"/>
+                      <a:tailEnd type="none" w="med" len="med"/>
+                    </a:lnT>
+                    <a:lnB w="6350" cap="flat" cmpd="sng" algn="ctr">
+                      <a:solidFill>
+                        <a:srgbClr val="E3E8E9"/>
+                      </a:solidFill>
+                      <a:prstDash val="solid"/>
+                      <a:round/>
+                      <a:headEnd type="none" w="med" len="med"/>
+                      <a:tailEnd type="none" w="med" len="med"/>
+                    </a:lnB>
+                    <a:solidFill>
+                      <a:srgbClr val="F0F4F5"/>
+                    </a:solidFill>
+                  </a:tcPr>
+                </a:tc>
+                <a:tc>
+                  <a:txBody>
+                    <a:bodyPr/>
+                    <a:lstStyle/>
+                    <a:p>
+                      <a:pPr algn="r" indent="0" marL="0">
+                        <a:buNone/>
+                      </a:pPr>
+                      <a:r>
+                        <a:rPr lang="en-US" sz="1000" b="1" dirty="0">
+                          <a:solidFill>
+                            <a:srgbClr val="0B2A3D"/>
+                          </a:solidFill>
+                          <a:latin typeface="Calibri" pitchFamily="34" charset="0"/>
+                          <a:ea typeface="Calibri" pitchFamily="34" charset="-122"/>
+                          <a:cs typeface="Calibri" pitchFamily="34" charset="-120"/>
+                        </a:rPr>
+                        <a:t>US$ 173,2 mil</a:t>
+                      </a:r>
+                      <a:endParaRPr lang="en-US" sz="1000" dirty="0">
+                        <a:latin typeface="Calibri" charset="0"/>
+                        <a:ea typeface="Calibri" charset="0"/>
+                        <a:cs typeface="Calibri" charset="0"/>
+                      </a:endParaRPr>
+                    </a:p>
+                  </a:txBody>
+                  <a:tcPr marL="91440" marR="91440" marT="45720" marB="45720" anchor="ctr">
+                    <a:lnL w="6350" cap="flat" cmpd="sng" algn="ctr">
+                      <a:solidFill>
+                        <a:srgbClr val="E3E8E9"/>
+                      </a:solidFill>
+                      <a:prstDash val="solid"/>
+                      <a:round/>
+                      <a:headEnd type="none" w="med" len="med"/>
+                      <a:tailEnd type="none" w="med" len="med"/>
+                    </a:lnL>
+                    <a:lnR w="6350" cap="flat" cmpd="sng" algn="ctr">
+                      <a:solidFill>
+                        <a:srgbClr val="E3E8E9"/>
+                      </a:solidFill>
+                      <a:prstDash val="solid"/>
+                      <a:round/>
+                      <a:headEnd type="none" w="med" len="med"/>
+                      <a:tailEnd type="none" w="med" len="med"/>
+                    </a:lnR>
+                    <a:lnT w="6350" cap="flat" cmpd="sng" algn="ctr">
+                      <a:solidFill>
+                        <a:srgbClr val="E3E8E9"/>
+                      </a:solidFill>
+                      <a:prstDash val="solid"/>
+                      <a:round/>
+                      <a:headEnd type="none" w="med" len="med"/>
+                      <a:tailEnd type="none" w="med" len="med"/>
+                    </a:lnT>
+                    <a:lnB w="6350" cap="flat" cmpd="sng" algn="ctr">
+                      <a:solidFill>
+                        <a:srgbClr val="E3E8E9"/>
+                      </a:solidFill>
+                      <a:prstDash val="solid"/>
+                      <a:round/>
+                      <a:headEnd type="none" w="med" len="med"/>
+                      <a:tailEnd type="none" w="med" len="med"/>
+                    </a:lnB>
+                    <a:solidFill>
+                      <a:srgbClr val="F0F4F5"/>
+                    </a:solidFill>
+                  </a:tcPr>
+                </a:tc>
+              </a:tr>
+              <a:tr h="288036">
+                <a:tc>
+                  <a:txBody>
+                    <a:bodyPr/>
+                    <a:lstStyle/>
+                    <a:p>
+                      <a:pPr indent="0" marL="0">
+                        <a:buNone/>
+                      </a:pPr>
+                      <a:r>
+                        <a:rPr lang="en-US" sz="1000" dirty="0">
+                          <a:solidFill>
+                            <a:srgbClr val="1C2B33"/>
+                          </a:solidFill>
+                          <a:latin typeface="Calibri" pitchFamily="34" charset="0"/>
+                          <a:ea typeface="Calibri" pitchFamily="34" charset="-122"/>
+                          <a:cs typeface="Calibri" pitchFamily="34" charset="-120"/>
+                        </a:rPr>
+                        <a:t>Troca da Estação Meteorológica</a:t>
+                      </a:r>
+                      <a:endParaRPr lang="en-US" sz="1000" dirty="0">
+                        <a:latin typeface="Calibri" charset="0"/>
+                        <a:ea typeface="Calibri" charset="0"/>
+                        <a:cs typeface="Calibri" charset="0"/>
+                      </a:endParaRPr>
+                    </a:p>
+                  </a:txBody>
+                  <a:tcPr marL="91440" marR="91440" marT="45720" marB="45720" anchor="ctr">
+                    <a:lnL w="6350" cap="flat" cmpd="sng" algn="ctr">
+                      <a:solidFill>
+                        <a:srgbClr val="E3E8E9"/>
+                      </a:solidFill>
+                      <a:prstDash val="solid"/>
+                      <a:round/>
+                      <a:headEnd type="none" w="med" len="med"/>
+                      <a:tailEnd type="none" w="med" len="med"/>
+                    </a:lnL>
+                    <a:lnR w="6350" cap="flat" cmpd="sng" algn="ctr">
+                      <a:solidFill>
+                        <a:srgbClr val="E3E8E9"/>
+                      </a:solidFill>
+                      <a:prstDash val="solid"/>
+                      <a:round/>
+                      <a:headEnd type="none" w="med" len="med"/>
+                      <a:tailEnd type="none" w="med" len="med"/>
+                    </a:lnR>
+                    <a:lnT w="6350" cap="flat" cmpd="sng" algn="ctr">
+                      <a:solidFill>
+                        <a:srgbClr val="E3E8E9"/>
+                      </a:solidFill>
+                      <a:prstDash val="solid"/>
+                      <a:round/>
+                      <a:headEnd type="none" w="med" len="med"/>
+                      <a:tailEnd type="none" w="med" len="med"/>
+                    </a:lnT>
+                    <a:lnB w="6350" cap="flat" cmpd="sng" algn="ctr">
+                      <a:solidFill>
+                        <a:srgbClr val="E3E8E9"/>
+                      </a:solidFill>
+                      <a:prstDash val="solid"/>
+                      <a:round/>
+                      <a:headEnd type="none" w="med" len="med"/>
+                      <a:tailEnd type="none" w="med" len="med"/>
+                    </a:lnB>
+                    <a:solidFill>
+                      <a:srgbClr val="FFFFFF"/>
+                    </a:solidFill>
+                  </a:tcPr>
+                </a:tc>
+                <a:tc>
+                  <a:txBody>
+                    <a:bodyPr/>
+                    <a:lstStyle/>
+                    <a:p>
+                      <a:pPr indent="0" marL="0">
+                        <a:buNone/>
+                      </a:pPr>
+                      <a:r>
+                        <a:rPr lang="en-US" sz="950" dirty="0">
+                          <a:solidFill>
+                            <a:srgbClr val="5B6B73"/>
+                          </a:solidFill>
+                          <a:latin typeface="Calibri" pitchFamily="34" charset="0"/>
+                          <a:ea typeface="Calibri" pitchFamily="34" charset="-122"/>
+                          <a:cs typeface="Calibri" pitchFamily="34" charset="-120"/>
+                        </a:rPr>
+                        <a:t>Integridade e Regulatório</a:t>
                       </a:r>
                       <a:endParaRPr lang="en-US" sz="950" dirty="0">
                         <a:latin typeface="Calibri" charset="0"/>
@@ -23218,7 +24412,7 @@
                           <a:ea typeface="Calibri" pitchFamily="34" charset="-122"/>
                           <a:cs typeface="Calibri" pitchFamily="34" charset="-120"/>
                         </a:rPr>
-                        <a:t>US$ 217,9 mil</a:t>
+                        <a:t>US$ 169,1 mil</a:t>
                       </a:r>
                       <a:endParaRPr lang="en-US" sz="1000" dirty="0">
                         <a:latin typeface="Calibri" charset="0"/>
@@ -23562,555 +24756,7 @@
                           <a:ea typeface="Calibri" pitchFamily="34" charset="-122"/>
                           <a:cs typeface="Calibri" pitchFamily="34" charset="-120"/>
                         </a:rPr>
-                        <a:t>Implantação do projeto 'Muster Digital'</a:t>
-                      </a:r>
-                      <a:endParaRPr lang="en-US" sz="1000" dirty="0">
-                        <a:latin typeface="Calibri" charset="0"/>
-                        <a:ea typeface="Calibri" charset="0"/>
-                        <a:cs typeface="Calibri" charset="0"/>
-                      </a:endParaRPr>
-                    </a:p>
-                  </a:txBody>
-                  <a:tcPr marL="91440" marR="91440" marT="45720" marB="45720" anchor="ctr">
-                    <a:lnL w="6350" cap="flat" cmpd="sng" algn="ctr">
-                      <a:solidFill>
-                        <a:srgbClr val="E3E8E9"/>
-                      </a:solidFill>
-                      <a:prstDash val="solid"/>
-                      <a:round/>
-                      <a:headEnd type="none" w="med" len="med"/>
-                      <a:tailEnd type="none" w="med" len="med"/>
-                    </a:lnL>
-                    <a:lnR w="6350" cap="flat" cmpd="sng" algn="ctr">
-                      <a:solidFill>
-                        <a:srgbClr val="E3E8E9"/>
-                      </a:solidFill>
-                      <a:prstDash val="solid"/>
-                      <a:round/>
-                      <a:headEnd type="none" w="med" len="med"/>
-                      <a:tailEnd type="none" w="med" len="med"/>
-                    </a:lnR>
-                    <a:lnT w="6350" cap="flat" cmpd="sng" algn="ctr">
-                      <a:solidFill>
-                        <a:srgbClr val="E3E8E9"/>
-                      </a:solidFill>
-                      <a:prstDash val="solid"/>
-                      <a:round/>
-                      <a:headEnd type="none" w="med" len="med"/>
-                      <a:tailEnd type="none" w="med" len="med"/>
-                    </a:lnT>
-                    <a:lnB w="6350" cap="flat" cmpd="sng" algn="ctr">
-                      <a:solidFill>
-                        <a:srgbClr val="E3E8E9"/>
-                      </a:solidFill>
-                      <a:prstDash val="solid"/>
-                      <a:round/>
-                      <a:headEnd type="none" w="med" len="med"/>
-                      <a:tailEnd type="none" w="med" len="med"/>
-                    </a:lnB>
-                    <a:solidFill>
-                      <a:srgbClr val="FFFFFF"/>
-                    </a:solidFill>
-                  </a:tcPr>
-                </a:tc>
-                <a:tc>
-                  <a:txBody>
-                    <a:bodyPr/>
-                    <a:lstStyle/>
-                    <a:p>
-                      <a:pPr indent="0" marL="0">
-                        <a:buNone/>
-                      </a:pPr>
-                      <a:r>
-                        <a:rPr lang="en-US" sz="950" dirty="0">
-                          <a:solidFill>
-                            <a:srgbClr val="5B6B73"/>
-                          </a:solidFill>
-                          <a:latin typeface="Calibri" pitchFamily="34" charset="0"/>
-                          <a:ea typeface="Calibri" pitchFamily="34" charset="-122"/>
-                          <a:cs typeface="Calibri" pitchFamily="34" charset="-120"/>
-                        </a:rPr>
-                        <a:t>Bem Estar/Segurança</a:t>
-                      </a:r>
-                      <a:endParaRPr lang="en-US" sz="950" dirty="0">
-                        <a:latin typeface="Calibri" charset="0"/>
-                        <a:ea typeface="Calibri" charset="0"/>
-                        <a:cs typeface="Calibri" charset="0"/>
-                      </a:endParaRPr>
-                    </a:p>
-                  </a:txBody>
-                  <a:tcPr marL="91440" marR="91440" marT="45720" marB="45720" anchor="ctr">
-                    <a:lnL w="6350" cap="flat" cmpd="sng" algn="ctr">
-                      <a:solidFill>
-                        <a:srgbClr val="E3E8E9"/>
-                      </a:solidFill>
-                      <a:prstDash val="solid"/>
-                      <a:round/>
-                      <a:headEnd type="none" w="med" len="med"/>
-                      <a:tailEnd type="none" w="med" len="med"/>
-                    </a:lnL>
-                    <a:lnR w="6350" cap="flat" cmpd="sng" algn="ctr">
-                      <a:solidFill>
-                        <a:srgbClr val="E3E8E9"/>
-                      </a:solidFill>
-                      <a:prstDash val="solid"/>
-                      <a:round/>
-                      <a:headEnd type="none" w="med" len="med"/>
-                      <a:tailEnd type="none" w="med" len="med"/>
-                    </a:lnR>
-                    <a:lnT w="6350" cap="flat" cmpd="sng" algn="ctr">
-                      <a:solidFill>
-                        <a:srgbClr val="E3E8E9"/>
-                      </a:solidFill>
-                      <a:prstDash val="solid"/>
-                      <a:round/>
-                      <a:headEnd type="none" w="med" len="med"/>
-                      <a:tailEnd type="none" w="med" len="med"/>
-                    </a:lnT>
-                    <a:lnB w="6350" cap="flat" cmpd="sng" algn="ctr">
-                      <a:solidFill>
-                        <a:srgbClr val="E3E8E9"/>
-                      </a:solidFill>
-                      <a:prstDash val="solid"/>
-                      <a:round/>
-                      <a:headEnd type="none" w="med" len="med"/>
-                      <a:tailEnd type="none" w="med" len="med"/>
-                    </a:lnB>
-                    <a:solidFill>
-                      <a:srgbClr val="FFFFFF"/>
-                    </a:solidFill>
-                  </a:tcPr>
-                </a:tc>
-                <a:tc>
-                  <a:txBody>
-                    <a:bodyPr/>
-                    <a:lstStyle/>
-                    <a:p>
-                      <a:pPr indent="0" marL="0">
-                        <a:buNone/>
-                      </a:pPr>
-                      <a:r>
-                        <a:rPr lang="en-US" sz="950" dirty="0">
-                          <a:solidFill>
-                            <a:srgbClr val="5B6B73"/>
-                          </a:solidFill>
-                          <a:latin typeface="Calibri" pitchFamily="34" charset="0"/>
-                          <a:ea typeface="Calibri" pitchFamily="34" charset="-122"/>
-                          <a:cs typeface="Calibri" pitchFamily="34" charset="-120"/>
-                        </a:rPr>
-                        <a:t>Saúde e Segurança Ocupacional</a:t>
-                      </a:r>
-                      <a:endParaRPr lang="en-US" sz="950" dirty="0">
-                        <a:latin typeface="Calibri" charset="0"/>
-                        <a:ea typeface="Calibri" charset="0"/>
-                        <a:cs typeface="Calibri" charset="0"/>
-                      </a:endParaRPr>
-                    </a:p>
-                  </a:txBody>
-                  <a:tcPr marL="91440" marR="91440" marT="45720" marB="45720" anchor="ctr">
-                    <a:lnL w="6350" cap="flat" cmpd="sng" algn="ctr">
-                      <a:solidFill>
-                        <a:srgbClr val="E3E8E9"/>
-                      </a:solidFill>
-                      <a:prstDash val="solid"/>
-                      <a:round/>
-                      <a:headEnd type="none" w="med" len="med"/>
-                      <a:tailEnd type="none" w="med" len="med"/>
-                    </a:lnL>
-                    <a:lnR w="6350" cap="flat" cmpd="sng" algn="ctr">
-                      <a:solidFill>
-                        <a:srgbClr val="E3E8E9"/>
-                      </a:solidFill>
-                      <a:prstDash val="solid"/>
-                      <a:round/>
-                      <a:headEnd type="none" w="med" len="med"/>
-                      <a:tailEnd type="none" w="med" len="med"/>
-                    </a:lnR>
-                    <a:lnT w="6350" cap="flat" cmpd="sng" algn="ctr">
-                      <a:solidFill>
-                        <a:srgbClr val="E3E8E9"/>
-                      </a:solidFill>
-                      <a:prstDash val="solid"/>
-                      <a:round/>
-                      <a:headEnd type="none" w="med" len="med"/>
-                      <a:tailEnd type="none" w="med" len="med"/>
-                    </a:lnT>
-                    <a:lnB w="6350" cap="flat" cmpd="sng" algn="ctr">
-                      <a:solidFill>
-                        <a:srgbClr val="E3E8E9"/>
-                      </a:solidFill>
-                      <a:prstDash val="solid"/>
-                      <a:round/>
-                      <a:headEnd type="none" w="med" len="med"/>
-                      <a:tailEnd type="none" w="med" len="med"/>
-                    </a:lnB>
-                    <a:solidFill>
-                      <a:srgbClr val="FFFFFF"/>
-                    </a:solidFill>
-                  </a:tcPr>
-                </a:tc>
-                <a:tc>
-                  <a:txBody>
-                    <a:bodyPr/>
-                    <a:lstStyle/>
-                    <a:p>
-                      <a:pPr algn="r" indent="0" marL="0">
-                        <a:buNone/>
-                      </a:pPr>
-                      <a:r>
-                        <a:rPr lang="en-US" sz="1000" b="1" dirty="0">
-                          <a:solidFill>
-                            <a:srgbClr val="0B2A3D"/>
-                          </a:solidFill>
-                          <a:latin typeface="Calibri" pitchFamily="34" charset="0"/>
-                          <a:ea typeface="Calibri" pitchFamily="34" charset="-122"/>
-                          <a:cs typeface="Calibri" pitchFamily="34" charset="-120"/>
-                        </a:rPr>
-                        <a:t>US$ 150,0 mil</a:t>
-                      </a:r>
-                      <a:endParaRPr lang="en-US" sz="1000" dirty="0">
-                        <a:latin typeface="Calibri" charset="0"/>
-                        <a:ea typeface="Calibri" charset="0"/>
-                        <a:cs typeface="Calibri" charset="0"/>
-                      </a:endParaRPr>
-                    </a:p>
-                  </a:txBody>
-                  <a:tcPr marL="91440" marR="91440" marT="45720" marB="45720" anchor="ctr">
-                    <a:lnL w="6350" cap="flat" cmpd="sng" algn="ctr">
-                      <a:solidFill>
-                        <a:srgbClr val="E3E8E9"/>
-                      </a:solidFill>
-                      <a:prstDash val="solid"/>
-                      <a:round/>
-                      <a:headEnd type="none" w="med" len="med"/>
-                      <a:tailEnd type="none" w="med" len="med"/>
-                    </a:lnL>
-                    <a:lnR w="6350" cap="flat" cmpd="sng" algn="ctr">
-                      <a:solidFill>
-                        <a:srgbClr val="E3E8E9"/>
-                      </a:solidFill>
-                      <a:prstDash val="solid"/>
-                      <a:round/>
-                      <a:headEnd type="none" w="med" len="med"/>
-                      <a:tailEnd type="none" w="med" len="med"/>
-                    </a:lnR>
-                    <a:lnT w="6350" cap="flat" cmpd="sng" algn="ctr">
-                      <a:solidFill>
-                        <a:srgbClr val="E3E8E9"/>
-                      </a:solidFill>
-                      <a:prstDash val="solid"/>
-                      <a:round/>
-                      <a:headEnd type="none" w="med" len="med"/>
-                      <a:tailEnd type="none" w="med" len="med"/>
-                    </a:lnT>
-                    <a:lnB w="6350" cap="flat" cmpd="sng" algn="ctr">
-                      <a:solidFill>
-                        <a:srgbClr val="E3E8E9"/>
-                      </a:solidFill>
-                      <a:prstDash val="solid"/>
-                      <a:round/>
-                      <a:headEnd type="none" w="med" len="med"/>
-                      <a:tailEnd type="none" w="med" len="med"/>
-                    </a:lnB>
-                    <a:solidFill>
-                      <a:srgbClr val="FFFFFF"/>
-                    </a:solidFill>
-                  </a:tcPr>
-                </a:tc>
-              </a:tr>
-              <a:tr h="288036">
-                <a:tc>
-                  <a:txBody>
-                    <a:bodyPr/>
-                    <a:lstStyle/>
-                    <a:p>
-                      <a:pPr indent="0" marL="0">
-                        <a:buNone/>
-                      </a:pPr>
-                      <a:r>
-                        <a:rPr lang="en-US" sz="1000" dirty="0">
-                          <a:solidFill>
-                            <a:srgbClr val="1C2B33"/>
-                          </a:solidFill>
-                          <a:latin typeface="Calibri" pitchFamily="34" charset="0"/>
-                          <a:ea typeface="Calibri" pitchFamily="34" charset="-122"/>
-                          <a:cs typeface="Calibri" pitchFamily="34" charset="-120"/>
-                        </a:rPr>
-                        <a:t>PÓS TA - NR13</a:t>
-                      </a:r>
-                      <a:endParaRPr lang="en-US" sz="1000" dirty="0">
-                        <a:latin typeface="Calibri" charset="0"/>
-                        <a:ea typeface="Calibri" charset="0"/>
-                        <a:cs typeface="Calibri" charset="0"/>
-                      </a:endParaRPr>
-                    </a:p>
-                  </a:txBody>
-                  <a:tcPr marL="91440" marR="91440" marT="45720" marB="45720" anchor="ctr">
-                    <a:lnL w="6350" cap="flat" cmpd="sng" algn="ctr">
-                      <a:solidFill>
-                        <a:srgbClr val="E3E8E9"/>
-                      </a:solidFill>
-                      <a:prstDash val="solid"/>
-                      <a:round/>
-                      <a:headEnd type="none" w="med" len="med"/>
-                      <a:tailEnd type="none" w="med" len="med"/>
-                    </a:lnL>
-                    <a:lnR w="6350" cap="flat" cmpd="sng" algn="ctr">
-                      <a:solidFill>
-                        <a:srgbClr val="E3E8E9"/>
-                      </a:solidFill>
-                      <a:prstDash val="solid"/>
-                      <a:round/>
-                      <a:headEnd type="none" w="med" len="med"/>
-                      <a:tailEnd type="none" w="med" len="med"/>
-                    </a:lnR>
-                    <a:lnT w="6350" cap="flat" cmpd="sng" algn="ctr">
-                      <a:solidFill>
-                        <a:srgbClr val="E3E8E9"/>
-                      </a:solidFill>
-                      <a:prstDash val="solid"/>
-                      <a:round/>
-                      <a:headEnd type="none" w="med" len="med"/>
-                      <a:tailEnd type="none" w="med" len="med"/>
-                    </a:lnT>
-                    <a:lnB w="6350" cap="flat" cmpd="sng" algn="ctr">
-                      <a:solidFill>
-                        <a:srgbClr val="E3E8E9"/>
-                      </a:solidFill>
-                      <a:prstDash val="solid"/>
-                      <a:round/>
-                      <a:headEnd type="none" w="med" len="med"/>
-                      <a:tailEnd type="none" w="med" len="med"/>
-                    </a:lnB>
-                    <a:solidFill>
-                      <a:srgbClr val="F0F4F5"/>
-                    </a:solidFill>
-                  </a:tcPr>
-                </a:tc>
-                <a:tc>
-                  <a:txBody>
-                    <a:bodyPr/>
-                    <a:lstStyle/>
-                    <a:p>
-                      <a:pPr indent="0" marL="0">
-                        <a:buNone/>
-                      </a:pPr>
-                      <a:r>
-                        <a:rPr lang="en-US" sz="950" dirty="0">
-                          <a:solidFill>
-                            <a:srgbClr val="5B6B73"/>
-                          </a:solidFill>
-                          <a:latin typeface="Calibri" pitchFamily="34" charset="0"/>
-                          <a:ea typeface="Calibri" pitchFamily="34" charset="-122"/>
-                          <a:cs typeface="Calibri" pitchFamily="34" charset="-120"/>
-                        </a:rPr>
-                        <a:t>Eficiência de Produção</a:t>
-                      </a:r>
-                      <a:endParaRPr lang="en-US" sz="950" dirty="0">
-                        <a:latin typeface="Calibri" charset="0"/>
-                        <a:ea typeface="Calibri" charset="0"/>
-                        <a:cs typeface="Calibri" charset="0"/>
-                      </a:endParaRPr>
-                    </a:p>
-                  </a:txBody>
-                  <a:tcPr marL="91440" marR="91440" marT="45720" marB="45720" anchor="ctr">
-                    <a:lnL w="6350" cap="flat" cmpd="sng" algn="ctr">
-                      <a:solidFill>
-                        <a:srgbClr val="E3E8E9"/>
-                      </a:solidFill>
-                      <a:prstDash val="solid"/>
-                      <a:round/>
-                      <a:headEnd type="none" w="med" len="med"/>
-                      <a:tailEnd type="none" w="med" len="med"/>
-                    </a:lnL>
-                    <a:lnR w="6350" cap="flat" cmpd="sng" algn="ctr">
-                      <a:solidFill>
-                        <a:srgbClr val="E3E8E9"/>
-                      </a:solidFill>
-                      <a:prstDash val="solid"/>
-                      <a:round/>
-                      <a:headEnd type="none" w="med" len="med"/>
-                      <a:tailEnd type="none" w="med" len="med"/>
-                    </a:lnR>
-                    <a:lnT w="6350" cap="flat" cmpd="sng" algn="ctr">
-                      <a:solidFill>
-                        <a:srgbClr val="E3E8E9"/>
-                      </a:solidFill>
-                      <a:prstDash val="solid"/>
-                      <a:round/>
-                      <a:headEnd type="none" w="med" len="med"/>
-                      <a:tailEnd type="none" w="med" len="med"/>
-                    </a:lnT>
-                    <a:lnB w="6350" cap="flat" cmpd="sng" algn="ctr">
-                      <a:solidFill>
-                        <a:srgbClr val="E3E8E9"/>
-                      </a:solidFill>
-                      <a:prstDash val="solid"/>
-                      <a:round/>
-                      <a:headEnd type="none" w="med" len="med"/>
-                      <a:tailEnd type="none" w="med" len="med"/>
-                    </a:lnB>
-                    <a:solidFill>
-                      <a:srgbClr val="F0F4F5"/>
-                    </a:solidFill>
-                  </a:tcPr>
-                </a:tc>
-                <a:tc>
-                  <a:txBody>
-                    <a:bodyPr/>
-                    <a:lstStyle/>
-                    <a:p>
-                      <a:pPr indent="0" marL="0">
-                        <a:buNone/>
-                      </a:pPr>
-                      <a:r>
-                        <a:rPr lang="en-US" sz="950" dirty="0">
-                          <a:solidFill>
-                            <a:srgbClr val="5B6B73"/>
-                          </a:solidFill>
-                          <a:latin typeface="Calibri" pitchFamily="34" charset="0"/>
-                          <a:ea typeface="Calibri" pitchFamily="34" charset="-122"/>
-                          <a:cs typeface="Calibri" pitchFamily="34" charset="-120"/>
-                        </a:rPr>
-                        <a:t>TA - Parada Programada</a:t>
-                      </a:r>
-                      <a:endParaRPr lang="en-US" sz="950" dirty="0">
-                        <a:latin typeface="Calibri" charset="0"/>
-                        <a:ea typeface="Calibri" charset="0"/>
-                        <a:cs typeface="Calibri" charset="0"/>
-                      </a:endParaRPr>
-                    </a:p>
-                  </a:txBody>
-                  <a:tcPr marL="91440" marR="91440" marT="45720" marB="45720" anchor="ctr">
-                    <a:lnL w="6350" cap="flat" cmpd="sng" algn="ctr">
-                      <a:solidFill>
-                        <a:srgbClr val="E3E8E9"/>
-                      </a:solidFill>
-                      <a:prstDash val="solid"/>
-                      <a:round/>
-                      <a:headEnd type="none" w="med" len="med"/>
-                      <a:tailEnd type="none" w="med" len="med"/>
-                    </a:lnL>
-                    <a:lnR w="6350" cap="flat" cmpd="sng" algn="ctr">
-                      <a:solidFill>
-                        <a:srgbClr val="E3E8E9"/>
-                      </a:solidFill>
-                      <a:prstDash val="solid"/>
-                      <a:round/>
-                      <a:headEnd type="none" w="med" len="med"/>
-                      <a:tailEnd type="none" w="med" len="med"/>
-                    </a:lnR>
-                    <a:lnT w="6350" cap="flat" cmpd="sng" algn="ctr">
-                      <a:solidFill>
-                        <a:srgbClr val="E3E8E9"/>
-                      </a:solidFill>
-                      <a:prstDash val="solid"/>
-                      <a:round/>
-                      <a:headEnd type="none" w="med" len="med"/>
-                      <a:tailEnd type="none" w="med" len="med"/>
-                    </a:lnT>
-                    <a:lnB w="6350" cap="flat" cmpd="sng" algn="ctr">
-                      <a:solidFill>
-                        <a:srgbClr val="E3E8E9"/>
-                      </a:solidFill>
-                      <a:prstDash val="solid"/>
-                      <a:round/>
-                      <a:headEnd type="none" w="med" len="med"/>
-                      <a:tailEnd type="none" w="med" len="med"/>
-                    </a:lnB>
-                    <a:solidFill>
-                      <a:srgbClr val="F0F4F5"/>
-                    </a:solidFill>
-                  </a:tcPr>
-                </a:tc>
-                <a:tc>
-                  <a:txBody>
-                    <a:bodyPr/>
-                    <a:lstStyle/>
-                    <a:p>
-                      <a:pPr algn="r" indent="0" marL="0">
-                        <a:buNone/>
-                      </a:pPr>
-                      <a:r>
-                        <a:rPr lang="en-US" sz="1000" b="1" dirty="0">
-                          <a:solidFill>
-                            <a:srgbClr val="0B2A3D"/>
-                          </a:solidFill>
-                          <a:latin typeface="Calibri" pitchFamily="34" charset="0"/>
-                          <a:ea typeface="Calibri" pitchFamily="34" charset="-122"/>
-                          <a:cs typeface="Calibri" pitchFamily="34" charset="-120"/>
-                        </a:rPr>
-                        <a:t>US$ 135,6 mil</a:t>
-                      </a:r>
-                      <a:endParaRPr lang="en-US" sz="1000" dirty="0">
-                        <a:latin typeface="Calibri" charset="0"/>
-                        <a:ea typeface="Calibri" charset="0"/>
-                        <a:cs typeface="Calibri" charset="0"/>
-                      </a:endParaRPr>
-                    </a:p>
-                  </a:txBody>
-                  <a:tcPr marL="91440" marR="91440" marT="45720" marB="45720" anchor="ctr">
-                    <a:lnL w="6350" cap="flat" cmpd="sng" algn="ctr">
-                      <a:solidFill>
-                        <a:srgbClr val="E3E8E9"/>
-                      </a:solidFill>
-                      <a:prstDash val="solid"/>
-                      <a:round/>
-                      <a:headEnd type="none" w="med" len="med"/>
-                      <a:tailEnd type="none" w="med" len="med"/>
-                    </a:lnL>
-                    <a:lnR w="6350" cap="flat" cmpd="sng" algn="ctr">
-                      <a:solidFill>
-                        <a:srgbClr val="E3E8E9"/>
-                      </a:solidFill>
-                      <a:prstDash val="solid"/>
-                      <a:round/>
-                      <a:headEnd type="none" w="med" len="med"/>
-                      <a:tailEnd type="none" w="med" len="med"/>
-                    </a:lnR>
-                    <a:lnT w="6350" cap="flat" cmpd="sng" algn="ctr">
-                      <a:solidFill>
-                        <a:srgbClr val="E3E8E9"/>
-                      </a:solidFill>
-                      <a:prstDash val="solid"/>
-                      <a:round/>
-                      <a:headEnd type="none" w="med" len="med"/>
-                      <a:tailEnd type="none" w="med" len="med"/>
-                    </a:lnT>
-                    <a:lnB w="6350" cap="flat" cmpd="sng" algn="ctr">
-                      <a:solidFill>
-                        <a:srgbClr val="E3E8E9"/>
-                      </a:solidFill>
-                      <a:prstDash val="solid"/>
-                      <a:round/>
-                      <a:headEnd type="none" w="med" len="med"/>
-                      <a:tailEnd type="none" w="med" len="med"/>
-                    </a:lnB>
-                    <a:solidFill>
-                      <a:srgbClr val="F0F4F5"/>
-                    </a:solidFill>
-                  </a:tcPr>
-                </a:tc>
-              </a:tr>
-              <a:tr h="288036">
-                <a:tc>
-                  <a:txBody>
-                    <a:bodyPr/>
-                    <a:lstStyle/>
-                    <a:p>
-                      <a:pPr indent="0" marL="0">
-                        <a:buNone/>
-                      </a:pPr>
-                      <a:r>
-                        <a:rPr lang="en-US" sz="1000" dirty="0">
-                          <a:solidFill>
-                            <a:srgbClr val="1C2B33"/>
-                          </a:solidFill>
-                          <a:latin typeface="Calibri" pitchFamily="34" charset="0"/>
-                          <a:ea typeface="Calibri" pitchFamily="34" charset="-122"/>
-                          <a:cs typeface="Calibri" pitchFamily="34" charset="-120"/>
-                        </a:rPr>
-                        <a:t>PRÉ TA - Caldeiraria</a:t>
+                        <a:t>TA - Desmobilização</a:t>
                       </a:r>
                       <a:endParaRPr lang="en-US" sz="1000" dirty="0">
                         <a:latin typeface="Calibri" charset="0"/>
@@ -24314,7 +24960,7 @@
                           <a:ea typeface="Calibri" pitchFamily="34" charset="-122"/>
                           <a:cs typeface="Calibri" pitchFamily="34" charset="-120"/>
                         </a:rPr>
-                        <a:t>US$ 132,9 mil</a:t>
+                        <a:t>US$ 162,1 mil</a:t>
                       </a:r>
                       <a:endParaRPr lang="en-US" sz="1000" dirty="0">
                         <a:latin typeface="Calibri" charset="0"/>
@@ -24384,7 +25030,7 @@
                           <a:ea typeface="Calibri" pitchFamily="34" charset="-122"/>
                           <a:cs typeface="Calibri" pitchFamily="34" charset="-120"/>
                         </a:rPr>
-                        <a:t>ESTUDO DE ENGENHARIA</a:t>
+                        <a:t>Implantação do projeto 'Muster Digital'</a:t>
                       </a:r>
                       <a:endParaRPr lang="en-US" sz="1000" dirty="0">
                         <a:latin typeface="Calibri" charset="0"/>
@@ -24452,7 +25098,7 @@
                           <a:ea typeface="Calibri" pitchFamily="34" charset="-122"/>
                           <a:cs typeface="Calibri" pitchFamily="34" charset="-120"/>
                         </a:rPr>
-                        <a:t>Eficiência de Produção</a:t>
+                        <a:t>Bem Estar/Segurança</a:t>
                       </a:r>
                       <a:endParaRPr lang="en-US" sz="950" dirty="0">
                         <a:latin typeface="Calibri" charset="0"/>
@@ -24520,7 +25166,7 @@
                           <a:ea typeface="Calibri" pitchFamily="34" charset="-122"/>
                           <a:cs typeface="Calibri" pitchFamily="34" charset="-120"/>
                         </a:rPr>
-                        <a:t>Projetos</a:t>
+                        <a:t>Saúde e Segurança Ocupacional</a:t>
                       </a:r>
                       <a:endParaRPr lang="en-US" sz="950" dirty="0">
                         <a:latin typeface="Calibri" charset="0"/>
@@ -24588,555 +25234,7 @@
                           <a:ea typeface="Calibri" pitchFamily="34" charset="-122"/>
                           <a:cs typeface="Calibri" pitchFamily="34" charset="-120"/>
                         </a:rPr>
-                        <a:t>US$ 120,0 mil</a:t>
-                      </a:r>
-                      <a:endParaRPr lang="en-US" sz="1000" dirty="0">
-                        <a:latin typeface="Calibri" charset="0"/>
-                        <a:ea typeface="Calibri" charset="0"/>
-                        <a:cs typeface="Calibri" charset="0"/>
-                      </a:endParaRPr>
-                    </a:p>
-                  </a:txBody>
-                  <a:tcPr marL="91440" marR="91440" marT="45720" marB="45720" anchor="ctr">
-                    <a:lnL w="6350" cap="flat" cmpd="sng" algn="ctr">
-                      <a:solidFill>
-                        <a:srgbClr val="E3E8E9"/>
-                      </a:solidFill>
-                      <a:prstDash val="solid"/>
-                      <a:round/>
-                      <a:headEnd type="none" w="med" len="med"/>
-                      <a:tailEnd type="none" w="med" len="med"/>
-                    </a:lnL>
-                    <a:lnR w="6350" cap="flat" cmpd="sng" algn="ctr">
-                      <a:solidFill>
-                        <a:srgbClr val="E3E8E9"/>
-                      </a:solidFill>
-                      <a:prstDash val="solid"/>
-                      <a:round/>
-                      <a:headEnd type="none" w="med" len="med"/>
-                      <a:tailEnd type="none" w="med" len="med"/>
-                    </a:lnR>
-                    <a:lnT w="6350" cap="flat" cmpd="sng" algn="ctr">
-                      <a:solidFill>
-                        <a:srgbClr val="E3E8E9"/>
-                      </a:solidFill>
-                      <a:prstDash val="solid"/>
-                      <a:round/>
-                      <a:headEnd type="none" w="med" len="med"/>
-                      <a:tailEnd type="none" w="med" len="med"/>
-                    </a:lnT>
-                    <a:lnB w="6350" cap="flat" cmpd="sng" algn="ctr">
-                      <a:solidFill>
-                        <a:srgbClr val="E3E8E9"/>
-                      </a:solidFill>
-                      <a:prstDash val="solid"/>
-                      <a:round/>
-                      <a:headEnd type="none" w="med" len="med"/>
-                      <a:tailEnd type="none" w="med" len="med"/>
-                    </a:lnB>
-                    <a:solidFill>
-                      <a:srgbClr val="F0F4F5"/>
-                    </a:solidFill>
-                  </a:tcPr>
-                </a:tc>
-              </a:tr>
-              <a:tr h="288036">
-                <a:tc>
-                  <a:txBody>
-                    <a:bodyPr/>
-                    <a:lstStyle/>
-                    <a:p>
-                      <a:pPr indent="0" marL="0">
-                        <a:buNone/>
-                      </a:pPr>
-                      <a:r>
-                        <a:rPr lang="en-US" sz="1000" dirty="0">
-                          <a:solidFill>
-                            <a:srgbClr val="1C2B33"/>
-                          </a:solidFill>
-                          <a:latin typeface="Calibri" pitchFamily="34" charset="0"/>
-                          <a:ea typeface="Calibri" pitchFamily="34" charset="-122"/>
-                          <a:cs typeface="Calibri" pitchFamily="34" charset="-120"/>
-                        </a:rPr>
-                        <a:t>PRÉ TA - NR13</a:t>
-                      </a:r>
-                      <a:endParaRPr lang="en-US" sz="1000" dirty="0">
-                        <a:latin typeface="Calibri" charset="0"/>
-                        <a:ea typeface="Calibri" charset="0"/>
-                        <a:cs typeface="Calibri" charset="0"/>
-                      </a:endParaRPr>
-                    </a:p>
-                  </a:txBody>
-                  <a:tcPr marL="91440" marR="91440" marT="45720" marB="45720" anchor="ctr">
-                    <a:lnL w="6350" cap="flat" cmpd="sng" algn="ctr">
-                      <a:solidFill>
-                        <a:srgbClr val="E3E8E9"/>
-                      </a:solidFill>
-                      <a:prstDash val="solid"/>
-                      <a:round/>
-                      <a:headEnd type="none" w="med" len="med"/>
-                      <a:tailEnd type="none" w="med" len="med"/>
-                    </a:lnL>
-                    <a:lnR w="6350" cap="flat" cmpd="sng" algn="ctr">
-                      <a:solidFill>
-                        <a:srgbClr val="E3E8E9"/>
-                      </a:solidFill>
-                      <a:prstDash val="solid"/>
-                      <a:round/>
-                      <a:headEnd type="none" w="med" len="med"/>
-                      <a:tailEnd type="none" w="med" len="med"/>
-                    </a:lnR>
-                    <a:lnT w="6350" cap="flat" cmpd="sng" algn="ctr">
-                      <a:solidFill>
-                        <a:srgbClr val="E3E8E9"/>
-                      </a:solidFill>
-                      <a:prstDash val="solid"/>
-                      <a:round/>
-                      <a:headEnd type="none" w="med" len="med"/>
-                      <a:tailEnd type="none" w="med" len="med"/>
-                    </a:lnT>
-                    <a:lnB w="6350" cap="flat" cmpd="sng" algn="ctr">
-                      <a:solidFill>
-                        <a:srgbClr val="E3E8E9"/>
-                      </a:solidFill>
-                      <a:prstDash val="solid"/>
-                      <a:round/>
-                      <a:headEnd type="none" w="med" len="med"/>
-                      <a:tailEnd type="none" w="med" len="med"/>
-                    </a:lnB>
-                    <a:solidFill>
-                      <a:srgbClr val="FFFFFF"/>
-                    </a:solidFill>
-                  </a:tcPr>
-                </a:tc>
-                <a:tc>
-                  <a:txBody>
-                    <a:bodyPr/>
-                    <a:lstStyle/>
-                    <a:p>
-                      <a:pPr indent="0" marL="0">
-                        <a:buNone/>
-                      </a:pPr>
-                      <a:r>
-                        <a:rPr lang="en-US" sz="950" dirty="0">
-                          <a:solidFill>
-                            <a:srgbClr val="5B6B73"/>
-                          </a:solidFill>
-                          <a:latin typeface="Calibri" pitchFamily="34" charset="0"/>
-                          <a:ea typeface="Calibri" pitchFamily="34" charset="-122"/>
-                          <a:cs typeface="Calibri" pitchFamily="34" charset="-120"/>
-                        </a:rPr>
-                        <a:t>Eficiência de Produção</a:t>
-                      </a:r>
-                      <a:endParaRPr lang="en-US" sz="950" dirty="0">
-                        <a:latin typeface="Calibri" charset="0"/>
-                        <a:ea typeface="Calibri" charset="0"/>
-                        <a:cs typeface="Calibri" charset="0"/>
-                      </a:endParaRPr>
-                    </a:p>
-                  </a:txBody>
-                  <a:tcPr marL="91440" marR="91440" marT="45720" marB="45720" anchor="ctr">
-                    <a:lnL w="6350" cap="flat" cmpd="sng" algn="ctr">
-                      <a:solidFill>
-                        <a:srgbClr val="E3E8E9"/>
-                      </a:solidFill>
-                      <a:prstDash val="solid"/>
-                      <a:round/>
-                      <a:headEnd type="none" w="med" len="med"/>
-                      <a:tailEnd type="none" w="med" len="med"/>
-                    </a:lnL>
-                    <a:lnR w="6350" cap="flat" cmpd="sng" algn="ctr">
-                      <a:solidFill>
-                        <a:srgbClr val="E3E8E9"/>
-                      </a:solidFill>
-                      <a:prstDash val="solid"/>
-                      <a:round/>
-                      <a:headEnd type="none" w="med" len="med"/>
-                      <a:tailEnd type="none" w="med" len="med"/>
-                    </a:lnR>
-                    <a:lnT w="6350" cap="flat" cmpd="sng" algn="ctr">
-                      <a:solidFill>
-                        <a:srgbClr val="E3E8E9"/>
-                      </a:solidFill>
-                      <a:prstDash val="solid"/>
-                      <a:round/>
-                      <a:headEnd type="none" w="med" len="med"/>
-                      <a:tailEnd type="none" w="med" len="med"/>
-                    </a:lnT>
-                    <a:lnB w="6350" cap="flat" cmpd="sng" algn="ctr">
-                      <a:solidFill>
-                        <a:srgbClr val="E3E8E9"/>
-                      </a:solidFill>
-                      <a:prstDash val="solid"/>
-                      <a:round/>
-                      <a:headEnd type="none" w="med" len="med"/>
-                      <a:tailEnd type="none" w="med" len="med"/>
-                    </a:lnB>
-                    <a:solidFill>
-                      <a:srgbClr val="FFFFFF"/>
-                    </a:solidFill>
-                  </a:tcPr>
-                </a:tc>
-                <a:tc>
-                  <a:txBody>
-                    <a:bodyPr/>
-                    <a:lstStyle/>
-                    <a:p>
-                      <a:pPr indent="0" marL="0">
-                        <a:buNone/>
-                      </a:pPr>
-                      <a:r>
-                        <a:rPr lang="en-US" sz="950" dirty="0">
-                          <a:solidFill>
-                            <a:srgbClr val="5B6B73"/>
-                          </a:solidFill>
-                          <a:latin typeface="Calibri" pitchFamily="34" charset="0"/>
-                          <a:ea typeface="Calibri" pitchFamily="34" charset="-122"/>
-                          <a:cs typeface="Calibri" pitchFamily="34" charset="-120"/>
-                        </a:rPr>
-                        <a:t>TA - Parada Programada</a:t>
-                      </a:r>
-                      <a:endParaRPr lang="en-US" sz="950" dirty="0">
-                        <a:latin typeface="Calibri" charset="0"/>
-                        <a:ea typeface="Calibri" charset="0"/>
-                        <a:cs typeface="Calibri" charset="0"/>
-                      </a:endParaRPr>
-                    </a:p>
-                  </a:txBody>
-                  <a:tcPr marL="91440" marR="91440" marT="45720" marB="45720" anchor="ctr">
-                    <a:lnL w="6350" cap="flat" cmpd="sng" algn="ctr">
-                      <a:solidFill>
-                        <a:srgbClr val="E3E8E9"/>
-                      </a:solidFill>
-                      <a:prstDash val="solid"/>
-                      <a:round/>
-                      <a:headEnd type="none" w="med" len="med"/>
-                      <a:tailEnd type="none" w="med" len="med"/>
-                    </a:lnL>
-                    <a:lnR w="6350" cap="flat" cmpd="sng" algn="ctr">
-                      <a:solidFill>
-                        <a:srgbClr val="E3E8E9"/>
-                      </a:solidFill>
-                      <a:prstDash val="solid"/>
-                      <a:round/>
-                      <a:headEnd type="none" w="med" len="med"/>
-                      <a:tailEnd type="none" w="med" len="med"/>
-                    </a:lnR>
-                    <a:lnT w="6350" cap="flat" cmpd="sng" algn="ctr">
-                      <a:solidFill>
-                        <a:srgbClr val="E3E8E9"/>
-                      </a:solidFill>
-                      <a:prstDash val="solid"/>
-                      <a:round/>
-                      <a:headEnd type="none" w="med" len="med"/>
-                      <a:tailEnd type="none" w="med" len="med"/>
-                    </a:lnT>
-                    <a:lnB w="6350" cap="flat" cmpd="sng" algn="ctr">
-                      <a:solidFill>
-                        <a:srgbClr val="E3E8E9"/>
-                      </a:solidFill>
-                      <a:prstDash val="solid"/>
-                      <a:round/>
-                      <a:headEnd type="none" w="med" len="med"/>
-                      <a:tailEnd type="none" w="med" len="med"/>
-                    </a:lnB>
-                    <a:solidFill>
-                      <a:srgbClr val="FFFFFF"/>
-                    </a:solidFill>
-                  </a:tcPr>
-                </a:tc>
-                <a:tc>
-                  <a:txBody>
-                    <a:bodyPr/>
-                    <a:lstStyle/>
-                    <a:p>
-                      <a:pPr algn="r" indent="0" marL="0">
-                        <a:buNone/>
-                      </a:pPr>
-                      <a:r>
-                        <a:rPr lang="en-US" sz="1000" b="1" dirty="0">
-                          <a:solidFill>
-                            <a:srgbClr val="0B2A3D"/>
-                          </a:solidFill>
-                          <a:latin typeface="Calibri" pitchFamily="34" charset="0"/>
-                          <a:ea typeface="Calibri" pitchFamily="34" charset="-122"/>
-                          <a:cs typeface="Calibri" pitchFamily="34" charset="-120"/>
-                        </a:rPr>
-                        <a:t>US$ 65,1 mil</a:t>
-                      </a:r>
-                      <a:endParaRPr lang="en-US" sz="1000" dirty="0">
-                        <a:latin typeface="Calibri" charset="0"/>
-                        <a:ea typeface="Calibri" charset="0"/>
-                        <a:cs typeface="Calibri" charset="0"/>
-                      </a:endParaRPr>
-                    </a:p>
-                  </a:txBody>
-                  <a:tcPr marL="91440" marR="91440" marT="45720" marB="45720" anchor="ctr">
-                    <a:lnL w="6350" cap="flat" cmpd="sng" algn="ctr">
-                      <a:solidFill>
-                        <a:srgbClr val="E3E8E9"/>
-                      </a:solidFill>
-                      <a:prstDash val="solid"/>
-                      <a:round/>
-                      <a:headEnd type="none" w="med" len="med"/>
-                      <a:tailEnd type="none" w="med" len="med"/>
-                    </a:lnL>
-                    <a:lnR w="6350" cap="flat" cmpd="sng" algn="ctr">
-                      <a:solidFill>
-                        <a:srgbClr val="E3E8E9"/>
-                      </a:solidFill>
-                      <a:prstDash val="solid"/>
-                      <a:round/>
-                      <a:headEnd type="none" w="med" len="med"/>
-                      <a:tailEnd type="none" w="med" len="med"/>
-                    </a:lnR>
-                    <a:lnT w="6350" cap="flat" cmpd="sng" algn="ctr">
-                      <a:solidFill>
-                        <a:srgbClr val="E3E8E9"/>
-                      </a:solidFill>
-                      <a:prstDash val="solid"/>
-                      <a:round/>
-                      <a:headEnd type="none" w="med" len="med"/>
-                      <a:tailEnd type="none" w="med" len="med"/>
-                    </a:lnT>
-                    <a:lnB w="6350" cap="flat" cmpd="sng" algn="ctr">
-                      <a:solidFill>
-                        <a:srgbClr val="E3E8E9"/>
-                      </a:solidFill>
-                      <a:prstDash val="solid"/>
-                      <a:round/>
-                      <a:headEnd type="none" w="med" len="med"/>
-                      <a:tailEnd type="none" w="med" len="med"/>
-                    </a:lnB>
-                    <a:solidFill>
-                      <a:srgbClr val="FFFFFF"/>
-                    </a:solidFill>
-                  </a:tcPr>
-                </a:tc>
-              </a:tr>
-              <a:tr h="288036">
-                <a:tc>
-                  <a:txBody>
-                    <a:bodyPr/>
-                    <a:lstStyle/>
-                    <a:p>
-                      <a:pPr indent="0" marL="0">
-                        <a:buNone/>
-                      </a:pPr>
-                      <a:r>
-                        <a:rPr lang="en-US" sz="1000" dirty="0">
-                          <a:solidFill>
-                            <a:srgbClr val="1C2B33"/>
-                          </a:solidFill>
-                          <a:latin typeface="Calibri" pitchFamily="34" charset="0"/>
-                          <a:ea typeface="Calibri" pitchFamily="34" charset="-122"/>
-                          <a:cs typeface="Calibri" pitchFamily="34" charset="-120"/>
-                        </a:rPr>
-                        <a:t>Obstrução Sistema de Águas Cinzas</a:t>
-                      </a:r>
-                      <a:endParaRPr lang="en-US" sz="1000" dirty="0">
-                        <a:latin typeface="Calibri" charset="0"/>
-                        <a:ea typeface="Calibri" charset="0"/>
-                        <a:cs typeface="Calibri" charset="0"/>
-                      </a:endParaRPr>
-                    </a:p>
-                  </a:txBody>
-                  <a:tcPr marL="91440" marR="91440" marT="45720" marB="45720" anchor="ctr">
-                    <a:lnL w="6350" cap="flat" cmpd="sng" algn="ctr">
-                      <a:solidFill>
-                        <a:srgbClr val="E3E8E9"/>
-                      </a:solidFill>
-                      <a:prstDash val="solid"/>
-                      <a:round/>
-                      <a:headEnd type="none" w="med" len="med"/>
-                      <a:tailEnd type="none" w="med" len="med"/>
-                    </a:lnL>
-                    <a:lnR w="6350" cap="flat" cmpd="sng" algn="ctr">
-                      <a:solidFill>
-                        <a:srgbClr val="E3E8E9"/>
-                      </a:solidFill>
-                      <a:prstDash val="solid"/>
-                      <a:round/>
-                      <a:headEnd type="none" w="med" len="med"/>
-                      <a:tailEnd type="none" w="med" len="med"/>
-                    </a:lnR>
-                    <a:lnT w="6350" cap="flat" cmpd="sng" algn="ctr">
-                      <a:solidFill>
-                        <a:srgbClr val="E3E8E9"/>
-                      </a:solidFill>
-                      <a:prstDash val="solid"/>
-                      <a:round/>
-                      <a:headEnd type="none" w="med" len="med"/>
-                      <a:tailEnd type="none" w="med" len="med"/>
-                    </a:lnT>
-                    <a:lnB w="6350" cap="flat" cmpd="sng" algn="ctr">
-                      <a:solidFill>
-                        <a:srgbClr val="E3E8E9"/>
-                      </a:solidFill>
-                      <a:prstDash val="solid"/>
-                      <a:round/>
-                      <a:headEnd type="none" w="med" len="med"/>
-                      <a:tailEnd type="none" w="med" len="med"/>
-                    </a:lnB>
-                    <a:solidFill>
-                      <a:srgbClr val="F0F4F5"/>
-                    </a:solidFill>
-                  </a:tcPr>
-                </a:tc>
-                <a:tc>
-                  <a:txBody>
-                    <a:bodyPr/>
-                    <a:lstStyle/>
-                    <a:p>
-                      <a:pPr indent="0" marL="0">
-                        <a:buNone/>
-                      </a:pPr>
-                      <a:r>
-                        <a:rPr lang="en-US" sz="950" dirty="0">
-                          <a:solidFill>
-                            <a:srgbClr val="5B6B73"/>
-                          </a:solidFill>
-                          <a:latin typeface="Calibri" pitchFamily="34" charset="0"/>
-                          <a:ea typeface="Calibri" pitchFamily="34" charset="-122"/>
-                          <a:cs typeface="Calibri" pitchFamily="34" charset="-120"/>
-                        </a:rPr>
-                        <a:t>Integridade e Regulatório</a:t>
-                      </a:r>
-                      <a:endParaRPr lang="en-US" sz="950" dirty="0">
-                        <a:latin typeface="Calibri" charset="0"/>
-                        <a:ea typeface="Calibri" charset="0"/>
-                        <a:cs typeface="Calibri" charset="0"/>
-                      </a:endParaRPr>
-                    </a:p>
-                  </a:txBody>
-                  <a:tcPr marL="91440" marR="91440" marT="45720" marB="45720" anchor="ctr">
-                    <a:lnL w="6350" cap="flat" cmpd="sng" algn="ctr">
-                      <a:solidFill>
-                        <a:srgbClr val="E3E8E9"/>
-                      </a:solidFill>
-                      <a:prstDash val="solid"/>
-                      <a:round/>
-                      <a:headEnd type="none" w="med" len="med"/>
-                      <a:tailEnd type="none" w="med" len="med"/>
-                    </a:lnL>
-                    <a:lnR w="6350" cap="flat" cmpd="sng" algn="ctr">
-                      <a:solidFill>
-                        <a:srgbClr val="E3E8E9"/>
-                      </a:solidFill>
-                      <a:prstDash val="solid"/>
-                      <a:round/>
-                      <a:headEnd type="none" w="med" len="med"/>
-                      <a:tailEnd type="none" w="med" len="med"/>
-                    </a:lnR>
-                    <a:lnT w="6350" cap="flat" cmpd="sng" algn="ctr">
-                      <a:solidFill>
-                        <a:srgbClr val="E3E8E9"/>
-                      </a:solidFill>
-                      <a:prstDash val="solid"/>
-                      <a:round/>
-                      <a:headEnd type="none" w="med" len="med"/>
-                      <a:tailEnd type="none" w="med" len="med"/>
-                    </a:lnT>
-                    <a:lnB w="6350" cap="flat" cmpd="sng" algn="ctr">
-                      <a:solidFill>
-                        <a:srgbClr val="E3E8E9"/>
-                      </a:solidFill>
-                      <a:prstDash val="solid"/>
-                      <a:round/>
-                      <a:headEnd type="none" w="med" len="med"/>
-                      <a:tailEnd type="none" w="med" len="med"/>
-                    </a:lnB>
-                    <a:solidFill>
-                      <a:srgbClr val="F0F4F5"/>
-                    </a:solidFill>
-                  </a:tcPr>
-                </a:tc>
-                <a:tc>
-                  <a:txBody>
-                    <a:bodyPr/>
-                    <a:lstStyle/>
-                    <a:p>
-                      <a:pPr indent="0" marL="0">
-                        <a:buNone/>
-                      </a:pPr>
-                      <a:r>
-                        <a:rPr lang="en-US" sz="950" dirty="0">
-                          <a:solidFill>
-                            <a:srgbClr val="5B6B73"/>
-                          </a:solidFill>
-                          <a:latin typeface="Calibri" pitchFamily="34" charset="0"/>
-                          <a:ea typeface="Calibri" pitchFamily="34" charset="-122"/>
-                          <a:cs typeface="Calibri" pitchFamily="34" charset="-120"/>
-                        </a:rPr>
-                        <a:t>Projetos</a:t>
-                      </a:r>
-                      <a:endParaRPr lang="en-US" sz="950" dirty="0">
-                        <a:latin typeface="Calibri" charset="0"/>
-                        <a:ea typeface="Calibri" charset="0"/>
-                        <a:cs typeface="Calibri" charset="0"/>
-                      </a:endParaRPr>
-                    </a:p>
-                  </a:txBody>
-                  <a:tcPr marL="91440" marR="91440" marT="45720" marB="45720" anchor="ctr">
-                    <a:lnL w="6350" cap="flat" cmpd="sng" algn="ctr">
-                      <a:solidFill>
-                        <a:srgbClr val="E3E8E9"/>
-                      </a:solidFill>
-                      <a:prstDash val="solid"/>
-                      <a:round/>
-                      <a:headEnd type="none" w="med" len="med"/>
-                      <a:tailEnd type="none" w="med" len="med"/>
-                    </a:lnL>
-                    <a:lnR w="6350" cap="flat" cmpd="sng" algn="ctr">
-                      <a:solidFill>
-                        <a:srgbClr val="E3E8E9"/>
-                      </a:solidFill>
-                      <a:prstDash val="solid"/>
-                      <a:round/>
-                      <a:headEnd type="none" w="med" len="med"/>
-                      <a:tailEnd type="none" w="med" len="med"/>
-                    </a:lnR>
-                    <a:lnT w="6350" cap="flat" cmpd="sng" algn="ctr">
-                      <a:solidFill>
-                        <a:srgbClr val="E3E8E9"/>
-                      </a:solidFill>
-                      <a:prstDash val="solid"/>
-                      <a:round/>
-                      <a:headEnd type="none" w="med" len="med"/>
-                      <a:tailEnd type="none" w="med" len="med"/>
-                    </a:lnT>
-                    <a:lnB w="6350" cap="flat" cmpd="sng" algn="ctr">
-                      <a:solidFill>
-                        <a:srgbClr val="E3E8E9"/>
-                      </a:solidFill>
-                      <a:prstDash val="solid"/>
-                      <a:round/>
-                      <a:headEnd type="none" w="med" len="med"/>
-                      <a:tailEnd type="none" w="med" len="med"/>
-                    </a:lnB>
-                    <a:solidFill>
-                      <a:srgbClr val="F0F4F5"/>
-                    </a:solidFill>
-                  </a:tcPr>
-                </a:tc>
-                <a:tc>
-                  <a:txBody>
-                    <a:bodyPr/>
-                    <a:lstStyle/>
-                    <a:p>
-                      <a:pPr algn="r" indent="0" marL="0">
-                        <a:buNone/>
-                      </a:pPr>
-                      <a:r>
-                        <a:rPr lang="en-US" sz="1000" b="1" dirty="0">
-                          <a:solidFill>
-                            <a:srgbClr val="0B2A3D"/>
-                          </a:solidFill>
-                          <a:latin typeface="Calibri" pitchFamily="34" charset="0"/>
-                          <a:ea typeface="Calibri" pitchFamily="34" charset="-122"/>
-                          <a:cs typeface="Calibri" pitchFamily="34" charset="-120"/>
-                        </a:rPr>
-                        <a:t>US$ 50,9 mil</a:t>
+                        <a:t>US$ 150,0 mil</a:t>
                       </a:r>
                       <a:endParaRPr lang="en-US" sz="1000" dirty="0">
                         <a:latin typeface="Calibri" charset="0"/>
@@ -25206,7 +25304,7 @@
                           <a:ea typeface="Calibri" pitchFamily="34" charset="-122"/>
                           <a:cs typeface="Calibri" pitchFamily="34" charset="-120"/>
                         </a:rPr>
-                        <a:t>Outros 15 escopos (itens de menor valor individual)</a:t>
+                        <a:t>Outros 26 escopos (itens de menor valor individual)</a:t>
                       </a:r>
                       <a:endParaRPr lang="en-US" sz="950" dirty="0">
                         <a:latin typeface="Calibri" charset="0"/>
@@ -25280,7 +25378,7 @@
                           <a:ea typeface="Calibri" pitchFamily="34" charset="-122"/>
                           <a:cs typeface="Calibri" pitchFamily="34" charset="-120"/>
                         </a:rPr>
-                        <a:t>US$ 228,0 mil</a:t>
+                        <a:t>US$ 1,0 mi</a:t>
                       </a:r>
                       <a:endParaRPr lang="en-US" sz="1000" dirty="0">
                         <a:latin typeface="Calibri" charset="0"/>

</xml_diff>